<commit_message>
Week 6 foundation: copy lesson, light context file, get online; no live connector or pair exercise
</commit_message>
<xml_diff>
--- a/lessons/week-6/_src/week6-lecture.pptx
+++ b/lessons/week-6/_src/week6-lecture.pptx
@@ -17,13 +17,6 @@
     <p:sldId id="265" r:id="rId17"/>
     <p:sldId id="266" r:id="rId18"/>
     <p:sldId id="267" r:id="rId19"/>
-    <p:sldId id="268" r:id="rId20"/>
-    <p:sldId id="269" r:id="rId21"/>
-    <p:sldId id="270" r:id="rId22"/>
-    <p:sldId id="271" r:id="rId23"/>
-    <p:sldId id="272" r:id="rId24"/>
-    <p:sldId id="273" r:id="rId25"/>
-    <p:sldId id="274" r:id="rId26"/>
   </p:sldIdLst>
   <p:sldSz cx="12191695" cy="6858000" type="screen4x3"/>
   <p:notesSz cx="6858000" cy="9144000"/>
@@ -520,19 +513,7 @@
           <a:lstStyle/>
           <a:p>
             <a:r>
-              <a:t>5:05 · 30 seconds</a:t>
-            </a:r>
-          </a:p>
-          <a:p/>
-          <a:p>
-            <a:r>
-              <a:t>Tonight is mostly live demos, not slides. Three of them. Everything tonight is also one markdown lesson students can paste into their own AI later, so nobody has to catch every word.</a:t>
-            </a:r>
-          </a:p>
-          <a:p/>
-          <a:p>
-            <a:r>
-              <a:t>(Background for you, not to teach: this whole lecture is the 4D AI Fluency framework in practice. Context files are Description that persists; checking the output out loud is Discernment; deciding what to hand the agent is Delegation; checking before you publish is Diligence.)</a:t>
+              <a:t>5:05–5:06. Three simple demos: copy the lesson, context that sticks, getting online. No live connector tonight.</a:t>
             </a:r>
           </a:p>
         </p:txBody>
@@ -602,13 +583,7 @@
           <a:lstStyle/>
           <a:p>
             <a:r>
-              <a:t>5:17–5:18 · 1 min</a:t>
-            </a:r>
-          </a:p>
-          <a:p/>
-          <a:p>
-            <a:r>
-              <a:t>This is the most common problem in submissions so far: a link that points to a file on your own computer. If the address starts with file:// or C:\, nobody else can open it. Test: send the link to yourself and open it on your phone, off wifi.</a:t>
+              <a:t>5:31–5:33. Concept only. A connector often uses a standard called Model Context Protocol. Don’t show a server URL or set one up. This week, copying the markdown is the step toward that.</a:t>
             </a:r>
           </a:p>
         </p:txBody>
@@ -678,13 +653,7 @@
           <a:lstStyle/>
           <a:p>
             <a:r>
-              <a:t>5:18–5:19 · 1 min</a:t>
-            </a:r>
-          </a:p>
-          <a:p/>
-          <a:p>
-            <a:r>
-              <a:t>Commit = a save point with a note. Push = send your save points to GitHub. Deploy = publish. Most confusion comes from treating these as one thing.</a:t>
+              <a:t>5:33–5:35. Free link on account page. No history? Paste last two submissions. No due date. Then trios 5:35–6:05.</a:t>
             </a:r>
           </a:p>
         </p:txBody>
@@ -754,618 +723,7 @@
           <a:lstStyle/>
           <a:p>
             <a:r>
-              <a:t>5:19–5:27 · 8 min LIVE · exact clicks on the demo script page</a:t>
-            </a:r>
-          </a:p>
-          <a:p/>
-          <a:p>
-            <a:r>
-              <a:t>Use the zip from the class files page so you start from a plain folder with no git history.</a:t>
-            </a:r>
-          </a:p>
-          <a:p>
-            <a:r>
-              <a:t>1. Unzip. GitHub Desktop: File → Add local repository → choose the folder → 'create a repository' → Create.</a:t>
-            </a:r>
-          </a:p>
-          <a:p>
-            <a:r>
-              <a:t>2. Commit to main ('first version'). Publish repository; UNTICK 'keep this code private'.</a:t>
-            </a:r>
-          </a:p>
-          <a:p>
-            <a:r>
-              <a:t>3. On github.com: Settings → Pages → Source: Deploy from a branch → main / (root) → Save. About a minute.</a:t>
-            </a:r>
-          </a:p>
-          <a:p>
-            <a:r>
-              <a:t>4. Open the https://&lt;you&gt;.github.io/&lt;repo&gt;/ link on your phone; hold it up.</a:t>
-            </a:r>
-          </a:p>
-          <a:p>
-            <a:r>
-              <a:t>5. Ask the agent for one small change, commit, push, refresh after ~1 min.</a:t>
-            </a:r>
-          </a:p>
-          <a:p>
-            <a:r>
-              <a:t>While Pages builds, say: Vercel does the same for React/Next/Vite projects: import the GitHub repo at vercel.com/new and click Deploy.</a:t>
-            </a:r>
-          </a:p>
-          <a:p>
-            <a:r>
-              <a:t>IF PAGES IS SLOW: show the already-live copy at unforcedagi.github.io/lvb-week6-demo and move on. The handout 'Get your project online' has every step with a no-install option.</a:t>
-            </a:r>
-          </a:p>
-        </p:txBody>
-      </p:sp>
-      <p:sp>
-        <p:nvSpPr>
-          <p:cNvPr id="4" name="Slide Number Placeholder 3"/>
-          <p:cNvSpPr>
-            <a:spLocks noGrp="1"/>
-          </p:cNvSpPr>
-          <p:nvPr>
-            <p:ph type="sldNum" idx="5" sz="quarter"/>
-          </p:nvPr>
-        </p:nvSpPr>
-        <p:spPr/>
-      </p:sp>
-    </p:spTree>
-  </p:cSld>
-  <p:clrMapOvr>
-    <a:masterClrMapping/>
-  </p:clrMapOvr>
-</p:notes>
-</file>
-
-<file path=ppt/notesSlides/notesSlide13.xml><?xml version="1.0" encoding="utf-8"?>
-<p:notes xmlns:a="http://schemas.openxmlformats.org/drawingml/2006/main" xmlns:p="http://schemas.openxmlformats.org/presentationml/2006/main" xmlns:r="http://schemas.openxmlformats.org/officeDocument/2006/relationships">
-  <p:cSld>
-    <p:spTree>
-      <p:nvGrpSpPr>
-        <p:cNvPr id="1" name=""/>
-        <p:cNvGrpSpPr/>
-        <p:nvPr/>
-      </p:nvGrpSpPr>
-      <p:grpSpPr>
-        <a:xfrm>
-          <a:off x="0" y="0"/>
-          <a:ext cx="0" cy="0"/>
-          <a:chOff x="0" y="0"/>
-          <a:chExt cx="0" cy="0"/>
-        </a:xfrm>
-      </p:grpSpPr>
-      <p:sp>
-        <p:nvSpPr>
-          <p:cNvPr id="2" name="Slide Image Placeholder 1"/>
-          <p:cNvSpPr>
-            <a:spLocks noGrp="1"/>
-          </p:cNvSpPr>
-          <p:nvPr>
-            <p:ph type="sldImg" idx="2"/>
-          </p:nvPr>
-        </p:nvSpPr>
-        <p:spPr/>
-      </p:sp>
-      <p:sp>
-        <p:nvSpPr>
-          <p:cNvPr id="3" name="Notes Placeholder 2"/>
-          <p:cNvSpPr>
-            <a:spLocks noGrp="1"/>
-          </p:cNvSpPr>
-          <p:nvPr>
-            <p:ph type="body" idx="3" sz="quarter"/>
-          </p:nvPr>
-        </p:nvSpPr>
-        <p:spPr/>
-        <p:txBody>
-          <a:bodyPr/>
-          <a:lstStyle/>
-          <a:p>
-            <a:r>
-              <a:t>5:27 · 30 seconds. The handout's fix-it table, in brief. Most first deploys hit one of these. Name them so nobody feels stuck alone; the handout on the Week 6 page has the full steps.</a:t>
-            </a:r>
-          </a:p>
-        </p:txBody>
-      </p:sp>
-      <p:sp>
-        <p:nvSpPr>
-          <p:cNvPr id="4" name="Slide Number Placeholder 3"/>
-          <p:cNvSpPr>
-            <a:spLocks noGrp="1"/>
-          </p:cNvSpPr>
-          <p:nvPr>
-            <p:ph type="sldNum" idx="5" sz="quarter"/>
-          </p:nvPr>
-        </p:nvSpPr>
-        <p:spPr/>
-      </p:sp>
-    </p:spTree>
-  </p:cSld>
-  <p:clrMapOvr>
-    <a:masterClrMapping/>
-  </p:clrMapOvr>
-</p:notes>
-</file>
-
-<file path=ppt/notesSlides/notesSlide14.xml><?xml version="1.0" encoding="utf-8"?>
-<p:notes xmlns:a="http://schemas.openxmlformats.org/drawingml/2006/main" xmlns:p="http://schemas.openxmlformats.org/presentationml/2006/main" xmlns:r="http://schemas.openxmlformats.org/officeDocument/2006/relationships">
-  <p:cSld>
-    <p:spTree>
-      <p:nvGrpSpPr>
-        <p:cNvPr id="1" name=""/>
-        <p:cNvGrpSpPr/>
-        <p:nvPr/>
-      </p:nvGrpSpPr>
-      <p:grpSpPr>
-        <a:xfrm>
-          <a:off x="0" y="0"/>
-          <a:ext cx="0" cy="0"/>
-          <a:chOff x="0" y="0"/>
-          <a:chExt cx="0" cy="0"/>
-        </a:xfrm>
-      </p:grpSpPr>
-      <p:sp>
-        <p:nvSpPr>
-          <p:cNvPr id="2" name="Slide Image Placeholder 1"/>
-          <p:cNvSpPr>
-            <a:spLocks noGrp="1"/>
-          </p:cNvSpPr>
-          <p:nvPr>
-            <p:ph type="sldImg" idx="2"/>
-          </p:nvPr>
-        </p:nvSpPr>
-        <p:spPr/>
-      </p:sp>
-      <p:sp>
-        <p:nvSpPr>
-          <p:cNvPr id="3" name="Notes Placeholder 2"/>
-          <p:cNvSpPr>
-            <a:spLocks noGrp="1"/>
-          </p:cNvSpPr>
-          <p:nvPr>
-            <p:ph type="body" idx="3" sz="quarter"/>
-          </p:nvPr>
-        </p:nvSpPr>
-        <p:spPr/>
-        <p:txBody>
-          <a:bodyPr/>
-          <a:lstStyle/>
-          <a:p>
-            <a:r>
-              <a:t>5:27–5:28 · 1 min</a:t>
-            </a:r>
-          </a:p>
-          <a:p/>
-          <a:p>
-            <a:r>
-              <a:t>API = how one program asks another for things; every service's menu is different. MCP (Model Context Protocol) is an open standard: write the connector once, use it in any MCP-capable app. Analogy: different wall sockets vs a universal adapter. Reading adds context; writing (sending, paying, deleting) changes the world. Start read-only; ask before anything that changes things. A web page that says 'ignore your instructions' is data, not your boss.</a:t>
-            </a:r>
-          </a:p>
-        </p:txBody>
-      </p:sp>
-      <p:sp>
-        <p:nvSpPr>
-          <p:cNvPr id="4" name="Slide Number Placeholder 3"/>
-          <p:cNvSpPr>
-            <a:spLocks noGrp="1"/>
-          </p:cNvSpPr>
-          <p:nvPr>
-            <p:ph type="sldNum" idx="5" sz="quarter"/>
-          </p:nvPr>
-        </p:nvSpPr>
-        <p:spPr/>
-      </p:sp>
-    </p:spTree>
-  </p:cSld>
-  <p:clrMapOvr>
-    <a:masterClrMapping/>
-  </p:clrMapOvr>
-</p:notes>
-</file>
-
-<file path=ppt/notesSlides/notesSlide15.xml><?xml version="1.0" encoding="utf-8"?>
-<p:notes xmlns:a="http://schemas.openxmlformats.org/drawingml/2006/main" xmlns:p="http://schemas.openxmlformats.org/presentationml/2006/main" xmlns:r="http://schemas.openxmlformats.org/officeDocument/2006/relationships">
-  <p:cSld>
-    <p:spTree>
-      <p:nvGrpSpPr>
-        <p:cNvPr id="1" name=""/>
-        <p:cNvGrpSpPr/>
-        <p:nvPr/>
-      </p:nvGrpSpPr>
-      <p:grpSpPr>
-        <a:xfrm>
-          <a:off x="0" y="0"/>
-          <a:ext cx="0" cy="0"/>
-          <a:chOff x="0" y="0"/>
-          <a:chExt cx="0" cy="0"/>
-        </a:xfrm>
-      </p:grpSpPr>
-      <p:sp>
-        <p:nvSpPr>
-          <p:cNvPr id="2" name="Slide Image Placeholder 1"/>
-          <p:cNvSpPr>
-            <a:spLocks noGrp="1"/>
-          </p:cNvSpPr>
-          <p:nvPr>
-            <p:ph type="sldImg" idx="2"/>
-          </p:nvPr>
-        </p:nvSpPr>
-        <p:spPr/>
-      </p:sp>
-      <p:sp>
-        <p:nvSpPr>
-          <p:cNvPr id="3" name="Notes Placeholder 2"/>
-          <p:cNvSpPr>
-            <a:spLocks noGrp="1"/>
-          </p:cNvSpPr>
-          <p:nvPr>
-            <p:ph type="body" idx="3" sz="quarter"/>
-          </p:nvPr>
-        </p:nvSpPr>
-        <p:spPr/>
-        <p:txBody>
-          <a:bodyPr/>
-          <a:lstStyle/>
-          <a:p>
-            <a:r>
-              <a:t>5:28–5:33 · 5 min LIVE</a:t>
-            </a:r>
-          </a:p>
-          <a:p/>
-          <a:p>
-            <a:r>
-              <a:t>Claude Code: claude mcp add --transport http lvb https://api.learnvibe.build/mcp, then start claude and run /mcp to see it connected.</a:t>
-            </a:r>
-          </a:p>
-          <a:p>
-            <a:r>
-              <a:t>Claude app: Settings → Connectors → Add custom connector → paste the URL (plans vary).</a:t>
-            </a:r>
-          </a:p>
-          <a:p>
-            <a:r>
-              <a:t>Ask it to list the lessons, then to teach the AGENTS.md part and quiz you. It's read-only and public: no student data, nothing it can change. That's the safe way to start with any connector.</a:t>
-            </a:r>
-          </a:p>
-          <a:p>
-            <a:r>
-              <a:t>IF IT STALLS: open cu.learnvibe.build/lessons/week-6/lesson.md, copy it, paste into any chat with the same prompt. Same result, no connector.</a:t>
-            </a:r>
-          </a:p>
-        </p:txBody>
-      </p:sp>
-      <p:sp>
-        <p:nvSpPr>
-          <p:cNvPr id="4" name="Slide Number Placeholder 3"/>
-          <p:cNvSpPr>
-            <a:spLocks noGrp="1"/>
-          </p:cNvSpPr>
-          <p:nvPr>
-            <p:ph type="sldNum" idx="5" sz="quarter"/>
-          </p:nvPr>
-        </p:nvSpPr>
-        <p:spPr/>
-      </p:sp>
-    </p:spTree>
-  </p:cSld>
-  <p:clrMapOvr>
-    <a:masterClrMapping/>
-  </p:clrMapOvr>
-</p:notes>
-</file>
-
-<file path=ppt/notesSlides/notesSlide16.xml><?xml version="1.0" encoding="utf-8"?>
-<p:notes xmlns:a="http://schemas.openxmlformats.org/drawingml/2006/main" xmlns:p="http://schemas.openxmlformats.org/presentationml/2006/main" xmlns:r="http://schemas.openxmlformats.org/officeDocument/2006/relationships">
-  <p:cSld>
-    <p:spTree>
-      <p:nvGrpSpPr>
-        <p:cNvPr id="1" name=""/>
-        <p:cNvGrpSpPr/>
-        <p:nvPr/>
-      </p:nvGrpSpPr>
-      <p:grpSpPr>
-        <a:xfrm>
-          <a:off x="0" y="0"/>
-          <a:ext cx="0" cy="0"/>
-          <a:chOff x="0" y="0"/>
-          <a:chExt cx="0" cy="0"/>
-        </a:xfrm>
-      </p:grpSpPr>
-      <p:sp>
-        <p:nvSpPr>
-          <p:cNvPr id="2" name="Slide Image Placeholder 1"/>
-          <p:cNvSpPr>
-            <a:spLocks noGrp="1"/>
-          </p:cNvSpPr>
-          <p:nvPr>
-            <p:ph type="sldImg" idx="2"/>
-          </p:nvPr>
-        </p:nvSpPr>
-        <p:spPr/>
-      </p:sp>
-      <p:sp>
-        <p:nvSpPr>
-          <p:cNvPr id="3" name="Notes Placeholder 2"/>
-          <p:cNvSpPr>
-            <a:spLocks noGrp="1"/>
-          </p:cNvSpPr>
-          <p:nvPr>
-            <p:ph type="body" idx="3" sz="quarter"/>
-          </p:nvPr>
-        </p:nvSpPr>
-        <p:spPr/>
-        <p:txBody>
-          <a:bodyPr/>
-          <a:lstStyle/>
-          <a:p>
-            <a:r>
-              <a:t>5:33 · 30 seconds. The through-line, made concrete. Background (not taught): this is Description, Discernment, Delegation and Diligence in practice. A connector that can write (send email, edit files) deserves a pause: what can it change, and can you undo it? Content an AI reads can contain instructions (prompt injection); treat it as data.</a:t>
-            </a:r>
-          </a:p>
-        </p:txBody>
-      </p:sp>
-      <p:sp>
-        <p:nvSpPr>
-          <p:cNvPr id="4" name="Slide Number Placeholder 3"/>
-          <p:cNvSpPr>
-            <a:spLocks noGrp="1"/>
-          </p:cNvSpPr>
-          <p:nvPr>
-            <p:ph type="sldNum" idx="5" sz="quarter"/>
-          </p:nvPr>
-        </p:nvSpPr>
-        <p:spPr/>
-      </p:sp>
-    </p:spTree>
-  </p:cSld>
-  <p:clrMapOvr>
-    <a:masterClrMapping/>
-  </p:clrMapOvr>
-</p:notes>
-</file>
-
-<file path=ppt/notesSlides/notesSlide17.xml><?xml version="1.0" encoding="utf-8"?>
-<p:notes xmlns:a="http://schemas.openxmlformats.org/drawingml/2006/main" xmlns:p="http://schemas.openxmlformats.org/presentationml/2006/main" xmlns:r="http://schemas.openxmlformats.org/officeDocument/2006/relationships">
-  <p:cSld>
-    <p:spTree>
-      <p:nvGrpSpPr>
-        <p:cNvPr id="1" name=""/>
-        <p:cNvGrpSpPr/>
-        <p:nvPr/>
-      </p:nvGrpSpPr>
-      <p:grpSpPr>
-        <a:xfrm>
-          <a:off x="0" y="0"/>
-          <a:ext cx="0" cy="0"/>
-          <a:chOff x="0" y="0"/>
-          <a:chExt cx="0" cy="0"/>
-        </a:xfrm>
-      </p:grpSpPr>
-      <p:sp>
-        <p:nvSpPr>
-          <p:cNvPr id="2" name="Slide Image Placeholder 1"/>
-          <p:cNvSpPr>
-            <a:spLocks noGrp="1"/>
-          </p:cNvSpPr>
-          <p:nvPr>
-            <p:ph type="sldImg" idx="2"/>
-          </p:nvPr>
-        </p:nvSpPr>
-        <p:spPr/>
-      </p:sp>
-      <p:sp>
-        <p:nvSpPr>
-          <p:cNvPr id="3" name="Notes Placeholder 2"/>
-          <p:cNvSpPr>
-            <a:spLocks noGrp="1"/>
-          </p:cNvSpPr>
-          <p:nvPr>
-            <p:ph type="body" idx="3" sz="quarter"/>
-          </p:nvPr>
-        </p:nvSpPr>
-        <p:spPr/>
-        <p:txBody>
-          <a:bodyPr/>
-          <a:lstStyle/>
-          <a:p>
-            <a:r>
-              <a:t>5:33–5:35 · 2 min</a:t>
-            </a:r>
-          </a:p>
-          <a:p/>
-          <a:p>
-            <a:r>
-              <a:t>Shipper asked her AI to place her on Every's Eight Levels of AI Adoption from her actual past work, turned that into recommendations, then had it teach her the next step. Same move as tonight: give your AI context about you, and it can coach you. Free plan or no chat history? Paste your AGENTS.md or your last two submissions and ask 'what level am I, with examples?' Gift link: on your account page and in tonight's announcement. No due date.</a:t>
-            </a:r>
-          </a:p>
-          <a:p>
-            <a:r>
-              <a:t>Then: trios, 5:35–6:05.</a:t>
-            </a:r>
-          </a:p>
-        </p:txBody>
-      </p:sp>
-      <p:sp>
-        <p:nvSpPr>
-          <p:cNvPr id="4" name="Slide Number Placeholder 3"/>
-          <p:cNvSpPr>
-            <a:spLocks noGrp="1"/>
-          </p:cNvSpPr>
-          <p:nvPr>
-            <p:ph type="sldNum" idx="5" sz="quarter"/>
-          </p:nvPr>
-        </p:nvSpPr>
-        <p:spPr/>
-      </p:sp>
-    </p:spTree>
-  </p:cSld>
-  <p:clrMapOvr>
-    <a:masterClrMapping/>
-  </p:clrMapOvr>
-</p:notes>
-</file>
-
-<file path=ppt/notesSlides/notesSlide18.xml><?xml version="1.0" encoding="utf-8"?>
-<p:notes xmlns:a="http://schemas.openxmlformats.org/drawingml/2006/main" xmlns:p="http://schemas.openxmlformats.org/presentationml/2006/main" xmlns:r="http://schemas.openxmlformats.org/officeDocument/2006/relationships">
-  <p:cSld>
-    <p:spTree>
-      <p:nvGrpSpPr>
-        <p:cNvPr id="1" name=""/>
-        <p:cNvGrpSpPr/>
-        <p:nvPr/>
-      </p:nvGrpSpPr>
-      <p:grpSpPr>
-        <a:xfrm>
-          <a:off x="0" y="0"/>
-          <a:ext cx="0" cy="0"/>
-          <a:chOff x="0" y="0"/>
-          <a:chExt cx="0" cy="0"/>
-        </a:xfrm>
-      </p:grpSpPr>
-      <p:sp>
-        <p:nvSpPr>
-          <p:cNvPr id="2" name="Slide Image Placeholder 1"/>
-          <p:cNvSpPr>
-            <a:spLocks noGrp="1"/>
-          </p:cNvSpPr>
-          <p:nvPr>
-            <p:ph type="sldImg" idx="2"/>
-          </p:nvPr>
-        </p:nvSpPr>
-        <p:spPr/>
-      </p:sp>
-      <p:sp>
-        <p:nvSpPr>
-          <p:cNvPr id="3" name="Notes Placeholder 2"/>
-          <p:cNvSpPr>
-            <a:spLocks noGrp="1"/>
-          </p:cNvSpPr>
-          <p:nvPr>
-            <p:ph type="body" idx="3" sz="quarter"/>
-          </p:nvPr>
-        </p:nvSpPr>
-        <p:spPr/>
-        <p:txBody>
-          <a:bodyPr/>
-          <a:lstStyle/>
-          <a:p>
-            <a:r>
-              <a:t>6:05–6:25 · 20 min PAIR ACTIVITY (show at 6:05, after trios)</a:t>
-            </a:r>
-          </a:p>
-          <a:p/>
-          <a:p>
-            <a:r>
-              <a:t>Interview questions: Who is this for? What is it, in one sentence? What's it built with? What should the AI never do? Where do the facts live? What does done look like? Partner types; owner corrects. Then each person opens their own project, adds the file, asks their agent 'What is this project and who is it for?' and one real task, and revises what it got wrong. No project yet? Write it for the project you want to start. Then 6:25–6:55: build with it, and get it online (use the handout).</a:t>
-            </a:r>
-          </a:p>
-        </p:txBody>
-      </p:sp>
-      <p:sp>
-        <p:nvSpPr>
-          <p:cNvPr id="4" name="Slide Number Placeholder 3"/>
-          <p:cNvSpPr>
-            <a:spLocks noGrp="1"/>
-          </p:cNvSpPr>
-          <p:nvPr>
-            <p:ph type="sldNum" idx="5" sz="quarter"/>
-          </p:nvPr>
-        </p:nvSpPr>
-        <p:spPr/>
-      </p:sp>
-    </p:spTree>
-  </p:cSld>
-  <p:clrMapOvr>
-    <a:masterClrMapping/>
-  </p:clrMapOvr>
-</p:notes>
-</file>
-
-<file path=ppt/notesSlides/notesSlide19.xml><?xml version="1.0" encoding="utf-8"?>
-<p:notes xmlns:a="http://schemas.openxmlformats.org/drawingml/2006/main" xmlns:p="http://schemas.openxmlformats.org/presentationml/2006/main" xmlns:r="http://schemas.openxmlformats.org/officeDocument/2006/relationships">
-  <p:cSld>
-    <p:spTree>
-      <p:nvGrpSpPr>
-        <p:cNvPr id="1" name=""/>
-        <p:cNvGrpSpPr/>
-        <p:nvPr/>
-      </p:nvGrpSpPr>
-      <p:grpSpPr>
-        <a:xfrm>
-          <a:off x="0" y="0"/>
-          <a:ext cx="0" cy="0"/>
-          <a:chOff x="0" y="0"/>
-          <a:chExt cx="0" cy="0"/>
-        </a:xfrm>
-      </p:grpSpPr>
-      <p:sp>
-        <p:nvSpPr>
-          <p:cNvPr id="2" name="Slide Image Placeholder 1"/>
-          <p:cNvSpPr>
-            <a:spLocks noGrp="1"/>
-          </p:cNvSpPr>
-          <p:nvPr>
-            <p:ph type="sldImg" idx="2"/>
-          </p:nvPr>
-        </p:nvSpPr>
-        <p:spPr/>
-      </p:sp>
-      <p:sp>
-        <p:nvSpPr>
-          <p:cNvPr id="3" name="Notes Placeholder 2"/>
-          <p:cNvSpPr>
-            <a:spLocks noGrp="1"/>
-          </p:cNvSpPr>
-          <p:nvPr>
-            <p:ph type="body" idx="3" sz="quarter"/>
-          </p:nvPr>
-        </p:nvSpPr>
-        <p:spPr/>
-        <p:txBody>
-          <a:bodyPr/>
-          <a:lstStyle/>
-          <a:p>
-            <a:r>
-              <a:t>Reference only · 0 min</a:t>
-            </a:r>
-          </a:p>
-          <a:p/>
-          <a:p>
-            <a:r>
-              <a:t>https://agents.md/</a:t>
-            </a:r>
-          </a:p>
-          <a:p>
-            <a:r>
-              <a:t>https://www.anthropic.com/engineering/effective-context-engineering-for-ai-agents</a:t>
-            </a:r>
-          </a:p>
-          <a:p>
-            <a:r>
-              <a:t>https://docs.github.com/en/pages/getting-started-with-github-pages</a:t>
-            </a:r>
-          </a:p>
-          <a:p>
-            <a:r>
-              <a:t>https://desktop.github.com/</a:t>
-            </a:r>
-          </a:p>
-          <a:p>
-            <a:r>
-              <a:t>https://vercel.com/docs/getting-started-with-vercel</a:t>
-            </a:r>
-          </a:p>
-          <a:p>
-            <a:r>
-              <a:t>https://modelcontextprotocol.io/docs/learn/architecture</a:t>
-            </a:r>
-          </a:p>
-          <a:p>
-            <a:r>
-              <a:t>https://academy.claude.com/courses/ai-fluency-framework-foundations (Dakan, Feller, Anthropic; CC BY-NC-SA 4.0)</a:t>
+              <a:t>6:05–7:05. No prescribed pairs or interview exercise. Build, test, help each other as needed. 7:05–7:35 optional studio.</a:t>
             </a:r>
           </a:p>
         </p:txBody>
@@ -1435,13 +793,7 @@
           <a:lstStyle/>
           <a:p>
             <a:r>
-              <a:t>5:05–5:06 · 30 seconds</a:t>
-            </a:r>
-          </a:p>
-          <a:p/>
-          <a:p>
-            <a:r>
-              <a:t>The through-line, said once: choose what your AI sees, check what it produces, control what it can change. The footer on every slide says which demo we're in.</a:t>
+              <a:t>5:06–5:11. Open cu.learnvibe.build/lessons/week-6/, click Copy lesson as markdown, paste into a fresh chat. Ask exactly: Teach me this and quiz me. Answer one question. If it stalls, use the real rehearsal output on the demo script page.</a:t>
             </a:r>
           </a:p>
         </p:txBody>
@@ -1511,19 +863,7 @@
           <a:lstStyle/>
           <a:p>
             <a:r>
-              <a:t>5:06–5:07 · 1 min</a:t>
-            </a:r>
-          </a:p>
-          <a:p/>
-          <a:p>
-            <a:r>
-              <a:t>The context window is what the model sees for this answer: your message, the chat so far, files and tool results. Training knowledge is separate; app 'memory' is the app looking things up for it. Ask the room: who has had to re-explain their project to an AI three times this week?</a:t>
-            </a:r>
-          </a:p>
-          <a:p/>
-          <a:p>
-            <a:r>
-              <a:t>(Background: this is Description. A good description says what you want (product), how to approach it (process) and how to behave (performance).)</a:t>
+              <a:t>5:11–5:12. Show the raw lesson. Point to # headings and - bullets; no syntax lesson beyond that.</a:t>
             </a:r>
           </a:p>
         </p:txBody>
@@ -1593,13 +933,7 @@
           <a:lstStyle/>
           <a:p>
             <a:r>
-              <a:t>5:07–5:08 · 1 min</a:t>
-            </a:r>
-          </a:p>
-          <a:p/>
-          <a:p>
-            <a:r>
-              <a:t>A .md file is just a text file. # makes headings, - makes lists. Humans can read it raw; AIs read it really well. Every lesson on the course site is a markdown file you can copy. You've seen it already: AI chat answers are written in markdown.</a:t>
+              <a:t>5:12–5:13. These are ordinary markdown files in your project. Specific support varies by tool; Claude Code reads CLAUDE.md, and our tested installation also found AGENTS.md. No template or prescribed structure. Say what you would tell a new teammate.</a:t>
             </a:r>
           </a:p>
         </p:txBody>
@@ -1669,13 +1003,7 @@
           <a:lstStyle/>
           <a:p>
             <a:r>
-              <a:t>5:08–5:09 · 1 min</a:t>
-            </a:r>
-          </a:p>
-          <a:p/>
-          <a:p>
-            <a:r>
-              <a:t>Write it once and stop re-explaining your project. What goes in: who it's for, what it is, the stack, conventions, where facts live, and what 'done' looks like. Claude Code reads CLAUDE.md, and also reads AGENTS.md in practice (verified today); a CLAUDE.md that just says 'see AGENTS.md' covers both. Always check the tool actually read it: ask it what the project is.</a:t>
+              <a:t>5:13–5:15. Write these five lines live as CLAUDE.md. This is one example, not a template. The extra facts help the agent aim at the actual audience.</a:t>
             </a:r>
           </a:p>
         </p:txBody>
@@ -1745,13 +1073,7 @@
           <a:lstStyle/>
           <a:p>
             <a:r>
-              <a:t>5:08–5:09 · 1 min</a:t>
-            </a:r>
-          </a:p>
-          <a:p/>
-          <a:p>
-            <a:r>
-              <a:t>Six headings are enough. The most useful line is often a rule: never invent facts, only use docs/event-facts.md. Short beats long: the agent reads all of it every session, so every line should earn its place. Never put passwords or API keys in it; it's a file in your repo.</a:t>
+              <a:t>5:15–5:23. Use Hill Plant Swap. Exact prompt: Improve the homepage. Don’t edit any files: describe the changes you’d make in 6 bullets or fewer. Compare audience, unnecessary RSVP, simplicity. Start a third fresh session: Without reading any files, what is this project, and what should you never do? If delayed, use real captured results on demo script.</a:t>
             </a:r>
           </a:p>
         </p:txBody>
@@ -1821,43 +1143,7 @@
           <a:lstStyle/>
           <a:p>
             <a:r>
-              <a:t>5:09–5:17 · 8 min LIVE · exact steps and prompts on the demo script page</a:t>
-            </a:r>
-          </a:p>
-          <a:p/>
-          <a:p>
-            <a:r>
-              <a:t>Repo: github.com/unforcedagi/lvb-week6-demo (Hill Plant Swap, fictional). It has NO AGENTS.md on purpose.</a:t>
-            </a:r>
-          </a:p>
-          <a:p>
-            <a:r>
-              <a:t>1. (1 min) Open it in your agent. Prompt: 'Improve the homepage.' Expect generic: invented dates, maybe a framework, a 'garden lovers' audience.</a:t>
-            </a:r>
-          </a:p>
-          <a:p>
-            <a:r>
-              <a:t>2. (3 min) Write AGENTS.md live, asking the room for each line: who it's for, what it is, stack, conventions, facts, what done looks like.</a:t>
-            </a:r>
-          </a:p>
-          <a:p>
-            <a:r>
-              <a:t>3. (2 min) Same prompt. Narrate what you check: are the facts from docs/event-facts.md? Phone-first? No framework? (That narration is discernment; don't name it.)</a:t>
-            </a:r>
-          </a:p>
-          <a:p>
-            <a:r>
-              <a:t>4. (1 min) Quit, start a fresh session, ask 'What is this project and who is it for?' It knows: the file persists, the chat didn't.</a:t>
-            </a:r>
-          </a:p>
-          <a:p>
-            <a:r>
-              <a:t>5. (1 min) Show the 'Where to look' section: the index.</a:t>
-            </a:r>
-          </a:p>
-          <a:p>
-            <a:r>
-              <a:t>IF IT STALLS: the prepared AGENTS.md is on the demo script page. Paste it, and show the rehearsal output tab. Never show invented output.</a:t>
+              <a:t>5:23–5:24. Local files and localhost links aren’t public. Open the published link on another phone.</a:t>
             </a:r>
           </a:p>
         </p:txBody>
@@ -1927,7 +1213,7 @@
           <a:lstStyle/>
           <a:p>
             <a:r>
-              <a:t>Shown after the demo, 30 seconds. This is roughly what we just wrote live. The full template is on the Week 6 page: copy it, fill it in for your own project tonight in studio.</a:t>
+              <a:t>5:24–5:25. Explain these as three different steps.</a:t>
             </a:r>
           </a:p>
         </p:txBody>
@@ -1997,13 +1283,7 @@
           <a:lstStyle/>
           <a:p>
             <a:r>
-              <a:t>5:17 · 30 seconds (shown at the end of Demo 1)</a:t>
-            </a:r>
-          </a:p>
-          <a:p/>
-          <a:p>
-            <a:r>
-              <a:t>The demo repo starts with one doc; this is how the index grows. A short top file says what exists and links deeper. The AI reads the small map, then opens only what it needs. Indexes nest: an index can point to other indexes. The course site does exactly this: cu.learnvibe.build/llms.txt is an index of every lesson (live tonight after class).</a:t>
+              <a:t>5:25–5:31. Use plain-folder zip. Commit first version, publish public repo, Settings Pages main root. If waiting, show pre-deployed Hill Plant Swap. React/Vite/Next app: Vercel instead. Handout covers exact clicks.</a:t>
             </a:r>
           </a:p>
         </p:txBody>
@@ -5094,7 +4374,7 @@
                 </a:solidFill>
                 <a:latin typeface="Fraunces"/>
               </a:rPr>
-              <a:t>What can your AI see?</a:t>
+              <a:t>Give your AI something to work with</a:t>
             </a:r>
           </a:p>
           <a:p>
@@ -5110,7 +4390,7 @@
                 </a:solidFill>
                 <a:latin typeface="DM Sans"/>
               </a:rPr>
-              <a:t>Context that sticks, getting online, connectors</a:t>
+              <a:t>Context that sticks. A link anyone can open.</a:t>
             </a:r>
           </a:p>
           <a:p>
@@ -5165,7 +4445,7 @@
                 </a:solidFill>
                 <a:latin typeface="DM Sans"/>
               </a:rPr>
-              <a:t>Week 6 · Opening        1 / 19</a:t>
+              <a:t>Week 6 · Opening        1 / 12</a:t>
             </a:r>
           </a:p>
         </p:txBody>
@@ -5267,70 +4547,27 @@
               </a:spcAft>
             </a:pPr>
             <a:r>
-              <a:rPr sz="3200" b="1">
+              <a:rPr sz="4000" b="1">
                 <a:solidFill>
                   <a:srgbClr val="272A25"/>
                 </a:solidFill>
                 <a:latin typeface="Fraunces"/>
               </a:rPr>
-              <a:t>Your link has to work on someone else's phone</a:t>
-            </a:r>
-          </a:p>
-        </p:txBody>
-      </p:sp>
-      <p:sp>
-        <p:nvSpPr>
-          <p:cNvPr id="4" name="Rectangle 3"/>
-          <p:cNvSpPr/>
-          <p:nvPr/>
-        </p:nvSpPr>
-        <p:spPr>
-          <a:xfrm>
-            <a:off x="822960" y="1828800"/>
-            <a:ext cx="6583680" cy="4023360"/>
-          </a:xfrm>
-          <a:prstGeom prst="rect">
-            <a:avLst/>
-          </a:prstGeom>
-          <a:solidFill>
-            <a:srgbClr val="EEECE2"/>
-          </a:solidFill>
-          <a:ln>
-            <a:noFill/>
-          </a:ln>
-        </p:spPr>
-        <p:style>
-          <a:lnRef idx="1">
-            <a:schemeClr val="accent1"/>
-          </a:lnRef>
-          <a:fillRef idx="3">
-            <a:schemeClr val="accent1"/>
-          </a:fillRef>
-          <a:effectRef idx="2">
-            <a:schemeClr val="accent1"/>
-          </a:effectRef>
-          <a:fontRef idx="minor">
-            <a:schemeClr val="lt1"/>
-          </a:fontRef>
-        </p:style>
-        <p:txBody>
-          <a:bodyPr rtlCol="0" anchor="ctr"/>
-          <a:lstStyle/>
-          <a:p>
-            <a:pPr algn="ctr"/>
-          </a:p>
-        </p:txBody>
-      </p:sp>
-      <p:sp>
-        <p:nvSpPr>
-          <p:cNvPr id="5" name="TextBox 4"/>
+              <a:t>Next week: your AI reaches your tools</a:t>
+            </a:r>
+          </a:p>
+        </p:txBody>
+      </p:sp>
+      <p:sp>
+        <p:nvSpPr>
+          <p:cNvPr id="4" name="TextBox 3"/>
           <p:cNvSpPr txBox="1"/>
           <p:nvPr/>
         </p:nvSpPr>
         <p:spPr>
           <a:xfrm>
-            <a:off x="1097280" y="2011680"/>
-            <a:ext cx="6217920" cy="3749039"/>
+            <a:off x="822960" y="2011680"/>
+            <a:ext cx="10607040" cy="4206240"/>
           </a:xfrm>
           <a:prstGeom prst="rect">
             <a:avLst/>
@@ -5345,127 +4582,56 @@
           <a:p>
             <a:pPr>
               <a:spcAft>
-                <a:spcPts val="200"/>
+                <a:spcPts val="2200"/>
               </a:spcAft>
             </a:pPr>
             <a:r>
-              <a:rPr sz="1800" b="0">
+              <a:rPr sz="3000" b="0">
                 <a:solidFill>
                   <a:srgbClr val="272A25"/>
                 </a:solidFill>
-                <a:latin typeface="DejaVu Sans Mono"/>
+                <a:latin typeface="DM Sans"/>
               </a:rPr>
-              <a:t>✗  file:///Users/you/Desktop/project/index.html</a:t>
+              <a:t>•  API: one program asking another for something.</a:t>
             </a:r>
           </a:p>
           <a:p>
             <a:pPr>
               <a:spcAft>
-                <a:spcPts val="200"/>
+                <a:spcPts val="2200"/>
               </a:spcAft>
             </a:pPr>
             <a:r>
-              <a:rPr sz="1800" b="0">
+              <a:rPr sz="3000" b="0">
                 <a:solidFill>
                   <a:srgbClr val="272A25"/>
                 </a:solidFill>
-                <a:latin typeface="DejaVu Sans Mono"/>
+                <a:latin typeface="DM Sans"/>
               </a:rPr>
-              <a:t>     only works on your laptop</a:t>
+              <a:t>•  Connector: your AI reaches your tools directly.</a:t>
             </a:r>
           </a:p>
           <a:p>
             <a:pPr>
               <a:spcAft>
-                <a:spcPts val="200"/>
+                <a:spcPts val="2200"/>
               </a:spcAft>
             </a:pPr>
             <a:r>
-              <a:rPr sz="1800" b="0">
+              <a:rPr sz="3000" b="0">
                 <a:solidFill>
                   <a:srgbClr val="272A25"/>
-                </a:solidFill>
-                <a:latin typeface="DejaVu Sans Mono"/>
-              </a:rPr>
-              <a:t> </a:t>
-            </a:r>
-          </a:p>
-          <a:p>
-            <a:pPr>
-              <a:spcAft>
-                <a:spcPts val="200"/>
-              </a:spcAft>
-            </a:pPr>
-            <a:r>
-              <a:rPr sz="1800" b="0">
-                <a:solidFill>
-                  <a:srgbClr val="272A25"/>
-                </a:solidFill>
-                <a:latin typeface="DejaVu Sans Mono"/>
-              </a:rPr>
-              <a:t>✓  https://you.github.io/project/</a:t>
-            </a:r>
-          </a:p>
-          <a:p>
-            <a:pPr>
-              <a:spcAft>
-                <a:spcPts val="200"/>
-              </a:spcAft>
-            </a:pPr>
-            <a:r>
-              <a:rPr sz="1800" b="0">
-                <a:solidFill>
-                  <a:srgbClr val="272A25"/>
-                </a:solidFill>
-                <a:latin typeface="DejaVu Sans Mono"/>
-              </a:rPr>
-              <a:t>     works for anyone, anywhere</a:t>
-            </a:r>
-          </a:p>
-        </p:txBody>
-      </p:sp>
-      <p:sp>
-        <p:nvSpPr>
-          <p:cNvPr id="6" name="TextBox 5"/>
-          <p:cNvSpPr txBox="1"/>
-          <p:nvPr/>
-        </p:nvSpPr>
-        <p:spPr>
-          <a:xfrm>
-            <a:off x="7772400" y="3108960"/>
-            <a:ext cx="3931920" cy="1828800"/>
-          </a:xfrm>
-          <a:prstGeom prst="rect">
-            <a:avLst/>
-          </a:prstGeom>
-          <a:noFill/>
-        </p:spPr>
-        <p:txBody>
-          <a:bodyPr wrap="square">
-            <a:spAutoFit/>
-          </a:bodyPr>
-          <a:lstStyle/>
-          <a:p>
-            <a:pPr>
-              <a:spcAft>
-                <a:spcPts val="1400"/>
-              </a:spcAft>
-            </a:pPr>
-            <a:r>
-              <a:rPr sz="2800" b="0">
-                <a:solidFill>
-                  <a:srgbClr val="64665D"/>
                 </a:solidFill>
                 <a:latin typeface="DM Sans"/>
               </a:rPr>
-              <a:t>If it starts with file://, nobody else can see it.</a:t>
-            </a:r>
-          </a:p>
-        </p:txBody>
-      </p:sp>
-      <p:sp>
-        <p:nvSpPr>
-          <p:cNvPr id="7" name="TextBox 6"/>
+              <a:t>•  Instead of you pasting. Next week we’ll connect.</a:t>
+            </a:r>
+          </a:p>
+        </p:txBody>
+      </p:sp>
+      <p:sp>
+        <p:nvSpPr>
+          <p:cNvPr id="5" name="TextBox 4"/>
           <p:cNvSpPr txBox="1"/>
           <p:nvPr/>
         </p:nvSpPr>
@@ -5497,7 +4663,7 @@
                 </a:solidFill>
                 <a:latin typeface="DM Sans"/>
               </a:rPr>
-              <a:t>Week 6 · Demo 2 · Get it online        10 / 19</a:t>
+              <a:t>Week 6 · Looking ahead        10 / 12</a:t>
             </a:r>
           </a:p>
         </p:txBody>
@@ -5605,354 +4771,21 @@
                 </a:solidFill>
                 <a:latin typeface="Fraunces"/>
               </a:rPr>
-              <a:t>Three different things</a:t>
-            </a:r>
-          </a:p>
-        </p:txBody>
-      </p:sp>
-      <p:sp>
-        <p:nvSpPr>
-          <p:cNvPr id="4" name="Rounded Rectangle 3"/>
-          <p:cNvSpPr/>
-          <p:nvPr/>
-        </p:nvSpPr>
-        <p:spPr>
-          <a:xfrm>
-            <a:off x="822960" y="2103120"/>
-            <a:ext cx="2377440" cy="1097280"/>
-          </a:xfrm>
-          <a:prstGeom prst="roundRect">
-            <a:avLst/>
-          </a:prstGeom>
-          <a:solidFill>
-            <a:srgbClr val="A83D2B"/>
-          </a:solidFill>
-          <a:ln>
-            <a:noFill/>
-          </a:ln>
-        </p:spPr>
-        <p:style>
-          <a:lnRef idx="1">
-            <a:schemeClr val="accent1"/>
-          </a:lnRef>
-          <a:fillRef idx="3">
-            <a:schemeClr val="accent1"/>
-          </a:fillRef>
-          <a:effectRef idx="2">
-            <a:schemeClr val="accent1"/>
-          </a:effectRef>
-          <a:fontRef idx="minor">
-            <a:schemeClr val="lt1"/>
-          </a:fontRef>
-        </p:style>
-        <p:txBody>
-          <a:bodyPr rtlCol="0" anchor="ctr"/>
-          <a:lstStyle/>
-          <a:p>
-            <a:pPr algn="ctr"/>
-            <a:r>
-              <a:rPr sz="2200" b="1">
-                <a:solidFill>
-                  <a:srgbClr val="FFFFFF"/>
-                </a:solidFill>
-              </a:rPr>
-              <a:t>Folder</a:t>
-            </a:r>
-          </a:p>
-        </p:txBody>
-      </p:sp>
-      <p:sp>
-        <p:nvSpPr>
-          <p:cNvPr id="5" name="Right Arrow 4"/>
-          <p:cNvSpPr/>
-          <p:nvPr/>
-        </p:nvSpPr>
-        <p:spPr>
-          <a:xfrm>
-            <a:off x="3246120" y="2468880"/>
-            <a:ext cx="320040" cy="365760"/>
-          </a:xfrm>
-          <a:prstGeom prst="rightArrow">
-            <a:avLst/>
-          </a:prstGeom>
-          <a:solidFill>
-            <a:srgbClr val="64665D"/>
-          </a:solidFill>
-          <a:ln>
-            <a:noFill/>
-          </a:ln>
-        </p:spPr>
-        <p:style>
-          <a:lnRef idx="1">
-            <a:schemeClr val="accent1"/>
-          </a:lnRef>
-          <a:fillRef idx="3">
-            <a:schemeClr val="accent1"/>
-          </a:fillRef>
-          <a:effectRef idx="2">
-            <a:schemeClr val="accent1"/>
-          </a:effectRef>
-          <a:fontRef idx="minor">
-            <a:schemeClr val="lt1"/>
-          </a:fontRef>
-        </p:style>
-        <p:txBody>
-          <a:bodyPr rtlCol="0" anchor="ctr"/>
-          <a:lstStyle/>
-          <a:p>
-            <a:pPr algn="ctr"/>
-          </a:p>
-        </p:txBody>
-      </p:sp>
-      <p:sp>
-        <p:nvSpPr>
-          <p:cNvPr id="6" name="Rounded Rectangle 5"/>
-          <p:cNvSpPr/>
-          <p:nvPr/>
-        </p:nvSpPr>
-        <p:spPr>
-          <a:xfrm>
-            <a:off x="3611880" y="2103120"/>
-            <a:ext cx="2377440" cy="1097280"/>
-          </a:xfrm>
-          <a:prstGeom prst="roundRect">
-            <a:avLst/>
-          </a:prstGeom>
-          <a:solidFill>
-            <a:srgbClr val="272A25"/>
-          </a:solidFill>
-          <a:ln>
-            <a:noFill/>
-          </a:ln>
-        </p:spPr>
-        <p:style>
-          <a:lnRef idx="1">
-            <a:schemeClr val="accent1"/>
-          </a:lnRef>
-          <a:fillRef idx="3">
-            <a:schemeClr val="accent1"/>
-          </a:fillRef>
-          <a:effectRef idx="2">
-            <a:schemeClr val="accent1"/>
-          </a:effectRef>
-          <a:fontRef idx="minor">
-            <a:schemeClr val="lt1"/>
-          </a:fontRef>
-        </p:style>
-        <p:txBody>
-          <a:bodyPr rtlCol="0" anchor="ctr"/>
-          <a:lstStyle/>
-          <a:p>
-            <a:pPr algn="ctr"/>
-            <a:r>
-              <a:rPr sz="2200" b="1">
-                <a:solidFill>
-                  <a:srgbClr val="FFFFFF"/>
-                </a:solidFill>
-              </a:rPr>
-              <a:t>Commit</a:t>
-            </a:r>
-          </a:p>
-        </p:txBody>
-      </p:sp>
-      <p:sp>
-        <p:nvSpPr>
-          <p:cNvPr id="7" name="Right Arrow 6"/>
-          <p:cNvSpPr/>
-          <p:nvPr/>
-        </p:nvSpPr>
-        <p:spPr>
-          <a:xfrm>
-            <a:off x="6035040" y="2468880"/>
-            <a:ext cx="320040" cy="365760"/>
-          </a:xfrm>
-          <a:prstGeom prst="rightArrow">
-            <a:avLst/>
-          </a:prstGeom>
-          <a:solidFill>
-            <a:srgbClr val="64665D"/>
-          </a:solidFill>
-          <a:ln>
-            <a:noFill/>
-          </a:ln>
-        </p:spPr>
-        <p:style>
-          <a:lnRef idx="1">
-            <a:schemeClr val="accent1"/>
-          </a:lnRef>
-          <a:fillRef idx="3">
-            <a:schemeClr val="accent1"/>
-          </a:fillRef>
-          <a:effectRef idx="2">
-            <a:schemeClr val="accent1"/>
-          </a:effectRef>
-          <a:fontRef idx="minor">
-            <a:schemeClr val="lt1"/>
-          </a:fontRef>
-        </p:style>
-        <p:txBody>
-          <a:bodyPr rtlCol="0" anchor="ctr"/>
-          <a:lstStyle/>
-          <a:p>
-            <a:pPr algn="ctr"/>
-          </a:p>
-        </p:txBody>
-      </p:sp>
-      <p:sp>
-        <p:nvSpPr>
-          <p:cNvPr id="8" name="Rounded Rectangle 7"/>
-          <p:cNvSpPr/>
-          <p:nvPr/>
-        </p:nvSpPr>
-        <p:spPr>
-          <a:xfrm>
-            <a:off x="6400800" y="2103120"/>
-            <a:ext cx="2377440" cy="1097280"/>
-          </a:xfrm>
-          <a:prstGeom prst="roundRect">
-            <a:avLst/>
-          </a:prstGeom>
-          <a:solidFill>
-            <a:srgbClr val="272A25"/>
-          </a:solidFill>
-          <a:ln>
-            <a:noFill/>
-          </a:ln>
-        </p:spPr>
-        <p:style>
-          <a:lnRef idx="1">
-            <a:schemeClr val="accent1"/>
-          </a:lnRef>
-          <a:fillRef idx="3">
-            <a:schemeClr val="accent1"/>
-          </a:fillRef>
-          <a:effectRef idx="2">
-            <a:schemeClr val="accent1"/>
-          </a:effectRef>
-          <a:fontRef idx="minor">
-            <a:schemeClr val="lt1"/>
-          </a:fontRef>
-        </p:style>
-        <p:txBody>
-          <a:bodyPr rtlCol="0" anchor="ctr"/>
-          <a:lstStyle/>
-          <a:p>
-            <a:pPr algn="ctr"/>
-            <a:r>
-              <a:rPr sz="2200" b="1">
-                <a:solidFill>
-                  <a:srgbClr val="FFFFFF"/>
-                </a:solidFill>
-              </a:rPr>
-              <a:t>Push</a:t>
-            </a:r>
-          </a:p>
-        </p:txBody>
-      </p:sp>
-      <p:sp>
-        <p:nvSpPr>
-          <p:cNvPr id="9" name="Right Arrow 8"/>
-          <p:cNvSpPr/>
-          <p:nvPr/>
-        </p:nvSpPr>
-        <p:spPr>
-          <a:xfrm>
-            <a:off x="8823960" y="2468880"/>
-            <a:ext cx="320040" cy="365760"/>
-          </a:xfrm>
-          <a:prstGeom prst="rightArrow">
-            <a:avLst/>
-          </a:prstGeom>
-          <a:solidFill>
-            <a:srgbClr val="64665D"/>
-          </a:solidFill>
-          <a:ln>
-            <a:noFill/>
-          </a:ln>
-        </p:spPr>
-        <p:style>
-          <a:lnRef idx="1">
-            <a:schemeClr val="accent1"/>
-          </a:lnRef>
-          <a:fillRef idx="3">
-            <a:schemeClr val="accent1"/>
-          </a:fillRef>
-          <a:effectRef idx="2">
-            <a:schemeClr val="accent1"/>
-          </a:effectRef>
-          <a:fontRef idx="minor">
-            <a:schemeClr val="lt1"/>
-          </a:fontRef>
-        </p:style>
-        <p:txBody>
-          <a:bodyPr rtlCol="0" anchor="ctr"/>
-          <a:lstStyle/>
-          <a:p>
-            <a:pPr algn="ctr"/>
-          </a:p>
-        </p:txBody>
-      </p:sp>
-      <p:sp>
-        <p:nvSpPr>
-          <p:cNvPr id="10" name="Rounded Rectangle 9"/>
-          <p:cNvSpPr/>
-          <p:nvPr/>
-        </p:nvSpPr>
-        <p:spPr>
-          <a:xfrm>
-            <a:off x="9189720" y="2103120"/>
-            <a:ext cx="2377440" cy="1097280"/>
-          </a:xfrm>
-          <a:prstGeom prst="roundRect">
-            <a:avLst/>
-          </a:prstGeom>
-          <a:solidFill>
-            <a:srgbClr val="272A25"/>
-          </a:solidFill>
-          <a:ln>
-            <a:noFill/>
-          </a:ln>
-        </p:spPr>
-        <p:style>
-          <a:lnRef idx="1">
-            <a:schemeClr val="accent1"/>
-          </a:lnRef>
-          <a:fillRef idx="3">
-            <a:schemeClr val="accent1"/>
-          </a:fillRef>
-          <a:effectRef idx="2">
-            <a:schemeClr val="accent1"/>
-          </a:effectRef>
-          <a:fontRef idx="minor">
-            <a:schemeClr val="lt1"/>
-          </a:fontRef>
-        </p:style>
-        <p:txBody>
-          <a:bodyPr rtlCol="0" anchor="ctr"/>
-          <a:lstStyle/>
-          <a:p>
-            <a:pPr algn="ctr"/>
-            <a:r>
-              <a:rPr sz="2200" b="1">
-                <a:solidFill>
-                  <a:srgbClr val="FFFFFF"/>
-                </a:solidFill>
-              </a:rPr>
-              <a:t>Live link</a:t>
-            </a:r>
-          </a:p>
-        </p:txBody>
-      </p:sp>
-      <p:sp>
-        <p:nvSpPr>
-          <p:cNvPr id="11" name="TextBox 10"/>
+              <a:t>This week’s reading: your AI as a coach</a:t>
+            </a:r>
+          </a:p>
+        </p:txBody>
+      </p:sp>
+      <p:sp>
+        <p:nvSpPr>
+          <p:cNvPr id="4" name="TextBox 3"/>
           <p:cNvSpPr txBox="1"/>
           <p:nvPr/>
         </p:nvSpPr>
         <p:spPr>
           <a:xfrm>
-            <a:off x="822960" y="3931920"/>
-            <a:ext cx="10607040" cy="2286000"/>
+            <a:off x="822960" y="2011680"/>
+            <a:ext cx="10607040" cy="4206240"/>
           </a:xfrm>
           <a:prstGeom prst="rect">
             <a:avLst/>
@@ -5967,56 +4800,56 @@
           <a:p>
             <a:pPr>
               <a:spcAft>
-                <a:spcPts val="1800"/>
+                <a:spcPts val="2200"/>
               </a:spcAft>
             </a:pPr>
             <a:r>
-              <a:rPr sz="2800" b="0">
+              <a:rPr sz="3000" b="0">
                 <a:solidFill>
                   <a:srgbClr val="272A25"/>
                 </a:solidFill>
                 <a:latin typeface="DM Sans"/>
               </a:rPr>
-              <a:t>•  Git: save points for your project, on your laptop</a:t>
+              <a:t>•  Arielle Shipper · How to Get Better at AI by Asking AI</a:t>
             </a:r>
           </a:p>
           <a:p>
             <a:pPr>
               <a:spcAft>
-                <a:spcPts val="1800"/>
+                <a:spcPts val="2200"/>
               </a:spcAft>
             </a:pPr>
             <a:r>
-              <a:rPr sz="2800" b="0">
+              <a:rPr sz="3000" b="0">
                 <a:solidFill>
                   <a:srgbClr val="272A25"/>
                 </a:solidFill>
                 <a:latin typeface="DM Sans"/>
               </a:rPr>
-              <a:t>•  GitHub: a copy of those save points, online</a:t>
+              <a:t>•  Give your AI examples of how you’ve worked.</a:t>
             </a:r>
           </a:p>
           <a:p>
             <a:pPr>
               <a:spcAft>
-                <a:spcPts val="1800"/>
+                <a:spcPts val="2200"/>
               </a:spcAft>
             </a:pPr>
             <a:r>
-              <a:rPr sz="2800" b="0">
+              <a:rPr sz="3000" b="0">
                 <a:solidFill>
                   <a:srgbClr val="272A25"/>
                 </a:solidFill>
                 <a:latin typeface="DM Sans"/>
               </a:rPr>
-              <a:t>•  Pages / Vercel: turns that copy into a website</a:t>
-            </a:r>
-          </a:p>
-        </p:txBody>
-      </p:sp>
-      <p:sp>
-        <p:nvSpPr>
-          <p:cNvPr id="12" name="TextBox 11"/>
+              <a:t>•  Ask it to teach you one next step.</a:t>
+            </a:r>
+          </a:p>
+        </p:txBody>
+      </p:sp>
+      <p:sp>
+        <p:nvSpPr>
+          <p:cNvPr id="5" name="TextBox 4"/>
           <p:cNvSpPr txBox="1"/>
           <p:nvPr/>
         </p:nvSpPr>
@@ -6048,7 +4881,7 @@
                 </a:solidFill>
                 <a:latin typeface="DM Sans"/>
               </a:rPr>
-              <a:t>Week 6 · Demo 2 · Get it online        11 / 19</a:t>
+              <a:t>Week 6 · Close        11 / 12</a:t>
             </a:r>
           </a:p>
         </p:txBody>
@@ -6156,64 +4989,21 @@
                 </a:solidFill>
                 <a:latin typeface="Fraunces"/>
               </a:rPr>
-              <a:t>Live demo · from folder to link</a:t>
-            </a:r>
-          </a:p>
-        </p:txBody>
-      </p:sp>
-      <p:sp>
-        <p:nvSpPr>
-          <p:cNvPr id="4" name="Rectangle 3"/>
-          <p:cNvSpPr/>
-          <p:nvPr/>
-        </p:nvSpPr>
-        <p:spPr>
-          <a:xfrm>
-            <a:off x="822960" y="1828800"/>
-            <a:ext cx="6583680" cy="4023360"/>
-          </a:xfrm>
-          <a:prstGeom prst="rect">
-            <a:avLst/>
-          </a:prstGeom>
-          <a:solidFill>
-            <a:srgbClr val="EEECE2"/>
-          </a:solidFill>
-          <a:ln>
-            <a:noFill/>
-          </a:ln>
-        </p:spPr>
-        <p:style>
-          <a:lnRef idx="1">
-            <a:schemeClr val="accent1"/>
-          </a:lnRef>
-          <a:fillRef idx="3">
-            <a:schemeClr val="accent1"/>
-          </a:fillRef>
-          <a:effectRef idx="2">
-            <a:schemeClr val="accent1"/>
-          </a:effectRef>
-          <a:fontRef idx="minor">
-            <a:schemeClr val="lt1"/>
-          </a:fontRef>
-        </p:style>
-        <p:txBody>
-          <a:bodyPr rtlCol="0" anchor="ctr"/>
-          <a:lstStyle/>
-          <a:p>
-            <a:pPr algn="ctr"/>
-          </a:p>
-        </p:txBody>
-      </p:sp>
-      <p:sp>
-        <p:nvSpPr>
-          <p:cNvPr id="5" name="TextBox 4"/>
+              <a:t>Studio: build</a:t>
+            </a:r>
+          </a:p>
+        </p:txBody>
+      </p:sp>
+      <p:sp>
+        <p:nvSpPr>
+          <p:cNvPr id="4" name="TextBox 3"/>
           <p:cNvSpPr txBox="1"/>
           <p:nvPr/>
         </p:nvSpPr>
         <p:spPr>
           <a:xfrm>
-            <a:off x="1097280" y="2011680"/>
-            <a:ext cx="6217920" cy="3749039"/>
+            <a:off x="822960" y="2011680"/>
+            <a:ext cx="10607040" cy="4206240"/>
           </a:xfrm>
           <a:prstGeom prst="rect">
             <a:avLst/>
@@ -6228,127 +5018,56 @@
           <a:p>
             <a:pPr>
               <a:spcAft>
-                <a:spcPts val="200"/>
+                <a:spcPts val="2200"/>
               </a:spcAft>
             </a:pPr>
             <a:r>
-              <a:rPr sz="1800" b="0">
+              <a:rPr sz="3000" b="0">
                 <a:solidFill>
                   <a:srgbClr val="272A25"/>
                 </a:solidFill>
-                <a:latin typeface="DejaVu Sans Mono"/>
+                <a:latin typeface="DM Sans"/>
               </a:rPr>
-              <a:t>1 · Download the project folder</a:t>
+              <a:t>•  Work on your project.</a:t>
             </a:r>
           </a:p>
           <a:p>
             <a:pPr>
               <a:spcAft>
-                <a:spcPts val="200"/>
+                <a:spcPts val="2200"/>
               </a:spcAft>
             </a:pPr>
             <a:r>
-              <a:rPr sz="1800" b="0">
+              <a:rPr sz="3000" b="0">
                 <a:solidFill>
                   <a:srgbClr val="272A25"/>
                 </a:solidFill>
-                <a:latin typeface="DejaVu Sans Mono"/>
+                <a:latin typeface="DM Sans"/>
               </a:rPr>
-              <a:t>2 · GitHub Desktop: create repo, commit, publish</a:t>
+              <a:t>•  Optional: ask your AI what it needs to know.</a:t>
             </a:r>
           </a:p>
           <a:p>
             <a:pPr>
               <a:spcAft>
-                <a:spcPts val="200"/>
+                <a:spcPts val="2200"/>
               </a:spcAft>
             </a:pPr>
             <a:r>
-              <a:rPr sz="1800" b="0">
+              <a:rPr sz="3000" b="0">
                 <a:solidFill>
                   <a:srgbClr val="272A25"/>
-                </a:solidFill>
-                <a:latin typeface="DejaVu Sans Mono"/>
-              </a:rPr>
-              <a:t>3 · Settings → Pages → main → Save</a:t>
-            </a:r>
-          </a:p>
-          <a:p>
-            <a:pPr>
-              <a:spcAft>
-                <a:spcPts val="200"/>
-              </a:spcAft>
-            </a:pPr>
-            <a:r>
-              <a:rPr sz="1800" b="0">
-                <a:solidFill>
-                  <a:srgbClr val="272A25"/>
-                </a:solidFill>
-                <a:latin typeface="DejaVu Sans Mono"/>
-              </a:rPr>
-              <a:t>4 · Open the link on a phone</a:t>
-            </a:r>
-          </a:p>
-          <a:p>
-            <a:pPr>
-              <a:spcAft>
-                <a:spcPts val="200"/>
-              </a:spcAft>
-            </a:pPr>
-            <a:r>
-              <a:rPr sz="1800" b="0">
-                <a:solidFill>
-                  <a:srgbClr val="272A25"/>
-                </a:solidFill>
-                <a:latin typeface="DejaVu Sans Mono"/>
-              </a:rPr>
-              <a:t>5 · Change something, commit, push, refresh</a:t>
-            </a:r>
-          </a:p>
-        </p:txBody>
-      </p:sp>
-      <p:sp>
-        <p:nvSpPr>
-          <p:cNvPr id="6" name="TextBox 5"/>
-          <p:cNvSpPr txBox="1"/>
-          <p:nvPr/>
-        </p:nvSpPr>
-        <p:spPr>
-          <a:xfrm>
-            <a:off x="7772400" y="3108960"/>
-            <a:ext cx="3931920" cy="1828800"/>
-          </a:xfrm>
-          <a:prstGeom prst="rect">
-            <a:avLst/>
-          </a:prstGeom>
-          <a:noFill/>
-        </p:spPr>
-        <p:txBody>
-          <a:bodyPr wrap="square">
-            <a:spAutoFit/>
-          </a:bodyPr>
-          <a:lstStyle/>
-          <a:p>
-            <a:pPr>
-              <a:spcAft>
-                <a:spcPts val="1400"/>
-              </a:spcAft>
-            </a:pPr>
-            <a:r>
-              <a:rPr sz="2800" b="0">
-                <a:solidFill>
-                  <a:srgbClr val="64665D"/>
                 </a:solidFill>
                 <a:latin typeface="DM Sans"/>
               </a:rPr>
-              <a:t>Handout: “Get your project online”, step by step.</a:t>
-            </a:r>
-          </a:p>
-        </p:txBody>
-      </p:sp>
-      <p:sp>
-        <p:nvSpPr>
-          <p:cNvPr id="7" name="TextBox 6"/>
+              <a:t>•  Save that context as a markdown file.</a:t>
+            </a:r>
+          </a:p>
+        </p:txBody>
+      </p:sp>
+      <p:sp>
+        <p:nvSpPr>
+          <p:cNvPr id="5" name="TextBox 4"/>
           <p:cNvSpPr txBox="1"/>
           <p:nvPr/>
         </p:nvSpPr>
@@ -6380,1613 +5099,7 @@
                 </a:solidFill>
                 <a:latin typeface="DM Sans"/>
               </a:rPr>
-              <a:t>Week 6 · Demo 2 · Get it online        12 / 19</a:t>
-            </a:r>
-          </a:p>
-        </p:txBody>
-      </p:sp>
-    </p:spTree>
-  </p:cSld>
-  <p:clrMapOvr>
-    <a:masterClrMapping/>
-  </p:clrMapOvr>
-</p:sld>
-</file>
-
-<file path=ppt/slides/slide13.xml><?xml version="1.0" encoding="utf-8"?>
-<p:sld xmlns:a="http://schemas.openxmlformats.org/drawingml/2006/main" xmlns:p="http://schemas.openxmlformats.org/presentationml/2006/main" xmlns:r="http://schemas.openxmlformats.org/officeDocument/2006/relationships">
-  <p:cSld>
-    <p:bg>
-      <p:bgPr>
-        <a:solidFill>
-          <a:srgbClr val="F7F5EE"/>
-        </a:solidFill>
-        <a:effectLst/>
-      </p:bgPr>
-    </p:bg>
-    <p:spTree>
-      <p:nvGrpSpPr>
-        <p:cNvPr id="1" name=""/>
-        <p:cNvGrpSpPr/>
-        <p:nvPr/>
-      </p:nvGrpSpPr>
-      <p:grpSpPr/>
-      <p:sp>
-        <p:nvSpPr>
-          <p:cNvPr id="2" name="Rectangle 1"/>
-          <p:cNvSpPr/>
-          <p:nvPr/>
-        </p:nvSpPr>
-        <p:spPr>
-          <a:xfrm>
-            <a:off x="0" y="0"/>
-            <a:ext cx="228600" cy="6858000"/>
-          </a:xfrm>
-          <a:prstGeom prst="rect">
-            <a:avLst/>
-          </a:prstGeom>
-          <a:solidFill>
-            <a:srgbClr val="A83D2B"/>
-          </a:solidFill>
-          <a:ln>
-            <a:noFill/>
-          </a:ln>
-        </p:spPr>
-        <p:style>
-          <a:lnRef idx="1">
-            <a:schemeClr val="accent1"/>
-          </a:lnRef>
-          <a:fillRef idx="3">
-            <a:schemeClr val="accent1"/>
-          </a:fillRef>
-          <a:effectRef idx="2">
-            <a:schemeClr val="accent1"/>
-          </a:effectRef>
-          <a:fontRef idx="minor">
-            <a:schemeClr val="lt1"/>
-          </a:fontRef>
-        </p:style>
-        <p:txBody>
-          <a:bodyPr rtlCol="0" anchor="ctr"/>
-          <a:lstStyle/>
-          <a:p>
-            <a:pPr algn="ctr"/>
-          </a:p>
-        </p:txBody>
-      </p:sp>
-      <p:sp>
-        <p:nvSpPr>
-          <p:cNvPr id="3" name="TextBox 2"/>
-          <p:cNvSpPr txBox="1"/>
-          <p:nvPr/>
-        </p:nvSpPr>
-        <p:spPr>
-          <a:xfrm>
-            <a:off x="822960" y="548640"/>
-            <a:ext cx="10607040" cy="1188720"/>
-          </a:xfrm>
-          <a:prstGeom prst="rect">
-            <a:avLst/>
-          </a:prstGeom>
-          <a:noFill/>
-        </p:spPr>
-        <p:txBody>
-          <a:bodyPr wrap="square">
-            <a:spAutoFit/>
-          </a:bodyPr>
-          <a:lstStyle/>
-          <a:p>
-            <a:pPr>
-              <a:spcAft>
-                <a:spcPts val="1400"/>
-              </a:spcAft>
-            </a:pPr>
-            <a:r>
-              <a:rPr sz="4000" b="1">
-                <a:solidFill>
-                  <a:srgbClr val="272A25"/>
-                </a:solidFill>
-                <a:latin typeface="Fraunces"/>
-              </a:rPr>
-              <a:t>When the link doesn't work</a:t>
-            </a:r>
-          </a:p>
-        </p:txBody>
-      </p:sp>
-      <p:sp>
-        <p:nvSpPr>
-          <p:cNvPr id="4" name="TextBox 3"/>
-          <p:cNvSpPr txBox="1"/>
-          <p:nvPr/>
-        </p:nvSpPr>
-        <p:spPr>
-          <a:xfrm>
-            <a:off x="822960" y="2011680"/>
-            <a:ext cx="10607040" cy="4206240"/>
-          </a:xfrm>
-          <a:prstGeom prst="rect">
-            <a:avLst/>
-          </a:prstGeom>
-          <a:noFill/>
-        </p:spPr>
-        <p:txBody>
-          <a:bodyPr wrap="square">
-            <a:spAutoFit/>
-          </a:bodyPr>
-          <a:lstStyle/>
-          <a:p>
-            <a:pPr>
-              <a:spcAft>
-                <a:spcPts val="1600"/>
-              </a:spcAft>
-            </a:pPr>
-            <a:r>
-              <a:rPr sz="2600" b="0">
-                <a:solidFill>
-                  <a:srgbClr val="272A25"/>
-                </a:solidFill>
-                <a:latin typeface="DM Sans"/>
-              </a:rPr>
-              <a:t>•  404: wait 1–2 min, then check Settings → Pages</a:t>
-            </a:r>
-          </a:p>
-          <a:p>
-            <a:pPr>
-              <a:spcAft>
-                <a:spcPts val="1600"/>
-              </a:spcAft>
-            </a:pPr>
-            <a:r>
-              <a:rPr sz="2600" b="0">
-                <a:solidFill>
-                  <a:srgbClr val="272A25"/>
-                </a:solidFill>
-                <a:latin typeface="DM Sans"/>
-              </a:rPr>
-              <a:t>•  Page with no styles: paths start with / (use style.css)</a:t>
-            </a:r>
-          </a:p>
-          <a:p>
-            <a:pPr>
-              <a:spcAft>
-                <a:spcPts val="1600"/>
-              </a:spcAft>
-            </a:pPr>
-            <a:r>
-              <a:rPr sz="2600" b="0">
-                <a:solidFill>
-                  <a:srgbClr val="272A25"/>
-                </a:solidFill>
-                <a:latin typeface="DM Sans"/>
-              </a:rPr>
-              <a:t>•  Only the README shows: index.html must be in the top folder</a:t>
-            </a:r>
-          </a:p>
-          <a:p>
-            <a:pPr>
-              <a:spcAft>
-                <a:spcPts val="1600"/>
-              </a:spcAft>
-            </a:pPr>
-            <a:r>
-              <a:rPr sz="2600" b="0">
-                <a:solidFill>
-                  <a:srgbClr val="272A25"/>
-                </a:solidFill>
-                <a:latin typeface="DM Sans"/>
-              </a:rPr>
-              <a:t>•  Old version: hard refresh, or wait a minute</a:t>
-            </a:r>
-          </a:p>
-          <a:p>
-            <a:pPr>
-              <a:spcAft>
-                <a:spcPts val="1600"/>
-              </a:spcAft>
-            </a:pPr>
-            <a:r>
-              <a:rPr sz="2600" b="0">
-                <a:solidFill>
-                  <a:srgbClr val="272A25"/>
-                </a:solidFill>
-                <a:latin typeface="DM Sans"/>
-              </a:rPr>
-              <a:t>•  Private repo on a free plan: make it public, or use Vercel</a:t>
-            </a:r>
-          </a:p>
-        </p:txBody>
-      </p:sp>
-      <p:sp>
-        <p:nvSpPr>
-          <p:cNvPr id="5" name="TextBox 4"/>
-          <p:cNvSpPr txBox="1"/>
-          <p:nvPr/>
-        </p:nvSpPr>
-        <p:spPr>
-          <a:xfrm>
-            <a:off x="822960" y="6263640"/>
-            <a:ext cx="10607040" cy="365760"/>
-          </a:xfrm>
-          <a:prstGeom prst="rect">
-            <a:avLst/>
-          </a:prstGeom>
-          <a:noFill/>
-        </p:spPr>
-        <p:txBody>
-          <a:bodyPr wrap="square">
-            <a:spAutoFit/>
-          </a:bodyPr>
-          <a:lstStyle/>
-          <a:p>
-            <a:pPr algn="r">
-              <a:spcAft>
-                <a:spcPts val="1400"/>
-              </a:spcAft>
-            </a:pPr>
-            <a:r>
-              <a:rPr sz="1600" b="0">
-                <a:solidFill>
-                  <a:srgbClr val="64665D"/>
-                </a:solidFill>
-                <a:latin typeface="DM Sans"/>
-              </a:rPr>
-              <a:t>Week 6 · Demo 2 · Get it online        13 / 19</a:t>
-            </a:r>
-          </a:p>
-        </p:txBody>
-      </p:sp>
-    </p:spTree>
-  </p:cSld>
-  <p:clrMapOvr>
-    <a:masterClrMapping/>
-  </p:clrMapOvr>
-</p:sld>
-</file>
-
-<file path=ppt/slides/slide14.xml><?xml version="1.0" encoding="utf-8"?>
-<p:sld xmlns:a="http://schemas.openxmlformats.org/drawingml/2006/main" xmlns:p="http://schemas.openxmlformats.org/presentationml/2006/main" xmlns:r="http://schemas.openxmlformats.org/officeDocument/2006/relationships">
-  <p:cSld>
-    <p:bg>
-      <p:bgPr>
-        <a:solidFill>
-          <a:srgbClr val="F7F5EE"/>
-        </a:solidFill>
-        <a:effectLst/>
-      </p:bgPr>
-    </p:bg>
-    <p:spTree>
-      <p:nvGrpSpPr>
-        <p:cNvPr id="1" name=""/>
-        <p:cNvGrpSpPr/>
-        <p:nvPr/>
-      </p:nvGrpSpPr>
-      <p:grpSpPr/>
-      <p:sp>
-        <p:nvSpPr>
-          <p:cNvPr id="2" name="Rectangle 1"/>
-          <p:cNvSpPr/>
-          <p:nvPr/>
-        </p:nvSpPr>
-        <p:spPr>
-          <a:xfrm>
-            <a:off x="0" y="0"/>
-            <a:ext cx="228600" cy="6858000"/>
-          </a:xfrm>
-          <a:prstGeom prst="rect">
-            <a:avLst/>
-          </a:prstGeom>
-          <a:solidFill>
-            <a:srgbClr val="A83D2B"/>
-          </a:solidFill>
-          <a:ln>
-            <a:noFill/>
-          </a:ln>
-        </p:spPr>
-        <p:style>
-          <a:lnRef idx="1">
-            <a:schemeClr val="accent1"/>
-          </a:lnRef>
-          <a:fillRef idx="3">
-            <a:schemeClr val="accent1"/>
-          </a:fillRef>
-          <a:effectRef idx="2">
-            <a:schemeClr val="accent1"/>
-          </a:effectRef>
-          <a:fontRef idx="minor">
-            <a:schemeClr val="lt1"/>
-          </a:fontRef>
-        </p:style>
-        <p:txBody>
-          <a:bodyPr rtlCol="0" anchor="ctr"/>
-          <a:lstStyle/>
-          <a:p>
-            <a:pPr algn="ctr"/>
-          </a:p>
-        </p:txBody>
-      </p:sp>
-      <p:sp>
-        <p:nvSpPr>
-          <p:cNvPr id="3" name="TextBox 2"/>
-          <p:cNvSpPr txBox="1"/>
-          <p:nvPr/>
-        </p:nvSpPr>
-        <p:spPr>
-          <a:xfrm>
-            <a:off x="822960" y="548640"/>
-            <a:ext cx="10607040" cy="1188720"/>
-          </a:xfrm>
-          <a:prstGeom prst="rect">
-            <a:avLst/>
-          </a:prstGeom>
-          <a:noFill/>
-        </p:spPr>
-        <p:txBody>
-          <a:bodyPr wrap="square">
-            <a:spAutoFit/>
-          </a:bodyPr>
-          <a:lstStyle/>
-          <a:p>
-            <a:pPr>
-              <a:spcAft>
-                <a:spcPts val="1400"/>
-              </a:spcAft>
-            </a:pPr>
-            <a:r>
-              <a:rPr sz="4000" b="1">
-                <a:solidFill>
-                  <a:srgbClr val="272A25"/>
-                </a:solidFill>
-                <a:latin typeface="Fraunces"/>
-              </a:rPr>
-              <a:t>API vs. MCP</a:t>
-            </a:r>
-          </a:p>
-        </p:txBody>
-      </p:sp>
-      <p:sp>
-        <p:nvSpPr>
-          <p:cNvPr id="4" name="TextBox 3"/>
-          <p:cNvSpPr txBox="1"/>
-          <p:nvPr/>
-        </p:nvSpPr>
-        <p:spPr>
-          <a:xfrm>
-            <a:off x="822960" y="2011680"/>
-            <a:ext cx="10607040" cy="4206240"/>
-          </a:xfrm>
-          <a:prstGeom prst="rect">
-            <a:avLst/>
-          </a:prstGeom>
-          <a:noFill/>
-        </p:spPr>
-        <p:txBody>
-          <a:bodyPr wrap="square">
-            <a:spAutoFit/>
-          </a:bodyPr>
-          <a:lstStyle/>
-          <a:p>
-            <a:pPr>
-              <a:spcAft>
-                <a:spcPts val="2200"/>
-              </a:spcAft>
-            </a:pPr>
-            <a:r>
-              <a:rPr sz="3000" b="0">
-                <a:solidFill>
-                  <a:srgbClr val="272A25"/>
-                </a:solidFill>
-                <a:latin typeface="DM Sans"/>
-              </a:rPr>
-              <a:t>•  API: one service's own menu of requests</a:t>
-            </a:r>
-          </a:p>
-          <a:p>
-            <a:pPr>
-              <a:spcAft>
-                <a:spcPts val="2200"/>
-              </a:spcAft>
-            </a:pPr>
-            <a:r>
-              <a:rPr sz="3000" b="0">
-                <a:solidFill>
-                  <a:srgbClr val="272A25"/>
-                </a:solidFill>
-                <a:latin typeface="DM Sans"/>
-              </a:rPr>
-              <a:t>•  MCP: one standard plug for AI apps to use many tools</a:t>
-            </a:r>
-          </a:p>
-          <a:p>
-            <a:pPr>
-              <a:spcAft>
-                <a:spcPts val="2200"/>
-              </a:spcAft>
-            </a:pPr>
-            <a:r>
-              <a:rPr sz="3000" b="0">
-                <a:solidFill>
-                  <a:srgbClr val="272A25"/>
-                </a:solidFill>
-                <a:latin typeface="DM Sans"/>
-              </a:rPr>
-              <a:t>•  MCP servers often call APIs underneath</a:t>
-            </a:r>
-          </a:p>
-        </p:txBody>
-      </p:sp>
-      <p:sp>
-        <p:nvSpPr>
-          <p:cNvPr id="5" name="TextBox 4"/>
-          <p:cNvSpPr txBox="1"/>
-          <p:nvPr/>
-        </p:nvSpPr>
-        <p:spPr>
-          <a:xfrm>
-            <a:off x="822960" y="6263640"/>
-            <a:ext cx="10607040" cy="365760"/>
-          </a:xfrm>
-          <a:prstGeom prst="rect">
-            <a:avLst/>
-          </a:prstGeom>
-          <a:noFill/>
-        </p:spPr>
-        <p:txBody>
-          <a:bodyPr wrap="square">
-            <a:spAutoFit/>
-          </a:bodyPr>
-          <a:lstStyle/>
-          <a:p>
-            <a:pPr algn="r">
-              <a:spcAft>
-                <a:spcPts val="1400"/>
-              </a:spcAft>
-            </a:pPr>
-            <a:r>
-              <a:rPr sz="1600" b="0">
-                <a:solidFill>
-                  <a:srgbClr val="64665D"/>
-                </a:solidFill>
-                <a:latin typeface="DM Sans"/>
-              </a:rPr>
-              <a:t>Week 6 · Demo 3 · Connectors        14 / 19</a:t>
-            </a:r>
-          </a:p>
-        </p:txBody>
-      </p:sp>
-    </p:spTree>
-  </p:cSld>
-  <p:clrMapOvr>
-    <a:masterClrMapping/>
-  </p:clrMapOvr>
-</p:sld>
-</file>
-
-<file path=ppt/slides/slide15.xml><?xml version="1.0" encoding="utf-8"?>
-<p:sld xmlns:a="http://schemas.openxmlformats.org/drawingml/2006/main" xmlns:p="http://schemas.openxmlformats.org/presentationml/2006/main" xmlns:r="http://schemas.openxmlformats.org/officeDocument/2006/relationships">
-  <p:cSld>
-    <p:bg>
-      <p:bgPr>
-        <a:solidFill>
-          <a:srgbClr val="F7F5EE"/>
-        </a:solidFill>
-        <a:effectLst/>
-      </p:bgPr>
-    </p:bg>
-    <p:spTree>
-      <p:nvGrpSpPr>
-        <p:cNvPr id="1" name=""/>
-        <p:cNvGrpSpPr/>
-        <p:nvPr/>
-      </p:nvGrpSpPr>
-      <p:grpSpPr/>
-      <p:sp>
-        <p:nvSpPr>
-          <p:cNvPr id="2" name="Rectangle 1"/>
-          <p:cNvSpPr/>
-          <p:nvPr/>
-        </p:nvSpPr>
-        <p:spPr>
-          <a:xfrm>
-            <a:off x="0" y="0"/>
-            <a:ext cx="228600" cy="6858000"/>
-          </a:xfrm>
-          <a:prstGeom prst="rect">
-            <a:avLst/>
-          </a:prstGeom>
-          <a:solidFill>
-            <a:srgbClr val="A83D2B"/>
-          </a:solidFill>
-          <a:ln>
-            <a:noFill/>
-          </a:ln>
-        </p:spPr>
-        <p:style>
-          <a:lnRef idx="1">
-            <a:schemeClr val="accent1"/>
-          </a:lnRef>
-          <a:fillRef idx="3">
-            <a:schemeClr val="accent1"/>
-          </a:fillRef>
-          <a:effectRef idx="2">
-            <a:schemeClr val="accent1"/>
-          </a:effectRef>
-          <a:fontRef idx="minor">
-            <a:schemeClr val="lt1"/>
-          </a:fontRef>
-        </p:style>
-        <p:txBody>
-          <a:bodyPr rtlCol="0" anchor="ctr"/>
-          <a:lstStyle/>
-          <a:p>
-            <a:pPr algn="ctr"/>
-          </a:p>
-        </p:txBody>
-      </p:sp>
-      <p:sp>
-        <p:nvSpPr>
-          <p:cNvPr id="3" name="TextBox 2"/>
-          <p:cNvSpPr txBox="1"/>
-          <p:nvPr/>
-        </p:nvSpPr>
-        <p:spPr>
-          <a:xfrm>
-            <a:off x="822960" y="548640"/>
-            <a:ext cx="10607040" cy="1188720"/>
-          </a:xfrm>
-          <a:prstGeom prst="rect">
-            <a:avLst/>
-          </a:prstGeom>
-          <a:noFill/>
-        </p:spPr>
-        <p:txBody>
-          <a:bodyPr wrap="square">
-            <a:spAutoFit/>
-          </a:bodyPr>
-          <a:lstStyle/>
-          <a:p>
-            <a:pPr>
-              <a:spcAft>
-                <a:spcPts val="1400"/>
-              </a:spcAft>
-            </a:pPr>
-            <a:r>
-              <a:rPr sz="3200" b="1">
-                <a:solidFill>
-                  <a:srgbClr val="272A25"/>
-                </a:solidFill>
-                <a:latin typeface="Fraunces"/>
-              </a:rPr>
-              <a:t>Live demo · connect your AI to this course</a:t>
-            </a:r>
-          </a:p>
-        </p:txBody>
-      </p:sp>
-      <p:sp>
-        <p:nvSpPr>
-          <p:cNvPr id="4" name="TextBox 3"/>
-          <p:cNvSpPr txBox="1"/>
-          <p:nvPr/>
-        </p:nvSpPr>
-        <p:spPr>
-          <a:xfrm>
-            <a:off x="822960" y="2011680"/>
-            <a:ext cx="10607040" cy="4206240"/>
-          </a:xfrm>
-          <a:prstGeom prst="rect">
-            <a:avLst/>
-          </a:prstGeom>
-          <a:noFill/>
-        </p:spPr>
-        <p:txBody>
-          <a:bodyPr wrap="square">
-            <a:spAutoFit/>
-          </a:bodyPr>
-          <a:lstStyle/>
-          <a:p>
-            <a:pPr>
-              <a:spcAft>
-                <a:spcPts val="2200"/>
-              </a:spcAft>
-            </a:pPr>
-            <a:r>
-              <a:rPr sz="3000" b="0">
-                <a:solidFill>
-                  <a:srgbClr val="272A25"/>
-                </a:solidFill>
-                <a:latin typeface="DM Sans"/>
-              </a:rPr>
-              <a:t>•  https://api.learnvibe.build/mcp</a:t>
-            </a:r>
-          </a:p>
-          <a:p>
-            <a:pPr>
-              <a:spcAft>
-                <a:spcPts val="2200"/>
-              </a:spcAft>
-            </a:pPr>
-            <a:r>
-              <a:rPr sz="3000" b="0">
-                <a:solidFill>
-                  <a:srgbClr val="272A25"/>
-                </a:solidFill>
-                <a:latin typeface="DM Sans"/>
-              </a:rPr>
-              <a:t>•  Add it as a custom connector (or `claude mcp add`)</a:t>
-            </a:r>
-          </a:p>
-          <a:p>
-            <a:pPr>
-              <a:spcAft>
-                <a:spcPts val="2200"/>
-              </a:spcAft>
-            </a:pPr>
-            <a:r>
-              <a:rPr sz="3000" b="0">
-                <a:solidFill>
-                  <a:srgbClr val="272A25"/>
-                </a:solidFill>
-                <a:latin typeface="DM Sans"/>
-              </a:rPr>
-              <a:t>•  Ask: “Using the course connector, teach me tonight's lesson on AGENTS.md, then quiz me.”</a:t>
-            </a:r>
-          </a:p>
-        </p:txBody>
-      </p:sp>
-      <p:sp>
-        <p:nvSpPr>
-          <p:cNvPr id="5" name="TextBox 4"/>
-          <p:cNvSpPr txBox="1"/>
-          <p:nvPr/>
-        </p:nvSpPr>
-        <p:spPr>
-          <a:xfrm>
-            <a:off x="822960" y="6263640"/>
-            <a:ext cx="10607040" cy="365760"/>
-          </a:xfrm>
-          <a:prstGeom prst="rect">
-            <a:avLst/>
-          </a:prstGeom>
-          <a:noFill/>
-        </p:spPr>
-        <p:txBody>
-          <a:bodyPr wrap="square">
-            <a:spAutoFit/>
-          </a:bodyPr>
-          <a:lstStyle/>
-          <a:p>
-            <a:pPr algn="r">
-              <a:spcAft>
-                <a:spcPts val="1400"/>
-              </a:spcAft>
-            </a:pPr>
-            <a:r>
-              <a:rPr sz="1600" b="0">
-                <a:solidFill>
-                  <a:srgbClr val="64665D"/>
-                </a:solidFill>
-                <a:latin typeface="DM Sans"/>
-              </a:rPr>
-              <a:t>Week 6 · Demo 3 · Connectors        15 / 19</a:t>
-            </a:r>
-          </a:p>
-        </p:txBody>
-      </p:sp>
-    </p:spTree>
-  </p:cSld>
-  <p:clrMapOvr>
-    <a:masterClrMapping/>
-  </p:clrMapOvr>
-</p:sld>
-</file>
-
-<file path=ppt/slides/slide16.xml><?xml version="1.0" encoding="utf-8"?>
-<p:sld xmlns:a="http://schemas.openxmlformats.org/drawingml/2006/main" xmlns:p="http://schemas.openxmlformats.org/presentationml/2006/main" xmlns:r="http://schemas.openxmlformats.org/officeDocument/2006/relationships">
-  <p:cSld>
-    <p:bg>
-      <p:bgPr>
-        <a:solidFill>
-          <a:srgbClr val="F7F5EE"/>
-        </a:solidFill>
-        <a:effectLst/>
-      </p:bgPr>
-    </p:bg>
-    <p:spTree>
-      <p:nvGrpSpPr>
-        <p:cNvPr id="1" name=""/>
-        <p:cNvGrpSpPr/>
-        <p:nvPr/>
-      </p:nvGrpSpPr>
-      <p:grpSpPr/>
-      <p:sp>
-        <p:nvSpPr>
-          <p:cNvPr id="2" name="Rectangle 1"/>
-          <p:cNvSpPr/>
-          <p:nvPr/>
-        </p:nvSpPr>
-        <p:spPr>
-          <a:xfrm>
-            <a:off x="0" y="0"/>
-            <a:ext cx="228600" cy="6858000"/>
-          </a:xfrm>
-          <a:prstGeom prst="rect">
-            <a:avLst/>
-          </a:prstGeom>
-          <a:solidFill>
-            <a:srgbClr val="A83D2B"/>
-          </a:solidFill>
-          <a:ln>
-            <a:noFill/>
-          </a:ln>
-        </p:spPr>
-        <p:style>
-          <a:lnRef idx="1">
-            <a:schemeClr val="accent1"/>
-          </a:lnRef>
-          <a:fillRef idx="3">
-            <a:schemeClr val="accent1"/>
-          </a:fillRef>
-          <a:effectRef idx="2">
-            <a:schemeClr val="accent1"/>
-          </a:effectRef>
-          <a:fontRef idx="minor">
-            <a:schemeClr val="lt1"/>
-          </a:fontRef>
-        </p:style>
-        <p:txBody>
-          <a:bodyPr rtlCol="0" anchor="ctr"/>
-          <a:lstStyle/>
-          <a:p>
-            <a:pPr algn="ctr"/>
-          </a:p>
-        </p:txBody>
-      </p:sp>
-      <p:sp>
-        <p:nvSpPr>
-          <p:cNvPr id="3" name="TextBox 2"/>
-          <p:cNvSpPr txBox="1"/>
-          <p:nvPr/>
-        </p:nvSpPr>
-        <p:spPr>
-          <a:xfrm>
-            <a:off x="822960" y="548640"/>
-            <a:ext cx="10607040" cy="1188720"/>
-          </a:xfrm>
-          <a:prstGeom prst="rect">
-            <a:avLst/>
-          </a:prstGeom>
-          <a:noFill/>
-        </p:spPr>
-        <p:txBody>
-          <a:bodyPr wrap="square">
-            <a:spAutoFit/>
-          </a:bodyPr>
-          <a:lstStyle/>
-          <a:p>
-            <a:pPr>
-              <a:spcAft>
-                <a:spcPts val="1400"/>
-              </a:spcAft>
-            </a:pPr>
-            <a:r>
-              <a:rPr sz="4000" b="1">
-                <a:solidFill>
-                  <a:srgbClr val="272A25"/>
-                </a:solidFill>
-                <a:latin typeface="Fraunces"/>
-              </a:rPr>
-              <a:t>Choose · check · control</a:t>
-            </a:r>
-          </a:p>
-        </p:txBody>
-      </p:sp>
-      <p:sp>
-        <p:nvSpPr>
-          <p:cNvPr id="4" name="TextBox 3"/>
-          <p:cNvSpPr txBox="1"/>
-          <p:nvPr/>
-        </p:nvSpPr>
-        <p:spPr>
-          <a:xfrm>
-            <a:off x="822960" y="2011680"/>
-            <a:ext cx="10607040" cy="4206240"/>
-          </a:xfrm>
-          <a:prstGeom prst="rect">
-            <a:avLst/>
-          </a:prstGeom>
-          <a:noFill/>
-        </p:spPr>
-        <p:txBody>
-          <a:bodyPr wrap="square">
-            <a:spAutoFit/>
-          </a:bodyPr>
-          <a:lstStyle/>
-          <a:p>
-            <a:pPr>
-              <a:spcAft>
-                <a:spcPts val="1600"/>
-              </a:spcAft>
-            </a:pPr>
-            <a:r>
-              <a:rPr sz="2600" b="0">
-                <a:solidFill>
-                  <a:srgbClr val="272A25"/>
-                </a:solidFill>
-                <a:latin typeface="DM Sans"/>
-              </a:rPr>
-              <a:t>•  Choose what it sees: context files, connectors</a:t>
-            </a:r>
-          </a:p>
-          <a:p>
-            <a:pPr>
-              <a:spcAft>
-                <a:spcPts val="1600"/>
-              </a:spcAft>
-            </a:pPr>
-            <a:r>
-              <a:rPr sz="2600" b="0">
-                <a:solidFill>
-                  <a:srgbClr val="272A25"/>
-                </a:solidFill>
-                <a:latin typeface="DM Sans"/>
-              </a:rPr>
-              <a:t>•  Check what it produces: fluent ≠ correct, say what you checked</a:t>
-            </a:r>
-          </a:p>
-          <a:p>
-            <a:pPr>
-              <a:spcAft>
-                <a:spcPts val="1600"/>
-              </a:spcAft>
-            </a:pPr>
-            <a:r>
-              <a:rPr sz="2600" b="0">
-                <a:solidFill>
-                  <a:srgbClr val="272A25"/>
-                </a:solidFill>
-                <a:latin typeface="DM Sans"/>
-              </a:rPr>
-              <a:t>•  Control what it can change: read-only first, ask before writes</a:t>
-            </a:r>
-          </a:p>
-          <a:p>
-            <a:pPr>
-              <a:spcAft>
-                <a:spcPts val="1600"/>
-              </a:spcAft>
-            </a:pPr>
-            <a:r>
-              <a:rPr sz="2600" b="0">
-                <a:solidFill>
-                  <a:srgbClr val="272A25"/>
-                </a:solidFill>
-                <a:latin typeface="DM Sans"/>
-              </a:rPr>
-              <a:t>•  This course's connector is read-only, on purpose</a:t>
-            </a:r>
-          </a:p>
-        </p:txBody>
-      </p:sp>
-      <p:sp>
-        <p:nvSpPr>
-          <p:cNvPr id="5" name="TextBox 4"/>
-          <p:cNvSpPr txBox="1"/>
-          <p:nvPr/>
-        </p:nvSpPr>
-        <p:spPr>
-          <a:xfrm>
-            <a:off x="822960" y="6263640"/>
-            <a:ext cx="10607040" cy="365760"/>
-          </a:xfrm>
-          <a:prstGeom prst="rect">
-            <a:avLst/>
-          </a:prstGeom>
-          <a:noFill/>
-        </p:spPr>
-        <p:txBody>
-          <a:bodyPr wrap="square">
-            <a:spAutoFit/>
-          </a:bodyPr>
-          <a:lstStyle/>
-          <a:p>
-            <a:pPr algn="r">
-              <a:spcAft>
-                <a:spcPts val="1400"/>
-              </a:spcAft>
-            </a:pPr>
-            <a:r>
-              <a:rPr sz="1600" b="0">
-                <a:solidFill>
-                  <a:srgbClr val="64665D"/>
-                </a:solidFill>
-                <a:latin typeface="DM Sans"/>
-              </a:rPr>
-              <a:t>Week 6 · Demo 3 · Connectors        16 / 19</a:t>
-            </a:r>
-          </a:p>
-        </p:txBody>
-      </p:sp>
-    </p:spTree>
-  </p:cSld>
-  <p:clrMapOvr>
-    <a:masterClrMapping/>
-  </p:clrMapOvr>
-</p:sld>
-</file>
-
-<file path=ppt/slides/slide17.xml><?xml version="1.0" encoding="utf-8"?>
-<p:sld xmlns:a="http://schemas.openxmlformats.org/drawingml/2006/main" xmlns:p="http://schemas.openxmlformats.org/presentationml/2006/main" xmlns:r="http://schemas.openxmlformats.org/officeDocument/2006/relationships">
-  <p:cSld>
-    <p:bg>
-      <p:bgPr>
-        <a:solidFill>
-          <a:srgbClr val="F7F5EE"/>
-        </a:solidFill>
-        <a:effectLst/>
-      </p:bgPr>
-    </p:bg>
-    <p:spTree>
-      <p:nvGrpSpPr>
-        <p:cNvPr id="1" name=""/>
-        <p:cNvGrpSpPr/>
-        <p:nvPr/>
-      </p:nvGrpSpPr>
-      <p:grpSpPr/>
-      <p:sp>
-        <p:nvSpPr>
-          <p:cNvPr id="2" name="Rectangle 1"/>
-          <p:cNvSpPr/>
-          <p:nvPr/>
-        </p:nvSpPr>
-        <p:spPr>
-          <a:xfrm>
-            <a:off x="0" y="0"/>
-            <a:ext cx="228600" cy="6858000"/>
-          </a:xfrm>
-          <a:prstGeom prst="rect">
-            <a:avLst/>
-          </a:prstGeom>
-          <a:solidFill>
-            <a:srgbClr val="A83D2B"/>
-          </a:solidFill>
-          <a:ln>
-            <a:noFill/>
-          </a:ln>
-        </p:spPr>
-        <p:style>
-          <a:lnRef idx="1">
-            <a:schemeClr val="accent1"/>
-          </a:lnRef>
-          <a:fillRef idx="3">
-            <a:schemeClr val="accent1"/>
-          </a:fillRef>
-          <a:effectRef idx="2">
-            <a:schemeClr val="accent1"/>
-          </a:effectRef>
-          <a:fontRef idx="minor">
-            <a:schemeClr val="lt1"/>
-          </a:fontRef>
-        </p:style>
-        <p:txBody>
-          <a:bodyPr rtlCol="0" anchor="ctr"/>
-          <a:lstStyle/>
-          <a:p>
-            <a:pPr algn="ctr"/>
-          </a:p>
-        </p:txBody>
-      </p:sp>
-      <p:sp>
-        <p:nvSpPr>
-          <p:cNvPr id="3" name="TextBox 2"/>
-          <p:cNvSpPr txBox="1"/>
-          <p:nvPr/>
-        </p:nvSpPr>
-        <p:spPr>
-          <a:xfrm>
-            <a:off x="822960" y="548640"/>
-            <a:ext cx="10607040" cy="1188720"/>
-          </a:xfrm>
-          <a:prstGeom prst="rect">
-            <a:avLst/>
-          </a:prstGeom>
-          <a:noFill/>
-        </p:spPr>
-        <p:txBody>
-          <a:bodyPr wrap="square">
-            <a:spAutoFit/>
-          </a:bodyPr>
-          <a:lstStyle/>
-          <a:p>
-            <a:pPr>
-              <a:spcAft>
-                <a:spcPts val="1400"/>
-              </a:spcAft>
-            </a:pPr>
-            <a:r>
-              <a:rPr sz="4000" b="1">
-                <a:solidFill>
-                  <a:srgbClr val="272A25"/>
-                </a:solidFill>
-                <a:latin typeface="Fraunces"/>
-              </a:rPr>
-              <a:t>This week's reading: your AI as a coach</a:t>
-            </a:r>
-          </a:p>
-        </p:txBody>
-      </p:sp>
-      <p:sp>
-        <p:nvSpPr>
-          <p:cNvPr id="4" name="TextBox 3"/>
-          <p:cNvSpPr txBox="1"/>
-          <p:nvPr/>
-        </p:nvSpPr>
-        <p:spPr>
-          <a:xfrm>
-            <a:off x="822960" y="2011680"/>
-            <a:ext cx="10607040" cy="4206240"/>
-          </a:xfrm>
-          <a:prstGeom prst="rect">
-            <a:avLst/>
-          </a:prstGeom>
-          <a:noFill/>
-        </p:spPr>
-        <p:txBody>
-          <a:bodyPr wrap="square">
-            <a:spAutoFit/>
-          </a:bodyPr>
-          <a:lstStyle/>
-          <a:p>
-            <a:pPr>
-              <a:spcAft>
-                <a:spcPts val="2200"/>
-              </a:spcAft>
-            </a:pPr>
-            <a:r>
-              <a:rPr sz="3000" b="0">
-                <a:solidFill>
-                  <a:srgbClr val="272A25"/>
-                </a:solidFill>
-                <a:latin typeface="DM Sans"/>
-              </a:rPr>
-              <a:t>•  Arielle Shipper, “How to Get Better at AI by Asking AI” (Every)</a:t>
-            </a:r>
-          </a:p>
-          <a:p>
-            <a:pPr>
-              <a:spcAft>
-                <a:spcPts val="2200"/>
-              </a:spcAft>
-            </a:pPr>
-            <a:r>
-              <a:rPr sz="3000" b="0">
-                <a:solidFill>
-                  <a:srgbClr val="272A25"/>
-                </a:solidFill>
-                <a:latin typeface="DM Sans"/>
-              </a:rPr>
-              <a:t>•  Ask your AI: which of the eight levels am I, with examples?</a:t>
-            </a:r>
-          </a:p>
-          <a:p>
-            <a:pPr>
-              <a:spcAft>
-                <a:spcPts val="2200"/>
-              </a:spcAft>
-            </a:pPr>
-            <a:r>
-              <a:rPr sz="3000" b="0">
-                <a:solidFill>
-                  <a:srgbClr val="272A25"/>
-                </a:solidFill>
-                <a:latin typeface="DM Sans"/>
-              </a:rPr>
-              <a:t>•  Then: “teach me the next step”</a:t>
-            </a:r>
-          </a:p>
-        </p:txBody>
-      </p:sp>
-      <p:sp>
-        <p:nvSpPr>
-          <p:cNvPr id="5" name="TextBox 4"/>
-          <p:cNvSpPr txBox="1"/>
-          <p:nvPr/>
-        </p:nvSpPr>
-        <p:spPr>
-          <a:xfrm>
-            <a:off x="822960" y="6263640"/>
-            <a:ext cx="10607040" cy="365760"/>
-          </a:xfrm>
-          <a:prstGeom prst="rect">
-            <a:avLst/>
-          </a:prstGeom>
-          <a:noFill/>
-        </p:spPr>
-        <p:txBody>
-          <a:bodyPr wrap="square">
-            <a:spAutoFit/>
-          </a:bodyPr>
-          <a:lstStyle/>
-          <a:p>
-            <a:pPr algn="r">
-              <a:spcAft>
-                <a:spcPts val="1400"/>
-              </a:spcAft>
-            </a:pPr>
-            <a:r>
-              <a:rPr sz="1600" b="0">
-                <a:solidFill>
-                  <a:srgbClr val="64665D"/>
-                </a:solidFill>
-                <a:latin typeface="DM Sans"/>
-              </a:rPr>
-              <a:t>Week 6 · Close        17 / 19</a:t>
-            </a:r>
-          </a:p>
-        </p:txBody>
-      </p:sp>
-    </p:spTree>
-  </p:cSld>
-  <p:clrMapOvr>
-    <a:masterClrMapping/>
-  </p:clrMapOvr>
-</p:sld>
-</file>
-
-<file path=ppt/slides/slide18.xml><?xml version="1.0" encoding="utf-8"?>
-<p:sld xmlns:a="http://schemas.openxmlformats.org/drawingml/2006/main" xmlns:p="http://schemas.openxmlformats.org/presentationml/2006/main" xmlns:r="http://schemas.openxmlformats.org/officeDocument/2006/relationships">
-  <p:cSld>
-    <p:bg>
-      <p:bgPr>
-        <a:solidFill>
-          <a:srgbClr val="F7F5EE"/>
-        </a:solidFill>
-        <a:effectLst/>
-      </p:bgPr>
-    </p:bg>
-    <p:spTree>
-      <p:nvGrpSpPr>
-        <p:cNvPr id="1" name=""/>
-        <p:cNvGrpSpPr/>
-        <p:nvPr/>
-      </p:nvGrpSpPr>
-      <p:grpSpPr/>
-      <p:sp>
-        <p:nvSpPr>
-          <p:cNvPr id="2" name="Rectangle 1"/>
-          <p:cNvSpPr/>
-          <p:nvPr/>
-        </p:nvSpPr>
-        <p:spPr>
-          <a:xfrm>
-            <a:off x="0" y="0"/>
-            <a:ext cx="228600" cy="6858000"/>
-          </a:xfrm>
-          <a:prstGeom prst="rect">
-            <a:avLst/>
-          </a:prstGeom>
-          <a:solidFill>
-            <a:srgbClr val="A83D2B"/>
-          </a:solidFill>
-          <a:ln>
-            <a:noFill/>
-          </a:ln>
-        </p:spPr>
-        <p:style>
-          <a:lnRef idx="1">
-            <a:schemeClr val="accent1"/>
-          </a:lnRef>
-          <a:fillRef idx="3">
-            <a:schemeClr val="accent1"/>
-          </a:fillRef>
-          <a:effectRef idx="2">
-            <a:schemeClr val="accent1"/>
-          </a:effectRef>
-          <a:fontRef idx="minor">
-            <a:schemeClr val="lt1"/>
-          </a:fontRef>
-        </p:style>
-        <p:txBody>
-          <a:bodyPr rtlCol="0" anchor="ctr"/>
-          <a:lstStyle/>
-          <a:p>
-            <a:pPr algn="ctr"/>
-          </a:p>
-        </p:txBody>
-      </p:sp>
-      <p:sp>
-        <p:nvSpPr>
-          <p:cNvPr id="3" name="TextBox 2"/>
-          <p:cNvSpPr txBox="1"/>
-          <p:nvPr/>
-        </p:nvSpPr>
-        <p:spPr>
-          <a:xfrm>
-            <a:off x="822960" y="548640"/>
-            <a:ext cx="10607040" cy="1188720"/>
-          </a:xfrm>
-          <a:prstGeom prst="rect">
-            <a:avLst/>
-          </a:prstGeom>
-          <a:noFill/>
-        </p:spPr>
-        <p:txBody>
-          <a:bodyPr wrap="square">
-            <a:spAutoFit/>
-          </a:bodyPr>
-          <a:lstStyle/>
-          <a:p>
-            <a:pPr>
-              <a:spcAft>
-                <a:spcPts val="1400"/>
-              </a:spcAft>
-            </a:pPr>
-            <a:r>
-              <a:rPr sz="4000" b="1">
-                <a:solidFill>
-                  <a:srgbClr val="272A25"/>
-                </a:solidFill>
-                <a:latin typeface="Fraunces"/>
-              </a:rPr>
-              <a:t>Studio · write each other's AGENTS.md</a:t>
-            </a:r>
-          </a:p>
-        </p:txBody>
-      </p:sp>
-      <p:sp>
-        <p:nvSpPr>
-          <p:cNvPr id="4" name="TextBox 3"/>
-          <p:cNvSpPr txBox="1"/>
-          <p:nvPr/>
-        </p:nvSpPr>
-        <p:spPr>
-          <a:xfrm>
-            <a:off x="822960" y="2011680"/>
-            <a:ext cx="10607040" cy="4206240"/>
-          </a:xfrm>
-          <a:prstGeom prst="rect">
-            <a:avLst/>
-          </a:prstGeom>
-          <a:noFill/>
-        </p:spPr>
-        <p:txBody>
-          <a:bodyPr wrap="square">
-            <a:spAutoFit/>
-          </a:bodyPr>
-          <a:lstStyle/>
-          <a:p>
-            <a:pPr>
-              <a:spcAft>
-                <a:spcPts val="2200"/>
-              </a:spcAft>
-            </a:pPr>
-            <a:r>
-              <a:rPr sz="3000" b="0">
-                <a:solidFill>
-                  <a:srgbClr val="272A25"/>
-                </a:solidFill>
-                <a:latin typeface="DM Sans"/>
-              </a:rPr>
-              <a:t>•  Pairs, 20 minutes</a:t>
-            </a:r>
-          </a:p>
-          <a:p>
-            <a:pPr>
-              <a:spcAft>
-                <a:spcPts val="2200"/>
-              </a:spcAft>
-            </a:pPr>
-            <a:r>
-              <a:rPr sz="3000" b="0">
-                <a:solidFill>
-                  <a:srgbClr val="272A25"/>
-                </a:solidFill>
-                <a:latin typeface="DM Sans"/>
-              </a:rPr>
-              <a:t>•  8 min each: your partner interviews you and drafts your AGENTS.md</a:t>
-            </a:r>
-          </a:p>
-          <a:p>
-            <a:pPr>
-              <a:spcAft>
-                <a:spcPts val="2200"/>
-              </a:spcAft>
-            </a:pPr>
-            <a:r>
-              <a:rPr sz="3000" b="0">
-                <a:solidFill>
-                  <a:srgbClr val="272A25"/>
-                </a:solidFill>
-                <a:latin typeface="DM Sans"/>
-              </a:rPr>
-              <a:t>•  4 min: test it with your own agent, then revise</a:t>
-            </a:r>
-          </a:p>
-        </p:txBody>
-      </p:sp>
-      <p:sp>
-        <p:nvSpPr>
-          <p:cNvPr id="5" name="TextBox 4"/>
-          <p:cNvSpPr txBox="1"/>
-          <p:nvPr/>
-        </p:nvSpPr>
-        <p:spPr>
-          <a:xfrm>
-            <a:off x="822960" y="6263640"/>
-            <a:ext cx="10607040" cy="365760"/>
-          </a:xfrm>
-          <a:prstGeom prst="rect">
-            <a:avLst/>
-          </a:prstGeom>
-          <a:noFill/>
-        </p:spPr>
-        <p:txBody>
-          <a:bodyPr wrap="square">
-            <a:spAutoFit/>
-          </a:bodyPr>
-          <a:lstStyle/>
-          <a:p>
-            <a:pPr algn="r">
-              <a:spcAft>
-                <a:spcPts val="1400"/>
-              </a:spcAft>
-            </a:pPr>
-            <a:r>
-              <a:rPr sz="1600" b="0">
-                <a:solidFill>
-                  <a:srgbClr val="64665D"/>
-                </a:solidFill>
-                <a:latin typeface="DM Sans"/>
-              </a:rPr>
-              <a:t>Week 6 · Close        18 / 19</a:t>
-            </a:r>
-          </a:p>
-        </p:txBody>
-      </p:sp>
-    </p:spTree>
-  </p:cSld>
-  <p:clrMapOvr>
-    <a:masterClrMapping/>
-  </p:clrMapOvr>
-</p:sld>
-</file>
-
-<file path=ppt/slides/slide19.xml><?xml version="1.0" encoding="utf-8"?>
-<p:sld xmlns:a="http://schemas.openxmlformats.org/drawingml/2006/main" xmlns:p="http://schemas.openxmlformats.org/presentationml/2006/main" xmlns:r="http://schemas.openxmlformats.org/officeDocument/2006/relationships">
-  <p:cSld>
-    <p:bg>
-      <p:bgPr>
-        <a:solidFill>
-          <a:srgbClr val="F7F5EE"/>
-        </a:solidFill>
-        <a:effectLst/>
-      </p:bgPr>
-    </p:bg>
-    <p:spTree>
-      <p:nvGrpSpPr>
-        <p:cNvPr id="1" name=""/>
-        <p:cNvGrpSpPr/>
-        <p:nvPr/>
-      </p:nvGrpSpPr>
-      <p:grpSpPr/>
-      <p:sp>
-        <p:nvSpPr>
-          <p:cNvPr id="2" name="Rectangle 1"/>
-          <p:cNvSpPr/>
-          <p:nvPr/>
-        </p:nvSpPr>
-        <p:spPr>
-          <a:xfrm>
-            <a:off x="0" y="0"/>
-            <a:ext cx="228600" cy="6858000"/>
-          </a:xfrm>
-          <a:prstGeom prst="rect">
-            <a:avLst/>
-          </a:prstGeom>
-          <a:solidFill>
-            <a:srgbClr val="A83D2B"/>
-          </a:solidFill>
-          <a:ln>
-            <a:noFill/>
-          </a:ln>
-        </p:spPr>
-        <p:style>
-          <a:lnRef idx="1">
-            <a:schemeClr val="accent1"/>
-          </a:lnRef>
-          <a:fillRef idx="3">
-            <a:schemeClr val="accent1"/>
-          </a:fillRef>
-          <a:effectRef idx="2">
-            <a:schemeClr val="accent1"/>
-          </a:effectRef>
-          <a:fontRef idx="minor">
-            <a:schemeClr val="lt1"/>
-          </a:fontRef>
-        </p:style>
-        <p:txBody>
-          <a:bodyPr rtlCol="0" anchor="ctr"/>
-          <a:lstStyle/>
-          <a:p>
-            <a:pPr algn="ctr"/>
-          </a:p>
-        </p:txBody>
-      </p:sp>
-      <p:sp>
-        <p:nvSpPr>
-          <p:cNvPr id="3" name="TextBox 2"/>
-          <p:cNvSpPr txBox="1"/>
-          <p:nvPr/>
-        </p:nvSpPr>
-        <p:spPr>
-          <a:xfrm>
-            <a:off x="822960" y="548640"/>
-            <a:ext cx="10607040" cy="1188720"/>
-          </a:xfrm>
-          <a:prstGeom prst="rect">
-            <a:avLst/>
-          </a:prstGeom>
-          <a:noFill/>
-        </p:spPr>
-        <p:txBody>
-          <a:bodyPr wrap="square">
-            <a:spAutoFit/>
-          </a:bodyPr>
-          <a:lstStyle/>
-          <a:p>
-            <a:pPr>
-              <a:spcAft>
-                <a:spcPts val="1400"/>
-              </a:spcAft>
-            </a:pPr>
-            <a:r>
-              <a:rPr sz="4000" b="1">
-                <a:solidFill>
-                  <a:srgbClr val="272A25"/>
-                </a:solidFill>
-                <a:latin typeface="Fraunces"/>
-              </a:rPr>
-              <a:t>Sources</a:t>
-            </a:r>
-          </a:p>
-        </p:txBody>
-      </p:sp>
-      <p:sp>
-        <p:nvSpPr>
-          <p:cNvPr id="4" name="TextBox 3"/>
-          <p:cNvSpPr txBox="1"/>
-          <p:nvPr/>
-        </p:nvSpPr>
-        <p:spPr>
-          <a:xfrm>
-            <a:off x="822960" y="2011680"/>
-            <a:ext cx="10607040" cy="4206240"/>
-          </a:xfrm>
-          <a:prstGeom prst="rect">
-            <a:avLst/>
-          </a:prstGeom>
-          <a:noFill/>
-        </p:spPr>
-        <p:txBody>
-          <a:bodyPr wrap="square">
-            <a:spAutoFit/>
-          </a:bodyPr>
-          <a:lstStyle/>
-          <a:p>
-            <a:pPr>
-              <a:spcAft>
-                <a:spcPts val="1600"/>
-              </a:spcAft>
-            </a:pPr>
-            <a:r>
-              <a:rPr sz="2600" b="0">
-                <a:solidFill>
-                  <a:srgbClr val="272A25"/>
-                </a:solidFill>
-                <a:latin typeface="DM Sans"/>
-              </a:rPr>
-              <a:t>•  AGENTS.md convention · agents.md</a:t>
-            </a:r>
-          </a:p>
-          <a:p>
-            <a:pPr>
-              <a:spcAft>
-                <a:spcPts val="1600"/>
-              </a:spcAft>
-            </a:pPr>
-            <a:r>
-              <a:rPr sz="2600" b="0">
-                <a:solidFill>
-                  <a:srgbClr val="272A25"/>
-                </a:solidFill>
-                <a:latin typeface="DM Sans"/>
-              </a:rPr>
-              <a:t>•  Effective context engineering · Anthropic</a:t>
-            </a:r>
-          </a:p>
-          <a:p>
-            <a:pPr>
-              <a:spcAft>
-                <a:spcPts val="1600"/>
-              </a:spcAft>
-            </a:pPr>
-            <a:r>
-              <a:rPr sz="2600" b="0">
-                <a:solidFill>
-                  <a:srgbClr val="272A25"/>
-                </a:solidFill>
-                <a:latin typeface="DM Sans"/>
-              </a:rPr>
-              <a:t>•  GitHub Pages · docs.github.com/pages</a:t>
-            </a:r>
-          </a:p>
-          <a:p>
-            <a:pPr>
-              <a:spcAft>
-                <a:spcPts val="1600"/>
-              </a:spcAft>
-            </a:pPr>
-            <a:r>
-              <a:rPr sz="2600" b="0">
-                <a:solidFill>
-                  <a:srgbClr val="272A25"/>
-                </a:solidFill>
-                <a:latin typeface="DM Sans"/>
-              </a:rPr>
-              <a:t>•  MCP · modelcontextprotocol.io</a:t>
-            </a:r>
-          </a:p>
-          <a:p>
-            <a:pPr>
-              <a:spcAft>
-                <a:spcPts val="1600"/>
-              </a:spcAft>
-            </a:pPr>
-            <a:r>
-              <a:rPr sz="2600" b="0">
-                <a:solidFill>
-                  <a:srgbClr val="272A25"/>
-                </a:solidFill>
-                <a:latin typeface="DM Sans"/>
-              </a:rPr>
-              <a:t>•  AI Fluency (further reading) · academy.claude.com</a:t>
-            </a:r>
-          </a:p>
-        </p:txBody>
-      </p:sp>
-      <p:sp>
-        <p:nvSpPr>
-          <p:cNvPr id="5" name="TextBox 4"/>
-          <p:cNvSpPr txBox="1"/>
-          <p:nvPr/>
-        </p:nvSpPr>
-        <p:spPr>
-          <a:xfrm>
-            <a:off x="822960" y="6263640"/>
-            <a:ext cx="10607040" cy="365760"/>
-          </a:xfrm>
-          <a:prstGeom prst="rect">
-            <a:avLst/>
-          </a:prstGeom>
-          <a:noFill/>
-        </p:spPr>
-        <p:txBody>
-          <a:bodyPr wrap="square">
-            <a:spAutoFit/>
-          </a:bodyPr>
-          <a:lstStyle/>
-          <a:p>
-            <a:pPr algn="r">
-              <a:spcAft>
-                <a:spcPts val="1400"/>
-              </a:spcAft>
-            </a:pPr>
-            <a:r>
-              <a:rPr sz="1600" b="0">
-                <a:solidFill>
-                  <a:srgbClr val="64665D"/>
-                </a:solidFill>
-                <a:latin typeface="DM Sans"/>
-              </a:rPr>
-              <a:t>Week 6 · Close        19 / 19</a:t>
+              <a:t>Week 6 · Studio        12 / 12</a:t>
             </a:r>
           </a:p>
         </p:txBody>
@@ -8094,7 +5207,7 @@
                 </a:solidFill>
                 <a:latin typeface="Fraunces"/>
               </a:rPr>
-              <a:t>Tonight: three demos</a:t>
+              <a:t>Demo 1 · copy the lesson</a:t>
             </a:r>
           </a:p>
         </p:txBody>
@@ -8133,7 +5246,7 @@
                 </a:solidFill>
                 <a:latin typeface="DM Sans"/>
               </a:rPr>
-              <a:t>•  1 · Give your AI context that sticks (AGENTS.md)</a:t>
+              <a:t>•  Copy the lesson markdown into your AI.</a:t>
             </a:r>
           </a:p>
           <a:p>
@@ -8149,7 +5262,7 @@
                 </a:solidFill>
                 <a:latin typeface="DM Sans"/>
               </a:rPr>
-              <a:t>•  2 · Get your project online: a link anyone can open</a:t>
+              <a:t>•  Ask: “Teach me this and quiz me.”</a:t>
             </a:r>
           </a:p>
           <a:p>
@@ -8165,7 +5278,7 @@
                 </a:solidFill>
                 <a:latin typeface="DM Sans"/>
               </a:rPr>
-              <a:t>•  3 · Connect your AI to the course</a:t>
+              <a:t>•  Check its explanation against the lesson.</a:t>
             </a:r>
           </a:p>
         </p:txBody>
@@ -8204,7 +5317,7 @@
                 </a:solidFill>
                 <a:latin typeface="DM Sans"/>
               </a:rPr>
-              <a:t>Week 6 · Opening        2 / 19</a:t>
+              <a:t>Week 6 · Demo 1 · Learn with your AI        2 / 12</a:t>
             </a:r>
           </a:p>
         </p:txBody>
@@ -8312,7 +5425,7 @@
                 </a:solidFill>
                 <a:latin typeface="Fraunces"/>
               </a:rPr>
-              <a:t>Your AI starts every session from zero</a:t>
+              <a:t>Markdown is just a text file</a:t>
             </a:r>
           </a:p>
         </p:txBody>
@@ -8351,7 +5464,7 @@
                 </a:solidFill>
                 <a:latin typeface="DM Sans"/>
               </a:rPr>
-              <a:t>•  It only sees what's in front of it right now</a:t>
+              <a:t>•  A .md file is plain text, with headings and lists.</a:t>
             </a:r>
           </a:p>
           <a:p>
@@ -8367,7 +5480,7 @@
                 </a:solidFill>
                 <a:latin typeface="DM Sans"/>
               </a:rPr>
-              <a:t>•  It doesn't know your project unless you tell it</a:t>
+              <a:t>•  You can read it. Your AI can read it.</a:t>
             </a:r>
           </a:p>
           <a:p>
@@ -8383,7 +5496,7 @@
                 </a:solidFill>
                 <a:latin typeface="DM Sans"/>
               </a:rPr>
-              <a:t>•  A generic answer is usually a context problem</a:t>
+              <a:t>•  Context can live in a file instead of your memory.</a:t>
             </a:r>
           </a:p>
         </p:txBody>
@@ -8422,7 +5535,7 @@
                 </a:solidFill>
                 <a:latin typeface="DM Sans"/>
               </a:rPr>
-              <a:t>Week 6 · Demo 1 · Context that sticks        3 / 19</a:t>
+              <a:t>Week 6 · Demo 2 · Context that sticks        3 / 12</a:t>
             </a:r>
           </a:p>
         </p:txBody>
@@ -8524,70 +5637,27 @@
               </a:spcAft>
             </a:pPr>
             <a:r>
-              <a:rPr sz="3200" b="1">
+              <a:rPr sz="4000" b="1">
                 <a:solidFill>
                   <a:srgbClr val="272A25"/>
                 </a:solidFill>
                 <a:latin typeface="Fraunces"/>
               </a:rPr>
-              <a:t>Markdown: plain text with a little structure</a:t>
-            </a:r>
-          </a:p>
-        </p:txBody>
-      </p:sp>
-      <p:sp>
-        <p:nvSpPr>
-          <p:cNvPr id="4" name="Rectangle 3"/>
-          <p:cNvSpPr/>
-          <p:nvPr/>
-        </p:nvSpPr>
-        <p:spPr>
-          <a:xfrm>
-            <a:off x="822960" y="1828800"/>
-            <a:ext cx="6583680" cy="4023360"/>
-          </a:xfrm>
-          <a:prstGeom prst="rect">
-            <a:avLst/>
-          </a:prstGeom>
-          <a:solidFill>
-            <a:srgbClr val="EEECE2"/>
-          </a:solidFill>
-          <a:ln>
-            <a:noFill/>
-          </a:ln>
-        </p:spPr>
-        <p:style>
-          <a:lnRef idx="1">
-            <a:schemeClr val="accent1"/>
-          </a:lnRef>
-          <a:fillRef idx="3">
-            <a:schemeClr val="accent1"/>
-          </a:fillRef>
-          <a:effectRef idx="2">
-            <a:schemeClr val="accent1"/>
-          </a:effectRef>
-          <a:fontRef idx="minor">
-            <a:schemeClr val="lt1"/>
-          </a:fontRef>
-        </p:style>
-        <p:txBody>
-          <a:bodyPr rtlCol="0" anchor="ctr"/>
-          <a:lstStyle/>
-          <a:p>
-            <a:pPr algn="ctr"/>
-          </a:p>
-        </p:txBody>
-      </p:sp>
-      <p:sp>
-        <p:nvSpPr>
-          <p:cNvPr id="5" name="TextBox 4"/>
+              <a:t>Context that sticks</a:t>
+            </a:r>
+          </a:p>
+        </p:txBody>
+      </p:sp>
+      <p:sp>
+        <p:nvSpPr>
+          <p:cNvPr id="4" name="TextBox 3"/>
           <p:cNvSpPr txBox="1"/>
           <p:nvPr/>
         </p:nvSpPr>
         <p:spPr>
           <a:xfrm>
-            <a:off x="1097280" y="2011680"/>
-            <a:ext cx="6217920" cy="3749039"/>
+            <a:off x="822960" y="2011680"/>
+            <a:ext cx="10607040" cy="4206240"/>
           </a:xfrm>
           <a:prstGeom prst="rect">
             <a:avLst/>
@@ -8602,143 +5672,56 @@
           <a:p>
             <a:pPr>
               <a:spcAft>
-                <a:spcPts val="200"/>
+                <a:spcPts val="2200"/>
               </a:spcAft>
             </a:pPr>
             <a:r>
-              <a:rPr sz="2400" b="0">
+              <a:rPr sz="3000" b="0">
                 <a:solidFill>
                   <a:srgbClr val="272A25"/>
                 </a:solidFill>
-                <a:latin typeface="DejaVu Sans Mono"/>
+                <a:latin typeface="DM Sans"/>
               </a:rPr>
-              <a:t># Big heading</a:t>
+              <a:t>•  Claude Code loads CLAUDE.md at session start.</a:t>
             </a:r>
           </a:p>
           <a:p>
             <a:pPr>
               <a:spcAft>
-                <a:spcPts val="200"/>
+                <a:spcPts val="2200"/>
               </a:spcAft>
             </a:pPr>
             <a:r>
-              <a:rPr sz="2400" b="0">
+              <a:rPr sz="3000" b="0">
                 <a:solidFill>
                   <a:srgbClr val="272A25"/>
                 </a:solidFill>
-                <a:latin typeface="DejaVu Sans Mono"/>
+                <a:latin typeface="DM Sans"/>
               </a:rPr>
-              <a:t>## Smaller heading</a:t>
+              <a:t>•  Cursor and other coding tools can load AGENTS.md.</a:t>
             </a:r>
           </a:p>
           <a:p>
             <a:pPr>
               <a:spcAft>
-                <a:spcPts val="200"/>
+                <a:spcPts val="2200"/>
               </a:spcAft>
             </a:pPr>
             <a:r>
-              <a:rPr sz="2400" b="0">
+              <a:rPr sz="3000" b="0">
                 <a:solidFill>
                   <a:srgbClr val="272A25"/>
-                </a:solidFill>
-                <a:latin typeface="DejaVu Sans Mono"/>
-              </a:rPr>
-              <a:t>- a bullet point</a:t>
-            </a:r>
-          </a:p>
-          <a:p>
-            <a:pPr>
-              <a:spcAft>
-                <a:spcPts val="200"/>
-              </a:spcAft>
-            </a:pPr>
-            <a:r>
-              <a:rPr sz="2400" b="0">
-                <a:solidFill>
-                  <a:srgbClr val="272A25"/>
-                </a:solidFill>
-                <a:latin typeface="DejaVu Sans Mono"/>
-              </a:rPr>
-              <a:t>**bold**  *italic*</a:t>
-            </a:r>
-          </a:p>
-          <a:p>
-            <a:pPr>
-              <a:spcAft>
-                <a:spcPts val="200"/>
-              </a:spcAft>
-            </a:pPr>
-            <a:r>
-              <a:rPr sz="2400" b="0">
-                <a:solidFill>
-                  <a:srgbClr val="272A25"/>
-                </a:solidFill>
-                <a:latin typeface="DejaVu Sans Mono"/>
-              </a:rPr>
-              <a:t>[a link](https://example.com)</a:t>
-            </a:r>
-          </a:p>
-          <a:p>
-            <a:pPr>
-              <a:spcAft>
-                <a:spcPts val="200"/>
-              </a:spcAft>
-            </a:pPr>
-            <a:r>
-              <a:rPr sz="2400" b="0">
-                <a:solidFill>
-                  <a:srgbClr val="272A25"/>
-                </a:solidFill>
-                <a:latin typeface="DejaVu Sans Mono"/>
-              </a:rPr>
-              <a:t>`some code`</a:t>
-            </a:r>
-          </a:p>
-        </p:txBody>
-      </p:sp>
-      <p:sp>
-        <p:nvSpPr>
-          <p:cNvPr id="6" name="TextBox 5"/>
-          <p:cNvSpPr txBox="1"/>
-          <p:nvPr/>
-        </p:nvSpPr>
-        <p:spPr>
-          <a:xfrm>
-            <a:off x="7772400" y="3108960"/>
-            <a:ext cx="3931920" cy="1828800"/>
-          </a:xfrm>
-          <a:prstGeom prst="rect">
-            <a:avLst/>
-          </a:prstGeom>
-          <a:noFill/>
-        </p:spPr>
-        <p:txBody>
-          <a:bodyPr wrap="square">
-            <a:spAutoFit/>
-          </a:bodyPr>
-          <a:lstStyle/>
-          <a:p>
-            <a:pPr>
-              <a:spcAft>
-                <a:spcPts val="1400"/>
-              </a:spcAft>
-            </a:pPr>
-            <a:r>
-              <a:rPr sz="2800" b="0">
-                <a:solidFill>
-                  <a:srgbClr val="64665D"/>
                 </a:solidFill>
                 <a:latin typeface="DM Sans"/>
               </a:rPr>
-              <a:t>Plain text. Readable by you and by your AI.</a:t>
-            </a:r>
-          </a:p>
-        </p:txBody>
-      </p:sp>
-      <p:sp>
-        <p:nvSpPr>
-          <p:cNvPr id="7" name="TextBox 6"/>
+              <a:t>•  In a chat app: paste the file or add it to a Project.</a:t>
+            </a:r>
+          </a:p>
+        </p:txBody>
+      </p:sp>
+      <p:sp>
+        <p:nvSpPr>
+          <p:cNvPr id="5" name="TextBox 4"/>
           <p:cNvSpPr txBox="1"/>
           <p:nvPr/>
         </p:nvSpPr>
@@ -8770,7 +5753,7 @@
                 </a:solidFill>
                 <a:latin typeface="DM Sans"/>
               </a:rPr>
-              <a:t>Week 6 · Demo 1 · Context that sticks        4 / 19</a:t>
+              <a:t>Week 6 · Demo 2 · Context that sticks        4 / 12</a:t>
             </a:r>
           </a:p>
         </p:txBody>
@@ -8878,21 +5861,64 @@
                 </a:solidFill>
                 <a:latin typeface="Fraunces"/>
               </a:rPr>
-              <a:t>AGENTS.md: context that sticks</a:t>
-            </a:r>
-          </a:p>
-        </p:txBody>
-      </p:sp>
-      <p:sp>
-        <p:nvSpPr>
-          <p:cNvPr id="4" name="TextBox 3"/>
+              <a:t>One small example</a:t>
+            </a:r>
+          </a:p>
+        </p:txBody>
+      </p:sp>
+      <p:sp>
+        <p:nvSpPr>
+          <p:cNvPr id="4" name="Rectangle 3"/>
+          <p:cNvSpPr/>
+          <p:nvPr/>
+        </p:nvSpPr>
+        <p:spPr>
+          <a:xfrm>
+            <a:off x="822960" y="1828800"/>
+            <a:ext cx="6583680" cy="4023360"/>
+          </a:xfrm>
+          <a:prstGeom prst="rect">
+            <a:avLst/>
+          </a:prstGeom>
+          <a:solidFill>
+            <a:srgbClr val="EEECE2"/>
+          </a:solidFill>
+          <a:ln>
+            <a:noFill/>
+          </a:ln>
+        </p:spPr>
+        <p:style>
+          <a:lnRef idx="1">
+            <a:schemeClr val="accent1"/>
+          </a:lnRef>
+          <a:fillRef idx="3">
+            <a:schemeClr val="accent1"/>
+          </a:fillRef>
+          <a:effectRef idx="2">
+            <a:schemeClr val="accent1"/>
+          </a:effectRef>
+          <a:fontRef idx="minor">
+            <a:schemeClr val="lt1"/>
+          </a:fontRef>
+        </p:style>
+        <p:txBody>
+          <a:bodyPr rtlCol="0" anchor="ctr"/>
+          <a:lstStyle/>
+          <a:p>
+            <a:pPr algn="ctr"/>
+          </a:p>
+        </p:txBody>
+      </p:sp>
+      <p:sp>
+        <p:nvSpPr>
+          <p:cNvPr id="5" name="TextBox 4"/>
           <p:cNvSpPr txBox="1"/>
           <p:nvPr/>
         </p:nvSpPr>
         <p:spPr>
           <a:xfrm>
-            <a:off x="822960" y="2011680"/>
-            <a:ext cx="10607040" cy="4206240"/>
+            <a:off x="1097280" y="2011680"/>
+            <a:ext cx="6217920" cy="3749039"/>
           </a:xfrm>
           <a:prstGeom prst="rect">
             <a:avLst/>
@@ -8907,72 +5933,127 @@
           <a:p>
             <a:pPr>
               <a:spcAft>
-                <a:spcPts val="1600"/>
+                <a:spcPts val="200"/>
               </a:spcAft>
             </a:pPr>
             <a:r>
-              <a:rPr sz="2600" b="0">
+              <a:rPr sz="1800" b="0">
                 <a:solidFill>
                   <a:srgbClr val="272A25"/>
+                </a:solidFill>
+                <a:latin typeface="DejaVu Sans Mono"/>
+              </a:rPr>
+              <a:t># Hill Plant Swap</a:t>
+            </a:r>
+          </a:p>
+          <a:p>
+            <a:pPr>
+              <a:spcAft>
+                <a:spcPts val="200"/>
+              </a:spcAft>
+            </a:pPr>
+            <a:r>
+              <a:rPr sz="1800" b="0">
+                <a:solidFill>
+                  <a:srgbClr val="272A25"/>
+                </a:solidFill>
+                <a:latin typeface="DejaVu Sans Mono"/>
+              </a:rPr>
+              <a:t>A one-page website for a free monthly plant swap on the Hill, near CU.</a:t>
+            </a:r>
+          </a:p>
+          <a:p>
+            <a:pPr>
+              <a:spcAft>
+                <a:spcPts val="200"/>
+              </a:spcAft>
+            </a:pPr>
+            <a:r>
+              <a:rPr sz="1800" b="0">
+                <a:solidFill>
+                  <a:srgbClr val="272A25"/>
+                </a:solidFill>
+                <a:latin typeface="DejaVu Sans Mono"/>
+              </a:rPr>
+              <a:t>It's for first-year students who are nervous about going.</a:t>
+            </a:r>
+          </a:p>
+          <a:p>
+            <a:pPr>
+              <a:spcAft>
+                <a:spcPts val="200"/>
+              </a:spcAft>
+            </a:pPr>
+            <a:r>
+              <a:rPr sz="1800" b="0">
+                <a:solidFill>
+                  <a:srgbClr val="272A25"/>
+                </a:solidFill>
+                <a:latin typeface="DejaVu Sans Mono"/>
+              </a:rPr>
+              <a:t>Keep it plain HTML and CSS. No JavaScript.</a:t>
+            </a:r>
+          </a:p>
+          <a:p>
+            <a:pPr>
+              <a:spcAft>
+                <a:spcPts val="200"/>
+              </a:spcAft>
+            </a:pPr>
+            <a:r>
+              <a:rPr sz="1800" b="0">
+                <a:solidFill>
+                  <a:srgbClr val="272A25"/>
+                </a:solidFill>
+                <a:latin typeface="DejaVu Sans Mono"/>
+              </a:rPr>
+              <a:t>Only use the facts in docs/event-facts.md. Never make up dates or places.</a:t>
+            </a:r>
+          </a:p>
+        </p:txBody>
+      </p:sp>
+      <p:sp>
+        <p:nvSpPr>
+          <p:cNvPr id="6" name="TextBox 5"/>
+          <p:cNvSpPr txBox="1"/>
+          <p:nvPr/>
+        </p:nvSpPr>
+        <p:spPr>
+          <a:xfrm>
+            <a:off x="7772400" y="3108960"/>
+            <a:ext cx="3931920" cy="1828800"/>
+          </a:xfrm>
+          <a:prstGeom prst="rect">
+            <a:avLst/>
+          </a:prstGeom>
+          <a:noFill/>
+        </p:spPr>
+        <p:txBody>
+          <a:bodyPr wrap="square">
+            <a:spAutoFit/>
+          </a:bodyPr>
+          <a:lstStyle/>
+          <a:p>
+            <a:pPr>
+              <a:spcAft>
+                <a:spcPts val="1400"/>
+              </a:spcAft>
+            </a:pPr>
+            <a:r>
+              <a:rPr sz="2800" b="0">
+                <a:solidFill>
+                  <a:srgbClr val="64665D"/>
                 </a:solidFill>
                 <a:latin typeface="DM Sans"/>
               </a:rPr>
-              <a:t>•  A markdown file in your project folder</a:t>
-            </a:r>
-          </a:p>
-          <a:p>
-            <a:pPr>
-              <a:spcAft>
-                <a:spcPts val="1600"/>
-              </a:spcAft>
-            </a:pPr>
-            <a:r>
-              <a:rPr sz="2600" b="0">
-                <a:solidFill>
-                  <a:srgbClr val="272A25"/>
-                </a:solidFill>
-                <a:latin typeface="DM Sans"/>
-              </a:rPr>
-              <a:t>•  Coding agents read it at the start of every session</a:t>
-            </a:r>
-          </a:p>
-          <a:p>
-            <a:pPr>
-              <a:spcAft>
-                <a:spcPts val="1600"/>
-              </a:spcAft>
-            </a:pPr>
-            <a:r>
-              <a:rPr sz="2600" b="0">
-                <a:solidFill>
-                  <a:srgbClr val="272A25"/>
-                </a:solidFill>
-                <a:latin typeface="DM Sans"/>
-              </a:rPr>
-              <a:t>•  AGENTS.md: Codex, Cursor, many others · CLAUDE.md: Claude Code</a:t>
-            </a:r>
-          </a:p>
-          <a:p>
-            <a:pPr>
-              <a:spcAft>
-                <a:spcPts val="1600"/>
-              </a:spcAft>
-            </a:pPr>
-            <a:r>
-              <a:rPr sz="2600" b="0">
-                <a:solidFill>
-                  <a:srgbClr val="272A25"/>
-                </a:solidFill>
-                <a:latin typeface="DM Sans"/>
-              </a:rPr>
-              <a:t>•  In a chat app: paste it in, or add it to a Project</a:t>
-            </a:r>
-          </a:p>
-        </p:txBody>
-      </p:sp>
-      <p:sp>
-        <p:nvSpPr>
-          <p:cNvPr id="5" name="TextBox 4"/>
+              <a:t>Plain words. Nothing fancy.</a:t>
+            </a:r>
+          </a:p>
+        </p:txBody>
+      </p:sp>
+      <p:sp>
+        <p:nvSpPr>
+          <p:cNvPr id="7" name="TextBox 6"/>
           <p:cNvSpPr txBox="1"/>
           <p:nvPr/>
         </p:nvSpPr>
@@ -9004,7 +6085,7 @@
                 </a:solidFill>
                 <a:latin typeface="DM Sans"/>
               </a:rPr>
-              <a:t>Week 6 · Demo 1 · Context that sticks        5 / 19</a:t>
+              <a:t>Week 6 · Demo 2 · Context that sticks        5 / 12</a:t>
             </a:r>
           </a:p>
         </p:txBody>
@@ -9112,7 +6193,7 @@
                 </a:solidFill>
                 <a:latin typeface="Fraunces"/>
               </a:rPr>
-              <a:t>What goes in AGENTS.md</a:t>
+              <a:t>Demo 2 · ask again</a:t>
             </a:r>
           </a:p>
         </p:txBody>
@@ -9141,97 +6222,49 @@
           <a:p>
             <a:pPr>
               <a:spcAft>
-                <a:spcPts val="1600"/>
+                <a:spcPts val="2200"/>
               </a:spcAft>
             </a:pPr>
             <a:r>
-              <a:rPr sz="2600" b="0">
+              <a:rPr sz="3000" b="0">
                 <a:solidFill>
                   <a:srgbClr val="272A25"/>
                 </a:solidFill>
                 <a:latin typeface="DM Sans"/>
               </a:rPr>
-              <a:t>•  Who it's for, and what they need</a:t>
+              <a:t>•  Ask about the small project, cold.</a:t>
             </a:r>
           </a:p>
           <a:p>
             <a:pPr>
               <a:spcAft>
-                <a:spcPts val="1600"/>
+                <a:spcPts val="2200"/>
               </a:spcAft>
             </a:pPr>
             <a:r>
-              <a:rPr sz="2600" b="0">
+              <a:rPr sz="3000" b="0">
                 <a:solidFill>
                   <a:srgbClr val="272A25"/>
                 </a:solidFill>
                 <a:latin typeface="DM Sans"/>
               </a:rPr>
-              <a:t>•  What it is, in one sentence</a:t>
+              <a:t>•  Add the short context file. Ask again.</a:t>
             </a:r>
           </a:p>
           <a:p>
             <a:pPr>
               <a:spcAft>
-                <a:spcPts val="1600"/>
+                <a:spcPts val="2200"/>
               </a:spcAft>
             </a:pPr>
             <a:r>
-              <a:rPr sz="2600" b="0">
+              <a:rPr sz="3000" b="0">
                 <a:solidFill>
                   <a:srgbClr val="272A25"/>
                 </a:solidFill>
                 <a:latin typeface="DM Sans"/>
               </a:rPr>
-              <a:t>•  Stack and conventions ("plain HTML, no build step")</a:t>
-            </a:r>
-          </a:p>
-          <a:p>
-            <a:pPr>
-              <a:spcAft>
-                <a:spcPts val="1600"/>
-              </a:spcAft>
-            </a:pPr>
-            <a:r>
-              <a:rPr sz="2600" b="0">
-                <a:solidFill>
-                  <a:srgbClr val="272A25"/>
-                </a:solidFill>
-                <a:latin typeface="DM Sans"/>
-              </a:rPr>
-              <a:t>•  Where the facts live (and "never invent facts")</a:t>
-            </a:r>
-          </a:p>
-          <a:p>
-            <a:pPr>
-              <a:spcAft>
-                <a:spcPts val="1600"/>
-              </a:spcAft>
-            </a:pPr>
-            <a:r>
-              <a:rPr sz="2600" b="0">
-                <a:solidFill>
-                  <a:srgbClr val="272A25"/>
-                </a:solidFill>
-                <a:latin typeface="DM Sans"/>
-              </a:rPr>
-              <a:t>•  What "done" looks like</a:t>
-            </a:r>
-          </a:p>
-          <a:p>
-            <a:pPr>
-              <a:spcAft>
-                <a:spcPts val="1600"/>
-              </a:spcAft>
-            </a:pPr>
-            <a:r>
-              <a:rPr sz="2600" b="0">
-                <a:solidFill>
-                  <a:srgbClr val="272A25"/>
-                </a:solidFill>
-                <a:latin typeface="DM Sans"/>
-              </a:rPr>
-              <a:t>•  Keep it short, true, and secret-free</a:t>
+              <a:t>•  Start a fresh session: does it still know?</a:t>
             </a:r>
           </a:p>
         </p:txBody>
@@ -9270,7 +6303,7 @@
                 </a:solidFill>
                 <a:latin typeface="DM Sans"/>
               </a:rPr>
-              <a:t>Week 6 · Demo 1 · Context that sticks        6 / 19</a:t>
+              <a:t>Week 6 · Demo 2 · Context that sticks        6 / 12</a:t>
             </a:r>
           </a:p>
         </p:txBody>
@@ -9378,7 +6411,7 @@
                 </a:solidFill>
                 <a:latin typeface="Fraunces"/>
               </a:rPr>
-              <a:t>Live demo · the same question, twice</a:t>
+              <a:t>A link someone else can open</a:t>
             </a:r>
           </a:p>
         </p:txBody>
@@ -9460,7 +6493,7 @@
                 </a:solidFill>
                 <a:latin typeface="DejaVu Sans Mono"/>
               </a:rPr>
-              <a:t>1 · Open the project. Ask: “Improve the homepage.”</a:t>
+              <a:t>file:///Users/you/Desktop/index.html</a:t>
             </a:r>
           </a:p>
           <a:p>
@@ -9476,7 +6509,7 @@
                 </a:solidFill>
                 <a:latin typeface="DejaVu Sans Mono"/>
               </a:rPr>
-              <a:t>2 · Write AGENTS.md together (2 min)</a:t>
+              <a:t>Only on your laptop.</a:t>
             </a:r>
           </a:p>
           <a:p>
@@ -9492,7 +6525,7 @@
                 </a:solidFill>
                 <a:latin typeface="DejaVu Sans Mono"/>
               </a:rPr>
-              <a:t>3 · Ask again. Compare.</a:t>
+              <a:t> </a:t>
             </a:r>
           </a:p>
           <a:p>
@@ -9508,7 +6541,7 @@
                 </a:solidFill>
                 <a:latin typeface="DejaVu Sans Mono"/>
               </a:rPr>
-              <a:t>4 · Fresh session: does it still know?</a:t>
+              <a:t>https://you.github.io/project/</a:t>
             </a:r>
           </a:p>
           <a:p>
@@ -9524,7 +6557,7 @@
                 </a:solidFill>
                 <a:latin typeface="DejaVu Sans Mono"/>
               </a:rPr>
-              <a:t>5 · Add an index pointing to docs/</a:t>
+              <a:t>A published website.</a:t>
             </a:r>
           </a:p>
         </p:txBody>
@@ -9563,7 +6596,7 @@
                 </a:solidFill>
                 <a:latin typeface="DM Sans"/>
               </a:rPr>
-              <a:t>Same question. Different context. Different answer.</a:t>
+              <a:t>Your laptop isn’t the internet.</a:t>
             </a:r>
           </a:p>
         </p:txBody>
@@ -9602,7 +6635,7 @@
                 </a:solidFill>
                 <a:latin typeface="DM Sans"/>
               </a:rPr>
-              <a:t>Week 6 · Demo 1 · Context that sticks        7 / 19</a:t>
+              <a:t>Week 6 · Demo 3 · Get it online        7 / 12</a:t>
             </a:r>
           </a:p>
         </p:txBody>
@@ -9710,27 +6743,27 @@
                 </a:solidFill>
                 <a:latin typeface="Fraunces"/>
               </a:rPr>
-              <a:t>A real AGENTS.md (the demo's)</a:t>
-            </a:r>
-          </a:p>
-        </p:txBody>
-      </p:sp>
-      <p:sp>
-        <p:nvSpPr>
-          <p:cNvPr id="4" name="Rectangle 3"/>
+              <a:t>Save. Send. Publish.</a:t>
+            </a:r>
+          </a:p>
+        </p:txBody>
+      </p:sp>
+      <p:sp>
+        <p:nvSpPr>
+          <p:cNvPr id="4" name="Rounded Rectangle 3"/>
           <p:cNvSpPr/>
           <p:nvPr/>
         </p:nvSpPr>
         <p:spPr>
           <a:xfrm>
-            <a:off x="822960" y="1828800"/>
-            <a:ext cx="6583680" cy="4023360"/>
-          </a:xfrm>
-          <a:prstGeom prst="rect">
+            <a:off x="822960" y="2103120"/>
+            <a:ext cx="2377440" cy="1097280"/>
+          </a:xfrm>
+          <a:prstGeom prst="roundRect">
             <a:avLst/>
           </a:prstGeom>
           <a:solidFill>
-            <a:srgbClr val="EEECE2"/>
+            <a:srgbClr val="A83D2B"/>
           </a:solidFill>
           <a:ln>
             <a:noFill/>
@@ -9755,19 +6788,309 @@
           <a:lstStyle/>
           <a:p>
             <a:pPr algn="ctr"/>
-          </a:p>
-        </p:txBody>
-      </p:sp>
-      <p:sp>
-        <p:nvSpPr>
-          <p:cNvPr id="5" name="TextBox 4"/>
+            <a:r>
+              <a:rPr sz="2200" b="1">
+                <a:solidFill>
+                  <a:srgbClr val="FFFFFF"/>
+                </a:solidFill>
+              </a:rPr>
+              <a:t>Folder</a:t>
+            </a:r>
+          </a:p>
+        </p:txBody>
+      </p:sp>
+      <p:sp>
+        <p:nvSpPr>
+          <p:cNvPr id="5" name="Right Arrow 4"/>
+          <p:cNvSpPr/>
+          <p:nvPr/>
+        </p:nvSpPr>
+        <p:spPr>
+          <a:xfrm>
+            <a:off x="3246120" y="2468880"/>
+            <a:ext cx="320040" cy="365760"/>
+          </a:xfrm>
+          <a:prstGeom prst="rightArrow">
+            <a:avLst/>
+          </a:prstGeom>
+          <a:solidFill>
+            <a:srgbClr val="64665D"/>
+          </a:solidFill>
+          <a:ln>
+            <a:noFill/>
+          </a:ln>
+        </p:spPr>
+        <p:style>
+          <a:lnRef idx="1">
+            <a:schemeClr val="accent1"/>
+          </a:lnRef>
+          <a:fillRef idx="3">
+            <a:schemeClr val="accent1"/>
+          </a:fillRef>
+          <a:effectRef idx="2">
+            <a:schemeClr val="accent1"/>
+          </a:effectRef>
+          <a:fontRef idx="minor">
+            <a:schemeClr val="lt1"/>
+          </a:fontRef>
+        </p:style>
+        <p:txBody>
+          <a:bodyPr rtlCol="0" anchor="ctr"/>
+          <a:lstStyle/>
+          <a:p>
+            <a:pPr algn="ctr"/>
+          </a:p>
+        </p:txBody>
+      </p:sp>
+      <p:sp>
+        <p:nvSpPr>
+          <p:cNvPr id="6" name="Rounded Rectangle 5"/>
+          <p:cNvSpPr/>
+          <p:nvPr/>
+        </p:nvSpPr>
+        <p:spPr>
+          <a:xfrm>
+            <a:off x="3611880" y="2103120"/>
+            <a:ext cx="2377440" cy="1097280"/>
+          </a:xfrm>
+          <a:prstGeom prst="roundRect">
+            <a:avLst/>
+          </a:prstGeom>
+          <a:solidFill>
+            <a:srgbClr val="272A25"/>
+          </a:solidFill>
+          <a:ln>
+            <a:noFill/>
+          </a:ln>
+        </p:spPr>
+        <p:style>
+          <a:lnRef idx="1">
+            <a:schemeClr val="accent1"/>
+          </a:lnRef>
+          <a:fillRef idx="3">
+            <a:schemeClr val="accent1"/>
+          </a:fillRef>
+          <a:effectRef idx="2">
+            <a:schemeClr val="accent1"/>
+          </a:effectRef>
+          <a:fontRef idx="minor">
+            <a:schemeClr val="lt1"/>
+          </a:fontRef>
+        </p:style>
+        <p:txBody>
+          <a:bodyPr rtlCol="0" anchor="ctr"/>
+          <a:lstStyle/>
+          <a:p>
+            <a:pPr algn="ctr"/>
+            <a:r>
+              <a:rPr sz="2200" b="1">
+                <a:solidFill>
+                  <a:srgbClr val="FFFFFF"/>
+                </a:solidFill>
+              </a:rPr>
+              <a:t>Commit</a:t>
+            </a:r>
+          </a:p>
+        </p:txBody>
+      </p:sp>
+      <p:sp>
+        <p:nvSpPr>
+          <p:cNvPr id="7" name="Right Arrow 6"/>
+          <p:cNvSpPr/>
+          <p:nvPr/>
+        </p:nvSpPr>
+        <p:spPr>
+          <a:xfrm>
+            <a:off x="6035040" y="2468880"/>
+            <a:ext cx="320040" cy="365760"/>
+          </a:xfrm>
+          <a:prstGeom prst="rightArrow">
+            <a:avLst/>
+          </a:prstGeom>
+          <a:solidFill>
+            <a:srgbClr val="64665D"/>
+          </a:solidFill>
+          <a:ln>
+            <a:noFill/>
+          </a:ln>
+        </p:spPr>
+        <p:style>
+          <a:lnRef idx="1">
+            <a:schemeClr val="accent1"/>
+          </a:lnRef>
+          <a:fillRef idx="3">
+            <a:schemeClr val="accent1"/>
+          </a:fillRef>
+          <a:effectRef idx="2">
+            <a:schemeClr val="accent1"/>
+          </a:effectRef>
+          <a:fontRef idx="minor">
+            <a:schemeClr val="lt1"/>
+          </a:fontRef>
+        </p:style>
+        <p:txBody>
+          <a:bodyPr rtlCol="0" anchor="ctr"/>
+          <a:lstStyle/>
+          <a:p>
+            <a:pPr algn="ctr"/>
+          </a:p>
+        </p:txBody>
+      </p:sp>
+      <p:sp>
+        <p:nvSpPr>
+          <p:cNvPr id="8" name="Rounded Rectangle 7"/>
+          <p:cNvSpPr/>
+          <p:nvPr/>
+        </p:nvSpPr>
+        <p:spPr>
+          <a:xfrm>
+            <a:off x="6400800" y="2103120"/>
+            <a:ext cx="2377440" cy="1097280"/>
+          </a:xfrm>
+          <a:prstGeom prst="roundRect">
+            <a:avLst/>
+          </a:prstGeom>
+          <a:solidFill>
+            <a:srgbClr val="272A25"/>
+          </a:solidFill>
+          <a:ln>
+            <a:noFill/>
+          </a:ln>
+        </p:spPr>
+        <p:style>
+          <a:lnRef idx="1">
+            <a:schemeClr val="accent1"/>
+          </a:lnRef>
+          <a:fillRef idx="3">
+            <a:schemeClr val="accent1"/>
+          </a:fillRef>
+          <a:effectRef idx="2">
+            <a:schemeClr val="accent1"/>
+          </a:effectRef>
+          <a:fontRef idx="minor">
+            <a:schemeClr val="lt1"/>
+          </a:fontRef>
+        </p:style>
+        <p:txBody>
+          <a:bodyPr rtlCol="0" anchor="ctr"/>
+          <a:lstStyle/>
+          <a:p>
+            <a:pPr algn="ctr"/>
+            <a:r>
+              <a:rPr sz="2200" b="1">
+                <a:solidFill>
+                  <a:srgbClr val="FFFFFF"/>
+                </a:solidFill>
+              </a:rPr>
+              <a:t>Push</a:t>
+            </a:r>
+          </a:p>
+        </p:txBody>
+      </p:sp>
+      <p:sp>
+        <p:nvSpPr>
+          <p:cNvPr id="9" name="Right Arrow 8"/>
+          <p:cNvSpPr/>
+          <p:nvPr/>
+        </p:nvSpPr>
+        <p:spPr>
+          <a:xfrm>
+            <a:off x="8823960" y="2468880"/>
+            <a:ext cx="320040" cy="365760"/>
+          </a:xfrm>
+          <a:prstGeom prst="rightArrow">
+            <a:avLst/>
+          </a:prstGeom>
+          <a:solidFill>
+            <a:srgbClr val="64665D"/>
+          </a:solidFill>
+          <a:ln>
+            <a:noFill/>
+          </a:ln>
+        </p:spPr>
+        <p:style>
+          <a:lnRef idx="1">
+            <a:schemeClr val="accent1"/>
+          </a:lnRef>
+          <a:fillRef idx="3">
+            <a:schemeClr val="accent1"/>
+          </a:fillRef>
+          <a:effectRef idx="2">
+            <a:schemeClr val="accent1"/>
+          </a:effectRef>
+          <a:fontRef idx="minor">
+            <a:schemeClr val="lt1"/>
+          </a:fontRef>
+        </p:style>
+        <p:txBody>
+          <a:bodyPr rtlCol="0" anchor="ctr"/>
+          <a:lstStyle/>
+          <a:p>
+            <a:pPr algn="ctr"/>
+          </a:p>
+        </p:txBody>
+      </p:sp>
+      <p:sp>
+        <p:nvSpPr>
+          <p:cNvPr id="10" name="Rounded Rectangle 9"/>
+          <p:cNvSpPr/>
+          <p:nvPr/>
+        </p:nvSpPr>
+        <p:spPr>
+          <a:xfrm>
+            <a:off x="9189720" y="2103120"/>
+            <a:ext cx="2377440" cy="1097280"/>
+          </a:xfrm>
+          <a:prstGeom prst="roundRect">
+            <a:avLst/>
+          </a:prstGeom>
+          <a:solidFill>
+            <a:srgbClr val="272A25"/>
+          </a:solidFill>
+          <a:ln>
+            <a:noFill/>
+          </a:ln>
+        </p:spPr>
+        <p:style>
+          <a:lnRef idx="1">
+            <a:schemeClr val="accent1"/>
+          </a:lnRef>
+          <a:fillRef idx="3">
+            <a:schemeClr val="accent1"/>
+          </a:fillRef>
+          <a:effectRef idx="2">
+            <a:schemeClr val="accent1"/>
+          </a:effectRef>
+          <a:fontRef idx="minor">
+            <a:schemeClr val="lt1"/>
+          </a:fontRef>
+        </p:style>
+        <p:txBody>
+          <a:bodyPr rtlCol="0" anchor="ctr"/>
+          <a:lstStyle/>
+          <a:p>
+            <a:pPr algn="ctr"/>
+            <a:r>
+              <a:rPr sz="2200" b="1">
+                <a:solidFill>
+                  <a:srgbClr val="FFFFFF"/>
+                </a:solidFill>
+              </a:rPr>
+              <a:t>Live link</a:t>
+            </a:r>
+          </a:p>
+        </p:txBody>
+      </p:sp>
+      <p:sp>
+        <p:nvSpPr>
+          <p:cNvPr id="11" name="TextBox 10"/>
           <p:cNvSpPr txBox="1"/>
           <p:nvPr/>
         </p:nvSpPr>
         <p:spPr>
           <a:xfrm>
-            <a:off x="1097280" y="2011680"/>
-            <a:ext cx="6217920" cy="3749039"/>
+            <a:off x="822960" y="3931920"/>
+            <a:ext cx="10607040" cy="2286000"/>
           </a:xfrm>
           <a:prstGeom prst="rect">
             <a:avLst/>
@@ -9782,143 +7105,56 @@
           <a:p>
             <a:pPr>
               <a:spcAft>
-                <a:spcPts val="200"/>
+                <a:spcPts val="1800"/>
               </a:spcAft>
             </a:pPr>
             <a:r>
-              <a:rPr sz="1800" b="0">
+              <a:rPr sz="2800" b="0">
                 <a:solidFill>
                   <a:srgbClr val="272A25"/>
                 </a:solidFill>
-                <a:latin typeface="DejaVu Sans Mono"/>
+                <a:latin typeface="DM Sans"/>
               </a:rPr>
-              <a:t># Hill Plant Swap</a:t>
+              <a:t>•  Commit: a save point on your laptop.</a:t>
             </a:r>
           </a:p>
           <a:p>
             <a:pPr>
               <a:spcAft>
-                <a:spcPts val="200"/>
+                <a:spcPts val="1800"/>
               </a:spcAft>
             </a:pPr>
             <a:r>
-              <a:rPr sz="1800" b="0">
+              <a:rPr sz="2800" b="0">
                 <a:solidFill>
                   <a:srgbClr val="272A25"/>
                 </a:solidFill>
-                <a:latin typeface="DejaVu Sans Mono"/>
+                <a:latin typeface="DM Sans"/>
               </a:rPr>
-              <a:t>Who: first-year students on phones, nervous</a:t>
+              <a:t>•  Push: send it to GitHub.</a:t>
             </a:r>
           </a:p>
           <a:p>
             <a:pPr>
               <a:spcAft>
-                <a:spcPts val="200"/>
+                <a:spcPts val="1800"/>
               </a:spcAft>
             </a:pPr>
             <a:r>
-              <a:rPr sz="1800" b="0">
+              <a:rPr sz="2800" b="0">
                 <a:solidFill>
                   <a:srgbClr val="272A25"/>
-                </a:solidFill>
-                <a:latin typeface="DejaVu Sans Mono"/>
-              </a:rPr>
-              <a:t>What: one page announcing a free monthly swap</a:t>
-            </a:r>
-          </a:p>
-          <a:p>
-            <a:pPr>
-              <a:spcAft>
-                <a:spcPts val="200"/>
-              </a:spcAft>
-            </a:pPr>
-            <a:r>
-              <a:rPr sz="1800" b="0">
-                <a:solidFill>
-                  <a:srgbClr val="272A25"/>
-                </a:solidFill>
-                <a:latin typeface="DejaVu Sans Mono"/>
-              </a:rPr>
-              <a:t>Stack: plain HTML + CSS, no JavaScript</a:t>
-            </a:r>
-          </a:p>
-          <a:p>
-            <a:pPr>
-              <a:spcAft>
-                <a:spcPts val="200"/>
-              </a:spcAft>
-            </a:pPr>
-            <a:r>
-              <a:rPr sz="1800" b="0">
-                <a:solidFill>
-                  <a:srgbClr val="272A25"/>
-                </a:solidFill>
-                <a:latin typeface="DejaVu Sans Mono"/>
-              </a:rPr>
-              <a:t>Facts: only docs/event-facts.md; never invent</a:t>
-            </a:r>
-          </a:p>
-          <a:p>
-            <a:pPr>
-              <a:spcAft>
-                <a:spcPts val="200"/>
-              </a:spcAft>
-            </a:pPr>
-            <a:r>
-              <a:rPr sz="1800" b="0">
-                <a:solidFill>
-                  <a:srgbClr val="272A25"/>
-                </a:solidFill>
-                <a:latin typeface="DejaVu Sans Mono"/>
-              </a:rPr>
-              <a:t>Done: date + place readable at 390px in 10 s</a:t>
-            </a:r>
-          </a:p>
-        </p:txBody>
-      </p:sp>
-      <p:sp>
-        <p:nvSpPr>
-          <p:cNvPr id="6" name="TextBox 5"/>
-          <p:cNvSpPr txBox="1"/>
-          <p:nvPr/>
-        </p:nvSpPr>
-        <p:spPr>
-          <a:xfrm>
-            <a:off x="7772400" y="3108960"/>
-            <a:ext cx="3931920" cy="1828800"/>
-          </a:xfrm>
-          <a:prstGeom prst="rect">
-            <a:avLst/>
-          </a:prstGeom>
-          <a:noFill/>
-        </p:spPr>
-        <p:txBody>
-          <a:bodyPr wrap="square">
-            <a:spAutoFit/>
-          </a:bodyPr>
-          <a:lstStyle/>
-          <a:p>
-            <a:pPr>
-              <a:spcAft>
-                <a:spcPts val="1400"/>
-              </a:spcAft>
-            </a:pPr>
-            <a:r>
-              <a:rPr sz="2800" b="0">
-                <a:solidFill>
-                  <a:srgbClr val="64665D"/>
                 </a:solidFill>
                 <a:latin typeface="DM Sans"/>
               </a:rPr>
-              <a:t>Six lines. Every session starts here.</a:t>
-            </a:r>
-          </a:p>
-        </p:txBody>
-      </p:sp>
-      <p:sp>
-        <p:nvSpPr>
-          <p:cNvPr id="7" name="TextBox 6"/>
+              <a:t>•  Deploy: turn it into a live website.</a:t>
+            </a:r>
+          </a:p>
+        </p:txBody>
+      </p:sp>
+      <p:sp>
+        <p:nvSpPr>
+          <p:cNvPr id="12" name="TextBox 11"/>
           <p:cNvSpPr txBox="1"/>
           <p:nvPr/>
         </p:nvSpPr>
@@ -9950,7 +7186,7 @@
                 </a:solidFill>
                 <a:latin typeface="DM Sans"/>
               </a:rPr>
-              <a:t>Week 6 · Demo 1 · Context that sticks        8 / 19</a:t>
+              <a:t>Week 6 · Demo 3 · Get it online        8 / 12</a:t>
             </a:r>
           </a:p>
         </p:txBody>
@@ -10058,64 +7294,21 @@
                 </a:solidFill>
                 <a:latin typeface="Fraunces"/>
               </a:rPr>
-              <a:t>Index files: a map, not a dump</a:t>
-            </a:r>
-          </a:p>
-        </p:txBody>
-      </p:sp>
-      <p:sp>
-        <p:nvSpPr>
-          <p:cNvPr id="4" name="Rectangle 3"/>
-          <p:cNvSpPr/>
-          <p:nvPr/>
-        </p:nvSpPr>
-        <p:spPr>
-          <a:xfrm>
-            <a:off x="822960" y="1828800"/>
-            <a:ext cx="6583680" cy="4023360"/>
-          </a:xfrm>
-          <a:prstGeom prst="rect">
-            <a:avLst/>
-          </a:prstGeom>
-          <a:solidFill>
-            <a:srgbClr val="EEECE2"/>
-          </a:solidFill>
-          <a:ln>
-            <a:noFill/>
-          </a:ln>
-        </p:spPr>
-        <p:style>
-          <a:lnRef idx="1">
-            <a:schemeClr val="accent1"/>
-          </a:lnRef>
-          <a:fillRef idx="3">
-            <a:schemeClr val="accent1"/>
-          </a:fillRef>
-          <a:effectRef idx="2">
-            <a:schemeClr val="accent1"/>
-          </a:effectRef>
-          <a:fontRef idx="minor">
-            <a:schemeClr val="lt1"/>
-          </a:fontRef>
-        </p:style>
-        <p:txBody>
-          <a:bodyPr rtlCol="0" anchor="ctr"/>
-          <a:lstStyle/>
-          <a:p>
-            <a:pPr algn="ctr"/>
-          </a:p>
-        </p:txBody>
-      </p:sp>
-      <p:sp>
-        <p:nvSpPr>
-          <p:cNvPr id="5" name="TextBox 4"/>
+              <a:t>Demo 3 · getting online</a:t>
+            </a:r>
+          </a:p>
+        </p:txBody>
+      </p:sp>
+      <p:sp>
+        <p:nvSpPr>
+          <p:cNvPr id="4" name="TextBox 3"/>
           <p:cNvSpPr txBox="1"/>
           <p:nvPr/>
         </p:nvSpPr>
         <p:spPr>
           <a:xfrm>
-            <a:off x="1097280" y="2011680"/>
-            <a:ext cx="6217920" cy="3749039"/>
+            <a:off x="822960" y="2011680"/>
+            <a:ext cx="10607040" cy="4206240"/>
           </a:xfrm>
           <a:prstGeom prst="rect">
             <a:avLst/>
@@ -10130,111 +7323,56 @@
           <a:p>
             <a:pPr>
               <a:spcAft>
-                <a:spcPts val="200"/>
+                <a:spcPts val="2200"/>
               </a:spcAft>
             </a:pPr>
             <a:r>
-              <a:rPr sz="1800" b="0">
+              <a:rPr sz="3000" b="0">
                 <a:solidFill>
                   <a:srgbClr val="272A25"/>
                 </a:solidFill>
-                <a:latin typeface="DejaVu Sans Mono"/>
+                <a:latin typeface="DM Sans"/>
               </a:rPr>
-              <a:t>## Where to look</a:t>
+              <a:t>•  GitHub Desktop: create, commit, publish.</a:t>
             </a:r>
           </a:p>
           <a:p>
             <a:pPr>
               <a:spcAft>
-                <a:spcPts val="200"/>
+                <a:spcPts val="2200"/>
               </a:spcAft>
             </a:pPr>
             <a:r>
-              <a:rPr sz="1800" b="0">
+              <a:rPr sz="3000" b="0">
                 <a:solidFill>
                   <a:srgbClr val="272A25"/>
                 </a:solidFill>
-                <a:latin typeface="DejaVu Sans Mono"/>
+                <a:latin typeface="DM Sans"/>
               </a:rPr>
-              <a:t>- docs/event-facts.md: the only source of facts</a:t>
+              <a:t>•  GitHub → Settings → Pages → main → Save.</a:t>
             </a:r>
           </a:p>
           <a:p>
             <a:pPr>
               <a:spcAft>
-                <a:spcPts val="200"/>
+                <a:spcPts val="2200"/>
               </a:spcAft>
             </a:pPr>
             <a:r>
-              <a:rPr sz="1800" b="0">
+              <a:rPr sz="3000" b="0">
                 <a:solidFill>
                   <a:srgbClr val="272A25"/>
-                </a:solidFill>
-                <a:latin typeface="DejaVu Sans Mono"/>
-              </a:rPr>
-              <a:t>- docs/audience.md: who visits</a:t>
-            </a:r>
-          </a:p>
-          <a:p>
-            <a:pPr>
-              <a:spcAft>
-                <a:spcPts val="200"/>
-              </a:spcAft>
-            </a:pPr>
-            <a:r>
-              <a:rPr sz="1800" b="0">
-                <a:solidFill>
-                  <a:srgbClr val="272A25"/>
-                </a:solidFill>
-                <a:latin typeface="DejaVu Sans Mono"/>
-              </a:rPr>
-              <a:t>- research/index.md: interview notes (its own index)</a:t>
-            </a:r>
-          </a:p>
-        </p:txBody>
-      </p:sp>
-      <p:sp>
-        <p:nvSpPr>
-          <p:cNvPr id="6" name="TextBox 5"/>
-          <p:cNvSpPr txBox="1"/>
-          <p:nvPr/>
-        </p:nvSpPr>
-        <p:spPr>
-          <a:xfrm>
-            <a:off x="7772400" y="3108960"/>
-            <a:ext cx="3931920" cy="1828800"/>
-          </a:xfrm>
-          <a:prstGeom prst="rect">
-            <a:avLst/>
-          </a:prstGeom>
-          <a:noFill/>
-        </p:spPr>
-        <p:txBody>
-          <a:bodyPr wrap="square">
-            <a:spAutoFit/>
-          </a:bodyPr>
-          <a:lstStyle/>
-          <a:p>
-            <a:pPr>
-              <a:spcAft>
-                <a:spcPts val="1400"/>
-              </a:spcAft>
-            </a:pPr>
-            <a:r>
-              <a:rPr sz="2800" b="0">
-                <a:solidFill>
-                  <a:srgbClr val="64665D"/>
                 </a:solidFill>
                 <a:latin typeface="DM Sans"/>
               </a:rPr>
-              <a:t>The AI reads the map, then opens only what it needs.</a:t>
-            </a:r>
-          </a:p>
-        </p:txBody>
-      </p:sp>
-      <p:sp>
-        <p:nvSpPr>
-          <p:cNvPr id="7" name="TextBox 6"/>
+              <a:t>•  Open the live link on a phone.</a:t>
+            </a:r>
+          </a:p>
+        </p:txBody>
+      </p:sp>
+      <p:sp>
+        <p:nvSpPr>
+          <p:cNvPr id="5" name="TextBox 4"/>
           <p:cNvSpPr txBox="1"/>
           <p:nvPr/>
         </p:nvSpPr>
@@ -10266,7 +7404,7 @@
                 </a:solidFill>
                 <a:latin typeface="DM Sans"/>
               </a:rPr>
-              <a:t>Week 6 · Demo 1 · Context that sticks        9 / 19</a:t>
+              <a:t>Week 6 · Demo 3 · Get it online        9 / 12</a:t>
             </a:r>
           </a:p>
         </p:txBody>

</xml_diff>

<commit_message>
Week 6: simplify to the foundation (Aaron's 4:22 direction) (#9)
* Week 6 foundation: copy lesson, light context file, get online; no live connector or pair exercise

* No connector advertising anywhere in Week 6; concept only next week

---------

Co-authored-by: unforcedagi <agi@unforced.dev>
</commit_message>
<xml_diff>
--- a/lessons/week-6/_src/week6-lecture.pptx
+++ b/lessons/week-6/_src/week6-lecture.pptx
@@ -17,13 +17,6 @@
     <p:sldId id="265" r:id="rId17"/>
     <p:sldId id="266" r:id="rId18"/>
     <p:sldId id="267" r:id="rId19"/>
-    <p:sldId id="268" r:id="rId20"/>
-    <p:sldId id="269" r:id="rId21"/>
-    <p:sldId id="270" r:id="rId22"/>
-    <p:sldId id="271" r:id="rId23"/>
-    <p:sldId id="272" r:id="rId24"/>
-    <p:sldId id="273" r:id="rId25"/>
-    <p:sldId id="274" r:id="rId26"/>
   </p:sldIdLst>
   <p:sldSz cx="12191695" cy="6858000" type="screen4x3"/>
   <p:notesSz cx="6858000" cy="9144000"/>
@@ -520,19 +513,7 @@
           <a:lstStyle/>
           <a:p>
             <a:r>
-              <a:t>5:05 · 30 seconds</a:t>
-            </a:r>
-          </a:p>
-          <a:p/>
-          <a:p>
-            <a:r>
-              <a:t>Tonight is mostly live demos, not slides. Three of them. Everything tonight is also one markdown lesson students can paste into their own AI later, so nobody has to catch every word.</a:t>
-            </a:r>
-          </a:p>
-          <a:p/>
-          <a:p>
-            <a:r>
-              <a:t>(Background for you, not to teach: this whole lecture is the 4D AI Fluency framework in practice. Context files are Description that persists; checking the output out loud is Discernment; deciding what to hand the agent is Delegation; checking before you publish is Diligence.)</a:t>
+              <a:t>5:05–5:06. Three simple demos: copy the lesson, context that sticks, getting online. No live connector tonight.</a:t>
             </a:r>
           </a:p>
         </p:txBody>
@@ -602,13 +583,7 @@
           <a:lstStyle/>
           <a:p>
             <a:r>
-              <a:t>5:17–5:18 · 1 min</a:t>
-            </a:r>
-          </a:p>
-          <a:p/>
-          <a:p>
-            <a:r>
-              <a:t>This is the most common problem in submissions so far: a link that points to a file on your own computer. If the address starts with file:// or C:\, nobody else can open it. Test: send the link to yourself and open it on your phone, off wifi.</a:t>
+              <a:t>5:31–5:33. Concept only. Don’t show a server URL or set one up. This week, copying the markdown is the step toward that.</a:t>
             </a:r>
           </a:p>
         </p:txBody>
@@ -678,13 +653,7 @@
           <a:lstStyle/>
           <a:p>
             <a:r>
-              <a:t>5:18–5:19 · 1 min</a:t>
-            </a:r>
-          </a:p>
-          <a:p/>
-          <a:p>
-            <a:r>
-              <a:t>Commit = a save point with a note. Push = send your save points to GitHub. Deploy = publish. Most confusion comes from treating these as one thing.</a:t>
+              <a:t>5:33–5:35. Free link on account page. No history? Paste last two submissions. No due date. Then trios 5:35–6:05.</a:t>
             </a:r>
           </a:p>
         </p:txBody>
@@ -754,618 +723,7 @@
           <a:lstStyle/>
           <a:p>
             <a:r>
-              <a:t>5:19–5:27 · 8 min LIVE · exact clicks on the demo script page</a:t>
-            </a:r>
-          </a:p>
-          <a:p/>
-          <a:p>
-            <a:r>
-              <a:t>Use the zip from the class files page so you start from a plain folder with no git history.</a:t>
-            </a:r>
-          </a:p>
-          <a:p>
-            <a:r>
-              <a:t>1. Unzip. GitHub Desktop: File → Add local repository → choose the folder → 'create a repository' → Create.</a:t>
-            </a:r>
-          </a:p>
-          <a:p>
-            <a:r>
-              <a:t>2. Commit to main ('first version'). Publish repository; UNTICK 'keep this code private'.</a:t>
-            </a:r>
-          </a:p>
-          <a:p>
-            <a:r>
-              <a:t>3. On github.com: Settings → Pages → Source: Deploy from a branch → main / (root) → Save. About a minute.</a:t>
-            </a:r>
-          </a:p>
-          <a:p>
-            <a:r>
-              <a:t>4. Open the https://&lt;you&gt;.github.io/&lt;repo&gt;/ link on your phone; hold it up.</a:t>
-            </a:r>
-          </a:p>
-          <a:p>
-            <a:r>
-              <a:t>5. Ask the agent for one small change, commit, push, refresh after ~1 min.</a:t>
-            </a:r>
-          </a:p>
-          <a:p>
-            <a:r>
-              <a:t>While Pages builds, say: Vercel does the same for React/Next/Vite projects: import the GitHub repo at vercel.com/new and click Deploy.</a:t>
-            </a:r>
-          </a:p>
-          <a:p>
-            <a:r>
-              <a:t>IF PAGES IS SLOW: show the already-live copy at unforcedagi.github.io/lvb-week6-demo and move on. The handout 'Get your project online' has every step with a no-install option.</a:t>
-            </a:r>
-          </a:p>
-        </p:txBody>
-      </p:sp>
-      <p:sp>
-        <p:nvSpPr>
-          <p:cNvPr id="4" name="Slide Number Placeholder 3"/>
-          <p:cNvSpPr>
-            <a:spLocks noGrp="1"/>
-          </p:cNvSpPr>
-          <p:nvPr>
-            <p:ph type="sldNum" idx="5" sz="quarter"/>
-          </p:nvPr>
-        </p:nvSpPr>
-        <p:spPr/>
-      </p:sp>
-    </p:spTree>
-  </p:cSld>
-  <p:clrMapOvr>
-    <a:masterClrMapping/>
-  </p:clrMapOvr>
-</p:notes>
-</file>
-
-<file path=ppt/notesSlides/notesSlide13.xml><?xml version="1.0" encoding="utf-8"?>
-<p:notes xmlns:a="http://schemas.openxmlformats.org/drawingml/2006/main" xmlns:p="http://schemas.openxmlformats.org/presentationml/2006/main" xmlns:r="http://schemas.openxmlformats.org/officeDocument/2006/relationships">
-  <p:cSld>
-    <p:spTree>
-      <p:nvGrpSpPr>
-        <p:cNvPr id="1" name=""/>
-        <p:cNvGrpSpPr/>
-        <p:nvPr/>
-      </p:nvGrpSpPr>
-      <p:grpSpPr>
-        <a:xfrm>
-          <a:off x="0" y="0"/>
-          <a:ext cx="0" cy="0"/>
-          <a:chOff x="0" y="0"/>
-          <a:chExt cx="0" cy="0"/>
-        </a:xfrm>
-      </p:grpSpPr>
-      <p:sp>
-        <p:nvSpPr>
-          <p:cNvPr id="2" name="Slide Image Placeholder 1"/>
-          <p:cNvSpPr>
-            <a:spLocks noGrp="1"/>
-          </p:cNvSpPr>
-          <p:nvPr>
-            <p:ph type="sldImg" idx="2"/>
-          </p:nvPr>
-        </p:nvSpPr>
-        <p:spPr/>
-      </p:sp>
-      <p:sp>
-        <p:nvSpPr>
-          <p:cNvPr id="3" name="Notes Placeholder 2"/>
-          <p:cNvSpPr>
-            <a:spLocks noGrp="1"/>
-          </p:cNvSpPr>
-          <p:nvPr>
-            <p:ph type="body" idx="3" sz="quarter"/>
-          </p:nvPr>
-        </p:nvSpPr>
-        <p:spPr/>
-        <p:txBody>
-          <a:bodyPr/>
-          <a:lstStyle/>
-          <a:p>
-            <a:r>
-              <a:t>5:27 · 30 seconds. The handout's fix-it table, in brief. Most first deploys hit one of these. Name them so nobody feels stuck alone; the handout on the Week 6 page has the full steps.</a:t>
-            </a:r>
-          </a:p>
-        </p:txBody>
-      </p:sp>
-      <p:sp>
-        <p:nvSpPr>
-          <p:cNvPr id="4" name="Slide Number Placeholder 3"/>
-          <p:cNvSpPr>
-            <a:spLocks noGrp="1"/>
-          </p:cNvSpPr>
-          <p:nvPr>
-            <p:ph type="sldNum" idx="5" sz="quarter"/>
-          </p:nvPr>
-        </p:nvSpPr>
-        <p:spPr/>
-      </p:sp>
-    </p:spTree>
-  </p:cSld>
-  <p:clrMapOvr>
-    <a:masterClrMapping/>
-  </p:clrMapOvr>
-</p:notes>
-</file>
-
-<file path=ppt/notesSlides/notesSlide14.xml><?xml version="1.0" encoding="utf-8"?>
-<p:notes xmlns:a="http://schemas.openxmlformats.org/drawingml/2006/main" xmlns:p="http://schemas.openxmlformats.org/presentationml/2006/main" xmlns:r="http://schemas.openxmlformats.org/officeDocument/2006/relationships">
-  <p:cSld>
-    <p:spTree>
-      <p:nvGrpSpPr>
-        <p:cNvPr id="1" name=""/>
-        <p:cNvGrpSpPr/>
-        <p:nvPr/>
-      </p:nvGrpSpPr>
-      <p:grpSpPr>
-        <a:xfrm>
-          <a:off x="0" y="0"/>
-          <a:ext cx="0" cy="0"/>
-          <a:chOff x="0" y="0"/>
-          <a:chExt cx="0" cy="0"/>
-        </a:xfrm>
-      </p:grpSpPr>
-      <p:sp>
-        <p:nvSpPr>
-          <p:cNvPr id="2" name="Slide Image Placeholder 1"/>
-          <p:cNvSpPr>
-            <a:spLocks noGrp="1"/>
-          </p:cNvSpPr>
-          <p:nvPr>
-            <p:ph type="sldImg" idx="2"/>
-          </p:nvPr>
-        </p:nvSpPr>
-        <p:spPr/>
-      </p:sp>
-      <p:sp>
-        <p:nvSpPr>
-          <p:cNvPr id="3" name="Notes Placeholder 2"/>
-          <p:cNvSpPr>
-            <a:spLocks noGrp="1"/>
-          </p:cNvSpPr>
-          <p:nvPr>
-            <p:ph type="body" idx="3" sz="quarter"/>
-          </p:nvPr>
-        </p:nvSpPr>
-        <p:spPr/>
-        <p:txBody>
-          <a:bodyPr/>
-          <a:lstStyle/>
-          <a:p>
-            <a:r>
-              <a:t>5:27–5:28 · 1 min</a:t>
-            </a:r>
-          </a:p>
-          <a:p/>
-          <a:p>
-            <a:r>
-              <a:t>API = how one program asks another for things; every service's menu is different. MCP (Model Context Protocol) is an open standard: write the connector once, use it in any MCP-capable app. Analogy: different wall sockets vs a universal adapter. Reading adds context; writing (sending, paying, deleting) changes the world. Start read-only; ask before anything that changes things. A web page that says 'ignore your instructions' is data, not your boss.</a:t>
-            </a:r>
-          </a:p>
-        </p:txBody>
-      </p:sp>
-      <p:sp>
-        <p:nvSpPr>
-          <p:cNvPr id="4" name="Slide Number Placeholder 3"/>
-          <p:cNvSpPr>
-            <a:spLocks noGrp="1"/>
-          </p:cNvSpPr>
-          <p:nvPr>
-            <p:ph type="sldNum" idx="5" sz="quarter"/>
-          </p:nvPr>
-        </p:nvSpPr>
-        <p:spPr/>
-      </p:sp>
-    </p:spTree>
-  </p:cSld>
-  <p:clrMapOvr>
-    <a:masterClrMapping/>
-  </p:clrMapOvr>
-</p:notes>
-</file>
-
-<file path=ppt/notesSlides/notesSlide15.xml><?xml version="1.0" encoding="utf-8"?>
-<p:notes xmlns:a="http://schemas.openxmlformats.org/drawingml/2006/main" xmlns:p="http://schemas.openxmlformats.org/presentationml/2006/main" xmlns:r="http://schemas.openxmlformats.org/officeDocument/2006/relationships">
-  <p:cSld>
-    <p:spTree>
-      <p:nvGrpSpPr>
-        <p:cNvPr id="1" name=""/>
-        <p:cNvGrpSpPr/>
-        <p:nvPr/>
-      </p:nvGrpSpPr>
-      <p:grpSpPr>
-        <a:xfrm>
-          <a:off x="0" y="0"/>
-          <a:ext cx="0" cy="0"/>
-          <a:chOff x="0" y="0"/>
-          <a:chExt cx="0" cy="0"/>
-        </a:xfrm>
-      </p:grpSpPr>
-      <p:sp>
-        <p:nvSpPr>
-          <p:cNvPr id="2" name="Slide Image Placeholder 1"/>
-          <p:cNvSpPr>
-            <a:spLocks noGrp="1"/>
-          </p:cNvSpPr>
-          <p:nvPr>
-            <p:ph type="sldImg" idx="2"/>
-          </p:nvPr>
-        </p:nvSpPr>
-        <p:spPr/>
-      </p:sp>
-      <p:sp>
-        <p:nvSpPr>
-          <p:cNvPr id="3" name="Notes Placeholder 2"/>
-          <p:cNvSpPr>
-            <a:spLocks noGrp="1"/>
-          </p:cNvSpPr>
-          <p:nvPr>
-            <p:ph type="body" idx="3" sz="quarter"/>
-          </p:nvPr>
-        </p:nvSpPr>
-        <p:spPr/>
-        <p:txBody>
-          <a:bodyPr/>
-          <a:lstStyle/>
-          <a:p>
-            <a:r>
-              <a:t>5:28–5:33 · 5 min LIVE</a:t>
-            </a:r>
-          </a:p>
-          <a:p/>
-          <a:p>
-            <a:r>
-              <a:t>Claude Code: claude mcp add --transport http lvb https://api.learnvibe.build/mcp, then start claude and run /mcp to see it connected.</a:t>
-            </a:r>
-          </a:p>
-          <a:p>
-            <a:r>
-              <a:t>Claude app: Settings → Connectors → Add custom connector → paste the URL (plans vary).</a:t>
-            </a:r>
-          </a:p>
-          <a:p>
-            <a:r>
-              <a:t>Ask it to list the lessons, then to teach the AGENTS.md part and quiz you. It's read-only and public: no student data, nothing it can change. That's the safe way to start with any connector.</a:t>
-            </a:r>
-          </a:p>
-          <a:p>
-            <a:r>
-              <a:t>IF IT STALLS: open cu.learnvibe.build/lessons/week-6/lesson.md, copy it, paste into any chat with the same prompt. Same result, no connector.</a:t>
-            </a:r>
-          </a:p>
-        </p:txBody>
-      </p:sp>
-      <p:sp>
-        <p:nvSpPr>
-          <p:cNvPr id="4" name="Slide Number Placeholder 3"/>
-          <p:cNvSpPr>
-            <a:spLocks noGrp="1"/>
-          </p:cNvSpPr>
-          <p:nvPr>
-            <p:ph type="sldNum" idx="5" sz="quarter"/>
-          </p:nvPr>
-        </p:nvSpPr>
-        <p:spPr/>
-      </p:sp>
-    </p:spTree>
-  </p:cSld>
-  <p:clrMapOvr>
-    <a:masterClrMapping/>
-  </p:clrMapOvr>
-</p:notes>
-</file>
-
-<file path=ppt/notesSlides/notesSlide16.xml><?xml version="1.0" encoding="utf-8"?>
-<p:notes xmlns:a="http://schemas.openxmlformats.org/drawingml/2006/main" xmlns:p="http://schemas.openxmlformats.org/presentationml/2006/main" xmlns:r="http://schemas.openxmlformats.org/officeDocument/2006/relationships">
-  <p:cSld>
-    <p:spTree>
-      <p:nvGrpSpPr>
-        <p:cNvPr id="1" name=""/>
-        <p:cNvGrpSpPr/>
-        <p:nvPr/>
-      </p:nvGrpSpPr>
-      <p:grpSpPr>
-        <a:xfrm>
-          <a:off x="0" y="0"/>
-          <a:ext cx="0" cy="0"/>
-          <a:chOff x="0" y="0"/>
-          <a:chExt cx="0" cy="0"/>
-        </a:xfrm>
-      </p:grpSpPr>
-      <p:sp>
-        <p:nvSpPr>
-          <p:cNvPr id="2" name="Slide Image Placeholder 1"/>
-          <p:cNvSpPr>
-            <a:spLocks noGrp="1"/>
-          </p:cNvSpPr>
-          <p:nvPr>
-            <p:ph type="sldImg" idx="2"/>
-          </p:nvPr>
-        </p:nvSpPr>
-        <p:spPr/>
-      </p:sp>
-      <p:sp>
-        <p:nvSpPr>
-          <p:cNvPr id="3" name="Notes Placeholder 2"/>
-          <p:cNvSpPr>
-            <a:spLocks noGrp="1"/>
-          </p:cNvSpPr>
-          <p:nvPr>
-            <p:ph type="body" idx="3" sz="quarter"/>
-          </p:nvPr>
-        </p:nvSpPr>
-        <p:spPr/>
-        <p:txBody>
-          <a:bodyPr/>
-          <a:lstStyle/>
-          <a:p>
-            <a:r>
-              <a:t>5:33 · 30 seconds. The through-line, made concrete. Background (not taught): this is Description, Discernment, Delegation and Diligence in practice. A connector that can write (send email, edit files) deserves a pause: what can it change, and can you undo it? Content an AI reads can contain instructions (prompt injection); treat it as data.</a:t>
-            </a:r>
-          </a:p>
-        </p:txBody>
-      </p:sp>
-      <p:sp>
-        <p:nvSpPr>
-          <p:cNvPr id="4" name="Slide Number Placeholder 3"/>
-          <p:cNvSpPr>
-            <a:spLocks noGrp="1"/>
-          </p:cNvSpPr>
-          <p:nvPr>
-            <p:ph type="sldNum" idx="5" sz="quarter"/>
-          </p:nvPr>
-        </p:nvSpPr>
-        <p:spPr/>
-      </p:sp>
-    </p:spTree>
-  </p:cSld>
-  <p:clrMapOvr>
-    <a:masterClrMapping/>
-  </p:clrMapOvr>
-</p:notes>
-</file>
-
-<file path=ppt/notesSlides/notesSlide17.xml><?xml version="1.0" encoding="utf-8"?>
-<p:notes xmlns:a="http://schemas.openxmlformats.org/drawingml/2006/main" xmlns:p="http://schemas.openxmlformats.org/presentationml/2006/main" xmlns:r="http://schemas.openxmlformats.org/officeDocument/2006/relationships">
-  <p:cSld>
-    <p:spTree>
-      <p:nvGrpSpPr>
-        <p:cNvPr id="1" name=""/>
-        <p:cNvGrpSpPr/>
-        <p:nvPr/>
-      </p:nvGrpSpPr>
-      <p:grpSpPr>
-        <a:xfrm>
-          <a:off x="0" y="0"/>
-          <a:ext cx="0" cy="0"/>
-          <a:chOff x="0" y="0"/>
-          <a:chExt cx="0" cy="0"/>
-        </a:xfrm>
-      </p:grpSpPr>
-      <p:sp>
-        <p:nvSpPr>
-          <p:cNvPr id="2" name="Slide Image Placeholder 1"/>
-          <p:cNvSpPr>
-            <a:spLocks noGrp="1"/>
-          </p:cNvSpPr>
-          <p:nvPr>
-            <p:ph type="sldImg" idx="2"/>
-          </p:nvPr>
-        </p:nvSpPr>
-        <p:spPr/>
-      </p:sp>
-      <p:sp>
-        <p:nvSpPr>
-          <p:cNvPr id="3" name="Notes Placeholder 2"/>
-          <p:cNvSpPr>
-            <a:spLocks noGrp="1"/>
-          </p:cNvSpPr>
-          <p:nvPr>
-            <p:ph type="body" idx="3" sz="quarter"/>
-          </p:nvPr>
-        </p:nvSpPr>
-        <p:spPr/>
-        <p:txBody>
-          <a:bodyPr/>
-          <a:lstStyle/>
-          <a:p>
-            <a:r>
-              <a:t>5:33–5:35 · 2 min</a:t>
-            </a:r>
-          </a:p>
-          <a:p/>
-          <a:p>
-            <a:r>
-              <a:t>Shipper asked her AI to place her on Every's Eight Levels of AI Adoption from her actual past work, turned that into recommendations, then had it teach her the next step. Same move as tonight: give your AI context about you, and it can coach you. Free plan or no chat history? Paste your AGENTS.md or your last two submissions and ask 'what level am I, with examples?' Gift link: on your account page and in tonight's announcement. No due date.</a:t>
-            </a:r>
-          </a:p>
-          <a:p>
-            <a:r>
-              <a:t>Then: trios, 5:35–6:05.</a:t>
-            </a:r>
-          </a:p>
-        </p:txBody>
-      </p:sp>
-      <p:sp>
-        <p:nvSpPr>
-          <p:cNvPr id="4" name="Slide Number Placeholder 3"/>
-          <p:cNvSpPr>
-            <a:spLocks noGrp="1"/>
-          </p:cNvSpPr>
-          <p:nvPr>
-            <p:ph type="sldNum" idx="5" sz="quarter"/>
-          </p:nvPr>
-        </p:nvSpPr>
-        <p:spPr/>
-      </p:sp>
-    </p:spTree>
-  </p:cSld>
-  <p:clrMapOvr>
-    <a:masterClrMapping/>
-  </p:clrMapOvr>
-</p:notes>
-</file>
-
-<file path=ppt/notesSlides/notesSlide18.xml><?xml version="1.0" encoding="utf-8"?>
-<p:notes xmlns:a="http://schemas.openxmlformats.org/drawingml/2006/main" xmlns:p="http://schemas.openxmlformats.org/presentationml/2006/main" xmlns:r="http://schemas.openxmlformats.org/officeDocument/2006/relationships">
-  <p:cSld>
-    <p:spTree>
-      <p:nvGrpSpPr>
-        <p:cNvPr id="1" name=""/>
-        <p:cNvGrpSpPr/>
-        <p:nvPr/>
-      </p:nvGrpSpPr>
-      <p:grpSpPr>
-        <a:xfrm>
-          <a:off x="0" y="0"/>
-          <a:ext cx="0" cy="0"/>
-          <a:chOff x="0" y="0"/>
-          <a:chExt cx="0" cy="0"/>
-        </a:xfrm>
-      </p:grpSpPr>
-      <p:sp>
-        <p:nvSpPr>
-          <p:cNvPr id="2" name="Slide Image Placeholder 1"/>
-          <p:cNvSpPr>
-            <a:spLocks noGrp="1"/>
-          </p:cNvSpPr>
-          <p:nvPr>
-            <p:ph type="sldImg" idx="2"/>
-          </p:nvPr>
-        </p:nvSpPr>
-        <p:spPr/>
-      </p:sp>
-      <p:sp>
-        <p:nvSpPr>
-          <p:cNvPr id="3" name="Notes Placeholder 2"/>
-          <p:cNvSpPr>
-            <a:spLocks noGrp="1"/>
-          </p:cNvSpPr>
-          <p:nvPr>
-            <p:ph type="body" idx="3" sz="quarter"/>
-          </p:nvPr>
-        </p:nvSpPr>
-        <p:spPr/>
-        <p:txBody>
-          <a:bodyPr/>
-          <a:lstStyle/>
-          <a:p>
-            <a:r>
-              <a:t>6:05–6:25 · 20 min PAIR ACTIVITY (show at 6:05, after trios)</a:t>
-            </a:r>
-          </a:p>
-          <a:p/>
-          <a:p>
-            <a:r>
-              <a:t>Interview questions: Who is this for? What is it, in one sentence? What's it built with? What should the AI never do? Where do the facts live? What does done look like? Partner types; owner corrects. Then each person opens their own project, adds the file, asks their agent 'What is this project and who is it for?' and one real task, and revises what it got wrong. No project yet? Write it for the project you want to start. Then 6:25–6:55: build with it, and get it online (use the handout).</a:t>
-            </a:r>
-          </a:p>
-        </p:txBody>
-      </p:sp>
-      <p:sp>
-        <p:nvSpPr>
-          <p:cNvPr id="4" name="Slide Number Placeholder 3"/>
-          <p:cNvSpPr>
-            <a:spLocks noGrp="1"/>
-          </p:cNvSpPr>
-          <p:nvPr>
-            <p:ph type="sldNum" idx="5" sz="quarter"/>
-          </p:nvPr>
-        </p:nvSpPr>
-        <p:spPr/>
-      </p:sp>
-    </p:spTree>
-  </p:cSld>
-  <p:clrMapOvr>
-    <a:masterClrMapping/>
-  </p:clrMapOvr>
-</p:notes>
-</file>
-
-<file path=ppt/notesSlides/notesSlide19.xml><?xml version="1.0" encoding="utf-8"?>
-<p:notes xmlns:a="http://schemas.openxmlformats.org/drawingml/2006/main" xmlns:p="http://schemas.openxmlformats.org/presentationml/2006/main" xmlns:r="http://schemas.openxmlformats.org/officeDocument/2006/relationships">
-  <p:cSld>
-    <p:spTree>
-      <p:nvGrpSpPr>
-        <p:cNvPr id="1" name=""/>
-        <p:cNvGrpSpPr/>
-        <p:nvPr/>
-      </p:nvGrpSpPr>
-      <p:grpSpPr>
-        <a:xfrm>
-          <a:off x="0" y="0"/>
-          <a:ext cx="0" cy="0"/>
-          <a:chOff x="0" y="0"/>
-          <a:chExt cx="0" cy="0"/>
-        </a:xfrm>
-      </p:grpSpPr>
-      <p:sp>
-        <p:nvSpPr>
-          <p:cNvPr id="2" name="Slide Image Placeholder 1"/>
-          <p:cNvSpPr>
-            <a:spLocks noGrp="1"/>
-          </p:cNvSpPr>
-          <p:nvPr>
-            <p:ph type="sldImg" idx="2"/>
-          </p:nvPr>
-        </p:nvSpPr>
-        <p:spPr/>
-      </p:sp>
-      <p:sp>
-        <p:nvSpPr>
-          <p:cNvPr id="3" name="Notes Placeholder 2"/>
-          <p:cNvSpPr>
-            <a:spLocks noGrp="1"/>
-          </p:cNvSpPr>
-          <p:nvPr>
-            <p:ph type="body" idx="3" sz="quarter"/>
-          </p:nvPr>
-        </p:nvSpPr>
-        <p:spPr/>
-        <p:txBody>
-          <a:bodyPr/>
-          <a:lstStyle/>
-          <a:p>
-            <a:r>
-              <a:t>Reference only · 0 min</a:t>
-            </a:r>
-          </a:p>
-          <a:p/>
-          <a:p>
-            <a:r>
-              <a:t>https://agents.md/</a:t>
-            </a:r>
-          </a:p>
-          <a:p>
-            <a:r>
-              <a:t>https://www.anthropic.com/engineering/effective-context-engineering-for-ai-agents</a:t>
-            </a:r>
-          </a:p>
-          <a:p>
-            <a:r>
-              <a:t>https://docs.github.com/en/pages/getting-started-with-github-pages</a:t>
-            </a:r>
-          </a:p>
-          <a:p>
-            <a:r>
-              <a:t>https://desktop.github.com/</a:t>
-            </a:r>
-          </a:p>
-          <a:p>
-            <a:r>
-              <a:t>https://vercel.com/docs/getting-started-with-vercel</a:t>
-            </a:r>
-          </a:p>
-          <a:p>
-            <a:r>
-              <a:t>https://modelcontextprotocol.io/docs/learn/architecture</a:t>
-            </a:r>
-          </a:p>
-          <a:p>
-            <a:r>
-              <a:t>https://academy.claude.com/courses/ai-fluency-framework-foundations (Dakan, Feller, Anthropic; CC BY-NC-SA 4.0)</a:t>
+              <a:t>6:05–7:05. No prescribed pairs or interview exercise. Build, test, help each other as needed. 7:05–7:35 optional studio.</a:t>
             </a:r>
           </a:p>
         </p:txBody>
@@ -1435,13 +793,7 @@
           <a:lstStyle/>
           <a:p>
             <a:r>
-              <a:t>5:05–5:06 · 30 seconds</a:t>
-            </a:r>
-          </a:p>
-          <a:p/>
-          <a:p>
-            <a:r>
-              <a:t>The through-line, said once: choose what your AI sees, check what it produces, control what it can change. The footer on every slide says which demo we're in.</a:t>
+              <a:t>5:06–5:11. Open cu.learnvibe.build/lessons/week-6/, click Copy lesson as markdown, paste into a fresh chat. Ask exactly: Teach me this and quiz me. Answer one question. If it stalls, use the real rehearsal output on the demo script page.</a:t>
             </a:r>
           </a:p>
         </p:txBody>
@@ -1511,19 +863,7 @@
           <a:lstStyle/>
           <a:p>
             <a:r>
-              <a:t>5:06–5:07 · 1 min</a:t>
-            </a:r>
-          </a:p>
-          <a:p/>
-          <a:p>
-            <a:r>
-              <a:t>The context window is what the model sees for this answer: your message, the chat so far, files and tool results. Training knowledge is separate; app 'memory' is the app looking things up for it. Ask the room: who has had to re-explain their project to an AI three times this week?</a:t>
-            </a:r>
-          </a:p>
-          <a:p/>
-          <a:p>
-            <a:r>
-              <a:t>(Background: this is Description. A good description says what you want (product), how to approach it (process) and how to behave (performance).)</a:t>
+              <a:t>5:11–5:12. Show the raw lesson. Point to # headings and - bullets; no syntax lesson beyond that.</a:t>
             </a:r>
           </a:p>
         </p:txBody>
@@ -1593,13 +933,7 @@
           <a:lstStyle/>
           <a:p>
             <a:r>
-              <a:t>5:07–5:08 · 1 min</a:t>
-            </a:r>
-          </a:p>
-          <a:p/>
-          <a:p>
-            <a:r>
-              <a:t>A .md file is just a text file. # makes headings, - makes lists. Humans can read it raw; AIs read it really well. Every lesson on the course site is a markdown file you can copy. You've seen it already: AI chat answers are written in markdown.</a:t>
+              <a:t>5:12–5:13. These are ordinary markdown files in your project. Specific support varies by tool; Claude Code reads CLAUDE.md, and our tested installation also found AGENTS.md. No template or prescribed structure. Say what you would tell a new teammate.</a:t>
             </a:r>
           </a:p>
         </p:txBody>
@@ -1669,13 +1003,7 @@
           <a:lstStyle/>
           <a:p>
             <a:r>
-              <a:t>5:08–5:09 · 1 min</a:t>
-            </a:r>
-          </a:p>
-          <a:p/>
-          <a:p>
-            <a:r>
-              <a:t>Write it once and stop re-explaining your project. What goes in: who it's for, what it is, the stack, conventions, where facts live, and what 'done' looks like. Claude Code reads CLAUDE.md, and also reads AGENTS.md in practice (verified today); a CLAUDE.md that just says 'see AGENTS.md' covers both. Always check the tool actually read it: ask it what the project is.</a:t>
+              <a:t>5:13–5:15. Write these five lines live as CLAUDE.md. This is one example, not a template. The extra facts help the agent aim at the actual audience.</a:t>
             </a:r>
           </a:p>
         </p:txBody>
@@ -1745,13 +1073,7 @@
           <a:lstStyle/>
           <a:p>
             <a:r>
-              <a:t>5:08–5:09 · 1 min</a:t>
-            </a:r>
-          </a:p>
-          <a:p/>
-          <a:p>
-            <a:r>
-              <a:t>Six headings are enough. The most useful line is often a rule: never invent facts, only use docs/event-facts.md. Short beats long: the agent reads all of it every session, so every line should earn its place. Never put passwords or API keys in it; it's a file in your repo.</a:t>
+              <a:t>5:15–5:23. Use Hill Plant Swap. Exact prompt: Improve the homepage. Don’t edit any files: describe the changes you’d make in 6 bullets or fewer. Compare audience, unnecessary RSVP, simplicity. Start a third fresh session: Without reading any files, what is this project, and what should you never do? If delayed, use real captured results on demo script.</a:t>
             </a:r>
           </a:p>
         </p:txBody>
@@ -1821,43 +1143,7 @@
           <a:lstStyle/>
           <a:p>
             <a:r>
-              <a:t>5:09–5:17 · 8 min LIVE · exact steps and prompts on the demo script page</a:t>
-            </a:r>
-          </a:p>
-          <a:p/>
-          <a:p>
-            <a:r>
-              <a:t>Repo: github.com/unforcedagi/lvb-week6-demo (Hill Plant Swap, fictional). It has NO AGENTS.md on purpose.</a:t>
-            </a:r>
-          </a:p>
-          <a:p>
-            <a:r>
-              <a:t>1. (1 min) Open it in your agent. Prompt: 'Improve the homepage.' Expect generic: invented dates, maybe a framework, a 'garden lovers' audience.</a:t>
-            </a:r>
-          </a:p>
-          <a:p>
-            <a:r>
-              <a:t>2. (3 min) Write AGENTS.md live, asking the room for each line: who it's for, what it is, stack, conventions, facts, what done looks like.</a:t>
-            </a:r>
-          </a:p>
-          <a:p>
-            <a:r>
-              <a:t>3. (2 min) Same prompt. Narrate what you check: are the facts from docs/event-facts.md? Phone-first? No framework? (That narration is discernment; don't name it.)</a:t>
-            </a:r>
-          </a:p>
-          <a:p>
-            <a:r>
-              <a:t>4. (1 min) Quit, start a fresh session, ask 'What is this project and who is it for?' It knows: the file persists, the chat didn't.</a:t>
-            </a:r>
-          </a:p>
-          <a:p>
-            <a:r>
-              <a:t>5. (1 min) Show the 'Where to look' section: the index.</a:t>
-            </a:r>
-          </a:p>
-          <a:p>
-            <a:r>
-              <a:t>IF IT STALLS: the prepared AGENTS.md is on the demo script page. Paste it, and show the rehearsal output tab. Never show invented output.</a:t>
+              <a:t>5:23–5:24. Local files and localhost links aren’t public. Open the published link on another phone.</a:t>
             </a:r>
           </a:p>
         </p:txBody>
@@ -1927,7 +1213,7 @@
           <a:lstStyle/>
           <a:p>
             <a:r>
-              <a:t>Shown after the demo, 30 seconds. This is roughly what we just wrote live. The full template is on the Week 6 page: copy it, fill it in for your own project tonight in studio.</a:t>
+              <a:t>5:24–5:25. Explain these as three different steps.</a:t>
             </a:r>
           </a:p>
         </p:txBody>
@@ -1997,13 +1283,7 @@
           <a:lstStyle/>
           <a:p>
             <a:r>
-              <a:t>5:17 · 30 seconds (shown at the end of Demo 1)</a:t>
-            </a:r>
-          </a:p>
-          <a:p/>
-          <a:p>
-            <a:r>
-              <a:t>The demo repo starts with one doc; this is how the index grows. A short top file says what exists and links deeper. The AI reads the small map, then opens only what it needs. Indexes nest: an index can point to other indexes. The course site does exactly this: cu.learnvibe.build/llms.txt is an index of every lesson (live tonight after class).</a:t>
+              <a:t>5:25–5:31. Use plain-folder zip. Commit first version, publish public repo, Settings Pages main root. If waiting, show pre-deployed Hill Plant Swap. React/Vite/Next app: Vercel instead. Handout covers exact clicks.</a:t>
             </a:r>
           </a:p>
         </p:txBody>
@@ -5094,7 +4374,7 @@
                 </a:solidFill>
                 <a:latin typeface="Fraunces"/>
               </a:rPr>
-              <a:t>What can your AI see?</a:t>
+              <a:t>Give your AI something to work with</a:t>
             </a:r>
           </a:p>
           <a:p>
@@ -5110,7 +4390,7 @@
                 </a:solidFill>
                 <a:latin typeface="DM Sans"/>
               </a:rPr>
-              <a:t>Context that sticks, getting online, connectors</a:t>
+              <a:t>Context that sticks. A link anyone can open.</a:t>
             </a:r>
           </a:p>
           <a:p>
@@ -5165,7 +4445,7 @@
                 </a:solidFill>
                 <a:latin typeface="DM Sans"/>
               </a:rPr>
-              <a:t>Week 6 · Opening        1 / 19</a:t>
+              <a:t>Week 6 · Opening        1 / 12</a:t>
             </a:r>
           </a:p>
         </p:txBody>
@@ -5267,70 +4547,27 @@
               </a:spcAft>
             </a:pPr>
             <a:r>
-              <a:rPr sz="3200" b="1">
+              <a:rPr sz="4000" b="1">
                 <a:solidFill>
                   <a:srgbClr val="272A25"/>
                 </a:solidFill>
                 <a:latin typeface="Fraunces"/>
               </a:rPr>
-              <a:t>Your link has to work on someone else's phone</a:t>
-            </a:r>
-          </a:p>
-        </p:txBody>
-      </p:sp>
-      <p:sp>
-        <p:nvSpPr>
-          <p:cNvPr id="4" name="Rectangle 3"/>
-          <p:cNvSpPr/>
-          <p:nvPr/>
-        </p:nvSpPr>
-        <p:spPr>
-          <a:xfrm>
-            <a:off x="822960" y="1828800"/>
-            <a:ext cx="6583680" cy="4023360"/>
-          </a:xfrm>
-          <a:prstGeom prst="rect">
-            <a:avLst/>
-          </a:prstGeom>
-          <a:solidFill>
-            <a:srgbClr val="EEECE2"/>
-          </a:solidFill>
-          <a:ln>
-            <a:noFill/>
-          </a:ln>
-        </p:spPr>
-        <p:style>
-          <a:lnRef idx="1">
-            <a:schemeClr val="accent1"/>
-          </a:lnRef>
-          <a:fillRef idx="3">
-            <a:schemeClr val="accent1"/>
-          </a:fillRef>
-          <a:effectRef idx="2">
-            <a:schemeClr val="accent1"/>
-          </a:effectRef>
-          <a:fontRef idx="minor">
-            <a:schemeClr val="lt1"/>
-          </a:fontRef>
-        </p:style>
-        <p:txBody>
-          <a:bodyPr rtlCol="0" anchor="ctr"/>
-          <a:lstStyle/>
-          <a:p>
-            <a:pPr algn="ctr"/>
-          </a:p>
-        </p:txBody>
-      </p:sp>
-      <p:sp>
-        <p:nvSpPr>
-          <p:cNvPr id="5" name="TextBox 4"/>
+              <a:t>Next week: your AI reaches your tools</a:t>
+            </a:r>
+          </a:p>
+        </p:txBody>
+      </p:sp>
+      <p:sp>
+        <p:nvSpPr>
+          <p:cNvPr id="4" name="TextBox 3"/>
           <p:cNvSpPr txBox="1"/>
           <p:nvPr/>
         </p:nvSpPr>
         <p:spPr>
           <a:xfrm>
-            <a:off x="1097280" y="2011680"/>
-            <a:ext cx="6217920" cy="3749039"/>
+            <a:off x="822960" y="2011680"/>
+            <a:ext cx="10607040" cy="4206240"/>
           </a:xfrm>
           <a:prstGeom prst="rect">
             <a:avLst/>
@@ -5345,127 +4582,56 @@
           <a:p>
             <a:pPr>
               <a:spcAft>
-                <a:spcPts val="200"/>
+                <a:spcPts val="2200"/>
               </a:spcAft>
             </a:pPr>
             <a:r>
-              <a:rPr sz="1800" b="0">
+              <a:rPr sz="3000" b="0">
                 <a:solidFill>
                   <a:srgbClr val="272A25"/>
                 </a:solidFill>
-                <a:latin typeface="DejaVu Sans Mono"/>
+                <a:latin typeface="DM Sans"/>
               </a:rPr>
-              <a:t>✗  file:///Users/you/Desktop/project/index.html</a:t>
+              <a:t>•  API: one program asking another for something.</a:t>
             </a:r>
           </a:p>
           <a:p>
             <a:pPr>
               <a:spcAft>
-                <a:spcPts val="200"/>
+                <a:spcPts val="2200"/>
               </a:spcAft>
             </a:pPr>
             <a:r>
-              <a:rPr sz="1800" b="0">
+              <a:rPr sz="3000" b="0">
                 <a:solidFill>
                   <a:srgbClr val="272A25"/>
                 </a:solidFill>
-                <a:latin typeface="DejaVu Sans Mono"/>
+                <a:latin typeface="DM Sans"/>
               </a:rPr>
-              <a:t>     only works on your laptop</a:t>
+              <a:t>•  Connector: your AI reaches your tools directly.</a:t>
             </a:r>
           </a:p>
           <a:p>
             <a:pPr>
               <a:spcAft>
-                <a:spcPts val="200"/>
+                <a:spcPts val="2200"/>
               </a:spcAft>
             </a:pPr>
             <a:r>
-              <a:rPr sz="1800" b="0">
+              <a:rPr sz="3000" b="0">
                 <a:solidFill>
                   <a:srgbClr val="272A25"/>
-                </a:solidFill>
-                <a:latin typeface="DejaVu Sans Mono"/>
-              </a:rPr>
-              <a:t> </a:t>
-            </a:r>
-          </a:p>
-          <a:p>
-            <a:pPr>
-              <a:spcAft>
-                <a:spcPts val="200"/>
-              </a:spcAft>
-            </a:pPr>
-            <a:r>
-              <a:rPr sz="1800" b="0">
-                <a:solidFill>
-                  <a:srgbClr val="272A25"/>
-                </a:solidFill>
-                <a:latin typeface="DejaVu Sans Mono"/>
-              </a:rPr>
-              <a:t>✓  https://you.github.io/project/</a:t>
-            </a:r>
-          </a:p>
-          <a:p>
-            <a:pPr>
-              <a:spcAft>
-                <a:spcPts val="200"/>
-              </a:spcAft>
-            </a:pPr>
-            <a:r>
-              <a:rPr sz="1800" b="0">
-                <a:solidFill>
-                  <a:srgbClr val="272A25"/>
-                </a:solidFill>
-                <a:latin typeface="DejaVu Sans Mono"/>
-              </a:rPr>
-              <a:t>     works for anyone, anywhere</a:t>
-            </a:r>
-          </a:p>
-        </p:txBody>
-      </p:sp>
-      <p:sp>
-        <p:nvSpPr>
-          <p:cNvPr id="6" name="TextBox 5"/>
-          <p:cNvSpPr txBox="1"/>
-          <p:nvPr/>
-        </p:nvSpPr>
-        <p:spPr>
-          <a:xfrm>
-            <a:off x="7772400" y="3108960"/>
-            <a:ext cx="3931920" cy="1828800"/>
-          </a:xfrm>
-          <a:prstGeom prst="rect">
-            <a:avLst/>
-          </a:prstGeom>
-          <a:noFill/>
-        </p:spPr>
-        <p:txBody>
-          <a:bodyPr wrap="square">
-            <a:spAutoFit/>
-          </a:bodyPr>
-          <a:lstStyle/>
-          <a:p>
-            <a:pPr>
-              <a:spcAft>
-                <a:spcPts val="1400"/>
-              </a:spcAft>
-            </a:pPr>
-            <a:r>
-              <a:rPr sz="2800" b="0">
-                <a:solidFill>
-                  <a:srgbClr val="64665D"/>
                 </a:solidFill>
                 <a:latin typeface="DM Sans"/>
               </a:rPr>
-              <a:t>If it starts with file://, nobody else can see it.</a:t>
-            </a:r>
-          </a:p>
-        </p:txBody>
-      </p:sp>
-      <p:sp>
-        <p:nvSpPr>
-          <p:cNvPr id="7" name="TextBox 6"/>
+              <a:t>•  Instead of you pasting. Next week we’ll connect.</a:t>
+            </a:r>
+          </a:p>
+        </p:txBody>
+      </p:sp>
+      <p:sp>
+        <p:nvSpPr>
+          <p:cNvPr id="5" name="TextBox 4"/>
           <p:cNvSpPr txBox="1"/>
           <p:nvPr/>
         </p:nvSpPr>
@@ -5497,7 +4663,7 @@
                 </a:solidFill>
                 <a:latin typeface="DM Sans"/>
               </a:rPr>
-              <a:t>Week 6 · Demo 2 · Get it online        10 / 19</a:t>
+              <a:t>Week 6 · Looking ahead        10 / 12</a:t>
             </a:r>
           </a:p>
         </p:txBody>
@@ -5605,354 +4771,21 @@
                 </a:solidFill>
                 <a:latin typeface="Fraunces"/>
               </a:rPr>
-              <a:t>Three different things</a:t>
-            </a:r>
-          </a:p>
-        </p:txBody>
-      </p:sp>
-      <p:sp>
-        <p:nvSpPr>
-          <p:cNvPr id="4" name="Rounded Rectangle 3"/>
-          <p:cNvSpPr/>
-          <p:nvPr/>
-        </p:nvSpPr>
-        <p:spPr>
-          <a:xfrm>
-            <a:off x="822960" y="2103120"/>
-            <a:ext cx="2377440" cy="1097280"/>
-          </a:xfrm>
-          <a:prstGeom prst="roundRect">
-            <a:avLst/>
-          </a:prstGeom>
-          <a:solidFill>
-            <a:srgbClr val="A83D2B"/>
-          </a:solidFill>
-          <a:ln>
-            <a:noFill/>
-          </a:ln>
-        </p:spPr>
-        <p:style>
-          <a:lnRef idx="1">
-            <a:schemeClr val="accent1"/>
-          </a:lnRef>
-          <a:fillRef idx="3">
-            <a:schemeClr val="accent1"/>
-          </a:fillRef>
-          <a:effectRef idx="2">
-            <a:schemeClr val="accent1"/>
-          </a:effectRef>
-          <a:fontRef idx="minor">
-            <a:schemeClr val="lt1"/>
-          </a:fontRef>
-        </p:style>
-        <p:txBody>
-          <a:bodyPr rtlCol="0" anchor="ctr"/>
-          <a:lstStyle/>
-          <a:p>
-            <a:pPr algn="ctr"/>
-            <a:r>
-              <a:rPr sz="2200" b="1">
-                <a:solidFill>
-                  <a:srgbClr val="FFFFFF"/>
-                </a:solidFill>
-              </a:rPr>
-              <a:t>Folder</a:t>
-            </a:r>
-          </a:p>
-        </p:txBody>
-      </p:sp>
-      <p:sp>
-        <p:nvSpPr>
-          <p:cNvPr id="5" name="Right Arrow 4"/>
-          <p:cNvSpPr/>
-          <p:nvPr/>
-        </p:nvSpPr>
-        <p:spPr>
-          <a:xfrm>
-            <a:off x="3246120" y="2468880"/>
-            <a:ext cx="320040" cy="365760"/>
-          </a:xfrm>
-          <a:prstGeom prst="rightArrow">
-            <a:avLst/>
-          </a:prstGeom>
-          <a:solidFill>
-            <a:srgbClr val="64665D"/>
-          </a:solidFill>
-          <a:ln>
-            <a:noFill/>
-          </a:ln>
-        </p:spPr>
-        <p:style>
-          <a:lnRef idx="1">
-            <a:schemeClr val="accent1"/>
-          </a:lnRef>
-          <a:fillRef idx="3">
-            <a:schemeClr val="accent1"/>
-          </a:fillRef>
-          <a:effectRef idx="2">
-            <a:schemeClr val="accent1"/>
-          </a:effectRef>
-          <a:fontRef idx="minor">
-            <a:schemeClr val="lt1"/>
-          </a:fontRef>
-        </p:style>
-        <p:txBody>
-          <a:bodyPr rtlCol="0" anchor="ctr"/>
-          <a:lstStyle/>
-          <a:p>
-            <a:pPr algn="ctr"/>
-          </a:p>
-        </p:txBody>
-      </p:sp>
-      <p:sp>
-        <p:nvSpPr>
-          <p:cNvPr id="6" name="Rounded Rectangle 5"/>
-          <p:cNvSpPr/>
-          <p:nvPr/>
-        </p:nvSpPr>
-        <p:spPr>
-          <a:xfrm>
-            <a:off x="3611880" y="2103120"/>
-            <a:ext cx="2377440" cy="1097280"/>
-          </a:xfrm>
-          <a:prstGeom prst="roundRect">
-            <a:avLst/>
-          </a:prstGeom>
-          <a:solidFill>
-            <a:srgbClr val="272A25"/>
-          </a:solidFill>
-          <a:ln>
-            <a:noFill/>
-          </a:ln>
-        </p:spPr>
-        <p:style>
-          <a:lnRef idx="1">
-            <a:schemeClr val="accent1"/>
-          </a:lnRef>
-          <a:fillRef idx="3">
-            <a:schemeClr val="accent1"/>
-          </a:fillRef>
-          <a:effectRef idx="2">
-            <a:schemeClr val="accent1"/>
-          </a:effectRef>
-          <a:fontRef idx="minor">
-            <a:schemeClr val="lt1"/>
-          </a:fontRef>
-        </p:style>
-        <p:txBody>
-          <a:bodyPr rtlCol="0" anchor="ctr"/>
-          <a:lstStyle/>
-          <a:p>
-            <a:pPr algn="ctr"/>
-            <a:r>
-              <a:rPr sz="2200" b="1">
-                <a:solidFill>
-                  <a:srgbClr val="FFFFFF"/>
-                </a:solidFill>
-              </a:rPr>
-              <a:t>Commit</a:t>
-            </a:r>
-          </a:p>
-        </p:txBody>
-      </p:sp>
-      <p:sp>
-        <p:nvSpPr>
-          <p:cNvPr id="7" name="Right Arrow 6"/>
-          <p:cNvSpPr/>
-          <p:nvPr/>
-        </p:nvSpPr>
-        <p:spPr>
-          <a:xfrm>
-            <a:off x="6035040" y="2468880"/>
-            <a:ext cx="320040" cy="365760"/>
-          </a:xfrm>
-          <a:prstGeom prst="rightArrow">
-            <a:avLst/>
-          </a:prstGeom>
-          <a:solidFill>
-            <a:srgbClr val="64665D"/>
-          </a:solidFill>
-          <a:ln>
-            <a:noFill/>
-          </a:ln>
-        </p:spPr>
-        <p:style>
-          <a:lnRef idx="1">
-            <a:schemeClr val="accent1"/>
-          </a:lnRef>
-          <a:fillRef idx="3">
-            <a:schemeClr val="accent1"/>
-          </a:fillRef>
-          <a:effectRef idx="2">
-            <a:schemeClr val="accent1"/>
-          </a:effectRef>
-          <a:fontRef idx="minor">
-            <a:schemeClr val="lt1"/>
-          </a:fontRef>
-        </p:style>
-        <p:txBody>
-          <a:bodyPr rtlCol="0" anchor="ctr"/>
-          <a:lstStyle/>
-          <a:p>
-            <a:pPr algn="ctr"/>
-          </a:p>
-        </p:txBody>
-      </p:sp>
-      <p:sp>
-        <p:nvSpPr>
-          <p:cNvPr id="8" name="Rounded Rectangle 7"/>
-          <p:cNvSpPr/>
-          <p:nvPr/>
-        </p:nvSpPr>
-        <p:spPr>
-          <a:xfrm>
-            <a:off x="6400800" y="2103120"/>
-            <a:ext cx="2377440" cy="1097280"/>
-          </a:xfrm>
-          <a:prstGeom prst="roundRect">
-            <a:avLst/>
-          </a:prstGeom>
-          <a:solidFill>
-            <a:srgbClr val="272A25"/>
-          </a:solidFill>
-          <a:ln>
-            <a:noFill/>
-          </a:ln>
-        </p:spPr>
-        <p:style>
-          <a:lnRef idx="1">
-            <a:schemeClr val="accent1"/>
-          </a:lnRef>
-          <a:fillRef idx="3">
-            <a:schemeClr val="accent1"/>
-          </a:fillRef>
-          <a:effectRef idx="2">
-            <a:schemeClr val="accent1"/>
-          </a:effectRef>
-          <a:fontRef idx="minor">
-            <a:schemeClr val="lt1"/>
-          </a:fontRef>
-        </p:style>
-        <p:txBody>
-          <a:bodyPr rtlCol="0" anchor="ctr"/>
-          <a:lstStyle/>
-          <a:p>
-            <a:pPr algn="ctr"/>
-            <a:r>
-              <a:rPr sz="2200" b="1">
-                <a:solidFill>
-                  <a:srgbClr val="FFFFFF"/>
-                </a:solidFill>
-              </a:rPr>
-              <a:t>Push</a:t>
-            </a:r>
-          </a:p>
-        </p:txBody>
-      </p:sp>
-      <p:sp>
-        <p:nvSpPr>
-          <p:cNvPr id="9" name="Right Arrow 8"/>
-          <p:cNvSpPr/>
-          <p:nvPr/>
-        </p:nvSpPr>
-        <p:spPr>
-          <a:xfrm>
-            <a:off x="8823960" y="2468880"/>
-            <a:ext cx="320040" cy="365760"/>
-          </a:xfrm>
-          <a:prstGeom prst="rightArrow">
-            <a:avLst/>
-          </a:prstGeom>
-          <a:solidFill>
-            <a:srgbClr val="64665D"/>
-          </a:solidFill>
-          <a:ln>
-            <a:noFill/>
-          </a:ln>
-        </p:spPr>
-        <p:style>
-          <a:lnRef idx="1">
-            <a:schemeClr val="accent1"/>
-          </a:lnRef>
-          <a:fillRef idx="3">
-            <a:schemeClr val="accent1"/>
-          </a:fillRef>
-          <a:effectRef idx="2">
-            <a:schemeClr val="accent1"/>
-          </a:effectRef>
-          <a:fontRef idx="minor">
-            <a:schemeClr val="lt1"/>
-          </a:fontRef>
-        </p:style>
-        <p:txBody>
-          <a:bodyPr rtlCol="0" anchor="ctr"/>
-          <a:lstStyle/>
-          <a:p>
-            <a:pPr algn="ctr"/>
-          </a:p>
-        </p:txBody>
-      </p:sp>
-      <p:sp>
-        <p:nvSpPr>
-          <p:cNvPr id="10" name="Rounded Rectangle 9"/>
-          <p:cNvSpPr/>
-          <p:nvPr/>
-        </p:nvSpPr>
-        <p:spPr>
-          <a:xfrm>
-            <a:off x="9189720" y="2103120"/>
-            <a:ext cx="2377440" cy="1097280"/>
-          </a:xfrm>
-          <a:prstGeom prst="roundRect">
-            <a:avLst/>
-          </a:prstGeom>
-          <a:solidFill>
-            <a:srgbClr val="272A25"/>
-          </a:solidFill>
-          <a:ln>
-            <a:noFill/>
-          </a:ln>
-        </p:spPr>
-        <p:style>
-          <a:lnRef idx="1">
-            <a:schemeClr val="accent1"/>
-          </a:lnRef>
-          <a:fillRef idx="3">
-            <a:schemeClr val="accent1"/>
-          </a:fillRef>
-          <a:effectRef idx="2">
-            <a:schemeClr val="accent1"/>
-          </a:effectRef>
-          <a:fontRef idx="minor">
-            <a:schemeClr val="lt1"/>
-          </a:fontRef>
-        </p:style>
-        <p:txBody>
-          <a:bodyPr rtlCol="0" anchor="ctr"/>
-          <a:lstStyle/>
-          <a:p>
-            <a:pPr algn="ctr"/>
-            <a:r>
-              <a:rPr sz="2200" b="1">
-                <a:solidFill>
-                  <a:srgbClr val="FFFFFF"/>
-                </a:solidFill>
-              </a:rPr>
-              <a:t>Live link</a:t>
-            </a:r>
-          </a:p>
-        </p:txBody>
-      </p:sp>
-      <p:sp>
-        <p:nvSpPr>
-          <p:cNvPr id="11" name="TextBox 10"/>
+              <a:t>This week’s reading: your AI as a coach</a:t>
+            </a:r>
+          </a:p>
+        </p:txBody>
+      </p:sp>
+      <p:sp>
+        <p:nvSpPr>
+          <p:cNvPr id="4" name="TextBox 3"/>
           <p:cNvSpPr txBox="1"/>
           <p:nvPr/>
         </p:nvSpPr>
         <p:spPr>
           <a:xfrm>
-            <a:off x="822960" y="3931920"/>
-            <a:ext cx="10607040" cy="2286000"/>
+            <a:off x="822960" y="2011680"/>
+            <a:ext cx="10607040" cy="4206240"/>
           </a:xfrm>
           <a:prstGeom prst="rect">
             <a:avLst/>
@@ -5967,56 +4800,56 @@
           <a:p>
             <a:pPr>
               <a:spcAft>
-                <a:spcPts val="1800"/>
+                <a:spcPts val="2200"/>
               </a:spcAft>
             </a:pPr>
             <a:r>
-              <a:rPr sz="2800" b="0">
+              <a:rPr sz="3000" b="0">
                 <a:solidFill>
                   <a:srgbClr val="272A25"/>
                 </a:solidFill>
                 <a:latin typeface="DM Sans"/>
               </a:rPr>
-              <a:t>•  Git: save points for your project, on your laptop</a:t>
+              <a:t>•  Arielle Shipper · How to Get Better at AI by Asking AI</a:t>
             </a:r>
           </a:p>
           <a:p>
             <a:pPr>
               <a:spcAft>
-                <a:spcPts val="1800"/>
+                <a:spcPts val="2200"/>
               </a:spcAft>
             </a:pPr>
             <a:r>
-              <a:rPr sz="2800" b="0">
+              <a:rPr sz="3000" b="0">
                 <a:solidFill>
                   <a:srgbClr val="272A25"/>
                 </a:solidFill>
                 <a:latin typeface="DM Sans"/>
               </a:rPr>
-              <a:t>•  GitHub: a copy of those save points, online</a:t>
+              <a:t>•  Give your AI examples of how you’ve worked.</a:t>
             </a:r>
           </a:p>
           <a:p>
             <a:pPr>
               <a:spcAft>
-                <a:spcPts val="1800"/>
+                <a:spcPts val="2200"/>
               </a:spcAft>
             </a:pPr>
             <a:r>
-              <a:rPr sz="2800" b="0">
+              <a:rPr sz="3000" b="0">
                 <a:solidFill>
                   <a:srgbClr val="272A25"/>
                 </a:solidFill>
                 <a:latin typeface="DM Sans"/>
               </a:rPr>
-              <a:t>•  Pages / Vercel: turns that copy into a website</a:t>
-            </a:r>
-          </a:p>
-        </p:txBody>
-      </p:sp>
-      <p:sp>
-        <p:nvSpPr>
-          <p:cNvPr id="12" name="TextBox 11"/>
+              <a:t>•  Ask it to teach you one next step.</a:t>
+            </a:r>
+          </a:p>
+        </p:txBody>
+      </p:sp>
+      <p:sp>
+        <p:nvSpPr>
+          <p:cNvPr id="5" name="TextBox 4"/>
           <p:cNvSpPr txBox="1"/>
           <p:nvPr/>
         </p:nvSpPr>
@@ -6048,7 +4881,7 @@
                 </a:solidFill>
                 <a:latin typeface="DM Sans"/>
               </a:rPr>
-              <a:t>Week 6 · Demo 2 · Get it online        11 / 19</a:t>
+              <a:t>Week 6 · Close        11 / 12</a:t>
             </a:r>
           </a:p>
         </p:txBody>
@@ -6156,64 +4989,21 @@
                 </a:solidFill>
                 <a:latin typeface="Fraunces"/>
               </a:rPr>
-              <a:t>Live demo · from folder to link</a:t>
-            </a:r>
-          </a:p>
-        </p:txBody>
-      </p:sp>
-      <p:sp>
-        <p:nvSpPr>
-          <p:cNvPr id="4" name="Rectangle 3"/>
-          <p:cNvSpPr/>
-          <p:nvPr/>
-        </p:nvSpPr>
-        <p:spPr>
-          <a:xfrm>
-            <a:off x="822960" y="1828800"/>
-            <a:ext cx="6583680" cy="4023360"/>
-          </a:xfrm>
-          <a:prstGeom prst="rect">
-            <a:avLst/>
-          </a:prstGeom>
-          <a:solidFill>
-            <a:srgbClr val="EEECE2"/>
-          </a:solidFill>
-          <a:ln>
-            <a:noFill/>
-          </a:ln>
-        </p:spPr>
-        <p:style>
-          <a:lnRef idx="1">
-            <a:schemeClr val="accent1"/>
-          </a:lnRef>
-          <a:fillRef idx="3">
-            <a:schemeClr val="accent1"/>
-          </a:fillRef>
-          <a:effectRef idx="2">
-            <a:schemeClr val="accent1"/>
-          </a:effectRef>
-          <a:fontRef idx="minor">
-            <a:schemeClr val="lt1"/>
-          </a:fontRef>
-        </p:style>
-        <p:txBody>
-          <a:bodyPr rtlCol="0" anchor="ctr"/>
-          <a:lstStyle/>
-          <a:p>
-            <a:pPr algn="ctr"/>
-          </a:p>
-        </p:txBody>
-      </p:sp>
-      <p:sp>
-        <p:nvSpPr>
-          <p:cNvPr id="5" name="TextBox 4"/>
+              <a:t>Studio: build</a:t>
+            </a:r>
+          </a:p>
+        </p:txBody>
+      </p:sp>
+      <p:sp>
+        <p:nvSpPr>
+          <p:cNvPr id="4" name="TextBox 3"/>
           <p:cNvSpPr txBox="1"/>
           <p:nvPr/>
         </p:nvSpPr>
         <p:spPr>
           <a:xfrm>
-            <a:off x="1097280" y="2011680"/>
-            <a:ext cx="6217920" cy="3749039"/>
+            <a:off x="822960" y="2011680"/>
+            <a:ext cx="10607040" cy="4206240"/>
           </a:xfrm>
           <a:prstGeom prst="rect">
             <a:avLst/>
@@ -6228,127 +5018,56 @@
           <a:p>
             <a:pPr>
               <a:spcAft>
-                <a:spcPts val="200"/>
+                <a:spcPts val="2200"/>
               </a:spcAft>
             </a:pPr>
             <a:r>
-              <a:rPr sz="1800" b="0">
+              <a:rPr sz="3000" b="0">
                 <a:solidFill>
                   <a:srgbClr val="272A25"/>
                 </a:solidFill>
-                <a:latin typeface="DejaVu Sans Mono"/>
+                <a:latin typeface="DM Sans"/>
               </a:rPr>
-              <a:t>1 · Download the project folder</a:t>
+              <a:t>•  Work on your project.</a:t>
             </a:r>
           </a:p>
           <a:p>
             <a:pPr>
               <a:spcAft>
-                <a:spcPts val="200"/>
+                <a:spcPts val="2200"/>
               </a:spcAft>
             </a:pPr>
             <a:r>
-              <a:rPr sz="1800" b="0">
+              <a:rPr sz="3000" b="0">
                 <a:solidFill>
                   <a:srgbClr val="272A25"/>
                 </a:solidFill>
-                <a:latin typeface="DejaVu Sans Mono"/>
+                <a:latin typeface="DM Sans"/>
               </a:rPr>
-              <a:t>2 · GitHub Desktop: create repo, commit, publish</a:t>
+              <a:t>•  Optional: ask your AI what it needs to know.</a:t>
             </a:r>
           </a:p>
           <a:p>
             <a:pPr>
               <a:spcAft>
-                <a:spcPts val="200"/>
+                <a:spcPts val="2200"/>
               </a:spcAft>
             </a:pPr>
             <a:r>
-              <a:rPr sz="1800" b="0">
+              <a:rPr sz="3000" b="0">
                 <a:solidFill>
                   <a:srgbClr val="272A25"/>
-                </a:solidFill>
-                <a:latin typeface="DejaVu Sans Mono"/>
-              </a:rPr>
-              <a:t>3 · Settings → Pages → main → Save</a:t>
-            </a:r>
-          </a:p>
-          <a:p>
-            <a:pPr>
-              <a:spcAft>
-                <a:spcPts val="200"/>
-              </a:spcAft>
-            </a:pPr>
-            <a:r>
-              <a:rPr sz="1800" b="0">
-                <a:solidFill>
-                  <a:srgbClr val="272A25"/>
-                </a:solidFill>
-                <a:latin typeface="DejaVu Sans Mono"/>
-              </a:rPr>
-              <a:t>4 · Open the link on a phone</a:t>
-            </a:r>
-          </a:p>
-          <a:p>
-            <a:pPr>
-              <a:spcAft>
-                <a:spcPts val="200"/>
-              </a:spcAft>
-            </a:pPr>
-            <a:r>
-              <a:rPr sz="1800" b="0">
-                <a:solidFill>
-                  <a:srgbClr val="272A25"/>
-                </a:solidFill>
-                <a:latin typeface="DejaVu Sans Mono"/>
-              </a:rPr>
-              <a:t>5 · Change something, commit, push, refresh</a:t>
-            </a:r>
-          </a:p>
-        </p:txBody>
-      </p:sp>
-      <p:sp>
-        <p:nvSpPr>
-          <p:cNvPr id="6" name="TextBox 5"/>
-          <p:cNvSpPr txBox="1"/>
-          <p:nvPr/>
-        </p:nvSpPr>
-        <p:spPr>
-          <a:xfrm>
-            <a:off x="7772400" y="3108960"/>
-            <a:ext cx="3931920" cy="1828800"/>
-          </a:xfrm>
-          <a:prstGeom prst="rect">
-            <a:avLst/>
-          </a:prstGeom>
-          <a:noFill/>
-        </p:spPr>
-        <p:txBody>
-          <a:bodyPr wrap="square">
-            <a:spAutoFit/>
-          </a:bodyPr>
-          <a:lstStyle/>
-          <a:p>
-            <a:pPr>
-              <a:spcAft>
-                <a:spcPts val="1400"/>
-              </a:spcAft>
-            </a:pPr>
-            <a:r>
-              <a:rPr sz="2800" b="0">
-                <a:solidFill>
-                  <a:srgbClr val="64665D"/>
                 </a:solidFill>
                 <a:latin typeface="DM Sans"/>
               </a:rPr>
-              <a:t>Handout: “Get your project online”, step by step.</a:t>
-            </a:r>
-          </a:p>
-        </p:txBody>
-      </p:sp>
-      <p:sp>
-        <p:nvSpPr>
-          <p:cNvPr id="7" name="TextBox 6"/>
+              <a:t>•  Save that context as a markdown file.</a:t>
+            </a:r>
+          </a:p>
+        </p:txBody>
+      </p:sp>
+      <p:sp>
+        <p:nvSpPr>
+          <p:cNvPr id="5" name="TextBox 4"/>
           <p:cNvSpPr txBox="1"/>
           <p:nvPr/>
         </p:nvSpPr>
@@ -6380,1613 +5099,7 @@
                 </a:solidFill>
                 <a:latin typeface="DM Sans"/>
               </a:rPr>
-              <a:t>Week 6 · Demo 2 · Get it online        12 / 19</a:t>
-            </a:r>
-          </a:p>
-        </p:txBody>
-      </p:sp>
-    </p:spTree>
-  </p:cSld>
-  <p:clrMapOvr>
-    <a:masterClrMapping/>
-  </p:clrMapOvr>
-</p:sld>
-</file>
-
-<file path=ppt/slides/slide13.xml><?xml version="1.0" encoding="utf-8"?>
-<p:sld xmlns:a="http://schemas.openxmlformats.org/drawingml/2006/main" xmlns:p="http://schemas.openxmlformats.org/presentationml/2006/main" xmlns:r="http://schemas.openxmlformats.org/officeDocument/2006/relationships">
-  <p:cSld>
-    <p:bg>
-      <p:bgPr>
-        <a:solidFill>
-          <a:srgbClr val="F7F5EE"/>
-        </a:solidFill>
-        <a:effectLst/>
-      </p:bgPr>
-    </p:bg>
-    <p:spTree>
-      <p:nvGrpSpPr>
-        <p:cNvPr id="1" name=""/>
-        <p:cNvGrpSpPr/>
-        <p:nvPr/>
-      </p:nvGrpSpPr>
-      <p:grpSpPr/>
-      <p:sp>
-        <p:nvSpPr>
-          <p:cNvPr id="2" name="Rectangle 1"/>
-          <p:cNvSpPr/>
-          <p:nvPr/>
-        </p:nvSpPr>
-        <p:spPr>
-          <a:xfrm>
-            <a:off x="0" y="0"/>
-            <a:ext cx="228600" cy="6858000"/>
-          </a:xfrm>
-          <a:prstGeom prst="rect">
-            <a:avLst/>
-          </a:prstGeom>
-          <a:solidFill>
-            <a:srgbClr val="A83D2B"/>
-          </a:solidFill>
-          <a:ln>
-            <a:noFill/>
-          </a:ln>
-        </p:spPr>
-        <p:style>
-          <a:lnRef idx="1">
-            <a:schemeClr val="accent1"/>
-          </a:lnRef>
-          <a:fillRef idx="3">
-            <a:schemeClr val="accent1"/>
-          </a:fillRef>
-          <a:effectRef idx="2">
-            <a:schemeClr val="accent1"/>
-          </a:effectRef>
-          <a:fontRef idx="minor">
-            <a:schemeClr val="lt1"/>
-          </a:fontRef>
-        </p:style>
-        <p:txBody>
-          <a:bodyPr rtlCol="0" anchor="ctr"/>
-          <a:lstStyle/>
-          <a:p>
-            <a:pPr algn="ctr"/>
-          </a:p>
-        </p:txBody>
-      </p:sp>
-      <p:sp>
-        <p:nvSpPr>
-          <p:cNvPr id="3" name="TextBox 2"/>
-          <p:cNvSpPr txBox="1"/>
-          <p:nvPr/>
-        </p:nvSpPr>
-        <p:spPr>
-          <a:xfrm>
-            <a:off x="822960" y="548640"/>
-            <a:ext cx="10607040" cy="1188720"/>
-          </a:xfrm>
-          <a:prstGeom prst="rect">
-            <a:avLst/>
-          </a:prstGeom>
-          <a:noFill/>
-        </p:spPr>
-        <p:txBody>
-          <a:bodyPr wrap="square">
-            <a:spAutoFit/>
-          </a:bodyPr>
-          <a:lstStyle/>
-          <a:p>
-            <a:pPr>
-              <a:spcAft>
-                <a:spcPts val="1400"/>
-              </a:spcAft>
-            </a:pPr>
-            <a:r>
-              <a:rPr sz="4000" b="1">
-                <a:solidFill>
-                  <a:srgbClr val="272A25"/>
-                </a:solidFill>
-                <a:latin typeface="Fraunces"/>
-              </a:rPr>
-              <a:t>When the link doesn't work</a:t>
-            </a:r>
-          </a:p>
-        </p:txBody>
-      </p:sp>
-      <p:sp>
-        <p:nvSpPr>
-          <p:cNvPr id="4" name="TextBox 3"/>
-          <p:cNvSpPr txBox="1"/>
-          <p:nvPr/>
-        </p:nvSpPr>
-        <p:spPr>
-          <a:xfrm>
-            <a:off x="822960" y="2011680"/>
-            <a:ext cx="10607040" cy="4206240"/>
-          </a:xfrm>
-          <a:prstGeom prst="rect">
-            <a:avLst/>
-          </a:prstGeom>
-          <a:noFill/>
-        </p:spPr>
-        <p:txBody>
-          <a:bodyPr wrap="square">
-            <a:spAutoFit/>
-          </a:bodyPr>
-          <a:lstStyle/>
-          <a:p>
-            <a:pPr>
-              <a:spcAft>
-                <a:spcPts val="1600"/>
-              </a:spcAft>
-            </a:pPr>
-            <a:r>
-              <a:rPr sz="2600" b="0">
-                <a:solidFill>
-                  <a:srgbClr val="272A25"/>
-                </a:solidFill>
-                <a:latin typeface="DM Sans"/>
-              </a:rPr>
-              <a:t>•  404: wait 1–2 min, then check Settings → Pages</a:t>
-            </a:r>
-          </a:p>
-          <a:p>
-            <a:pPr>
-              <a:spcAft>
-                <a:spcPts val="1600"/>
-              </a:spcAft>
-            </a:pPr>
-            <a:r>
-              <a:rPr sz="2600" b="0">
-                <a:solidFill>
-                  <a:srgbClr val="272A25"/>
-                </a:solidFill>
-                <a:latin typeface="DM Sans"/>
-              </a:rPr>
-              <a:t>•  Page with no styles: paths start with / (use style.css)</a:t>
-            </a:r>
-          </a:p>
-          <a:p>
-            <a:pPr>
-              <a:spcAft>
-                <a:spcPts val="1600"/>
-              </a:spcAft>
-            </a:pPr>
-            <a:r>
-              <a:rPr sz="2600" b="0">
-                <a:solidFill>
-                  <a:srgbClr val="272A25"/>
-                </a:solidFill>
-                <a:latin typeface="DM Sans"/>
-              </a:rPr>
-              <a:t>•  Only the README shows: index.html must be in the top folder</a:t>
-            </a:r>
-          </a:p>
-          <a:p>
-            <a:pPr>
-              <a:spcAft>
-                <a:spcPts val="1600"/>
-              </a:spcAft>
-            </a:pPr>
-            <a:r>
-              <a:rPr sz="2600" b="0">
-                <a:solidFill>
-                  <a:srgbClr val="272A25"/>
-                </a:solidFill>
-                <a:latin typeface="DM Sans"/>
-              </a:rPr>
-              <a:t>•  Old version: hard refresh, or wait a minute</a:t>
-            </a:r>
-          </a:p>
-          <a:p>
-            <a:pPr>
-              <a:spcAft>
-                <a:spcPts val="1600"/>
-              </a:spcAft>
-            </a:pPr>
-            <a:r>
-              <a:rPr sz="2600" b="0">
-                <a:solidFill>
-                  <a:srgbClr val="272A25"/>
-                </a:solidFill>
-                <a:latin typeface="DM Sans"/>
-              </a:rPr>
-              <a:t>•  Private repo on a free plan: make it public, or use Vercel</a:t>
-            </a:r>
-          </a:p>
-        </p:txBody>
-      </p:sp>
-      <p:sp>
-        <p:nvSpPr>
-          <p:cNvPr id="5" name="TextBox 4"/>
-          <p:cNvSpPr txBox="1"/>
-          <p:nvPr/>
-        </p:nvSpPr>
-        <p:spPr>
-          <a:xfrm>
-            <a:off x="822960" y="6263640"/>
-            <a:ext cx="10607040" cy="365760"/>
-          </a:xfrm>
-          <a:prstGeom prst="rect">
-            <a:avLst/>
-          </a:prstGeom>
-          <a:noFill/>
-        </p:spPr>
-        <p:txBody>
-          <a:bodyPr wrap="square">
-            <a:spAutoFit/>
-          </a:bodyPr>
-          <a:lstStyle/>
-          <a:p>
-            <a:pPr algn="r">
-              <a:spcAft>
-                <a:spcPts val="1400"/>
-              </a:spcAft>
-            </a:pPr>
-            <a:r>
-              <a:rPr sz="1600" b="0">
-                <a:solidFill>
-                  <a:srgbClr val="64665D"/>
-                </a:solidFill>
-                <a:latin typeface="DM Sans"/>
-              </a:rPr>
-              <a:t>Week 6 · Demo 2 · Get it online        13 / 19</a:t>
-            </a:r>
-          </a:p>
-        </p:txBody>
-      </p:sp>
-    </p:spTree>
-  </p:cSld>
-  <p:clrMapOvr>
-    <a:masterClrMapping/>
-  </p:clrMapOvr>
-</p:sld>
-</file>
-
-<file path=ppt/slides/slide14.xml><?xml version="1.0" encoding="utf-8"?>
-<p:sld xmlns:a="http://schemas.openxmlformats.org/drawingml/2006/main" xmlns:p="http://schemas.openxmlformats.org/presentationml/2006/main" xmlns:r="http://schemas.openxmlformats.org/officeDocument/2006/relationships">
-  <p:cSld>
-    <p:bg>
-      <p:bgPr>
-        <a:solidFill>
-          <a:srgbClr val="F7F5EE"/>
-        </a:solidFill>
-        <a:effectLst/>
-      </p:bgPr>
-    </p:bg>
-    <p:spTree>
-      <p:nvGrpSpPr>
-        <p:cNvPr id="1" name=""/>
-        <p:cNvGrpSpPr/>
-        <p:nvPr/>
-      </p:nvGrpSpPr>
-      <p:grpSpPr/>
-      <p:sp>
-        <p:nvSpPr>
-          <p:cNvPr id="2" name="Rectangle 1"/>
-          <p:cNvSpPr/>
-          <p:nvPr/>
-        </p:nvSpPr>
-        <p:spPr>
-          <a:xfrm>
-            <a:off x="0" y="0"/>
-            <a:ext cx="228600" cy="6858000"/>
-          </a:xfrm>
-          <a:prstGeom prst="rect">
-            <a:avLst/>
-          </a:prstGeom>
-          <a:solidFill>
-            <a:srgbClr val="A83D2B"/>
-          </a:solidFill>
-          <a:ln>
-            <a:noFill/>
-          </a:ln>
-        </p:spPr>
-        <p:style>
-          <a:lnRef idx="1">
-            <a:schemeClr val="accent1"/>
-          </a:lnRef>
-          <a:fillRef idx="3">
-            <a:schemeClr val="accent1"/>
-          </a:fillRef>
-          <a:effectRef idx="2">
-            <a:schemeClr val="accent1"/>
-          </a:effectRef>
-          <a:fontRef idx="minor">
-            <a:schemeClr val="lt1"/>
-          </a:fontRef>
-        </p:style>
-        <p:txBody>
-          <a:bodyPr rtlCol="0" anchor="ctr"/>
-          <a:lstStyle/>
-          <a:p>
-            <a:pPr algn="ctr"/>
-          </a:p>
-        </p:txBody>
-      </p:sp>
-      <p:sp>
-        <p:nvSpPr>
-          <p:cNvPr id="3" name="TextBox 2"/>
-          <p:cNvSpPr txBox="1"/>
-          <p:nvPr/>
-        </p:nvSpPr>
-        <p:spPr>
-          <a:xfrm>
-            <a:off x="822960" y="548640"/>
-            <a:ext cx="10607040" cy="1188720"/>
-          </a:xfrm>
-          <a:prstGeom prst="rect">
-            <a:avLst/>
-          </a:prstGeom>
-          <a:noFill/>
-        </p:spPr>
-        <p:txBody>
-          <a:bodyPr wrap="square">
-            <a:spAutoFit/>
-          </a:bodyPr>
-          <a:lstStyle/>
-          <a:p>
-            <a:pPr>
-              <a:spcAft>
-                <a:spcPts val="1400"/>
-              </a:spcAft>
-            </a:pPr>
-            <a:r>
-              <a:rPr sz="4000" b="1">
-                <a:solidFill>
-                  <a:srgbClr val="272A25"/>
-                </a:solidFill>
-                <a:latin typeface="Fraunces"/>
-              </a:rPr>
-              <a:t>API vs. MCP</a:t>
-            </a:r>
-          </a:p>
-        </p:txBody>
-      </p:sp>
-      <p:sp>
-        <p:nvSpPr>
-          <p:cNvPr id="4" name="TextBox 3"/>
-          <p:cNvSpPr txBox="1"/>
-          <p:nvPr/>
-        </p:nvSpPr>
-        <p:spPr>
-          <a:xfrm>
-            <a:off x="822960" y="2011680"/>
-            <a:ext cx="10607040" cy="4206240"/>
-          </a:xfrm>
-          <a:prstGeom prst="rect">
-            <a:avLst/>
-          </a:prstGeom>
-          <a:noFill/>
-        </p:spPr>
-        <p:txBody>
-          <a:bodyPr wrap="square">
-            <a:spAutoFit/>
-          </a:bodyPr>
-          <a:lstStyle/>
-          <a:p>
-            <a:pPr>
-              <a:spcAft>
-                <a:spcPts val="2200"/>
-              </a:spcAft>
-            </a:pPr>
-            <a:r>
-              <a:rPr sz="3000" b="0">
-                <a:solidFill>
-                  <a:srgbClr val="272A25"/>
-                </a:solidFill>
-                <a:latin typeface="DM Sans"/>
-              </a:rPr>
-              <a:t>•  API: one service's own menu of requests</a:t>
-            </a:r>
-          </a:p>
-          <a:p>
-            <a:pPr>
-              <a:spcAft>
-                <a:spcPts val="2200"/>
-              </a:spcAft>
-            </a:pPr>
-            <a:r>
-              <a:rPr sz="3000" b="0">
-                <a:solidFill>
-                  <a:srgbClr val="272A25"/>
-                </a:solidFill>
-                <a:latin typeface="DM Sans"/>
-              </a:rPr>
-              <a:t>•  MCP: one standard plug for AI apps to use many tools</a:t>
-            </a:r>
-          </a:p>
-          <a:p>
-            <a:pPr>
-              <a:spcAft>
-                <a:spcPts val="2200"/>
-              </a:spcAft>
-            </a:pPr>
-            <a:r>
-              <a:rPr sz="3000" b="0">
-                <a:solidFill>
-                  <a:srgbClr val="272A25"/>
-                </a:solidFill>
-                <a:latin typeface="DM Sans"/>
-              </a:rPr>
-              <a:t>•  MCP servers often call APIs underneath</a:t>
-            </a:r>
-          </a:p>
-        </p:txBody>
-      </p:sp>
-      <p:sp>
-        <p:nvSpPr>
-          <p:cNvPr id="5" name="TextBox 4"/>
-          <p:cNvSpPr txBox="1"/>
-          <p:nvPr/>
-        </p:nvSpPr>
-        <p:spPr>
-          <a:xfrm>
-            <a:off x="822960" y="6263640"/>
-            <a:ext cx="10607040" cy="365760"/>
-          </a:xfrm>
-          <a:prstGeom prst="rect">
-            <a:avLst/>
-          </a:prstGeom>
-          <a:noFill/>
-        </p:spPr>
-        <p:txBody>
-          <a:bodyPr wrap="square">
-            <a:spAutoFit/>
-          </a:bodyPr>
-          <a:lstStyle/>
-          <a:p>
-            <a:pPr algn="r">
-              <a:spcAft>
-                <a:spcPts val="1400"/>
-              </a:spcAft>
-            </a:pPr>
-            <a:r>
-              <a:rPr sz="1600" b="0">
-                <a:solidFill>
-                  <a:srgbClr val="64665D"/>
-                </a:solidFill>
-                <a:latin typeface="DM Sans"/>
-              </a:rPr>
-              <a:t>Week 6 · Demo 3 · Connectors        14 / 19</a:t>
-            </a:r>
-          </a:p>
-        </p:txBody>
-      </p:sp>
-    </p:spTree>
-  </p:cSld>
-  <p:clrMapOvr>
-    <a:masterClrMapping/>
-  </p:clrMapOvr>
-</p:sld>
-</file>
-
-<file path=ppt/slides/slide15.xml><?xml version="1.0" encoding="utf-8"?>
-<p:sld xmlns:a="http://schemas.openxmlformats.org/drawingml/2006/main" xmlns:p="http://schemas.openxmlformats.org/presentationml/2006/main" xmlns:r="http://schemas.openxmlformats.org/officeDocument/2006/relationships">
-  <p:cSld>
-    <p:bg>
-      <p:bgPr>
-        <a:solidFill>
-          <a:srgbClr val="F7F5EE"/>
-        </a:solidFill>
-        <a:effectLst/>
-      </p:bgPr>
-    </p:bg>
-    <p:spTree>
-      <p:nvGrpSpPr>
-        <p:cNvPr id="1" name=""/>
-        <p:cNvGrpSpPr/>
-        <p:nvPr/>
-      </p:nvGrpSpPr>
-      <p:grpSpPr/>
-      <p:sp>
-        <p:nvSpPr>
-          <p:cNvPr id="2" name="Rectangle 1"/>
-          <p:cNvSpPr/>
-          <p:nvPr/>
-        </p:nvSpPr>
-        <p:spPr>
-          <a:xfrm>
-            <a:off x="0" y="0"/>
-            <a:ext cx="228600" cy="6858000"/>
-          </a:xfrm>
-          <a:prstGeom prst="rect">
-            <a:avLst/>
-          </a:prstGeom>
-          <a:solidFill>
-            <a:srgbClr val="A83D2B"/>
-          </a:solidFill>
-          <a:ln>
-            <a:noFill/>
-          </a:ln>
-        </p:spPr>
-        <p:style>
-          <a:lnRef idx="1">
-            <a:schemeClr val="accent1"/>
-          </a:lnRef>
-          <a:fillRef idx="3">
-            <a:schemeClr val="accent1"/>
-          </a:fillRef>
-          <a:effectRef idx="2">
-            <a:schemeClr val="accent1"/>
-          </a:effectRef>
-          <a:fontRef idx="minor">
-            <a:schemeClr val="lt1"/>
-          </a:fontRef>
-        </p:style>
-        <p:txBody>
-          <a:bodyPr rtlCol="0" anchor="ctr"/>
-          <a:lstStyle/>
-          <a:p>
-            <a:pPr algn="ctr"/>
-          </a:p>
-        </p:txBody>
-      </p:sp>
-      <p:sp>
-        <p:nvSpPr>
-          <p:cNvPr id="3" name="TextBox 2"/>
-          <p:cNvSpPr txBox="1"/>
-          <p:nvPr/>
-        </p:nvSpPr>
-        <p:spPr>
-          <a:xfrm>
-            <a:off x="822960" y="548640"/>
-            <a:ext cx="10607040" cy="1188720"/>
-          </a:xfrm>
-          <a:prstGeom prst="rect">
-            <a:avLst/>
-          </a:prstGeom>
-          <a:noFill/>
-        </p:spPr>
-        <p:txBody>
-          <a:bodyPr wrap="square">
-            <a:spAutoFit/>
-          </a:bodyPr>
-          <a:lstStyle/>
-          <a:p>
-            <a:pPr>
-              <a:spcAft>
-                <a:spcPts val="1400"/>
-              </a:spcAft>
-            </a:pPr>
-            <a:r>
-              <a:rPr sz="3200" b="1">
-                <a:solidFill>
-                  <a:srgbClr val="272A25"/>
-                </a:solidFill>
-                <a:latin typeface="Fraunces"/>
-              </a:rPr>
-              <a:t>Live demo · connect your AI to this course</a:t>
-            </a:r>
-          </a:p>
-        </p:txBody>
-      </p:sp>
-      <p:sp>
-        <p:nvSpPr>
-          <p:cNvPr id="4" name="TextBox 3"/>
-          <p:cNvSpPr txBox="1"/>
-          <p:nvPr/>
-        </p:nvSpPr>
-        <p:spPr>
-          <a:xfrm>
-            <a:off x="822960" y="2011680"/>
-            <a:ext cx="10607040" cy="4206240"/>
-          </a:xfrm>
-          <a:prstGeom prst="rect">
-            <a:avLst/>
-          </a:prstGeom>
-          <a:noFill/>
-        </p:spPr>
-        <p:txBody>
-          <a:bodyPr wrap="square">
-            <a:spAutoFit/>
-          </a:bodyPr>
-          <a:lstStyle/>
-          <a:p>
-            <a:pPr>
-              <a:spcAft>
-                <a:spcPts val="2200"/>
-              </a:spcAft>
-            </a:pPr>
-            <a:r>
-              <a:rPr sz="3000" b="0">
-                <a:solidFill>
-                  <a:srgbClr val="272A25"/>
-                </a:solidFill>
-                <a:latin typeface="DM Sans"/>
-              </a:rPr>
-              <a:t>•  https://api.learnvibe.build/mcp</a:t>
-            </a:r>
-          </a:p>
-          <a:p>
-            <a:pPr>
-              <a:spcAft>
-                <a:spcPts val="2200"/>
-              </a:spcAft>
-            </a:pPr>
-            <a:r>
-              <a:rPr sz="3000" b="0">
-                <a:solidFill>
-                  <a:srgbClr val="272A25"/>
-                </a:solidFill>
-                <a:latin typeface="DM Sans"/>
-              </a:rPr>
-              <a:t>•  Add it as a custom connector (or `claude mcp add`)</a:t>
-            </a:r>
-          </a:p>
-          <a:p>
-            <a:pPr>
-              <a:spcAft>
-                <a:spcPts val="2200"/>
-              </a:spcAft>
-            </a:pPr>
-            <a:r>
-              <a:rPr sz="3000" b="0">
-                <a:solidFill>
-                  <a:srgbClr val="272A25"/>
-                </a:solidFill>
-                <a:latin typeface="DM Sans"/>
-              </a:rPr>
-              <a:t>•  Ask: “Using the course connector, teach me tonight's lesson on AGENTS.md, then quiz me.”</a:t>
-            </a:r>
-          </a:p>
-        </p:txBody>
-      </p:sp>
-      <p:sp>
-        <p:nvSpPr>
-          <p:cNvPr id="5" name="TextBox 4"/>
-          <p:cNvSpPr txBox="1"/>
-          <p:nvPr/>
-        </p:nvSpPr>
-        <p:spPr>
-          <a:xfrm>
-            <a:off x="822960" y="6263640"/>
-            <a:ext cx="10607040" cy="365760"/>
-          </a:xfrm>
-          <a:prstGeom prst="rect">
-            <a:avLst/>
-          </a:prstGeom>
-          <a:noFill/>
-        </p:spPr>
-        <p:txBody>
-          <a:bodyPr wrap="square">
-            <a:spAutoFit/>
-          </a:bodyPr>
-          <a:lstStyle/>
-          <a:p>
-            <a:pPr algn="r">
-              <a:spcAft>
-                <a:spcPts val="1400"/>
-              </a:spcAft>
-            </a:pPr>
-            <a:r>
-              <a:rPr sz="1600" b="0">
-                <a:solidFill>
-                  <a:srgbClr val="64665D"/>
-                </a:solidFill>
-                <a:latin typeface="DM Sans"/>
-              </a:rPr>
-              <a:t>Week 6 · Demo 3 · Connectors        15 / 19</a:t>
-            </a:r>
-          </a:p>
-        </p:txBody>
-      </p:sp>
-    </p:spTree>
-  </p:cSld>
-  <p:clrMapOvr>
-    <a:masterClrMapping/>
-  </p:clrMapOvr>
-</p:sld>
-</file>
-
-<file path=ppt/slides/slide16.xml><?xml version="1.0" encoding="utf-8"?>
-<p:sld xmlns:a="http://schemas.openxmlformats.org/drawingml/2006/main" xmlns:p="http://schemas.openxmlformats.org/presentationml/2006/main" xmlns:r="http://schemas.openxmlformats.org/officeDocument/2006/relationships">
-  <p:cSld>
-    <p:bg>
-      <p:bgPr>
-        <a:solidFill>
-          <a:srgbClr val="F7F5EE"/>
-        </a:solidFill>
-        <a:effectLst/>
-      </p:bgPr>
-    </p:bg>
-    <p:spTree>
-      <p:nvGrpSpPr>
-        <p:cNvPr id="1" name=""/>
-        <p:cNvGrpSpPr/>
-        <p:nvPr/>
-      </p:nvGrpSpPr>
-      <p:grpSpPr/>
-      <p:sp>
-        <p:nvSpPr>
-          <p:cNvPr id="2" name="Rectangle 1"/>
-          <p:cNvSpPr/>
-          <p:nvPr/>
-        </p:nvSpPr>
-        <p:spPr>
-          <a:xfrm>
-            <a:off x="0" y="0"/>
-            <a:ext cx="228600" cy="6858000"/>
-          </a:xfrm>
-          <a:prstGeom prst="rect">
-            <a:avLst/>
-          </a:prstGeom>
-          <a:solidFill>
-            <a:srgbClr val="A83D2B"/>
-          </a:solidFill>
-          <a:ln>
-            <a:noFill/>
-          </a:ln>
-        </p:spPr>
-        <p:style>
-          <a:lnRef idx="1">
-            <a:schemeClr val="accent1"/>
-          </a:lnRef>
-          <a:fillRef idx="3">
-            <a:schemeClr val="accent1"/>
-          </a:fillRef>
-          <a:effectRef idx="2">
-            <a:schemeClr val="accent1"/>
-          </a:effectRef>
-          <a:fontRef idx="minor">
-            <a:schemeClr val="lt1"/>
-          </a:fontRef>
-        </p:style>
-        <p:txBody>
-          <a:bodyPr rtlCol="0" anchor="ctr"/>
-          <a:lstStyle/>
-          <a:p>
-            <a:pPr algn="ctr"/>
-          </a:p>
-        </p:txBody>
-      </p:sp>
-      <p:sp>
-        <p:nvSpPr>
-          <p:cNvPr id="3" name="TextBox 2"/>
-          <p:cNvSpPr txBox="1"/>
-          <p:nvPr/>
-        </p:nvSpPr>
-        <p:spPr>
-          <a:xfrm>
-            <a:off x="822960" y="548640"/>
-            <a:ext cx="10607040" cy="1188720"/>
-          </a:xfrm>
-          <a:prstGeom prst="rect">
-            <a:avLst/>
-          </a:prstGeom>
-          <a:noFill/>
-        </p:spPr>
-        <p:txBody>
-          <a:bodyPr wrap="square">
-            <a:spAutoFit/>
-          </a:bodyPr>
-          <a:lstStyle/>
-          <a:p>
-            <a:pPr>
-              <a:spcAft>
-                <a:spcPts val="1400"/>
-              </a:spcAft>
-            </a:pPr>
-            <a:r>
-              <a:rPr sz="4000" b="1">
-                <a:solidFill>
-                  <a:srgbClr val="272A25"/>
-                </a:solidFill>
-                <a:latin typeface="Fraunces"/>
-              </a:rPr>
-              <a:t>Choose · check · control</a:t>
-            </a:r>
-          </a:p>
-        </p:txBody>
-      </p:sp>
-      <p:sp>
-        <p:nvSpPr>
-          <p:cNvPr id="4" name="TextBox 3"/>
-          <p:cNvSpPr txBox="1"/>
-          <p:nvPr/>
-        </p:nvSpPr>
-        <p:spPr>
-          <a:xfrm>
-            <a:off x="822960" y="2011680"/>
-            <a:ext cx="10607040" cy="4206240"/>
-          </a:xfrm>
-          <a:prstGeom prst="rect">
-            <a:avLst/>
-          </a:prstGeom>
-          <a:noFill/>
-        </p:spPr>
-        <p:txBody>
-          <a:bodyPr wrap="square">
-            <a:spAutoFit/>
-          </a:bodyPr>
-          <a:lstStyle/>
-          <a:p>
-            <a:pPr>
-              <a:spcAft>
-                <a:spcPts val="1600"/>
-              </a:spcAft>
-            </a:pPr>
-            <a:r>
-              <a:rPr sz="2600" b="0">
-                <a:solidFill>
-                  <a:srgbClr val="272A25"/>
-                </a:solidFill>
-                <a:latin typeface="DM Sans"/>
-              </a:rPr>
-              <a:t>•  Choose what it sees: context files, connectors</a:t>
-            </a:r>
-          </a:p>
-          <a:p>
-            <a:pPr>
-              <a:spcAft>
-                <a:spcPts val="1600"/>
-              </a:spcAft>
-            </a:pPr>
-            <a:r>
-              <a:rPr sz="2600" b="0">
-                <a:solidFill>
-                  <a:srgbClr val="272A25"/>
-                </a:solidFill>
-                <a:latin typeface="DM Sans"/>
-              </a:rPr>
-              <a:t>•  Check what it produces: fluent ≠ correct, say what you checked</a:t>
-            </a:r>
-          </a:p>
-          <a:p>
-            <a:pPr>
-              <a:spcAft>
-                <a:spcPts val="1600"/>
-              </a:spcAft>
-            </a:pPr>
-            <a:r>
-              <a:rPr sz="2600" b="0">
-                <a:solidFill>
-                  <a:srgbClr val="272A25"/>
-                </a:solidFill>
-                <a:latin typeface="DM Sans"/>
-              </a:rPr>
-              <a:t>•  Control what it can change: read-only first, ask before writes</a:t>
-            </a:r>
-          </a:p>
-          <a:p>
-            <a:pPr>
-              <a:spcAft>
-                <a:spcPts val="1600"/>
-              </a:spcAft>
-            </a:pPr>
-            <a:r>
-              <a:rPr sz="2600" b="0">
-                <a:solidFill>
-                  <a:srgbClr val="272A25"/>
-                </a:solidFill>
-                <a:latin typeface="DM Sans"/>
-              </a:rPr>
-              <a:t>•  This course's connector is read-only, on purpose</a:t>
-            </a:r>
-          </a:p>
-        </p:txBody>
-      </p:sp>
-      <p:sp>
-        <p:nvSpPr>
-          <p:cNvPr id="5" name="TextBox 4"/>
-          <p:cNvSpPr txBox="1"/>
-          <p:nvPr/>
-        </p:nvSpPr>
-        <p:spPr>
-          <a:xfrm>
-            <a:off x="822960" y="6263640"/>
-            <a:ext cx="10607040" cy="365760"/>
-          </a:xfrm>
-          <a:prstGeom prst="rect">
-            <a:avLst/>
-          </a:prstGeom>
-          <a:noFill/>
-        </p:spPr>
-        <p:txBody>
-          <a:bodyPr wrap="square">
-            <a:spAutoFit/>
-          </a:bodyPr>
-          <a:lstStyle/>
-          <a:p>
-            <a:pPr algn="r">
-              <a:spcAft>
-                <a:spcPts val="1400"/>
-              </a:spcAft>
-            </a:pPr>
-            <a:r>
-              <a:rPr sz="1600" b="0">
-                <a:solidFill>
-                  <a:srgbClr val="64665D"/>
-                </a:solidFill>
-                <a:latin typeface="DM Sans"/>
-              </a:rPr>
-              <a:t>Week 6 · Demo 3 · Connectors        16 / 19</a:t>
-            </a:r>
-          </a:p>
-        </p:txBody>
-      </p:sp>
-    </p:spTree>
-  </p:cSld>
-  <p:clrMapOvr>
-    <a:masterClrMapping/>
-  </p:clrMapOvr>
-</p:sld>
-</file>
-
-<file path=ppt/slides/slide17.xml><?xml version="1.0" encoding="utf-8"?>
-<p:sld xmlns:a="http://schemas.openxmlformats.org/drawingml/2006/main" xmlns:p="http://schemas.openxmlformats.org/presentationml/2006/main" xmlns:r="http://schemas.openxmlformats.org/officeDocument/2006/relationships">
-  <p:cSld>
-    <p:bg>
-      <p:bgPr>
-        <a:solidFill>
-          <a:srgbClr val="F7F5EE"/>
-        </a:solidFill>
-        <a:effectLst/>
-      </p:bgPr>
-    </p:bg>
-    <p:spTree>
-      <p:nvGrpSpPr>
-        <p:cNvPr id="1" name=""/>
-        <p:cNvGrpSpPr/>
-        <p:nvPr/>
-      </p:nvGrpSpPr>
-      <p:grpSpPr/>
-      <p:sp>
-        <p:nvSpPr>
-          <p:cNvPr id="2" name="Rectangle 1"/>
-          <p:cNvSpPr/>
-          <p:nvPr/>
-        </p:nvSpPr>
-        <p:spPr>
-          <a:xfrm>
-            <a:off x="0" y="0"/>
-            <a:ext cx="228600" cy="6858000"/>
-          </a:xfrm>
-          <a:prstGeom prst="rect">
-            <a:avLst/>
-          </a:prstGeom>
-          <a:solidFill>
-            <a:srgbClr val="A83D2B"/>
-          </a:solidFill>
-          <a:ln>
-            <a:noFill/>
-          </a:ln>
-        </p:spPr>
-        <p:style>
-          <a:lnRef idx="1">
-            <a:schemeClr val="accent1"/>
-          </a:lnRef>
-          <a:fillRef idx="3">
-            <a:schemeClr val="accent1"/>
-          </a:fillRef>
-          <a:effectRef idx="2">
-            <a:schemeClr val="accent1"/>
-          </a:effectRef>
-          <a:fontRef idx="minor">
-            <a:schemeClr val="lt1"/>
-          </a:fontRef>
-        </p:style>
-        <p:txBody>
-          <a:bodyPr rtlCol="0" anchor="ctr"/>
-          <a:lstStyle/>
-          <a:p>
-            <a:pPr algn="ctr"/>
-          </a:p>
-        </p:txBody>
-      </p:sp>
-      <p:sp>
-        <p:nvSpPr>
-          <p:cNvPr id="3" name="TextBox 2"/>
-          <p:cNvSpPr txBox="1"/>
-          <p:nvPr/>
-        </p:nvSpPr>
-        <p:spPr>
-          <a:xfrm>
-            <a:off x="822960" y="548640"/>
-            <a:ext cx="10607040" cy="1188720"/>
-          </a:xfrm>
-          <a:prstGeom prst="rect">
-            <a:avLst/>
-          </a:prstGeom>
-          <a:noFill/>
-        </p:spPr>
-        <p:txBody>
-          <a:bodyPr wrap="square">
-            <a:spAutoFit/>
-          </a:bodyPr>
-          <a:lstStyle/>
-          <a:p>
-            <a:pPr>
-              <a:spcAft>
-                <a:spcPts val="1400"/>
-              </a:spcAft>
-            </a:pPr>
-            <a:r>
-              <a:rPr sz="4000" b="1">
-                <a:solidFill>
-                  <a:srgbClr val="272A25"/>
-                </a:solidFill>
-                <a:latin typeface="Fraunces"/>
-              </a:rPr>
-              <a:t>This week's reading: your AI as a coach</a:t>
-            </a:r>
-          </a:p>
-        </p:txBody>
-      </p:sp>
-      <p:sp>
-        <p:nvSpPr>
-          <p:cNvPr id="4" name="TextBox 3"/>
-          <p:cNvSpPr txBox="1"/>
-          <p:nvPr/>
-        </p:nvSpPr>
-        <p:spPr>
-          <a:xfrm>
-            <a:off x="822960" y="2011680"/>
-            <a:ext cx="10607040" cy="4206240"/>
-          </a:xfrm>
-          <a:prstGeom prst="rect">
-            <a:avLst/>
-          </a:prstGeom>
-          <a:noFill/>
-        </p:spPr>
-        <p:txBody>
-          <a:bodyPr wrap="square">
-            <a:spAutoFit/>
-          </a:bodyPr>
-          <a:lstStyle/>
-          <a:p>
-            <a:pPr>
-              <a:spcAft>
-                <a:spcPts val="2200"/>
-              </a:spcAft>
-            </a:pPr>
-            <a:r>
-              <a:rPr sz="3000" b="0">
-                <a:solidFill>
-                  <a:srgbClr val="272A25"/>
-                </a:solidFill>
-                <a:latin typeface="DM Sans"/>
-              </a:rPr>
-              <a:t>•  Arielle Shipper, “How to Get Better at AI by Asking AI” (Every)</a:t>
-            </a:r>
-          </a:p>
-          <a:p>
-            <a:pPr>
-              <a:spcAft>
-                <a:spcPts val="2200"/>
-              </a:spcAft>
-            </a:pPr>
-            <a:r>
-              <a:rPr sz="3000" b="0">
-                <a:solidFill>
-                  <a:srgbClr val="272A25"/>
-                </a:solidFill>
-                <a:latin typeface="DM Sans"/>
-              </a:rPr>
-              <a:t>•  Ask your AI: which of the eight levels am I, with examples?</a:t>
-            </a:r>
-          </a:p>
-          <a:p>
-            <a:pPr>
-              <a:spcAft>
-                <a:spcPts val="2200"/>
-              </a:spcAft>
-            </a:pPr>
-            <a:r>
-              <a:rPr sz="3000" b="0">
-                <a:solidFill>
-                  <a:srgbClr val="272A25"/>
-                </a:solidFill>
-                <a:latin typeface="DM Sans"/>
-              </a:rPr>
-              <a:t>•  Then: “teach me the next step”</a:t>
-            </a:r>
-          </a:p>
-        </p:txBody>
-      </p:sp>
-      <p:sp>
-        <p:nvSpPr>
-          <p:cNvPr id="5" name="TextBox 4"/>
-          <p:cNvSpPr txBox="1"/>
-          <p:nvPr/>
-        </p:nvSpPr>
-        <p:spPr>
-          <a:xfrm>
-            <a:off x="822960" y="6263640"/>
-            <a:ext cx="10607040" cy="365760"/>
-          </a:xfrm>
-          <a:prstGeom prst="rect">
-            <a:avLst/>
-          </a:prstGeom>
-          <a:noFill/>
-        </p:spPr>
-        <p:txBody>
-          <a:bodyPr wrap="square">
-            <a:spAutoFit/>
-          </a:bodyPr>
-          <a:lstStyle/>
-          <a:p>
-            <a:pPr algn="r">
-              <a:spcAft>
-                <a:spcPts val="1400"/>
-              </a:spcAft>
-            </a:pPr>
-            <a:r>
-              <a:rPr sz="1600" b="0">
-                <a:solidFill>
-                  <a:srgbClr val="64665D"/>
-                </a:solidFill>
-                <a:latin typeface="DM Sans"/>
-              </a:rPr>
-              <a:t>Week 6 · Close        17 / 19</a:t>
-            </a:r>
-          </a:p>
-        </p:txBody>
-      </p:sp>
-    </p:spTree>
-  </p:cSld>
-  <p:clrMapOvr>
-    <a:masterClrMapping/>
-  </p:clrMapOvr>
-</p:sld>
-</file>
-
-<file path=ppt/slides/slide18.xml><?xml version="1.0" encoding="utf-8"?>
-<p:sld xmlns:a="http://schemas.openxmlformats.org/drawingml/2006/main" xmlns:p="http://schemas.openxmlformats.org/presentationml/2006/main" xmlns:r="http://schemas.openxmlformats.org/officeDocument/2006/relationships">
-  <p:cSld>
-    <p:bg>
-      <p:bgPr>
-        <a:solidFill>
-          <a:srgbClr val="F7F5EE"/>
-        </a:solidFill>
-        <a:effectLst/>
-      </p:bgPr>
-    </p:bg>
-    <p:spTree>
-      <p:nvGrpSpPr>
-        <p:cNvPr id="1" name=""/>
-        <p:cNvGrpSpPr/>
-        <p:nvPr/>
-      </p:nvGrpSpPr>
-      <p:grpSpPr/>
-      <p:sp>
-        <p:nvSpPr>
-          <p:cNvPr id="2" name="Rectangle 1"/>
-          <p:cNvSpPr/>
-          <p:nvPr/>
-        </p:nvSpPr>
-        <p:spPr>
-          <a:xfrm>
-            <a:off x="0" y="0"/>
-            <a:ext cx="228600" cy="6858000"/>
-          </a:xfrm>
-          <a:prstGeom prst="rect">
-            <a:avLst/>
-          </a:prstGeom>
-          <a:solidFill>
-            <a:srgbClr val="A83D2B"/>
-          </a:solidFill>
-          <a:ln>
-            <a:noFill/>
-          </a:ln>
-        </p:spPr>
-        <p:style>
-          <a:lnRef idx="1">
-            <a:schemeClr val="accent1"/>
-          </a:lnRef>
-          <a:fillRef idx="3">
-            <a:schemeClr val="accent1"/>
-          </a:fillRef>
-          <a:effectRef idx="2">
-            <a:schemeClr val="accent1"/>
-          </a:effectRef>
-          <a:fontRef idx="minor">
-            <a:schemeClr val="lt1"/>
-          </a:fontRef>
-        </p:style>
-        <p:txBody>
-          <a:bodyPr rtlCol="0" anchor="ctr"/>
-          <a:lstStyle/>
-          <a:p>
-            <a:pPr algn="ctr"/>
-          </a:p>
-        </p:txBody>
-      </p:sp>
-      <p:sp>
-        <p:nvSpPr>
-          <p:cNvPr id="3" name="TextBox 2"/>
-          <p:cNvSpPr txBox="1"/>
-          <p:nvPr/>
-        </p:nvSpPr>
-        <p:spPr>
-          <a:xfrm>
-            <a:off x="822960" y="548640"/>
-            <a:ext cx="10607040" cy="1188720"/>
-          </a:xfrm>
-          <a:prstGeom prst="rect">
-            <a:avLst/>
-          </a:prstGeom>
-          <a:noFill/>
-        </p:spPr>
-        <p:txBody>
-          <a:bodyPr wrap="square">
-            <a:spAutoFit/>
-          </a:bodyPr>
-          <a:lstStyle/>
-          <a:p>
-            <a:pPr>
-              <a:spcAft>
-                <a:spcPts val="1400"/>
-              </a:spcAft>
-            </a:pPr>
-            <a:r>
-              <a:rPr sz="4000" b="1">
-                <a:solidFill>
-                  <a:srgbClr val="272A25"/>
-                </a:solidFill>
-                <a:latin typeface="Fraunces"/>
-              </a:rPr>
-              <a:t>Studio · write each other's AGENTS.md</a:t>
-            </a:r>
-          </a:p>
-        </p:txBody>
-      </p:sp>
-      <p:sp>
-        <p:nvSpPr>
-          <p:cNvPr id="4" name="TextBox 3"/>
-          <p:cNvSpPr txBox="1"/>
-          <p:nvPr/>
-        </p:nvSpPr>
-        <p:spPr>
-          <a:xfrm>
-            <a:off x="822960" y="2011680"/>
-            <a:ext cx="10607040" cy="4206240"/>
-          </a:xfrm>
-          <a:prstGeom prst="rect">
-            <a:avLst/>
-          </a:prstGeom>
-          <a:noFill/>
-        </p:spPr>
-        <p:txBody>
-          <a:bodyPr wrap="square">
-            <a:spAutoFit/>
-          </a:bodyPr>
-          <a:lstStyle/>
-          <a:p>
-            <a:pPr>
-              <a:spcAft>
-                <a:spcPts val="2200"/>
-              </a:spcAft>
-            </a:pPr>
-            <a:r>
-              <a:rPr sz="3000" b="0">
-                <a:solidFill>
-                  <a:srgbClr val="272A25"/>
-                </a:solidFill>
-                <a:latin typeface="DM Sans"/>
-              </a:rPr>
-              <a:t>•  Pairs, 20 minutes</a:t>
-            </a:r>
-          </a:p>
-          <a:p>
-            <a:pPr>
-              <a:spcAft>
-                <a:spcPts val="2200"/>
-              </a:spcAft>
-            </a:pPr>
-            <a:r>
-              <a:rPr sz="3000" b="0">
-                <a:solidFill>
-                  <a:srgbClr val="272A25"/>
-                </a:solidFill>
-                <a:latin typeface="DM Sans"/>
-              </a:rPr>
-              <a:t>•  8 min each: your partner interviews you and drafts your AGENTS.md</a:t>
-            </a:r>
-          </a:p>
-          <a:p>
-            <a:pPr>
-              <a:spcAft>
-                <a:spcPts val="2200"/>
-              </a:spcAft>
-            </a:pPr>
-            <a:r>
-              <a:rPr sz="3000" b="0">
-                <a:solidFill>
-                  <a:srgbClr val="272A25"/>
-                </a:solidFill>
-                <a:latin typeface="DM Sans"/>
-              </a:rPr>
-              <a:t>•  4 min: test it with your own agent, then revise</a:t>
-            </a:r>
-          </a:p>
-        </p:txBody>
-      </p:sp>
-      <p:sp>
-        <p:nvSpPr>
-          <p:cNvPr id="5" name="TextBox 4"/>
-          <p:cNvSpPr txBox="1"/>
-          <p:nvPr/>
-        </p:nvSpPr>
-        <p:spPr>
-          <a:xfrm>
-            <a:off x="822960" y="6263640"/>
-            <a:ext cx="10607040" cy="365760"/>
-          </a:xfrm>
-          <a:prstGeom prst="rect">
-            <a:avLst/>
-          </a:prstGeom>
-          <a:noFill/>
-        </p:spPr>
-        <p:txBody>
-          <a:bodyPr wrap="square">
-            <a:spAutoFit/>
-          </a:bodyPr>
-          <a:lstStyle/>
-          <a:p>
-            <a:pPr algn="r">
-              <a:spcAft>
-                <a:spcPts val="1400"/>
-              </a:spcAft>
-            </a:pPr>
-            <a:r>
-              <a:rPr sz="1600" b="0">
-                <a:solidFill>
-                  <a:srgbClr val="64665D"/>
-                </a:solidFill>
-                <a:latin typeface="DM Sans"/>
-              </a:rPr>
-              <a:t>Week 6 · Close        18 / 19</a:t>
-            </a:r>
-          </a:p>
-        </p:txBody>
-      </p:sp>
-    </p:spTree>
-  </p:cSld>
-  <p:clrMapOvr>
-    <a:masterClrMapping/>
-  </p:clrMapOvr>
-</p:sld>
-</file>
-
-<file path=ppt/slides/slide19.xml><?xml version="1.0" encoding="utf-8"?>
-<p:sld xmlns:a="http://schemas.openxmlformats.org/drawingml/2006/main" xmlns:p="http://schemas.openxmlformats.org/presentationml/2006/main" xmlns:r="http://schemas.openxmlformats.org/officeDocument/2006/relationships">
-  <p:cSld>
-    <p:bg>
-      <p:bgPr>
-        <a:solidFill>
-          <a:srgbClr val="F7F5EE"/>
-        </a:solidFill>
-        <a:effectLst/>
-      </p:bgPr>
-    </p:bg>
-    <p:spTree>
-      <p:nvGrpSpPr>
-        <p:cNvPr id="1" name=""/>
-        <p:cNvGrpSpPr/>
-        <p:nvPr/>
-      </p:nvGrpSpPr>
-      <p:grpSpPr/>
-      <p:sp>
-        <p:nvSpPr>
-          <p:cNvPr id="2" name="Rectangle 1"/>
-          <p:cNvSpPr/>
-          <p:nvPr/>
-        </p:nvSpPr>
-        <p:spPr>
-          <a:xfrm>
-            <a:off x="0" y="0"/>
-            <a:ext cx="228600" cy="6858000"/>
-          </a:xfrm>
-          <a:prstGeom prst="rect">
-            <a:avLst/>
-          </a:prstGeom>
-          <a:solidFill>
-            <a:srgbClr val="A83D2B"/>
-          </a:solidFill>
-          <a:ln>
-            <a:noFill/>
-          </a:ln>
-        </p:spPr>
-        <p:style>
-          <a:lnRef idx="1">
-            <a:schemeClr val="accent1"/>
-          </a:lnRef>
-          <a:fillRef idx="3">
-            <a:schemeClr val="accent1"/>
-          </a:fillRef>
-          <a:effectRef idx="2">
-            <a:schemeClr val="accent1"/>
-          </a:effectRef>
-          <a:fontRef idx="minor">
-            <a:schemeClr val="lt1"/>
-          </a:fontRef>
-        </p:style>
-        <p:txBody>
-          <a:bodyPr rtlCol="0" anchor="ctr"/>
-          <a:lstStyle/>
-          <a:p>
-            <a:pPr algn="ctr"/>
-          </a:p>
-        </p:txBody>
-      </p:sp>
-      <p:sp>
-        <p:nvSpPr>
-          <p:cNvPr id="3" name="TextBox 2"/>
-          <p:cNvSpPr txBox="1"/>
-          <p:nvPr/>
-        </p:nvSpPr>
-        <p:spPr>
-          <a:xfrm>
-            <a:off x="822960" y="548640"/>
-            <a:ext cx="10607040" cy="1188720"/>
-          </a:xfrm>
-          <a:prstGeom prst="rect">
-            <a:avLst/>
-          </a:prstGeom>
-          <a:noFill/>
-        </p:spPr>
-        <p:txBody>
-          <a:bodyPr wrap="square">
-            <a:spAutoFit/>
-          </a:bodyPr>
-          <a:lstStyle/>
-          <a:p>
-            <a:pPr>
-              <a:spcAft>
-                <a:spcPts val="1400"/>
-              </a:spcAft>
-            </a:pPr>
-            <a:r>
-              <a:rPr sz="4000" b="1">
-                <a:solidFill>
-                  <a:srgbClr val="272A25"/>
-                </a:solidFill>
-                <a:latin typeface="Fraunces"/>
-              </a:rPr>
-              <a:t>Sources</a:t>
-            </a:r>
-          </a:p>
-        </p:txBody>
-      </p:sp>
-      <p:sp>
-        <p:nvSpPr>
-          <p:cNvPr id="4" name="TextBox 3"/>
-          <p:cNvSpPr txBox="1"/>
-          <p:nvPr/>
-        </p:nvSpPr>
-        <p:spPr>
-          <a:xfrm>
-            <a:off x="822960" y="2011680"/>
-            <a:ext cx="10607040" cy="4206240"/>
-          </a:xfrm>
-          <a:prstGeom prst="rect">
-            <a:avLst/>
-          </a:prstGeom>
-          <a:noFill/>
-        </p:spPr>
-        <p:txBody>
-          <a:bodyPr wrap="square">
-            <a:spAutoFit/>
-          </a:bodyPr>
-          <a:lstStyle/>
-          <a:p>
-            <a:pPr>
-              <a:spcAft>
-                <a:spcPts val="1600"/>
-              </a:spcAft>
-            </a:pPr>
-            <a:r>
-              <a:rPr sz="2600" b="0">
-                <a:solidFill>
-                  <a:srgbClr val="272A25"/>
-                </a:solidFill>
-                <a:latin typeface="DM Sans"/>
-              </a:rPr>
-              <a:t>•  AGENTS.md convention · agents.md</a:t>
-            </a:r>
-          </a:p>
-          <a:p>
-            <a:pPr>
-              <a:spcAft>
-                <a:spcPts val="1600"/>
-              </a:spcAft>
-            </a:pPr>
-            <a:r>
-              <a:rPr sz="2600" b="0">
-                <a:solidFill>
-                  <a:srgbClr val="272A25"/>
-                </a:solidFill>
-                <a:latin typeface="DM Sans"/>
-              </a:rPr>
-              <a:t>•  Effective context engineering · Anthropic</a:t>
-            </a:r>
-          </a:p>
-          <a:p>
-            <a:pPr>
-              <a:spcAft>
-                <a:spcPts val="1600"/>
-              </a:spcAft>
-            </a:pPr>
-            <a:r>
-              <a:rPr sz="2600" b="0">
-                <a:solidFill>
-                  <a:srgbClr val="272A25"/>
-                </a:solidFill>
-                <a:latin typeface="DM Sans"/>
-              </a:rPr>
-              <a:t>•  GitHub Pages · docs.github.com/pages</a:t>
-            </a:r>
-          </a:p>
-          <a:p>
-            <a:pPr>
-              <a:spcAft>
-                <a:spcPts val="1600"/>
-              </a:spcAft>
-            </a:pPr>
-            <a:r>
-              <a:rPr sz="2600" b="0">
-                <a:solidFill>
-                  <a:srgbClr val="272A25"/>
-                </a:solidFill>
-                <a:latin typeface="DM Sans"/>
-              </a:rPr>
-              <a:t>•  MCP · modelcontextprotocol.io</a:t>
-            </a:r>
-          </a:p>
-          <a:p>
-            <a:pPr>
-              <a:spcAft>
-                <a:spcPts val="1600"/>
-              </a:spcAft>
-            </a:pPr>
-            <a:r>
-              <a:rPr sz="2600" b="0">
-                <a:solidFill>
-                  <a:srgbClr val="272A25"/>
-                </a:solidFill>
-                <a:latin typeface="DM Sans"/>
-              </a:rPr>
-              <a:t>•  AI Fluency (further reading) · academy.claude.com</a:t>
-            </a:r>
-          </a:p>
-        </p:txBody>
-      </p:sp>
-      <p:sp>
-        <p:nvSpPr>
-          <p:cNvPr id="5" name="TextBox 4"/>
-          <p:cNvSpPr txBox="1"/>
-          <p:nvPr/>
-        </p:nvSpPr>
-        <p:spPr>
-          <a:xfrm>
-            <a:off x="822960" y="6263640"/>
-            <a:ext cx="10607040" cy="365760"/>
-          </a:xfrm>
-          <a:prstGeom prst="rect">
-            <a:avLst/>
-          </a:prstGeom>
-          <a:noFill/>
-        </p:spPr>
-        <p:txBody>
-          <a:bodyPr wrap="square">
-            <a:spAutoFit/>
-          </a:bodyPr>
-          <a:lstStyle/>
-          <a:p>
-            <a:pPr algn="r">
-              <a:spcAft>
-                <a:spcPts val="1400"/>
-              </a:spcAft>
-            </a:pPr>
-            <a:r>
-              <a:rPr sz="1600" b="0">
-                <a:solidFill>
-                  <a:srgbClr val="64665D"/>
-                </a:solidFill>
-                <a:latin typeface="DM Sans"/>
-              </a:rPr>
-              <a:t>Week 6 · Close        19 / 19</a:t>
+              <a:t>Week 6 · Studio        12 / 12</a:t>
             </a:r>
           </a:p>
         </p:txBody>
@@ -8094,7 +5207,7 @@
                 </a:solidFill>
                 <a:latin typeface="Fraunces"/>
               </a:rPr>
-              <a:t>Tonight: three demos</a:t>
+              <a:t>Demo 1 · copy the lesson</a:t>
             </a:r>
           </a:p>
         </p:txBody>
@@ -8133,7 +5246,7 @@
                 </a:solidFill>
                 <a:latin typeface="DM Sans"/>
               </a:rPr>
-              <a:t>•  1 · Give your AI context that sticks (AGENTS.md)</a:t>
+              <a:t>•  Copy the lesson markdown into your AI.</a:t>
             </a:r>
           </a:p>
           <a:p>
@@ -8149,7 +5262,7 @@
                 </a:solidFill>
                 <a:latin typeface="DM Sans"/>
               </a:rPr>
-              <a:t>•  2 · Get your project online: a link anyone can open</a:t>
+              <a:t>•  Ask: “Teach me this and quiz me.”</a:t>
             </a:r>
           </a:p>
           <a:p>
@@ -8165,7 +5278,7 @@
                 </a:solidFill>
                 <a:latin typeface="DM Sans"/>
               </a:rPr>
-              <a:t>•  3 · Connect your AI to the course</a:t>
+              <a:t>•  Check its explanation against the lesson.</a:t>
             </a:r>
           </a:p>
         </p:txBody>
@@ -8204,7 +5317,7 @@
                 </a:solidFill>
                 <a:latin typeface="DM Sans"/>
               </a:rPr>
-              <a:t>Week 6 · Opening        2 / 19</a:t>
+              <a:t>Week 6 · Demo 1 · Learn with your AI        2 / 12</a:t>
             </a:r>
           </a:p>
         </p:txBody>
@@ -8312,7 +5425,7 @@
                 </a:solidFill>
                 <a:latin typeface="Fraunces"/>
               </a:rPr>
-              <a:t>Your AI starts every session from zero</a:t>
+              <a:t>Markdown is just a text file</a:t>
             </a:r>
           </a:p>
         </p:txBody>
@@ -8351,7 +5464,7 @@
                 </a:solidFill>
                 <a:latin typeface="DM Sans"/>
               </a:rPr>
-              <a:t>•  It only sees what's in front of it right now</a:t>
+              <a:t>•  A .md file is plain text, with headings and lists.</a:t>
             </a:r>
           </a:p>
           <a:p>
@@ -8367,7 +5480,7 @@
                 </a:solidFill>
                 <a:latin typeface="DM Sans"/>
               </a:rPr>
-              <a:t>•  It doesn't know your project unless you tell it</a:t>
+              <a:t>•  You can read it. Your AI can read it.</a:t>
             </a:r>
           </a:p>
           <a:p>
@@ -8383,7 +5496,7 @@
                 </a:solidFill>
                 <a:latin typeface="DM Sans"/>
               </a:rPr>
-              <a:t>•  A generic answer is usually a context problem</a:t>
+              <a:t>•  Context can live in a file instead of your memory.</a:t>
             </a:r>
           </a:p>
         </p:txBody>
@@ -8422,7 +5535,7 @@
                 </a:solidFill>
                 <a:latin typeface="DM Sans"/>
               </a:rPr>
-              <a:t>Week 6 · Demo 1 · Context that sticks        3 / 19</a:t>
+              <a:t>Week 6 · Demo 2 · Context that sticks        3 / 12</a:t>
             </a:r>
           </a:p>
         </p:txBody>
@@ -8524,70 +5637,27 @@
               </a:spcAft>
             </a:pPr>
             <a:r>
-              <a:rPr sz="3200" b="1">
+              <a:rPr sz="4000" b="1">
                 <a:solidFill>
                   <a:srgbClr val="272A25"/>
                 </a:solidFill>
                 <a:latin typeface="Fraunces"/>
               </a:rPr>
-              <a:t>Markdown: plain text with a little structure</a:t>
-            </a:r>
-          </a:p>
-        </p:txBody>
-      </p:sp>
-      <p:sp>
-        <p:nvSpPr>
-          <p:cNvPr id="4" name="Rectangle 3"/>
-          <p:cNvSpPr/>
-          <p:nvPr/>
-        </p:nvSpPr>
-        <p:spPr>
-          <a:xfrm>
-            <a:off x="822960" y="1828800"/>
-            <a:ext cx="6583680" cy="4023360"/>
-          </a:xfrm>
-          <a:prstGeom prst="rect">
-            <a:avLst/>
-          </a:prstGeom>
-          <a:solidFill>
-            <a:srgbClr val="EEECE2"/>
-          </a:solidFill>
-          <a:ln>
-            <a:noFill/>
-          </a:ln>
-        </p:spPr>
-        <p:style>
-          <a:lnRef idx="1">
-            <a:schemeClr val="accent1"/>
-          </a:lnRef>
-          <a:fillRef idx="3">
-            <a:schemeClr val="accent1"/>
-          </a:fillRef>
-          <a:effectRef idx="2">
-            <a:schemeClr val="accent1"/>
-          </a:effectRef>
-          <a:fontRef idx="minor">
-            <a:schemeClr val="lt1"/>
-          </a:fontRef>
-        </p:style>
-        <p:txBody>
-          <a:bodyPr rtlCol="0" anchor="ctr"/>
-          <a:lstStyle/>
-          <a:p>
-            <a:pPr algn="ctr"/>
-          </a:p>
-        </p:txBody>
-      </p:sp>
-      <p:sp>
-        <p:nvSpPr>
-          <p:cNvPr id="5" name="TextBox 4"/>
+              <a:t>Context that sticks</a:t>
+            </a:r>
+          </a:p>
+        </p:txBody>
+      </p:sp>
+      <p:sp>
+        <p:nvSpPr>
+          <p:cNvPr id="4" name="TextBox 3"/>
           <p:cNvSpPr txBox="1"/>
           <p:nvPr/>
         </p:nvSpPr>
         <p:spPr>
           <a:xfrm>
-            <a:off x="1097280" y="2011680"/>
-            <a:ext cx="6217920" cy="3749039"/>
+            <a:off x="822960" y="2011680"/>
+            <a:ext cx="10607040" cy="4206240"/>
           </a:xfrm>
           <a:prstGeom prst="rect">
             <a:avLst/>
@@ -8602,143 +5672,56 @@
           <a:p>
             <a:pPr>
               <a:spcAft>
-                <a:spcPts val="200"/>
+                <a:spcPts val="2200"/>
               </a:spcAft>
             </a:pPr>
             <a:r>
-              <a:rPr sz="2400" b="0">
+              <a:rPr sz="3000" b="0">
                 <a:solidFill>
                   <a:srgbClr val="272A25"/>
                 </a:solidFill>
-                <a:latin typeface="DejaVu Sans Mono"/>
+                <a:latin typeface="DM Sans"/>
               </a:rPr>
-              <a:t># Big heading</a:t>
+              <a:t>•  Claude Code loads CLAUDE.md at session start.</a:t>
             </a:r>
           </a:p>
           <a:p>
             <a:pPr>
               <a:spcAft>
-                <a:spcPts val="200"/>
+                <a:spcPts val="2200"/>
               </a:spcAft>
             </a:pPr>
             <a:r>
-              <a:rPr sz="2400" b="0">
+              <a:rPr sz="3000" b="0">
                 <a:solidFill>
                   <a:srgbClr val="272A25"/>
                 </a:solidFill>
-                <a:latin typeface="DejaVu Sans Mono"/>
+                <a:latin typeface="DM Sans"/>
               </a:rPr>
-              <a:t>## Smaller heading</a:t>
+              <a:t>•  Cursor and other coding tools can load AGENTS.md.</a:t>
             </a:r>
           </a:p>
           <a:p>
             <a:pPr>
               <a:spcAft>
-                <a:spcPts val="200"/>
+                <a:spcPts val="2200"/>
               </a:spcAft>
             </a:pPr>
             <a:r>
-              <a:rPr sz="2400" b="0">
+              <a:rPr sz="3000" b="0">
                 <a:solidFill>
                   <a:srgbClr val="272A25"/>
-                </a:solidFill>
-                <a:latin typeface="DejaVu Sans Mono"/>
-              </a:rPr>
-              <a:t>- a bullet point</a:t>
-            </a:r>
-          </a:p>
-          <a:p>
-            <a:pPr>
-              <a:spcAft>
-                <a:spcPts val="200"/>
-              </a:spcAft>
-            </a:pPr>
-            <a:r>
-              <a:rPr sz="2400" b="0">
-                <a:solidFill>
-                  <a:srgbClr val="272A25"/>
-                </a:solidFill>
-                <a:latin typeface="DejaVu Sans Mono"/>
-              </a:rPr>
-              <a:t>**bold**  *italic*</a:t>
-            </a:r>
-          </a:p>
-          <a:p>
-            <a:pPr>
-              <a:spcAft>
-                <a:spcPts val="200"/>
-              </a:spcAft>
-            </a:pPr>
-            <a:r>
-              <a:rPr sz="2400" b="0">
-                <a:solidFill>
-                  <a:srgbClr val="272A25"/>
-                </a:solidFill>
-                <a:latin typeface="DejaVu Sans Mono"/>
-              </a:rPr>
-              <a:t>[a link](https://example.com)</a:t>
-            </a:r>
-          </a:p>
-          <a:p>
-            <a:pPr>
-              <a:spcAft>
-                <a:spcPts val="200"/>
-              </a:spcAft>
-            </a:pPr>
-            <a:r>
-              <a:rPr sz="2400" b="0">
-                <a:solidFill>
-                  <a:srgbClr val="272A25"/>
-                </a:solidFill>
-                <a:latin typeface="DejaVu Sans Mono"/>
-              </a:rPr>
-              <a:t>`some code`</a:t>
-            </a:r>
-          </a:p>
-        </p:txBody>
-      </p:sp>
-      <p:sp>
-        <p:nvSpPr>
-          <p:cNvPr id="6" name="TextBox 5"/>
-          <p:cNvSpPr txBox="1"/>
-          <p:nvPr/>
-        </p:nvSpPr>
-        <p:spPr>
-          <a:xfrm>
-            <a:off x="7772400" y="3108960"/>
-            <a:ext cx="3931920" cy="1828800"/>
-          </a:xfrm>
-          <a:prstGeom prst="rect">
-            <a:avLst/>
-          </a:prstGeom>
-          <a:noFill/>
-        </p:spPr>
-        <p:txBody>
-          <a:bodyPr wrap="square">
-            <a:spAutoFit/>
-          </a:bodyPr>
-          <a:lstStyle/>
-          <a:p>
-            <a:pPr>
-              <a:spcAft>
-                <a:spcPts val="1400"/>
-              </a:spcAft>
-            </a:pPr>
-            <a:r>
-              <a:rPr sz="2800" b="0">
-                <a:solidFill>
-                  <a:srgbClr val="64665D"/>
                 </a:solidFill>
                 <a:latin typeface="DM Sans"/>
               </a:rPr>
-              <a:t>Plain text. Readable by you and by your AI.</a:t>
-            </a:r>
-          </a:p>
-        </p:txBody>
-      </p:sp>
-      <p:sp>
-        <p:nvSpPr>
-          <p:cNvPr id="7" name="TextBox 6"/>
+              <a:t>•  In a chat app: paste the file or add it to a Project.</a:t>
+            </a:r>
+          </a:p>
+        </p:txBody>
+      </p:sp>
+      <p:sp>
+        <p:nvSpPr>
+          <p:cNvPr id="5" name="TextBox 4"/>
           <p:cNvSpPr txBox="1"/>
           <p:nvPr/>
         </p:nvSpPr>
@@ -8770,7 +5753,7 @@
                 </a:solidFill>
                 <a:latin typeface="DM Sans"/>
               </a:rPr>
-              <a:t>Week 6 · Demo 1 · Context that sticks        4 / 19</a:t>
+              <a:t>Week 6 · Demo 2 · Context that sticks        4 / 12</a:t>
             </a:r>
           </a:p>
         </p:txBody>
@@ -8878,21 +5861,64 @@
                 </a:solidFill>
                 <a:latin typeface="Fraunces"/>
               </a:rPr>
-              <a:t>AGENTS.md: context that sticks</a:t>
-            </a:r>
-          </a:p>
-        </p:txBody>
-      </p:sp>
-      <p:sp>
-        <p:nvSpPr>
-          <p:cNvPr id="4" name="TextBox 3"/>
+              <a:t>One small example</a:t>
+            </a:r>
+          </a:p>
+        </p:txBody>
+      </p:sp>
+      <p:sp>
+        <p:nvSpPr>
+          <p:cNvPr id="4" name="Rectangle 3"/>
+          <p:cNvSpPr/>
+          <p:nvPr/>
+        </p:nvSpPr>
+        <p:spPr>
+          <a:xfrm>
+            <a:off x="822960" y="1828800"/>
+            <a:ext cx="6583680" cy="4023360"/>
+          </a:xfrm>
+          <a:prstGeom prst="rect">
+            <a:avLst/>
+          </a:prstGeom>
+          <a:solidFill>
+            <a:srgbClr val="EEECE2"/>
+          </a:solidFill>
+          <a:ln>
+            <a:noFill/>
+          </a:ln>
+        </p:spPr>
+        <p:style>
+          <a:lnRef idx="1">
+            <a:schemeClr val="accent1"/>
+          </a:lnRef>
+          <a:fillRef idx="3">
+            <a:schemeClr val="accent1"/>
+          </a:fillRef>
+          <a:effectRef idx="2">
+            <a:schemeClr val="accent1"/>
+          </a:effectRef>
+          <a:fontRef idx="minor">
+            <a:schemeClr val="lt1"/>
+          </a:fontRef>
+        </p:style>
+        <p:txBody>
+          <a:bodyPr rtlCol="0" anchor="ctr"/>
+          <a:lstStyle/>
+          <a:p>
+            <a:pPr algn="ctr"/>
+          </a:p>
+        </p:txBody>
+      </p:sp>
+      <p:sp>
+        <p:nvSpPr>
+          <p:cNvPr id="5" name="TextBox 4"/>
           <p:cNvSpPr txBox="1"/>
           <p:nvPr/>
         </p:nvSpPr>
         <p:spPr>
           <a:xfrm>
-            <a:off x="822960" y="2011680"/>
-            <a:ext cx="10607040" cy="4206240"/>
+            <a:off x="1097280" y="2011680"/>
+            <a:ext cx="6217920" cy="3749039"/>
           </a:xfrm>
           <a:prstGeom prst="rect">
             <a:avLst/>
@@ -8907,72 +5933,127 @@
           <a:p>
             <a:pPr>
               <a:spcAft>
-                <a:spcPts val="1600"/>
+                <a:spcPts val="200"/>
               </a:spcAft>
             </a:pPr>
             <a:r>
-              <a:rPr sz="2600" b="0">
+              <a:rPr sz="1800" b="0">
                 <a:solidFill>
                   <a:srgbClr val="272A25"/>
+                </a:solidFill>
+                <a:latin typeface="DejaVu Sans Mono"/>
+              </a:rPr>
+              <a:t># Hill Plant Swap</a:t>
+            </a:r>
+          </a:p>
+          <a:p>
+            <a:pPr>
+              <a:spcAft>
+                <a:spcPts val="200"/>
+              </a:spcAft>
+            </a:pPr>
+            <a:r>
+              <a:rPr sz="1800" b="0">
+                <a:solidFill>
+                  <a:srgbClr val="272A25"/>
+                </a:solidFill>
+                <a:latin typeface="DejaVu Sans Mono"/>
+              </a:rPr>
+              <a:t>A one-page website for a free monthly plant swap on the Hill, near CU.</a:t>
+            </a:r>
+          </a:p>
+          <a:p>
+            <a:pPr>
+              <a:spcAft>
+                <a:spcPts val="200"/>
+              </a:spcAft>
+            </a:pPr>
+            <a:r>
+              <a:rPr sz="1800" b="0">
+                <a:solidFill>
+                  <a:srgbClr val="272A25"/>
+                </a:solidFill>
+                <a:latin typeface="DejaVu Sans Mono"/>
+              </a:rPr>
+              <a:t>It's for first-year students who are nervous about going.</a:t>
+            </a:r>
+          </a:p>
+          <a:p>
+            <a:pPr>
+              <a:spcAft>
+                <a:spcPts val="200"/>
+              </a:spcAft>
+            </a:pPr>
+            <a:r>
+              <a:rPr sz="1800" b="0">
+                <a:solidFill>
+                  <a:srgbClr val="272A25"/>
+                </a:solidFill>
+                <a:latin typeface="DejaVu Sans Mono"/>
+              </a:rPr>
+              <a:t>Keep it plain HTML and CSS. No JavaScript.</a:t>
+            </a:r>
+          </a:p>
+          <a:p>
+            <a:pPr>
+              <a:spcAft>
+                <a:spcPts val="200"/>
+              </a:spcAft>
+            </a:pPr>
+            <a:r>
+              <a:rPr sz="1800" b="0">
+                <a:solidFill>
+                  <a:srgbClr val="272A25"/>
+                </a:solidFill>
+                <a:latin typeface="DejaVu Sans Mono"/>
+              </a:rPr>
+              <a:t>Only use the facts in docs/event-facts.md. Never make up dates or places.</a:t>
+            </a:r>
+          </a:p>
+        </p:txBody>
+      </p:sp>
+      <p:sp>
+        <p:nvSpPr>
+          <p:cNvPr id="6" name="TextBox 5"/>
+          <p:cNvSpPr txBox="1"/>
+          <p:nvPr/>
+        </p:nvSpPr>
+        <p:spPr>
+          <a:xfrm>
+            <a:off x="7772400" y="3108960"/>
+            <a:ext cx="3931920" cy="1828800"/>
+          </a:xfrm>
+          <a:prstGeom prst="rect">
+            <a:avLst/>
+          </a:prstGeom>
+          <a:noFill/>
+        </p:spPr>
+        <p:txBody>
+          <a:bodyPr wrap="square">
+            <a:spAutoFit/>
+          </a:bodyPr>
+          <a:lstStyle/>
+          <a:p>
+            <a:pPr>
+              <a:spcAft>
+                <a:spcPts val="1400"/>
+              </a:spcAft>
+            </a:pPr>
+            <a:r>
+              <a:rPr sz="2800" b="0">
+                <a:solidFill>
+                  <a:srgbClr val="64665D"/>
                 </a:solidFill>
                 <a:latin typeface="DM Sans"/>
               </a:rPr>
-              <a:t>•  A markdown file in your project folder</a:t>
-            </a:r>
-          </a:p>
-          <a:p>
-            <a:pPr>
-              <a:spcAft>
-                <a:spcPts val="1600"/>
-              </a:spcAft>
-            </a:pPr>
-            <a:r>
-              <a:rPr sz="2600" b="0">
-                <a:solidFill>
-                  <a:srgbClr val="272A25"/>
-                </a:solidFill>
-                <a:latin typeface="DM Sans"/>
-              </a:rPr>
-              <a:t>•  Coding agents read it at the start of every session</a:t>
-            </a:r>
-          </a:p>
-          <a:p>
-            <a:pPr>
-              <a:spcAft>
-                <a:spcPts val="1600"/>
-              </a:spcAft>
-            </a:pPr>
-            <a:r>
-              <a:rPr sz="2600" b="0">
-                <a:solidFill>
-                  <a:srgbClr val="272A25"/>
-                </a:solidFill>
-                <a:latin typeface="DM Sans"/>
-              </a:rPr>
-              <a:t>•  AGENTS.md: Codex, Cursor, many others · CLAUDE.md: Claude Code</a:t>
-            </a:r>
-          </a:p>
-          <a:p>
-            <a:pPr>
-              <a:spcAft>
-                <a:spcPts val="1600"/>
-              </a:spcAft>
-            </a:pPr>
-            <a:r>
-              <a:rPr sz="2600" b="0">
-                <a:solidFill>
-                  <a:srgbClr val="272A25"/>
-                </a:solidFill>
-                <a:latin typeface="DM Sans"/>
-              </a:rPr>
-              <a:t>•  In a chat app: paste it in, or add it to a Project</a:t>
-            </a:r>
-          </a:p>
-        </p:txBody>
-      </p:sp>
-      <p:sp>
-        <p:nvSpPr>
-          <p:cNvPr id="5" name="TextBox 4"/>
+              <a:t>Plain words. Nothing fancy.</a:t>
+            </a:r>
+          </a:p>
+        </p:txBody>
+      </p:sp>
+      <p:sp>
+        <p:nvSpPr>
+          <p:cNvPr id="7" name="TextBox 6"/>
           <p:cNvSpPr txBox="1"/>
           <p:nvPr/>
         </p:nvSpPr>
@@ -9004,7 +6085,7 @@
                 </a:solidFill>
                 <a:latin typeface="DM Sans"/>
               </a:rPr>
-              <a:t>Week 6 · Demo 1 · Context that sticks        5 / 19</a:t>
+              <a:t>Week 6 · Demo 2 · Context that sticks        5 / 12</a:t>
             </a:r>
           </a:p>
         </p:txBody>
@@ -9112,7 +6193,7 @@
                 </a:solidFill>
                 <a:latin typeface="Fraunces"/>
               </a:rPr>
-              <a:t>What goes in AGENTS.md</a:t>
+              <a:t>Demo 2 · ask again</a:t>
             </a:r>
           </a:p>
         </p:txBody>
@@ -9141,97 +6222,49 @@
           <a:p>
             <a:pPr>
               <a:spcAft>
-                <a:spcPts val="1600"/>
+                <a:spcPts val="2200"/>
               </a:spcAft>
             </a:pPr>
             <a:r>
-              <a:rPr sz="2600" b="0">
+              <a:rPr sz="3000" b="0">
                 <a:solidFill>
                   <a:srgbClr val="272A25"/>
                 </a:solidFill>
                 <a:latin typeface="DM Sans"/>
               </a:rPr>
-              <a:t>•  Who it's for, and what they need</a:t>
+              <a:t>•  Ask about the small project, cold.</a:t>
             </a:r>
           </a:p>
           <a:p>
             <a:pPr>
               <a:spcAft>
-                <a:spcPts val="1600"/>
+                <a:spcPts val="2200"/>
               </a:spcAft>
             </a:pPr>
             <a:r>
-              <a:rPr sz="2600" b="0">
+              <a:rPr sz="3000" b="0">
                 <a:solidFill>
                   <a:srgbClr val="272A25"/>
                 </a:solidFill>
                 <a:latin typeface="DM Sans"/>
               </a:rPr>
-              <a:t>•  What it is, in one sentence</a:t>
+              <a:t>•  Add the short context file. Ask again.</a:t>
             </a:r>
           </a:p>
           <a:p>
             <a:pPr>
               <a:spcAft>
-                <a:spcPts val="1600"/>
+                <a:spcPts val="2200"/>
               </a:spcAft>
             </a:pPr>
             <a:r>
-              <a:rPr sz="2600" b="0">
+              <a:rPr sz="3000" b="0">
                 <a:solidFill>
                   <a:srgbClr val="272A25"/>
                 </a:solidFill>
                 <a:latin typeface="DM Sans"/>
               </a:rPr>
-              <a:t>•  Stack and conventions ("plain HTML, no build step")</a:t>
-            </a:r>
-          </a:p>
-          <a:p>
-            <a:pPr>
-              <a:spcAft>
-                <a:spcPts val="1600"/>
-              </a:spcAft>
-            </a:pPr>
-            <a:r>
-              <a:rPr sz="2600" b="0">
-                <a:solidFill>
-                  <a:srgbClr val="272A25"/>
-                </a:solidFill>
-                <a:latin typeface="DM Sans"/>
-              </a:rPr>
-              <a:t>•  Where the facts live (and "never invent facts")</a:t>
-            </a:r>
-          </a:p>
-          <a:p>
-            <a:pPr>
-              <a:spcAft>
-                <a:spcPts val="1600"/>
-              </a:spcAft>
-            </a:pPr>
-            <a:r>
-              <a:rPr sz="2600" b="0">
-                <a:solidFill>
-                  <a:srgbClr val="272A25"/>
-                </a:solidFill>
-                <a:latin typeface="DM Sans"/>
-              </a:rPr>
-              <a:t>•  What "done" looks like</a:t>
-            </a:r>
-          </a:p>
-          <a:p>
-            <a:pPr>
-              <a:spcAft>
-                <a:spcPts val="1600"/>
-              </a:spcAft>
-            </a:pPr>
-            <a:r>
-              <a:rPr sz="2600" b="0">
-                <a:solidFill>
-                  <a:srgbClr val="272A25"/>
-                </a:solidFill>
-                <a:latin typeface="DM Sans"/>
-              </a:rPr>
-              <a:t>•  Keep it short, true, and secret-free</a:t>
+              <a:t>•  Start a fresh session: does it still know?</a:t>
             </a:r>
           </a:p>
         </p:txBody>
@@ -9270,7 +6303,7 @@
                 </a:solidFill>
                 <a:latin typeface="DM Sans"/>
               </a:rPr>
-              <a:t>Week 6 · Demo 1 · Context that sticks        6 / 19</a:t>
+              <a:t>Week 6 · Demo 2 · Context that sticks        6 / 12</a:t>
             </a:r>
           </a:p>
         </p:txBody>
@@ -9378,7 +6411,7 @@
                 </a:solidFill>
                 <a:latin typeface="Fraunces"/>
               </a:rPr>
-              <a:t>Live demo · the same question, twice</a:t>
+              <a:t>A link someone else can open</a:t>
             </a:r>
           </a:p>
         </p:txBody>
@@ -9460,7 +6493,7 @@
                 </a:solidFill>
                 <a:latin typeface="DejaVu Sans Mono"/>
               </a:rPr>
-              <a:t>1 · Open the project. Ask: “Improve the homepage.”</a:t>
+              <a:t>file:///Users/you/Desktop/index.html</a:t>
             </a:r>
           </a:p>
           <a:p>
@@ -9476,7 +6509,7 @@
                 </a:solidFill>
                 <a:latin typeface="DejaVu Sans Mono"/>
               </a:rPr>
-              <a:t>2 · Write AGENTS.md together (2 min)</a:t>
+              <a:t>Only on your laptop.</a:t>
             </a:r>
           </a:p>
           <a:p>
@@ -9492,7 +6525,7 @@
                 </a:solidFill>
                 <a:latin typeface="DejaVu Sans Mono"/>
               </a:rPr>
-              <a:t>3 · Ask again. Compare.</a:t>
+              <a:t> </a:t>
             </a:r>
           </a:p>
           <a:p>
@@ -9508,7 +6541,7 @@
                 </a:solidFill>
                 <a:latin typeface="DejaVu Sans Mono"/>
               </a:rPr>
-              <a:t>4 · Fresh session: does it still know?</a:t>
+              <a:t>https://you.github.io/project/</a:t>
             </a:r>
           </a:p>
           <a:p>
@@ -9524,7 +6557,7 @@
                 </a:solidFill>
                 <a:latin typeface="DejaVu Sans Mono"/>
               </a:rPr>
-              <a:t>5 · Add an index pointing to docs/</a:t>
+              <a:t>A published website.</a:t>
             </a:r>
           </a:p>
         </p:txBody>
@@ -9563,7 +6596,7 @@
                 </a:solidFill>
                 <a:latin typeface="DM Sans"/>
               </a:rPr>
-              <a:t>Same question. Different context. Different answer.</a:t>
+              <a:t>Your laptop isn’t the internet.</a:t>
             </a:r>
           </a:p>
         </p:txBody>
@@ -9602,7 +6635,7 @@
                 </a:solidFill>
                 <a:latin typeface="DM Sans"/>
               </a:rPr>
-              <a:t>Week 6 · Demo 1 · Context that sticks        7 / 19</a:t>
+              <a:t>Week 6 · Demo 3 · Get it online        7 / 12</a:t>
             </a:r>
           </a:p>
         </p:txBody>
@@ -9710,27 +6743,27 @@
                 </a:solidFill>
                 <a:latin typeface="Fraunces"/>
               </a:rPr>
-              <a:t>A real AGENTS.md (the demo's)</a:t>
-            </a:r>
-          </a:p>
-        </p:txBody>
-      </p:sp>
-      <p:sp>
-        <p:nvSpPr>
-          <p:cNvPr id="4" name="Rectangle 3"/>
+              <a:t>Save. Send. Publish.</a:t>
+            </a:r>
+          </a:p>
+        </p:txBody>
+      </p:sp>
+      <p:sp>
+        <p:nvSpPr>
+          <p:cNvPr id="4" name="Rounded Rectangle 3"/>
           <p:cNvSpPr/>
           <p:nvPr/>
         </p:nvSpPr>
         <p:spPr>
           <a:xfrm>
-            <a:off x="822960" y="1828800"/>
-            <a:ext cx="6583680" cy="4023360"/>
-          </a:xfrm>
-          <a:prstGeom prst="rect">
+            <a:off x="822960" y="2103120"/>
+            <a:ext cx="2377440" cy="1097280"/>
+          </a:xfrm>
+          <a:prstGeom prst="roundRect">
             <a:avLst/>
           </a:prstGeom>
           <a:solidFill>
-            <a:srgbClr val="EEECE2"/>
+            <a:srgbClr val="A83D2B"/>
           </a:solidFill>
           <a:ln>
             <a:noFill/>
@@ -9755,19 +6788,309 @@
           <a:lstStyle/>
           <a:p>
             <a:pPr algn="ctr"/>
-          </a:p>
-        </p:txBody>
-      </p:sp>
-      <p:sp>
-        <p:nvSpPr>
-          <p:cNvPr id="5" name="TextBox 4"/>
+            <a:r>
+              <a:rPr sz="2200" b="1">
+                <a:solidFill>
+                  <a:srgbClr val="FFFFFF"/>
+                </a:solidFill>
+              </a:rPr>
+              <a:t>Folder</a:t>
+            </a:r>
+          </a:p>
+        </p:txBody>
+      </p:sp>
+      <p:sp>
+        <p:nvSpPr>
+          <p:cNvPr id="5" name="Right Arrow 4"/>
+          <p:cNvSpPr/>
+          <p:nvPr/>
+        </p:nvSpPr>
+        <p:spPr>
+          <a:xfrm>
+            <a:off x="3246120" y="2468880"/>
+            <a:ext cx="320040" cy="365760"/>
+          </a:xfrm>
+          <a:prstGeom prst="rightArrow">
+            <a:avLst/>
+          </a:prstGeom>
+          <a:solidFill>
+            <a:srgbClr val="64665D"/>
+          </a:solidFill>
+          <a:ln>
+            <a:noFill/>
+          </a:ln>
+        </p:spPr>
+        <p:style>
+          <a:lnRef idx="1">
+            <a:schemeClr val="accent1"/>
+          </a:lnRef>
+          <a:fillRef idx="3">
+            <a:schemeClr val="accent1"/>
+          </a:fillRef>
+          <a:effectRef idx="2">
+            <a:schemeClr val="accent1"/>
+          </a:effectRef>
+          <a:fontRef idx="minor">
+            <a:schemeClr val="lt1"/>
+          </a:fontRef>
+        </p:style>
+        <p:txBody>
+          <a:bodyPr rtlCol="0" anchor="ctr"/>
+          <a:lstStyle/>
+          <a:p>
+            <a:pPr algn="ctr"/>
+          </a:p>
+        </p:txBody>
+      </p:sp>
+      <p:sp>
+        <p:nvSpPr>
+          <p:cNvPr id="6" name="Rounded Rectangle 5"/>
+          <p:cNvSpPr/>
+          <p:nvPr/>
+        </p:nvSpPr>
+        <p:spPr>
+          <a:xfrm>
+            <a:off x="3611880" y="2103120"/>
+            <a:ext cx="2377440" cy="1097280"/>
+          </a:xfrm>
+          <a:prstGeom prst="roundRect">
+            <a:avLst/>
+          </a:prstGeom>
+          <a:solidFill>
+            <a:srgbClr val="272A25"/>
+          </a:solidFill>
+          <a:ln>
+            <a:noFill/>
+          </a:ln>
+        </p:spPr>
+        <p:style>
+          <a:lnRef idx="1">
+            <a:schemeClr val="accent1"/>
+          </a:lnRef>
+          <a:fillRef idx="3">
+            <a:schemeClr val="accent1"/>
+          </a:fillRef>
+          <a:effectRef idx="2">
+            <a:schemeClr val="accent1"/>
+          </a:effectRef>
+          <a:fontRef idx="minor">
+            <a:schemeClr val="lt1"/>
+          </a:fontRef>
+        </p:style>
+        <p:txBody>
+          <a:bodyPr rtlCol="0" anchor="ctr"/>
+          <a:lstStyle/>
+          <a:p>
+            <a:pPr algn="ctr"/>
+            <a:r>
+              <a:rPr sz="2200" b="1">
+                <a:solidFill>
+                  <a:srgbClr val="FFFFFF"/>
+                </a:solidFill>
+              </a:rPr>
+              <a:t>Commit</a:t>
+            </a:r>
+          </a:p>
+        </p:txBody>
+      </p:sp>
+      <p:sp>
+        <p:nvSpPr>
+          <p:cNvPr id="7" name="Right Arrow 6"/>
+          <p:cNvSpPr/>
+          <p:nvPr/>
+        </p:nvSpPr>
+        <p:spPr>
+          <a:xfrm>
+            <a:off x="6035040" y="2468880"/>
+            <a:ext cx="320040" cy="365760"/>
+          </a:xfrm>
+          <a:prstGeom prst="rightArrow">
+            <a:avLst/>
+          </a:prstGeom>
+          <a:solidFill>
+            <a:srgbClr val="64665D"/>
+          </a:solidFill>
+          <a:ln>
+            <a:noFill/>
+          </a:ln>
+        </p:spPr>
+        <p:style>
+          <a:lnRef idx="1">
+            <a:schemeClr val="accent1"/>
+          </a:lnRef>
+          <a:fillRef idx="3">
+            <a:schemeClr val="accent1"/>
+          </a:fillRef>
+          <a:effectRef idx="2">
+            <a:schemeClr val="accent1"/>
+          </a:effectRef>
+          <a:fontRef idx="minor">
+            <a:schemeClr val="lt1"/>
+          </a:fontRef>
+        </p:style>
+        <p:txBody>
+          <a:bodyPr rtlCol="0" anchor="ctr"/>
+          <a:lstStyle/>
+          <a:p>
+            <a:pPr algn="ctr"/>
+          </a:p>
+        </p:txBody>
+      </p:sp>
+      <p:sp>
+        <p:nvSpPr>
+          <p:cNvPr id="8" name="Rounded Rectangle 7"/>
+          <p:cNvSpPr/>
+          <p:nvPr/>
+        </p:nvSpPr>
+        <p:spPr>
+          <a:xfrm>
+            <a:off x="6400800" y="2103120"/>
+            <a:ext cx="2377440" cy="1097280"/>
+          </a:xfrm>
+          <a:prstGeom prst="roundRect">
+            <a:avLst/>
+          </a:prstGeom>
+          <a:solidFill>
+            <a:srgbClr val="272A25"/>
+          </a:solidFill>
+          <a:ln>
+            <a:noFill/>
+          </a:ln>
+        </p:spPr>
+        <p:style>
+          <a:lnRef idx="1">
+            <a:schemeClr val="accent1"/>
+          </a:lnRef>
+          <a:fillRef idx="3">
+            <a:schemeClr val="accent1"/>
+          </a:fillRef>
+          <a:effectRef idx="2">
+            <a:schemeClr val="accent1"/>
+          </a:effectRef>
+          <a:fontRef idx="minor">
+            <a:schemeClr val="lt1"/>
+          </a:fontRef>
+        </p:style>
+        <p:txBody>
+          <a:bodyPr rtlCol="0" anchor="ctr"/>
+          <a:lstStyle/>
+          <a:p>
+            <a:pPr algn="ctr"/>
+            <a:r>
+              <a:rPr sz="2200" b="1">
+                <a:solidFill>
+                  <a:srgbClr val="FFFFFF"/>
+                </a:solidFill>
+              </a:rPr>
+              <a:t>Push</a:t>
+            </a:r>
+          </a:p>
+        </p:txBody>
+      </p:sp>
+      <p:sp>
+        <p:nvSpPr>
+          <p:cNvPr id="9" name="Right Arrow 8"/>
+          <p:cNvSpPr/>
+          <p:nvPr/>
+        </p:nvSpPr>
+        <p:spPr>
+          <a:xfrm>
+            <a:off x="8823960" y="2468880"/>
+            <a:ext cx="320040" cy="365760"/>
+          </a:xfrm>
+          <a:prstGeom prst="rightArrow">
+            <a:avLst/>
+          </a:prstGeom>
+          <a:solidFill>
+            <a:srgbClr val="64665D"/>
+          </a:solidFill>
+          <a:ln>
+            <a:noFill/>
+          </a:ln>
+        </p:spPr>
+        <p:style>
+          <a:lnRef idx="1">
+            <a:schemeClr val="accent1"/>
+          </a:lnRef>
+          <a:fillRef idx="3">
+            <a:schemeClr val="accent1"/>
+          </a:fillRef>
+          <a:effectRef idx="2">
+            <a:schemeClr val="accent1"/>
+          </a:effectRef>
+          <a:fontRef idx="minor">
+            <a:schemeClr val="lt1"/>
+          </a:fontRef>
+        </p:style>
+        <p:txBody>
+          <a:bodyPr rtlCol="0" anchor="ctr"/>
+          <a:lstStyle/>
+          <a:p>
+            <a:pPr algn="ctr"/>
+          </a:p>
+        </p:txBody>
+      </p:sp>
+      <p:sp>
+        <p:nvSpPr>
+          <p:cNvPr id="10" name="Rounded Rectangle 9"/>
+          <p:cNvSpPr/>
+          <p:nvPr/>
+        </p:nvSpPr>
+        <p:spPr>
+          <a:xfrm>
+            <a:off x="9189720" y="2103120"/>
+            <a:ext cx="2377440" cy="1097280"/>
+          </a:xfrm>
+          <a:prstGeom prst="roundRect">
+            <a:avLst/>
+          </a:prstGeom>
+          <a:solidFill>
+            <a:srgbClr val="272A25"/>
+          </a:solidFill>
+          <a:ln>
+            <a:noFill/>
+          </a:ln>
+        </p:spPr>
+        <p:style>
+          <a:lnRef idx="1">
+            <a:schemeClr val="accent1"/>
+          </a:lnRef>
+          <a:fillRef idx="3">
+            <a:schemeClr val="accent1"/>
+          </a:fillRef>
+          <a:effectRef idx="2">
+            <a:schemeClr val="accent1"/>
+          </a:effectRef>
+          <a:fontRef idx="minor">
+            <a:schemeClr val="lt1"/>
+          </a:fontRef>
+        </p:style>
+        <p:txBody>
+          <a:bodyPr rtlCol="0" anchor="ctr"/>
+          <a:lstStyle/>
+          <a:p>
+            <a:pPr algn="ctr"/>
+            <a:r>
+              <a:rPr sz="2200" b="1">
+                <a:solidFill>
+                  <a:srgbClr val="FFFFFF"/>
+                </a:solidFill>
+              </a:rPr>
+              <a:t>Live link</a:t>
+            </a:r>
+          </a:p>
+        </p:txBody>
+      </p:sp>
+      <p:sp>
+        <p:nvSpPr>
+          <p:cNvPr id="11" name="TextBox 10"/>
           <p:cNvSpPr txBox="1"/>
           <p:nvPr/>
         </p:nvSpPr>
         <p:spPr>
           <a:xfrm>
-            <a:off x="1097280" y="2011680"/>
-            <a:ext cx="6217920" cy="3749039"/>
+            <a:off x="822960" y="3931920"/>
+            <a:ext cx="10607040" cy="2286000"/>
           </a:xfrm>
           <a:prstGeom prst="rect">
             <a:avLst/>
@@ -9782,143 +7105,56 @@
           <a:p>
             <a:pPr>
               <a:spcAft>
-                <a:spcPts val="200"/>
+                <a:spcPts val="1800"/>
               </a:spcAft>
             </a:pPr>
             <a:r>
-              <a:rPr sz="1800" b="0">
+              <a:rPr sz="2800" b="0">
                 <a:solidFill>
                   <a:srgbClr val="272A25"/>
                 </a:solidFill>
-                <a:latin typeface="DejaVu Sans Mono"/>
+                <a:latin typeface="DM Sans"/>
               </a:rPr>
-              <a:t># Hill Plant Swap</a:t>
+              <a:t>•  Commit: a save point on your laptop.</a:t>
             </a:r>
           </a:p>
           <a:p>
             <a:pPr>
               <a:spcAft>
-                <a:spcPts val="200"/>
+                <a:spcPts val="1800"/>
               </a:spcAft>
             </a:pPr>
             <a:r>
-              <a:rPr sz="1800" b="0">
+              <a:rPr sz="2800" b="0">
                 <a:solidFill>
                   <a:srgbClr val="272A25"/>
                 </a:solidFill>
-                <a:latin typeface="DejaVu Sans Mono"/>
+                <a:latin typeface="DM Sans"/>
               </a:rPr>
-              <a:t>Who: first-year students on phones, nervous</a:t>
+              <a:t>•  Push: send it to GitHub.</a:t>
             </a:r>
           </a:p>
           <a:p>
             <a:pPr>
               <a:spcAft>
-                <a:spcPts val="200"/>
+                <a:spcPts val="1800"/>
               </a:spcAft>
             </a:pPr>
             <a:r>
-              <a:rPr sz="1800" b="0">
+              <a:rPr sz="2800" b="0">
                 <a:solidFill>
                   <a:srgbClr val="272A25"/>
-                </a:solidFill>
-                <a:latin typeface="DejaVu Sans Mono"/>
-              </a:rPr>
-              <a:t>What: one page announcing a free monthly swap</a:t>
-            </a:r>
-          </a:p>
-          <a:p>
-            <a:pPr>
-              <a:spcAft>
-                <a:spcPts val="200"/>
-              </a:spcAft>
-            </a:pPr>
-            <a:r>
-              <a:rPr sz="1800" b="0">
-                <a:solidFill>
-                  <a:srgbClr val="272A25"/>
-                </a:solidFill>
-                <a:latin typeface="DejaVu Sans Mono"/>
-              </a:rPr>
-              <a:t>Stack: plain HTML + CSS, no JavaScript</a:t>
-            </a:r>
-          </a:p>
-          <a:p>
-            <a:pPr>
-              <a:spcAft>
-                <a:spcPts val="200"/>
-              </a:spcAft>
-            </a:pPr>
-            <a:r>
-              <a:rPr sz="1800" b="0">
-                <a:solidFill>
-                  <a:srgbClr val="272A25"/>
-                </a:solidFill>
-                <a:latin typeface="DejaVu Sans Mono"/>
-              </a:rPr>
-              <a:t>Facts: only docs/event-facts.md; never invent</a:t>
-            </a:r>
-          </a:p>
-          <a:p>
-            <a:pPr>
-              <a:spcAft>
-                <a:spcPts val="200"/>
-              </a:spcAft>
-            </a:pPr>
-            <a:r>
-              <a:rPr sz="1800" b="0">
-                <a:solidFill>
-                  <a:srgbClr val="272A25"/>
-                </a:solidFill>
-                <a:latin typeface="DejaVu Sans Mono"/>
-              </a:rPr>
-              <a:t>Done: date + place readable at 390px in 10 s</a:t>
-            </a:r>
-          </a:p>
-        </p:txBody>
-      </p:sp>
-      <p:sp>
-        <p:nvSpPr>
-          <p:cNvPr id="6" name="TextBox 5"/>
-          <p:cNvSpPr txBox="1"/>
-          <p:nvPr/>
-        </p:nvSpPr>
-        <p:spPr>
-          <a:xfrm>
-            <a:off x="7772400" y="3108960"/>
-            <a:ext cx="3931920" cy="1828800"/>
-          </a:xfrm>
-          <a:prstGeom prst="rect">
-            <a:avLst/>
-          </a:prstGeom>
-          <a:noFill/>
-        </p:spPr>
-        <p:txBody>
-          <a:bodyPr wrap="square">
-            <a:spAutoFit/>
-          </a:bodyPr>
-          <a:lstStyle/>
-          <a:p>
-            <a:pPr>
-              <a:spcAft>
-                <a:spcPts val="1400"/>
-              </a:spcAft>
-            </a:pPr>
-            <a:r>
-              <a:rPr sz="2800" b="0">
-                <a:solidFill>
-                  <a:srgbClr val="64665D"/>
                 </a:solidFill>
                 <a:latin typeface="DM Sans"/>
               </a:rPr>
-              <a:t>Six lines. Every session starts here.</a:t>
-            </a:r>
-          </a:p>
-        </p:txBody>
-      </p:sp>
-      <p:sp>
-        <p:nvSpPr>
-          <p:cNvPr id="7" name="TextBox 6"/>
+              <a:t>•  Deploy: turn it into a live website.</a:t>
+            </a:r>
+          </a:p>
+        </p:txBody>
+      </p:sp>
+      <p:sp>
+        <p:nvSpPr>
+          <p:cNvPr id="12" name="TextBox 11"/>
           <p:cNvSpPr txBox="1"/>
           <p:nvPr/>
         </p:nvSpPr>
@@ -9950,7 +7186,7 @@
                 </a:solidFill>
                 <a:latin typeface="DM Sans"/>
               </a:rPr>
-              <a:t>Week 6 · Demo 1 · Context that sticks        8 / 19</a:t>
+              <a:t>Week 6 · Demo 3 · Get it online        8 / 12</a:t>
             </a:r>
           </a:p>
         </p:txBody>
@@ -10058,64 +7294,21 @@
                 </a:solidFill>
                 <a:latin typeface="Fraunces"/>
               </a:rPr>
-              <a:t>Index files: a map, not a dump</a:t>
-            </a:r>
-          </a:p>
-        </p:txBody>
-      </p:sp>
-      <p:sp>
-        <p:nvSpPr>
-          <p:cNvPr id="4" name="Rectangle 3"/>
-          <p:cNvSpPr/>
-          <p:nvPr/>
-        </p:nvSpPr>
-        <p:spPr>
-          <a:xfrm>
-            <a:off x="822960" y="1828800"/>
-            <a:ext cx="6583680" cy="4023360"/>
-          </a:xfrm>
-          <a:prstGeom prst="rect">
-            <a:avLst/>
-          </a:prstGeom>
-          <a:solidFill>
-            <a:srgbClr val="EEECE2"/>
-          </a:solidFill>
-          <a:ln>
-            <a:noFill/>
-          </a:ln>
-        </p:spPr>
-        <p:style>
-          <a:lnRef idx="1">
-            <a:schemeClr val="accent1"/>
-          </a:lnRef>
-          <a:fillRef idx="3">
-            <a:schemeClr val="accent1"/>
-          </a:fillRef>
-          <a:effectRef idx="2">
-            <a:schemeClr val="accent1"/>
-          </a:effectRef>
-          <a:fontRef idx="minor">
-            <a:schemeClr val="lt1"/>
-          </a:fontRef>
-        </p:style>
-        <p:txBody>
-          <a:bodyPr rtlCol="0" anchor="ctr"/>
-          <a:lstStyle/>
-          <a:p>
-            <a:pPr algn="ctr"/>
-          </a:p>
-        </p:txBody>
-      </p:sp>
-      <p:sp>
-        <p:nvSpPr>
-          <p:cNvPr id="5" name="TextBox 4"/>
+              <a:t>Demo 3 · getting online</a:t>
+            </a:r>
+          </a:p>
+        </p:txBody>
+      </p:sp>
+      <p:sp>
+        <p:nvSpPr>
+          <p:cNvPr id="4" name="TextBox 3"/>
           <p:cNvSpPr txBox="1"/>
           <p:nvPr/>
         </p:nvSpPr>
         <p:spPr>
           <a:xfrm>
-            <a:off x="1097280" y="2011680"/>
-            <a:ext cx="6217920" cy="3749039"/>
+            <a:off x="822960" y="2011680"/>
+            <a:ext cx="10607040" cy="4206240"/>
           </a:xfrm>
           <a:prstGeom prst="rect">
             <a:avLst/>
@@ -10130,111 +7323,56 @@
           <a:p>
             <a:pPr>
               <a:spcAft>
-                <a:spcPts val="200"/>
+                <a:spcPts val="2200"/>
               </a:spcAft>
             </a:pPr>
             <a:r>
-              <a:rPr sz="1800" b="0">
+              <a:rPr sz="3000" b="0">
                 <a:solidFill>
                   <a:srgbClr val="272A25"/>
                 </a:solidFill>
-                <a:latin typeface="DejaVu Sans Mono"/>
+                <a:latin typeface="DM Sans"/>
               </a:rPr>
-              <a:t>## Where to look</a:t>
+              <a:t>•  GitHub Desktop: create, commit, publish.</a:t>
             </a:r>
           </a:p>
           <a:p>
             <a:pPr>
               <a:spcAft>
-                <a:spcPts val="200"/>
+                <a:spcPts val="2200"/>
               </a:spcAft>
             </a:pPr>
             <a:r>
-              <a:rPr sz="1800" b="0">
+              <a:rPr sz="3000" b="0">
                 <a:solidFill>
                   <a:srgbClr val="272A25"/>
                 </a:solidFill>
-                <a:latin typeface="DejaVu Sans Mono"/>
+                <a:latin typeface="DM Sans"/>
               </a:rPr>
-              <a:t>- docs/event-facts.md: the only source of facts</a:t>
+              <a:t>•  GitHub → Settings → Pages → main → Save.</a:t>
             </a:r>
           </a:p>
           <a:p>
             <a:pPr>
               <a:spcAft>
-                <a:spcPts val="200"/>
+                <a:spcPts val="2200"/>
               </a:spcAft>
             </a:pPr>
             <a:r>
-              <a:rPr sz="1800" b="0">
+              <a:rPr sz="3000" b="0">
                 <a:solidFill>
                   <a:srgbClr val="272A25"/>
-                </a:solidFill>
-                <a:latin typeface="DejaVu Sans Mono"/>
-              </a:rPr>
-              <a:t>- docs/audience.md: who visits</a:t>
-            </a:r>
-          </a:p>
-          <a:p>
-            <a:pPr>
-              <a:spcAft>
-                <a:spcPts val="200"/>
-              </a:spcAft>
-            </a:pPr>
-            <a:r>
-              <a:rPr sz="1800" b="0">
-                <a:solidFill>
-                  <a:srgbClr val="272A25"/>
-                </a:solidFill>
-                <a:latin typeface="DejaVu Sans Mono"/>
-              </a:rPr>
-              <a:t>- research/index.md: interview notes (its own index)</a:t>
-            </a:r>
-          </a:p>
-        </p:txBody>
-      </p:sp>
-      <p:sp>
-        <p:nvSpPr>
-          <p:cNvPr id="6" name="TextBox 5"/>
-          <p:cNvSpPr txBox="1"/>
-          <p:nvPr/>
-        </p:nvSpPr>
-        <p:spPr>
-          <a:xfrm>
-            <a:off x="7772400" y="3108960"/>
-            <a:ext cx="3931920" cy="1828800"/>
-          </a:xfrm>
-          <a:prstGeom prst="rect">
-            <a:avLst/>
-          </a:prstGeom>
-          <a:noFill/>
-        </p:spPr>
-        <p:txBody>
-          <a:bodyPr wrap="square">
-            <a:spAutoFit/>
-          </a:bodyPr>
-          <a:lstStyle/>
-          <a:p>
-            <a:pPr>
-              <a:spcAft>
-                <a:spcPts val="1400"/>
-              </a:spcAft>
-            </a:pPr>
-            <a:r>
-              <a:rPr sz="2800" b="0">
-                <a:solidFill>
-                  <a:srgbClr val="64665D"/>
                 </a:solidFill>
                 <a:latin typeface="DM Sans"/>
               </a:rPr>
-              <a:t>The AI reads the map, then opens only what it needs.</a:t>
-            </a:r>
-          </a:p>
-        </p:txBody>
-      </p:sp>
-      <p:sp>
-        <p:nvSpPr>
-          <p:cNvPr id="7" name="TextBox 6"/>
+              <a:t>•  Open the live link on a phone.</a:t>
+            </a:r>
+          </a:p>
+        </p:txBody>
+      </p:sp>
+      <p:sp>
+        <p:nvSpPr>
+          <p:cNvPr id="5" name="TextBox 4"/>
           <p:cNvSpPr txBox="1"/>
           <p:nvPr/>
         </p:nvSpPr>
@@ -10266,7 +7404,7 @@
                 </a:solidFill>
                 <a:latin typeface="DM Sans"/>
               </a:rPr>
-              <a:t>Week 6 · Demo 1 · Context that sticks        9 / 19</a:t>
+              <a:t>Week 6 · Demo 3 · Get it online        9 / 12</a:t>
             </a:r>
           </a:p>
         </p:txBody>

</xml_diff>

<commit_message>
Week 6 final sequence: slides first, one open Claude conversation, small-group learning builds
</commit_message>
<xml_diff>
--- a/lessons/week-6/_src/week6-lecture.pptx
+++ b/lessons/week-6/_src/week6-lecture.pptx
@@ -17,6 +17,7 @@
     <p:sldId id="265" r:id="rId17"/>
     <p:sldId id="266" r:id="rId18"/>
     <p:sldId id="267" r:id="rId19"/>
+    <p:sldId id="268" r:id="rId20"/>
   </p:sldIdLst>
   <p:sldSz cx="12191695" cy="6858000" type="screen4x3"/>
   <p:notesSz cx="6858000" cy="9144000"/>
@@ -513,7 +514,7 @@
           <a:lstStyle/>
           <a:p>
             <a:r>
-              <a:t>5:05–5:06. Three simple demos: copy the lesson, context that sticks, getting online. No live connector tonight.</a:t>
+              <a:t>5:05–5:06. Teach through the slides first. One open-ended live conversation with Claude at the end, then small-group building. No predetermined build.</a:t>
             </a:r>
           </a:p>
         </p:txBody>
@@ -583,7 +584,7 @@
           <a:lstStyle/>
           <a:p>
             <a:r>
-              <a:t>5:31–5:33. Concept only. Don’t show a server URL or set one up. This week, copying the markdown is the step toward that.</a:t>
+              <a:t>5:22–5:25. Show where the button is without starting the demo yet. The lesson includes this invitation and enough context for the group work.</a:t>
             </a:r>
           </a:p>
         </p:txBody>
@@ -653,7 +654,7 @@
           <a:lstStyle/>
           <a:p>
             <a:r>
-              <a:t>5:33–5:35. Free link on account page. No history? Paste last two submissions. No due date. Then trios 5:35–6:05.</a:t>
+              <a:t>5:25–5:35. Aaron chooses the conversation and any build in the moment. No scripted project or staged before/after. If Claude stalls, discuss what you would ask and move into group work.</a:t>
             </a:r>
           </a:p>
         </p:txBody>
@@ -723,7 +724,77 @@
           <a:lstStyle/>
           <a:p>
             <a:r>
-              <a:t>6:05–7:05. No prescribed pairs or interview exercise. Build, test, help each other as needed. 7:05–7:35 optional studio.</a:t>
+              <a:t>5:35 onward. This is the group-work invitation, not a rigid template. Students choose who to work with, what to learn and what to build. No predefined roles or prescribed file format.</a:t>
+            </a:r>
+          </a:p>
+        </p:txBody>
+      </p:sp>
+      <p:sp>
+        <p:nvSpPr>
+          <p:cNvPr id="4" name="Slide Number Placeholder 3"/>
+          <p:cNvSpPr>
+            <a:spLocks noGrp="1"/>
+          </p:cNvSpPr>
+          <p:nvPr>
+            <p:ph type="sldNum" idx="5" sz="quarter"/>
+          </p:nvPr>
+        </p:nvSpPr>
+        <p:spPr/>
+      </p:sp>
+    </p:spTree>
+  </p:cSld>
+  <p:clrMapOvr>
+    <a:masterClrMapping/>
+  </p:clrMapOvr>
+</p:notes>
+</file>
+
+<file path=ppt/notesSlides/notesSlide13.xml><?xml version="1.0" encoding="utf-8"?>
+<p:notes xmlns:a="http://schemas.openxmlformats.org/drawingml/2006/main" xmlns:p="http://schemas.openxmlformats.org/presentationml/2006/main" xmlns:r="http://schemas.openxmlformats.org/officeDocument/2006/relationships">
+  <p:cSld>
+    <p:spTree>
+      <p:nvGrpSpPr>
+        <p:cNvPr id="1" name=""/>
+        <p:cNvGrpSpPr/>
+        <p:nvPr/>
+      </p:nvGrpSpPr>
+      <p:grpSpPr>
+        <a:xfrm>
+          <a:off x="0" y="0"/>
+          <a:ext cx="0" cy="0"/>
+          <a:chOff x="0" y="0"/>
+          <a:chExt cx="0" cy="0"/>
+        </a:xfrm>
+      </p:grpSpPr>
+      <p:sp>
+        <p:nvSpPr>
+          <p:cNvPr id="2" name="Slide Image Placeholder 1"/>
+          <p:cNvSpPr>
+            <a:spLocks noGrp="1"/>
+          </p:cNvSpPr>
+          <p:nvPr>
+            <p:ph type="sldImg" idx="2"/>
+          </p:nvPr>
+        </p:nvSpPr>
+        <p:spPr/>
+      </p:sp>
+      <p:sp>
+        <p:nvSpPr>
+          <p:cNvPr id="3" name="Notes Placeholder 2"/>
+          <p:cNvSpPr>
+            <a:spLocks noGrp="1"/>
+          </p:cNvSpPr>
+          <p:nvPr>
+            <p:ph type="body" idx="3" sz="quarter"/>
+          </p:nvPr>
+        </p:nvSpPr>
+        <p:spPr/>
+        <p:txBody>
+          <a:bodyPr/>
+          <a:lstStyle/>
+          <a:p>
+            <a:r>
+              <a:t>Group work. Optional nudge: ask your AI what it needs to know about your project and save that context as markdown. If unsure where to start, use the Week 6 Copy button and ask for help choosing a learning idea. Work is not done merely because code runs: check whether it teaches the right thing.</a:t>
             </a:r>
           </a:p>
         </p:txBody>
@@ -793,7 +864,7 @@
           <a:lstStyle/>
           <a:p>
             <a:r>
-              <a:t>5:06–5:11. Open cu.learnvibe.build/lessons/week-6/, click Copy lesson as markdown, paste into a fresh chat. Ask exactly: Teach me this and quiz me. Answer one question. If it stalls, use the real rehearsal output on the demo script page.</a:t>
+              <a:t>5:06–5:08. Students can learn the tools by asking the tools. The answer is a starting point, not an authority.</a:t>
             </a:r>
           </a:p>
         </p:txBody>
@@ -863,7 +934,7 @@
           <a:lstStyle/>
           <a:p>
             <a:r>
-              <a:t>5:11–5:12. Show the raw lesson. Point to # headings and - bullets; no syntax lesson beyond that.</a:t>
+              <a:t>5:08–5:10. Explicit tie: Shipper used her AI as a coach, reflecting on actual projects and learning the next step. Without long chat history, paste your last two submissions or describe what you have tried. The free reading link is in your account. No due date announced.</a:t>
             </a:r>
           </a:p>
         </p:txBody>
@@ -933,7 +1004,7 @@
           <a:lstStyle/>
           <a:p>
             <a:r>
-              <a:t>5:12–5:13. These are ordinary markdown files in your project. Specific support varies by tool; Claude Code reads CLAUDE.md, and our tested installation also found AGENTS.md. No template or prescribed structure. Say what you would tell a new teammate.</a:t>
+              <a:t>5:10–5:12. # marks a heading; - marks a list. The lesson itself is markdown. No technical deep dive.</a:t>
             </a:r>
           </a:p>
         </p:txBody>
@@ -1003,7 +1074,7 @@
           <a:lstStyle/>
           <a:p>
             <a:r>
-              <a:t>5:13–5:15. Write these five lines live as CLAUDE.md. This is one example, not a template. The extra facts help the agent aim at the actual audience.</a:t>
+              <a:t>5:12–5:14. Specific support varies by tool. These are ordinary files with plain words. They help the next session know what you mean without re-explaining everything. No live demo here and no template.</a:t>
             </a:r>
           </a:p>
         </p:txBody>
@@ -1073,7 +1144,7 @@
           <a:lstStyle/>
           <a:p>
             <a:r>
-              <a:t>5:15–5:23. Use Hill Plant Swap. Exact prompt: Improve the homepage. Don’t edit any files: describe the changes you’d make in 6 bullets or fewer. Compare audience, unnecessary RSVP, simplicity. Start a third fresh session: Without reading any files, what is this project, and what should you never do? If delayed, use real captured results on demo script.</a:t>
+              <a:t>5:14–5:16. Read the example as what you would tell a new teammate. The point is persistent context, not a prescribed format.</a:t>
             </a:r>
           </a:p>
         </p:txBody>
@@ -1143,7 +1214,7 @@
           <a:lstStyle/>
           <a:p>
             <a:r>
-              <a:t>5:23–5:24. Local files and localhost links aren’t public. Open the published link on another phone.</a:t>
+              <a:t>5:16–5:18. Commit saves a version locally. Push sends it to GitHub. Deploy publishes a website.</a:t>
             </a:r>
           </a:p>
         </p:txBody>
@@ -1213,7 +1284,7 @@
           <a:lstStyle/>
           <a:p>
             <a:r>
-              <a:t>5:24–5:25. Explain these as three different steps.</a:t>
+              <a:t>5:18–5:20. Plain HTML/CSS: Pages. A framework app may need a different host such as Vercel. The handout is optional detail; all essential concepts are on this slide. No deployment demo tonight.</a:t>
             </a:r>
           </a:p>
         </p:txBody>
@@ -1283,7 +1354,7 @@
           <a:lstStyle/>
           <a:p>
             <a:r>
-              <a:t>5:25–5:31. Use plain-folder zip. Commit first version, publish public repo, Settings Pages main root. If waiting, show pre-deployed Hill Plant Swap. React/Vite/Next app: Vercel instead. Handout covers exact clicks.</a:t>
+              <a:t>5:20–5:22. Concept only; no course connector, server address or setup.</a:t>
             </a:r>
           </a:p>
         </p:txBody>
@@ -4374,7 +4445,7 @@
                 </a:solidFill>
                 <a:latin typeface="Fraunces"/>
               </a:rPr>
-              <a:t>Give your AI something to work with</a:t>
+              <a:t>Learn with your AI</a:t>
             </a:r>
           </a:p>
           <a:p>
@@ -4390,7 +4461,7 @@
                 </a:solidFill>
                 <a:latin typeface="DM Sans"/>
               </a:rPr>
-              <a:t>Context that sticks. A link anyone can open.</a:t>
+              <a:t>Use AI to understand AI. Then build something that helps you learn.</a:t>
             </a:r>
           </a:p>
           <a:p>
@@ -4445,7 +4516,7 @@
                 </a:solidFill>
                 <a:latin typeface="DM Sans"/>
               </a:rPr>
-              <a:t>Week 6 · Opening        1 / 12</a:t>
+              <a:t>Week 6 · Opening        1 / 13</a:t>
             </a:r>
           </a:p>
         </p:txBody>
@@ -4547,13 +4618,13 @@
               </a:spcAft>
             </a:pPr>
             <a:r>
-              <a:rPr sz="4000" b="1">
+              <a:rPr sz="3200" b="1">
                 <a:solidFill>
                   <a:srgbClr val="272A25"/>
                 </a:solidFill>
                 <a:latin typeface="Fraunces"/>
               </a:rPr>
-              <a:t>Next week: your AI reaches your tools</a:t>
+              <a:t>Everything you need is on the Week 6 page</a:t>
             </a:r>
           </a:p>
         </p:txBody>
@@ -4592,7 +4663,7 @@
                 </a:solidFill>
                 <a:latin typeface="DM Sans"/>
               </a:rPr>
-              <a:t>•  API: one program asking another for something.</a:t>
+              <a:t>•  cu.learnvibe.build → Everything for Week 6</a:t>
             </a:r>
           </a:p>
           <a:p>
@@ -4608,7 +4679,7 @@
                 </a:solidFill>
                 <a:latin typeface="DM Sans"/>
               </a:rPr>
-              <a:t>•  Connector: your AI reaches your tools directly.</a:t>
+              <a:t>•  Click “Copy lesson as markdown” → paste into your AI.</a:t>
             </a:r>
           </a:p>
           <a:p>
@@ -4624,7 +4695,7 @@
                 </a:solidFill>
                 <a:latin typeface="DM Sans"/>
               </a:rPr>
-              <a:t>•  Instead of you pasting. Next week we’ll connect.</a:t>
+              <a:t>•  Ask: “Teach me this and quiz me.”</a:t>
             </a:r>
           </a:p>
         </p:txBody>
@@ -4663,7 +4734,7 @@
                 </a:solidFill>
                 <a:latin typeface="DM Sans"/>
               </a:rPr>
-              <a:t>Week 6 · Looking ahead        10 / 12</a:t>
+              <a:t>Week 6 · Learn with AI        10 / 13</a:t>
             </a:r>
           </a:p>
         </p:txBody>
@@ -4771,7 +4842,7 @@
                 </a:solidFill>
                 <a:latin typeface="Fraunces"/>
               </a:rPr>
-              <a:t>This week’s reading: your AI as a coach</a:t>
+              <a:t>One live conversation with Claude</a:t>
             </a:r>
           </a:p>
         </p:txBody>
@@ -4810,7 +4881,7 @@
                 </a:solidFill>
                 <a:latin typeface="DM Sans"/>
               </a:rPr>
-              <a:t>•  Arielle Shipper · How to Get Better at AI by Asking AI</a:t>
+              <a:t>•  Copy the lesson markdown into Claude.</a:t>
             </a:r>
           </a:p>
           <a:p>
@@ -4826,7 +4897,7 @@
                 </a:solidFill>
                 <a:latin typeface="DM Sans"/>
               </a:rPr>
-              <a:t>•  Give your AI examples of how you’ve worked.</a:t>
+              <a:t>•  Talk through what you want to understand.</a:t>
             </a:r>
           </a:p>
           <a:p>
@@ -4842,7 +4913,7 @@
                 </a:solidFill>
                 <a:latin typeface="DM Sans"/>
               </a:rPr>
-              <a:t>•  Ask it to teach you one next step.</a:t>
+              <a:t>•  Maybe ask Claude to build a little thing from that conversation.</a:t>
             </a:r>
           </a:p>
         </p:txBody>
@@ -4881,7 +4952,7 @@
                 </a:solidFill>
                 <a:latin typeface="DM Sans"/>
               </a:rPr>
-              <a:t>Week 6 · Close        11 / 12</a:t>
+              <a:t>Week 6 · Live demo        11 / 13</a:t>
             </a:r>
           </a:p>
         </p:txBody>
@@ -4983,13 +5054,13 @@
               </a:spcAft>
             </a:pPr>
             <a:r>
-              <a:rPr sz="4000" b="1">
+              <a:rPr sz="3200" b="1">
                 <a:solidFill>
                   <a:srgbClr val="272A25"/>
                 </a:solidFill>
                 <a:latin typeface="Fraunces"/>
               </a:rPr>
-              <a:t>Studio: build</a:t>
+              <a:t>In small groups: build something that helps you learn</a:t>
             </a:r>
           </a:p>
         </p:txBody>
@@ -5028,7 +5099,7 @@
                 </a:solidFill>
                 <a:latin typeface="DM Sans"/>
               </a:rPr>
-              <a:t>•  Work on your project.</a:t>
+              <a:t>•  Choose your own topic and approach.</a:t>
             </a:r>
           </a:p>
           <a:p>
@@ -5044,7 +5115,7 @@
                 </a:solidFill>
                 <a:latin typeface="DM Sans"/>
               </a:rPr>
-              <a:t>•  Optional: ask your AI what it needs to know.</a:t>
+              <a:t>•  Try a quiz, interactive explainer, practice tool—or your own idea.</a:t>
             </a:r>
           </a:p>
           <a:p>
@@ -5060,7 +5131,7 @@
                 </a:solidFill>
                 <a:latin typeface="DM Sans"/>
               </a:rPr>
-              <a:t>•  Save that context as a markdown file.</a:t>
+              <a:t>•  Use your AI, test what you build, and show what it helped you learn.</a:t>
             </a:r>
           </a:p>
         </p:txBody>
@@ -5099,7 +5170,225 @@
                 </a:solidFill>
                 <a:latin typeface="DM Sans"/>
               </a:rPr>
-              <a:t>Week 6 · Studio        12 / 12</a:t>
+              <a:t>Week 6 · Group work        12 / 13</a:t>
+            </a:r>
+          </a:p>
+        </p:txBody>
+      </p:sp>
+    </p:spTree>
+  </p:cSld>
+  <p:clrMapOvr>
+    <a:masterClrMapping/>
+  </p:clrMapOvr>
+</p:sld>
+</file>
+
+<file path=ppt/slides/slide13.xml><?xml version="1.0" encoding="utf-8"?>
+<p:sld xmlns:a="http://schemas.openxmlformats.org/drawingml/2006/main" xmlns:p="http://schemas.openxmlformats.org/presentationml/2006/main" xmlns:r="http://schemas.openxmlformats.org/officeDocument/2006/relationships">
+  <p:cSld>
+    <p:bg>
+      <p:bgPr>
+        <a:solidFill>
+          <a:srgbClr val="F7F5EE"/>
+        </a:solidFill>
+        <a:effectLst/>
+      </p:bgPr>
+    </p:bg>
+    <p:spTree>
+      <p:nvGrpSpPr>
+        <p:cNvPr id="1" name=""/>
+        <p:cNvGrpSpPr/>
+        <p:nvPr/>
+      </p:nvGrpSpPr>
+      <p:grpSpPr/>
+      <p:sp>
+        <p:nvSpPr>
+          <p:cNvPr id="2" name="Rectangle 1"/>
+          <p:cNvSpPr/>
+          <p:nvPr/>
+        </p:nvSpPr>
+        <p:spPr>
+          <a:xfrm>
+            <a:off x="0" y="0"/>
+            <a:ext cx="228600" cy="6858000"/>
+          </a:xfrm>
+          <a:prstGeom prst="rect">
+            <a:avLst/>
+          </a:prstGeom>
+          <a:solidFill>
+            <a:srgbClr val="A83D2B"/>
+          </a:solidFill>
+          <a:ln>
+            <a:noFill/>
+          </a:ln>
+        </p:spPr>
+        <p:style>
+          <a:lnRef idx="1">
+            <a:schemeClr val="accent1"/>
+          </a:lnRef>
+          <a:fillRef idx="3">
+            <a:schemeClr val="accent1"/>
+          </a:fillRef>
+          <a:effectRef idx="2">
+            <a:schemeClr val="accent1"/>
+          </a:effectRef>
+          <a:fontRef idx="minor">
+            <a:schemeClr val="lt1"/>
+          </a:fontRef>
+        </p:style>
+        <p:txBody>
+          <a:bodyPr rtlCol="0" anchor="ctr"/>
+          <a:lstStyle/>
+          <a:p>
+            <a:pPr algn="ctr"/>
+          </a:p>
+        </p:txBody>
+      </p:sp>
+      <p:sp>
+        <p:nvSpPr>
+          <p:cNvPr id="3" name="TextBox 2"/>
+          <p:cNvSpPr txBox="1"/>
+          <p:nvPr/>
+        </p:nvSpPr>
+        <p:spPr>
+          <a:xfrm>
+            <a:off x="822960" y="548640"/>
+            <a:ext cx="10607040" cy="1188720"/>
+          </a:xfrm>
+          <a:prstGeom prst="rect">
+            <a:avLst/>
+          </a:prstGeom>
+          <a:noFill/>
+        </p:spPr>
+        <p:txBody>
+          <a:bodyPr wrap="square">
+            <a:spAutoFit/>
+          </a:bodyPr>
+          <a:lstStyle/>
+          <a:p>
+            <a:pPr>
+              <a:spcAft>
+                <a:spcPts val="1400"/>
+              </a:spcAft>
+            </a:pPr>
+            <a:r>
+              <a:rPr sz="4000" b="1">
+                <a:solidFill>
+                  <a:srgbClr val="272A25"/>
+                </a:solidFill>
+                <a:latin typeface="Fraunces"/>
+              </a:rPr>
+              <a:t>Start with a learning question</a:t>
+            </a:r>
+          </a:p>
+        </p:txBody>
+      </p:sp>
+      <p:sp>
+        <p:nvSpPr>
+          <p:cNvPr id="4" name="TextBox 3"/>
+          <p:cNvSpPr txBox="1"/>
+          <p:nvPr/>
+        </p:nvSpPr>
+        <p:spPr>
+          <a:xfrm>
+            <a:off x="822960" y="2011680"/>
+            <a:ext cx="10607040" cy="4206240"/>
+          </a:xfrm>
+          <a:prstGeom prst="rect">
+            <a:avLst/>
+          </a:prstGeom>
+          <a:noFill/>
+        </p:spPr>
+        <p:txBody>
+          <a:bodyPr wrap="square">
+            <a:spAutoFit/>
+          </a:bodyPr>
+          <a:lstStyle/>
+          <a:p>
+            <a:pPr>
+              <a:spcAft>
+                <a:spcPts val="2200"/>
+              </a:spcAft>
+            </a:pPr>
+            <a:r>
+              <a:rPr sz="3000" b="0">
+                <a:solidFill>
+                  <a:srgbClr val="272A25"/>
+                </a:solidFill>
+                <a:latin typeface="DM Sans"/>
+              </a:rPr>
+              <a:t>•  What do you want to understand or practise?</a:t>
+            </a:r>
+          </a:p>
+          <a:p>
+            <a:pPr>
+              <a:spcAft>
+                <a:spcPts val="2200"/>
+              </a:spcAft>
+            </a:pPr>
+            <a:r>
+              <a:rPr sz="3000" b="0">
+                <a:solidFill>
+                  <a:srgbClr val="272A25"/>
+                </a:solidFill>
+                <a:latin typeface="DM Sans"/>
+              </a:rPr>
+              <a:t>•  Give your AI the lesson, your question, or both.</a:t>
+            </a:r>
+          </a:p>
+          <a:p>
+            <a:pPr>
+              <a:spcAft>
+                <a:spcPts val="2200"/>
+              </a:spcAft>
+            </a:pPr>
+            <a:r>
+              <a:rPr sz="3000" b="0">
+                <a:solidFill>
+                  <a:srgbClr val="272A25"/>
+                </a:solidFill>
+                <a:latin typeface="DM Sans"/>
+              </a:rPr>
+              <a:t>•  Build a small first version; try it and revise.</a:t>
+            </a:r>
+          </a:p>
+        </p:txBody>
+      </p:sp>
+      <p:sp>
+        <p:nvSpPr>
+          <p:cNvPr id="5" name="TextBox 4"/>
+          <p:cNvSpPr txBox="1"/>
+          <p:nvPr/>
+        </p:nvSpPr>
+        <p:spPr>
+          <a:xfrm>
+            <a:off x="822960" y="6263640"/>
+            <a:ext cx="10607040" cy="365760"/>
+          </a:xfrm>
+          <a:prstGeom prst="rect">
+            <a:avLst/>
+          </a:prstGeom>
+          <a:noFill/>
+        </p:spPr>
+        <p:txBody>
+          <a:bodyPr wrap="square">
+            <a:spAutoFit/>
+          </a:bodyPr>
+          <a:lstStyle/>
+          <a:p>
+            <a:pPr algn="r">
+              <a:spcAft>
+                <a:spcPts val="1400"/>
+              </a:spcAft>
+            </a:pPr>
+            <a:r>
+              <a:rPr sz="1600" b="0">
+                <a:solidFill>
+                  <a:srgbClr val="64665D"/>
+                </a:solidFill>
+                <a:latin typeface="DM Sans"/>
+              </a:rPr>
+              <a:t>Week 6 · Group work        13 / 13</a:t>
             </a:r>
           </a:p>
         </p:txBody>
@@ -5207,7 +5496,7 @@
                 </a:solidFill>
                 <a:latin typeface="Fraunces"/>
               </a:rPr>
-              <a:t>Demo 1 · copy the lesson</a:t>
+              <a:t>Your AI can help you learn about AI</a:t>
             </a:r>
           </a:p>
         </p:txBody>
@@ -5246,7 +5535,7 @@
                 </a:solidFill>
                 <a:latin typeface="DM Sans"/>
               </a:rPr>
-              <a:t>•  Copy the lesson markdown into your AI.</a:t>
+              <a:t>•  Ask for an explanation at your level.</a:t>
             </a:r>
           </a:p>
           <a:p>
@@ -5262,7 +5551,7 @@
                 </a:solidFill>
                 <a:latin typeface="DM Sans"/>
               </a:rPr>
-              <a:t>•  Ask: “Teach me this and quiz me.”</a:t>
+              <a:t>•  Ask it to quiz you, then explain what you missed.</a:t>
             </a:r>
           </a:p>
           <a:p>
@@ -5278,7 +5567,7 @@
                 </a:solidFill>
                 <a:latin typeface="DM Sans"/>
               </a:rPr>
-              <a:t>•  Check its explanation against the lesson.</a:t>
+              <a:t>•  Check its claims against the material you gave it.</a:t>
             </a:r>
           </a:p>
         </p:txBody>
@@ -5317,7 +5606,7 @@
                 </a:solidFill>
                 <a:latin typeface="DM Sans"/>
               </a:rPr>
-              <a:t>Week 6 · Demo 1 · Learn with your AI        2 / 12</a:t>
+              <a:t>Week 6 · Learn with AI        2 / 13</a:t>
             </a:r>
           </a:p>
         </p:txBody>
@@ -5425,7 +5714,7 @@
                 </a:solidFill>
                 <a:latin typeface="Fraunces"/>
               </a:rPr>
-              <a:t>Markdown is just a text file</a:t>
+              <a:t>This week’s reading: your AI as a coach</a:t>
             </a:r>
           </a:p>
         </p:txBody>
@@ -5464,7 +5753,7 @@
                 </a:solidFill>
                 <a:latin typeface="DM Sans"/>
               </a:rPr>
-              <a:t>•  A .md file is plain text, with headings and lists.</a:t>
+              <a:t>•  Arielle Shipper · How to Get Better at AI by Asking AI</a:t>
             </a:r>
           </a:p>
           <a:p>
@@ -5480,7 +5769,7 @@
                 </a:solidFill>
                 <a:latin typeface="DM Sans"/>
               </a:rPr>
-              <a:t>•  You can read it. Your AI can read it.</a:t>
+              <a:t>•  Use examples of your own work to ask: “What should I learn next?”</a:t>
             </a:r>
           </a:p>
           <a:p>
@@ -5496,7 +5785,7 @@
                 </a:solidFill>
                 <a:latin typeface="DM Sans"/>
               </a:rPr>
-              <a:t>•  Context can live in a file instead of your memory.</a:t>
+              <a:t>•  Then: “Teach me that next step.”</a:t>
             </a:r>
           </a:p>
         </p:txBody>
@@ -5535,7 +5824,7 @@
                 </a:solidFill>
                 <a:latin typeface="DM Sans"/>
               </a:rPr>
-              <a:t>Week 6 · Demo 2 · Context that sticks        3 / 12</a:t>
+              <a:t>Week 6 · Learn with AI        3 / 13</a:t>
             </a:r>
           </a:p>
         </p:txBody>
@@ -5643,7 +5932,7 @@
                 </a:solidFill>
                 <a:latin typeface="Fraunces"/>
               </a:rPr>
-              <a:t>Context that sticks</a:t>
+              <a:t>Markdown is just a text file</a:t>
             </a:r>
           </a:p>
         </p:txBody>
@@ -5682,7 +5971,7 @@
                 </a:solidFill>
                 <a:latin typeface="DM Sans"/>
               </a:rPr>
-              <a:t>•  Claude Code loads CLAUDE.md at session start.</a:t>
+              <a:t>•  A .md file is plain text, with headings and lists.</a:t>
             </a:r>
           </a:p>
           <a:p>
@@ -5698,7 +5987,7 @@
                 </a:solidFill>
                 <a:latin typeface="DM Sans"/>
               </a:rPr>
-              <a:t>•  Cursor and other coding tools can load AGENTS.md.</a:t>
+              <a:t>•  You can read it. Your AI can read it.</a:t>
             </a:r>
           </a:p>
           <a:p>
@@ -5714,7 +6003,7 @@
                 </a:solidFill>
                 <a:latin typeface="DM Sans"/>
               </a:rPr>
-              <a:t>•  In a chat app: paste the file or add it to a Project.</a:t>
+              <a:t>•  A lesson or project context can live in that file.</a:t>
             </a:r>
           </a:p>
         </p:txBody>
@@ -5753,7 +6042,7 @@
                 </a:solidFill>
                 <a:latin typeface="DM Sans"/>
               </a:rPr>
-              <a:t>Week 6 · Demo 2 · Context that sticks        4 / 12</a:t>
+              <a:t>Week 6 · Context        4 / 13</a:t>
             </a:r>
           </a:p>
         </p:txBody>
@@ -5861,64 +6150,21 @@
                 </a:solidFill>
                 <a:latin typeface="Fraunces"/>
               </a:rPr>
-              <a:t>One small example</a:t>
-            </a:r>
-          </a:p>
-        </p:txBody>
-      </p:sp>
-      <p:sp>
-        <p:nvSpPr>
-          <p:cNvPr id="4" name="Rectangle 3"/>
-          <p:cNvSpPr/>
-          <p:nvPr/>
-        </p:nvSpPr>
-        <p:spPr>
-          <a:xfrm>
-            <a:off x="822960" y="1828800"/>
-            <a:ext cx="6583680" cy="4023360"/>
-          </a:xfrm>
-          <a:prstGeom prst="rect">
-            <a:avLst/>
-          </a:prstGeom>
-          <a:solidFill>
-            <a:srgbClr val="EEECE2"/>
-          </a:solidFill>
-          <a:ln>
-            <a:noFill/>
-          </a:ln>
-        </p:spPr>
-        <p:style>
-          <a:lnRef idx="1">
-            <a:schemeClr val="accent1"/>
-          </a:lnRef>
-          <a:fillRef idx="3">
-            <a:schemeClr val="accent1"/>
-          </a:fillRef>
-          <a:effectRef idx="2">
-            <a:schemeClr val="accent1"/>
-          </a:effectRef>
-          <a:fontRef idx="minor">
-            <a:schemeClr val="lt1"/>
-          </a:fontRef>
-        </p:style>
-        <p:txBody>
-          <a:bodyPr rtlCol="0" anchor="ctr"/>
-          <a:lstStyle/>
-          <a:p>
-            <a:pPr algn="ctr"/>
-          </a:p>
-        </p:txBody>
-      </p:sp>
-      <p:sp>
-        <p:nvSpPr>
-          <p:cNvPr id="5" name="TextBox 4"/>
+              <a:t>Context that sticks</a:t>
+            </a:r>
+          </a:p>
+        </p:txBody>
+      </p:sp>
+      <p:sp>
+        <p:nvSpPr>
+          <p:cNvPr id="4" name="TextBox 3"/>
           <p:cNvSpPr txBox="1"/>
           <p:nvPr/>
         </p:nvSpPr>
         <p:spPr>
           <a:xfrm>
-            <a:off x="1097280" y="2011680"/>
-            <a:ext cx="6217920" cy="3749039"/>
+            <a:off x="822960" y="2011680"/>
+            <a:ext cx="10607040" cy="4206240"/>
           </a:xfrm>
           <a:prstGeom prst="rect">
             <a:avLst/>
@@ -5933,127 +6179,56 @@
           <a:p>
             <a:pPr>
               <a:spcAft>
-                <a:spcPts val="200"/>
+                <a:spcPts val="2200"/>
               </a:spcAft>
             </a:pPr>
             <a:r>
-              <a:rPr sz="1800" b="0">
+              <a:rPr sz="3000" b="0">
                 <a:solidFill>
                   <a:srgbClr val="272A25"/>
                 </a:solidFill>
-                <a:latin typeface="DejaVu Sans Mono"/>
+                <a:latin typeface="DM Sans"/>
               </a:rPr>
-              <a:t># Hill Plant Swap</a:t>
+              <a:t>•  Claude Code loads CLAUDE.md at session start.</a:t>
             </a:r>
           </a:p>
           <a:p>
             <a:pPr>
               <a:spcAft>
-                <a:spcPts val="200"/>
+                <a:spcPts val="2200"/>
               </a:spcAft>
             </a:pPr>
             <a:r>
-              <a:rPr sz="1800" b="0">
+              <a:rPr sz="3000" b="0">
                 <a:solidFill>
                   <a:srgbClr val="272A25"/>
                 </a:solidFill>
-                <a:latin typeface="DejaVu Sans Mono"/>
+                <a:latin typeface="DM Sans"/>
               </a:rPr>
-              <a:t>A one-page website for a free monthly plant swap on the Hill, near CU.</a:t>
+              <a:t>•  Cursor and other coding tools can load AGENTS.md.</a:t>
             </a:r>
           </a:p>
           <a:p>
             <a:pPr>
               <a:spcAft>
-                <a:spcPts val="200"/>
+                <a:spcPts val="2200"/>
               </a:spcAft>
             </a:pPr>
             <a:r>
-              <a:rPr sz="1800" b="0">
+              <a:rPr sz="3000" b="0">
                 <a:solidFill>
                   <a:srgbClr val="272A25"/>
-                </a:solidFill>
-                <a:latin typeface="DejaVu Sans Mono"/>
-              </a:rPr>
-              <a:t>It's for first-year students who are nervous about going.</a:t>
-            </a:r>
-          </a:p>
-          <a:p>
-            <a:pPr>
-              <a:spcAft>
-                <a:spcPts val="200"/>
-              </a:spcAft>
-            </a:pPr>
-            <a:r>
-              <a:rPr sz="1800" b="0">
-                <a:solidFill>
-                  <a:srgbClr val="272A25"/>
-                </a:solidFill>
-                <a:latin typeface="DejaVu Sans Mono"/>
-              </a:rPr>
-              <a:t>Keep it plain HTML and CSS. No JavaScript.</a:t>
-            </a:r>
-          </a:p>
-          <a:p>
-            <a:pPr>
-              <a:spcAft>
-                <a:spcPts val="200"/>
-              </a:spcAft>
-            </a:pPr>
-            <a:r>
-              <a:rPr sz="1800" b="0">
-                <a:solidFill>
-                  <a:srgbClr val="272A25"/>
-                </a:solidFill>
-                <a:latin typeface="DejaVu Sans Mono"/>
-              </a:rPr>
-              <a:t>Only use the facts in docs/event-facts.md. Never make up dates or places.</a:t>
-            </a:r>
-          </a:p>
-        </p:txBody>
-      </p:sp>
-      <p:sp>
-        <p:nvSpPr>
-          <p:cNvPr id="6" name="TextBox 5"/>
-          <p:cNvSpPr txBox="1"/>
-          <p:nvPr/>
-        </p:nvSpPr>
-        <p:spPr>
-          <a:xfrm>
-            <a:off x="7772400" y="3108960"/>
-            <a:ext cx="3931920" cy="1828800"/>
-          </a:xfrm>
-          <a:prstGeom prst="rect">
-            <a:avLst/>
-          </a:prstGeom>
-          <a:noFill/>
-        </p:spPr>
-        <p:txBody>
-          <a:bodyPr wrap="square">
-            <a:spAutoFit/>
-          </a:bodyPr>
-          <a:lstStyle/>
-          <a:p>
-            <a:pPr>
-              <a:spcAft>
-                <a:spcPts val="1400"/>
-              </a:spcAft>
-            </a:pPr>
-            <a:r>
-              <a:rPr sz="2800" b="0">
-                <a:solidFill>
-                  <a:srgbClr val="64665D"/>
                 </a:solidFill>
                 <a:latin typeface="DM Sans"/>
               </a:rPr>
-              <a:t>Plain words. Nothing fancy.</a:t>
-            </a:r>
-          </a:p>
-        </p:txBody>
-      </p:sp>
-      <p:sp>
-        <p:nvSpPr>
-          <p:cNvPr id="7" name="TextBox 6"/>
+              <a:t>•  In a chat app: paste the file or add it to a Project.</a:t>
+            </a:r>
+          </a:p>
+        </p:txBody>
+      </p:sp>
+      <p:sp>
+        <p:nvSpPr>
+          <p:cNvPr id="5" name="TextBox 4"/>
           <p:cNvSpPr txBox="1"/>
           <p:nvPr/>
         </p:nvSpPr>
@@ -6085,7 +6260,7 @@
                 </a:solidFill>
                 <a:latin typeface="DM Sans"/>
               </a:rPr>
-              <a:t>Week 6 · Demo 2 · Context that sticks        5 / 12</a:t>
+              <a:t>Week 6 · Context        5 / 13</a:t>
             </a:r>
           </a:p>
         </p:txBody>
@@ -6193,21 +6368,64 @@
                 </a:solidFill>
                 <a:latin typeface="Fraunces"/>
               </a:rPr>
-              <a:t>Demo 2 · ask again</a:t>
-            </a:r>
-          </a:p>
-        </p:txBody>
-      </p:sp>
-      <p:sp>
-        <p:nvSpPr>
-          <p:cNvPr id="4" name="TextBox 3"/>
+              <a:t>One small example</a:t>
+            </a:r>
+          </a:p>
+        </p:txBody>
+      </p:sp>
+      <p:sp>
+        <p:nvSpPr>
+          <p:cNvPr id="4" name="Rectangle 3"/>
+          <p:cNvSpPr/>
+          <p:nvPr/>
+        </p:nvSpPr>
+        <p:spPr>
+          <a:xfrm>
+            <a:off x="822960" y="1828800"/>
+            <a:ext cx="6583680" cy="4023360"/>
+          </a:xfrm>
+          <a:prstGeom prst="rect">
+            <a:avLst/>
+          </a:prstGeom>
+          <a:solidFill>
+            <a:srgbClr val="EEECE2"/>
+          </a:solidFill>
+          <a:ln>
+            <a:noFill/>
+          </a:ln>
+        </p:spPr>
+        <p:style>
+          <a:lnRef idx="1">
+            <a:schemeClr val="accent1"/>
+          </a:lnRef>
+          <a:fillRef idx="3">
+            <a:schemeClr val="accent1"/>
+          </a:fillRef>
+          <a:effectRef idx="2">
+            <a:schemeClr val="accent1"/>
+          </a:effectRef>
+          <a:fontRef idx="minor">
+            <a:schemeClr val="lt1"/>
+          </a:fontRef>
+        </p:style>
+        <p:txBody>
+          <a:bodyPr rtlCol="0" anchor="ctr"/>
+          <a:lstStyle/>
+          <a:p>
+            <a:pPr algn="ctr"/>
+          </a:p>
+        </p:txBody>
+      </p:sp>
+      <p:sp>
+        <p:nvSpPr>
+          <p:cNvPr id="5" name="TextBox 4"/>
           <p:cNvSpPr txBox="1"/>
           <p:nvPr/>
         </p:nvSpPr>
         <p:spPr>
           <a:xfrm>
-            <a:off x="822960" y="2011680"/>
-            <a:ext cx="10607040" cy="4206240"/>
+            <a:off x="1097280" y="2011680"/>
+            <a:ext cx="6217920" cy="3749039"/>
           </a:xfrm>
           <a:prstGeom prst="rect">
             <a:avLst/>
@@ -6222,56 +6440,127 @@
           <a:p>
             <a:pPr>
               <a:spcAft>
-                <a:spcPts val="2200"/>
+                <a:spcPts val="200"/>
               </a:spcAft>
             </a:pPr>
             <a:r>
-              <a:rPr sz="3000" b="0">
+              <a:rPr sz="1800" b="0">
                 <a:solidFill>
                   <a:srgbClr val="272A25"/>
+                </a:solidFill>
+                <a:latin typeface="DejaVu Sans Mono"/>
+              </a:rPr>
+              <a:t># Hill Plant Swap</a:t>
+            </a:r>
+          </a:p>
+          <a:p>
+            <a:pPr>
+              <a:spcAft>
+                <a:spcPts val="200"/>
+              </a:spcAft>
+            </a:pPr>
+            <a:r>
+              <a:rPr sz="1800" b="0">
+                <a:solidFill>
+                  <a:srgbClr val="272A25"/>
+                </a:solidFill>
+                <a:latin typeface="DejaVu Sans Mono"/>
+              </a:rPr>
+              <a:t>A one-page website for a free plant swap near CU.</a:t>
+            </a:r>
+          </a:p>
+          <a:p>
+            <a:pPr>
+              <a:spcAft>
+                <a:spcPts val="200"/>
+              </a:spcAft>
+            </a:pPr>
+            <a:r>
+              <a:rPr sz="1800" b="0">
+                <a:solidFill>
+                  <a:srgbClr val="272A25"/>
+                </a:solidFill>
+                <a:latin typeface="DejaVu Sans Mono"/>
+              </a:rPr>
+              <a:t>For first-year students who are nervous about going.</a:t>
+            </a:r>
+          </a:p>
+          <a:p>
+            <a:pPr>
+              <a:spcAft>
+                <a:spcPts val="200"/>
+              </a:spcAft>
+            </a:pPr>
+            <a:r>
+              <a:rPr sz="1800" b="0">
+                <a:solidFill>
+                  <a:srgbClr val="272A25"/>
+                </a:solidFill>
+                <a:latin typeface="DejaVu Sans Mono"/>
+              </a:rPr>
+              <a:t>Keep it plain HTML and CSS. No JavaScript.</a:t>
+            </a:r>
+          </a:p>
+          <a:p>
+            <a:pPr>
+              <a:spcAft>
+                <a:spcPts val="200"/>
+              </a:spcAft>
+            </a:pPr>
+            <a:r>
+              <a:rPr sz="1800" b="0">
+                <a:solidFill>
+                  <a:srgbClr val="272A25"/>
+                </a:solidFill>
+                <a:latin typeface="DejaVu Sans Mono"/>
+              </a:rPr>
+              <a:t>Use docs/event-facts.md. Never make up dates.</a:t>
+            </a:r>
+          </a:p>
+        </p:txBody>
+      </p:sp>
+      <p:sp>
+        <p:nvSpPr>
+          <p:cNvPr id="6" name="TextBox 5"/>
+          <p:cNvSpPr txBox="1"/>
+          <p:nvPr/>
+        </p:nvSpPr>
+        <p:spPr>
+          <a:xfrm>
+            <a:off x="7772400" y="3108960"/>
+            <a:ext cx="3931920" cy="1828800"/>
+          </a:xfrm>
+          <a:prstGeom prst="rect">
+            <a:avLst/>
+          </a:prstGeom>
+          <a:noFill/>
+        </p:spPr>
+        <p:txBody>
+          <a:bodyPr wrap="square">
+            <a:spAutoFit/>
+          </a:bodyPr>
+          <a:lstStyle/>
+          <a:p>
+            <a:pPr>
+              <a:spcAft>
+                <a:spcPts val="1400"/>
+              </a:spcAft>
+            </a:pPr>
+            <a:r>
+              <a:rPr sz="2800" b="0">
+                <a:solidFill>
+                  <a:srgbClr val="64665D"/>
                 </a:solidFill>
                 <a:latin typeface="DM Sans"/>
               </a:rPr>
-              <a:t>•  Ask about the small project, cold.</a:t>
-            </a:r>
-          </a:p>
-          <a:p>
-            <a:pPr>
-              <a:spcAft>
-                <a:spcPts val="2200"/>
-              </a:spcAft>
-            </a:pPr>
-            <a:r>
-              <a:rPr sz="3000" b="0">
-                <a:solidFill>
-                  <a:srgbClr val="272A25"/>
-                </a:solidFill>
-                <a:latin typeface="DM Sans"/>
-              </a:rPr>
-              <a:t>•  Add the short context file. Ask again.</a:t>
-            </a:r>
-          </a:p>
-          <a:p>
-            <a:pPr>
-              <a:spcAft>
-                <a:spcPts val="2200"/>
-              </a:spcAft>
-            </a:pPr>
-            <a:r>
-              <a:rPr sz="3000" b="0">
-                <a:solidFill>
-                  <a:srgbClr val="272A25"/>
-                </a:solidFill>
-                <a:latin typeface="DM Sans"/>
-              </a:rPr>
-              <a:t>•  Start a fresh session: does it still know?</a:t>
-            </a:r>
-          </a:p>
-        </p:txBody>
-      </p:sp>
-      <p:sp>
-        <p:nvSpPr>
-          <p:cNvPr id="5" name="TextBox 4"/>
+              <a:t>Plain words. Nothing fancy.</a:t>
+            </a:r>
+          </a:p>
+        </p:txBody>
+      </p:sp>
+      <p:sp>
+        <p:nvSpPr>
+          <p:cNvPr id="7" name="TextBox 6"/>
           <p:cNvSpPr txBox="1"/>
           <p:nvPr/>
         </p:nvSpPr>
@@ -6303,7 +6592,7 @@
                 </a:solidFill>
                 <a:latin typeface="DM Sans"/>
               </a:rPr>
-              <a:t>Week 6 · Demo 2 · Context that sticks        6 / 12</a:t>
+              <a:t>Week 6 · Context        6 / 13</a:t>
             </a:r>
           </a:p>
         </p:txBody>
@@ -6418,57 +6707,14 @@
       </p:sp>
       <p:sp>
         <p:nvSpPr>
-          <p:cNvPr id="4" name="Rectangle 3"/>
-          <p:cNvSpPr/>
-          <p:nvPr/>
-        </p:nvSpPr>
-        <p:spPr>
-          <a:xfrm>
-            <a:off x="822960" y="1828800"/>
-            <a:ext cx="6583680" cy="4023360"/>
-          </a:xfrm>
-          <a:prstGeom prst="rect">
-            <a:avLst/>
-          </a:prstGeom>
-          <a:solidFill>
-            <a:srgbClr val="EEECE2"/>
-          </a:solidFill>
-          <a:ln>
-            <a:noFill/>
-          </a:ln>
-        </p:spPr>
-        <p:style>
-          <a:lnRef idx="1">
-            <a:schemeClr val="accent1"/>
-          </a:lnRef>
-          <a:fillRef idx="3">
-            <a:schemeClr val="accent1"/>
-          </a:fillRef>
-          <a:effectRef idx="2">
-            <a:schemeClr val="accent1"/>
-          </a:effectRef>
-          <a:fontRef idx="minor">
-            <a:schemeClr val="lt1"/>
-          </a:fontRef>
-        </p:style>
-        <p:txBody>
-          <a:bodyPr rtlCol="0" anchor="ctr"/>
-          <a:lstStyle/>
-          <a:p>
-            <a:pPr algn="ctr"/>
-          </a:p>
-        </p:txBody>
-      </p:sp>
-      <p:sp>
-        <p:nvSpPr>
-          <p:cNvPr id="5" name="TextBox 4"/>
+          <p:cNvPr id="4" name="TextBox 3"/>
           <p:cNvSpPr txBox="1"/>
           <p:nvPr/>
         </p:nvSpPr>
         <p:spPr>
           <a:xfrm>
-            <a:off x="1097280" y="2011680"/>
-            <a:ext cx="6217920" cy="3749039"/>
+            <a:off x="822960" y="2011680"/>
+            <a:ext cx="10607040" cy="4206240"/>
           </a:xfrm>
           <a:prstGeom prst="rect">
             <a:avLst/>
@@ -6483,127 +6729,56 @@
           <a:p>
             <a:pPr>
               <a:spcAft>
-                <a:spcPts val="200"/>
+                <a:spcPts val="2200"/>
               </a:spcAft>
             </a:pPr>
             <a:r>
-              <a:rPr sz="1800" b="0">
+              <a:rPr sz="3000" b="0">
                 <a:solidFill>
                   <a:srgbClr val="272A25"/>
                 </a:solidFill>
-                <a:latin typeface="DejaVu Sans Mono"/>
+                <a:latin typeface="DM Sans"/>
               </a:rPr>
-              <a:t>file:///Users/you/Desktop/index.html</a:t>
+              <a:t>•  file:// and localhost links only work on your computer.</a:t>
             </a:r>
           </a:p>
           <a:p>
             <a:pPr>
               <a:spcAft>
-                <a:spcPts val="200"/>
+                <a:spcPts val="2200"/>
               </a:spcAft>
             </a:pPr>
             <a:r>
-              <a:rPr sz="1800" b="0">
+              <a:rPr sz="3000" b="0">
                 <a:solidFill>
                   <a:srgbClr val="272A25"/>
                 </a:solidFill>
-                <a:latin typeface="DejaVu Sans Mono"/>
+                <a:latin typeface="DM Sans"/>
               </a:rPr>
-              <a:t>Only on your laptop.</a:t>
+              <a:t>•  A public HTTPS link works on someone else’s phone.</a:t>
             </a:r>
           </a:p>
           <a:p>
             <a:pPr>
               <a:spcAft>
-                <a:spcPts val="200"/>
+                <a:spcPts val="2200"/>
               </a:spcAft>
             </a:pPr>
             <a:r>
-              <a:rPr sz="1800" b="0">
+              <a:rPr sz="3000" b="0">
                 <a:solidFill>
                   <a:srgbClr val="272A25"/>
-                </a:solidFill>
-                <a:latin typeface="DejaVu Sans Mono"/>
-              </a:rPr>
-              <a:t> </a:t>
-            </a:r>
-          </a:p>
-          <a:p>
-            <a:pPr>
-              <a:spcAft>
-                <a:spcPts val="200"/>
-              </a:spcAft>
-            </a:pPr>
-            <a:r>
-              <a:rPr sz="1800" b="0">
-                <a:solidFill>
-                  <a:srgbClr val="272A25"/>
-                </a:solidFill>
-                <a:latin typeface="DejaVu Sans Mono"/>
-              </a:rPr>
-              <a:t>https://you.github.io/project/</a:t>
-            </a:r>
-          </a:p>
-          <a:p>
-            <a:pPr>
-              <a:spcAft>
-                <a:spcPts val="200"/>
-              </a:spcAft>
-            </a:pPr>
-            <a:r>
-              <a:rPr sz="1800" b="0">
-                <a:solidFill>
-                  <a:srgbClr val="272A25"/>
-                </a:solidFill>
-                <a:latin typeface="DejaVu Sans Mono"/>
-              </a:rPr>
-              <a:t>A published website.</a:t>
-            </a:r>
-          </a:p>
-        </p:txBody>
-      </p:sp>
-      <p:sp>
-        <p:nvSpPr>
-          <p:cNvPr id="6" name="TextBox 5"/>
-          <p:cNvSpPr txBox="1"/>
-          <p:nvPr/>
-        </p:nvSpPr>
-        <p:spPr>
-          <a:xfrm>
-            <a:off x="7772400" y="3108960"/>
-            <a:ext cx="3931920" cy="1828800"/>
-          </a:xfrm>
-          <a:prstGeom prst="rect">
-            <a:avLst/>
-          </a:prstGeom>
-          <a:noFill/>
-        </p:spPr>
-        <p:txBody>
-          <a:bodyPr wrap="square">
-            <a:spAutoFit/>
-          </a:bodyPr>
-          <a:lstStyle/>
-          <a:p>
-            <a:pPr>
-              <a:spcAft>
-                <a:spcPts val="1400"/>
-              </a:spcAft>
-            </a:pPr>
-            <a:r>
-              <a:rPr sz="2800" b="0">
-                <a:solidFill>
-                  <a:srgbClr val="64665D"/>
                 </a:solidFill>
                 <a:latin typeface="DM Sans"/>
               </a:rPr>
-              <a:t>Your laptop isn’t the internet.</a:t>
-            </a:r>
-          </a:p>
-        </p:txBody>
-      </p:sp>
-      <p:sp>
-        <p:nvSpPr>
-          <p:cNvPr id="7" name="TextBox 6"/>
+              <a:t>•  Commit → push → deploy are three different steps.</a:t>
+            </a:r>
+          </a:p>
+        </p:txBody>
+      </p:sp>
+      <p:sp>
+        <p:nvSpPr>
+          <p:cNvPr id="5" name="TextBox 4"/>
           <p:cNvSpPr txBox="1"/>
           <p:nvPr/>
         </p:nvSpPr>
@@ -6635,7 +6810,7 @@
                 </a:solidFill>
                 <a:latin typeface="DM Sans"/>
               </a:rPr>
-              <a:t>Week 6 · Demo 3 · Get it online        7 / 12</a:t>
+              <a:t>Week 6 · Getting online        7 / 13</a:t>
             </a:r>
           </a:p>
         </p:txBody>
@@ -6743,354 +6918,21 @@
                 </a:solidFill>
                 <a:latin typeface="Fraunces"/>
               </a:rPr>
-              <a:t>Save. Send. Publish.</a:t>
-            </a:r>
-          </a:p>
-        </p:txBody>
-      </p:sp>
-      <p:sp>
-        <p:nvSpPr>
-          <p:cNvPr id="4" name="Rounded Rectangle 3"/>
-          <p:cNvSpPr/>
-          <p:nvPr/>
-        </p:nvSpPr>
-        <p:spPr>
-          <a:xfrm>
-            <a:off x="822960" y="2103120"/>
-            <a:ext cx="2377440" cy="1097280"/>
-          </a:xfrm>
-          <a:prstGeom prst="roundRect">
-            <a:avLst/>
-          </a:prstGeom>
-          <a:solidFill>
-            <a:srgbClr val="A83D2B"/>
-          </a:solidFill>
-          <a:ln>
-            <a:noFill/>
-          </a:ln>
-        </p:spPr>
-        <p:style>
-          <a:lnRef idx="1">
-            <a:schemeClr val="accent1"/>
-          </a:lnRef>
-          <a:fillRef idx="3">
-            <a:schemeClr val="accent1"/>
-          </a:fillRef>
-          <a:effectRef idx="2">
-            <a:schemeClr val="accent1"/>
-          </a:effectRef>
-          <a:fontRef idx="minor">
-            <a:schemeClr val="lt1"/>
-          </a:fontRef>
-        </p:style>
-        <p:txBody>
-          <a:bodyPr rtlCol="0" anchor="ctr"/>
-          <a:lstStyle/>
-          <a:p>
-            <a:pPr algn="ctr"/>
-            <a:r>
-              <a:rPr sz="2200" b="1">
-                <a:solidFill>
-                  <a:srgbClr val="FFFFFF"/>
-                </a:solidFill>
-              </a:rPr>
-              <a:t>Folder</a:t>
-            </a:r>
-          </a:p>
-        </p:txBody>
-      </p:sp>
-      <p:sp>
-        <p:nvSpPr>
-          <p:cNvPr id="5" name="Right Arrow 4"/>
-          <p:cNvSpPr/>
-          <p:nvPr/>
-        </p:nvSpPr>
-        <p:spPr>
-          <a:xfrm>
-            <a:off x="3246120" y="2468880"/>
-            <a:ext cx="320040" cy="365760"/>
-          </a:xfrm>
-          <a:prstGeom prst="rightArrow">
-            <a:avLst/>
-          </a:prstGeom>
-          <a:solidFill>
-            <a:srgbClr val="64665D"/>
-          </a:solidFill>
-          <a:ln>
-            <a:noFill/>
-          </a:ln>
-        </p:spPr>
-        <p:style>
-          <a:lnRef idx="1">
-            <a:schemeClr val="accent1"/>
-          </a:lnRef>
-          <a:fillRef idx="3">
-            <a:schemeClr val="accent1"/>
-          </a:fillRef>
-          <a:effectRef idx="2">
-            <a:schemeClr val="accent1"/>
-          </a:effectRef>
-          <a:fontRef idx="minor">
-            <a:schemeClr val="lt1"/>
-          </a:fontRef>
-        </p:style>
-        <p:txBody>
-          <a:bodyPr rtlCol="0" anchor="ctr"/>
-          <a:lstStyle/>
-          <a:p>
-            <a:pPr algn="ctr"/>
-          </a:p>
-        </p:txBody>
-      </p:sp>
-      <p:sp>
-        <p:nvSpPr>
-          <p:cNvPr id="6" name="Rounded Rectangle 5"/>
-          <p:cNvSpPr/>
-          <p:nvPr/>
-        </p:nvSpPr>
-        <p:spPr>
-          <a:xfrm>
-            <a:off x="3611880" y="2103120"/>
-            <a:ext cx="2377440" cy="1097280"/>
-          </a:xfrm>
-          <a:prstGeom prst="roundRect">
-            <a:avLst/>
-          </a:prstGeom>
-          <a:solidFill>
-            <a:srgbClr val="272A25"/>
-          </a:solidFill>
-          <a:ln>
-            <a:noFill/>
-          </a:ln>
-        </p:spPr>
-        <p:style>
-          <a:lnRef idx="1">
-            <a:schemeClr val="accent1"/>
-          </a:lnRef>
-          <a:fillRef idx="3">
-            <a:schemeClr val="accent1"/>
-          </a:fillRef>
-          <a:effectRef idx="2">
-            <a:schemeClr val="accent1"/>
-          </a:effectRef>
-          <a:fontRef idx="minor">
-            <a:schemeClr val="lt1"/>
-          </a:fontRef>
-        </p:style>
-        <p:txBody>
-          <a:bodyPr rtlCol="0" anchor="ctr"/>
-          <a:lstStyle/>
-          <a:p>
-            <a:pPr algn="ctr"/>
-            <a:r>
-              <a:rPr sz="2200" b="1">
-                <a:solidFill>
-                  <a:srgbClr val="FFFFFF"/>
-                </a:solidFill>
-              </a:rPr>
-              <a:t>Commit</a:t>
-            </a:r>
-          </a:p>
-        </p:txBody>
-      </p:sp>
-      <p:sp>
-        <p:nvSpPr>
-          <p:cNvPr id="7" name="Right Arrow 6"/>
-          <p:cNvSpPr/>
-          <p:nvPr/>
-        </p:nvSpPr>
-        <p:spPr>
-          <a:xfrm>
-            <a:off x="6035040" y="2468880"/>
-            <a:ext cx="320040" cy="365760"/>
-          </a:xfrm>
-          <a:prstGeom prst="rightArrow">
-            <a:avLst/>
-          </a:prstGeom>
-          <a:solidFill>
-            <a:srgbClr val="64665D"/>
-          </a:solidFill>
-          <a:ln>
-            <a:noFill/>
-          </a:ln>
-        </p:spPr>
-        <p:style>
-          <a:lnRef idx="1">
-            <a:schemeClr val="accent1"/>
-          </a:lnRef>
-          <a:fillRef idx="3">
-            <a:schemeClr val="accent1"/>
-          </a:fillRef>
-          <a:effectRef idx="2">
-            <a:schemeClr val="accent1"/>
-          </a:effectRef>
-          <a:fontRef idx="minor">
-            <a:schemeClr val="lt1"/>
-          </a:fontRef>
-        </p:style>
-        <p:txBody>
-          <a:bodyPr rtlCol="0" anchor="ctr"/>
-          <a:lstStyle/>
-          <a:p>
-            <a:pPr algn="ctr"/>
-          </a:p>
-        </p:txBody>
-      </p:sp>
-      <p:sp>
-        <p:nvSpPr>
-          <p:cNvPr id="8" name="Rounded Rectangle 7"/>
-          <p:cNvSpPr/>
-          <p:nvPr/>
-        </p:nvSpPr>
-        <p:spPr>
-          <a:xfrm>
-            <a:off x="6400800" y="2103120"/>
-            <a:ext cx="2377440" cy="1097280"/>
-          </a:xfrm>
-          <a:prstGeom prst="roundRect">
-            <a:avLst/>
-          </a:prstGeom>
-          <a:solidFill>
-            <a:srgbClr val="272A25"/>
-          </a:solidFill>
-          <a:ln>
-            <a:noFill/>
-          </a:ln>
-        </p:spPr>
-        <p:style>
-          <a:lnRef idx="1">
-            <a:schemeClr val="accent1"/>
-          </a:lnRef>
-          <a:fillRef idx="3">
-            <a:schemeClr val="accent1"/>
-          </a:fillRef>
-          <a:effectRef idx="2">
-            <a:schemeClr val="accent1"/>
-          </a:effectRef>
-          <a:fontRef idx="minor">
-            <a:schemeClr val="lt1"/>
-          </a:fontRef>
-        </p:style>
-        <p:txBody>
-          <a:bodyPr rtlCol="0" anchor="ctr"/>
-          <a:lstStyle/>
-          <a:p>
-            <a:pPr algn="ctr"/>
-            <a:r>
-              <a:rPr sz="2200" b="1">
-                <a:solidFill>
-                  <a:srgbClr val="FFFFFF"/>
-                </a:solidFill>
-              </a:rPr>
-              <a:t>Push</a:t>
-            </a:r>
-          </a:p>
-        </p:txBody>
-      </p:sp>
-      <p:sp>
-        <p:nvSpPr>
-          <p:cNvPr id="9" name="Right Arrow 8"/>
-          <p:cNvSpPr/>
-          <p:nvPr/>
-        </p:nvSpPr>
-        <p:spPr>
-          <a:xfrm>
-            <a:off x="8823960" y="2468880"/>
-            <a:ext cx="320040" cy="365760"/>
-          </a:xfrm>
-          <a:prstGeom prst="rightArrow">
-            <a:avLst/>
-          </a:prstGeom>
-          <a:solidFill>
-            <a:srgbClr val="64665D"/>
-          </a:solidFill>
-          <a:ln>
-            <a:noFill/>
-          </a:ln>
-        </p:spPr>
-        <p:style>
-          <a:lnRef idx="1">
-            <a:schemeClr val="accent1"/>
-          </a:lnRef>
-          <a:fillRef idx="3">
-            <a:schemeClr val="accent1"/>
-          </a:fillRef>
-          <a:effectRef idx="2">
-            <a:schemeClr val="accent1"/>
-          </a:effectRef>
-          <a:fontRef idx="minor">
-            <a:schemeClr val="lt1"/>
-          </a:fontRef>
-        </p:style>
-        <p:txBody>
-          <a:bodyPr rtlCol="0" anchor="ctr"/>
-          <a:lstStyle/>
-          <a:p>
-            <a:pPr algn="ctr"/>
-          </a:p>
-        </p:txBody>
-      </p:sp>
-      <p:sp>
-        <p:nvSpPr>
-          <p:cNvPr id="10" name="Rounded Rectangle 9"/>
-          <p:cNvSpPr/>
-          <p:nvPr/>
-        </p:nvSpPr>
-        <p:spPr>
-          <a:xfrm>
-            <a:off x="9189720" y="2103120"/>
-            <a:ext cx="2377440" cy="1097280"/>
-          </a:xfrm>
-          <a:prstGeom prst="roundRect">
-            <a:avLst/>
-          </a:prstGeom>
-          <a:solidFill>
-            <a:srgbClr val="272A25"/>
-          </a:solidFill>
-          <a:ln>
-            <a:noFill/>
-          </a:ln>
-        </p:spPr>
-        <p:style>
-          <a:lnRef idx="1">
-            <a:schemeClr val="accent1"/>
-          </a:lnRef>
-          <a:fillRef idx="3">
-            <a:schemeClr val="accent1"/>
-          </a:fillRef>
-          <a:effectRef idx="2">
-            <a:schemeClr val="accent1"/>
-          </a:effectRef>
-          <a:fontRef idx="minor">
-            <a:schemeClr val="lt1"/>
-          </a:fontRef>
-        </p:style>
-        <p:txBody>
-          <a:bodyPr rtlCol="0" anchor="ctr"/>
-          <a:lstStyle/>
-          <a:p>
-            <a:pPr algn="ctr"/>
-            <a:r>
-              <a:rPr sz="2200" b="1">
-                <a:solidFill>
-                  <a:srgbClr val="FFFFFF"/>
-                </a:solidFill>
-              </a:rPr>
-              <a:t>Live link</a:t>
-            </a:r>
-          </a:p>
-        </p:txBody>
-      </p:sp>
-      <p:sp>
-        <p:nvSpPr>
-          <p:cNvPr id="11" name="TextBox 10"/>
+              <a:t>The short path online</a:t>
+            </a:r>
+          </a:p>
+        </p:txBody>
+      </p:sp>
+      <p:sp>
+        <p:nvSpPr>
+          <p:cNvPr id="4" name="TextBox 3"/>
           <p:cNvSpPr txBox="1"/>
           <p:nvPr/>
         </p:nvSpPr>
         <p:spPr>
           <a:xfrm>
-            <a:off x="822960" y="3931920"/>
-            <a:ext cx="10607040" cy="2286000"/>
+            <a:off x="822960" y="2011680"/>
+            <a:ext cx="10607040" cy="4206240"/>
           </a:xfrm>
           <a:prstGeom prst="rect">
             <a:avLst/>
@@ -7105,56 +6947,56 @@
           <a:p>
             <a:pPr>
               <a:spcAft>
-                <a:spcPts val="1800"/>
+                <a:spcPts val="2200"/>
               </a:spcAft>
             </a:pPr>
             <a:r>
-              <a:rPr sz="2800" b="0">
+              <a:rPr sz="3000" b="0">
                 <a:solidFill>
                   <a:srgbClr val="272A25"/>
                 </a:solidFill>
                 <a:latin typeface="DM Sans"/>
               </a:rPr>
-              <a:t>•  Commit: a save point on your laptop.</a:t>
+              <a:t>•  GitHub Desktop: create repo → commit → publish.</a:t>
             </a:r>
           </a:p>
           <a:p>
             <a:pPr>
               <a:spcAft>
-                <a:spcPts val="1800"/>
+                <a:spcPts val="2200"/>
               </a:spcAft>
             </a:pPr>
             <a:r>
-              <a:rPr sz="2800" b="0">
+              <a:rPr sz="3000" b="0">
                 <a:solidFill>
                   <a:srgbClr val="272A25"/>
                 </a:solidFill>
                 <a:latin typeface="DM Sans"/>
               </a:rPr>
-              <a:t>•  Push: send it to GitHub.</a:t>
+              <a:t>•  GitHub: Settings → Pages → main / root → Save.</a:t>
             </a:r>
           </a:p>
           <a:p>
             <a:pPr>
               <a:spcAft>
-                <a:spcPts val="1800"/>
+                <a:spcPts val="2200"/>
               </a:spcAft>
             </a:pPr>
             <a:r>
-              <a:rPr sz="2800" b="0">
+              <a:rPr sz="3000" b="0">
                 <a:solidFill>
                   <a:srgbClr val="272A25"/>
                 </a:solidFill>
                 <a:latin typeface="DM Sans"/>
               </a:rPr>
-              <a:t>•  Deploy: turn it into a live website.</a:t>
-            </a:r>
-          </a:p>
-        </p:txBody>
-      </p:sp>
-      <p:sp>
-        <p:nvSpPr>
-          <p:cNvPr id="12" name="TextBox 11"/>
+              <a:t>•  Open the published link on another phone.</a:t>
+            </a:r>
+          </a:p>
+        </p:txBody>
+      </p:sp>
+      <p:sp>
+        <p:nvSpPr>
+          <p:cNvPr id="5" name="TextBox 4"/>
           <p:cNvSpPr txBox="1"/>
           <p:nvPr/>
         </p:nvSpPr>
@@ -7186,7 +7028,7 @@
                 </a:solidFill>
                 <a:latin typeface="DM Sans"/>
               </a:rPr>
-              <a:t>Week 6 · Demo 3 · Get it online        8 / 12</a:t>
+              <a:t>Week 6 · Getting online        8 / 13</a:t>
             </a:r>
           </a:p>
         </p:txBody>
@@ -7294,7 +7136,7 @@
                 </a:solidFill>
                 <a:latin typeface="Fraunces"/>
               </a:rPr>
-              <a:t>Demo 3 · getting online</a:t>
+              <a:t>Next week: your AI reaches your tools</a:t>
             </a:r>
           </a:p>
         </p:txBody>
@@ -7333,7 +7175,7 @@
                 </a:solidFill>
                 <a:latin typeface="DM Sans"/>
               </a:rPr>
-              <a:t>•  GitHub Desktop: create, commit, publish.</a:t>
+              <a:t>•  API: one program asking another for something.</a:t>
             </a:r>
           </a:p>
           <a:p>
@@ -7349,7 +7191,7 @@
                 </a:solidFill>
                 <a:latin typeface="DM Sans"/>
               </a:rPr>
-              <a:t>•  GitHub → Settings → Pages → main → Save.</a:t>
+              <a:t>•  Connector: your AI reaches tools directly, instead of you pasting.</a:t>
             </a:r>
           </a:p>
           <a:p>
@@ -7365,7 +7207,7 @@
                 </a:solidFill>
                 <a:latin typeface="DM Sans"/>
               </a:rPr>
-              <a:t>•  Open the live link on a phone.</a:t>
+              <a:t>•  This week we copy. Next week we’ll connect.</a:t>
             </a:r>
           </a:p>
         </p:txBody>
@@ -7404,7 +7246,7 @@
                 </a:solidFill>
                 <a:latin typeface="DM Sans"/>
               </a:rPr>
-              <a:t>Week 6 · Demo 3 · Get it online        9 / 12</a:t>
+              <a:t>Week 6 · Looking ahead        9 / 13</a:t>
             </a:r>
           </a:p>
         </p:txBody>

</xml_diff>

<commit_message>
Week 6 final: slides → one live conversation → small-group learning builds (#10)
* Week 6 foundation: copy lesson, light context file, get online; no live connector or pair exercise

* No connector advertising anywhere in Week 6; concept only next week

* Week 6 final sequence: slides first, one open Claude conversation, small-group learning builds

* Align lesson title/contents and remove staged-demo resource cards

---------

Co-authored-by: unforcedagi <agi@unforced.dev>
</commit_message>
<xml_diff>
--- a/lessons/week-6/_src/week6-lecture.pptx
+++ b/lessons/week-6/_src/week6-lecture.pptx
@@ -17,6 +17,7 @@
     <p:sldId id="265" r:id="rId17"/>
     <p:sldId id="266" r:id="rId18"/>
     <p:sldId id="267" r:id="rId19"/>
+    <p:sldId id="268" r:id="rId20"/>
   </p:sldIdLst>
   <p:sldSz cx="12191695" cy="6858000" type="screen4x3"/>
   <p:notesSz cx="6858000" cy="9144000"/>
@@ -513,7 +514,7 @@
           <a:lstStyle/>
           <a:p>
             <a:r>
-              <a:t>5:05–5:06. Three simple demos: copy the lesson, context that sticks, getting online. No live connector tonight.</a:t>
+              <a:t>5:05–5:06. Teach through the slides first. One open-ended live conversation with Claude at the end, then small-group building. No predetermined build.</a:t>
             </a:r>
           </a:p>
         </p:txBody>
@@ -583,7 +584,7 @@
           <a:lstStyle/>
           <a:p>
             <a:r>
-              <a:t>5:31–5:33. Concept only. Don’t show a server URL or set one up. This week, copying the markdown is the step toward that.</a:t>
+              <a:t>5:22–5:25. Show where the button is without starting the demo yet. The lesson includes this invitation and enough context for the group work.</a:t>
             </a:r>
           </a:p>
         </p:txBody>
@@ -653,7 +654,7 @@
           <a:lstStyle/>
           <a:p>
             <a:r>
-              <a:t>5:33–5:35. Free link on account page. No history? Paste last two submissions. No due date. Then trios 5:35–6:05.</a:t>
+              <a:t>5:25–5:35. Aaron chooses the conversation and any build in the moment. No scripted project or staged before/after. If Claude stalls, discuss what you would ask and move into group work.</a:t>
             </a:r>
           </a:p>
         </p:txBody>
@@ -723,7 +724,77 @@
           <a:lstStyle/>
           <a:p>
             <a:r>
-              <a:t>6:05–7:05. No prescribed pairs or interview exercise. Build, test, help each other as needed. 7:05–7:35 optional studio.</a:t>
+              <a:t>5:35 onward. This is the group-work invitation, not a rigid template. Students choose who to work with, what to learn and what to build. No predefined roles or prescribed file format.</a:t>
+            </a:r>
+          </a:p>
+        </p:txBody>
+      </p:sp>
+      <p:sp>
+        <p:nvSpPr>
+          <p:cNvPr id="4" name="Slide Number Placeholder 3"/>
+          <p:cNvSpPr>
+            <a:spLocks noGrp="1"/>
+          </p:cNvSpPr>
+          <p:nvPr>
+            <p:ph type="sldNum" idx="5" sz="quarter"/>
+          </p:nvPr>
+        </p:nvSpPr>
+        <p:spPr/>
+      </p:sp>
+    </p:spTree>
+  </p:cSld>
+  <p:clrMapOvr>
+    <a:masterClrMapping/>
+  </p:clrMapOvr>
+</p:notes>
+</file>
+
+<file path=ppt/notesSlides/notesSlide13.xml><?xml version="1.0" encoding="utf-8"?>
+<p:notes xmlns:a="http://schemas.openxmlformats.org/drawingml/2006/main" xmlns:p="http://schemas.openxmlformats.org/presentationml/2006/main" xmlns:r="http://schemas.openxmlformats.org/officeDocument/2006/relationships">
+  <p:cSld>
+    <p:spTree>
+      <p:nvGrpSpPr>
+        <p:cNvPr id="1" name=""/>
+        <p:cNvGrpSpPr/>
+        <p:nvPr/>
+      </p:nvGrpSpPr>
+      <p:grpSpPr>
+        <a:xfrm>
+          <a:off x="0" y="0"/>
+          <a:ext cx="0" cy="0"/>
+          <a:chOff x="0" y="0"/>
+          <a:chExt cx="0" cy="0"/>
+        </a:xfrm>
+      </p:grpSpPr>
+      <p:sp>
+        <p:nvSpPr>
+          <p:cNvPr id="2" name="Slide Image Placeholder 1"/>
+          <p:cNvSpPr>
+            <a:spLocks noGrp="1"/>
+          </p:cNvSpPr>
+          <p:nvPr>
+            <p:ph type="sldImg" idx="2"/>
+          </p:nvPr>
+        </p:nvSpPr>
+        <p:spPr/>
+      </p:sp>
+      <p:sp>
+        <p:nvSpPr>
+          <p:cNvPr id="3" name="Notes Placeholder 2"/>
+          <p:cNvSpPr>
+            <a:spLocks noGrp="1"/>
+          </p:cNvSpPr>
+          <p:nvPr>
+            <p:ph type="body" idx="3" sz="quarter"/>
+          </p:nvPr>
+        </p:nvSpPr>
+        <p:spPr/>
+        <p:txBody>
+          <a:bodyPr/>
+          <a:lstStyle/>
+          <a:p>
+            <a:r>
+              <a:t>Group work. Optional nudge: ask your AI what it needs to know about your project and save that context as markdown. If unsure where to start, use the Week 6 Copy button and ask for help choosing a learning idea. Work is not done merely because code runs: check whether it teaches the right thing.</a:t>
             </a:r>
           </a:p>
         </p:txBody>
@@ -793,7 +864,7 @@
           <a:lstStyle/>
           <a:p>
             <a:r>
-              <a:t>5:06–5:11. Open cu.learnvibe.build/lessons/week-6/, click Copy lesson as markdown, paste into a fresh chat. Ask exactly: Teach me this and quiz me. Answer one question. If it stalls, use the real rehearsal output on the demo script page.</a:t>
+              <a:t>5:06–5:08. Students can learn the tools by asking the tools. The answer is a starting point, not an authority.</a:t>
             </a:r>
           </a:p>
         </p:txBody>
@@ -863,7 +934,7 @@
           <a:lstStyle/>
           <a:p>
             <a:r>
-              <a:t>5:11–5:12. Show the raw lesson. Point to # headings and - bullets; no syntax lesson beyond that.</a:t>
+              <a:t>5:08–5:10. Explicit tie: Shipper used her AI as a coach, reflecting on actual projects and learning the next step. Without long chat history, paste your last two submissions or describe what you have tried. The free reading link is in your account. No due date announced.</a:t>
             </a:r>
           </a:p>
         </p:txBody>
@@ -933,7 +1004,7 @@
           <a:lstStyle/>
           <a:p>
             <a:r>
-              <a:t>5:12–5:13. These are ordinary markdown files in your project. Specific support varies by tool; Claude Code reads CLAUDE.md, and our tested installation also found AGENTS.md. No template or prescribed structure. Say what you would tell a new teammate.</a:t>
+              <a:t>5:10–5:12. # marks a heading; - marks a list. The lesson itself is markdown. No technical deep dive.</a:t>
             </a:r>
           </a:p>
         </p:txBody>
@@ -1003,7 +1074,7 @@
           <a:lstStyle/>
           <a:p>
             <a:r>
-              <a:t>5:13–5:15. Write these five lines live as CLAUDE.md. This is one example, not a template. The extra facts help the agent aim at the actual audience.</a:t>
+              <a:t>5:12–5:14. Specific support varies by tool. These are ordinary files with plain words. They help the next session know what you mean without re-explaining everything. No live demo here and no template.</a:t>
             </a:r>
           </a:p>
         </p:txBody>
@@ -1073,7 +1144,7 @@
           <a:lstStyle/>
           <a:p>
             <a:r>
-              <a:t>5:15–5:23. Use Hill Plant Swap. Exact prompt: Improve the homepage. Don’t edit any files: describe the changes you’d make in 6 bullets or fewer. Compare audience, unnecessary RSVP, simplicity. Start a third fresh session: Without reading any files, what is this project, and what should you never do? If delayed, use real captured results on demo script.</a:t>
+              <a:t>5:14–5:16. Read the example as what you would tell a new teammate. The point is persistent context, not a prescribed format.</a:t>
             </a:r>
           </a:p>
         </p:txBody>
@@ -1143,7 +1214,7 @@
           <a:lstStyle/>
           <a:p>
             <a:r>
-              <a:t>5:23–5:24. Local files and localhost links aren’t public. Open the published link on another phone.</a:t>
+              <a:t>5:16–5:18. Commit saves a version locally. Push sends it to GitHub. Deploy publishes a website.</a:t>
             </a:r>
           </a:p>
         </p:txBody>
@@ -1213,7 +1284,7 @@
           <a:lstStyle/>
           <a:p>
             <a:r>
-              <a:t>5:24–5:25. Explain these as three different steps.</a:t>
+              <a:t>5:18–5:20. Plain HTML/CSS: Pages. A framework app may need a different host such as Vercel. The handout is optional detail; all essential concepts are on this slide. No deployment demo tonight.</a:t>
             </a:r>
           </a:p>
         </p:txBody>
@@ -1283,7 +1354,7 @@
           <a:lstStyle/>
           <a:p>
             <a:r>
-              <a:t>5:25–5:31. Use plain-folder zip. Commit first version, publish public repo, Settings Pages main root. If waiting, show pre-deployed Hill Plant Swap. React/Vite/Next app: Vercel instead. Handout covers exact clicks.</a:t>
+              <a:t>5:20–5:22. Concept only; no course connector, server address or setup.</a:t>
             </a:r>
           </a:p>
         </p:txBody>
@@ -4374,7 +4445,7 @@
                 </a:solidFill>
                 <a:latin typeface="Fraunces"/>
               </a:rPr>
-              <a:t>Give your AI something to work with</a:t>
+              <a:t>Learn with your AI</a:t>
             </a:r>
           </a:p>
           <a:p>
@@ -4390,7 +4461,7 @@
                 </a:solidFill>
                 <a:latin typeface="DM Sans"/>
               </a:rPr>
-              <a:t>Context that sticks. A link anyone can open.</a:t>
+              <a:t>Use AI to understand AI. Then build something that helps you learn.</a:t>
             </a:r>
           </a:p>
           <a:p>
@@ -4445,7 +4516,7 @@
                 </a:solidFill>
                 <a:latin typeface="DM Sans"/>
               </a:rPr>
-              <a:t>Week 6 · Opening        1 / 12</a:t>
+              <a:t>Week 6 · Opening        1 / 13</a:t>
             </a:r>
           </a:p>
         </p:txBody>
@@ -4547,13 +4618,13 @@
               </a:spcAft>
             </a:pPr>
             <a:r>
-              <a:rPr sz="4000" b="1">
+              <a:rPr sz="3200" b="1">
                 <a:solidFill>
                   <a:srgbClr val="272A25"/>
                 </a:solidFill>
                 <a:latin typeface="Fraunces"/>
               </a:rPr>
-              <a:t>Next week: your AI reaches your tools</a:t>
+              <a:t>Everything you need is on the Week 6 page</a:t>
             </a:r>
           </a:p>
         </p:txBody>
@@ -4592,7 +4663,7 @@
                 </a:solidFill>
                 <a:latin typeface="DM Sans"/>
               </a:rPr>
-              <a:t>•  API: one program asking another for something.</a:t>
+              <a:t>•  cu.learnvibe.build → Everything for Week 6</a:t>
             </a:r>
           </a:p>
           <a:p>
@@ -4608,7 +4679,7 @@
                 </a:solidFill>
                 <a:latin typeface="DM Sans"/>
               </a:rPr>
-              <a:t>•  Connector: your AI reaches your tools directly.</a:t>
+              <a:t>•  Click “Copy lesson as markdown” → paste into your AI.</a:t>
             </a:r>
           </a:p>
           <a:p>
@@ -4624,7 +4695,7 @@
                 </a:solidFill>
                 <a:latin typeface="DM Sans"/>
               </a:rPr>
-              <a:t>•  Instead of you pasting. Next week we’ll connect.</a:t>
+              <a:t>•  Ask: “Teach me this and quiz me.”</a:t>
             </a:r>
           </a:p>
         </p:txBody>
@@ -4663,7 +4734,7 @@
                 </a:solidFill>
                 <a:latin typeface="DM Sans"/>
               </a:rPr>
-              <a:t>Week 6 · Looking ahead        10 / 12</a:t>
+              <a:t>Week 6 · Learn with AI        10 / 13</a:t>
             </a:r>
           </a:p>
         </p:txBody>
@@ -4771,7 +4842,7 @@
                 </a:solidFill>
                 <a:latin typeface="Fraunces"/>
               </a:rPr>
-              <a:t>This week’s reading: your AI as a coach</a:t>
+              <a:t>One live conversation with Claude</a:t>
             </a:r>
           </a:p>
         </p:txBody>
@@ -4810,7 +4881,7 @@
                 </a:solidFill>
                 <a:latin typeface="DM Sans"/>
               </a:rPr>
-              <a:t>•  Arielle Shipper · How to Get Better at AI by Asking AI</a:t>
+              <a:t>•  Copy the lesson markdown into Claude.</a:t>
             </a:r>
           </a:p>
           <a:p>
@@ -4826,7 +4897,7 @@
                 </a:solidFill>
                 <a:latin typeface="DM Sans"/>
               </a:rPr>
-              <a:t>•  Give your AI examples of how you’ve worked.</a:t>
+              <a:t>•  Talk through what you want to understand.</a:t>
             </a:r>
           </a:p>
           <a:p>
@@ -4842,7 +4913,7 @@
                 </a:solidFill>
                 <a:latin typeface="DM Sans"/>
               </a:rPr>
-              <a:t>•  Ask it to teach you one next step.</a:t>
+              <a:t>•  Maybe ask Claude to build a little thing from that conversation.</a:t>
             </a:r>
           </a:p>
         </p:txBody>
@@ -4881,7 +4952,7 @@
                 </a:solidFill>
                 <a:latin typeface="DM Sans"/>
               </a:rPr>
-              <a:t>Week 6 · Close        11 / 12</a:t>
+              <a:t>Week 6 · Live demo        11 / 13</a:t>
             </a:r>
           </a:p>
         </p:txBody>
@@ -4983,13 +5054,13 @@
               </a:spcAft>
             </a:pPr>
             <a:r>
-              <a:rPr sz="4000" b="1">
+              <a:rPr sz="3200" b="1">
                 <a:solidFill>
                   <a:srgbClr val="272A25"/>
                 </a:solidFill>
                 <a:latin typeface="Fraunces"/>
               </a:rPr>
-              <a:t>Studio: build</a:t>
+              <a:t>In small groups: build something that helps you learn</a:t>
             </a:r>
           </a:p>
         </p:txBody>
@@ -5028,7 +5099,7 @@
                 </a:solidFill>
                 <a:latin typeface="DM Sans"/>
               </a:rPr>
-              <a:t>•  Work on your project.</a:t>
+              <a:t>•  Choose your own topic and approach.</a:t>
             </a:r>
           </a:p>
           <a:p>
@@ -5044,7 +5115,7 @@
                 </a:solidFill>
                 <a:latin typeface="DM Sans"/>
               </a:rPr>
-              <a:t>•  Optional: ask your AI what it needs to know.</a:t>
+              <a:t>•  Try a quiz, interactive explainer, practice tool—or your own idea.</a:t>
             </a:r>
           </a:p>
           <a:p>
@@ -5060,7 +5131,7 @@
                 </a:solidFill>
                 <a:latin typeface="DM Sans"/>
               </a:rPr>
-              <a:t>•  Save that context as a markdown file.</a:t>
+              <a:t>•  Use your AI, test what you build, and show what it helped you learn.</a:t>
             </a:r>
           </a:p>
         </p:txBody>
@@ -5099,7 +5170,225 @@
                 </a:solidFill>
                 <a:latin typeface="DM Sans"/>
               </a:rPr>
-              <a:t>Week 6 · Studio        12 / 12</a:t>
+              <a:t>Week 6 · Group work        12 / 13</a:t>
+            </a:r>
+          </a:p>
+        </p:txBody>
+      </p:sp>
+    </p:spTree>
+  </p:cSld>
+  <p:clrMapOvr>
+    <a:masterClrMapping/>
+  </p:clrMapOvr>
+</p:sld>
+</file>
+
+<file path=ppt/slides/slide13.xml><?xml version="1.0" encoding="utf-8"?>
+<p:sld xmlns:a="http://schemas.openxmlformats.org/drawingml/2006/main" xmlns:p="http://schemas.openxmlformats.org/presentationml/2006/main" xmlns:r="http://schemas.openxmlformats.org/officeDocument/2006/relationships">
+  <p:cSld>
+    <p:bg>
+      <p:bgPr>
+        <a:solidFill>
+          <a:srgbClr val="F7F5EE"/>
+        </a:solidFill>
+        <a:effectLst/>
+      </p:bgPr>
+    </p:bg>
+    <p:spTree>
+      <p:nvGrpSpPr>
+        <p:cNvPr id="1" name=""/>
+        <p:cNvGrpSpPr/>
+        <p:nvPr/>
+      </p:nvGrpSpPr>
+      <p:grpSpPr/>
+      <p:sp>
+        <p:nvSpPr>
+          <p:cNvPr id="2" name="Rectangle 1"/>
+          <p:cNvSpPr/>
+          <p:nvPr/>
+        </p:nvSpPr>
+        <p:spPr>
+          <a:xfrm>
+            <a:off x="0" y="0"/>
+            <a:ext cx="228600" cy="6858000"/>
+          </a:xfrm>
+          <a:prstGeom prst="rect">
+            <a:avLst/>
+          </a:prstGeom>
+          <a:solidFill>
+            <a:srgbClr val="A83D2B"/>
+          </a:solidFill>
+          <a:ln>
+            <a:noFill/>
+          </a:ln>
+        </p:spPr>
+        <p:style>
+          <a:lnRef idx="1">
+            <a:schemeClr val="accent1"/>
+          </a:lnRef>
+          <a:fillRef idx="3">
+            <a:schemeClr val="accent1"/>
+          </a:fillRef>
+          <a:effectRef idx="2">
+            <a:schemeClr val="accent1"/>
+          </a:effectRef>
+          <a:fontRef idx="minor">
+            <a:schemeClr val="lt1"/>
+          </a:fontRef>
+        </p:style>
+        <p:txBody>
+          <a:bodyPr rtlCol="0" anchor="ctr"/>
+          <a:lstStyle/>
+          <a:p>
+            <a:pPr algn="ctr"/>
+          </a:p>
+        </p:txBody>
+      </p:sp>
+      <p:sp>
+        <p:nvSpPr>
+          <p:cNvPr id="3" name="TextBox 2"/>
+          <p:cNvSpPr txBox="1"/>
+          <p:nvPr/>
+        </p:nvSpPr>
+        <p:spPr>
+          <a:xfrm>
+            <a:off x="822960" y="548640"/>
+            <a:ext cx="10607040" cy="1188720"/>
+          </a:xfrm>
+          <a:prstGeom prst="rect">
+            <a:avLst/>
+          </a:prstGeom>
+          <a:noFill/>
+        </p:spPr>
+        <p:txBody>
+          <a:bodyPr wrap="square">
+            <a:spAutoFit/>
+          </a:bodyPr>
+          <a:lstStyle/>
+          <a:p>
+            <a:pPr>
+              <a:spcAft>
+                <a:spcPts val="1400"/>
+              </a:spcAft>
+            </a:pPr>
+            <a:r>
+              <a:rPr sz="4000" b="1">
+                <a:solidFill>
+                  <a:srgbClr val="272A25"/>
+                </a:solidFill>
+                <a:latin typeface="Fraunces"/>
+              </a:rPr>
+              <a:t>Start with a learning question</a:t>
+            </a:r>
+          </a:p>
+        </p:txBody>
+      </p:sp>
+      <p:sp>
+        <p:nvSpPr>
+          <p:cNvPr id="4" name="TextBox 3"/>
+          <p:cNvSpPr txBox="1"/>
+          <p:nvPr/>
+        </p:nvSpPr>
+        <p:spPr>
+          <a:xfrm>
+            <a:off x="822960" y="2011680"/>
+            <a:ext cx="10607040" cy="4206240"/>
+          </a:xfrm>
+          <a:prstGeom prst="rect">
+            <a:avLst/>
+          </a:prstGeom>
+          <a:noFill/>
+        </p:spPr>
+        <p:txBody>
+          <a:bodyPr wrap="square">
+            <a:spAutoFit/>
+          </a:bodyPr>
+          <a:lstStyle/>
+          <a:p>
+            <a:pPr>
+              <a:spcAft>
+                <a:spcPts val="2200"/>
+              </a:spcAft>
+            </a:pPr>
+            <a:r>
+              <a:rPr sz="3000" b="0">
+                <a:solidFill>
+                  <a:srgbClr val="272A25"/>
+                </a:solidFill>
+                <a:latin typeface="DM Sans"/>
+              </a:rPr>
+              <a:t>•  What do you want to understand or practise?</a:t>
+            </a:r>
+          </a:p>
+          <a:p>
+            <a:pPr>
+              <a:spcAft>
+                <a:spcPts val="2200"/>
+              </a:spcAft>
+            </a:pPr>
+            <a:r>
+              <a:rPr sz="3000" b="0">
+                <a:solidFill>
+                  <a:srgbClr val="272A25"/>
+                </a:solidFill>
+                <a:latin typeface="DM Sans"/>
+              </a:rPr>
+              <a:t>•  Give your AI the lesson, your question, or both.</a:t>
+            </a:r>
+          </a:p>
+          <a:p>
+            <a:pPr>
+              <a:spcAft>
+                <a:spcPts val="2200"/>
+              </a:spcAft>
+            </a:pPr>
+            <a:r>
+              <a:rPr sz="3000" b="0">
+                <a:solidFill>
+                  <a:srgbClr val="272A25"/>
+                </a:solidFill>
+                <a:latin typeface="DM Sans"/>
+              </a:rPr>
+              <a:t>•  Build a small first version; try it and revise.</a:t>
+            </a:r>
+          </a:p>
+        </p:txBody>
+      </p:sp>
+      <p:sp>
+        <p:nvSpPr>
+          <p:cNvPr id="5" name="TextBox 4"/>
+          <p:cNvSpPr txBox="1"/>
+          <p:nvPr/>
+        </p:nvSpPr>
+        <p:spPr>
+          <a:xfrm>
+            <a:off x="822960" y="6263640"/>
+            <a:ext cx="10607040" cy="365760"/>
+          </a:xfrm>
+          <a:prstGeom prst="rect">
+            <a:avLst/>
+          </a:prstGeom>
+          <a:noFill/>
+        </p:spPr>
+        <p:txBody>
+          <a:bodyPr wrap="square">
+            <a:spAutoFit/>
+          </a:bodyPr>
+          <a:lstStyle/>
+          <a:p>
+            <a:pPr algn="r">
+              <a:spcAft>
+                <a:spcPts val="1400"/>
+              </a:spcAft>
+            </a:pPr>
+            <a:r>
+              <a:rPr sz="1600" b="0">
+                <a:solidFill>
+                  <a:srgbClr val="64665D"/>
+                </a:solidFill>
+                <a:latin typeface="DM Sans"/>
+              </a:rPr>
+              <a:t>Week 6 · Group work        13 / 13</a:t>
             </a:r>
           </a:p>
         </p:txBody>
@@ -5207,7 +5496,7 @@
                 </a:solidFill>
                 <a:latin typeface="Fraunces"/>
               </a:rPr>
-              <a:t>Demo 1 · copy the lesson</a:t>
+              <a:t>Your AI can help you learn about AI</a:t>
             </a:r>
           </a:p>
         </p:txBody>
@@ -5246,7 +5535,7 @@
                 </a:solidFill>
                 <a:latin typeface="DM Sans"/>
               </a:rPr>
-              <a:t>•  Copy the lesson markdown into your AI.</a:t>
+              <a:t>•  Ask for an explanation at your level.</a:t>
             </a:r>
           </a:p>
           <a:p>
@@ -5262,7 +5551,7 @@
                 </a:solidFill>
                 <a:latin typeface="DM Sans"/>
               </a:rPr>
-              <a:t>•  Ask: “Teach me this and quiz me.”</a:t>
+              <a:t>•  Ask it to quiz you, then explain what you missed.</a:t>
             </a:r>
           </a:p>
           <a:p>
@@ -5278,7 +5567,7 @@
                 </a:solidFill>
                 <a:latin typeface="DM Sans"/>
               </a:rPr>
-              <a:t>•  Check its explanation against the lesson.</a:t>
+              <a:t>•  Check its claims against the material you gave it.</a:t>
             </a:r>
           </a:p>
         </p:txBody>
@@ -5317,7 +5606,7 @@
                 </a:solidFill>
                 <a:latin typeface="DM Sans"/>
               </a:rPr>
-              <a:t>Week 6 · Demo 1 · Learn with your AI        2 / 12</a:t>
+              <a:t>Week 6 · Learn with AI        2 / 13</a:t>
             </a:r>
           </a:p>
         </p:txBody>
@@ -5425,7 +5714,7 @@
                 </a:solidFill>
                 <a:latin typeface="Fraunces"/>
               </a:rPr>
-              <a:t>Markdown is just a text file</a:t>
+              <a:t>This week’s reading: your AI as a coach</a:t>
             </a:r>
           </a:p>
         </p:txBody>
@@ -5464,7 +5753,7 @@
                 </a:solidFill>
                 <a:latin typeface="DM Sans"/>
               </a:rPr>
-              <a:t>•  A .md file is plain text, with headings and lists.</a:t>
+              <a:t>•  Arielle Shipper · How to Get Better at AI by Asking AI</a:t>
             </a:r>
           </a:p>
           <a:p>
@@ -5480,7 +5769,7 @@
                 </a:solidFill>
                 <a:latin typeface="DM Sans"/>
               </a:rPr>
-              <a:t>•  You can read it. Your AI can read it.</a:t>
+              <a:t>•  Use examples of your own work to ask: “What should I learn next?”</a:t>
             </a:r>
           </a:p>
           <a:p>
@@ -5496,7 +5785,7 @@
                 </a:solidFill>
                 <a:latin typeface="DM Sans"/>
               </a:rPr>
-              <a:t>•  Context can live in a file instead of your memory.</a:t>
+              <a:t>•  Then: “Teach me that next step.”</a:t>
             </a:r>
           </a:p>
         </p:txBody>
@@ -5535,7 +5824,7 @@
                 </a:solidFill>
                 <a:latin typeface="DM Sans"/>
               </a:rPr>
-              <a:t>Week 6 · Demo 2 · Context that sticks        3 / 12</a:t>
+              <a:t>Week 6 · Learn with AI        3 / 13</a:t>
             </a:r>
           </a:p>
         </p:txBody>
@@ -5643,7 +5932,7 @@
                 </a:solidFill>
                 <a:latin typeface="Fraunces"/>
               </a:rPr>
-              <a:t>Context that sticks</a:t>
+              <a:t>Markdown is just a text file</a:t>
             </a:r>
           </a:p>
         </p:txBody>
@@ -5682,7 +5971,7 @@
                 </a:solidFill>
                 <a:latin typeface="DM Sans"/>
               </a:rPr>
-              <a:t>•  Claude Code loads CLAUDE.md at session start.</a:t>
+              <a:t>•  A .md file is plain text, with headings and lists.</a:t>
             </a:r>
           </a:p>
           <a:p>
@@ -5698,7 +5987,7 @@
                 </a:solidFill>
                 <a:latin typeface="DM Sans"/>
               </a:rPr>
-              <a:t>•  Cursor and other coding tools can load AGENTS.md.</a:t>
+              <a:t>•  You can read it. Your AI can read it.</a:t>
             </a:r>
           </a:p>
           <a:p>
@@ -5714,7 +6003,7 @@
                 </a:solidFill>
                 <a:latin typeface="DM Sans"/>
               </a:rPr>
-              <a:t>•  In a chat app: paste the file or add it to a Project.</a:t>
+              <a:t>•  A lesson or project context can live in that file.</a:t>
             </a:r>
           </a:p>
         </p:txBody>
@@ -5753,7 +6042,7 @@
                 </a:solidFill>
                 <a:latin typeface="DM Sans"/>
               </a:rPr>
-              <a:t>Week 6 · Demo 2 · Context that sticks        4 / 12</a:t>
+              <a:t>Week 6 · Context        4 / 13</a:t>
             </a:r>
           </a:p>
         </p:txBody>
@@ -5861,64 +6150,21 @@
                 </a:solidFill>
                 <a:latin typeface="Fraunces"/>
               </a:rPr>
-              <a:t>One small example</a:t>
-            </a:r>
-          </a:p>
-        </p:txBody>
-      </p:sp>
-      <p:sp>
-        <p:nvSpPr>
-          <p:cNvPr id="4" name="Rectangle 3"/>
-          <p:cNvSpPr/>
-          <p:nvPr/>
-        </p:nvSpPr>
-        <p:spPr>
-          <a:xfrm>
-            <a:off x="822960" y="1828800"/>
-            <a:ext cx="6583680" cy="4023360"/>
-          </a:xfrm>
-          <a:prstGeom prst="rect">
-            <a:avLst/>
-          </a:prstGeom>
-          <a:solidFill>
-            <a:srgbClr val="EEECE2"/>
-          </a:solidFill>
-          <a:ln>
-            <a:noFill/>
-          </a:ln>
-        </p:spPr>
-        <p:style>
-          <a:lnRef idx="1">
-            <a:schemeClr val="accent1"/>
-          </a:lnRef>
-          <a:fillRef idx="3">
-            <a:schemeClr val="accent1"/>
-          </a:fillRef>
-          <a:effectRef idx="2">
-            <a:schemeClr val="accent1"/>
-          </a:effectRef>
-          <a:fontRef idx="minor">
-            <a:schemeClr val="lt1"/>
-          </a:fontRef>
-        </p:style>
-        <p:txBody>
-          <a:bodyPr rtlCol="0" anchor="ctr"/>
-          <a:lstStyle/>
-          <a:p>
-            <a:pPr algn="ctr"/>
-          </a:p>
-        </p:txBody>
-      </p:sp>
-      <p:sp>
-        <p:nvSpPr>
-          <p:cNvPr id="5" name="TextBox 4"/>
+              <a:t>Context that sticks</a:t>
+            </a:r>
+          </a:p>
+        </p:txBody>
+      </p:sp>
+      <p:sp>
+        <p:nvSpPr>
+          <p:cNvPr id="4" name="TextBox 3"/>
           <p:cNvSpPr txBox="1"/>
           <p:nvPr/>
         </p:nvSpPr>
         <p:spPr>
           <a:xfrm>
-            <a:off x="1097280" y="2011680"/>
-            <a:ext cx="6217920" cy="3749039"/>
+            <a:off x="822960" y="2011680"/>
+            <a:ext cx="10607040" cy="4206240"/>
           </a:xfrm>
           <a:prstGeom prst="rect">
             <a:avLst/>
@@ -5933,127 +6179,56 @@
           <a:p>
             <a:pPr>
               <a:spcAft>
-                <a:spcPts val="200"/>
+                <a:spcPts val="2200"/>
               </a:spcAft>
             </a:pPr>
             <a:r>
-              <a:rPr sz="1800" b="0">
+              <a:rPr sz="3000" b="0">
                 <a:solidFill>
                   <a:srgbClr val="272A25"/>
                 </a:solidFill>
-                <a:latin typeface="DejaVu Sans Mono"/>
+                <a:latin typeface="DM Sans"/>
               </a:rPr>
-              <a:t># Hill Plant Swap</a:t>
+              <a:t>•  Claude Code loads CLAUDE.md at session start.</a:t>
             </a:r>
           </a:p>
           <a:p>
             <a:pPr>
               <a:spcAft>
-                <a:spcPts val="200"/>
+                <a:spcPts val="2200"/>
               </a:spcAft>
             </a:pPr>
             <a:r>
-              <a:rPr sz="1800" b="0">
+              <a:rPr sz="3000" b="0">
                 <a:solidFill>
                   <a:srgbClr val="272A25"/>
                 </a:solidFill>
-                <a:latin typeface="DejaVu Sans Mono"/>
+                <a:latin typeface="DM Sans"/>
               </a:rPr>
-              <a:t>A one-page website for a free monthly plant swap on the Hill, near CU.</a:t>
+              <a:t>•  Cursor and other coding tools can load AGENTS.md.</a:t>
             </a:r>
           </a:p>
           <a:p>
             <a:pPr>
               <a:spcAft>
-                <a:spcPts val="200"/>
+                <a:spcPts val="2200"/>
               </a:spcAft>
             </a:pPr>
             <a:r>
-              <a:rPr sz="1800" b="0">
+              <a:rPr sz="3000" b="0">
                 <a:solidFill>
                   <a:srgbClr val="272A25"/>
-                </a:solidFill>
-                <a:latin typeface="DejaVu Sans Mono"/>
-              </a:rPr>
-              <a:t>It's for first-year students who are nervous about going.</a:t>
-            </a:r>
-          </a:p>
-          <a:p>
-            <a:pPr>
-              <a:spcAft>
-                <a:spcPts val="200"/>
-              </a:spcAft>
-            </a:pPr>
-            <a:r>
-              <a:rPr sz="1800" b="0">
-                <a:solidFill>
-                  <a:srgbClr val="272A25"/>
-                </a:solidFill>
-                <a:latin typeface="DejaVu Sans Mono"/>
-              </a:rPr>
-              <a:t>Keep it plain HTML and CSS. No JavaScript.</a:t>
-            </a:r>
-          </a:p>
-          <a:p>
-            <a:pPr>
-              <a:spcAft>
-                <a:spcPts val="200"/>
-              </a:spcAft>
-            </a:pPr>
-            <a:r>
-              <a:rPr sz="1800" b="0">
-                <a:solidFill>
-                  <a:srgbClr val="272A25"/>
-                </a:solidFill>
-                <a:latin typeface="DejaVu Sans Mono"/>
-              </a:rPr>
-              <a:t>Only use the facts in docs/event-facts.md. Never make up dates or places.</a:t>
-            </a:r>
-          </a:p>
-        </p:txBody>
-      </p:sp>
-      <p:sp>
-        <p:nvSpPr>
-          <p:cNvPr id="6" name="TextBox 5"/>
-          <p:cNvSpPr txBox="1"/>
-          <p:nvPr/>
-        </p:nvSpPr>
-        <p:spPr>
-          <a:xfrm>
-            <a:off x="7772400" y="3108960"/>
-            <a:ext cx="3931920" cy="1828800"/>
-          </a:xfrm>
-          <a:prstGeom prst="rect">
-            <a:avLst/>
-          </a:prstGeom>
-          <a:noFill/>
-        </p:spPr>
-        <p:txBody>
-          <a:bodyPr wrap="square">
-            <a:spAutoFit/>
-          </a:bodyPr>
-          <a:lstStyle/>
-          <a:p>
-            <a:pPr>
-              <a:spcAft>
-                <a:spcPts val="1400"/>
-              </a:spcAft>
-            </a:pPr>
-            <a:r>
-              <a:rPr sz="2800" b="0">
-                <a:solidFill>
-                  <a:srgbClr val="64665D"/>
                 </a:solidFill>
                 <a:latin typeface="DM Sans"/>
               </a:rPr>
-              <a:t>Plain words. Nothing fancy.</a:t>
-            </a:r>
-          </a:p>
-        </p:txBody>
-      </p:sp>
-      <p:sp>
-        <p:nvSpPr>
-          <p:cNvPr id="7" name="TextBox 6"/>
+              <a:t>•  In a chat app: paste the file or add it to a Project.</a:t>
+            </a:r>
+          </a:p>
+        </p:txBody>
+      </p:sp>
+      <p:sp>
+        <p:nvSpPr>
+          <p:cNvPr id="5" name="TextBox 4"/>
           <p:cNvSpPr txBox="1"/>
           <p:nvPr/>
         </p:nvSpPr>
@@ -6085,7 +6260,7 @@
                 </a:solidFill>
                 <a:latin typeface="DM Sans"/>
               </a:rPr>
-              <a:t>Week 6 · Demo 2 · Context that sticks        5 / 12</a:t>
+              <a:t>Week 6 · Context        5 / 13</a:t>
             </a:r>
           </a:p>
         </p:txBody>
@@ -6193,21 +6368,64 @@
                 </a:solidFill>
                 <a:latin typeface="Fraunces"/>
               </a:rPr>
-              <a:t>Demo 2 · ask again</a:t>
-            </a:r>
-          </a:p>
-        </p:txBody>
-      </p:sp>
-      <p:sp>
-        <p:nvSpPr>
-          <p:cNvPr id="4" name="TextBox 3"/>
+              <a:t>One small example</a:t>
+            </a:r>
+          </a:p>
+        </p:txBody>
+      </p:sp>
+      <p:sp>
+        <p:nvSpPr>
+          <p:cNvPr id="4" name="Rectangle 3"/>
+          <p:cNvSpPr/>
+          <p:nvPr/>
+        </p:nvSpPr>
+        <p:spPr>
+          <a:xfrm>
+            <a:off x="822960" y="1828800"/>
+            <a:ext cx="6583680" cy="4023360"/>
+          </a:xfrm>
+          <a:prstGeom prst="rect">
+            <a:avLst/>
+          </a:prstGeom>
+          <a:solidFill>
+            <a:srgbClr val="EEECE2"/>
+          </a:solidFill>
+          <a:ln>
+            <a:noFill/>
+          </a:ln>
+        </p:spPr>
+        <p:style>
+          <a:lnRef idx="1">
+            <a:schemeClr val="accent1"/>
+          </a:lnRef>
+          <a:fillRef idx="3">
+            <a:schemeClr val="accent1"/>
+          </a:fillRef>
+          <a:effectRef idx="2">
+            <a:schemeClr val="accent1"/>
+          </a:effectRef>
+          <a:fontRef idx="minor">
+            <a:schemeClr val="lt1"/>
+          </a:fontRef>
+        </p:style>
+        <p:txBody>
+          <a:bodyPr rtlCol="0" anchor="ctr"/>
+          <a:lstStyle/>
+          <a:p>
+            <a:pPr algn="ctr"/>
+          </a:p>
+        </p:txBody>
+      </p:sp>
+      <p:sp>
+        <p:nvSpPr>
+          <p:cNvPr id="5" name="TextBox 4"/>
           <p:cNvSpPr txBox="1"/>
           <p:nvPr/>
         </p:nvSpPr>
         <p:spPr>
           <a:xfrm>
-            <a:off x="822960" y="2011680"/>
-            <a:ext cx="10607040" cy="4206240"/>
+            <a:off x="1097280" y="2011680"/>
+            <a:ext cx="6217920" cy="3749039"/>
           </a:xfrm>
           <a:prstGeom prst="rect">
             <a:avLst/>
@@ -6222,56 +6440,127 @@
           <a:p>
             <a:pPr>
               <a:spcAft>
-                <a:spcPts val="2200"/>
+                <a:spcPts val="200"/>
               </a:spcAft>
             </a:pPr>
             <a:r>
-              <a:rPr sz="3000" b="0">
+              <a:rPr sz="1800" b="0">
                 <a:solidFill>
                   <a:srgbClr val="272A25"/>
+                </a:solidFill>
+                <a:latin typeface="DejaVu Sans Mono"/>
+              </a:rPr>
+              <a:t># Hill Plant Swap</a:t>
+            </a:r>
+          </a:p>
+          <a:p>
+            <a:pPr>
+              <a:spcAft>
+                <a:spcPts val="200"/>
+              </a:spcAft>
+            </a:pPr>
+            <a:r>
+              <a:rPr sz="1800" b="0">
+                <a:solidFill>
+                  <a:srgbClr val="272A25"/>
+                </a:solidFill>
+                <a:latin typeface="DejaVu Sans Mono"/>
+              </a:rPr>
+              <a:t>A one-page website for a free plant swap near CU.</a:t>
+            </a:r>
+          </a:p>
+          <a:p>
+            <a:pPr>
+              <a:spcAft>
+                <a:spcPts val="200"/>
+              </a:spcAft>
+            </a:pPr>
+            <a:r>
+              <a:rPr sz="1800" b="0">
+                <a:solidFill>
+                  <a:srgbClr val="272A25"/>
+                </a:solidFill>
+                <a:latin typeface="DejaVu Sans Mono"/>
+              </a:rPr>
+              <a:t>For first-year students who are nervous about going.</a:t>
+            </a:r>
+          </a:p>
+          <a:p>
+            <a:pPr>
+              <a:spcAft>
+                <a:spcPts val="200"/>
+              </a:spcAft>
+            </a:pPr>
+            <a:r>
+              <a:rPr sz="1800" b="0">
+                <a:solidFill>
+                  <a:srgbClr val="272A25"/>
+                </a:solidFill>
+                <a:latin typeface="DejaVu Sans Mono"/>
+              </a:rPr>
+              <a:t>Keep it plain HTML and CSS. No JavaScript.</a:t>
+            </a:r>
+          </a:p>
+          <a:p>
+            <a:pPr>
+              <a:spcAft>
+                <a:spcPts val="200"/>
+              </a:spcAft>
+            </a:pPr>
+            <a:r>
+              <a:rPr sz="1800" b="0">
+                <a:solidFill>
+                  <a:srgbClr val="272A25"/>
+                </a:solidFill>
+                <a:latin typeface="DejaVu Sans Mono"/>
+              </a:rPr>
+              <a:t>Use docs/event-facts.md. Never make up dates.</a:t>
+            </a:r>
+          </a:p>
+        </p:txBody>
+      </p:sp>
+      <p:sp>
+        <p:nvSpPr>
+          <p:cNvPr id="6" name="TextBox 5"/>
+          <p:cNvSpPr txBox="1"/>
+          <p:nvPr/>
+        </p:nvSpPr>
+        <p:spPr>
+          <a:xfrm>
+            <a:off x="7772400" y="3108960"/>
+            <a:ext cx="3931920" cy="1828800"/>
+          </a:xfrm>
+          <a:prstGeom prst="rect">
+            <a:avLst/>
+          </a:prstGeom>
+          <a:noFill/>
+        </p:spPr>
+        <p:txBody>
+          <a:bodyPr wrap="square">
+            <a:spAutoFit/>
+          </a:bodyPr>
+          <a:lstStyle/>
+          <a:p>
+            <a:pPr>
+              <a:spcAft>
+                <a:spcPts val="1400"/>
+              </a:spcAft>
+            </a:pPr>
+            <a:r>
+              <a:rPr sz="2800" b="0">
+                <a:solidFill>
+                  <a:srgbClr val="64665D"/>
                 </a:solidFill>
                 <a:latin typeface="DM Sans"/>
               </a:rPr>
-              <a:t>•  Ask about the small project, cold.</a:t>
-            </a:r>
-          </a:p>
-          <a:p>
-            <a:pPr>
-              <a:spcAft>
-                <a:spcPts val="2200"/>
-              </a:spcAft>
-            </a:pPr>
-            <a:r>
-              <a:rPr sz="3000" b="0">
-                <a:solidFill>
-                  <a:srgbClr val="272A25"/>
-                </a:solidFill>
-                <a:latin typeface="DM Sans"/>
-              </a:rPr>
-              <a:t>•  Add the short context file. Ask again.</a:t>
-            </a:r>
-          </a:p>
-          <a:p>
-            <a:pPr>
-              <a:spcAft>
-                <a:spcPts val="2200"/>
-              </a:spcAft>
-            </a:pPr>
-            <a:r>
-              <a:rPr sz="3000" b="0">
-                <a:solidFill>
-                  <a:srgbClr val="272A25"/>
-                </a:solidFill>
-                <a:latin typeface="DM Sans"/>
-              </a:rPr>
-              <a:t>•  Start a fresh session: does it still know?</a:t>
-            </a:r>
-          </a:p>
-        </p:txBody>
-      </p:sp>
-      <p:sp>
-        <p:nvSpPr>
-          <p:cNvPr id="5" name="TextBox 4"/>
+              <a:t>Plain words. Nothing fancy.</a:t>
+            </a:r>
+          </a:p>
+        </p:txBody>
+      </p:sp>
+      <p:sp>
+        <p:nvSpPr>
+          <p:cNvPr id="7" name="TextBox 6"/>
           <p:cNvSpPr txBox="1"/>
           <p:nvPr/>
         </p:nvSpPr>
@@ -6303,7 +6592,7 @@
                 </a:solidFill>
                 <a:latin typeface="DM Sans"/>
               </a:rPr>
-              <a:t>Week 6 · Demo 2 · Context that sticks        6 / 12</a:t>
+              <a:t>Week 6 · Context        6 / 13</a:t>
             </a:r>
           </a:p>
         </p:txBody>
@@ -6418,57 +6707,14 @@
       </p:sp>
       <p:sp>
         <p:nvSpPr>
-          <p:cNvPr id="4" name="Rectangle 3"/>
-          <p:cNvSpPr/>
-          <p:nvPr/>
-        </p:nvSpPr>
-        <p:spPr>
-          <a:xfrm>
-            <a:off x="822960" y="1828800"/>
-            <a:ext cx="6583680" cy="4023360"/>
-          </a:xfrm>
-          <a:prstGeom prst="rect">
-            <a:avLst/>
-          </a:prstGeom>
-          <a:solidFill>
-            <a:srgbClr val="EEECE2"/>
-          </a:solidFill>
-          <a:ln>
-            <a:noFill/>
-          </a:ln>
-        </p:spPr>
-        <p:style>
-          <a:lnRef idx="1">
-            <a:schemeClr val="accent1"/>
-          </a:lnRef>
-          <a:fillRef idx="3">
-            <a:schemeClr val="accent1"/>
-          </a:fillRef>
-          <a:effectRef idx="2">
-            <a:schemeClr val="accent1"/>
-          </a:effectRef>
-          <a:fontRef idx="minor">
-            <a:schemeClr val="lt1"/>
-          </a:fontRef>
-        </p:style>
-        <p:txBody>
-          <a:bodyPr rtlCol="0" anchor="ctr"/>
-          <a:lstStyle/>
-          <a:p>
-            <a:pPr algn="ctr"/>
-          </a:p>
-        </p:txBody>
-      </p:sp>
-      <p:sp>
-        <p:nvSpPr>
-          <p:cNvPr id="5" name="TextBox 4"/>
+          <p:cNvPr id="4" name="TextBox 3"/>
           <p:cNvSpPr txBox="1"/>
           <p:nvPr/>
         </p:nvSpPr>
         <p:spPr>
           <a:xfrm>
-            <a:off x="1097280" y="2011680"/>
-            <a:ext cx="6217920" cy="3749039"/>
+            <a:off x="822960" y="2011680"/>
+            <a:ext cx="10607040" cy="4206240"/>
           </a:xfrm>
           <a:prstGeom prst="rect">
             <a:avLst/>
@@ -6483,127 +6729,56 @@
           <a:p>
             <a:pPr>
               <a:spcAft>
-                <a:spcPts val="200"/>
+                <a:spcPts val="2200"/>
               </a:spcAft>
             </a:pPr>
             <a:r>
-              <a:rPr sz="1800" b="0">
+              <a:rPr sz="3000" b="0">
                 <a:solidFill>
                   <a:srgbClr val="272A25"/>
                 </a:solidFill>
-                <a:latin typeface="DejaVu Sans Mono"/>
+                <a:latin typeface="DM Sans"/>
               </a:rPr>
-              <a:t>file:///Users/you/Desktop/index.html</a:t>
+              <a:t>•  file:// and localhost links only work on your computer.</a:t>
             </a:r>
           </a:p>
           <a:p>
             <a:pPr>
               <a:spcAft>
-                <a:spcPts val="200"/>
+                <a:spcPts val="2200"/>
               </a:spcAft>
             </a:pPr>
             <a:r>
-              <a:rPr sz="1800" b="0">
+              <a:rPr sz="3000" b="0">
                 <a:solidFill>
                   <a:srgbClr val="272A25"/>
                 </a:solidFill>
-                <a:latin typeface="DejaVu Sans Mono"/>
+                <a:latin typeface="DM Sans"/>
               </a:rPr>
-              <a:t>Only on your laptop.</a:t>
+              <a:t>•  A public HTTPS link works on someone else’s phone.</a:t>
             </a:r>
           </a:p>
           <a:p>
             <a:pPr>
               <a:spcAft>
-                <a:spcPts val="200"/>
+                <a:spcPts val="2200"/>
               </a:spcAft>
             </a:pPr>
             <a:r>
-              <a:rPr sz="1800" b="0">
+              <a:rPr sz="3000" b="0">
                 <a:solidFill>
                   <a:srgbClr val="272A25"/>
-                </a:solidFill>
-                <a:latin typeface="DejaVu Sans Mono"/>
-              </a:rPr>
-              <a:t> </a:t>
-            </a:r>
-          </a:p>
-          <a:p>
-            <a:pPr>
-              <a:spcAft>
-                <a:spcPts val="200"/>
-              </a:spcAft>
-            </a:pPr>
-            <a:r>
-              <a:rPr sz="1800" b="0">
-                <a:solidFill>
-                  <a:srgbClr val="272A25"/>
-                </a:solidFill>
-                <a:latin typeface="DejaVu Sans Mono"/>
-              </a:rPr>
-              <a:t>https://you.github.io/project/</a:t>
-            </a:r>
-          </a:p>
-          <a:p>
-            <a:pPr>
-              <a:spcAft>
-                <a:spcPts val="200"/>
-              </a:spcAft>
-            </a:pPr>
-            <a:r>
-              <a:rPr sz="1800" b="0">
-                <a:solidFill>
-                  <a:srgbClr val="272A25"/>
-                </a:solidFill>
-                <a:latin typeface="DejaVu Sans Mono"/>
-              </a:rPr>
-              <a:t>A published website.</a:t>
-            </a:r>
-          </a:p>
-        </p:txBody>
-      </p:sp>
-      <p:sp>
-        <p:nvSpPr>
-          <p:cNvPr id="6" name="TextBox 5"/>
-          <p:cNvSpPr txBox="1"/>
-          <p:nvPr/>
-        </p:nvSpPr>
-        <p:spPr>
-          <a:xfrm>
-            <a:off x="7772400" y="3108960"/>
-            <a:ext cx="3931920" cy="1828800"/>
-          </a:xfrm>
-          <a:prstGeom prst="rect">
-            <a:avLst/>
-          </a:prstGeom>
-          <a:noFill/>
-        </p:spPr>
-        <p:txBody>
-          <a:bodyPr wrap="square">
-            <a:spAutoFit/>
-          </a:bodyPr>
-          <a:lstStyle/>
-          <a:p>
-            <a:pPr>
-              <a:spcAft>
-                <a:spcPts val="1400"/>
-              </a:spcAft>
-            </a:pPr>
-            <a:r>
-              <a:rPr sz="2800" b="0">
-                <a:solidFill>
-                  <a:srgbClr val="64665D"/>
                 </a:solidFill>
                 <a:latin typeface="DM Sans"/>
               </a:rPr>
-              <a:t>Your laptop isn’t the internet.</a:t>
-            </a:r>
-          </a:p>
-        </p:txBody>
-      </p:sp>
-      <p:sp>
-        <p:nvSpPr>
-          <p:cNvPr id="7" name="TextBox 6"/>
+              <a:t>•  Commit → push → deploy are three different steps.</a:t>
+            </a:r>
+          </a:p>
+        </p:txBody>
+      </p:sp>
+      <p:sp>
+        <p:nvSpPr>
+          <p:cNvPr id="5" name="TextBox 4"/>
           <p:cNvSpPr txBox="1"/>
           <p:nvPr/>
         </p:nvSpPr>
@@ -6635,7 +6810,7 @@
                 </a:solidFill>
                 <a:latin typeface="DM Sans"/>
               </a:rPr>
-              <a:t>Week 6 · Demo 3 · Get it online        7 / 12</a:t>
+              <a:t>Week 6 · Getting online        7 / 13</a:t>
             </a:r>
           </a:p>
         </p:txBody>
@@ -6743,354 +6918,21 @@
                 </a:solidFill>
                 <a:latin typeface="Fraunces"/>
               </a:rPr>
-              <a:t>Save. Send. Publish.</a:t>
-            </a:r>
-          </a:p>
-        </p:txBody>
-      </p:sp>
-      <p:sp>
-        <p:nvSpPr>
-          <p:cNvPr id="4" name="Rounded Rectangle 3"/>
-          <p:cNvSpPr/>
-          <p:nvPr/>
-        </p:nvSpPr>
-        <p:spPr>
-          <a:xfrm>
-            <a:off x="822960" y="2103120"/>
-            <a:ext cx="2377440" cy="1097280"/>
-          </a:xfrm>
-          <a:prstGeom prst="roundRect">
-            <a:avLst/>
-          </a:prstGeom>
-          <a:solidFill>
-            <a:srgbClr val="A83D2B"/>
-          </a:solidFill>
-          <a:ln>
-            <a:noFill/>
-          </a:ln>
-        </p:spPr>
-        <p:style>
-          <a:lnRef idx="1">
-            <a:schemeClr val="accent1"/>
-          </a:lnRef>
-          <a:fillRef idx="3">
-            <a:schemeClr val="accent1"/>
-          </a:fillRef>
-          <a:effectRef idx="2">
-            <a:schemeClr val="accent1"/>
-          </a:effectRef>
-          <a:fontRef idx="minor">
-            <a:schemeClr val="lt1"/>
-          </a:fontRef>
-        </p:style>
-        <p:txBody>
-          <a:bodyPr rtlCol="0" anchor="ctr"/>
-          <a:lstStyle/>
-          <a:p>
-            <a:pPr algn="ctr"/>
-            <a:r>
-              <a:rPr sz="2200" b="1">
-                <a:solidFill>
-                  <a:srgbClr val="FFFFFF"/>
-                </a:solidFill>
-              </a:rPr>
-              <a:t>Folder</a:t>
-            </a:r>
-          </a:p>
-        </p:txBody>
-      </p:sp>
-      <p:sp>
-        <p:nvSpPr>
-          <p:cNvPr id="5" name="Right Arrow 4"/>
-          <p:cNvSpPr/>
-          <p:nvPr/>
-        </p:nvSpPr>
-        <p:spPr>
-          <a:xfrm>
-            <a:off x="3246120" y="2468880"/>
-            <a:ext cx="320040" cy="365760"/>
-          </a:xfrm>
-          <a:prstGeom prst="rightArrow">
-            <a:avLst/>
-          </a:prstGeom>
-          <a:solidFill>
-            <a:srgbClr val="64665D"/>
-          </a:solidFill>
-          <a:ln>
-            <a:noFill/>
-          </a:ln>
-        </p:spPr>
-        <p:style>
-          <a:lnRef idx="1">
-            <a:schemeClr val="accent1"/>
-          </a:lnRef>
-          <a:fillRef idx="3">
-            <a:schemeClr val="accent1"/>
-          </a:fillRef>
-          <a:effectRef idx="2">
-            <a:schemeClr val="accent1"/>
-          </a:effectRef>
-          <a:fontRef idx="minor">
-            <a:schemeClr val="lt1"/>
-          </a:fontRef>
-        </p:style>
-        <p:txBody>
-          <a:bodyPr rtlCol="0" anchor="ctr"/>
-          <a:lstStyle/>
-          <a:p>
-            <a:pPr algn="ctr"/>
-          </a:p>
-        </p:txBody>
-      </p:sp>
-      <p:sp>
-        <p:nvSpPr>
-          <p:cNvPr id="6" name="Rounded Rectangle 5"/>
-          <p:cNvSpPr/>
-          <p:nvPr/>
-        </p:nvSpPr>
-        <p:spPr>
-          <a:xfrm>
-            <a:off x="3611880" y="2103120"/>
-            <a:ext cx="2377440" cy="1097280"/>
-          </a:xfrm>
-          <a:prstGeom prst="roundRect">
-            <a:avLst/>
-          </a:prstGeom>
-          <a:solidFill>
-            <a:srgbClr val="272A25"/>
-          </a:solidFill>
-          <a:ln>
-            <a:noFill/>
-          </a:ln>
-        </p:spPr>
-        <p:style>
-          <a:lnRef idx="1">
-            <a:schemeClr val="accent1"/>
-          </a:lnRef>
-          <a:fillRef idx="3">
-            <a:schemeClr val="accent1"/>
-          </a:fillRef>
-          <a:effectRef idx="2">
-            <a:schemeClr val="accent1"/>
-          </a:effectRef>
-          <a:fontRef idx="minor">
-            <a:schemeClr val="lt1"/>
-          </a:fontRef>
-        </p:style>
-        <p:txBody>
-          <a:bodyPr rtlCol="0" anchor="ctr"/>
-          <a:lstStyle/>
-          <a:p>
-            <a:pPr algn="ctr"/>
-            <a:r>
-              <a:rPr sz="2200" b="1">
-                <a:solidFill>
-                  <a:srgbClr val="FFFFFF"/>
-                </a:solidFill>
-              </a:rPr>
-              <a:t>Commit</a:t>
-            </a:r>
-          </a:p>
-        </p:txBody>
-      </p:sp>
-      <p:sp>
-        <p:nvSpPr>
-          <p:cNvPr id="7" name="Right Arrow 6"/>
-          <p:cNvSpPr/>
-          <p:nvPr/>
-        </p:nvSpPr>
-        <p:spPr>
-          <a:xfrm>
-            <a:off x="6035040" y="2468880"/>
-            <a:ext cx="320040" cy="365760"/>
-          </a:xfrm>
-          <a:prstGeom prst="rightArrow">
-            <a:avLst/>
-          </a:prstGeom>
-          <a:solidFill>
-            <a:srgbClr val="64665D"/>
-          </a:solidFill>
-          <a:ln>
-            <a:noFill/>
-          </a:ln>
-        </p:spPr>
-        <p:style>
-          <a:lnRef idx="1">
-            <a:schemeClr val="accent1"/>
-          </a:lnRef>
-          <a:fillRef idx="3">
-            <a:schemeClr val="accent1"/>
-          </a:fillRef>
-          <a:effectRef idx="2">
-            <a:schemeClr val="accent1"/>
-          </a:effectRef>
-          <a:fontRef idx="minor">
-            <a:schemeClr val="lt1"/>
-          </a:fontRef>
-        </p:style>
-        <p:txBody>
-          <a:bodyPr rtlCol="0" anchor="ctr"/>
-          <a:lstStyle/>
-          <a:p>
-            <a:pPr algn="ctr"/>
-          </a:p>
-        </p:txBody>
-      </p:sp>
-      <p:sp>
-        <p:nvSpPr>
-          <p:cNvPr id="8" name="Rounded Rectangle 7"/>
-          <p:cNvSpPr/>
-          <p:nvPr/>
-        </p:nvSpPr>
-        <p:spPr>
-          <a:xfrm>
-            <a:off x="6400800" y="2103120"/>
-            <a:ext cx="2377440" cy="1097280"/>
-          </a:xfrm>
-          <a:prstGeom prst="roundRect">
-            <a:avLst/>
-          </a:prstGeom>
-          <a:solidFill>
-            <a:srgbClr val="272A25"/>
-          </a:solidFill>
-          <a:ln>
-            <a:noFill/>
-          </a:ln>
-        </p:spPr>
-        <p:style>
-          <a:lnRef idx="1">
-            <a:schemeClr val="accent1"/>
-          </a:lnRef>
-          <a:fillRef idx="3">
-            <a:schemeClr val="accent1"/>
-          </a:fillRef>
-          <a:effectRef idx="2">
-            <a:schemeClr val="accent1"/>
-          </a:effectRef>
-          <a:fontRef idx="minor">
-            <a:schemeClr val="lt1"/>
-          </a:fontRef>
-        </p:style>
-        <p:txBody>
-          <a:bodyPr rtlCol="0" anchor="ctr"/>
-          <a:lstStyle/>
-          <a:p>
-            <a:pPr algn="ctr"/>
-            <a:r>
-              <a:rPr sz="2200" b="1">
-                <a:solidFill>
-                  <a:srgbClr val="FFFFFF"/>
-                </a:solidFill>
-              </a:rPr>
-              <a:t>Push</a:t>
-            </a:r>
-          </a:p>
-        </p:txBody>
-      </p:sp>
-      <p:sp>
-        <p:nvSpPr>
-          <p:cNvPr id="9" name="Right Arrow 8"/>
-          <p:cNvSpPr/>
-          <p:nvPr/>
-        </p:nvSpPr>
-        <p:spPr>
-          <a:xfrm>
-            <a:off x="8823960" y="2468880"/>
-            <a:ext cx="320040" cy="365760"/>
-          </a:xfrm>
-          <a:prstGeom prst="rightArrow">
-            <a:avLst/>
-          </a:prstGeom>
-          <a:solidFill>
-            <a:srgbClr val="64665D"/>
-          </a:solidFill>
-          <a:ln>
-            <a:noFill/>
-          </a:ln>
-        </p:spPr>
-        <p:style>
-          <a:lnRef idx="1">
-            <a:schemeClr val="accent1"/>
-          </a:lnRef>
-          <a:fillRef idx="3">
-            <a:schemeClr val="accent1"/>
-          </a:fillRef>
-          <a:effectRef idx="2">
-            <a:schemeClr val="accent1"/>
-          </a:effectRef>
-          <a:fontRef idx="minor">
-            <a:schemeClr val="lt1"/>
-          </a:fontRef>
-        </p:style>
-        <p:txBody>
-          <a:bodyPr rtlCol="0" anchor="ctr"/>
-          <a:lstStyle/>
-          <a:p>
-            <a:pPr algn="ctr"/>
-          </a:p>
-        </p:txBody>
-      </p:sp>
-      <p:sp>
-        <p:nvSpPr>
-          <p:cNvPr id="10" name="Rounded Rectangle 9"/>
-          <p:cNvSpPr/>
-          <p:nvPr/>
-        </p:nvSpPr>
-        <p:spPr>
-          <a:xfrm>
-            <a:off x="9189720" y="2103120"/>
-            <a:ext cx="2377440" cy="1097280"/>
-          </a:xfrm>
-          <a:prstGeom prst="roundRect">
-            <a:avLst/>
-          </a:prstGeom>
-          <a:solidFill>
-            <a:srgbClr val="272A25"/>
-          </a:solidFill>
-          <a:ln>
-            <a:noFill/>
-          </a:ln>
-        </p:spPr>
-        <p:style>
-          <a:lnRef idx="1">
-            <a:schemeClr val="accent1"/>
-          </a:lnRef>
-          <a:fillRef idx="3">
-            <a:schemeClr val="accent1"/>
-          </a:fillRef>
-          <a:effectRef idx="2">
-            <a:schemeClr val="accent1"/>
-          </a:effectRef>
-          <a:fontRef idx="minor">
-            <a:schemeClr val="lt1"/>
-          </a:fontRef>
-        </p:style>
-        <p:txBody>
-          <a:bodyPr rtlCol="0" anchor="ctr"/>
-          <a:lstStyle/>
-          <a:p>
-            <a:pPr algn="ctr"/>
-            <a:r>
-              <a:rPr sz="2200" b="1">
-                <a:solidFill>
-                  <a:srgbClr val="FFFFFF"/>
-                </a:solidFill>
-              </a:rPr>
-              <a:t>Live link</a:t>
-            </a:r>
-          </a:p>
-        </p:txBody>
-      </p:sp>
-      <p:sp>
-        <p:nvSpPr>
-          <p:cNvPr id="11" name="TextBox 10"/>
+              <a:t>The short path online</a:t>
+            </a:r>
+          </a:p>
+        </p:txBody>
+      </p:sp>
+      <p:sp>
+        <p:nvSpPr>
+          <p:cNvPr id="4" name="TextBox 3"/>
           <p:cNvSpPr txBox="1"/>
           <p:nvPr/>
         </p:nvSpPr>
         <p:spPr>
           <a:xfrm>
-            <a:off x="822960" y="3931920"/>
-            <a:ext cx="10607040" cy="2286000"/>
+            <a:off x="822960" y="2011680"/>
+            <a:ext cx="10607040" cy="4206240"/>
           </a:xfrm>
           <a:prstGeom prst="rect">
             <a:avLst/>
@@ -7105,56 +6947,56 @@
           <a:p>
             <a:pPr>
               <a:spcAft>
-                <a:spcPts val="1800"/>
+                <a:spcPts val="2200"/>
               </a:spcAft>
             </a:pPr>
             <a:r>
-              <a:rPr sz="2800" b="0">
+              <a:rPr sz="3000" b="0">
                 <a:solidFill>
                   <a:srgbClr val="272A25"/>
                 </a:solidFill>
                 <a:latin typeface="DM Sans"/>
               </a:rPr>
-              <a:t>•  Commit: a save point on your laptop.</a:t>
+              <a:t>•  GitHub Desktop: create repo → commit → publish.</a:t>
             </a:r>
           </a:p>
           <a:p>
             <a:pPr>
               <a:spcAft>
-                <a:spcPts val="1800"/>
+                <a:spcPts val="2200"/>
               </a:spcAft>
             </a:pPr>
             <a:r>
-              <a:rPr sz="2800" b="0">
+              <a:rPr sz="3000" b="0">
                 <a:solidFill>
                   <a:srgbClr val="272A25"/>
                 </a:solidFill>
                 <a:latin typeface="DM Sans"/>
               </a:rPr>
-              <a:t>•  Push: send it to GitHub.</a:t>
+              <a:t>•  GitHub: Settings → Pages → main / root → Save.</a:t>
             </a:r>
           </a:p>
           <a:p>
             <a:pPr>
               <a:spcAft>
-                <a:spcPts val="1800"/>
+                <a:spcPts val="2200"/>
               </a:spcAft>
             </a:pPr>
             <a:r>
-              <a:rPr sz="2800" b="0">
+              <a:rPr sz="3000" b="0">
                 <a:solidFill>
                   <a:srgbClr val="272A25"/>
                 </a:solidFill>
                 <a:latin typeface="DM Sans"/>
               </a:rPr>
-              <a:t>•  Deploy: turn it into a live website.</a:t>
-            </a:r>
-          </a:p>
-        </p:txBody>
-      </p:sp>
-      <p:sp>
-        <p:nvSpPr>
-          <p:cNvPr id="12" name="TextBox 11"/>
+              <a:t>•  Open the published link on another phone.</a:t>
+            </a:r>
+          </a:p>
+        </p:txBody>
+      </p:sp>
+      <p:sp>
+        <p:nvSpPr>
+          <p:cNvPr id="5" name="TextBox 4"/>
           <p:cNvSpPr txBox="1"/>
           <p:nvPr/>
         </p:nvSpPr>
@@ -7186,7 +7028,7 @@
                 </a:solidFill>
                 <a:latin typeface="DM Sans"/>
               </a:rPr>
-              <a:t>Week 6 · Demo 3 · Get it online        8 / 12</a:t>
+              <a:t>Week 6 · Getting online        8 / 13</a:t>
             </a:r>
           </a:p>
         </p:txBody>
@@ -7294,7 +7136,7 @@
                 </a:solidFill>
                 <a:latin typeface="Fraunces"/>
               </a:rPr>
-              <a:t>Demo 3 · getting online</a:t>
+              <a:t>Next week: your AI reaches your tools</a:t>
             </a:r>
           </a:p>
         </p:txBody>
@@ -7333,7 +7175,7 @@
                 </a:solidFill>
                 <a:latin typeface="DM Sans"/>
               </a:rPr>
-              <a:t>•  GitHub Desktop: create, commit, publish.</a:t>
+              <a:t>•  API: one program asking another for something.</a:t>
             </a:r>
           </a:p>
           <a:p>
@@ -7349,7 +7191,7 @@
                 </a:solidFill>
                 <a:latin typeface="DM Sans"/>
               </a:rPr>
-              <a:t>•  GitHub → Settings → Pages → main → Save.</a:t>
+              <a:t>•  Connector: your AI reaches tools directly, instead of you pasting.</a:t>
             </a:r>
           </a:p>
           <a:p>
@@ -7365,7 +7207,7 @@
                 </a:solidFill>
                 <a:latin typeface="DM Sans"/>
               </a:rPr>
-              <a:t>•  Open the live link on a phone.</a:t>
+              <a:t>•  This week we copy. Next week we’ll connect.</a:t>
             </a:r>
           </a:p>
         </p:txBody>
@@ -7404,7 +7246,7 @@
                 </a:solidFill>
                 <a:latin typeface="DM Sans"/>
               </a:rPr>
-              <a:t>Week 6 · Demo 3 · Get it online        9 / 12</a:t>
+              <a:t>Week 6 · Looking ahead        9 / 13</a:t>
             </a:r>
           </a:p>
         </p:txBody>

</xml_diff>

<commit_message>
Restore substantive Week 6 teaching from recent student gaps; definitions and examples before one demo
</commit_message>
<xml_diff>
--- a/lessons/week-6/_src/week6-lecture.pptx
+++ b/lessons/week-6/_src/week6-lecture.pptx
@@ -18,6 +18,19 @@
     <p:sldId id="266" r:id="rId18"/>
     <p:sldId id="267" r:id="rId19"/>
     <p:sldId id="268" r:id="rId20"/>
+    <p:sldId id="269" r:id="rId21"/>
+    <p:sldId id="270" r:id="rId22"/>
+    <p:sldId id="271" r:id="rId23"/>
+    <p:sldId id="272" r:id="rId24"/>
+    <p:sldId id="273" r:id="rId25"/>
+    <p:sldId id="274" r:id="rId26"/>
+    <p:sldId id="275" r:id="rId27"/>
+    <p:sldId id="276" r:id="rId28"/>
+    <p:sldId id="277" r:id="rId29"/>
+    <p:sldId id="278" r:id="rId30"/>
+    <p:sldId id="279" r:id="rId31"/>
+    <p:sldId id="280" r:id="rId32"/>
+    <p:sldId id="281" r:id="rId33"/>
   </p:sldIdLst>
   <p:sldSz cx="12191695" cy="6858000" type="screen4x3"/>
   <p:notesSz cx="6858000" cy="9144000"/>
@@ -514,7 +527,7 @@
           <a:lstStyle/>
           <a:p>
             <a:r>
-              <a:t>5:05–5:06. Teach through the slides first. One open-ended live conversation with Claude at the end, then small-group building. No predetermined build.</a:t>
+              <a:t>Teach the substantive slides first, then one open live conversation with Claude, then small-group work. No timed demo interruptions.</a:t>
             </a:r>
           </a:p>
         </p:txBody>
@@ -584,7 +597,7 @@
           <a:lstStyle/>
           <a:p>
             <a:r>
-              <a:t>5:22–5:25. Show where the button is without starting the demo yet. The lesson includes this invitation and enough context for the group work.</a:t>
+              <a:t>Do not imply any file name works universally. Our tested Claude Code installation also found AGENTS.md, but teach documented primary filenames. A fresh-session question can reveal whether the tool saw the file.</a:t>
             </a:r>
           </a:p>
         </p:txBody>
@@ -654,7 +667,7 @@
           <a:lstStyle/>
           <a:p>
             <a:r>
-              <a:t>5:25–5:35. Aaron chooses the conversation and any build in the moment. No scripted project or staged before/after. If Claude stalls, discuss what you would ask and move into group work.</a:t>
+              <a:t>Index files are a map, not evidence that the AI read the linked files. Ask it which sources it used.</a:t>
             </a:r>
           </a:p>
         </p:txBody>
@@ -724,7 +737,7 @@
           <a:lstStyle/>
           <a:p>
             <a:r>
-              <a:t>5:35 onward. This is the group-work invitation, not a rigid template. Students choose who to work with, what to learn and what to build. No predefined roles or prescribed file format.</a:t>
+              <a:t>Week 4/5 reflections describe trouble communicating aesthetics; a recent rebuild improved when the student described the feeling instead of only listing features.</a:t>
             </a:r>
           </a:p>
         </p:txBody>
@@ -794,7 +807,427 @@
           <a:lstStyle/>
           <a:p>
             <a:r>
-              <a:t>Group work. Optional nudge: ask your AI what it needs to know about your project and save that context as markdown. If unsure where to start, use the Week 6 Copy button and ask for help choosing a learning idea. Work is not done merely because code runs: check whether it teaches the right thing.</a:t>
+              <a:t>Recent Week 5 work caught non-clickable cards through use. Specific observed behavior gives the agent something testable.</a:t>
+            </a:r>
+          </a:p>
+        </p:txBody>
+      </p:sp>
+      <p:sp>
+        <p:nvSpPr>
+          <p:cNvPr id="4" name="Slide Number Placeholder 3"/>
+          <p:cNvSpPr>
+            <a:spLocks noGrp="1"/>
+          </p:cNvSpPr>
+          <p:nvPr>
+            <p:ph type="sldNum" idx="5" sz="quarter"/>
+          </p:nvPr>
+        </p:nvSpPr>
+        <p:spPr/>
+      </p:sp>
+    </p:spTree>
+  </p:cSld>
+  <p:clrMapOvr>
+    <a:masterClrMapping/>
+  </p:clrMapOvr>
+</p:notes>
+</file>
+
+<file path=ppt/notesSlides/notesSlide14.xml><?xml version="1.0" encoding="utf-8"?>
+<p:notes xmlns:a="http://schemas.openxmlformats.org/drawingml/2006/main" xmlns:p="http://schemas.openxmlformats.org/presentationml/2006/main" xmlns:r="http://schemas.openxmlformats.org/officeDocument/2006/relationships">
+  <p:cSld>
+    <p:spTree>
+      <p:nvGrpSpPr>
+        <p:cNvPr id="1" name=""/>
+        <p:cNvGrpSpPr/>
+        <p:nvPr/>
+      </p:nvGrpSpPr>
+      <p:grpSpPr>
+        <a:xfrm>
+          <a:off x="0" y="0"/>
+          <a:ext cx="0" cy="0"/>
+          <a:chOff x="0" y="0"/>
+          <a:chExt cx="0" cy="0"/>
+        </a:xfrm>
+      </p:grpSpPr>
+      <p:sp>
+        <p:nvSpPr>
+          <p:cNvPr id="2" name="Slide Image Placeholder 1"/>
+          <p:cNvSpPr>
+            <a:spLocks noGrp="1"/>
+          </p:cNvSpPr>
+          <p:nvPr>
+            <p:ph type="sldImg" idx="2"/>
+          </p:nvPr>
+        </p:nvSpPr>
+        <p:spPr/>
+      </p:sp>
+      <p:sp>
+        <p:nvSpPr>
+          <p:cNvPr id="3" name="Notes Placeholder 2"/>
+          <p:cNvSpPr>
+            <a:spLocks noGrp="1"/>
+          </p:cNvSpPr>
+          <p:nvPr>
+            <p:ph type="body" idx="3" sz="quarter"/>
+          </p:nvPr>
+        </p:nvSpPr>
+        <p:spPr/>
+        <p:txBody>
+          <a:bodyPr/>
+          <a:lstStyle/>
+          <a:p>
+            <a:r>
+              <a:t>Do not blindly rewrite the whole app. Before a risky fix, save a working version. Recent students used AI for testing/debugging but still needed to notice what failed.</a:t>
+            </a:r>
+          </a:p>
+        </p:txBody>
+      </p:sp>
+      <p:sp>
+        <p:nvSpPr>
+          <p:cNvPr id="4" name="Slide Number Placeholder 3"/>
+          <p:cNvSpPr>
+            <a:spLocks noGrp="1"/>
+          </p:cNvSpPr>
+          <p:nvPr>
+            <p:ph type="sldNum" idx="5" sz="quarter"/>
+          </p:nvPr>
+        </p:nvSpPr>
+        <p:spPr/>
+      </p:sp>
+    </p:spTree>
+  </p:cSld>
+  <p:clrMapOvr>
+    <a:masterClrMapping/>
+  </p:clrMapOvr>
+</p:notes>
+</file>
+
+<file path=ppt/notesSlides/notesSlide15.xml><?xml version="1.0" encoding="utf-8"?>
+<p:notes xmlns:a="http://schemas.openxmlformats.org/drawingml/2006/main" xmlns:p="http://schemas.openxmlformats.org/presentationml/2006/main" xmlns:r="http://schemas.openxmlformats.org/officeDocument/2006/relationships">
+  <p:cSld>
+    <p:spTree>
+      <p:nvGrpSpPr>
+        <p:cNvPr id="1" name=""/>
+        <p:cNvGrpSpPr/>
+        <p:nvPr/>
+      </p:nvGrpSpPr>
+      <p:grpSpPr>
+        <a:xfrm>
+          <a:off x="0" y="0"/>
+          <a:ext cx="0" cy="0"/>
+          <a:chOff x="0" y="0"/>
+          <a:chExt cx="0" cy="0"/>
+        </a:xfrm>
+      </p:grpSpPr>
+      <p:sp>
+        <p:nvSpPr>
+          <p:cNvPr id="2" name="Slide Image Placeholder 1"/>
+          <p:cNvSpPr>
+            <a:spLocks noGrp="1"/>
+          </p:cNvSpPr>
+          <p:nvPr>
+            <p:ph type="sldImg" idx="2"/>
+          </p:nvPr>
+        </p:nvSpPr>
+        <p:spPr/>
+      </p:sp>
+      <p:sp>
+        <p:nvSpPr>
+          <p:cNvPr id="3" name="Notes Placeholder 2"/>
+          <p:cNvSpPr>
+            <a:spLocks noGrp="1"/>
+          </p:cNvSpPr>
+          <p:nvPr>
+            <p:ph type="body" idx="3" sz="quarter"/>
+          </p:nvPr>
+        </p:nvSpPr>
+        <p:spPr/>
+        <p:txBody>
+          <a:bodyPr/>
+          <a:lstStyle/>
+          <a:p>
+            <a:r>
+              <a:t>A running build is not proof it is correct or useful. This transfers directly to the small-group learning builds.</a:t>
+            </a:r>
+          </a:p>
+        </p:txBody>
+      </p:sp>
+      <p:sp>
+        <p:nvSpPr>
+          <p:cNvPr id="4" name="Slide Number Placeholder 3"/>
+          <p:cNvSpPr>
+            <a:spLocks noGrp="1"/>
+          </p:cNvSpPr>
+          <p:nvPr>
+            <p:ph type="sldNum" idx="5" sz="quarter"/>
+          </p:nvPr>
+        </p:nvSpPr>
+        <p:spPr/>
+      </p:sp>
+    </p:spTree>
+  </p:cSld>
+  <p:clrMapOvr>
+    <a:masterClrMapping/>
+  </p:clrMapOvr>
+</p:notes>
+</file>
+
+<file path=ppt/notesSlides/notesSlide16.xml><?xml version="1.0" encoding="utf-8"?>
+<p:notes xmlns:a="http://schemas.openxmlformats.org/drawingml/2006/main" xmlns:p="http://schemas.openxmlformats.org/presentationml/2006/main" xmlns:r="http://schemas.openxmlformats.org/officeDocument/2006/relationships">
+  <p:cSld>
+    <p:spTree>
+      <p:nvGrpSpPr>
+        <p:cNvPr id="1" name=""/>
+        <p:cNvGrpSpPr/>
+        <p:nvPr/>
+      </p:nvGrpSpPr>
+      <p:grpSpPr>
+        <a:xfrm>
+          <a:off x="0" y="0"/>
+          <a:ext cx="0" cy="0"/>
+          <a:chOff x="0" y="0"/>
+          <a:chExt cx="0" cy="0"/>
+        </a:xfrm>
+      </p:grpSpPr>
+      <p:sp>
+        <p:nvSpPr>
+          <p:cNvPr id="2" name="Slide Image Placeholder 1"/>
+          <p:cNvSpPr>
+            <a:spLocks noGrp="1"/>
+          </p:cNvSpPr>
+          <p:nvPr>
+            <p:ph type="sldImg" idx="2"/>
+          </p:nvPr>
+        </p:nvSpPr>
+        <p:spPr/>
+      </p:sp>
+      <p:sp>
+        <p:nvSpPr>
+          <p:cNvPr id="3" name="Notes Placeholder 2"/>
+          <p:cNvSpPr>
+            <a:spLocks noGrp="1"/>
+          </p:cNvSpPr>
+          <p:nvPr>
+            <p:ph type="body" idx="3" sz="quarter"/>
+          </p:nvPr>
+        </p:nvSpPr>
+        <p:spPr/>
+        <p:txBody>
+          <a:bodyPr/>
+          <a:lstStyle/>
+          <a:p>
+            <a:r>
+              <a:t>Recent Week 5 submissions described switching tools and running out of credits. Persistent context is a practical continuity aid; do not imply unlimited free usage.</a:t>
+            </a:r>
+          </a:p>
+        </p:txBody>
+      </p:sp>
+      <p:sp>
+        <p:nvSpPr>
+          <p:cNvPr id="4" name="Slide Number Placeholder 3"/>
+          <p:cNvSpPr>
+            <a:spLocks noGrp="1"/>
+          </p:cNvSpPr>
+          <p:nvPr>
+            <p:ph type="sldNum" idx="5" sz="quarter"/>
+          </p:nvPr>
+        </p:nvSpPr>
+        <p:spPr/>
+      </p:sp>
+    </p:spTree>
+  </p:cSld>
+  <p:clrMapOvr>
+    <a:masterClrMapping/>
+  </p:clrMapOvr>
+</p:notes>
+</file>
+
+<file path=ppt/notesSlides/notesSlide17.xml><?xml version="1.0" encoding="utf-8"?>
+<p:notes xmlns:a="http://schemas.openxmlformats.org/drawingml/2006/main" xmlns:p="http://schemas.openxmlformats.org/presentationml/2006/main" xmlns:r="http://schemas.openxmlformats.org/officeDocument/2006/relationships">
+  <p:cSld>
+    <p:spTree>
+      <p:nvGrpSpPr>
+        <p:cNvPr id="1" name=""/>
+        <p:cNvGrpSpPr/>
+        <p:nvPr/>
+      </p:nvGrpSpPr>
+      <p:grpSpPr>
+        <a:xfrm>
+          <a:off x="0" y="0"/>
+          <a:ext cx="0" cy="0"/>
+          <a:chOff x="0" y="0"/>
+          <a:chExt cx="0" cy="0"/>
+        </a:xfrm>
+      </p:grpSpPr>
+      <p:sp>
+        <p:nvSpPr>
+          <p:cNvPr id="2" name="Slide Image Placeholder 1"/>
+          <p:cNvSpPr>
+            <a:spLocks noGrp="1"/>
+          </p:cNvSpPr>
+          <p:nvPr>
+            <p:ph type="sldImg" idx="2"/>
+          </p:nvPr>
+        </p:nvSpPr>
+        <p:spPr/>
+      </p:sp>
+      <p:sp>
+        <p:nvSpPr>
+          <p:cNvPr id="3" name="Notes Placeholder 2"/>
+          <p:cNvSpPr>
+            <a:spLocks noGrp="1"/>
+          </p:cNvSpPr>
+          <p:nvPr>
+            <p:ph type="body" idx="3" sz="quarter"/>
+          </p:nvPr>
+        </p:nvSpPr>
+        <p:spPr/>
+        <p:txBody>
+          <a:bodyPr/>
+          <a:lstStyle/>
+          <a:p>
+            <a:r>
+              <a:t>A GitHub repo can hold code without having a live website. A folder path cannot be submitted as an accessible build link.</a:t>
+            </a:r>
+          </a:p>
+        </p:txBody>
+      </p:sp>
+      <p:sp>
+        <p:nvSpPr>
+          <p:cNvPr id="4" name="Slide Number Placeholder 3"/>
+          <p:cNvSpPr>
+            <a:spLocks noGrp="1"/>
+          </p:cNvSpPr>
+          <p:nvPr>
+            <p:ph type="sldNum" idx="5" sz="quarter"/>
+          </p:nvPr>
+        </p:nvSpPr>
+        <p:spPr/>
+      </p:sp>
+    </p:spTree>
+  </p:cSld>
+  <p:clrMapOvr>
+    <a:masterClrMapping/>
+  </p:clrMapOvr>
+</p:notes>
+</file>
+
+<file path=ppt/notesSlides/notesSlide18.xml><?xml version="1.0" encoding="utf-8"?>
+<p:notes xmlns:a="http://schemas.openxmlformats.org/drawingml/2006/main" xmlns:p="http://schemas.openxmlformats.org/presentationml/2006/main" xmlns:r="http://schemas.openxmlformats.org/officeDocument/2006/relationships">
+  <p:cSld>
+    <p:spTree>
+      <p:nvGrpSpPr>
+        <p:cNvPr id="1" name=""/>
+        <p:cNvGrpSpPr/>
+        <p:nvPr/>
+      </p:nvGrpSpPr>
+      <p:grpSpPr>
+        <a:xfrm>
+          <a:off x="0" y="0"/>
+          <a:ext cx="0" cy="0"/>
+          <a:chOff x="0" y="0"/>
+          <a:chExt cx="0" cy="0"/>
+        </a:xfrm>
+      </p:grpSpPr>
+      <p:sp>
+        <p:nvSpPr>
+          <p:cNvPr id="2" name="Slide Image Placeholder 1"/>
+          <p:cNvSpPr>
+            <a:spLocks noGrp="1"/>
+          </p:cNvSpPr>
+          <p:nvPr>
+            <p:ph type="sldImg" idx="2"/>
+          </p:nvPr>
+        </p:nvSpPr>
+        <p:spPr/>
+      </p:sp>
+      <p:sp>
+        <p:nvSpPr>
+          <p:cNvPr id="3" name="Notes Placeholder 2"/>
+          <p:cNvSpPr>
+            <a:spLocks noGrp="1"/>
+          </p:cNvSpPr>
+          <p:nvPr>
+            <p:ph type="body" idx="3" sz="quarter"/>
+          </p:nvPr>
+        </p:nvSpPr>
+        <p:spPr/>
+        <p:txBody>
+          <a:bodyPr/>
+          <a:lstStyle/>
+          <a:p>
+            <a:r>
+              <a:t>Use an ordinary change as an example: fix a heading, commit “Clarify heading”, push, wait for deployment, verify the live page.</a:t>
+            </a:r>
+          </a:p>
+        </p:txBody>
+      </p:sp>
+      <p:sp>
+        <p:nvSpPr>
+          <p:cNvPr id="4" name="Slide Number Placeholder 3"/>
+          <p:cNvSpPr>
+            <a:spLocks noGrp="1"/>
+          </p:cNvSpPr>
+          <p:nvPr>
+            <p:ph type="sldNum" idx="5" sz="quarter"/>
+          </p:nvPr>
+        </p:nvSpPr>
+        <p:spPr/>
+      </p:sp>
+    </p:spTree>
+  </p:cSld>
+  <p:clrMapOvr>
+    <a:masterClrMapping/>
+  </p:clrMapOvr>
+</p:notes>
+</file>
+
+<file path=ppt/notesSlides/notesSlide19.xml><?xml version="1.0" encoding="utf-8"?>
+<p:notes xmlns:a="http://schemas.openxmlformats.org/drawingml/2006/main" xmlns:p="http://schemas.openxmlformats.org/presentationml/2006/main" xmlns:r="http://schemas.openxmlformats.org/officeDocument/2006/relationships">
+  <p:cSld>
+    <p:spTree>
+      <p:nvGrpSpPr>
+        <p:cNvPr id="1" name=""/>
+        <p:cNvGrpSpPr/>
+        <p:nvPr/>
+      </p:nvGrpSpPr>
+      <p:grpSpPr>
+        <a:xfrm>
+          <a:off x="0" y="0"/>
+          <a:ext cx="0" cy="0"/>
+          <a:chOff x="0" y="0"/>
+          <a:chExt cx="0" cy="0"/>
+        </a:xfrm>
+      </p:grpSpPr>
+      <p:sp>
+        <p:nvSpPr>
+          <p:cNvPr id="2" name="Slide Image Placeholder 1"/>
+          <p:cNvSpPr>
+            <a:spLocks noGrp="1"/>
+          </p:cNvSpPr>
+          <p:nvPr>
+            <p:ph type="sldImg" idx="2"/>
+          </p:nvPr>
+        </p:nvSpPr>
+        <p:spPr/>
+      </p:sp>
+      <p:sp>
+        <p:nvSpPr>
+          <p:cNvPr id="3" name="Notes Placeholder 2"/>
+          <p:cNvSpPr>
+            <a:spLocks noGrp="1"/>
+          </p:cNvSpPr>
+          <p:nvPr>
+            <p:ph type="body" idx="3" sz="quarter"/>
+          </p:nvPr>
+        </p:nvSpPr>
+        <p:spPr/>
+        <p:txBody>
+          <a:bodyPr/>
+          <a:lstStyle/>
+          <a:p>
+            <a:r>
+              <a:t>Repeated local-link issues in actual submissions. For a public build, check that it does not require your account to open.</a:t>
             </a:r>
           </a:p>
         </p:txBody>
@@ -864,7 +1297,497 @@
           <a:lstStyle/>
           <a:p>
             <a:r>
-              <a:t>5:06–5:08. Students can learn the tools by asking the tools. The answer is a starting point, not an authority.</a:t>
+              <a:t>Grounded in actual Week 4/5 submissions: visual intent failed to translate; one build had non-clickable cards; localhost and deployment-permission confusion persisted. Public slides deliberately omit names and private quotes.</a:t>
+            </a:r>
+          </a:p>
+        </p:txBody>
+      </p:sp>
+      <p:sp>
+        <p:nvSpPr>
+          <p:cNvPr id="4" name="Slide Number Placeholder 3"/>
+          <p:cNvSpPr>
+            <a:spLocks noGrp="1"/>
+          </p:cNvSpPr>
+          <p:nvPr>
+            <p:ph type="sldNum" idx="5" sz="quarter"/>
+          </p:nvPr>
+        </p:nvSpPr>
+        <p:spPr/>
+      </p:sp>
+    </p:spTree>
+  </p:cSld>
+  <p:clrMapOvr>
+    <a:masterClrMapping/>
+  </p:clrMapOvr>
+</p:notes>
+</file>
+
+<file path=ppt/notesSlides/notesSlide20.xml><?xml version="1.0" encoding="utf-8"?>
+<p:notes xmlns:a="http://schemas.openxmlformats.org/drawingml/2006/main" xmlns:p="http://schemas.openxmlformats.org/presentationml/2006/main" xmlns:r="http://schemas.openxmlformats.org/officeDocument/2006/relationships">
+  <p:cSld>
+    <p:spTree>
+      <p:nvGrpSpPr>
+        <p:cNvPr id="1" name=""/>
+        <p:cNvGrpSpPr/>
+        <p:nvPr/>
+      </p:nvGrpSpPr>
+      <p:grpSpPr>
+        <a:xfrm>
+          <a:off x="0" y="0"/>
+          <a:ext cx="0" cy="0"/>
+          <a:chOff x="0" y="0"/>
+          <a:chExt cx="0" cy="0"/>
+        </a:xfrm>
+      </p:grpSpPr>
+      <p:sp>
+        <p:nvSpPr>
+          <p:cNvPr id="2" name="Slide Image Placeholder 1"/>
+          <p:cNvSpPr>
+            <a:spLocks noGrp="1"/>
+          </p:cNvSpPr>
+          <p:nvPr>
+            <p:ph type="sldImg" idx="2"/>
+          </p:nvPr>
+        </p:nvSpPr>
+        <p:spPr/>
+      </p:sp>
+      <p:sp>
+        <p:nvSpPr>
+          <p:cNvPr id="3" name="Notes Placeholder 2"/>
+          <p:cNvSpPr>
+            <a:spLocks noGrp="1"/>
+          </p:cNvSpPr>
+          <p:nvPr>
+            <p:ph type="body" idx="3" sz="quarter"/>
+          </p:nvPr>
+        </p:nvSpPr>
+        <p:spPr/>
+        <p:txBody>
+          <a:bodyPr/>
+          <a:lstStyle/>
+          <a:p>
+            <a:r>
+              <a:t>Recent Week 5 publishing confusion was partly Vercel needing GitHub repo access. Do not prescribe Pages for every framework app; the handout is supplemental detail, not essential to the invitation.</a:t>
+            </a:r>
+          </a:p>
+        </p:txBody>
+      </p:sp>
+      <p:sp>
+        <p:nvSpPr>
+          <p:cNvPr id="4" name="Slide Number Placeholder 3"/>
+          <p:cNvSpPr>
+            <a:spLocks noGrp="1"/>
+          </p:cNvSpPr>
+          <p:nvPr>
+            <p:ph type="sldNum" idx="5" sz="quarter"/>
+          </p:nvPr>
+        </p:nvSpPr>
+        <p:spPr/>
+      </p:sp>
+    </p:spTree>
+  </p:cSld>
+  <p:clrMapOvr>
+    <a:masterClrMapping/>
+  </p:clrMapOvr>
+</p:notes>
+</file>
+
+<file path=ppt/notesSlides/notesSlide21.xml><?xml version="1.0" encoding="utf-8"?>
+<p:notes xmlns:a="http://schemas.openxmlformats.org/drawingml/2006/main" xmlns:p="http://schemas.openxmlformats.org/presentationml/2006/main" xmlns:r="http://schemas.openxmlformats.org/officeDocument/2006/relationships">
+  <p:cSld>
+    <p:spTree>
+      <p:nvGrpSpPr>
+        <p:cNvPr id="1" name=""/>
+        <p:cNvGrpSpPr/>
+        <p:nvPr/>
+      </p:nvGrpSpPr>
+      <p:grpSpPr>
+        <a:xfrm>
+          <a:off x="0" y="0"/>
+          <a:ext cx="0" cy="0"/>
+          <a:chOff x="0" y="0"/>
+          <a:chExt cx="0" cy="0"/>
+        </a:xfrm>
+      </p:grpSpPr>
+      <p:sp>
+        <p:nvSpPr>
+          <p:cNvPr id="2" name="Slide Image Placeholder 1"/>
+          <p:cNvSpPr>
+            <a:spLocks noGrp="1"/>
+          </p:cNvSpPr>
+          <p:nvPr>
+            <p:ph type="sldImg" idx="2"/>
+          </p:nvPr>
+        </p:nvSpPr>
+        <p:spPr/>
+      </p:sp>
+      <p:sp>
+        <p:nvSpPr>
+          <p:cNvPr id="3" name="Notes Placeholder 2"/>
+          <p:cNvSpPr>
+            <a:spLocks noGrp="1"/>
+          </p:cNvSpPr>
+          <p:nvPr>
+            <p:ph type="body" idx="3" sz="quarter"/>
+          </p:nvPr>
+        </p:nvSpPr>
+        <p:spPr/>
+        <p:txBody>
+          <a:bodyPr/>
+          <a:lstStyle/>
+          <a:p>
+            <a:r>
+              <a:t>Example: weather service API returns a forecast; an AI connector calls it for a conversation. Conceptual only: no course server URL, setup or connector demo this week.</a:t>
+            </a:r>
+          </a:p>
+        </p:txBody>
+      </p:sp>
+      <p:sp>
+        <p:nvSpPr>
+          <p:cNvPr id="4" name="Slide Number Placeholder 3"/>
+          <p:cNvSpPr>
+            <a:spLocks noGrp="1"/>
+          </p:cNvSpPr>
+          <p:nvPr>
+            <p:ph type="sldNum" idx="5" sz="quarter"/>
+          </p:nvPr>
+        </p:nvSpPr>
+        <p:spPr/>
+      </p:sp>
+    </p:spTree>
+  </p:cSld>
+  <p:clrMapOvr>
+    <a:masterClrMapping/>
+  </p:clrMapOvr>
+</p:notes>
+</file>
+
+<file path=ppt/notesSlides/notesSlide22.xml><?xml version="1.0" encoding="utf-8"?>
+<p:notes xmlns:a="http://schemas.openxmlformats.org/drawingml/2006/main" xmlns:p="http://schemas.openxmlformats.org/presentationml/2006/main" xmlns:r="http://schemas.openxmlformats.org/officeDocument/2006/relationships">
+  <p:cSld>
+    <p:spTree>
+      <p:nvGrpSpPr>
+        <p:cNvPr id="1" name=""/>
+        <p:cNvGrpSpPr/>
+        <p:nvPr/>
+      </p:nvGrpSpPr>
+      <p:grpSpPr>
+        <a:xfrm>
+          <a:off x="0" y="0"/>
+          <a:ext cx="0" cy="0"/>
+          <a:chOff x="0" y="0"/>
+          <a:chExt cx="0" cy="0"/>
+        </a:xfrm>
+      </p:grpSpPr>
+      <p:sp>
+        <p:nvSpPr>
+          <p:cNvPr id="2" name="Slide Image Placeholder 1"/>
+          <p:cNvSpPr>
+            <a:spLocks noGrp="1"/>
+          </p:cNvSpPr>
+          <p:nvPr>
+            <p:ph type="sldImg" idx="2"/>
+          </p:nvPr>
+        </p:nvSpPr>
+        <p:spPr/>
+      </p:sp>
+      <p:sp>
+        <p:nvSpPr>
+          <p:cNvPr id="3" name="Notes Placeholder 2"/>
+          <p:cNvSpPr>
+            <a:spLocks noGrp="1"/>
+          </p:cNvSpPr>
+          <p:nvPr>
+            <p:ph type="body" idx="3" sz="quarter"/>
+          </p:nvPr>
+        </p:nvSpPr>
+        <p:spPr/>
+        <p:txBody>
+          <a:bodyPr/>
+          <a:lstStyle/>
+          <a:p>
+            <a:r>
+              <a:t>Tools extend what the AI can do, not what it should be allowed to do. Responsibilities remain with the person using it. Four Ds stay implicit.</a:t>
+            </a:r>
+          </a:p>
+        </p:txBody>
+      </p:sp>
+      <p:sp>
+        <p:nvSpPr>
+          <p:cNvPr id="4" name="Slide Number Placeholder 3"/>
+          <p:cNvSpPr>
+            <a:spLocks noGrp="1"/>
+          </p:cNvSpPr>
+          <p:nvPr>
+            <p:ph type="sldNum" idx="5" sz="quarter"/>
+          </p:nvPr>
+        </p:nvSpPr>
+        <p:spPr/>
+      </p:sp>
+    </p:spTree>
+  </p:cSld>
+  <p:clrMapOvr>
+    <a:masterClrMapping/>
+  </p:clrMapOvr>
+</p:notes>
+</file>
+
+<file path=ppt/notesSlides/notesSlide23.xml><?xml version="1.0" encoding="utf-8"?>
+<p:notes xmlns:a="http://schemas.openxmlformats.org/drawingml/2006/main" xmlns:p="http://schemas.openxmlformats.org/presentationml/2006/main" xmlns:r="http://schemas.openxmlformats.org/officeDocument/2006/relationships">
+  <p:cSld>
+    <p:spTree>
+      <p:nvGrpSpPr>
+        <p:cNvPr id="1" name=""/>
+        <p:cNvGrpSpPr/>
+        <p:nvPr/>
+      </p:nvGrpSpPr>
+      <p:grpSpPr>
+        <a:xfrm>
+          <a:off x="0" y="0"/>
+          <a:ext cx="0" cy="0"/>
+          <a:chOff x="0" y="0"/>
+          <a:chExt cx="0" cy="0"/>
+        </a:xfrm>
+      </p:grpSpPr>
+      <p:sp>
+        <p:nvSpPr>
+          <p:cNvPr id="2" name="Slide Image Placeholder 1"/>
+          <p:cNvSpPr>
+            <a:spLocks noGrp="1"/>
+          </p:cNvSpPr>
+          <p:nvPr>
+            <p:ph type="sldImg" idx="2"/>
+          </p:nvPr>
+        </p:nvSpPr>
+        <p:spPr/>
+      </p:sp>
+      <p:sp>
+        <p:nvSpPr>
+          <p:cNvPr id="3" name="Notes Placeholder 2"/>
+          <p:cNvSpPr>
+            <a:spLocks noGrp="1"/>
+          </p:cNvSpPr>
+          <p:nvPr>
+            <p:ph type="body" idx="3" sz="quarter"/>
+          </p:nvPr>
+        </p:nvSpPr>
+        <p:spPr/>
+        <p:txBody>
+          <a:bodyPr/>
+          <a:lstStyle/>
+          <a:p>
+            <a:r>
+              <a:t>Every essential access instruction is here, not hidden in a handout. This is how the reading’s coaching idea becomes something students can do tonight.</a:t>
+            </a:r>
+          </a:p>
+        </p:txBody>
+      </p:sp>
+      <p:sp>
+        <p:nvSpPr>
+          <p:cNvPr id="4" name="Slide Number Placeholder 3"/>
+          <p:cNvSpPr>
+            <a:spLocks noGrp="1"/>
+          </p:cNvSpPr>
+          <p:nvPr>
+            <p:ph type="sldNum" idx="5" sz="quarter"/>
+          </p:nvPr>
+        </p:nvSpPr>
+        <p:spPr/>
+      </p:sp>
+    </p:spTree>
+  </p:cSld>
+  <p:clrMapOvr>
+    <a:masterClrMapping/>
+  </p:clrMapOvr>
+</p:notes>
+</file>
+
+<file path=ppt/notesSlides/notesSlide24.xml><?xml version="1.0" encoding="utf-8"?>
+<p:notes xmlns:a="http://schemas.openxmlformats.org/drawingml/2006/main" xmlns:p="http://schemas.openxmlformats.org/presentationml/2006/main" xmlns:r="http://schemas.openxmlformats.org/officeDocument/2006/relationships">
+  <p:cSld>
+    <p:spTree>
+      <p:nvGrpSpPr>
+        <p:cNvPr id="1" name=""/>
+        <p:cNvGrpSpPr/>
+        <p:nvPr/>
+      </p:nvGrpSpPr>
+      <p:grpSpPr>
+        <a:xfrm>
+          <a:off x="0" y="0"/>
+          <a:ext cx="0" cy="0"/>
+          <a:chOff x="0" y="0"/>
+          <a:chExt cx="0" cy="0"/>
+        </a:xfrm>
+      </p:grpSpPr>
+      <p:sp>
+        <p:nvSpPr>
+          <p:cNvPr id="2" name="Slide Image Placeholder 1"/>
+          <p:cNvSpPr>
+            <a:spLocks noGrp="1"/>
+          </p:cNvSpPr>
+          <p:nvPr>
+            <p:ph type="sldImg" idx="2"/>
+          </p:nvPr>
+        </p:nvSpPr>
+        <p:spPr/>
+      </p:sp>
+      <p:sp>
+        <p:nvSpPr>
+          <p:cNvPr id="3" name="Notes Placeholder 2"/>
+          <p:cNvSpPr>
+            <a:spLocks noGrp="1"/>
+          </p:cNvSpPr>
+          <p:nvPr>
+            <p:ph type="body" idx="3" sz="quarter"/>
+          </p:nvPr>
+        </p:nvSpPr>
+        <p:spPr/>
+        <p:txBody>
+          <a:bodyPr/>
+          <a:lstStyle/>
+          <a:p>
+            <a:r>
+              <a:t>This is the only live demo slot, after the teaching content. Do not prescribe a project, script or output. If delayed, discuss a question from the lesson and move to group work.</a:t>
+            </a:r>
+          </a:p>
+        </p:txBody>
+      </p:sp>
+      <p:sp>
+        <p:nvSpPr>
+          <p:cNvPr id="4" name="Slide Number Placeholder 3"/>
+          <p:cNvSpPr>
+            <a:spLocks noGrp="1"/>
+          </p:cNvSpPr>
+          <p:nvPr>
+            <p:ph type="sldNum" idx="5" sz="quarter"/>
+          </p:nvPr>
+        </p:nvSpPr>
+        <p:spPr/>
+      </p:sp>
+    </p:spTree>
+  </p:cSld>
+  <p:clrMapOvr>
+    <a:masterClrMapping/>
+  </p:clrMapOvr>
+</p:notes>
+</file>
+
+<file path=ppt/notesSlides/notesSlide25.xml><?xml version="1.0" encoding="utf-8"?>
+<p:notes xmlns:a="http://schemas.openxmlformats.org/drawingml/2006/main" xmlns:p="http://schemas.openxmlformats.org/presentationml/2006/main" xmlns:r="http://schemas.openxmlformats.org/officeDocument/2006/relationships">
+  <p:cSld>
+    <p:spTree>
+      <p:nvGrpSpPr>
+        <p:cNvPr id="1" name=""/>
+        <p:cNvGrpSpPr/>
+        <p:nvPr/>
+      </p:nvGrpSpPr>
+      <p:grpSpPr>
+        <a:xfrm>
+          <a:off x="0" y="0"/>
+          <a:ext cx="0" cy="0"/>
+          <a:chOff x="0" y="0"/>
+          <a:chExt cx="0" cy="0"/>
+        </a:xfrm>
+      </p:grpSpPr>
+      <p:sp>
+        <p:nvSpPr>
+          <p:cNvPr id="2" name="Slide Image Placeholder 1"/>
+          <p:cNvSpPr>
+            <a:spLocks noGrp="1"/>
+          </p:cNvSpPr>
+          <p:nvPr>
+            <p:ph type="sldImg" idx="2"/>
+          </p:nvPr>
+        </p:nvSpPr>
+        <p:spPr/>
+      </p:sp>
+      <p:sp>
+        <p:nvSpPr>
+          <p:cNvPr id="3" name="Notes Placeholder 2"/>
+          <p:cNvSpPr>
+            <a:spLocks noGrp="1"/>
+          </p:cNvSpPr>
+          <p:nvPr>
+            <p:ph type="body" idx="3" sz="quarter"/>
+          </p:nvPr>
+        </p:nvSpPr>
+        <p:spPr/>
+        <p:txBody>
+          <a:bodyPr/>
+          <a:lstStyle/>
+          <a:p>
+            <a:r>
+              <a:t>Open-ended invitation, no fixed template or prescribed roles. Help students choose a small first learning goal without deciding their project for them.</a:t>
+            </a:r>
+          </a:p>
+        </p:txBody>
+      </p:sp>
+      <p:sp>
+        <p:nvSpPr>
+          <p:cNvPr id="4" name="Slide Number Placeholder 3"/>
+          <p:cNvSpPr>
+            <a:spLocks noGrp="1"/>
+          </p:cNvSpPr>
+          <p:nvPr>
+            <p:ph type="sldNum" idx="5" sz="quarter"/>
+          </p:nvPr>
+        </p:nvSpPr>
+        <p:spPr/>
+      </p:sp>
+    </p:spTree>
+  </p:cSld>
+  <p:clrMapOvr>
+    <a:masterClrMapping/>
+  </p:clrMapOvr>
+</p:notes>
+</file>
+
+<file path=ppt/notesSlides/notesSlide26.xml><?xml version="1.0" encoding="utf-8"?>
+<p:notes xmlns:a="http://schemas.openxmlformats.org/drawingml/2006/main" xmlns:p="http://schemas.openxmlformats.org/presentationml/2006/main" xmlns:r="http://schemas.openxmlformats.org/officeDocument/2006/relationships">
+  <p:cSld>
+    <p:spTree>
+      <p:nvGrpSpPr>
+        <p:cNvPr id="1" name=""/>
+        <p:cNvGrpSpPr/>
+        <p:nvPr/>
+      </p:nvGrpSpPr>
+      <p:grpSpPr>
+        <a:xfrm>
+          <a:off x="0" y="0"/>
+          <a:ext cx="0" cy="0"/>
+          <a:chOff x="0" y="0"/>
+          <a:chExt cx="0" cy="0"/>
+        </a:xfrm>
+      </p:grpSpPr>
+      <p:sp>
+        <p:nvSpPr>
+          <p:cNvPr id="2" name="Slide Image Placeholder 1"/>
+          <p:cNvSpPr>
+            <a:spLocks noGrp="1"/>
+          </p:cNvSpPr>
+          <p:nvPr>
+            <p:ph type="sldImg" idx="2"/>
+          </p:nvPr>
+        </p:nvSpPr>
+        <p:spPr/>
+      </p:sp>
+      <p:sp>
+        <p:nvSpPr>
+          <p:cNvPr id="3" name="Notes Placeholder 2"/>
+          <p:cNvSpPr>
+            <a:spLocks noGrp="1"/>
+          </p:cNvSpPr>
+          <p:nvPr>
+            <p:ph type="body" idx="3" sz="quarter"/>
+          </p:nvPr>
+        </p:nvSpPr>
+        <p:spPr/>
+        <p:txBody>
+          <a:bodyPr/>
+          <a:lstStyle/>
+          <a:p>
+            <a:r>
+              <a:t>Optional: ask your AI what it needs to know about your project; save the useful context in markdown. Students can find the lesson from the preceding slide. No due date added.</a:t>
             </a:r>
           </a:p>
         </p:txBody>
@@ -934,7 +1857,7 @@
           <a:lstStyle/>
           <a:p>
             <a:r>
-              <a:t>5:08–5:10. Explicit tie: Shipper used her AI as a coach, reflecting on actual projects and learning the next step. Without long chat history, paste your last two submissions or describe what you have tried. The free reading link is in your account. No due date announced.</a:t>
+              <a:t>Students recently asked their tools to explain the tool itself while building. Model this as a learning practice, not outsourcing understanding.</a:t>
             </a:r>
           </a:p>
         </p:txBody>
@@ -1004,7 +1927,7 @@
           <a:lstStyle/>
           <a:p>
             <a:r>
-              <a:t>5:10–5:12. # marks a heading; - marks a list. The lesson itself is markdown. No technical deep dive.</a:t>
+              <a:t>Assigned reading. Shipper turned reflection on actual projects into a coaching conversation. The reading link is in students’ accounts; no new due date.</a:t>
             </a:r>
           </a:p>
         </p:txBody>
@@ -1074,7 +1997,7 @@
           <a:lstStyle/>
           <a:p>
             <a:r>
-              <a:t>5:12–5:14. Specific support varies by tool. These are ordinary files with plain words. They help the next session know what you mean without re-explaining everything. No live demo here and no template.</a:t>
+              <a:t>Free plans need not have long-term memory. Give a small truthful sample, not every private conversation.</a:t>
             </a:r>
           </a:p>
         </p:txBody>
@@ -1144,7 +2067,7 @@
           <a:lstStyle/>
           <a:p>
             <a:r>
-              <a:t>5:14–5:16. Read the example as what you would tell a new teammate. The point is persistent context, not a prescribed format.</a:t>
+              <a:t>Explain portability: the same text works across tools. A file can be edited without a platform account.</a:t>
             </a:r>
           </a:p>
         </p:txBody>
@@ -1214,7 +2137,7 @@
           <a:lstStyle/>
           <a:p>
             <a:r>
-              <a:t>5:16–5:18. Commit saves a version locally. Push sends it to GitHub. Deploy publishes a website.</a:t>
+              <a:t>Point out # and ## headings; - list; [label](URL) link; backticks for code. These are examples, not a context template.</a:t>
             </a:r>
           </a:p>
         </p:txBody>
@@ -1284,7 +2207,7 @@
           <a:lstStyle/>
           <a:p>
             <a:r>
-              <a:t>5:18–5:20. Plain HTML/CSS: Pages. A framework app may need a different host such as Vercel. The handout is optional detail; all essential concepts are on this slide. No deployment demo tonight.</a:t>
+              <a:t>Avoid claiming every app literally starts at zero: some add saved memory or project files. Ask what context the tool loaded.</a:t>
             </a:r>
           </a:p>
         </p:txBody>
@@ -1354,7 +2277,7 @@
           <a:lstStyle/>
           <a:p>
             <a:r>
-              <a:t>5:20–5:22. Concept only; no course connector, server address or setup.</a:t>
+              <a:t>These are useful questions, not a rigid template or pair interview. Student projects vary: portfolios, creative work, tools, simulations.</a:t>
             </a:r>
           </a:p>
         </p:txBody>
@@ -4461,7 +5384,7 @@
                 </a:solidFill>
                 <a:latin typeface="DM Sans"/>
               </a:rPr>
-              <a:t>Use AI to understand AI. Then build something that helps you learn.</a:t>
+              <a:t>Context, communication, checking, and building for your learning.</a:t>
             </a:r>
           </a:p>
           <a:p>
@@ -4516,7 +5439,7 @@
                 </a:solidFill>
                 <a:latin typeface="DM Sans"/>
               </a:rPr>
-              <a:t>Week 6 · Opening        1 / 13</a:t>
+              <a:t>Week 6 · Opening        1 / 26</a:t>
             </a:r>
           </a:p>
         </p:txBody>
@@ -4618,13 +5541,13 @@
               </a:spcAft>
             </a:pPr>
             <a:r>
-              <a:rPr sz="3200" b="1">
+              <a:rPr sz="4000" b="1">
                 <a:solidFill>
                   <a:srgbClr val="272A25"/>
                 </a:solidFill>
                 <a:latin typeface="Fraunces"/>
               </a:rPr>
-              <a:t>Everything you need is on the Week 6 page</a:t>
+              <a:t>Automatic loading is tool-specific</a:t>
             </a:r>
           </a:p>
         </p:txBody>
@@ -4663,7 +5586,7 @@
                 </a:solidFill>
                 <a:latin typeface="DM Sans"/>
               </a:rPr>
-              <a:t>•  cu.learnvibe.build → Everything for Week 6</a:t>
+              <a:t>•  Codex uses AGENTS.md; Claude Code uses CLAUDE.md.</a:t>
             </a:r>
           </a:p>
           <a:p>
@@ -4679,7 +5602,7 @@
                 </a:solidFill>
                 <a:latin typeface="DM Sans"/>
               </a:rPr>
-              <a:t>•  Click “Copy lesson as markdown” → paste into your AI.</a:t>
+              <a:t>•  Other tools have their own rules and supported filenames—check yours.</a:t>
             </a:r>
           </a:p>
           <a:p>
@@ -4695,7 +5618,7 @@
                 </a:solidFill>
                 <a:latin typeface="DM Sans"/>
               </a:rPr>
-              <a:t>•  Ask: “Teach me this and quiz me.”</a:t>
+              <a:t>•  In a chat app, paste the context or add it to a Project; it may not read local files.</a:t>
             </a:r>
           </a:p>
         </p:txBody>
@@ -4734,7 +5657,7 @@
                 </a:solidFill>
                 <a:latin typeface="DM Sans"/>
               </a:rPr>
-              <a:t>Week 6 · Learn with AI        10 / 13</a:t>
+              <a:t>Week 6 · Ongoing context        10 / 26</a:t>
             </a:r>
           </a:p>
         </p:txBody>
@@ -4842,7 +5765,7 @@
                 </a:solidFill>
                 <a:latin typeface="Fraunces"/>
               </a:rPr>
-              <a:t>One live conversation with Claude</a:t>
+              <a:t>An index points to deeper context</a:t>
             </a:r>
           </a:p>
         </p:txBody>
@@ -4881,7 +5804,7 @@
                 </a:solidFill>
                 <a:latin typeface="DM Sans"/>
               </a:rPr>
-              <a:t>•  Copy the lesson markdown into Claude.</a:t>
+              <a:t>•  A small index says which files exist and what each is for.</a:t>
             </a:r>
           </a:p>
           <a:p>
@@ -4897,7 +5820,7 @@
                 </a:solidFill>
                 <a:latin typeface="DM Sans"/>
               </a:rPr>
-              <a:t>•  Talk through what you want to understand.</a:t>
+              <a:t>•  Example: docs/facts.md → verified facts; docs/design.md → visual direction.</a:t>
             </a:r>
           </a:p>
           <a:p>
@@ -4913,7 +5836,7 @@
                 </a:solidFill>
                 <a:latin typeface="DM Sans"/>
               </a:rPr>
-              <a:t>•  Maybe ask Claude to build a little thing from that conversation.</a:t>
+              <a:t>•  The AI can open the relevant document instead of receiving one giant prompt.</a:t>
             </a:r>
           </a:p>
         </p:txBody>
@@ -4952,7 +5875,7 @@
                 </a:solidFill>
                 <a:latin typeface="DM Sans"/>
               </a:rPr>
-              <a:t>Week 6 · Live demo        11 / 13</a:t>
+              <a:t>Week 6 · Ongoing context        11 / 26</a:t>
             </a:r>
           </a:p>
         </p:txBody>
@@ -5060,7 +5983,7 @@
                 </a:solidFill>
                 <a:latin typeface="Fraunces"/>
               </a:rPr>
-              <a:t>In small groups: build something that helps you learn</a:t>
+              <a:t>Describe the design, not just the features</a:t>
             </a:r>
           </a:p>
         </p:txBody>
@@ -5099,7 +6022,7 @@
                 </a:solidFill>
                 <a:latin typeface="DM Sans"/>
               </a:rPr>
-              <a:t>•  Choose your own topic and approach.</a:t>
+              <a:t>•  “Make it better” leaves the visual choices to the model.</a:t>
             </a:r>
           </a:p>
           <a:p>
@@ -5115,7 +6038,7 @@
                 </a:solidFill>
                 <a:latin typeface="DM Sans"/>
               </a:rPr>
-              <a:t>•  Try a quiz, interactive explainer, practice tool—or your own idea.</a:t>
+              <a:t>•  Name the audience, feeling, hierarchy and interactions you want.</a:t>
             </a:r>
           </a:p>
           <a:p>
@@ -5131,7 +6054,7 @@
                 </a:solidFill>
                 <a:latin typeface="DM Sans"/>
               </a:rPr>
-              <a:t>•  Use your AI, test what you build, and show what it helped you learn.</a:t>
+              <a:t>•  Example: “Calm portfolio. Work first, muted colours, clickable project cards.”</a:t>
             </a:r>
           </a:p>
         </p:txBody>
@@ -5170,7 +6093,7 @@
                 </a:solidFill>
                 <a:latin typeface="DM Sans"/>
               </a:rPr>
-              <a:t>Week 6 · Group work        12 / 13</a:t>
+              <a:t>Week 6 · Communicate intent        12 / 26</a:t>
             </a:r>
           </a:p>
         </p:txBody>
@@ -5278,7 +6201,7 @@
                 </a:solidFill>
                 <a:latin typeface="Fraunces"/>
               </a:rPr>
-              <a:t>Start with a learning question</a:t>
+              <a:t>Make your feedback observable</a:t>
             </a:r>
           </a:p>
         </p:txBody>
@@ -5317,7 +6240,7 @@
                 </a:solidFill>
                 <a:latin typeface="DM Sans"/>
               </a:rPr>
-              <a:t>•  What do you want to understand or practise?</a:t>
+              <a:t>•  Give a reference or screenshot; say what to keep and what to change.</a:t>
             </a:r>
           </a:p>
           <a:p>
@@ -5333,7 +6256,7 @@
                 </a:solidFill>
                 <a:latin typeface="DM Sans"/>
               </a:rPr>
-              <a:t>•  Give your AI the lesson, your question, or both.</a:t>
+              <a:t>•  Instead of “It’s broken”: “Clicking this card should open the project; nothing happens.”</a:t>
             </a:r>
           </a:p>
           <a:p>
@@ -5349,7 +6272,7 @@
                 </a:solidFill>
                 <a:latin typeface="DM Sans"/>
               </a:rPr>
-              <a:t>•  Build a small first version; try it and revise.</a:t>
+              <a:t>•  Ask for one small change, then compare the result with your intention.</a:t>
             </a:r>
           </a:p>
         </p:txBody>
@@ -5388,7 +6311,1315 @@
                 </a:solidFill>
                 <a:latin typeface="DM Sans"/>
               </a:rPr>
-              <a:t>Week 6 · Group work        13 / 13</a:t>
+              <a:t>Week 6 · Communicate intent        13 / 26</a:t>
+            </a:r>
+          </a:p>
+        </p:txBody>
+      </p:sp>
+    </p:spTree>
+  </p:cSld>
+  <p:clrMapOvr>
+    <a:masterClrMapping/>
+  </p:clrMapOvr>
+</p:sld>
+</file>
+
+<file path=ppt/slides/slide14.xml><?xml version="1.0" encoding="utf-8"?>
+<p:sld xmlns:a="http://schemas.openxmlformats.org/drawingml/2006/main" xmlns:p="http://schemas.openxmlformats.org/presentationml/2006/main" xmlns:r="http://schemas.openxmlformats.org/officeDocument/2006/relationships">
+  <p:cSld>
+    <p:bg>
+      <p:bgPr>
+        <a:solidFill>
+          <a:srgbClr val="F7F5EE"/>
+        </a:solidFill>
+        <a:effectLst/>
+      </p:bgPr>
+    </p:bg>
+    <p:spTree>
+      <p:nvGrpSpPr>
+        <p:cNvPr id="1" name=""/>
+        <p:cNvGrpSpPr/>
+        <p:nvPr/>
+      </p:nvGrpSpPr>
+      <p:grpSpPr/>
+      <p:sp>
+        <p:nvSpPr>
+          <p:cNvPr id="2" name="Rectangle 1"/>
+          <p:cNvSpPr/>
+          <p:nvPr/>
+        </p:nvSpPr>
+        <p:spPr>
+          <a:xfrm>
+            <a:off x="0" y="0"/>
+            <a:ext cx="228600" cy="6858000"/>
+          </a:xfrm>
+          <a:prstGeom prst="rect">
+            <a:avLst/>
+          </a:prstGeom>
+          <a:solidFill>
+            <a:srgbClr val="A83D2B"/>
+          </a:solidFill>
+          <a:ln>
+            <a:noFill/>
+          </a:ln>
+        </p:spPr>
+        <p:style>
+          <a:lnRef idx="1">
+            <a:schemeClr val="accent1"/>
+          </a:lnRef>
+          <a:fillRef idx="3">
+            <a:schemeClr val="accent1"/>
+          </a:fillRef>
+          <a:effectRef idx="2">
+            <a:schemeClr val="accent1"/>
+          </a:effectRef>
+          <a:fontRef idx="minor">
+            <a:schemeClr val="lt1"/>
+          </a:fontRef>
+        </p:style>
+        <p:txBody>
+          <a:bodyPr rtlCol="0" anchor="ctr"/>
+          <a:lstStyle/>
+          <a:p>
+            <a:pPr algn="ctr"/>
+          </a:p>
+        </p:txBody>
+      </p:sp>
+      <p:sp>
+        <p:nvSpPr>
+          <p:cNvPr id="3" name="TextBox 2"/>
+          <p:cNvSpPr txBox="1"/>
+          <p:nvPr/>
+        </p:nvSpPr>
+        <p:spPr>
+          <a:xfrm>
+            <a:off x="822960" y="548640"/>
+            <a:ext cx="10607040" cy="1188720"/>
+          </a:xfrm>
+          <a:prstGeom prst="rect">
+            <a:avLst/>
+          </a:prstGeom>
+          <a:noFill/>
+        </p:spPr>
+        <p:txBody>
+          <a:bodyPr wrap="square">
+            <a:spAutoFit/>
+          </a:bodyPr>
+          <a:lstStyle/>
+          <a:p>
+            <a:pPr>
+              <a:spcAft>
+                <a:spcPts val="1400"/>
+              </a:spcAft>
+            </a:pPr>
+            <a:r>
+              <a:rPr sz="4000" b="1">
+                <a:solidFill>
+                  <a:srgbClr val="272A25"/>
+                </a:solidFill>
+                <a:latin typeface="Fraunces"/>
+              </a:rPr>
+              <a:t>Debugging: find the mismatch</a:t>
+            </a:r>
+          </a:p>
+        </p:txBody>
+      </p:sp>
+      <p:sp>
+        <p:nvSpPr>
+          <p:cNvPr id="4" name="TextBox 3"/>
+          <p:cNvSpPr txBox="1"/>
+          <p:nvPr/>
+        </p:nvSpPr>
+        <p:spPr>
+          <a:xfrm>
+            <a:off x="822960" y="2011680"/>
+            <a:ext cx="10607040" cy="4206240"/>
+          </a:xfrm>
+          <a:prstGeom prst="rect">
+            <a:avLst/>
+          </a:prstGeom>
+          <a:noFill/>
+        </p:spPr>
+        <p:txBody>
+          <a:bodyPr wrap="square">
+            <a:spAutoFit/>
+          </a:bodyPr>
+          <a:lstStyle/>
+          <a:p>
+            <a:pPr>
+              <a:spcAft>
+                <a:spcPts val="2200"/>
+              </a:spcAft>
+            </a:pPr>
+            <a:r>
+              <a:rPr sz="3000" b="0">
+                <a:solidFill>
+                  <a:srgbClr val="272A25"/>
+                </a:solidFill>
+                <a:latin typeface="DM Sans"/>
+              </a:rPr>
+              <a:t>•  A bug is a difference between expected and observed behavior.</a:t>
+            </a:r>
+          </a:p>
+          <a:p>
+            <a:pPr>
+              <a:spcAft>
+                <a:spcPts val="2200"/>
+              </a:spcAft>
+            </a:pPr>
+            <a:r>
+              <a:rPr sz="3000" b="0">
+                <a:solidFill>
+                  <a:srgbClr val="272A25"/>
+                </a:solidFill>
+                <a:latin typeface="DM Sans"/>
+              </a:rPr>
+              <a:t>•  Reproduce it: what exact actions cause it? Capture the error or screenshot.</a:t>
+            </a:r>
+          </a:p>
+          <a:p>
+            <a:pPr>
+              <a:spcAft>
+                <a:spcPts val="2200"/>
+              </a:spcAft>
+            </a:pPr>
+            <a:r>
+              <a:rPr sz="3000" b="0">
+                <a:solidFill>
+                  <a:srgbClr val="272A25"/>
+                </a:solidFill>
+                <a:latin typeface="DM Sans"/>
+              </a:rPr>
+              <a:t>•  Ask the AI for a cause and a small fix; rerun the same check afterward.</a:t>
+            </a:r>
+          </a:p>
+        </p:txBody>
+      </p:sp>
+      <p:sp>
+        <p:nvSpPr>
+          <p:cNvPr id="5" name="TextBox 4"/>
+          <p:cNvSpPr txBox="1"/>
+          <p:nvPr/>
+        </p:nvSpPr>
+        <p:spPr>
+          <a:xfrm>
+            <a:off x="822960" y="6263640"/>
+            <a:ext cx="10607040" cy="365760"/>
+          </a:xfrm>
+          <a:prstGeom prst="rect">
+            <a:avLst/>
+          </a:prstGeom>
+          <a:noFill/>
+        </p:spPr>
+        <p:txBody>
+          <a:bodyPr wrap="square">
+            <a:spAutoFit/>
+          </a:bodyPr>
+          <a:lstStyle/>
+          <a:p>
+            <a:pPr algn="r">
+              <a:spcAft>
+                <a:spcPts val="1400"/>
+              </a:spcAft>
+            </a:pPr>
+            <a:r>
+              <a:rPr sz="1600" b="0">
+                <a:solidFill>
+                  <a:srgbClr val="64665D"/>
+                </a:solidFill>
+                <a:latin typeface="DM Sans"/>
+              </a:rPr>
+              <a:t>Week 6 · Check the work        14 / 26</a:t>
+            </a:r>
+          </a:p>
+        </p:txBody>
+      </p:sp>
+    </p:spTree>
+  </p:cSld>
+  <p:clrMapOvr>
+    <a:masterClrMapping/>
+  </p:clrMapOvr>
+</p:sld>
+</file>
+
+<file path=ppt/slides/slide15.xml><?xml version="1.0" encoding="utf-8"?>
+<p:sld xmlns:a="http://schemas.openxmlformats.org/drawingml/2006/main" xmlns:p="http://schemas.openxmlformats.org/presentationml/2006/main" xmlns:r="http://schemas.openxmlformats.org/officeDocument/2006/relationships">
+  <p:cSld>
+    <p:bg>
+      <p:bgPr>
+        <a:solidFill>
+          <a:srgbClr val="F7F5EE"/>
+        </a:solidFill>
+        <a:effectLst/>
+      </p:bgPr>
+    </p:bg>
+    <p:spTree>
+      <p:nvGrpSpPr>
+        <p:cNvPr id="1" name=""/>
+        <p:cNvGrpSpPr/>
+        <p:nvPr/>
+      </p:nvGrpSpPr>
+      <p:grpSpPr/>
+      <p:sp>
+        <p:nvSpPr>
+          <p:cNvPr id="2" name="Rectangle 1"/>
+          <p:cNvSpPr/>
+          <p:nvPr/>
+        </p:nvSpPr>
+        <p:spPr>
+          <a:xfrm>
+            <a:off x="0" y="0"/>
+            <a:ext cx="228600" cy="6858000"/>
+          </a:xfrm>
+          <a:prstGeom prst="rect">
+            <a:avLst/>
+          </a:prstGeom>
+          <a:solidFill>
+            <a:srgbClr val="A83D2B"/>
+          </a:solidFill>
+          <a:ln>
+            <a:noFill/>
+          </a:ln>
+        </p:spPr>
+        <p:style>
+          <a:lnRef idx="1">
+            <a:schemeClr val="accent1"/>
+          </a:lnRef>
+          <a:fillRef idx="3">
+            <a:schemeClr val="accent1"/>
+          </a:fillRef>
+          <a:effectRef idx="2">
+            <a:schemeClr val="accent1"/>
+          </a:effectRef>
+          <a:fontRef idx="minor">
+            <a:schemeClr val="lt1"/>
+          </a:fontRef>
+        </p:style>
+        <p:txBody>
+          <a:bodyPr rtlCol="0" anchor="ctr"/>
+          <a:lstStyle/>
+          <a:p>
+            <a:pPr algn="ctr"/>
+          </a:p>
+        </p:txBody>
+      </p:sp>
+      <p:sp>
+        <p:nvSpPr>
+          <p:cNvPr id="3" name="TextBox 2"/>
+          <p:cNvSpPr txBox="1"/>
+          <p:nvPr/>
+        </p:nvSpPr>
+        <p:spPr>
+          <a:xfrm>
+            <a:off x="822960" y="548640"/>
+            <a:ext cx="10607040" cy="1188720"/>
+          </a:xfrm>
+          <a:prstGeom prst="rect">
+            <a:avLst/>
+          </a:prstGeom>
+          <a:noFill/>
+        </p:spPr>
+        <p:txBody>
+          <a:bodyPr wrap="square">
+            <a:spAutoFit/>
+          </a:bodyPr>
+          <a:lstStyle/>
+          <a:p>
+            <a:pPr>
+              <a:spcAft>
+                <a:spcPts val="1400"/>
+              </a:spcAft>
+            </a:pPr>
+            <a:r>
+              <a:rPr sz="4000" b="1">
+                <a:solidFill>
+                  <a:srgbClr val="272A25"/>
+                </a:solidFill>
+                <a:latin typeface="Fraunces"/>
+              </a:rPr>
+              <a:t>Check the experience—not just the code</a:t>
+            </a:r>
+          </a:p>
+        </p:txBody>
+      </p:sp>
+      <p:sp>
+        <p:nvSpPr>
+          <p:cNvPr id="4" name="TextBox 3"/>
+          <p:cNvSpPr txBox="1"/>
+          <p:nvPr/>
+        </p:nvSpPr>
+        <p:spPr>
+          <a:xfrm>
+            <a:off x="822960" y="2011680"/>
+            <a:ext cx="10607040" cy="4206240"/>
+          </a:xfrm>
+          <a:prstGeom prst="rect">
+            <a:avLst/>
+          </a:prstGeom>
+          <a:noFill/>
+        </p:spPr>
+        <p:txBody>
+          <a:bodyPr wrap="square">
+            <a:spAutoFit/>
+          </a:bodyPr>
+          <a:lstStyle/>
+          <a:p>
+            <a:pPr>
+              <a:spcAft>
+                <a:spcPts val="2200"/>
+              </a:spcAft>
+            </a:pPr>
+            <a:r>
+              <a:rPr sz="3000" b="0">
+                <a:solidFill>
+                  <a:srgbClr val="272A25"/>
+                </a:solidFill>
+                <a:latin typeface="DM Sans"/>
+              </a:rPr>
+              <a:t>•  Open it on a phone. Click every important button and link.</a:t>
+            </a:r>
+          </a:p>
+          <a:p>
+            <a:pPr>
+              <a:spcAft>
+                <a:spcPts val="2200"/>
+              </a:spcAft>
+            </a:pPr>
+            <a:r>
+              <a:rPr sz="3000" b="0">
+                <a:solidFill>
+                  <a:srgbClr val="272A25"/>
+                </a:solidFill>
+                <a:latin typeface="DM Sans"/>
+              </a:rPr>
+              <a:t>•  Try empty input, a strange answer, or a first-time visitor’s path.</a:t>
+            </a:r>
+          </a:p>
+          <a:p>
+            <a:pPr>
+              <a:spcAft>
+                <a:spcPts val="2200"/>
+              </a:spcAft>
+            </a:pPr>
+            <a:r>
+              <a:rPr sz="3000" b="0">
+                <a:solidFill>
+                  <a:srgbClr val="272A25"/>
+                </a:solidFill>
+                <a:latin typeface="DM Sans"/>
+              </a:rPr>
+              <a:t>•  For a learning tool, check its facts and quiz answers against a trustworthy source.</a:t>
+            </a:r>
+          </a:p>
+        </p:txBody>
+      </p:sp>
+      <p:sp>
+        <p:nvSpPr>
+          <p:cNvPr id="5" name="TextBox 4"/>
+          <p:cNvSpPr txBox="1"/>
+          <p:nvPr/>
+        </p:nvSpPr>
+        <p:spPr>
+          <a:xfrm>
+            <a:off x="822960" y="6263640"/>
+            <a:ext cx="10607040" cy="365760"/>
+          </a:xfrm>
+          <a:prstGeom prst="rect">
+            <a:avLst/>
+          </a:prstGeom>
+          <a:noFill/>
+        </p:spPr>
+        <p:txBody>
+          <a:bodyPr wrap="square">
+            <a:spAutoFit/>
+          </a:bodyPr>
+          <a:lstStyle/>
+          <a:p>
+            <a:pPr algn="r">
+              <a:spcAft>
+                <a:spcPts val="1400"/>
+              </a:spcAft>
+            </a:pPr>
+            <a:r>
+              <a:rPr sz="1600" b="0">
+                <a:solidFill>
+                  <a:srgbClr val="64665D"/>
+                </a:solidFill>
+                <a:latin typeface="DM Sans"/>
+              </a:rPr>
+              <a:t>Week 6 · Check the work        15 / 26</a:t>
+            </a:r>
+          </a:p>
+        </p:txBody>
+      </p:sp>
+    </p:spTree>
+  </p:cSld>
+  <p:clrMapOvr>
+    <a:masterClrMapping/>
+  </p:clrMapOvr>
+</p:sld>
+</file>
+
+<file path=ppt/slides/slide16.xml><?xml version="1.0" encoding="utf-8"?>
+<p:sld xmlns:a="http://schemas.openxmlformats.org/drawingml/2006/main" xmlns:p="http://schemas.openxmlformats.org/presentationml/2006/main" xmlns:r="http://schemas.openxmlformats.org/officeDocument/2006/relationships">
+  <p:cSld>
+    <p:bg>
+      <p:bgPr>
+        <a:solidFill>
+          <a:srgbClr val="F7F5EE"/>
+        </a:solidFill>
+        <a:effectLst/>
+      </p:bgPr>
+    </p:bg>
+    <p:spTree>
+      <p:nvGrpSpPr>
+        <p:cNvPr id="1" name=""/>
+        <p:cNvGrpSpPr/>
+        <p:nvPr/>
+      </p:nvGrpSpPr>
+      <p:grpSpPr/>
+      <p:sp>
+        <p:nvSpPr>
+          <p:cNvPr id="2" name="Rectangle 1"/>
+          <p:cNvSpPr/>
+          <p:nvPr/>
+        </p:nvSpPr>
+        <p:spPr>
+          <a:xfrm>
+            <a:off x="0" y="0"/>
+            <a:ext cx="228600" cy="6858000"/>
+          </a:xfrm>
+          <a:prstGeom prst="rect">
+            <a:avLst/>
+          </a:prstGeom>
+          <a:solidFill>
+            <a:srgbClr val="A83D2B"/>
+          </a:solidFill>
+          <a:ln>
+            <a:noFill/>
+          </a:ln>
+        </p:spPr>
+        <p:style>
+          <a:lnRef idx="1">
+            <a:schemeClr val="accent1"/>
+          </a:lnRef>
+          <a:fillRef idx="3">
+            <a:schemeClr val="accent1"/>
+          </a:fillRef>
+          <a:effectRef idx="2">
+            <a:schemeClr val="accent1"/>
+          </a:effectRef>
+          <a:fontRef idx="minor">
+            <a:schemeClr val="lt1"/>
+          </a:fontRef>
+        </p:style>
+        <p:txBody>
+          <a:bodyPr rtlCol="0" anchor="ctr"/>
+          <a:lstStyle/>
+          <a:p>
+            <a:pPr algn="ctr"/>
+          </a:p>
+        </p:txBody>
+      </p:sp>
+      <p:sp>
+        <p:nvSpPr>
+          <p:cNvPr id="3" name="TextBox 2"/>
+          <p:cNvSpPr txBox="1"/>
+          <p:nvPr/>
+        </p:nvSpPr>
+        <p:spPr>
+          <a:xfrm>
+            <a:off x="822960" y="548640"/>
+            <a:ext cx="10607040" cy="1188720"/>
+          </a:xfrm>
+          <a:prstGeom prst="rect">
+            <a:avLst/>
+          </a:prstGeom>
+          <a:noFill/>
+        </p:spPr>
+        <p:txBody>
+          <a:bodyPr wrap="square">
+            <a:spAutoFit/>
+          </a:bodyPr>
+          <a:lstStyle/>
+          <a:p>
+            <a:pPr>
+              <a:spcAft>
+                <a:spcPts val="1400"/>
+              </a:spcAft>
+            </a:pPr>
+            <a:r>
+              <a:rPr sz="4000" b="1">
+                <a:solidFill>
+                  <a:srgbClr val="272A25"/>
+                </a:solidFill>
+                <a:latin typeface="Fraunces"/>
+              </a:rPr>
+              <a:t>When free credits run out</a:t>
+            </a:r>
+          </a:p>
+        </p:txBody>
+      </p:sp>
+      <p:sp>
+        <p:nvSpPr>
+          <p:cNvPr id="4" name="TextBox 3"/>
+          <p:cNvSpPr txBox="1"/>
+          <p:nvPr/>
+        </p:nvSpPr>
+        <p:spPr>
+          <a:xfrm>
+            <a:off x="822960" y="2011680"/>
+            <a:ext cx="10607040" cy="4206240"/>
+          </a:xfrm>
+          <a:prstGeom prst="rect">
+            <a:avLst/>
+          </a:prstGeom>
+          <a:noFill/>
+        </p:spPr>
+        <p:txBody>
+          <a:bodyPr wrap="square">
+            <a:spAutoFit/>
+          </a:bodyPr>
+          <a:lstStyle/>
+          <a:p>
+            <a:pPr>
+              <a:spcAft>
+                <a:spcPts val="2200"/>
+              </a:spcAft>
+            </a:pPr>
+            <a:r>
+              <a:rPr sz="3000" b="0">
+                <a:solidFill>
+                  <a:srgbClr val="272A25"/>
+                </a:solidFill>
+                <a:latin typeface="DM Sans"/>
+              </a:rPr>
+              <a:t>•  Save files and a short note: what works, what failed, what to try next.</a:t>
+            </a:r>
+          </a:p>
+          <a:p>
+            <a:pPr>
+              <a:spcAft>
+                <a:spcPts val="2200"/>
+              </a:spcAft>
+            </a:pPr>
+            <a:r>
+              <a:rPr sz="3000" b="0">
+                <a:solidFill>
+                  <a:srgbClr val="272A25"/>
+                </a:solidFill>
+                <a:latin typeface="DM Sans"/>
+              </a:rPr>
+              <a:t>•  Use that note to continue in a fresh session or another tool.</a:t>
+            </a:r>
+          </a:p>
+          <a:p>
+            <a:pPr>
+              <a:spcAft>
+                <a:spcPts val="2200"/>
+              </a:spcAft>
+            </a:pPr>
+            <a:r>
+              <a:rPr sz="3000" b="0">
+                <a:solidFill>
+                  <a:srgbClr val="272A25"/>
+                </a:solidFill>
+                <a:latin typeface="DM Sans"/>
+              </a:rPr>
+              <a:t>•  Reduce the request: one change or one explanation at a time.</a:t>
+            </a:r>
+          </a:p>
+        </p:txBody>
+      </p:sp>
+      <p:sp>
+        <p:nvSpPr>
+          <p:cNvPr id="5" name="TextBox 4"/>
+          <p:cNvSpPr txBox="1"/>
+          <p:nvPr/>
+        </p:nvSpPr>
+        <p:spPr>
+          <a:xfrm>
+            <a:off x="822960" y="6263640"/>
+            <a:ext cx="10607040" cy="365760"/>
+          </a:xfrm>
+          <a:prstGeom prst="rect">
+            <a:avLst/>
+          </a:prstGeom>
+          <a:noFill/>
+        </p:spPr>
+        <p:txBody>
+          <a:bodyPr wrap="square">
+            <a:spAutoFit/>
+          </a:bodyPr>
+          <a:lstStyle/>
+          <a:p>
+            <a:pPr algn="r">
+              <a:spcAft>
+                <a:spcPts val="1400"/>
+              </a:spcAft>
+            </a:pPr>
+            <a:r>
+              <a:rPr sz="1600" b="0">
+                <a:solidFill>
+                  <a:srgbClr val="64665D"/>
+                </a:solidFill>
+                <a:latin typeface="DM Sans"/>
+              </a:rPr>
+              <a:t>Week 6 · Working within limits        16 / 26</a:t>
+            </a:r>
+          </a:p>
+        </p:txBody>
+      </p:sp>
+    </p:spTree>
+  </p:cSld>
+  <p:clrMapOvr>
+    <a:masterClrMapping/>
+  </p:clrMapOvr>
+</p:sld>
+</file>
+
+<file path=ppt/slides/slide17.xml><?xml version="1.0" encoding="utf-8"?>
+<p:sld xmlns:a="http://schemas.openxmlformats.org/drawingml/2006/main" xmlns:p="http://schemas.openxmlformats.org/presentationml/2006/main" xmlns:r="http://schemas.openxmlformats.org/officeDocument/2006/relationships">
+  <p:cSld>
+    <p:bg>
+      <p:bgPr>
+        <a:solidFill>
+          <a:srgbClr val="F7F5EE"/>
+        </a:solidFill>
+        <a:effectLst/>
+      </p:bgPr>
+    </p:bg>
+    <p:spTree>
+      <p:nvGrpSpPr>
+        <p:cNvPr id="1" name=""/>
+        <p:cNvGrpSpPr/>
+        <p:nvPr/>
+      </p:nvGrpSpPr>
+      <p:grpSpPr/>
+      <p:sp>
+        <p:nvSpPr>
+          <p:cNvPr id="2" name="Rectangle 1"/>
+          <p:cNvSpPr/>
+          <p:nvPr/>
+        </p:nvSpPr>
+        <p:spPr>
+          <a:xfrm>
+            <a:off x="0" y="0"/>
+            <a:ext cx="228600" cy="6858000"/>
+          </a:xfrm>
+          <a:prstGeom prst="rect">
+            <a:avLst/>
+          </a:prstGeom>
+          <a:solidFill>
+            <a:srgbClr val="A83D2B"/>
+          </a:solidFill>
+          <a:ln>
+            <a:noFill/>
+          </a:ln>
+        </p:spPr>
+        <p:style>
+          <a:lnRef idx="1">
+            <a:schemeClr val="accent1"/>
+          </a:lnRef>
+          <a:fillRef idx="3">
+            <a:schemeClr val="accent1"/>
+          </a:fillRef>
+          <a:effectRef idx="2">
+            <a:schemeClr val="accent1"/>
+          </a:effectRef>
+          <a:fontRef idx="minor">
+            <a:schemeClr val="lt1"/>
+          </a:fontRef>
+        </p:style>
+        <p:txBody>
+          <a:bodyPr rtlCol="0" anchor="ctr"/>
+          <a:lstStyle/>
+          <a:p>
+            <a:pPr algn="ctr"/>
+          </a:p>
+        </p:txBody>
+      </p:sp>
+      <p:sp>
+        <p:nvSpPr>
+          <p:cNvPr id="3" name="TextBox 2"/>
+          <p:cNvSpPr txBox="1"/>
+          <p:nvPr/>
+        </p:nvSpPr>
+        <p:spPr>
+          <a:xfrm>
+            <a:off x="822960" y="548640"/>
+            <a:ext cx="10607040" cy="1188720"/>
+          </a:xfrm>
+          <a:prstGeom prst="rect">
+            <a:avLst/>
+          </a:prstGeom>
+          <a:noFill/>
+        </p:spPr>
+        <p:txBody>
+          <a:bodyPr wrap="square">
+            <a:spAutoFit/>
+          </a:bodyPr>
+          <a:lstStyle/>
+          <a:p>
+            <a:pPr>
+              <a:spcAft>
+                <a:spcPts val="1400"/>
+              </a:spcAft>
+            </a:pPr>
+            <a:r>
+              <a:rPr sz="3200" b="1">
+                <a:solidFill>
+                  <a:srgbClr val="272A25"/>
+                </a:solidFill>
+                <a:latin typeface="Fraunces"/>
+              </a:rPr>
+              <a:t>Folder, repository, website: different things</a:t>
+            </a:r>
+          </a:p>
+        </p:txBody>
+      </p:sp>
+      <p:sp>
+        <p:nvSpPr>
+          <p:cNvPr id="4" name="TextBox 3"/>
+          <p:cNvSpPr txBox="1"/>
+          <p:nvPr/>
+        </p:nvSpPr>
+        <p:spPr>
+          <a:xfrm>
+            <a:off x="822960" y="2011680"/>
+            <a:ext cx="10607040" cy="4206240"/>
+          </a:xfrm>
+          <a:prstGeom prst="rect">
+            <a:avLst/>
+          </a:prstGeom>
+          <a:noFill/>
+        </p:spPr>
+        <p:txBody>
+          <a:bodyPr wrap="square">
+            <a:spAutoFit/>
+          </a:bodyPr>
+          <a:lstStyle/>
+          <a:p>
+            <a:pPr>
+              <a:spcAft>
+                <a:spcPts val="2200"/>
+              </a:spcAft>
+            </a:pPr>
+            <a:r>
+              <a:rPr sz="3000" b="0">
+                <a:solidFill>
+                  <a:srgbClr val="272A25"/>
+                </a:solidFill>
+                <a:latin typeface="DM Sans"/>
+              </a:rPr>
+              <a:t>•  Local folder: files on your own computer.</a:t>
+            </a:r>
+          </a:p>
+          <a:p>
+            <a:pPr>
+              <a:spcAft>
+                <a:spcPts val="2200"/>
+              </a:spcAft>
+            </a:pPr>
+            <a:r>
+              <a:rPr sz="3000" b="0">
+                <a:solidFill>
+                  <a:srgbClr val="272A25"/>
+                </a:solidFill>
+                <a:latin typeface="DM Sans"/>
+              </a:rPr>
+              <a:t>•  Git repository: those files plus a recorded history of versions.</a:t>
+            </a:r>
+          </a:p>
+          <a:p>
+            <a:pPr>
+              <a:spcAft>
+                <a:spcPts val="2200"/>
+              </a:spcAft>
+            </a:pPr>
+            <a:r>
+              <a:rPr sz="3000" b="0">
+                <a:solidFill>
+                  <a:srgbClr val="272A25"/>
+                </a:solidFill>
+                <a:latin typeface="DM Sans"/>
+              </a:rPr>
+              <a:t>•  Deployment: a published version that other people can open.</a:t>
+            </a:r>
+          </a:p>
+        </p:txBody>
+      </p:sp>
+      <p:sp>
+        <p:nvSpPr>
+          <p:cNvPr id="5" name="TextBox 4"/>
+          <p:cNvSpPr txBox="1"/>
+          <p:nvPr/>
+        </p:nvSpPr>
+        <p:spPr>
+          <a:xfrm>
+            <a:off x="822960" y="6263640"/>
+            <a:ext cx="10607040" cy="365760"/>
+          </a:xfrm>
+          <a:prstGeom prst="rect">
+            <a:avLst/>
+          </a:prstGeom>
+          <a:noFill/>
+        </p:spPr>
+        <p:txBody>
+          <a:bodyPr wrap="square">
+            <a:spAutoFit/>
+          </a:bodyPr>
+          <a:lstStyle/>
+          <a:p>
+            <a:pPr algn="r">
+              <a:spcAft>
+                <a:spcPts val="1400"/>
+              </a:spcAft>
+            </a:pPr>
+            <a:r>
+              <a:rPr sz="1600" b="0">
+                <a:solidFill>
+                  <a:srgbClr val="64665D"/>
+                </a:solidFill>
+                <a:latin typeface="DM Sans"/>
+              </a:rPr>
+              <a:t>Week 6 · Getting online        17 / 26</a:t>
+            </a:r>
+          </a:p>
+        </p:txBody>
+      </p:sp>
+    </p:spTree>
+  </p:cSld>
+  <p:clrMapOvr>
+    <a:masterClrMapping/>
+  </p:clrMapOvr>
+</p:sld>
+</file>
+
+<file path=ppt/slides/slide18.xml><?xml version="1.0" encoding="utf-8"?>
+<p:sld xmlns:a="http://schemas.openxmlformats.org/drawingml/2006/main" xmlns:p="http://schemas.openxmlformats.org/presentationml/2006/main" xmlns:r="http://schemas.openxmlformats.org/officeDocument/2006/relationships">
+  <p:cSld>
+    <p:bg>
+      <p:bgPr>
+        <a:solidFill>
+          <a:srgbClr val="F7F5EE"/>
+        </a:solidFill>
+        <a:effectLst/>
+      </p:bgPr>
+    </p:bg>
+    <p:spTree>
+      <p:nvGrpSpPr>
+        <p:cNvPr id="1" name=""/>
+        <p:cNvGrpSpPr/>
+        <p:nvPr/>
+      </p:nvGrpSpPr>
+      <p:grpSpPr/>
+      <p:sp>
+        <p:nvSpPr>
+          <p:cNvPr id="2" name="Rectangle 1"/>
+          <p:cNvSpPr/>
+          <p:nvPr/>
+        </p:nvSpPr>
+        <p:spPr>
+          <a:xfrm>
+            <a:off x="0" y="0"/>
+            <a:ext cx="228600" cy="6858000"/>
+          </a:xfrm>
+          <a:prstGeom prst="rect">
+            <a:avLst/>
+          </a:prstGeom>
+          <a:solidFill>
+            <a:srgbClr val="A83D2B"/>
+          </a:solidFill>
+          <a:ln>
+            <a:noFill/>
+          </a:ln>
+        </p:spPr>
+        <p:style>
+          <a:lnRef idx="1">
+            <a:schemeClr val="accent1"/>
+          </a:lnRef>
+          <a:fillRef idx="3">
+            <a:schemeClr val="accent1"/>
+          </a:fillRef>
+          <a:effectRef idx="2">
+            <a:schemeClr val="accent1"/>
+          </a:effectRef>
+          <a:fontRef idx="minor">
+            <a:schemeClr val="lt1"/>
+          </a:fontRef>
+        </p:style>
+        <p:txBody>
+          <a:bodyPr rtlCol="0" anchor="ctr"/>
+          <a:lstStyle/>
+          <a:p>
+            <a:pPr algn="ctr"/>
+          </a:p>
+        </p:txBody>
+      </p:sp>
+      <p:sp>
+        <p:nvSpPr>
+          <p:cNvPr id="3" name="TextBox 2"/>
+          <p:cNvSpPr txBox="1"/>
+          <p:nvPr/>
+        </p:nvSpPr>
+        <p:spPr>
+          <a:xfrm>
+            <a:off x="822960" y="548640"/>
+            <a:ext cx="10607040" cy="1188720"/>
+          </a:xfrm>
+          <a:prstGeom prst="rect">
+            <a:avLst/>
+          </a:prstGeom>
+          <a:noFill/>
+        </p:spPr>
+        <p:txBody>
+          <a:bodyPr wrap="square">
+            <a:spAutoFit/>
+          </a:bodyPr>
+          <a:lstStyle/>
+          <a:p>
+            <a:pPr>
+              <a:spcAft>
+                <a:spcPts val="1400"/>
+              </a:spcAft>
+            </a:pPr>
+            <a:r>
+              <a:rPr sz="4000" b="1">
+                <a:solidFill>
+                  <a:srgbClr val="272A25"/>
+                </a:solidFill>
+                <a:latin typeface="Fraunces"/>
+              </a:rPr>
+              <a:t>Commit, push, deploy: three actions</a:t>
+            </a:r>
+          </a:p>
+        </p:txBody>
+      </p:sp>
+      <p:sp>
+        <p:nvSpPr>
+          <p:cNvPr id="4" name="TextBox 3"/>
+          <p:cNvSpPr txBox="1"/>
+          <p:nvPr/>
+        </p:nvSpPr>
+        <p:spPr>
+          <a:xfrm>
+            <a:off x="822960" y="2011680"/>
+            <a:ext cx="10607040" cy="4206240"/>
+          </a:xfrm>
+          <a:prstGeom prst="rect">
+            <a:avLst/>
+          </a:prstGeom>
+          <a:noFill/>
+        </p:spPr>
+        <p:txBody>
+          <a:bodyPr wrap="square">
+            <a:spAutoFit/>
+          </a:bodyPr>
+          <a:lstStyle/>
+          <a:p>
+            <a:pPr>
+              <a:spcAft>
+                <a:spcPts val="2200"/>
+              </a:spcAft>
+            </a:pPr>
+            <a:r>
+              <a:rPr sz="3000" b="0">
+                <a:solidFill>
+                  <a:srgbClr val="272A25"/>
+                </a:solidFill>
+                <a:latin typeface="DM Sans"/>
+              </a:rPr>
+              <a:t>•  Commit saves a version and a message in your local Git history.</a:t>
+            </a:r>
+          </a:p>
+          <a:p>
+            <a:pPr>
+              <a:spcAft>
+                <a:spcPts val="2200"/>
+              </a:spcAft>
+            </a:pPr>
+            <a:r>
+              <a:rPr sz="3000" b="0">
+                <a:solidFill>
+                  <a:srgbClr val="272A25"/>
+                </a:solidFill>
+                <a:latin typeface="DM Sans"/>
+              </a:rPr>
+              <a:t>•  Push sends your commits to the repository on GitHub.</a:t>
+            </a:r>
+          </a:p>
+          <a:p>
+            <a:pPr>
+              <a:spcAft>
+                <a:spcPts val="2200"/>
+              </a:spcAft>
+            </a:pPr>
+            <a:r>
+              <a:rPr sz="3000" b="0">
+                <a:solidFill>
+                  <a:srgbClr val="272A25"/>
+                </a:solidFill>
+                <a:latin typeface="DM Sans"/>
+              </a:rPr>
+              <a:t>•  Deploy publishes the project through a host such as GitHub Pages or Vercel.</a:t>
+            </a:r>
+          </a:p>
+        </p:txBody>
+      </p:sp>
+      <p:sp>
+        <p:nvSpPr>
+          <p:cNvPr id="5" name="TextBox 4"/>
+          <p:cNvSpPr txBox="1"/>
+          <p:nvPr/>
+        </p:nvSpPr>
+        <p:spPr>
+          <a:xfrm>
+            <a:off x="822960" y="6263640"/>
+            <a:ext cx="10607040" cy="365760"/>
+          </a:xfrm>
+          <a:prstGeom prst="rect">
+            <a:avLst/>
+          </a:prstGeom>
+          <a:noFill/>
+        </p:spPr>
+        <p:txBody>
+          <a:bodyPr wrap="square">
+            <a:spAutoFit/>
+          </a:bodyPr>
+          <a:lstStyle/>
+          <a:p>
+            <a:pPr algn="r">
+              <a:spcAft>
+                <a:spcPts val="1400"/>
+              </a:spcAft>
+            </a:pPr>
+            <a:r>
+              <a:rPr sz="1600" b="0">
+                <a:solidFill>
+                  <a:srgbClr val="64665D"/>
+                </a:solidFill>
+                <a:latin typeface="DM Sans"/>
+              </a:rPr>
+              <a:t>Week 6 · Getting online        18 / 26</a:t>
+            </a:r>
+          </a:p>
+        </p:txBody>
+      </p:sp>
+    </p:spTree>
+  </p:cSld>
+  <p:clrMapOvr>
+    <a:masterClrMapping/>
+  </p:clrMapOvr>
+</p:sld>
+</file>
+
+<file path=ppt/slides/slide19.xml><?xml version="1.0" encoding="utf-8"?>
+<p:sld xmlns:a="http://schemas.openxmlformats.org/drawingml/2006/main" xmlns:p="http://schemas.openxmlformats.org/presentationml/2006/main" xmlns:r="http://schemas.openxmlformats.org/officeDocument/2006/relationships">
+  <p:cSld>
+    <p:bg>
+      <p:bgPr>
+        <a:solidFill>
+          <a:srgbClr val="F7F5EE"/>
+        </a:solidFill>
+        <a:effectLst/>
+      </p:bgPr>
+    </p:bg>
+    <p:spTree>
+      <p:nvGrpSpPr>
+        <p:cNvPr id="1" name=""/>
+        <p:cNvGrpSpPr/>
+        <p:nvPr/>
+      </p:nvGrpSpPr>
+      <p:grpSpPr/>
+      <p:sp>
+        <p:nvSpPr>
+          <p:cNvPr id="2" name="Rectangle 1"/>
+          <p:cNvSpPr/>
+          <p:nvPr/>
+        </p:nvSpPr>
+        <p:spPr>
+          <a:xfrm>
+            <a:off x="0" y="0"/>
+            <a:ext cx="228600" cy="6858000"/>
+          </a:xfrm>
+          <a:prstGeom prst="rect">
+            <a:avLst/>
+          </a:prstGeom>
+          <a:solidFill>
+            <a:srgbClr val="A83D2B"/>
+          </a:solidFill>
+          <a:ln>
+            <a:noFill/>
+          </a:ln>
+        </p:spPr>
+        <p:style>
+          <a:lnRef idx="1">
+            <a:schemeClr val="accent1"/>
+          </a:lnRef>
+          <a:fillRef idx="3">
+            <a:schemeClr val="accent1"/>
+          </a:fillRef>
+          <a:effectRef idx="2">
+            <a:schemeClr val="accent1"/>
+          </a:effectRef>
+          <a:fontRef idx="minor">
+            <a:schemeClr val="lt1"/>
+          </a:fontRef>
+        </p:style>
+        <p:txBody>
+          <a:bodyPr rtlCol="0" anchor="ctr"/>
+          <a:lstStyle/>
+          <a:p>
+            <a:pPr algn="ctr"/>
+          </a:p>
+        </p:txBody>
+      </p:sp>
+      <p:sp>
+        <p:nvSpPr>
+          <p:cNvPr id="3" name="TextBox 2"/>
+          <p:cNvSpPr txBox="1"/>
+          <p:nvPr/>
+        </p:nvSpPr>
+        <p:spPr>
+          <a:xfrm>
+            <a:off x="822960" y="548640"/>
+            <a:ext cx="10607040" cy="1188720"/>
+          </a:xfrm>
+          <a:prstGeom prst="rect">
+            <a:avLst/>
+          </a:prstGeom>
+          <a:noFill/>
+        </p:spPr>
+        <p:txBody>
+          <a:bodyPr wrap="square">
+            <a:spAutoFit/>
+          </a:bodyPr>
+          <a:lstStyle/>
+          <a:p>
+            <a:pPr>
+              <a:spcAft>
+                <a:spcPts val="1400"/>
+              </a:spcAft>
+            </a:pPr>
+            <a:r>
+              <a:rPr sz="3200" b="1">
+                <a:solidFill>
+                  <a:srgbClr val="272A25"/>
+                </a:solidFill>
+                <a:latin typeface="Fraunces"/>
+              </a:rPr>
+              <a:t>Your link must work on someone else’s phone</a:t>
+            </a:r>
+          </a:p>
+        </p:txBody>
+      </p:sp>
+      <p:sp>
+        <p:nvSpPr>
+          <p:cNvPr id="4" name="TextBox 3"/>
+          <p:cNvSpPr txBox="1"/>
+          <p:nvPr/>
+        </p:nvSpPr>
+        <p:spPr>
+          <a:xfrm>
+            <a:off x="822960" y="2011680"/>
+            <a:ext cx="10607040" cy="4206240"/>
+          </a:xfrm>
+          <a:prstGeom prst="rect">
+            <a:avLst/>
+          </a:prstGeom>
+          <a:noFill/>
+        </p:spPr>
+        <p:txBody>
+          <a:bodyPr wrap="square">
+            <a:spAutoFit/>
+          </a:bodyPr>
+          <a:lstStyle/>
+          <a:p>
+            <a:pPr>
+              <a:spcAft>
+                <a:spcPts val="2200"/>
+              </a:spcAft>
+            </a:pPr>
+            <a:r>
+              <a:rPr sz="3000" b="0">
+                <a:solidFill>
+                  <a:srgbClr val="272A25"/>
+                </a:solidFill>
+                <a:latin typeface="DM Sans"/>
+              </a:rPr>
+              <a:t>•  file:///… and localhost:8000 point to your own computer—not a public site.</a:t>
+            </a:r>
+          </a:p>
+          <a:p>
+            <a:pPr>
+              <a:spcAft>
+                <a:spcPts val="2200"/>
+              </a:spcAft>
+            </a:pPr>
+            <a:r>
+              <a:rPr sz="3000" b="0">
+                <a:solidFill>
+                  <a:srgbClr val="272A25"/>
+                </a:solidFill>
+                <a:latin typeface="DM Sans"/>
+              </a:rPr>
+              <a:t>•  A GitHub repository URL shows source; it may not be the live app URL.</a:t>
+            </a:r>
+          </a:p>
+          <a:p>
+            <a:pPr>
+              <a:spcAft>
+                <a:spcPts val="2200"/>
+              </a:spcAft>
+            </a:pPr>
+            <a:r>
+              <a:rPr sz="3000" b="0">
+                <a:solidFill>
+                  <a:srgbClr val="272A25"/>
+                </a:solidFill>
+                <a:latin typeface="DM Sans"/>
+              </a:rPr>
+              <a:t>•  Use the deployed HTTPS URL; test it on another device or in a private window.</a:t>
+            </a:r>
+          </a:p>
+        </p:txBody>
+      </p:sp>
+      <p:sp>
+        <p:nvSpPr>
+          <p:cNvPr id="5" name="TextBox 4"/>
+          <p:cNvSpPr txBox="1"/>
+          <p:nvPr/>
+        </p:nvSpPr>
+        <p:spPr>
+          <a:xfrm>
+            <a:off x="822960" y="6263640"/>
+            <a:ext cx="10607040" cy="365760"/>
+          </a:xfrm>
+          <a:prstGeom prst="rect">
+            <a:avLst/>
+          </a:prstGeom>
+          <a:noFill/>
+        </p:spPr>
+        <p:txBody>
+          <a:bodyPr wrap="square">
+            <a:spAutoFit/>
+          </a:bodyPr>
+          <a:lstStyle/>
+          <a:p>
+            <a:pPr algn="r">
+              <a:spcAft>
+                <a:spcPts val="1400"/>
+              </a:spcAft>
+            </a:pPr>
+            <a:r>
+              <a:rPr sz="1600" b="0">
+                <a:solidFill>
+                  <a:srgbClr val="64665D"/>
+                </a:solidFill>
+                <a:latin typeface="DM Sans"/>
+              </a:rPr>
+              <a:t>Week 6 · Getting online        19 / 26</a:t>
             </a:r>
           </a:p>
         </p:txBody>
@@ -5496,7 +7727,7 @@
                 </a:solidFill>
                 <a:latin typeface="Fraunces"/>
               </a:rPr>
-              <a:t>Your AI can help you learn about AI</a:t>
+              <a:t>What your recent builds taught us</a:t>
             </a:r>
           </a:p>
         </p:txBody>
@@ -5535,7 +7766,7 @@
                 </a:solidFill>
                 <a:latin typeface="DM Sans"/>
               </a:rPr>
-              <a:t>•  Ask for an explanation at your level.</a:t>
+              <a:t>•  The AI can finish a prompt and still miss the design you intended.</a:t>
             </a:r>
           </a:p>
           <a:p>
@@ -5551,7 +7782,7 @@
                 </a:solidFill>
                 <a:latin typeface="DM Sans"/>
               </a:rPr>
-              <a:t>•  Ask it to quiz you, then explain what you missed.</a:t>
+              <a:t>•  A page can look finished while its buttons do not work.</a:t>
             </a:r>
           </a:p>
           <a:p>
@@ -5567,7 +7798,7 @@
                 </a:solidFill>
                 <a:latin typeface="DM Sans"/>
               </a:rPr>
-              <a:t>•  Check its claims against the material you gave it.</a:t>
+              <a:t>•  A local link or a repo alone is not a published website.</a:t>
             </a:r>
           </a:p>
         </p:txBody>
@@ -5606,7 +7837,1533 @@
                 </a:solidFill>
                 <a:latin typeface="DM Sans"/>
               </a:rPr>
-              <a:t>Week 6 · Learn with AI        2 / 13</a:t>
+              <a:t>Week 6 · Why this matters        2 / 26</a:t>
+            </a:r>
+          </a:p>
+        </p:txBody>
+      </p:sp>
+    </p:spTree>
+  </p:cSld>
+  <p:clrMapOvr>
+    <a:masterClrMapping/>
+  </p:clrMapOvr>
+</p:sld>
+</file>
+
+<file path=ppt/slides/slide20.xml><?xml version="1.0" encoding="utf-8"?>
+<p:sld xmlns:a="http://schemas.openxmlformats.org/drawingml/2006/main" xmlns:p="http://schemas.openxmlformats.org/presentationml/2006/main" xmlns:r="http://schemas.openxmlformats.org/officeDocument/2006/relationships">
+  <p:cSld>
+    <p:bg>
+      <p:bgPr>
+        <a:solidFill>
+          <a:srgbClr val="F7F5EE"/>
+        </a:solidFill>
+        <a:effectLst/>
+      </p:bgPr>
+    </p:bg>
+    <p:spTree>
+      <p:nvGrpSpPr>
+        <p:cNvPr id="1" name=""/>
+        <p:cNvGrpSpPr/>
+        <p:nvPr/>
+      </p:nvGrpSpPr>
+      <p:grpSpPr/>
+      <p:sp>
+        <p:nvSpPr>
+          <p:cNvPr id="2" name="Rectangle 1"/>
+          <p:cNvSpPr/>
+          <p:nvPr/>
+        </p:nvSpPr>
+        <p:spPr>
+          <a:xfrm>
+            <a:off x="0" y="0"/>
+            <a:ext cx="228600" cy="6858000"/>
+          </a:xfrm>
+          <a:prstGeom prst="rect">
+            <a:avLst/>
+          </a:prstGeom>
+          <a:solidFill>
+            <a:srgbClr val="A83D2B"/>
+          </a:solidFill>
+          <a:ln>
+            <a:noFill/>
+          </a:ln>
+        </p:spPr>
+        <p:style>
+          <a:lnRef idx="1">
+            <a:schemeClr val="accent1"/>
+          </a:lnRef>
+          <a:fillRef idx="3">
+            <a:schemeClr val="accent1"/>
+          </a:fillRef>
+          <a:effectRef idx="2">
+            <a:schemeClr val="accent1"/>
+          </a:effectRef>
+          <a:fontRef idx="minor">
+            <a:schemeClr val="lt1"/>
+          </a:fontRef>
+        </p:style>
+        <p:txBody>
+          <a:bodyPr rtlCol="0" anchor="ctr"/>
+          <a:lstStyle/>
+          <a:p>
+            <a:pPr algn="ctr"/>
+          </a:p>
+        </p:txBody>
+      </p:sp>
+      <p:sp>
+        <p:nvSpPr>
+          <p:cNvPr id="3" name="TextBox 2"/>
+          <p:cNvSpPr txBox="1"/>
+          <p:nvPr/>
+        </p:nvSpPr>
+        <p:spPr>
+          <a:xfrm>
+            <a:off x="822960" y="548640"/>
+            <a:ext cx="10607040" cy="1188720"/>
+          </a:xfrm>
+          <a:prstGeom prst="rect">
+            <a:avLst/>
+          </a:prstGeom>
+          <a:noFill/>
+        </p:spPr>
+        <p:txBody>
+          <a:bodyPr wrap="square">
+            <a:spAutoFit/>
+          </a:bodyPr>
+          <a:lstStyle/>
+          <a:p>
+            <a:pPr>
+              <a:spcAft>
+                <a:spcPts val="1400"/>
+              </a:spcAft>
+            </a:pPr>
+            <a:r>
+              <a:rPr sz="4000" b="1">
+                <a:solidFill>
+                  <a:srgbClr val="272A25"/>
+                </a:solidFill>
+                <a:latin typeface="Fraunces"/>
+              </a:rPr>
+              <a:t>A practical path to publishing</a:t>
+            </a:r>
+          </a:p>
+        </p:txBody>
+      </p:sp>
+      <p:sp>
+        <p:nvSpPr>
+          <p:cNvPr id="4" name="TextBox 3"/>
+          <p:cNvSpPr txBox="1"/>
+          <p:nvPr/>
+        </p:nvSpPr>
+        <p:spPr>
+          <a:xfrm>
+            <a:off x="822960" y="2011680"/>
+            <a:ext cx="10607040" cy="4206240"/>
+          </a:xfrm>
+          <a:prstGeom prst="rect">
+            <a:avLst/>
+          </a:prstGeom>
+          <a:noFill/>
+        </p:spPr>
+        <p:txBody>
+          <a:bodyPr wrap="square">
+            <a:spAutoFit/>
+          </a:bodyPr>
+          <a:lstStyle/>
+          <a:p>
+            <a:pPr>
+              <a:spcAft>
+                <a:spcPts val="2200"/>
+              </a:spcAft>
+            </a:pPr>
+            <a:r>
+              <a:rPr sz="3000" b="0">
+                <a:solidFill>
+                  <a:srgbClr val="272A25"/>
+                </a:solidFill>
+                <a:latin typeface="DM Sans"/>
+              </a:rPr>
+              <a:t>•  GitHub Desktop: create a repository → commit → publish to GitHub.</a:t>
+            </a:r>
+          </a:p>
+          <a:p>
+            <a:pPr>
+              <a:spcAft>
+                <a:spcPts val="2200"/>
+              </a:spcAft>
+            </a:pPr>
+            <a:r>
+              <a:rPr sz="3000" b="0">
+                <a:solidFill>
+                  <a:srgbClr val="272A25"/>
+                </a:solidFill>
+                <a:latin typeface="DM Sans"/>
+              </a:rPr>
+              <a:t>•  Plain HTML/CSS: GitHub Settings → Pages → main branch / root → Save.</a:t>
+            </a:r>
+          </a:p>
+          <a:p>
+            <a:pPr>
+              <a:spcAft>
+                <a:spcPts val="2200"/>
+              </a:spcAft>
+            </a:pPr>
+            <a:r>
+              <a:rPr sz="3000" b="0">
+                <a:solidFill>
+                  <a:srgbClr val="272A25"/>
+                </a:solidFill>
+                <a:latin typeface="DM Sans"/>
+              </a:rPr>
+              <a:t>•  A framework app may need Vercel: allow repository access, deploy, then test the URL.</a:t>
+            </a:r>
+          </a:p>
+        </p:txBody>
+      </p:sp>
+      <p:sp>
+        <p:nvSpPr>
+          <p:cNvPr id="5" name="TextBox 4"/>
+          <p:cNvSpPr txBox="1"/>
+          <p:nvPr/>
+        </p:nvSpPr>
+        <p:spPr>
+          <a:xfrm>
+            <a:off x="822960" y="6263640"/>
+            <a:ext cx="10607040" cy="365760"/>
+          </a:xfrm>
+          <a:prstGeom prst="rect">
+            <a:avLst/>
+          </a:prstGeom>
+          <a:noFill/>
+        </p:spPr>
+        <p:txBody>
+          <a:bodyPr wrap="square">
+            <a:spAutoFit/>
+          </a:bodyPr>
+          <a:lstStyle/>
+          <a:p>
+            <a:pPr algn="r">
+              <a:spcAft>
+                <a:spcPts val="1400"/>
+              </a:spcAft>
+            </a:pPr>
+            <a:r>
+              <a:rPr sz="1600" b="0">
+                <a:solidFill>
+                  <a:srgbClr val="64665D"/>
+                </a:solidFill>
+                <a:latin typeface="DM Sans"/>
+              </a:rPr>
+              <a:t>Week 6 · Getting online        20 / 26</a:t>
+            </a:r>
+          </a:p>
+        </p:txBody>
+      </p:sp>
+    </p:spTree>
+  </p:cSld>
+  <p:clrMapOvr>
+    <a:masterClrMapping/>
+  </p:clrMapOvr>
+</p:sld>
+</file>
+
+<file path=ppt/slides/slide21.xml><?xml version="1.0" encoding="utf-8"?>
+<p:sld xmlns:a="http://schemas.openxmlformats.org/drawingml/2006/main" xmlns:p="http://schemas.openxmlformats.org/presentationml/2006/main" xmlns:r="http://schemas.openxmlformats.org/officeDocument/2006/relationships">
+  <p:cSld>
+    <p:bg>
+      <p:bgPr>
+        <a:solidFill>
+          <a:srgbClr val="F7F5EE"/>
+        </a:solidFill>
+        <a:effectLst/>
+      </p:bgPr>
+    </p:bg>
+    <p:spTree>
+      <p:nvGrpSpPr>
+        <p:cNvPr id="1" name=""/>
+        <p:cNvGrpSpPr/>
+        <p:nvPr/>
+      </p:nvGrpSpPr>
+      <p:grpSpPr/>
+      <p:sp>
+        <p:nvSpPr>
+          <p:cNvPr id="2" name="Rectangle 1"/>
+          <p:cNvSpPr/>
+          <p:nvPr/>
+        </p:nvSpPr>
+        <p:spPr>
+          <a:xfrm>
+            <a:off x="0" y="0"/>
+            <a:ext cx="228600" cy="6858000"/>
+          </a:xfrm>
+          <a:prstGeom prst="rect">
+            <a:avLst/>
+          </a:prstGeom>
+          <a:solidFill>
+            <a:srgbClr val="A83D2B"/>
+          </a:solidFill>
+          <a:ln>
+            <a:noFill/>
+          </a:ln>
+        </p:spPr>
+        <p:style>
+          <a:lnRef idx="1">
+            <a:schemeClr val="accent1"/>
+          </a:lnRef>
+          <a:fillRef idx="3">
+            <a:schemeClr val="accent1"/>
+          </a:fillRef>
+          <a:effectRef idx="2">
+            <a:schemeClr val="accent1"/>
+          </a:effectRef>
+          <a:fontRef idx="minor">
+            <a:schemeClr val="lt1"/>
+          </a:fontRef>
+        </p:style>
+        <p:txBody>
+          <a:bodyPr rtlCol="0" anchor="ctr"/>
+          <a:lstStyle/>
+          <a:p>
+            <a:pPr algn="ctr"/>
+          </a:p>
+        </p:txBody>
+      </p:sp>
+      <p:sp>
+        <p:nvSpPr>
+          <p:cNvPr id="3" name="TextBox 2"/>
+          <p:cNvSpPr txBox="1"/>
+          <p:nvPr/>
+        </p:nvSpPr>
+        <p:spPr>
+          <a:xfrm>
+            <a:off x="822960" y="548640"/>
+            <a:ext cx="10607040" cy="1188720"/>
+          </a:xfrm>
+          <a:prstGeom prst="rect">
+            <a:avLst/>
+          </a:prstGeom>
+          <a:noFill/>
+        </p:spPr>
+        <p:txBody>
+          <a:bodyPr wrap="square">
+            <a:spAutoFit/>
+          </a:bodyPr>
+          <a:lstStyle/>
+          <a:p>
+            <a:pPr>
+              <a:spcAft>
+                <a:spcPts val="1400"/>
+              </a:spcAft>
+            </a:pPr>
+            <a:r>
+              <a:rPr sz="3200" b="1">
+                <a:solidFill>
+                  <a:srgbClr val="272A25"/>
+                </a:solidFill>
+                <a:latin typeface="Fraunces"/>
+              </a:rPr>
+              <a:t>API, connector, MCP: what is the difference?</a:t>
+            </a:r>
+          </a:p>
+        </p:txBody>
+      </p:sp>
+      <p:sp>
+        <p:nvSpPr>
+          <p:cNvPr id="4" name="TextBox 3"/>
+          <p:cNvSpPr txBox="1"/>
+          <p:nvPr/>
+        </p:nvSpPr>
+        <p:spPr>
+          <a:xfrm>
+            <a:off x="822960" y="2011680"/>
+            <a:ext cx="10607040" cy="4206240"/>
+          </a:xfrm>
+          <a:prstGeom prst="rect">
+            <a:avLst/>
+          </a:prstGeom>
+          <a:noFill/>
+        </p:spPr>
+        <p:txBody>
+          <a:bodyPr wrap="square">
+            <a:spAutoFit/>
+          </a:bodyPr>
+          <a:lstStyle/>
+          <a:p>
+            <a:pPr>
+              <a:spcAft>
+                <a:spcPts val="2200"/>
+              </a:spcAft>
+            </a:pPr>
+            <a:r>
+              <a:rPr sz="3000" b="0">
+                <a:solidFill>
+                  <a:srgbClr val="272A25"/>
+                </a:solidFill>
+                <a:latin typeface="DM Sans"/>
+              </a:rPr>
+              <a:t>•  API: a service’s menu of requests that another program can make.</a:t>
+            </a:r>
+          </a:p>
+          <a:p>
+            <a:pPr>
+              <a:spcAft>
+                <a:spcPts val="2200"/>
+              </a:spcAft>
+            </a:pPr>
+            <a:r>
+              <a:rPr sz="3000" b="0">
+                <a:solidFill>
+                  <a:srgbClr val="272A25"/>
+                </a:solidFill>
+                <a:latin typeface="DM Sans"/>
+              </a:rPr>
+              <a:t>•  Connector: a bridge that lets your AI reach a service or files.</a:t>
+            </a:r>
+          </a:p>
+          <a:p>
+            <a:pPr>
+              <a:spcAft>
+                <a:spcPts val="2200"/>
+              </a:spcAft>
+            </a:pPr>
+            <a:r>
+              <a:rPr sz="3000" b="0">
+                <a:solidFill>
+                  <a:srgbClr val="272A25"/>
+                </a:solidFill>
+                <a:latin typeface="DM Sans"/>
+              </a:rPr>
+              <a:t>•  MCP: a shared protocol for AI apps to use tools; an MCP server may call an API.</a:t>
+            </a:r>
+          </a:p>
+        </p:txBody>
+      </p:sp>
+      <p:sp>
+        <p:nvSpPr>
+          <p:cNvPr id="5" name="TextBox 4"/>
+          <p:cNvSpPr txBox="1"/>
+          <p:nvPr/>
+        </p:nvSpPr>
+        <p:spPr>
+          <a:xfrm>
+            <a:off x="822960" y="6263640"/>
+            <a:ext cx="10607040" cy="365760"/>
+          </a:xfrm>
+          <a:prstGeom prst="rect">
+            <a:avLst/>
+          </a:prstGeom>
+          <a:noFill/>
+        </p:spPr>
+        <p:txBody>
+          <a:bodyPr wrap="square">
+            <a:spAutoFit/>
+          </a:bodyPr>
+          <a:lstStyle/>
+          <a:p>
+            <a:pPr algn="r">
+              <a:spcAft>
+                <a:spcPts val="1400"/>
+              </a:spcAft>
+            </a:pPr>
+            <a:r>
+              <a:rPr sz="1600" b="0">
+                <a:solidFill>
+                  <a:srgbClr val="64665D"/>
+                </a:solidFill>
+                <a:latin typeface="DM Sans"/>
+              </a:rPr>
+              <a:t>Week 6 · Connections—concept only        21 / 26</a:t>
+            </a:r>
+          </a:p>
+        </p:txBody>
+      </p:sp>
+    </p:spTree>
+  </p:cSld>
+  <p:clrMapOvr>
+    <a:masterClrMapping/>
+  </p:clrMapOvr>
+</p:sld>
+</file>
+
+<file path=ppt/slides/slide22.xml><?xml version="1.0" encoding="utf-8"?>
+<p:sld xmlns:a="http://schemas.openxmlformats.org/drawingml/2006/main" xmlns:p="http://schemas.openxmlformats.org/presentationml/2006/main" xmlns:r="http://schemas.openxmlformats.org/officeDocument/2006/relationships">
+  <p:cSld>
+    <p:bg>
+      <p:bgPr>
+        <a:solidFill>
+          <a:srgbClr val="F7F5EE"/>
+        </a:solidFill>
+        <a:effectLst/>
+      </p:bgPr>
+    </p:bg>
+    <p:spTree>
+      <p:nvGrpSpPr>
+        <p:cNvPr id="1" name=""/>
+        <p:cNvGrpSpPr/>
+        <p:nvPr/>
+      </p:nvGrpSpPr>
+      <p:grpSpPr/>
+      <p:sp>
+        <p:nvSpPr>
+          <p:cNvPr id="2" name="Rectangle 1"/>
+          <p:cNvSpPr/>
+          <p:nvPr/>
+        </p:nvSpPr>
+        <p:spPr>
+          <a:xfrm>
+            <a:off x="0" y="0"/>
+            <a:ext cx="228600" cy="6858000"/>
+          </a:xfrm>
+          <a:prstGeom prst="rect">
+            <a:avLst/>
+          </a:prstGeom>
+          <a:solidFill>
+            <a:srgbClr val="A83D2B"/>
+          </a:solidFill>
+          <a:ln>
+            <a:noFill/>
+          </a:ln>
+        </p:spPr>
+        <p:style>
+          <a:lnRef idx="1">
+            <a:schemeClr val="accent1"/>
+          </a:lnRef>
+          <a:fillRef idx="3">
+            <a:schemeClr val="accent1"/>
+          </a:fillRef>
+          <a:effectRef idx="2">
+            <a:schemeClr val="accent1"/>
+          </a:effectRef>
+          <a:fontRef idx="minor">
+            <a:schemeClr val="lt1"/>
+          </a:fontRef>
+        </p:style>
+        <p:txBody>
+          <a:bodyPr rtlCol="0" anchor="ctr"/>
+          <a:lstStyle/>
+          <a:p>
+            <a:pPr algn="ctr"/>
+          </a:p>
+        </p:txBody>
+      </p:sp>
+      <p:sp>
+        <p:nvSpPr>
+          <p:cNvPr id="3" name="TextBox 2"/>
+          <p:cNvSpPr txBox="1"/>
+          <p:nvPr/>
+        </p:nvSpPr>
+        <p:spPr>
+          <a:xfrm>
+            <a:off x="822960" y="548640"/>
+            <a:ext cx="10607040" cy="1188720"/>
+          </a:xfrm>
+          <a:prstGeom prst="rect">
+            <a:avLst/>
+          </a:prstGeom>
+          <a:noFill/>
+        </p:spPr>
+        <p:txBody>
+          <a:bodyPr wrap="square">
+            <a:spAutoFit/>
+          </a:bodyPr>
+          <a:lstStyle/>
+          <a:p>
+            <a:pPr>
+              <a:spcAft>
+                <a:spcPts val="1400"/>
+              </a:spcAft>
+            </a:pPr>
+            <a:r>
+              <a:rPr sz="4000" b="1">
+                <a:solidFill>
+                  <a:srgbClr val="272A25"/>
+                </a:solidFill>
+                <a:latin typeface="Fraunces"/>
+              </a:rPr>
+              <a:t>Access is a choice: read versus write</a:t>
+            </a:r>
+          </a:p>
+        </p:txBody>
+      </p:sp>
+      <p:sp>
+        <p:nvSpPr>
+          <p:cNvPr id="4" name="TextBox 3"/>
+          <p:cNvSpPr txBox="1"/>
+          <p:nvPr/>
+        </p:nvSpPr>
+        <p:spPr>
+          <a:xfrm>
+            <a:off x="822960" y="2011680"/>
+            <a:ext cx="10607040" cy="4206240"/>
+          </a:xfrm>
+          <a:prstGeom prst="rect">
+            <a:avLst/>
+          </a:prstGeom>
+          <a:noFill/>
+        </p:spPr>
+        <p:txBody>
+          <a:bodyPr wrap="square">
+            <a:spAutoFit/>
+          </a:bodyPr>
+          <a:lstStyle/>
+          <a:p>
+            <a:pPr>
+              <a:spcAft>
+                <a:spcPts val="2200"/>
+              </a:spcAft>
+            </a:pPr>
+            <a:r>
+              <a:rPr sz="3000" b="0">
+                <a:solidFill>
+                  <a:srgbClr val="272A25"/>
+                </a:solidFill>
+                <a:latin typeface="DM Sans"/>
+              </a:rPr>
+              <a:t>•  Read access can expose data; write access can change or delete it.</a:t>
+            </a:r>
+          </a:p>
+          <a:p>
+            <a:pPr>
+              <a:spcAft>
+                <a:spcPts val="2200"/>
+              </a:spcAft>
+            </a:pPr>
+            <a:r>
+              <a:rPr sz="3000" b="0">
+                <a:solidFill>
+                  <a:srgbClr val="272A25"/>
+                </a:solidFill>
+                <a:latin typeface="DM Sans"/>
+              </a:rPr>
+              <a:t>•  Give only the access needed; review changes before publishing or sending.</a:t>
+            </a:r>
+          </a:p>
+          <a:p>
+            <a:pPr>
+              <a:spcAft>
+                <a:spcPts val="2200"/>
+              </a:spcAft>
+            </a:pPr>
+            <a:r>
+              <a:rPr sz="3000" b="0">
+                <a:solidFill>
+                  <a:srgbClr val="272A25"/>
+                </a:solidFill>
+                <a:latin typeface="DM Sans"/>
+              </a:rPr>
+              <a:t>•  Keep keys, passwords and private data out of public files and repositories.</a:t>
+            </a:r>
+          </a:p>
+        </p:txBody>
+      </p:sp>
+      <p:sp>
+        <p:nvSpPr>
+          <p:cNvPr id="5" name="TextBox 4"/>
+          <p:cNvSpPr txBox="1"/>
+          <p:nvPr/>
+        </p:nvSpPr>
+        <p:spPr>
+          <a:xfrm>
+            <a:off x="822960" y="6263640"/>
+            <a:ext cx="10607040" cy="365760"/>
+          </a:xfrm>
+          <a:prstGeom prst="rect">
+            <a:avLst/>
+          </a:prstGeom>
+          <a:noFill/>
+        </p:spPr>
+        <p:txBody>
+          <a:bodyPr wrap="square">
+            <a:spAutoFit/>
+          </a:bodyPr>
+          <a:lstStyle/>
+          <a:p>
+            <a:pPr algn="r">
+              <a:spcAft>
+                <a:spcPts val="1400"/>
+              </a:spcAft>
+            </a:pPr>
+            <a:r>
+              <a:rPr sz="1600" b="0">
+                <a:solidFill>
+                  <a:srgbClr val="64665D"/>
+                </a:solidFill>
+                <a:latin typeface="DM Sans"/>
+              </a:rPr>
+              <a:t>Week 6 · Connections—concept only        22 / 26</a:t>
+            </a:r>
+          </a:p>
+        </p:txBody>
+      </p:sp>
+    </p:spTree>
+  </p:cSld>
+  <p:clrMapOvr>
+    <a:masterClrMapping/>
+  </p:clrMapOvr>
+</p:sld>
+</file>
+
+<file path=ppt/slides/slide23.xml><?xml version="1.0" encoding="utf-8"?>
+<p:sld xmlns:a="http://schemas.openxmlformats.org/drawingml/2006/main" xmlns:p="http://schemas.openxmlformats.org/presentationml/2006/main" xmlns:r="http://schemas.openxmlformats.org/officeDocument/2006/relationships">
+  <p:cSld>
+    <p:bg>
+      <p:bgPr>
+        <a:solidFill>
+          <a:srgbClr val="F7F5EE"/>
+        </a:solidFill>
+        <a:effectLst/>
+      </p:bgPr>
+    </p:bg>
+    <p:spTree>
+      <p:nvGrpSpPr>
+        <p:cNvPr id="1" name=""/>
+        <p:cNvGrpSpPr/>
+        <p:nvPr/>
+      </p:nvGrpSpPr>
+      <p:grpSpPr/>
+      <p:sp>
+        <p:nvSpPr>
+          <p:cNvPr id="2" name="Rectangle 1"/>
+          <p:cNvSpPr/>
+          <p:nvPr/>
+        </p:nvSpPr>
+        <p:spPr>
+          <a:xfrm>
+            <a:off x="0" y="0"/>
+            <a:ext cx="228600" cy="6858000"/>
+          </a:xfrm>
+          <a:prstGeom prst="rect">
+            <a:avLst/>
+          </a:prstGeom>
+          <a:solidFill>
+            <a:srgbClr val="A83D2B"/>
+          </a:solidFill>
+          <a:ln>
+            <a:noFill/>
+          </a:ln>
+        </p:spPr>
+        <p:style>
+          <a:lnRef idx="1">
+            <a:schemeClr val="accent1"/>
+          </a:lnRef>
+          <a:fillRef idx="3">
+            <a:schemeClr val="accent1"/>
+          </a:fillRef>
+          <a:effectRef idx="2">
+            <a:schemeClr val="accent1"/>
+          </a:effectRef>
+          <a:fontRef idx="minor">
+            <a:schemeClr val="lt1"/>
+          </a:fontRef>
+        </p:style>
+        <p:txBody>
+          <a:bodyPr rtlCol="0" anchor="ctr"/>
+          <a:lstStyle/>
+          <a:p>
+            <a:pPr algn="ctr"/>
+          </a:p>
+        </p:txBody>
+      </p:sp>
+      <p:sp>
+        <p:nvSpPr>
+          <p:cNvPr id="3" name="TextBox 2"/>
+          <p:cNvSpPr txBox="1"/>
+          <p:nvPr/>
+        </p:nvSpPr>
+        <p:spPr>
+          <a:xfrm>
+            <a:off x="822960" y="548640"/>
+            <a:ext cx="10607040" cy="1188720"/>
+          </a:xfrm>
+          <a:prstGeom prst="rect">
+            <a:avLst/>
+          </a:prstGeom>
+          <a:noFill/>
+        </p:spPr>
+        <p:txBody>
+          <a:bodyPr wrap="square">
+            <a:spAutoFit/>
+          </a:bodyPr>
+          <a:lstStyle/>
+          <a:p>
+            <a:pPr>
+              <a:spcAft>
+                <a:spcPts val="1400"/>
+              </a:spcAft>
+            </a:pPr>
+            <a:r>
+              <a:rPr sz="4000" b="1">
+                <a:solidFill>
+                  <a:srgbClr val="272A25"/>
+                </a:solidFill>
+                <a:latin typeface="Fraunces"/>
+              </a:rPr>
+              <a:t>Bring this lesson into your own AI</a:t>
+            </a:r>
+          </a:p>
+        </p:txBody>
+      </p:sp>
+      <p:sp>
+        <p:nvSpPr>
+          <p:cNvPr id="4" name="TextBox 3"/>
+          <p:cNvSpPr txBox="1"/>
+          <p:nvPr/>
+        </p:nvSpPr>
+        <p:spPr>
+          <a:xfrm>
+            <a:off x="822960" y="2011680"/>
+            <a:ext cx="10607040" cy="4206240"/>
+          </a:xfrm>
+          <a:prstGeom prst="rect">
+            <a:avLst/>
+          </a:prstGeom>
+          <a:noFill/>
+        </p:spPr>
+        <p:txBody>
+          <a:bodyPr wrap="square">
+            <a:spAutoFit/>
+          </a:bodyPr>
+          <a:lstStyle/>
+          <a:p>
+            <a:pPr>
+              <a:spcAft>
+                <a:spcPts val="2200"/>
+              </a:spcAft>
+            </a:pPr>
+            <a:r>
+              <a:rPr sz="3000" b="0">
+                <a:solidFill>
+                  <a:srgbClr val="272A25"/>
+                </a:solidFill>
+                <a:latin typeface="DM Sans"/>
+              </a:rPr>
+              <a:t>•  Open cu.learnvibe.build → Everything for Week 6.</a:t>
+            </a:r>
+          </a:p>
+          <a:p>
+            <a:pPr>
+              <a:spcAft>
+                <a:spcPts val="2200"/>
+              </a:spcAft>
+            </a:pPr>
+            <a:r>
+              <a:rPr sz="3000" b="0">
+                <a:solidFill>
+                  <a:srgbClr val="272A25"/>
+                </a:solidFill>
+                <a:latin typeface="DM Sans"/>
+              </a:rPr>
+              <a:t>•  Click “Copy lesson as markdown”; paste it into Claude or another AI.</a:t>
+            </a:r>
+          </a:p>
+          <a:p>
+            <a:pPr>
+              <a:spcAft>
+                <a:spcPts val="2200"/>
+              </a:spcAft>
+            </a:pPr>
+            <a:r>
+              <a:rPr sz="3000" b="0">
+                <a:solidFill>
+                  <a:srgbClr val="272A25"/>
+                </a:solidFill>
+                <a:latin typeface="DM Sans"/>
+              </a:rPr>
+              <a:t>•  Ask: “Teach me this and quiz me”—then ask follow-ups in your own words.</a:t>
+            </a:r>
+          </a:p>
+        </p:txBody>
+      </p:sp>
+      <p:sp>
+        <p:nvSpPr>
+          <p:cNvPr id="5" name="TextBox 4"/>
+          <p:cNvSpPr txBox="1"/>
+          <p:nvPr/>
+        </p:nvSpPr>
+        <p:spPr>
+          <a:xfrm>
+            <a:off x="822960" y="6263640"/>
+            <a:ext cx="10607040" cy="365760"/>
+          </a:xfrm>
+          <a:prstGeom prst="rect">
+            <a:avLst/>
+          </a:prstGeom>
+          <a:noFill/>
+        </p:spPr>
+        <p:txBody>
+          <a:bodyPr wrap="square">
+            <a:spAutoFit/>
+          </a:bodyPr>
+          <a:lstStyle/>
+          <a:p>
+            <a:pPr algn="r">
+              <a:spcAft>
+                <a:spcPts val="1400"/>
+              </a:spcAft>
+            </a:pPr>
+            <a:r>
+              <a:rPr sz="1600" b="0">
+                <a:solidFill>
+                  <a:srgbClr val="64665D"/>
+                </a:solidFill>
+                <a:latin typeface="DM Sans"/>
+              </a:rPr>
+              <a:t>Week 6 · Use the lesson        23 / 26</a:t>
+            </a:r>
+          </a:p>
+        </p:txBody>
+      </p:sp>
+    </p:spTree>
+  </p:cSld>
+  <p:clrMapOvr>
+    <a:masterClrMapping/>
+  </p:clrMapOvr>
+</p:sld>
+</file>
+
+<file path=ppt/slides/slide24.xml><?xml version="1.0" encoding="utf-8"?>
+<p:sld xmlns:a="http://schemas.openxmlformats.org/drawingml/2006/main" xmlns:p="http://schemas.openxmlformats.org/presentationml/2006/main" xmlns:r="http://schemas.openxmlformats.org/officeDocument/2006/relationships">
+  <p:cSld>
+    <p:bg>
+      <p:bgPr>
+        <a:solidFill>
+          <a:srgbClr val="F7F5EE"/>
+        </a:solidFill>
+        <a:effectLst/>
+      </p:bgPr>
+    </p:bg>
+    <p:spTree>
+      <p:nvGrpSpPr>
+        <p:cNvPr id="1" name=""/>
+        <p:cNvGrpSpPr/>
+        <p:nvPr/>
+      </p:nvGrpSpPr>
+      <p:grpSpPr/>
+      <p:sp>
+        <p:nvSpPr>
+          <p:cNvPr id="2" name="Rectangle 1"/>
+          <p:cNvSpPr/>
+          <p:nvPr/>
+        </p:nvSpPr>
+        <p:spPr>
+          <a:xfrm>
+            <a:off x="0" y="0"/>
+            <a:ext cx="228600" cy="6858000"/>
+          </a:xfrm>
+          <a:prstGeom prst="rect">
+            <a:avLst/>
+          </a:prstGeom>
+          <a:solidFill>
+            <a:srgbClr val="A83D2B"/>
+          </a:solidFill>
+          <a:ln>
+            <a:noFill/>
+          </a:ln>
+        </p:spPr>
+        <p:style>
+          <a:lnRef idx="1">
+            <a:schemeClr val="accent1"/>
+          </a:lnRef>
+          <a:fillRef idx="3">
+            <a:schemeClr val="accent1"/>
+          </a:fillRef>
+          <a:effectRef idx="2">
+            <a:schemeClr val="accent1"/>
+          </a:effectRef>
+          <a:fontRef idx="minor">
+            <a:schemeClr val="lt1"/>
+          </a:fontRef>
+        </p:style>
+        <p:txBody>
+          <a:bodyPr rtlCol="0" anchor="ctr"/>
+          <a:lstStyle/>
+          <a:p>
+            <a:pPr algn="ctr"/>
+          </a:p>
+        </p:txBody>
+      </p:sp>
+      <p:sp>
+        <p:nvSpPr>
+          <p:cNvPr id="3" name="TextBox 2"/>
+          <p:cNvSpPr txBox="1"/>
+          <p:nvPr/>
+        </p:nvSpPr>
+        <p:spPr>
+          <a:xfrm>
+            <a:off x="822960" y="548640"/>
+            <a:ext cx="10607040" cy="1188720"/>
+          </a:xfrm>
+          <a:prstGeom prst="rect">
+            <a:avLst/>
+          </a:prstGeom>
+          <a:noFill/>
+        </p:spPr>
+        <p:txBody>
+          <a:bodyPr wrap="square">
+            <a:spAutoFit/>
+          </a:bodyPr>
+          <a:lstStyle/>
+          <a:p>
+            <a:pPr>
+              <a:spcAft>
+                <a:spcPts val="1400"/>
+              </a:spcAft>
+            </a:pPr>
+            <a:r>
+              <a:rPr sz="3200" b="1">
+                <a:solidFill>
+                  <a:srgbClr val="272A25"/>
+                </a:solidFill>
+                <a:latin typeface="Fraunces"/>
+              </a:rPr>
+              <a:t>After the slides: one conversation with Claude</a:t>
+            </a:r>
+          </a:p>
+        </p:txBody>
+      </p:sp>
+      <p:sp>
+        <p:nvSpPr>
+          <p:cNvPr id="4" name="TextBox 3"/>
+          <p:cNvSpPr txBox="1"/>
+          <p:nvPr/>
+        </p:nvSpPr>
+        <p:spPr>
+          <a:xfrm>
+            <a:off x="822960" y="2011680"/>
+            <a:ext cx="10607040" cy="4206240"/>
+          </a:xfrm>
+          <a:prstGeom prst="rect">
+            <a:avLst/>
+          </a:prstGeom>
+          <a:noFill/>
+        </p:spPr>
+        <p:txBody>
+          <a:bodyPr wrap="square">
+            <a:spAutoFit/>
+          </a:bodyPr>
+          <a:lstStyle/>
+          <a:p>
+            <a:pPr>
+              <a:spcAft>
+                <a:spcPts val="2200"/>
+              </a:spcAft>
+            </a:pPr>
+            <a:r>
+              <a:rPr sz="3000" b="0">
+                <a:solidFill>
+                  <a:srgbClr val="272A25"/>
+                </a:solidFill>
+                <a:latin typeface="DM Sans"/>
+              </a:rPr>
+              <a:t>•  Aaron will paste the lesson and talk through it with Claude.</a:t>
+            </a:r>
+          </a:p>
+          <a:p>
+            <a:pPr>
+              <a:spcAft>
+                <a:spcPts val="2200"/>
+              </a:spcAft>
+            </a:pPr>
+            <a:r>
+              <a:rPr sz="3000" b="0">
+                <a:solidFill>
+                  <a:srgbClr val="272A25"/>
+                </a:solidFill>
+                <a:latin typeface="DM Sans"/>
+              </a:rPr>
+              <a:t>•  The conversation may lead to building a little thing.</a:t>
+            </a:r>
+          </a:p>
+          <a:p>
+            <a:pPr>
+              <a:spcAft>
+                <a:spcPts val="2200"/>
+              </a:spcAft>
+            </a:pPr>
+            <a:r>
+              <a:rPr sz="3000" b="0">
+                <a:solidFill>
+                  <a:srgbClr val="272A25"/>
+                </a:solidFill>
+                <a:latin typeface="DM Sans"/>
+              </a:rPr>
+              <a:t>•  Watch how questions, context and checking shape the result.</a:t>
+            </a:r>
+          </a:p>
+        </p:txBody>
+      </p:sp>
+      <p:sp>
+        <p:nvSpPr>
+          <p:cNvPr id="5" name="TextBox 4"/>
+          <p:cNvSpPr txBox="1"/>
+          <p:nvPr/>
+        </p:nvSpPr>
+        <p:spPr>
+          <a:xfrm>
+            <a:off x="822960" y="6263640"/>
+            <a:ext cx="10607040" cy="365760"/>
+          </a:xfrm>
+          <a:prstGeom prst="rect">
+            <a:avLst/>
+          </a:prstGeom>
+          <a:noFill/>
+        </p:spPr>
+        <p:txBody>
+          <a:bodyPr wrap="square">
+            <a:spAutoFit/>
+          </a:bodyPr>
+          <a:lstStyle/>
+          <a:p>
+            <a:pPr algn="r">
+              <a:spcAft>
+                <a:spcPts val="1400"/>
+              </a:spcAft>
+            </a:pPr>
+            <a:r>
+              <a:rPr sz="1600" b="0">
+                <a:solidFill>
+                  <a:srgbClr val="64665D"/>
+                </a:solidFill>
+                <a:latin typeface="DM Sans"/>
+              </a:rPr>
+              <a:t>Week 6 · One live demo        24 / 26</a:t>
+            </a:r>
+          </a:p>
+        </p:txBody>
+      </p:sp>
+    </p:spTree>
+  </p:cSld>
+  <p:clrMapOvr>
+    <a:masterClrMapping/>
+  </p:clrMapOvr>
+</p:sld>
+</file>
+
+<file path=ppt/slides/slide25.xml><?xml version="1.0" encoding="utf-8"?>
+<p:sld xmlns:a="http://schemas.openxmlformats.org/drawingml/2006/main" xmlns:p="http://schemas.openxmlformats.org/presentationml/2006/main" xmlns:r="http://schemas.openxmlformats.org/officeDocument/2006/relationships">
+  <p:cSld>
+    <p:bg>
+      <p:bgPr>
+        <a:solidFill>
+          <a:srgbClr val="F7F5EE"/>
+        </a:solidFill>
+        <a:effectLst/>
+      </p:bgPr>
+    </p:bg>
+    <p:spTree>
+      <p:nvGrpSpPr>
+        <p:cNvPr id="1" name=""/>
+        <p:cNvGrpSpPr/>
+        <p:nvPr/>
+      </p:nvGrpSpPr>
+      <p:grpSpPr/>
+      <p:sp>
+        <p:nvSpPr>
+          <p:cNvPr id="2" name="Rectangle 1"/>
+          <p:cNvSpPr/>
+          <p:nvPr/>
+        </p:nvSpPr>
+        <p:spPr>
+          <a:xfrm>
+            <a:off x="0" y="0"/>
+            <a:ext cx="228600" cy="6858000"/>
+          </a:xfrm>
+          <a:prstGeom prst="rect">
+            <a:avLst/>
+          </a:prstGeom>
+          <a:solidFill>
+            <a:srgbClr val="A83D2B"/>
+          </a:solidFill>
+          <a:ln>
+            <a:noFill/>
+          </a:ln>
+        </p:spPr>
+        <p:style>
+          <a:lnRef idx="1">
+            <a:schemeClr val="accent1"/>
+          </a:lnRef>
+          <a:fillRef idx="3">
+            <a:schemeClr val="accent1"/>
+          </a:fillRef>
+          <a:effectRef idx="2">
+            <a:schemeClr val="accent1"/>
+          </a:effectRef>
+          <a:fontRef idx="minor">
+            <a:schemeClr val="lt1"/>
+          </a:fontRef>
+        </p:style>
+        <p:txBody>
+          <a:bodyPr rtlCol="0" anchor="ctr"/>
+          <a:lstStyle/>
+          <a:p>
+            <a:pPr algn="ctr"/>
+          </a:p>
+        </p:txBody>
+      </p:sp>
+      <p:sp>
+        <p:nvSpPr>
+          <p:cNvPr id="3" name="TextBox 2"/>
+          <p:cNvSpPr txBox="1"/>
+          <p:nvPr/>
+        </p:nvSpPr>
+        <p:spPr>
+          <a:xfrm>
+            <a:off x="822960" y="548640"/>
+            <a:ext cx="10607040" cy="1188720"/>
+          </a:xfrm>
+          <a:prstGeom prst="rect">
+            <a:avLst/>
+          </a:prstGeom>
+          <a:noFill/>
+        </p:spPr>
+        <p:txBody>
+          <a:bodyPr wrap="square">
+            <a:spAutoFit/>
+          </a:bodyPr>
+          <a:lstStyle/>
+          <a:p>
+            <a:pPr>
+              <a:spcAft>
+                <a:spcPts val="1400"/>
+              </a:spcAft>
+            </a:pPr>
+            <a:r>
+              <a:rPr sz="3200" b="1">
+                <a:solidFill>
+                  <a:srgbClr val="272A25"/>
+                </a:solidFill>
+                <a:latin typeface="Fraunces"/>
+              </a:rPr>
+              <a:t>In small groups: build for your learning</a:t>
+            </a:r>
+          </a:p>
+        </p:txBody>
+      </p:sp>
+      <p:sp>
+        <p:nvSpPr>
+          <p:cNvPr id="4" name="TextBox 3"/>
+          <p:cNvSpPr txBox="1"/>
+          <p:nvPr/>
+        </p:nvSpPr>
+        <p:spPr>
+          <a:xfrm>
+            <a:off x="822960" y="2011680"/>
+            <a:ext cx="10607040" cy="4206240"/>
+          </a:xfrm>
+          <a:prstGeom prst="rect">
+            <a:avLst/>
+          </a:prstGeom>
+          <a:noFill/>
+        </p:spPr>
+        <p:txBody>
+          <a:bodyPr wrap="square">
+            <a:spAutoFit/>
+          </a:bodyPr>
+          <a:lstStyle/>
+          <a:p>
+            <a:pPr>
+              <a:spcAft>
+                <a:spcPts val="2200"/>
+              </a:spcAft>
+            </a:pPr>
+            <a:r>
+              <a:rPr sz="3000" b="0">
+                <a:solidFill>
+                  <a:srgbClr val="272A25"/>
+                </a:solidFill>
+                <a:latin typeface="DM Sans"/>
+              </a:rPr>
+              <a:t>•  Choose a topic you want to understand or practise, and your own approach.</a:t>
+            </a:r>
+          </a:p>
+          <a:p>
+            <a:pPr>
+              <a:spcAft>
+                <a:spcPts val="2200"/>
+              </a:spcAft>
+            </a:pPr>
+            <a:r>
+              <a:rPr sz="3000" b="0">
+                <a:solidFill>
+                  <a:srgbClr val="272A25"/>
+                </a:solidFill>
+                <a:latin typeface="DM Sans"/>
+              </a:rPr>
+              <a:t>•  Make a quiz, interactive explainer, practice tool—or an idea of your own.</a:t>
+            </a:r>
+          </a:p>
+          <a:p>
+            <a:pPr>
+              <a:spcAft>
+                <a:spcPts val="2200"/>
+              </a:spcAft>
+            </a:pPr>
+            <a:r>
+              <a:rPr sz="3000" b="0">
+                <a:solidFill>
+                  <a:srgbClr val="272A25"/>
+                </a:solidFill>
+                <a:latin typeface="DM Sans"/>
+              </a:rPr>
+              <a:t>•  Use your AI; try the first version yourselves; check it and revise.</a:t>
+            </a:r>
+          </a:p>
+        </p:txBody>
+      </p:sp>
+      <p:sp>
+        <p:nvSpPr>
+          <p:cNvPr id="5" name="TextBox 4"/>
+          <p:cNvSpPr txBox="1"/>
+          <p:nvPr/>
+        </p:nvSpPr>
+        <p:spPr>
+          <a:xfrm>
+            <a:off x="822960" y="6263640"/>
+            <a:ext cx="10607040" cy="365760"/>
+          </a:xfrm>
+          <a:prstGeom prst="rect">
+            <a:avLst/>
+          </a:prstGeom>
+          <a:noFill/>
+        </p:spPr>
+        <p:txBody>
+          <a:bodyPr wrap="square">
+            <a:spAutoFit/>
+          </a:bodyPr>
+          <a:lstStyle/>
+          <a:p>
+            <a:pPr algn="r">
+              <a:spcAft>
+                <a:spcPts val="1400"/>
+              </a:spcAft>
+            </a:pPr>
+            <a:r>
+              <a:rPr sz="1600" b="0">
+                <a:solidFill>
+                  <a:srgbClr val="64665D"/>
+                </a:solidFill>
+                <a:latin typeface="DM Sans"/>
+              </a:rPr>
+              <a:t>Week 6 · Group work        25 / 26</a:t>
+            </a:r>
+          </a:p>
+        </p:txBody>
+      </p:sp>
+    </p:spTree>
+  </p:cSld>
+  <p:clrMapOvr>
+    <a:masterClrMapping/>
+  </p:clrMapOvr>
+</p:sld>
+</file>
+
+<file path=ppt/slides/slide26.xml><?xml version="1.0" encoding="utf-8"?>
+<p:sld xmlns:a="http://schemas.openxmlformats.org/drawingml/2006/main" xmlns:p="http://schemas.openxmlformats.org/presentationml/2006/main" xmlns:r="http://schemas.openxmlformats.org/officeDocument/2006/relationships">
+  <p:cSld>
+    <p:bg>
+      <p:bgPr>
+        <a:solidFill>
+          <a:srgbClr val="F7F5EE"/>
+        </a:solidFill>
+        <a:effectLst/>
+      </p:bgPr>
+    </p:bg>
+    <p:spTree>
+      <p:nvGrpSpPr>
+        <p:cNvPr id="1" name=""/>
+        <p:cNvGrpSpPr/>
+        <p:nvPr/>
+      </p:nvGrpSpPr>
+      <p:grpSpPr/>
+      <p:sp>
+        <p:nvSpPr>
+          <p:cNvPr id="2" name="Rectangle 1"/>
+          <p:cNvSpPr/>
+          <p:nvPr/>
+        </p:nvSpPr>
+        <p:spPr>
+          <a:xfrm>
+            <a:off x="0" y="0"/>
+            <a:ext cx="228600" cy="6858000"/>
+          </a:xfrm>
+          <a:prstGeom prst="rect">
+            <a:avLst/>
+          </a:prstGeom>
+          <a:solidFill>
+            <a:srgbClr val="A83D2B"/>
+          </a:solidFill>
+          <a:ln>
+            <a:noFill/>
+          </a:ln>
+        </p:spPr>
+        <p:style>
+          <a:lnRef idx="1">
+            <a:schemeClr val="accent1"/>
+          </a:lnRef>
+          <a:fillRef idx="3">
+            <a:schemeClr val="accent1"/>
+          </a:fillRef>
+          <a:effectRef idx="2">
+            <a:schemeClr val="accent1"/>
+          </a:effectRef>
+          <a:fontRef idx="minor">
+            <a:schemeClr val="lt1"/>
+          </a:fontRef>
+        </p:style>
+        <p:txBody>
+          <a:bodyPr rtlCol="0" anchor="ctr"/>
+          <a:lstStyle/>
+          <a:p>
+            <a:pPr algn="ctr"/>
+          </a:p>
+        </p:txBody>
+      </p:sp>
+      <p:sp>
+        <p:nvSpPr>
+          <p:cNvPr id="3" name="TextBox 2"/>
+          <p:cNvSpPr txBox="1"/>
+          <p:nvPr/>
+        </p:nvSpPr>
+        <p:spPr>
+          <a:xfrm>
+            <a:off x="822960" y="548640"/>
+            <a:ext cx="10607040" cy="1188720"/>
+          </a:xfrm>
+          <a:prstGeom prst="rect">
+            <a:avLst/>
+          </a:prstGeom>
+          <a:noFill/>
+        </p:spPr>
+        <p:txBody>
+          <a:bodyPr wrap="square">
+            <a:spAutoFit/>
+          </a:bodyPr>
+          <a:lstStyle/>
+          <a:p>
+            <a:pPr>
+              <a:spcAft>
+                <a:spcPts val="1400"/>
+              </a:spcAft>
+            </a:pPr>
+            <a:r>
+              <a:rPr sz="4000" b="1">
+                <a:solidFill>
+                  <a:srgbClr val="272A25"/>
+                </a:solidFill>
+                <a:latin typeface="Fraunces"/>
+              </a:rPr>
+              <a:t>How to start—and what to share</a:t>
+            </a:r>
+          </a:p>
+        </p:txBody>
+      </p:sp>
+      <p:sp>
+        <p:nvSpPr>
+          <p:cNvPr id="4" name="TextBox 3"/>
+          <p:cNvSpPr txBox="1"/>
+          <p:nvPr/>
+        </p:nvSpPr>
+        <p:spPr>
+          <a:xfrm>
+            <a:off x="822960" y="2011680"/>
+            <a:ext cx="10607040" cy="4206240"/>
+          </a:xfrm>
+          <a:prstGeom prst="rect">
+            <a:avLst/>
+          </a:prstGeom>
+          <a:noFill/>
+        </p:spPr>
+        <p:txBody>
+          <a:bodyPr wrap="square">
+            <a:spAutoFit/>
+          </a:bodyPr>
+          <a:lstStyle/>
+          <a:p>
+            <a:pPr>
+              <a:spcAft>
+                <a:spcPts val="2200"/>
+              </a:spcAft>
+            </a:pPr>
+            <a:r>
+              <a:rPr sz="3000" b="0">
+                <a:solidFill>
+                  <a:srgbClr val="272A25"/>
+                </a:solidFill>
+                <a:latin typeface="DM Sans"/>
+              </a:rPr>
+              <a:t>•  Give your AI the lesson, your learning question, or both.</a:t>
+            </a:r>
+          </a:p>
+          <a:p>
+            <a:pPr>
+              <a:spcAft>
+                <a:spcPts val="2200"/>
+              </a:spcAft>
+            </a:pPr>
+            <a:r>
+              <a:rPr sz="3000" b="0">
+                <a:solidFill>
+                  <a:srgbClr val="272A25"/>
+                </a:solidFill>
+                <a:latin typeface="DM Sans"/>
+              </a:rPr>
+              <a:t>•  Ask for a small first version. Test whether it actually helps you learn.</a:t>
+            </a:r>
+          </a:p>
+          <a:p>
+            <a:pPr>
+              <a:spcAft>
+                <a:spcPts val="2200"/>
+              </a:spcAft>
+            </a:pPr>
+            <a:r>
+              <a:rPr sz="3000" b="0">
+                <a:solidFill>
+                  <a:srgbClr val="272A25"/>
+                </a:solidFill>
+                <a:latin typeface="DM Sans"/>
+              </a:rPr>
+              <a:t>•  Show what you made, what you learned, and one thing you checked or changed.</a:t>
+            </a:r>
+          </a:p>
+        </p:txBody>
+      </p:sp>
+      <p:sp>
+        <p:nvSpPr>
+          <p:cNvPr id="5" name="TextBox 4"/>
+          <p:cNvSpPr txBox="1"/>
+          <p:nvPr/>
+        </p:nvSpPr>
+        <p:spPr>
+          <a:xfrm>
+            <a:off x="822960" y="6263640"/>
+            <a:ext cx="10607040" cy="365760"/>
+          </a:xfrm>
+          <a:prstGeom prst="rect">
+            <a:avLst/>
+          </a:prstGeom>
+          <a:noFill/>
+        </p:spPr>
+        <p:txBody>
+          <a:bodyPr wrap="square">
+            <a:spAutoFit/>
+          </a:bodyPr>
+          <a:lstStyle/>
+          <a:p>
+            <a:pPr algn="r">
+              <a:spcAft>
+                <a:spcPts val="1400"/>
+              </a:spcAft>
+            </a:pPr>
+            <a:r>
+              <a:rPr sz="1600" b="0">
+                <a:solidFill>
+                  <a:srgbClr val="64665D"/>
+                </a:solidFill>
+                <a:latin typeface="DM Sans"/>
+              </a:rPr>
+              <a:t>Week 6 · Group work        26 / 26</a:t>
             </a:r>
           </a:p>
         </p:txBody>
@@ -5714,7 +9471,7 @@
                 </a:solidFill>
                 <a:latin typeface="Fraunces"/>
               </a:rPr>
-              <a:t>This week’s reading: your AI as a coach</a:t>
+              <a:t>Use AI to learn about AI</a:t>
             </a:r>
           </a:p>
         </p:txBody>
@@ -5753,7 +9510,7 @@
                 </a:solidFill>
                 <a:latin typeface="DM Sans"/>
               </a:rPr>
-              <a:t>•  Arielle Shipper · How to Get Better at AI by Asking AI</a:t>
+              <a:t>•  Ask for an explanation, an example, and a question to check your understanding.</a:t>
             </a:r>
           </a:p>
           <a:p>
@@ -5769,7 +9526,7 @@
                 </a:solidFill>
                 <a:latin typeface="DM Sans"/>
               </a:rPr>
-              <a:t>•  Use examples of your own work to ask: “What should I learn next?”</a:t>
+              <a:t>•  Say what you already know: “I know HTML; Git is new to me.”</a:t>
             </a:r>
           </a:p>
           <a:p>
@@ -5785,7 +9542,7 @@
                 </a:solidFill>
                 <a:latin typeface="DM Sans"/>
               </a:rPr>
-              <a:t>•  Then: “Teach me that next step.”</a:t>
+              <a:t>•  Compare its explanation with your source—not just how confident it sounds.</a:t>
             </a:r>
           </a:p>
         </p:txBody>
@@ -5824,7 +9581,7 @@
                 </a:solidFill>
                 <a:latin typeface="DM Sans"/>
               </a:rPr>
-              <a:t>Week 6 · Learn with AI        3 / 13</a:t>
+              <a:t>Week 6 · Learn with AI        3 / 26</a:t>
             </a:r>
           </a:p>
         </p:txBody>
@@ -5932,7 +9689,7 @@
                 </a:solidFill>
                 <a:latin typeface="Fraunces"/>
               </a:rPr>
-              <a:t>Markdown is just a text file</a:t>
+              <a:t>The reading: your AI as a coach</a:t>
             </a:r>
           </a:p>
         </p:txBody>
@@ -5971,7 +9728,7 @@
                 </a:solidFill>
                 <a:latin typeface="DM Sans"/>
               </a:rPr>
-              <a:t>•  A .md file is plain text, with headings and lists.</a:t>
+              <a:t>•  Arielle Shipper · “How to Get Better at AI by Asking AI” · Every</a:t>
             </a:r>
           </a:p>
           <a:p>
@@ -5987,7 +9744,7 @@
                 </a:solidFill>
                 <a:latin typeface="DM Sans"/>
               </a:rPr>
-              <a:t>•  You can read it. Your AI can read it.</a:t>
+              <a:t>•  Ask where you are on the Eight Levels of AI Adoption, with evidence from your work.</a:t>
             </a:r>
           </a:p>
           <a:p>
@@ -6003,7 +9760,7 @@
                 </a:solidFill>
                 <a:latin typeface="DM Sans"/>
               </a:rPr>
-              <a:t>•  A lesson or project context can live in that file.</a:t>
+              <a:t>•  Ask for one next step, then: “Teach me that and help me practise.”</a:t>
             </a:r>
           </a:p>
         </p:txBody>
@@ -6042,7 +9799,7 @@
                 </a:solidFill>
                 <a:latin typeface="DM Sans"/>
               </a:rPr>
-              <a:t>Week 6 · Context        4 / 13</a:t>
+              <a:t>Week 6 · Learn with AI        4 / 26</a:t>
             </a:r>
           </a:p>
         </p:txBody>
@@ -6144,13 +9901,13 @@
               </a:spcAft>
             </a:pPr>
             <a:r>
-              <a:rPr sz="4000" b="1">
+              <a:rPr sz="3200" b="1">
                 <a:solidFill>
                   <a:srgbClr val="272A25"/>
                 </a:solidFill>
                 <a:latin typeface="Fraunces"/>
               </a:rPr>
-              <a:t>Context that sticks</a:t>
+              <a:t>No long chat history? Bring your own evidence</a:t>
             </a:r>
           </a:p>
         </p:txBody>
@@ -6189,7 +9946,7 @@
                 </a:solidFill>
                 <a:latin typeface="DM Sans"/>
               </a:rPr>
-              <a:t>•  Claude Code loads CLAUDE.md at session start.</a:t>
+              <a:t>•  Paste your last two submissions or describe a recent project.</a:t>
             </a:r>
           </a:p>
           <a:p>
@@ -6205,7 +9962,7 @@
                 </a:solidFill>
                 <a:latin typeface="DM Sans"/>
               </a:rPr>
-              <a:t>•  Cursor and other coding tools can load AGENTS.md.</a:t>
+              <a:t>•  Ask: “What can I do already? Show examples. What should I learn next?”</a:t>
             </a:r>
           </a:p>
           <a:p>
@@ -6221,7 +9978,7 @@
                 </a:solidFill>
                 <a:latin typeface="DM Sans"/>
               </a:rPr>
-              <a:t>•  In a chat app: paste the file or add it to a Project.</a:t>
+              <a:t>•  Treat the AI’s assessment as a suggestion; correct its assumptions.</a:t>
             </a:r>
           </a:p>
         </p:txBody>
@@ -6260,7 +10017,7 @@
                 </a:solidFill>
                 <a:latin typeface="DM Sans"/>
               </a:rPr>
-              <a:t>Week 6 · Context        5 / 13</a:t>
+              <a:t>Week 6 · Learn with AI        5 / 26</a:t>
             </a:r>
           </a:p>
         </p:txBody>
@@ -6368,64 +10125,21 @@
                 </a:solidFill>
                 <a:latin typeface="Fraunces"/>
               </a:rPr>
-              <a:t>One small example</a:t>
-            </a:r>
-          </a:p>
-        </p:txBody>
-      </p:sp>
-      <p:sp>
-        <p:nvSpPr>
-          <p:cNvPr id="4" name="Rectangle 3"/>
-          <p:cNvSpPr/>
-          <p:nvPr/>
-        </p:nvSpPr>
-        <p:spPr>
-          <a:xfrm>
-            <a:off x="822960" y="1828800"/>
-            <a:ext cx="6583680" cy="4023360"/>
-          </a:xfrm>
-          <a:prstGeom prst="rect">
-            <a:avLst/>
-          </a:prstGeom>
-          <a:solidFill>
-            <a:srgbClr val="EEECE2"/>
-          </a:solidFill>
-          <a:ln>
-            <a:noFill/>
-          </a:ln>
-        </p:spPr>
-        <p:style>
-          <a:lnRef idx="1">
-            <a:schemeClr val="accent1"/>
-          </a:lnRef>
-          <a:fillRef idx="3">
-            <a:schemeClr val="accent1"/>
-          </a:fillRef>
-          <a:effectRef idx="2">
-            <a:schemeClr val="accent1"/>
-          </a:effectRef>
-          <a:fontRef idx="minor">
-            <a:schemeClr val="lt1"/>
-          </a:fontRef>
-        </p:style>
-        <p:txBody>
-          <a:bodyPr rtlCol="0" anchor="ctr"/>
-          <a:lstStyle/>
-          <a:p>
-            <a:pPr algn="ctr"/>
-          </a:p>
-        </p:txBody>
-      </p:sp>
-      <p:sp>
-        <p:nvSpPr>
-          <p:cNvPr id="5" name="TextBox 4"/>
+              <a:t>Markdown: readable, portable text</a:t>
+            </a:r>
+          </a:p>
+        </p:txBody>
+      </p:sp>
+      <p:sp>
+        <p:nvSpPr>
+          <p:cNvPr id="4" name="TextBox 3"/>
           <p:cNvSpPr txBox="1"/>
           <p:nvPr/>
         </p:nvSpPr>
         <p:spPr>
           <a:xfrm>
-            <a:off x="1097280" y="2011680"/>
-            <a:ext cx="6217920" cy="3749039"/>
+            <a:off x="822960" y="2011680"/>
+            <a:ext cx="10607040" cy="4206240"/>
           </a:xfrm>
           <a:prstGeom prst="rect">
             <a:avLst/>
@@ -6440,95 +10154,63 @@
           <a:p>
             <a:pPr>
               <a:spcAft>
-                <a:spcPts val="200"/>
-              </a:spcAft>
-            </a:pPr>
-            <a:r>
-              <a:rPr sz="1800" b="0">
+                <a:spcPts val="2200"/>
+              </a:spcAft>
+            </a:pPr>
+            <a:r>
+              <a:rPr sz="3000" b="0">
                 <a:solidFill>
                   <a:srgbClr val="272A25"/>
                 </a:solidFill>
-                <a:latin typeface="DejaVu Sans Mono"/>
-              </a:rPr>
-              <a:t># Hill Plant Swap</a:t>
+                <a:latin typeface="DM Sans"/>
+              </a:rPr>
+              <a:t>•  A .md file is a plain-text file—not a special app or database.</a:t>
             </a:r>
           </a:p>
           <a:p>
             <a:pPr>
               <a:spcAft>
-                <a:spcPts val="200"/>
-              </a:spcAft>
-            </a:pPr>
-            <a:r>
-              <a:rPr sz="1800" b="0">
+                <a:spcPts val="2200"/>
+              </a:spcAft>
+            </a:pPr>
+            <a:r>
+              <a:rPr sz="3000" b="0">
                 <a:solidFill>
                   <a:srgbClr val="272A25"/>
                 </a:solidFill>
-                <a:latin typeface="DejaVu Sans Mono"/>
-              </a:rPr>
-              <a:t>A one-page website for a free plant swap near CU.</a:t>
+                <a:latin typeface="DM Sans"/>
+              </a:rPr>
+              <a:t>•  A little punctuation adds structure: headings, lists, links, code.</a:t>
             </a:r>
           </a:p>
           <a:p>
             <a:pPr>
               <a:spcAft>
-                <a:spcPts val="200"/>
-              </a:spcAft>
-            </a:pPr>
-            <a:r>
-              <a:rPr sz="1800" b="0">
+                <a:spcPts val="2200"/>
+              </a:spcAft>
+            </a:pPr>
+            <a:r>
+              <a:rPr sz="3000" b="0">
                 <a:solidFill>
                   <a:srgbClr val="272A25"/>
                 </a:solidFill>
-                <a:latin typeface="DejaVu Sans Mono"/>
-              </a:rPr>
-              <a:t>For first-year students who are nervous about going.</a:t>
-            </a:r>
-          </a:p>
-          <a:p>
-            <a:pPr>
-              <a:spcAft>
-                <a:spcPts val="200"/>
-              </a:spcAft>
-            </a:pPr>
-            <a:r>
-              <a:rPr sz="1800" b="0">
-                <a:solidFill>
-                  <a:srgbClr val="272A25"/>
-                </a:solidFill>
-                <a:latin typeface="DejaVu Sans Mono"/>
-              </a:rPr>
-              <a:t>Keep it plain HTML and CSS. No JavaScript.</a:t>
-            </a:r>
-          </a:p>
-          <a:p>
-            <a:pPr>
-              <a:spcAft>
-                <a:spcPts val="200"/>
-              </a:spcAft>
-            </a:pPr>
-            <a:r>
-              <a:rPr sz="1800" b="0">
-                <a:solidFill>
-                  <a:srgbClr val="272A25"/>
-                </a:solidFill>
-                <a:latin typeface="DejaVu Sans Mono"/>
-              </a:rPr>
-              <a:t>Use docs/event-facts.md. Never make up dates.</a:t>
-            </a:r>
-          </a:p>
-        </p:txBody>
-      </p:sp>
-      <p:sp>
-        <p:nvSpPr>
-          <p:cNvPr id="6" name="TextBox 5"/>
+                <a:latin typeface="DM Sans"/>
+              </a:rPr>
+              <a:t>•  Read it in an editor, render it as a page, or paste it into your AI.</a:t>
+            </a:r>
+          </a:p>
+        </p:txBody>
+      </p:sp>
+      <p:sp>
+        <p:nvSpPr>
+          <p:cNvPr id="5" name="TextBox 4"/>
           <p:cNvSpPr txBox="1"/>
           <p:nvPr/>
         </p:nvSpPr>
         <p:spPr>
           <a:xfrm>
-            <a:off x="7772400" y="3108960"/>
-            <a:ext cx="3931920" cy="1828800"/>
+            <a:off x="822960" y="6263640"/>
+            <a:ext cx="10607040" cy="365760"/>
           </a:xfrm>
           <a:prstGeom prst="rect">
             <a:avLst/>
@@ -6541,58 +10223,19 @@
           </a:bodyPr>
           <a:lstStyle/>
           <a:p>
-            <a:pPr>
+            <a:pPr algn="r">
               <a:spcAft>
                 <a:spcPts val="1400"/>
               </a:spcAft>
             </a:pPr>
             <a:r>
-              <a:rPr sz="2800" b="0">
+              <a:rPr sz="1600" b="0">
                 <a:solidFill>
                   <a:srgbClr val="64665D"/>
                 </a:solidFill>
                 <a:latin typeface="DM Sans"/>
               </a:rPr>
-              <a:t>Plain words. Nothing fancy.</a:t>
-            </a:r>
-          </a:p>
-        </p:txBody>
-      </p:sp>
-      <p:sp>
-        <p:nvSpPr>
-          <p:cNvPr id="7" name="TextBox 6"/>
-          <p:cNvSpPr txBox="1"/>
-          <p:nvPr/>
-        </p:nvSpPr>
-        <p:spPr>
-          <a:xfrm>
-            <a:off x="822960" y="6263640"/>
-            <a:ext cx="10607040" cy="365760"/>
-          </a:xfrm>
-          <a:prstGeom prst="rect">
-            <a:avLst/>
-          </a:prstGeom>
-          <a:noFill/>
-        </p:spPr>
-        <p:txBody>
-          <a:bodyPr wrap="square">
-            <a:spAutoFit/>
-          </a:bodyPr>
-          <a:lstStyle/>
-          <a:p>
-            <a:pPr algn="r">
-              <a:spcAft>
-                <a:spcPts val="1400"/>
-              </a:spcAft>
-            </a:pPr>
-            <a:r>
-              <a:rPr sz="1600" b="0">
-                <a:solidFill>
-                  <a:srgbClr val="64665D"/>
-                </a:solidFill>
-                <a:latin typeface="DM Sans"/>
-              </a:rPr>
-              <a:t>Week 6 · Context        6 / 13</a:t>
+              <a:t>Week 6 · Markdown        6 / 26</a:t>
             </a:r>
           </a:p>
         </p:txBody>
@@ -6700,21 +10343,64 @@
                 </a:solidFill>
                 <a:latin typeface="Fraunces"/>
               </a:rPr>
-              <a:t>A link someone else can open</a:t>
-            </a:r>
-          </a:p>
-        </p:txBody>
-      </p:sp>
-      <p:sp>
-        <p:nvSpPr>
-          <p:cNvPr id="4" name="TextBox 3"/>
+              <a:t>Markdown you can read and write</a:t>
+            </a:r>
+          </a:p>
+        </p:txBody>
+      </p:sp>
+      <p:sp>
+        <p:nvSpPr>
+          <p:cNvPr id="4" name="Rectangle 3"/>
+          <p:cNvSpPr/>
+          <p:nvPr/>
+        </p:nvSpPr>
+        <p:spPr>
+          <a:xfrm>
+            <a:off x="822960" y="1828800"/>
+            <a:ext cx="6583680" cy="4023360"/>
+          </a:xfrm>
+          <a:prstGeom prst="rect">
+            <a:avLst/>
+          </a:prstGeom>
+          <a:solidFill>
+            <a:srgbClr val="EEECE2"/>
+          </a:solidFill>
+          <a:ln>
+            <a:noFill/>
+          </a:ln>
+        </p:spPr>
+        <p:style>
+          <a:lnRef idx="1">
+            <a:schemeClr val="accent1"/>
+          </a:lnRef>
+          <a:fillRef idx="3">
+            <a:schemeClr val="accent1"/>
+          </a:fillRef>
+          <a:effectRef idx="2">
+            <a:schemeClr val="accent1"/>
+          </a:effectRef>
+          <a:fontRef idx="minor">
+            <a:schemeClr val="lt1"/>
+          </a:fontRef>
+        </p:style>
+        <p:txBody>
+          <a:bodyPr rtlCol="0" anchor="ctr"/>
+          <a:lstStyle/>
+          <a:p>
+            <a:pPr algn="ctr"/>
+          </a:p>
+        </p:txBody>
+      </p:sp>
+      <p:sp>
+        <p:nvSpPr>
+          <p:cNvPr id="5" name="TextBox 4"/>
           <p:cNvSpPr txBox="1"/>
           <p:nvPr/>
         </p:nvSpPr>
         <p:spPr>
           <a:xfrm>
-            <a:off x="822960" y="2011680"/>
-            <a:ext cx="10607040" cy="4206240"/>
+            <a:off x="1097280" y="2011680"/>
+            <a:ext cx="6217920" cy="3749039"/>
           </a:xfrm>
           <a:prstGeom prst="rect">
             <a:avLst/>
@@ -6729,63 +10415,95 @@
           <a:p>
             <a:pPr>
               <a:spcAft>
-                <a:spcPts val="2200"/>
-              </a:spcAft>
-            </a:pPr>
-            <a:r>
-              <a:rPr sz="3000" b="0">
+                <a:spcPts val="200"/>
+              </a:spcAft>
+            </a:pPr>
+            <a:r>
+              <a:rPr sz="1800" b="0">
                 <a:solidFill>
                   <a:srgbClr val="272A25"/>
                 </a:solidFill>
-                <a:latin typeface="DM Sans"/>
-              </a:rPr>
-              <a:t>•  file:// and localhost links only work on your computer.</a:t>
+                <a:latin typeface="DejaVu Sans Mono"/>
+              </a:rPr>
+              <a:t># Project notes</a:t>
             </a:r>
           </a:p>
           <a:p>
             <a:pPr>
               <a:spcAft>
-                <a:spcPts val="2200"/>
-              </a:spcAft>
-            </a:pPr>
-            <a:r>
-              <a:rPr sz="3000" b="0">
+                <a:spcPts val="200"/>
+              </a:spcAft>
+            </a:pPr>
+            <a:r>
+              <a:rPr sz="1800" b="0">
                 <a:solidFill>
                   <a:srgbClr val="272A25"/>
                 </a:solidFill>
-                <a:latin typeface="DM Sans"/>
-              </a:rPr>
-              <a:t>•  A public HTTPS link works on someone else’s phone.</a:t>
+                <a:latin typeface="DejaVu Sans Mono"/>
+              </a:rPr>
+              <a:t>## What I want to learn</a:t>
             </a:r>
           </a:p>
           <a:p>
             <a:pPr>
               <a:spcAft>
-                <a:spcPts val="2200"/>
-              </a:spcAft>
-            </a:pPr>
-            <a:r>
-              <a:rPr sz="3000" b="0">
+                <a:spcPts val="200"/>
+              </a:spcAft>
+            </a:pPr>
+            <a:r>
+              <a:rPr sz="1800" b="0">
                 <a:solidFill>
                   <a:srgbClr val="272A25"/>
                 </a:solidFill>
-                <a:latin typeface="DM Sans"/>
-              </a:rPr>
-              <a:t>•  Commit → push → deploy are three different steps.</a:t>
-            </a:r>
-          </a:p>
-        </p:txBody>
-      </p:sp>
-      <p:sp>
-        <p:nvSpPr>
-          <p:cNvPr id="5" name="TextBox 4"/>
+                <a:latin typeface="DejaVu Sans Mono"/>
+              </a:rPr>
+              <a:t>- Explain commits before changing files.</a:t>
+            </a:r>
+          </a:p>
+          <a:p>
+            <a:pPr>
+              <a:spcAft>
+                <a:spcPts val="200"/>
+              </a:spcAft>
+            </a:pPr>
+            <a:r>
+              <a:rPr sz="1800" b="0">
+                <a:solidFill>
+                  <a:srgbClr val="272A25"/>
+                </a:solidFill>
+                <a:latin typeface="DejaVu Sans Mono"/>
+              </a:rPr>
+              <a:t>[Course lesson](https://cu.learnvibe.build/lessons/week-6/)</a:t>
+            </a:r>
+          </a:p>
+          <a:p>
+            <a:pPr>
+              <a:spcAft>
+                <a:spcPts val="200"/>
+              </a:spcAft>
+            </a:pPr>
+            <a:r>
+              <a:rPr sz="1800" b="0">
+                <a:solidFill>
+                  <a:srgbClr val="272A25"/>
+                </a:solidFill>
+                <a:latin typeface="DejaVu Sans Mono"/>
+              </a:rPr>
+              <a:t>Use `git status` to see what changed.</a:t>
+            </a:r>
+          </a:p>
+        </p:txBody>
+      </p:sp>
+      <p:sp>
+        <p:nvSpPr>
+          <p:cNvPr id="6" name="TextBox 5"/>
           <p:cNvSpPr txBox="1"/>
           <p:nvPr/>
         </p:nvSpPr>
         <p:spPr>
           <a:xfrm>
-            <a:off x="822960" y="6263640"/>
-            <a:ext cx="10607040" cy="365760"/>
+            <a:off x="7772400" y="3108960"/>
+            <a:ext cx="3931920" cy="1828800"/>
           </a:xfrm>
           <a:prstGeom prst="rect">
             <a:avLst/>
@@ -6798,6 +10516,45 @@
           </a:bodyPr>
           <a:lstStyle/>
           <a:p>
+            <a:pPr>
+              <a:spcAft>
+                <a:spcPts val="1400"/>
+              </a:spcAft>
+            </a:pPr>
+            <a:r>
+              <a:rPr sz="2800" b="0">
+                <a:solidFill>
+                  <a:srgbClr val="64665D"/>
+                </a:solidFill>
+                <a:latin typeface="DM Sans"/>
+              </a:rPr>
+              <a:t>Headings, lists, links, and code—with plain text underneath.</a:t>
+            </a:r>
+          </a:p>
+        </p:txBody>
+      </p:sp>
+      <p:sp>
+        <p:nvSpPr>
+          <p:cNvPr id="7" name="TextBox 6"/>
+          <p:cNvSpPr txBox="1"/>
+          <p:nvPr/>
+        </p:nvSpPr>
+        <p:spPr>
+          <a:xfrm>
+            <a:off x="822960" y="6263640"/>
+            <a:ext cx="10607040" cy="365760"/>
+          </a:xfrm>
+          <a:prstGeom prst="rect">
+            <a:avLst/>
+          </a:prstGeom>
+          <a:noFill/>
+        </p:spPr>
+        <p:txBody>
+          <a:bodyPr wrap="square">
+            <a:spAutoFit/>
+          </a:bodyPr>
+          <a:lstStyle/>
+          <a:p>
             <a:pPr algn="r">
               <a:spcAft>
                 <a:spcPts val="1400"/>
@@ -6810,7 +10567,7 @@
                 </a:solidFill>
                 <a:latin typeface="DM Sans"/>
               </a:rPr>
-              <a:t>Week 6 · Getting online        7 / 13</a:t>
+              <a:t>Week 6 · Markdown        7 / 26</a:t>
             </a:r>
           </a:p>
         </p:txBody>
@@ -6918,7 +10675,7 @@
                 </a:solidFill>
                 <a:latin typeface="Fraunces"/>
               </a:rPr>
-              <a:t>The short path online</a:t>
+              <a:t>Context: what the AI can actually see</a:t>
             </a:r>
           </a:p>
         </p:txBody>
@@ -6957,7 +10714,7 @@
                 </a:solidFill>
                 <a:latin typeface="DM Sans"/>
               </a:rPr>
-              <a:t>•  GitHub Desktop: create repo → commit → publish.</a:t>
+              <a:t>•  Its answer depends on the messages, files and tool results available now.</a:t>
             </a:r>
           </a:p>
           <a:p>
@@ -6973,7 +10730,7 @@
                 </a:solidFill>
                 <a:latin typeface="DM Sans"/>
               </a:rPr>
-              <a:t>•  GitHub: Settings → Pages → main / root → Save.</a:t>
+              <a:t>•  It does not automatically know your audience, preferences or project history.</a:t>
             </a:r>
           </a:p>
           <a:p>
@@ -6989,7 +10746,7 @@
                 </a:solidFill>
                 <a:latin typeface="DM Sans"/>
               </a:rPr>
-              <a:t>•  Open the published link on another phone.</a:t>
+              <a:t>•  “Improve my site” is weaker than a clear audience, goal and example.</a:t>
             </a:r>
           </a:p>
         </p:txBody>
@@ -7028,7 +10785,7 @@
                 </a:solidFill>
                 <a:latin typeface="DM Sans"/>
               </a:rPr>
-              <a:t>Week 6 · Getting online        8 / 13</a:t>
+              <a:t>Week 6 · Ongoing context        8 / 26</a:t>
             </a:r>
           </a:p>
         </p:txBody>
@@ -7130,13 +10887,13 @@
               </a:spcAft>
             </a:pPr>
             <a:r>
-              <a:rPr sz="4000" b="1">
+              <a:rPr sz="3200" b="1">
                 <a:solidFill>
                   <a:srgbClr val="272A25"/>
                 </a:solidFill>
                 <a:latin typeface="Fraunces"/>
               </a:rPr>
-              <a:t>Next week: your AI reaches your tools</a:t>
+              <a:t>Save project context instead of repeating it</a:t>
             </a:r>
           </a:p>
         </p:txBody>
@@ -7175,7 +10932,7 @@
                 </a:solidFill>
                 <a:latin typeface="DM Sans"/>
               </a:rPr>
-              <a:t>•  API: one program asking another for something.</a:t>
+              <a:t>•  Write down what the project is, who it is for, and what should stay true.</a:t>
             </a:r>
           </a:p>
           <a:p>
@@ -7191,7 +10948,7 @@
                 </a:solidFill>
                 <a:latin typeface="DM Sans"/>
               </a:rPr>
-              <a:t>•  Connector: your AI reaches tools directly, instead of you pasting.</a:t>
+              <a:t>•  Keep it short, correct and editable; update it when the project changes.</a:t>
             </a:r>
           </a:p>
           <a:p>
@@ -7207,7 +10964,7 @@
                 </a:solidFill>
                 <a:latin typeface="DM Sans"/>
               </a:rPr>
-              <a:t>•  This week we copy. Next week we’ll connect.</a:t>
+              <a:t>•  Example: “For nervous first-time visitors. Plain HTML/CSS. Do not invent event dates.”</a:t>
             </a:r>
           </a:p>
         </p:txBody>
@@ -7246,7 +11003,7 @@
                 </a:solidFill>
                 <a:latin typeface="DM Sans"/>
               </a:rPr>
-              <a:t>Week 6 · Looking ahead        9 / 13</a:t>
+              <a:t>Week 6 · Ongoing context        9 / 26</a:t>
             </a:r>
           </a:p>
         </p:txBody>

</xml_diff>

<commit_message>
Restore substantive Week 6 teaching from recent student gaps; definitions and examples before one demo (#11)
Co-authored-by: unforcedagi <agi@unforced.dev>
</commit_message>
<xml_diff>
--- a/lessons/week-6/_src/week6-lecture.pptx
+++ b/lessons/week-6/_src/week6-lecture.pptx
@@ -18,6 +18,19 @@
     <p:sldId id="266" r:id="rId18"/>
     <p:sldId id="267" r:id="rId19"/>
     <p:sldId id="268" r:id="rId20"/>
+    <p:sldId id="269" r:id="rId21"/>
+    <p:sldId id="270" r:id="rId22"/>
+    <p:sldId id="271" r:id="rId23"/>
+    <p:sldId id="272" r:id="rId24"/>
+    <p:sldId id="273" r:id="rId25"/>
+    <p:sldId id="274" r:id="rId26"/>
+    <p:sldId id="275" r:id="rId27"/>
+    <p:sldId id="276" r:id="rId28"/>
+    <p:sldId id="277" r:id="rId29"/>
+    <p:sldId id="278" r:id="rId30"/>
+    <p:sldId id="279" r:id="rId31"/>
+    <p:sldId id="280" r:id="rId32"/>
+    <p:sldId id="281" r:id="rId33"/>
   </p:sldIdLst>
   <p:sldSz cx="12191695" cy="6858000" type="screen4x3"/>
   <p:notesSz cx="6858000" cy="9144000"/>
@@ -514,7 +527,7 @@
           <a:lstStyle/>
           <a:p>
             <a:r>
-              <a:t>5:05–5:06. Teach through the slides first. One open-ended live conversation with Claude at the end, then small-group building. No predetermined build.</a:t>
+              <a:t>Teach the substantive slides first, then one open live conversation with Claude, then small-group work. No timed demo interruptions.</a:t>
             </a:r>
           </a:p>
         </p:txBody>
@@ -584,7 +597,7 @@
           <a:lstStyle/>
           <a:p>
             <a:r>
-              <a:t>5:22–5:25. Show where the button is without starting the demo yet. The lesson includes this invitation and enough context for the group work.</a:t>
+              <a:t>Do not imply any file name works universally. Our tested Claude Code installation also found AGENTS.md, but teach documented primary filenames. A fresh-session question can reveal whether the tool saw the file.</a:t>
             </a:r>
           </a:p>
         </p:txBody>
@@ -654,7 +667,7 @@
           <a:lstStyle/>
           <a:p>
             <a:r>
-              <a:t>5:25–5:35. Aaron chooses the conversation and any build in the moment. No scripted project or staged before/after. If Claude stalls, discuss what you would ask and move into group work.</a:t>
+              <a:t>Index files are a map, not evidence that the AI read the linked files. Ask it which sources it used.</a:t>
             </a:r>
           </a:p>
         </p:txBody>
@@ -724,7 +737,7 @@
           <a:lstStyle/>
           <a:p>
             <a:r>
-              <a:t>5:35 onward. This is the group-work invitation, not a rigid template. Students choose who to work with, what to learn and what to build. No predefined roles or prescribed file format.</a:t>
+              <a:t>Week 4/5 reflections describe trouble communicating aesthetics; a recent rebuild improved when the student described the feeling instead of only listing features.</a:t>
             </a:r>
           </a:p>
         </p:txBody>
@@ -794,7 +807,427 @@
           <a:lstStyle/>
           <a:p>
             <a:r>
-              <a:t>Group work. Optional nudge: ask your AI what it needs to know about your project and save that context as markdown. If unsure where to start, use the Week 6 Copy button and ask for help choosing a learning idea. Work is not done merely because code runs: check whether it teaches the right thing.</a:t>
+              <a:t>Recent Week 5 work caught non-clickable cards through use. Specific observed behavior gives the agent something testable.</a:t>
+            </a:r>
+          </a:p>
+        </p:txBody>
+      </p:sp>
+      <p:sp>
+        <p:nvSpPr>
+          <p:cNvPr id="4" name="Slide Number Placeholder 3"/>
+          <p:cNvSpPr>
+            <a:spLocks noGrp="1"/>
+          </p:cNvSpPr>
+          <p:nvPr>
+            <p:ph type="sldNum" idx="5" sz="quarter"/>
+          </p:nvPr>
+        </p:nvSpPr>
+        <p:spPr/>
+      </p:sp>
+    </p:spTree>
+  </p:cSld>
+  <p:clrMapOvr>
+    <a:masterClrMapping/>
+  </p:clrMapOvr>
+</p:notes>
+</file>
+
+<file path=ppt/notesSlides/notesSlide14.xml><?xml version="1.0" encoding="utf-8"?>
+<p:notes xmlns:a="http://schemas.openxmlformats.org/drawingml/2006/main" xmlns:p="http://schemas.openxmlformats.org/presentationml/2006/main" xmlns:r="http://schemas.openxmlformats.org/officeDocument/2006/relationships">
+  <p:cSld>
+    <p:spTree>
+      <p:nvGrpSpPr>
+        <p:cNvPr id="1" name=""/>
+        <p:cNvGrpSpPr/>
+        <p:nvPr/>
+      </p:nvGrpSpPr>
+      <p:grpSpPr>
+        <a:xfrm>
+          <a:off x="0" y="0"/>
+          <a:ext cx="0" cy="0"/>
+          <a:chOff x="0" y="0"/>
+          <a:chExt cx="0" cy="0"/>
+        </a:xfrm>
+      </p:grpSpPr>
+      <p:sp>
+        <p:nvSpPr>
+          <p:cNvPr id="2" name="Slide Image Placeholder 1"/>
+          <p:cNvSpPr>
+            <a:spLocks noGrp="1"/>
+          </p:cNvSpPr>
+          <p:nvPr>
+            <p:ph type="sldImg" idx="2"/>
+          </p:nvPr>
+        </p:nvSpPr>
+        <p:spPr/>
+      </p:sp>
+      <p:sp>
+        <p:nvSpPr>
+          <p:cNvPr id="3" name="Notes Placeholder 2"/>
+          <p:cNvSpPr>
+            <a:spLocks noGrp="1"/>
+          </p:cNvSpPr>
+          <p:nvPr>
+            <p:ph type="body" idx="3" sz="quarter"/>
+          </p:nvPr>
+        </p:nvSpPr>
+        <p:spPr/>
+        <p:txBody>
+          <a:bodyPr/>
+          <a:lstStyle/>
+          <a:p>
+            <a:r>
+              <a:t>Do not blindly rewrite the whole app. Before a risky fix, save a working version. Recent students used AI for testing/debugging but still needed to notice what failed.</a:t>
+            </a:r>
+          </a:p>
+        </p:txBody>
+      </p:sp>
+      <p:sp>
+        <p:nvSpPr>
+          <p:cNvPr id="4" name="Slide Number Placeholder 3"/>
+          <p:cNvSpPr>
+            <a:spLocks noGrp="1"/>
+          </p:cNvSpPr>
+          <p:nvPr>
+            <p:ph type="sldNum" idx="5" sz="quarter"/>
+          </p:nvPr>
+        </p:nvSpPr>
+        <p:spPr/>
+      </p:sp>
+    </p:spTree>
+  </p:cSld>
+  <p:clrMapOvr>
+    <a:masterClrMapping/>
+  </p:clrMapOvr>
+</p:notes>
+</file>
+
+<file path=ppt/notesSlides/notesSlide15.xml><?xml version="1.0" encoding="utf-8"?>
+<p:notes xmlns:a="http://schemas.openxmlformats.org/drawingml/2006/main" xmlns:p="http://schemas.openxmlformats.org/presentationml/2006/main" xmlns:r="http://schemas.openxmlformats.org/officeDocument/2006/relationships">
+  <p:cSld>
+    <p:spTree>
+      <p:nvGrpSpPr>
+        <p:cNvPr id="1" name=""/>
+        <p:cNvGrpSpPr/>
+        <p:nvPr/>
+      </p:nvGrpSpPr>
+      <p:grpSpPr>
+        <a:xfrm>
+          <a:off x="0" y="0"/>
+          <a:ext cx="0" cy="0"/>
+          <a:chOff x="0" y="0"/>
+          <a:chExt cx="0" cy="0"/>
+        </a:xfrm>
+      </p:grpSpPr>
+      <p:sp>
+        <p:nvSpPr>
+          <p:cNvPr id="2" name="Slide Image Placeholder 1"/>
+          <p:cNvSpPr>
+            <a:spLocks noGrp="1"/>
+          </p:cNvSpPr>
+          <p:nvPr>
+            <p:ph type="sldImg" idx="2"/>
+          </p:nvPr>
+        </p:nvSpPr>
+        <p:spPr/>
+      </p:sp>
+      <p:sp>
+        <p:nvSpPr>
+          <p:cNvPr id="3" name="Notes Placeholder 2"/>
+          <p:cNvSpPr>
+            <a:spLocks noGrp="1"/>
+          </p:cNvSpPr>
+          <p:nvPr>
+            <p:ph type="body" idx="3" sz="quarter"/>
+          </p:nvPr>
+        </p:nvSpPr>
+        <p:spPr/>
+        <p:txBody>
+          <a:bodyPr/>
+          <a:lstStyle/>
+          <a:p>
+            <a:r>
+              <a:t>A running build is not proof it is correct or useful. This transfers directly to the small-group learning builds.</a:t>
+            </a:r>
+          </a:p>
+        </p:txBody>
+      </p:sp>
+      <p:sp>
+        <p:nvSpPr>
+          <p:cNvPr id="4" name="Slide Number Placeholder 3"/>
+          <p:cNvSpPr>
+            <a:spLocks noGrp="1"/>
+          </p:cNvSpPr>
+          <p:nvPr>
+            <p:ph type="sldNum" idx="5" sz="quarter"/>
+          </p:nvPr>
+        </p:nvSpPr>
+        <p:spPr/>
+      </p:sp>
+    </p:spTree>
+  </p:cSld>
+  <p:clrMapOvr>
+    <a:masterClrMapping/>
+  </p:clrMapOvr>
+</p:notes>
+</file>
+
+<file path=ppt/notesSlides/notesSlide16.xml><?xml version="1.0" encoding="utf-8"?>
+<p:notes xmlns:a="http://schemas.openxmlformats.org/drawingml/2006/main" xmlns:p="http://schemas.openxmlformats.org/presentationml/2006/main" xmlns:r="http://schemas.openxmlformats.org/officeDocument/2006/relationships">
+  <p:cSld>
+    <p:spTree>
+      <p:nvGrpSpPr>
+        <p:cNvPr id="1" name=""/>
+        <p:cNvGrpSpPr/>
+        <p:nvPr/>
+      </p:nvGrpSpPr>
+      <p:grpSpPr>
+        <a:xfrm>
+          <a:off x="0" y="0"/>
+          <a:ext cx="0" cy="0"/>
+          <a:chOff x="0" y="0"/>
+          <a:chExt cx="0" cy="0"/>
+        </a:xfrm>
+      </p:grpSpPr>
+      <p:sp>
+        <p:nvSpPr>
+          <p:cNvPr id="2" name="Slide Image Placeholder 1"/>
+          <p:cNvSpPr>
+            <a:spLocks noGrp="1"/>
+          </p:cNvSpPr>
+          <p:nvPr>
+            <p:ph type="sldImg" idx="2"/>
+          </p:nvPr>
+        </p:nvSpPr>
+        <p:spPr/>
+      </p:sp>
+      <p:sp>
+        <p:nvSpPr>
+          <p:cNvPr id="3" name="Notes Placeholder 2"/>
+          <p:cNvSpPr>
+            <a:spLocks noGrp="1"/>
+          </p:cNvSpPr>
+          <p:nvPr>
+            <p:ph type="body" idx="3" sz="quarter"/>
+          </p:nvPr>
+        </p:nvSpPr>
+        <p:spPr/>
+        <p:txBody>
+          <a:bodyPr/>
+          <a:lstStyle/>
+          <a:p>
+            <a:r>
+              <a:t>Recent Week 5 submissions described switching tools and running out of credits. Persistent context is a practical continuity aid; do not imply unlimited free usage.</a:t>
+            </a:r>
+          </a:p>
+        </p:txBody>
+      </p:sp>
+      <p:sp>
+        <p:nvSpPr>
+          <p:cNvPr id="4" name="Slide Number Placeholder 3"/>
+          <p:cNvSpPr>
+            <a:spLocks noGrp="1"/>
+          </p:cNvSpPr>
+          <p:nvPr>
+            <p:ph type="sldNum" idx="5" sz="quarter"/>
+          </p:nvPr>
+        </p:nvSpPr>
+        <p:spPr/>
+      </p:sp>
+    </p:spTree>
+  </p:cSld>
+  <p:clrMapOvr>
+    <a:masterClrMapping/>
+  </p:clrMapOvr>
+</p:notes>
+</file>
+
+<file path=ppt/notesSlides/notesSlide17.xml><?xml version="1.0" encoding="utf-8"?>
+<p:notes xmlns:a="http://schemas.openxmlformats.org/drawingml/2006/main" xmlns:p="http://schemas.openxmlformats.org/presentationml/2006/main" xmlns:r="http://schemas.openxmlformats.org/officeDocument/2006/relationships">
+  <p:cSld>
+    <p:spTree>
+      <p:nvGrpSpPr>
+        <p:cNvPr id="1" name=""/>
+        <p:cNvGrpSpPr/>
+        <p:nvPr/>
+      </p:nvGrpSpPr>
+      <p:grpSpPr>
+        <a:xfrm>
+          <a:off x="0" y="0"/>
+          <a:ext cx="0" cy="0"/>
+          <a:chOff x="0" y="0"/>
+          <a:chExt cx="0" cy="0"/>
+        </a:xfrm>
+      </p:grpSpPr>
+      <p:sp>
+        <p:nvSpPr>
+          <p:cNvPr id="2" name="Slide Image Placeholder 1"/>
+          <p:cNvSpPr>
+            <a:spLocks noGrp="1"/>
+          </p:cNvSpPr>
+          <p:nvPr>
+            <p:ph type="sldImg" idx="2"/>
+          </p:nvPr>
+        </p:nvSpPr>
+        <p:spPr/>
+      </p:sp>
+      <p:sp>
+        <p:nvSpPr>
+          <p:cNvPr id="3" name="Notes Placeholder 2"/>
+          <p:cNvSpPr>
+            <a:spLocks noGrp="1"/>
+          </p:cNvSpPr>
+          <p:nvPr>
+            <p:ph type="body" idx="3" sz="quarter"/>
+          </p:nvPr>
+        </p:nvSpPr>
+        <p:spPr/>
+        <p:txBody>
+          <a:bodyPr/>
+          <a:lstStyle/>
+          <a:p>
+            <a:r>
+              <a:t>A GitHub repo can hold code without having a live website. A folder path cannot be submitted as an accessible build link.</a:t>
+            </a:r>
+          </a:p>
+        </p:txBody>
+      </p:sp>
+      <p:sp>
+        <p:nvSpPr>
+          <p:cNvPr id="4" name="Slide Number Placeholder 3"/>
+          <p:cNvSpPr>
+            <a:spLocks noGrp="1"/>
+          </p:cNvSpPr>
+          <p:nvPr>
+            <p:ph type="sldNum" idx="5" sz="quarter"/>
+          </p:nvPr>
+        </p:nvSpPr>
+        <p:spPr/>
+      </p:sp>
+    </p:spTree>
+  </p:cSld>
+  <p:clrMapOvr>
+    <a:masterClrMapping/>
+  </p:clrMapOvr>
+</p:notes>
+</file>
+
+<file path=ppt/notesSlides/notesSlide18.xml><?xml version="1.0" encoding="utf-8"?>
+<p:notes xmlns:a="http://schemas.openxmlformats.org/drawingml/2006/main" xmlns:p="http://schemas.openxmlformats.org/presentationml/2006/main" xmlns:r="http://schemas.openxmlformats.org/officeDocument/2006/relationships">
+  <p:cSld>
+    <p:spTree>
+      <p:nvGrpSpPr>
+        <p:cNvPr id="1" name=""/>
+        <p:cNvGrpSpPr/>
+        <p:nvPr/>
+      </p:nvGrpSpPr>
+      <p:grpSpPr>
+        <a:xfrm>
+          <a:off x="0" y="0"/>
+          <a:ext cx="0" cy="0"/>
+          <a:chOff x="0" y="0"/>
+          <a:chExt cx="0" cy="0"/>
+        </a:xfrm>
+      </p:grpSpPr>
+      <p:sp>
+        <p:nvSpPr>
+          <p:cNvPr id="2" name="Slide Image Placeholder 1"/>
+          <p:cNvSpPr>
+            <a:spLocks noGrp="1"/>
+          </p:cNvSpPr>
+          <p:nvPr>
+            <p:ph type="sldImg" idx="2"/>
+          </p:nvPr>
+        </p:nvSpPr>
+        <p:spPr/>
+      </p:sp>
+      <p:sp>
+        <p:nvSpPr>
+          <p:cNvPr id="3" name="Notes Placeholder 2"/>
+          <p:cNvSpPr>
+            <a:spLocks noGrp="1"/>
+          </p:cNvSpPr>
+          <p:nvPr>
+            <p:ph type="body" idx="3" sz="quarter"/>
+          </p:nvPr>
+        </p:nvSpPr>
+        <p:spPr/>
+        <p:txBody>
+          <a:bodyPr/>
+          <a:lstStyle/>
+          <a:p>
+            <a:r>
+              <a:t>Use an ordinary change as an example: fix a heading, commit “Clarify heading”, push, wait for deployment, verify the live page.</a:t>
+            </a:r>
+          </a:p>
+        </p:txBody>
+      </p:sp>
+      <p:sp>
+        <p:nvSpPr>
+          <p:cNvPr id="4" name="Slide Number Placeholder 3"/>
+          <p:cNvSpPr>
+            <a:spLocks noGrp="1"/>
+          </p:cNvSpPr>
+          <p:nvPr>
+            <p:ph type="sldNum" idx="5" sz="quarter"/>
+          </p:nvPr>
+        </p:nvSpPr>
+        <p:spPr/>
+      </p:sp>
+    </p:spTree>
+  </p:cSld>
+  <p:clrMapOvr>
+    <a:masterClrMapping/>
+  </p:clrMapOvr>
+</p:notes>
+</file>
+
+<file path=ppt/notesSlides/notesSlide19.xml><?xml version="1.0" encoding="utf-8"?>
+<p:notes xmlns:a="http://schemas.openxmlformats.org/drawingml/2006/main" xmlns:p="http://schemas.openxmlformats.org/presentationml/2006/main" xmlns:r="http://schemas.openxmlformats.org/officeDocument/2006/relationships">
+  <p:cSld>
+    <p:spTree>
+      <p:nvGrpSpPr>
+        <p:cNvPr id="1" name=""/>
+        <p:cNvGrpSpPr/>
+        <p:nvPr/>
+      </p:nvGrpSpPr>
+      <p:grpSpPr>
+        <a:xfrm>
+          <a:off x="0" y="0"/>
+          <a:ext cx="0" cy="0"/>
+          <a:chOff x="0" y="0"/>
+          <a:chExt cx="0" cy="0"/>
+        </a:xfrm>
+      </p:grpSpPr>
+      <p:sp>
+        <p:nvSpPr>
+          <p:cNvPr id="2" name="Slide Image Placeholder 1"/>
+          <p:cNvSpPr>
+            <a:spLocks noGrp="1"/>
+          </p:cNvSpPr>
+          <p:nvPr>
+            <p:ph type="sldImg" idx="2"/>
+          </p:nvPr>
+        </p:nvSpPr>
+        <p:spPr/>
+      </p:sp>
+      <p:sp>
+        <p:nvSpPr>
+          <p:cNvPr id="3" name="Notes Placeholder 2"/>
+          <p:cNvSpPr>
+            <a:spLocks noGrp="1"/>
+          </p:cNvSpPr>
+          <p:nvPr>
+            <p:ph type="body" idx="3" sz="quarter"/>
+          </p:nvPr>
+        </p:nvSpPr>
+        <p:spPr/>
+        <p:txBody>
+          <a:bodyPr/>
+          <a:lstStyle/>
+          <a:p>
+            <a:r>
+              <a:t>Repeated local-link issues in actual submissions. For a public build, check that it does not require your account to open.</a:t>
             </a:r>
           </a:p>
         </p:txBody>
@@ -864,7 +1297,497 @@
           <a:lstStyle/>
           <a:p>
             <a:r>
-              <a:t>5:06–5:08. Students can learn the tools by asking the tools. The answer is a starting point, not an authority.</a:t>
+              <a:t>Grounded in actual Week 4/5 submissions: visual intent failed to translate; one build had non-clickable cards; localhost and deployment-permission confusion persisted. Public slides deliberately omit names and private quotes.</a:t>
+            </a:r>
+          </a:p>
+        </p:txBody>
+      </p:sp>
+      <p:sp>
+        <p:nvSpPr>
+          <p:cNvPr id="4" name="Slide Number Placeholder 3"/>
+          <p:cNvSpPr>
+            <a:spLocks noGrp="1"/>
+          </p:cNvSpPr>
+          <p:nvPr>
+            <p:ph type="sldNum" idx="5" sz="quarter"/>
+          </p:nvPr>
+        </p:nvSpPr>
+        <p:spPr/>
+      </p:sp>
+    </p:spTree>
+  </p:cSld>
+  <p:clrMapOvr>
+    <a:masterClrMapping/>
+  </p:clrMapOvr>
+</p:notes>
+</file>
+
+<file path=ppt/notesSlides/notesSlide20.xml><?xml version="1.0" encoding="utf-8"?>
+<p:notes xmlns:a="http://schemas.openxmlformats.org/drawingml/2006/main" xmlns:p="http://schemas.openxmlformats.org/presentationml/2006/main" xmlns:r="http://schemas.openxmlformats.org/officeDocument/2006/relationships">
+  <p:cSld>
+    <p:spTree>
+      <p:nvGrpSpPr>
+        <p:cNvPr id="1" name=""/>
+        <p:cNvGrpSpPr/>
+        <p:nvPr/>
+      </p:nvGrpSpPr>
+      <p:grpSpPr>
+        <a:xfrm>
+          <a:off x="0" y="0"/>
+          <a:ext cx="0" cy="0"/>
+          <a:chOff x="0" y="0"/>
+          <a:chExt cx="0" cy="0"/>
+        </a:xfrm>
+      </p:grpSpPr>
+      <p:sp>
+        <p:nvSpPr>
+          <p:cNvPr id="2" name="Slide Image Placeholder 1"/>
+          <p:cNvSpPr>
+            <a:spLocks noGrp="1"/>
+          </p:cNvSpPr>
+          <p:nvPr>
+            <p:ph type="sldImg" idx="2"/>
+          </p:nvPr>
+        </p:nvSpPr>
+        <p:spPr/>
+      </p:sp>
+      <p:sp>
+        <p:nvSpPr>
+          <p:cNvPr id="3" name="Notes Placeholder 2"/>
+          <p:cNvSpPr>
+            <a:spLocks noGrp="1"/>
+          </p:cNvSpPr>
+          <p:nvPr>
+            <p:ph type="body" idx="3" sz="quarter"/>
+          </p:nvPr>
+        </p:nvSpPr>
+        <p:spPr/>
+        <p:txBody>
+          <a:bodyPr/>
+          <a:lstStyle/>
+          <a:p>
+            <a:r>
+              <a:t>Recent Week 5 publishing confusion was partly Vercel needing GitHub repo access. Do not prescribe Pages for every framework app; the handout is supplemental detail, not essential to the invitation.</a:t>
+            </a:r>
+          </a:p>
+        </p:txBody>
+      </p:sp>
+      <p:sp>
+        <p:nvSpPr>
+          <p:cNvPr id="4" name="Slide Number Placeholder 3"/>
+          <p:cNvSpPr>
+            <a:spLocks noGrp="1"/>
+          </p:cNvSpPr>
+          <p:nvPr>
+            <p:ph type="sldNum" idx="5" sz="quarter"/>
+          </p:nvPr>
+        </p:nvSpPr>
+        <p:spPr/>
+      </p:sp>
+    </p:spTree>
+  </p:cSld>
+  <p:clrMapOvr>
+    <a:masterClrMapping/>
+  </p:clrMapOvr>
+</p:notes>
+</file>
+
+<file path=ppt/notesSlides/notesSlide21.xml><?xml version="1.0" encoding="utf-8"?>
+<p:notes xmlns:a="http://schemas.openxmlformats.org/drawingml/2006/main" xmlns:p="http://schemas.openxmlformats.org/presentationml/2006/main" xmlns:r="http://schemas.openxmlformats.org/officeDocument/2006/relationships">
+  <p:cSld>
+    <p:spTree>
+      <p:nvGrpSpPr>
+        <p:cNvPr id="1" name=""/>
+        <p:cNvGrpSpPr/>
+        <p:nvPr/>
+      </p:nvGrpSpPr>
+      <p:grpSpPr>
+        <a:xfrm>
+          <a:off x="0" y="0"/>
+          <a:ext cx="0" cy="0"/>
+          <a:chOff x="0" y="0"/>
+          <a:chExt cx="0" cy="0"/>
+        </a:xfrm>
+      </p:grpSpPr>
+      <p:sp>
+        <p:nvSpPr>
+          <p:cNvPr id="2" name="Slide Image Placeholder 1"/>
+          <p:cNvSpPr>
+            <a:spLocks noGrp="1"/>
+          </p:cNvSpPr>
+          <p:nvPr>
+            <p:ph type="sldImg" idx="2"/>
+          </p:nvPr>
+        </p:nvSpPr>
+        <p:spPr/>
+      </p:sp>
+      <p:sp>
+        <p:nvSpPr>
+          <p:cNvPr id="3" name="Notes Placeholder 2"/>
+          <p:cNvSpPr>
+            <a:spLocks noGrp="1"/>
+          </p:cNvSpPr>
+          <p:nvPr>
+            <p:ph type="body" idx="3" sz="quarter"/>
+          </p:nvPr>
+        </p:nvSpPr>
+        <p:spPr/>
+        <p:txBody>
+          <a:bodyPr/>
+          <a:lstStyle/>
+          <a:p>
+            <a:r>
+              <a:t>Example: weather service API returns a forecast; an AI connector calls it for a conversation. Conceptual only: no course server URL, setup or connector demo this week.</a:t>
+            </a:r>
+          </a:p>
+        </p:txBody>
+      </p:sp>
+      <p:sp>
+        <p:nvSpPr>
+          <p:cNvPr id="4" name="Slide Number Placeholder 3"/>
+          <p:cNvSpPr>
+            <a:spLocks noGrp="1"/>
+          </p:cNvSpPr>
+          <p:nvPr>
+            <p:ph type="sldNum" idx="5" sz="quarter"/>
+          </p:nvPr>
+        </p:nvSpPr>
+        <p:spPr/>
+      </p:sp>
+    </p:spTree>
+  </p:cSld>
+  <p:clrMapOvr>
+    <a:masterClrMapping/>
+  </p:clrMapOvr>
+</p:notes>
+</file>
+
+<file path=ppt/notesSlides/notesSlide22.xml><?xml version="1.0" encoding="utf-8"?>
+<p:notes xmlns:a="http://schemas.openxmlformats.org/drawingml/2006/main" xmlns:p="http://schemas.openxmlformats.org/presentationml/2006/main" xmlns:r="http://schemas.openxmlformats.org/officeDocument/2006/relationships">
+  <p:cSld>
+    <p:spTree>
+      <p:nvGrpSpPr>
+        <p:cNvPr id="1" name=""/>
+        <p:cNvGrpSpPr/>
+        <p:nvPr/>
+      </p:nvGrpSpPr>
+      <p:grpSpPr>
+        <a:xfrm>
+          <a:off x="0" y="0"/>
+          <a:ext cx="0" cy="0"/>
+          <a:chOff x="0" y="0"/>
+          <a:chExt cx="0" cy="0"/>
+        </a:xfrm>
+      </p:grpSpPr>
+      <p:sp>
+        <p:nvSpPr>
+          <p:cNvPr id="2" name="Slide Image Placeholder 1"/>
+          <p:cNvSpPr>
+            <a:spLocks noGrp="1"/>
+          </p:cNvSpPr>
+          <p:nvPr>
+            <p:ph type="sldImg" idx="2"/>
+          </p:nvPr>
+        </p:nvSpPr>
+        <p:spPr/>
+      </p:sp>
+      <p:sp>
+        <p:nvSpPr>
+          <p:cNvPr id="3" name="Notes Placeholder 2"/>
+          <p:cNvSpPr>
+            <a:spLocks noGrp="1"/>
+          </p:cNvSpPr>
+          <p:nvPr>
+            <p:ph type="body" idx="3" sz="quarter"/>
+          </p:nvPr>
+        </p:nvSpPr>
+        <p:spPr/>
+        <p:txBody>
+          <a:bodyPr/>
+          <a:lstStyle/>
+          <a:p>
+            <a:r>
+              <a:t>Tools extend what the AI can do, not what it should be allowed to do. Responsibilities remain with the person using it. Four Ds stay implicit.</a:t>
+            </a:r>
+          </a:p>
+        </p:txBody>
+      </p:sp>
+      <p:sp>
+        <p:nvSpPr>
+          <p:cNvPr id="4" name="Slide Number Placeholder 3"/>
+          <p:cNvSpPr>
+            <a:spLocks noGrp="1"/>
+          </p:cNvSpPr>
+          <p:nvPr>
+            <p:ph type="sldNum" idx="5" sz="quarter"/>
+          </p:nvPr>
+        </p:nvSpPr>
+        <p:spPr/>
+      </p:sp>
+    </p:spTree>
+  </p:cSld>
+  <p:clrMapOvr>
+    <a:masterClrMapping/>
+  </p:clrMapOvr>
+</p:notes>
+</file>
+
+<file path=ppt/notesSlides/notesSlide23.xml><?xml version="1.0" encoding="utf-8"?>
+<p:notes xmlns:a="http://schemas.openxmlformats.org/drawingml/2006/main" xmlns:p="http://schemas.openxmlformats.org/presentationml/2006/main" xmlns:r="http://schemas.openxmlformats.org/officeDocument/2006/relationships">
+  <p:cSld>
+    <p:spTree>
+      <p:nvGrpSpPr>
+        <p:cNvPr id="1" name=""/>
+        <p:cNvGrpSpPr/>
+        <p:nvPr/>
+      </p:nvGrpSpPr>
+      <p:grpSpPr>
+        <a:xfrm>
+          <a:off x="0" y="0"/>
+          <a:ext cx="0" cy="0"/>
+          <a:chOff x="0" y="0"/>
+          <a:chExt cx="0" cy="0"/>
+        </a:xfrm>
+      </p:grpSpPr>
+      <p:sp>
+        <p:nvSpPr>
+          <p:cNvPr id="2" name="Slide Image Placeholder 1"/>
+          <p:cNvSpPr>
+            <a:spLocks noGrp="1"/>
+          </p:cNvSpPr>
+          <p:nvPr>
+            <p:ph type="sldImg" idx="2"/>
+          </p:nvPr>
+        </p:nvSpPr>
+        <p:spPr/>
+      </p:sp>
+      <p:sp>
+        <p:nvSpPr>
+          <p:cNvPr id="3" name="Notes Placeholder 2"/>
+          <p:cNvSpPr>
+            <a:spLocks noGrp="1"/>
+          </p:cNvSpPr>
+          <p:nvPr>
+            <p:ph type="body" idx="3" sz="quarter"/>
+          </p:nvPr>
+        </p:nvSpPr>
+        <p:spPr/>
+        <p:txBody>
+          <a:bodyPr/>
+          <a:lstStyle/>
+          <a:p>
+            <a:r>
+              <a:t>Every essential access instruction is here, not hidden in a handout. This is how the reading’s coaching idea becomes something students can do tonight.</a:t>
+            </a:r>
+          </a:p>
+        </p:txBody>
+      </p:sp>
+      <p:sp>
+        <p:nvSpPr>
+          <p:cNvPr id="4" name="Slide Number Placeholder 3"/>
+          <p:cNvSpPr>
+            <a:spLocks noGrp="1"/>
+          </p:cNvSpPr>
+          <p:nvPr>
+            <p:ph type="sldNum" idx="5" sz="quarter"/>
+          </p:nvPr>
+        </p:nvSpPr>
+        <p:spPr/>
+      </p:sp>
+    </p:spTree>
+  </p:cSld>
+  <p:clrMapOvr>
+    <a:masterClrMapping/>
+  </p:clrMapOvr>
+</p:notes>
+</file>
+
+<file path=ppt/notesSlides/notesSlide24.xml><?xml version="1.0" encoding="utf-8"?>
+<p:notes xmlns:a="http://schemas.openxmlformats.org/drawingml/2006/main" xmlns:p="http://schemas.openxmlformats.org/presentationml/2006/main" xmlns:r="http://schemas.openxmlformats.org/officeDocument/2006/relationships">
+  <p:cSld>
+    <p:spTree>
+      <p:nvGrpSpPr>
+        <p:cNvPr id="1" name=""/>
+        <p:cNvGrpSpPr/>
+        <p:nvPr/>
+      </p:nvGrpSpPr>
+      <p:grpSpPr>
+        <a:xfrm>
+          <a:off x="0" y="0"/>
+          <a:ext cx="0" cy="0"/>
+          <a:chOff x="0" y="0"/>
+          <a:chExt cx="0" cy="0"/>
+        </a:xfrm>
+      </p:grpSpPr>
+      <p:sp>
+        <p:nvSpPr>
+          <p:cNvPr id="2" name="Slide Image Placeholder 1"/>
+          <p:cNvSpPr>
+            <a:spLocks noGrp="1"/>
+          </p:cNvSpPr>
+          <p:nvPr>
+            <p:ph type="sldImg" idx="2"/>
+          </p:nvPr>
+        </p:nvSpPr>
+        <p:spPr/>
+      </p:sp>
+      <p:sp>
+        <p:nvSpPr>
+          <p:cNvPr id="3" name="Notes Placeholder 2"/>
+          <p:cNvSpPr>
+            <a:spLocks noGrp="1"/>
+          </p:cNvSpPr>
+          <p:nvPr>
+            <p:ph type="body" idx="3" sz="quarter"/>
+          </p:nvPr>
+        </p:nvSpPr>
+        <p:spPr/>
+        <p:txBody>
+          <a:bodyPr/>
+          <a:lstStyle/>
+          <a:p>
+            <a:r>
+              <a:t>This is the only live demo slot, after the teaching content. Do not prescribe a project, script or output. If delayed, discuss a question from the lesson and move to group work.</a:t>
+            </a:r>
+          </a:p>
+        </p:txBody>
+      </p:sp>
+      <p:sp>
+        <p:nvSpPr>
+          <p:cNvPr id="4" name="Slide Number Placeholder 3"/>
+          <p:cNvSpPr>
+            <a:spLocks noGrp="1"/>
+          </p:cNvSpPr>
+          <p:nvPr>
+            <p:ph type="sldNum" idx="5" sz="quarter"/>
+          </p:nvPr>
+        </p:nvSpPr>
+        <p:spPr/>
+      </p:sp>
+    </p:spTree>
+  </p:cSld>
+  <p:clrMapOvr>
+    <a:masterClrMapping/>
+  </p:clrMapOvr>
+</p:notes>
+</file>
+
+<file path=ppt/notesSlides/notesSlide25.xml><?xml version="1.0" encoding="utf-8"?>
+<p:notes xmlns:a="http://schemas.openxmlformats.org/drawingml/2006/main" xmlns:p="http://schemas.openxmlformats.org/presentationml/2006/main" xmlns:r="http://schemas.openxmlformats.org/officeDocument/2006/relationships">
+  <p:cSld>
+    <p:spTree>
+      <p:nvGrpSpPr>
+        <p:cNvPr id="1" name=""/>
+        <p:cNvGrpSpPr/>
+        <p:nvPr/>
+      </p:nvGrpSpPr>
+      <p:grpSpPr>
+        <a:xfrm>
+          <a:off x="0" y="0"/>
+          <a:ext cx="0" cy="0"/>
+          <a:chOff x="0" y="0"/>
+          <a:chExt cx="0" cy="0"/>
+        </a:xfrm>
+      </p:grpSpPr>
+      <p:sp>
+        <p:nvSpPr>
+          <p:cNvPr id="2" name="Slide Image Placeholder 1"/>
+          <p:cNvSpPr>
+            <a:spLocks noGrp="1"/>
+          </p:cNvSpPr>
+          <p:nvPr>
+            <p:ph type="sldImg" idx="2"/>
+          </p:nvPr>
+        </p:nvSpPr>
+        <p:spPr/>
+      </p:sp>
+      <p:sp>
+        <p:nvSpPr>
+          <p:cNvPr id="3" name="Notes Placeholder 2"/>
+          <p:cNvSpPr>
+            <a:spLocks noGrp="1"/>
+          </p:cNvSpPr>
+          <p:nvPr>
+            <p:ph type="body" idx="3" sz="quarter"/>
+          </p:nvPr>
+        </p:nvSpPr>
+        <p:spPr/>
+        <p:txBody>
+          <a:bodyPr/>
+          <a:lstStyle/>
+          <a:p>
+            <a:r>
+              <a:t>Open-ended invitation, no fixed template or prescribed roles. Help students choose a small first learning goal without deciding their project for them.</a:t>
+            </a:r>
+          </a:p>
+        </p:txBody>
+      </p:sp>
+      <p:sp>
+        <p:nvSpPr>
+          <p:cNvPr id="4" name="Slide Number Placeholder 3"/>
+          <p:cNvSpPr>
+            <a:spLocks noGrp="1"/>
+          </p:cNvSpPr>
+          <p:nvPr>
+            <p:ph type="sldNum" idx="5" sz="quarter"/>
+          </p:nvPr>
+        </p:nvSpPr>
+        <p:spPr/>
+      </p:sp>
+    </p:spTree>
+  </p:cSld>
+  <p:clrMapOvr>
+    <a:masterClrMapping/>
+  </p:clrMapOvr>
+</p:notes>
+</file>
+
+<file path=ppt/notesSlides/notesSlide26.xml><?xml version="1.0" encoding="utf-8"?>
+<p:notes xmlns:a="http://schemas.openxmlformats.org/drawingml/2006/main" xmlns:p="http://schemas.openxmlformats.org/presentationml/2006/main" xmlns:r="http://schemas.openxmlformats.org/officeDocument/2006/relationships">
+  <p:cSld>
+    <p:spTree>
+      <p:nvGrpSpPr>
+        <p:cNvPr id="1" name=""/>
+        <p:cNvGrpSpPr/>
+        <p:nvPr/>
+      </p:nvGrpSpPr>
+      <p:grpSpPr>
+        <a:xfrm>
+          <a:off x="0" y="0"/>
+          <a:ext cx="0" cy="0"/>
+          <a:chOff x="0" y="0"/>
+          <a:chExt cx="0" cy="0"/>
+        </a:xfrm>
+      </p:grpSpPr>
+      <p:sp>
+        <p:nvSpPr>
+          <p:cNvPr id="2" name="Slide Image Placeholder 1"/>
+          <p:cNvSpPr>
+            <a:spLocks noGrp="1"/>
+          </p:cNvSpPr>
+          <p:nvPr>
+            <p:ph type="sldImg" idx="2"/>
+          </p:nvPr>
+        </p:nvSpPr>
+        <p:spPr/>
+      </p:sp>
+      <p:sp>
+        <p:nvSpPr>
+          <p:cNvPr id="3" name="Notes Placeholder 2"/>
+          <p:cNvSpPr>
+            <a:spLocks noGrp="1"/>
+          </p:cNvSpPr>
+          <p:nvPr>
+            <p:ph type="body" idx="3" sz="quarter"/>
+          </p:nvPr>
+        </p:nvSpPr>
+        <p:spPr/>
+        <p:txBody>
+          <a:bodyPr/>
+          <a:lstStyle/>
+          <a:p>
+            <a:r>
+              <a:t>Optional: ask your AI what it needs to know about your project; save the useful context in markdown. Students can find the lesson from the preceding slide. No due date added.</a:t>
             </a:r>
           </a:p>
         </p:txBody>
@@ -934,7 +1857,7 @@
           <a:lstStyle/>
           <a:p>
             <a:r>
-              <a:t>5:08–5:10. Explicit tie: Shipper used her AI as a coach, reflecting on actual projects and learning the next step. Without long chat history, paste your last two submissions or describe what you have tried. The free reading link is in your account. No due date announced.</a:t>
+              <a:t>Students recently asked their tools to explain the tool itself while building. Model this as a learning practice, not outsourcing understanding.</a:t>
             </a:r>
           </a:p>
         </p:txBody>
@@ -1004,7 +1927,7 @@
           <a:lstStyle/>
           <a:p>
             <a:r>
-              <a:t>5:10–5:12. # marks a heading; - marks a list. The lesson itself is markdown. No technical deep dive.</a:t>
+              <a:t>Assigned reading. Shipper turned reflection on actual projects into a coaching conversation. The reading link is in students’ accounts; no new due date.</a:t>
             </a:r>
           </a:p>
         </p:txBody>
@@ -1074,7 +1997,7 @@
           <a:lstStyle/>
           <a:p>
             <a:r>
-              <a:t>5:12–5:14. Specific support varies by tool. These are ordinary files with plain words. They help the next session know what you mean without re-explaining everything. No live demo here and no template.</a:t>
+              <a:t>Free plans need not have long-term memory. Give a small truthful sample, not every private conversation.</a:t>
             </a:r>
           </a:p>
         </p:txBody>
@@ -1144,7 +2067,7 @@
           <a:lstStyle/>
           <a:p>
             <a:r>
-              <a:t>5:14–5:16. Read the example as what you would tell a new teammate. The point is persistent context, not a prescribed format.</a:t>
+              <a:t>Explain portability: the same text works across tools. A file can be edited without a platform account.</a:t>
             </a:r>
           </a:p>
         </p:txBody>
@@ -1214,7 +2137,7 @@
           <a:lstStyle/>
           <a:p>
             <a:r>
-              <a:t>5:16–5:18. Commit saves a version locally. Push sends it to GitHub. Deploy publishes a website.</a:t>
+              <a:t>Point out # and ## headings; - list; [label](URL) link; backticks for code. These are examples, not a context template.</a:t>
             </a:r>
           </a:p>
         </p:txBody>
@@ -1284,7 +2207,7 @@
           <a:lstStyle/>
           <a:p>
             <a:r>
-              <a:t>5:18–5:20. Plain HTML/CSS: Pages. A framework app may need a different host such as Vercel. The handout is optional detail; all essential concepts are on this slide. No deployment demo tonight.</a:t>
+              <a:t>Avoid claiming every app literally starts at zero: some add saved memory or project files. Ask what context the tool loaded.</a:t>
             </a:r>
           </a:p>
         </p:txBody>
@@ -1354,7 +2277,7 @@
           <a:lstStyle/>
           <a:p>
             <a:r>
-              <a:t>5:20–5:22. Concept only; no course connector, server address or setup.</a:t>
+              <a:t>These are useful questions, not a rigid template or pair interview. Student projects vary: portfolios, creative work, tools, simulations.</a:t>
             </a:r>
           </a:p>
         </p:txBody>
@@ -4461,7 +5384,7 @@
                 </a:solidFill>
                 <a:latin typeface="DM Sans"/>
               </a:rPr>
-              <a:t>Use AI to understand AI. Then build something that helps you learn.</a:t>
+              <a:t>Context, communication, checking, and building for your learning.</a:t>
             </a:r>
           </a:p>
           <a:p>
@@ -4516,7 +5439,7 @@
                 </a:solidFill>
                 <a:latin typeface="DM Sans"/>
               </a:rPr>
-              <a:t>Week 6 · Opening        1 / 13</a:t>
+              <a:t>Week 6 · Opening        1 / 26</a:t>
             </a:r>
           </a:p>
         </p:txBody>
@@ -4618,13 +5541,13 @@
               </a:spcAft>
             </a:pPr>
             <a:r>
-              <a:rPr sz="3200" b="1">
+              <a:rPr sz="4000" b="1">
                 <a:solidFill>
                   <a:srgbClr val="272A25"/>
                 </a:solidFill>
                 <a:latin typeface="Fraunces"/>
               </a:rPr>
-              <a:t>Everything you need is on the Week 6 page</a:t>
+              <a:t>Automatic loading is tool-specific</a:t>
             </a:r>
           </a:p>
         </p:txBody>
@@ -4663,7 +5586,7 @@
                 </a:solidFill>
                 <a:latin typeface="DM Sans"/>
               </a:rPr>
-              <a:t>•  cu.learnvibe.build → Everything for Week 6</a:t>
+              <a:t>•  Codex uses AGENTS.md; Claude Code uses CLAUDE.md.</a:t>
             </a:r>
           </a:p>
           <a:p>
@@ -4679,7 +5602,7 @@
                 </a:solidFill>
                 <a:latin typeface="DM Sans"/>
               </a:rPr>
-              <a:t>•  Click “Copy lesson as markdown” → paste into your AI.</a:t>
+              <a:t>•  Other tools have their own rules and supported filenames—check yours.</a:t>
             </a:r>
           </a:p>
           <a:p>
@@ -4695,7 +5618,7 @@
                 </a:solidFill>
                 <a:latin typeface="DM Sans"/>
               </a:rPr>
-              <a:t>•  Ask: “Teach me this and quiz me.”</a:t>
+              <a:t>•  In a chat app, paste the context or add it to a Project; it may not read local files.</a:t>
             </a:r>
           </a:p>
         </p:txBody>
@@ -4734,7 +5657,7 @@
                 </a:solidFill>
                 <a:latin typeface="DM Sans"/>
               </a:rPr>
-              <a:t>Week 6 · Learn with AI        10 / 13</a:t>
+              <a:t>Week 6 · Ongoing context        10 / 26</a:t>
             </a:r>
           </a:p>
         </p:txBody>
@@ -4842,7 +5765,7 @@
                 </a:solidFill>
                 <a:latin typeface="Fraunces"/>
               </a:rPr>
-              <a:t>One live conversation with Claude</a:t>
+              <a:t>An index points to deeper context</a:t>
             </a:r>
           </a:p>
         </p:txBody>
@@ -4881,7 +5804,7 @@
                 </a:solidFill>
                 <a:latin typeface="DM Sans"/>
               </a:rPr>
-              <a:t>•  Copy the lesson markdown into Claude.</a:t>
+              <a:t>•  A small index says which files exist and what each is for.</a:t>
             </a:r>
           </a:p>
           <a:p>
@@ -4897,7 +5820,7 @@
                 </a:solidFill>
                 <a:latin typeface="DM Sans"/>
               </a:rPr>
-              <a:t>•  Talk through what you want to understand.</a:t>
+              <a:t>•  Example: docs/facts.md → verified facts; docs/design.md → visual direction.</a:t>
             </a:r>
           </a:p>
           <a:p>
@@ -4913,7 +5836,7 @@
                 </a:solidFill>
                 <a:latin typeface="DM Sans"/>
               </a:rPr>
-              <a:t>•  Maybe ask Claude to build a little thing from that conversation.</a:t>
+              <a:t>•  The AI can open the relevant document instead of receiving one giant prompt.</a:t>
             </a:r>
           </a:p>
         </p:txBody>
@@ -4952,7 +5875,7 @@
                 </a:solidFill>
                 <a:latin typeface="DM Sans"/>
               </a:rPr>
-              <a:t>Week 6 · Live demo        11 / 13</a:t>
+              <a:t>Week 6 · Ongoing context        11 / 26</a:t>
             </a:r>
           </a:p>
         </p:txBody>
@@ -5060,7 +5983,7 @@
                 </a:solidFill>
                 <a:latin typeface="Fraunces"/>
               </a:rPr>
-              <a:t>In small groups: build something that helps you learn</a:t>
+              <a:t>Describe the design, not just the features</a:t>
             </a:r>
           </a:p>
         </p:txBody>
@@ -5099,7 +6022,7 @@
                 </a:solidFill>
                 <a:latin typeface="DM Sans"/>
               </a:rPr>
-              <a:t>•  Choose your own topic and approach.</a:t>
+              <a:t>•  “Make it better” leaves the visual choices to the model.</a:t>
             </a:r>
           </a:p>
           <a:p>
@@ -5115,7 +6038,7 @@
                 </a:solidFill>
                 <a:latin typeface="DM Sans"/>
               </a:rPr>
-              <a:t>•  Try a quiz, interactive explainer, practice tool—or your own idea.</a:t>
+              <a:t>•  Name the audience, feeling, hierarchy and interactions you want.</a:t>
             </a:r>
           </a:p>
           <a:p>
@@ -5131,7 +6054,7 @@
                 </a:solidFill>
                 <a:latin typeface="DM Sans"/>
               </a:rPr>
-              <a:t>•  Use your AI, test what you build, and show what it helped you learn.</a:t>
+              <a:t>•  Example: “Calm portfolio. Work first, muted colours, clickable project cards.”</a:t>
             </a:r>
           </a:p>
         </p:txBody>
@@ -5170,7 +6093,7 @@
                 </a:solidFill>
                 <a:latin typeface="DM Sans"/>
               </a:rPr>
-              <a:t>Week 6 · Group work        12 / 13</a:t>
+              <a:t>Week 6 · Communicate intent        12 / 26</a:t>
             </a:r>
           </a:p>
         </p:txBody>
@@ -5278,7 +6201,7 @@
                 </a:solidFill>
                 <a:latin typeface="Fraunces"/>
               </a:rPr>
-              <a:t>Start with a learning question</a:t>
+              <a:t>Make your feedback observable</a:t>
             </a:r>
           </a:p>
         </p:txBody>
@@ -5317,7 +6240,7 @@
                 </a:solidFill>
                 <a:latin typeface="DM Sans"/>
               </a:rPr>
-              <a:t>•  What do you want to understand or practise?</a:t>
+              <a:t>•  Give a reference or screenshot; say what to keep and what to change.</a:t>
             </a:r>
           </a:p>
           <a:p>
@@ -5333,7 +6256,7 @@
                 </a:solidFill>
                 <a:latin typeface="DM Sans"/>
               </a:rPr>
-              <a:t>•  Give your AI the lesson, your question, or both.</a:t>
+              <a:t>•  Instead of “It’s broken”: “Clicking this card should open the project; nothing happens.”</a:t>
             </a:r>
           </a:p>
           <a:p>
@@ -5349,7 +6272,7 @@
                 </a:solidFill>
                 <a:latin typeface="DM Sans"/>
               </a:rPr>
-              <a:t>•  Build a small first version; try it and revise.</a:t>
+              <a:t>•  Ask for one small change, then compare the result with your intention.</a:t>
             </a:r>
           </a:p>
         </p:txBody>
@@ -5388,7 +6311,1315 @@
                 </a:solidFill>
                 <a:latin typeface="DM Sans"/>
               </a:rPr>
-              <a:t>Week 6 · Group work        13 / 13</a:t>
+              <a:t>Week 6 · Communicate intent        13 / 26</a:t>
+            </a:r>
+          </a:p>
+        </p:txBody>
+      </p:sp>
+    </p:spTree>
+  </p:cSld>
+  <p:clrMapOvr>
+    <a:masterClrMapping/>
+  </p:clrMapOvr>
+</p:sld>
+</file>
+
+<file path=ppt/slides/slide14.xml><?xml version="1.0" encoding="utf-8"?>
+<p:sld xmlns:a="http://schemas.openxmlformats.org/drawingml/2006/main" xmlns:p="http://schemas.openxmlformats.org/presentationml/2006/main" xmlns:r="http://schemas.openxmlformats.org/officeDocument/2006/relationships">
+  <p:cSld>
+    <p:bg>
+      <p:bgPr>
+        <a:solidFill>
+          <a:srgbClr val="F7F5EE"/>
+        </a:solidFill>
+        <a:effectLst/>
+      </p:bgPr>
+    </p:bg>
+    <p:spTree>
+      <p:nvGrpSpPr>
+        <p:cNvPr id="1" name=""/>
+        <p:cNvGrpSpPr/>
+        <p:nvPr/>
+      </p:nvGrpSpPr>
+      <p:grpSpPr/>
+      <p:sp>
+        <p:nvSpPr>
+          <p:cNvPr id="2" name="Rectangle 1"/>
+          <p:cNvSpPr/>
+          <p:nvPr/>
+        </p:nvSpPr>
+        <p:spPr>
+          <a:xfrm>
+            <a:off x="0" y="0"/>
+            <a:ext cx="228600" cy="6858000"/>
+          </a:xfrm>
+          <a:prstGeom prst="rect">
+            <a:avLst/>
+          </a:prstGeom>
+          <a:solidFill>
+            <a:srgbClr val="A83D2B"/>
+          </a:solidFill>
+          <a:ln>
+            <a:noFill/>
+          </a:ln>
+        </p:spPr>
+        <p:style>
+          <a:lnRef idx="1">
+            <a:schemeClr val="accent1"/>
+          </a:lnRef>
+          <a:fillRef idx="3">
+            <a:schemeClr val="accent1"/>
+          </a:fillRef>
+          <a:effectRef idx="2">
+            <a:schemeClr val="accent1"/>
+          </a:effectRef>
+          <a:fontRef idx="minor">
+            <a:schemeClr val="lt1"/>
+          </a:fontRef>
+        </p:style>
+        <p:txBody>
+          <a:bodyPr rtlCol="0" anchor="ctr"/>
+          <a:lstStyle/>
+          <a:p>
+            <a:pPr algn="ctr"/>
+          </a:p>
+        </p:txBody>
+      </p:sp>
+      <p:sp>
+        <p:nvSpPr>
+          <p:cNvPr id="3" name="TextBox 2"/>
+          <p:cNvSpPr txBox="1"/>
+          <p:nvPr/>
+        </p:nvSpPr>
+        <p:spPr>
+          <a:xfrm>
+            <a:off x="822960" y="548640"/>
+            <a:ext cx="10607040" cy="1188720"/>
+          </a:xfrm>
+          <a:prstGeom prst="rect">
+            <a:avLst/>
+          </a:prstGeom>
+          <a:noFill/>
+        </p:spPr>
+        <p:txBody>
+          <a:bodyPr wrap="square">
+            <a:spAutoFit/>
+          </a:bodyPr>
+          <a:lstStyle/>
+          <a:p>
+            <a:pPr>
+              <a:spcAft>
+                <a:spcPts val="1400"/>
+              </a:spcAft>
+            </a:pPr>
+            <a:r>
+              <a:rPr sz="4000" b="1">
+                <a:solidFill>
+                  <a:srgbClr val="272A25"/>
+                </a:solidFill>
+                <a:latin typeface="Fraunces"/>
+              </a:rPr>
+              <a:t>Debugging: find the mismatch</a:t>
+            </a:r>
+          </a:p>
+        </p:txBody>
+      </p:sp>
+      <p:sp>
+        <p:nvSpPr>
+          <p:cNvPr id="4" name="TextBox 3"/>
+          <p:cNvSpPr txBox="1"/>
+          <p:nvPr/>
+        </p:nvSpPr>
+        <p:spPr>
+          <a:xfrm>
+            <a:off x="822960" y="2011680"/>
+            <a:ext cx="10607040" cy="4206240"/>
+          </a:xfrm>
+          <a:prstGeom prst="rect">
+            <a:avLst/>
+          </a:prstGeom>
+          <a:noFill/>
+        </p:spPr>
+        <p:txBody>
+          <a:bodyPr wrap="square">
+            <a:spAutoFit/>
+          </a:bodyPr>
+          <a:lstStyle/>
+          <a:p>
+            <a:pPr>
+              <a:spcAft>
+                <a:spcPts val="2200"/>
+              </a:spcAft>
+            </a:pPr>
+            <a:r>
+              <a:rPr sz="3000" b="0">
+                <a:solidFill>
+                  <a:srgbClr val="272A25"/>
+                </a:solidFill>
+                <a:latin typeface="DM Sans"/>
+              </a:rPr>
+              <a:t>•  A bug is a difference between expected and observed behavior.</a:t>
+            </a:r>
+          </a:p>
+          <a:p>
+            <a:pPr>
+              <a:spcAft>
+                <a:spcPts val="2200"/>
+              </a:spcAft>
+            </a:pPr>
+            <a:r>
+              <a:rPr sz="3000" b="0">
+                <a:solidFill>
+                  <a:srgbClr val="272A25"/>
+                </a:solidFill>
+                <a:latin typeface="DM Sans"/>
+              </a:rPr>
+              <a:t>•  Reproduce it: what exact actions cause it? Capture the error or screenshot.</a:t>
+            </a:r>
+          </a:p>
+          <a:p>
+            <a:pPr>
+              <a:spcAft>
+                <a:spcPts val="2200"/>
+              </a:spcAft>
+            </a:pPr>
+            <a:r>
+              <a:rPr sz="3000" b="0">
+                <a:solidFill>
+                  <a:srgbClr val="272A25"/>
+                </a:solidFill>
+                <a:latin typeface="DM Sans"/>
+              </a:rPr>
+              <a:t>•  Ask the AI for a cause and a small fix; rerun the same check afterward.</a:t>
+            </a:r>
+          </a:p>
+        </p:txBody>
+      </p:sp>
+      <p:sp>
+        <p:nvSpPr>
+          <p:cNvPr id="5" name="TextBox 4"/>
+          <p:cNvSpPr txBox="1"/>
+          <p:nvPr/>
+        </p:nvSpPr>
+        <p:spPr>
+          <a:xfrm>
+            <a:off x="822960" y="6263640"/>
+            <a:ext cx="10607040" cy="365760"/>
+          </a:xfrm>
+          <a:prstGeom prst="rect">
+            <a:avLst/>
+          </a:prstGeom>
+          <a:noFill/>
+        </p:spPr>
+        <p:txBody>
+          <a:bodyPr wrap="square">
+            <a:spAutoFit/>
+          </a:bodyPr>
+          <a:lstStyle/>
+          <a:p>
+            <a:pPr algn="r">
+              <a:spcAft>
+                <a:spcPts val="1400"/>
+              </a:spcAft>
+            </a:pPr>
+            <a:r>
+              <a:rPr sz="1600" b="0">
+                <a:solidFill>
+                  <a:srgbClr val="64665D"/>
+                </a:solidFill>
+                <a:latin typeface="DM Sans"/>
+              </a:rPr>
+              <a:t>Week 6 · Check the work        14 / 26</a:t>
+            </a:r>
+          </a:p>
+        </p:txBody>
+      </p:sp>
+    </p:spTree>
+  </p:cSld>
+  <p:clrMapOvr>
+    <a:masterClrMapping/>
+  </p:clrMapOvr>
+</p:sld>
+</file>
+
+<file path=ppt/slides/slide15.xml><?xml version="1.0" encoding="utf-8"?>
+<p:sld xmlns:a="http://schemas.openxmlformats.org/drawingml/2006/main" xmlns:p="http://schemas.openxmlformats.org/presentationml/2006/main" xmlns:r="http://schemas.openxmlformats.org/officeDocument/2006/relationships">
+  <p:cSld>
+    <p:bg>
+      <p:bgPr>
+        <a:solidFill>
+          <a:srgbClr val="F7F5EE"/>
+        </a:solidFill>
+        <a:effectLst/>
+      </p:bgPr>
+    </p:bg>
+    <p:spTree>
+      <p:nvGrpSpPr>
+        <p:cNvPr id="1" name=""/>
+        <p:cNvGrpSpPr/>
+        <p:nvPr/>
+      </p:nvGrpSpPr>
+      <p:grpSpPr/>
+      <p:sp>
+        <p:nvSpPr>
+          <p:cNvPr id="2" name="Rectangle 1"/>
+          <p:cNvSpPr/>
+          <p:nvPr/>
+        </p:nvSpPr>
+        <p:spPr>
+          <a:xfrm>
+            <a:off x="0" y="0"/>
+            <a:ext cx="228600" cy="6858000"/>
+          </a:xfrm>
+          <a:prstGeom prst="rect">
+            <a:avLst/>
+          </a:prstGeom>
+          <a:solidFill>
+            <a:srgbClr val="A83D2B"/>
+          </a:solidFill>
+          <a:ln>
+            <a:noFill/>
+          </a:ln>
+        </p:spPr>
+        <p:style>
+          <a:lnRef idx="1">
+            <a:schemeClr val="accent1"/>
+          </a:lnRef>
+          <a:fillRef idx="3">
+            <a:schemeClr val="accent1"/>
+          </a:fillRef>
+          <a:effectRef idx="2">
+            <a:schemeClr val="accent1"/>
+          </a:effectRef>
+          <a:fontRef idx="minor">
+            <a:schemeClr val="lt1"/>
+          </a:fontRef>
+        </p:style>
+        <p:txBody>
+          <a:bodyPr rtlCol="0" anchor="ctr"/>
+          <a:lstStyle/>
+          <a:p>
+            <a:pPr algn="ctr"/>
+          </a:p>
+        </p:txBody>
+      </p:sp>
+      <p:sp>
+        <p:nvSpPr>
+          <p:cNvPr id="3" name="TextBox 2"/>
+          <p:cNvSpPr txBox="1"/>
+          <p:nvPr/>
+        </p:nvSpPr>
+        <p:spPr>
+          <a:xfrm>
+            <a:off x="822960" y="548640"/>
+            <a:ext cx="10607040" cy="1188720"/>
+          </a:xfrm>
+          <a:prstGeom prst="rect">
+            <a:avLst/>
+          </a:prstGeom>
+          <a:noFill/>
+        </p:spPr>
+        <p:txBody>
+          <a:bodyPr wrap="square">
+            <a:spAutoFit/>
+          </a:bodyPr>
+          <a:lstStyle/>
+          <a:p>
+            <a:pPr>
+              <a:spcAft>
+                <a:spcPts val="1400"/>
+              </a:spcAft>
+            </a:pPr>
+            <a:r>
+              <a:rPr sz="4000" b="1">
+                <a:solidFill>
+                  <a:srgbClr val="272A25"/>
+                </a:solidFill>
+                <a:latin typeface="Fraunces"/>
+              </a:rPr>
+              <a:t>Check the experience—not just the code</a:t>
+            </a:r>
+          </a:p>
+        </p:txBody>
+      </p:sp>
+      <p:sp>
+        <p:nvSpPr>
+          <p:cNvPr id="4" name="TextBox 3"/>
+          <p:cNvSpPr txBox="1"/>
+          <p:nvPr/>
+        </p:nvSpPr>
+        <p:spPr>
+          <a:xfrm>
+            <a:off x="822960" y="2011680"/>
+            <a:ext cx="10607040" cy="4206240"/>
+          </a:xfrm>
+          <a:prstGeom prst="rect">
+            <a:avLst/>
+          </a:prstGeom>
+          <a:noFill/>
+        </p:spPr>
+        <p:txBody>
+          <a:bodyPr wrap="square">
+            <a:spAutoFit/>
+          </a:bodyPr>
+          <a:lstStyle/>
+          <a:p>
+            <a:pPr>
+              <a:spcAft>
+                <a:spcPts val="2200"/>
+              </a:spcAft>
+            </a:pPr>
+            <a:r>
+              <a:rPr sz="3000" b="0">
+                <a:solidFill>
+                  <a:srgbClr val="272A25"/>
+                </a:solidFill>
+                <a:latin typeface="DM Sans"/>
+              </a:rPr>
+              <a:t>•  Open it on a phone. Click every important button and link.</a:t>
+            </a:r>
+          </a:p>
+          <a:p>
+            <a:pPr>
+              <a:spcAft>
+                <a:spcPts val="2200"/>
+              </a:spcAft>
+            </a:pPr>
+            <a:r>
+              <a:rPr sz="3000" b="0">
+                <a:solidFill>
+                  <a:srgbClr val="272A25"/>
+                </a:solidFill>
+                <a:latin typeface="DM Sans"/>
+              </a:rPr>
+              <a:t>•  Try empty input, a strange answer, or a first-time visitor’s path.</a:t>
+            </a:r>
+          </a:p>
+          <a:p>
+            <a:pPr>
+              <a:spcAft>
+                <a:spcPts val="2200"/>
+              </a:spcAft>
+            </a:pPr>
+            <a:r>
+              <a:rPr sz="3000" b="0">
+                <a:solidFill>
+                  <a:srgbClr val="272A25"/>
+                </a:solidFill>
+                <a:latin typeface="DM Sans"/>
+              </a:rPr>
+              <a:t>•  For a learning tool, check its facts and quiz answers against a trustworthy source.</a:t>
+            </a:r>
+          </a:p>
+        </p:txBody>
+      </p:sp>
+      <p:sp>
+        <p:nvSpPr>
+          <p:cNvPr id="5" name="TextBox 4"/>
+          <p:cNvSpPr txBox="1"/>
+          <p:nvPr/>
+        </p:nvSpPr>
+        <p:spPr>
+          <a:xfrm>
+            <a:off x="822960" y="6263640"/>
+            <a:ext cx="10607040" cy="365760"/>
+          </a:xfrm>
+          <a:prstGeom prst="rect">
+            <a:avLst/>
+          </a:prstGeom>
+          <a:noFill/>
+        </p:spPr>
+        <p:txBody>
+          <a:bodyPr wrap="square">
+            <a:spAutoFit/>
+          </a:bodyPr>
+          <a:lstStyle/>
+          <a:p>
+            <a:pPr algn="r">
+              <a:spcAft>
+                <a:spcPts val="1400"/>
+              </a:spcAft>
+            </a:pPr>
+            <a:r>
+              <a:rPr sz="1600" b="0">
+                <a:solidFill>
+                  <a:srgbClr val="64665D"/>
+                </a:solidFill>
+                <a:latin typeface="DM Sans"/>
+              </a:rPr>
+              <a:t>Week 6 · Check the work        15 / 26</a:t>
+            </a:r>
+          </a:p>
+        </p:txBody>
+      </p:sp>
+    </p:spTree>
+  </p:cSld>
+  <p:clrMapOvr>
+    <a:masterClrMapping/>
+  </p:clrMapOvr>
+</p:sld>
+</file>
+
+<file path=ppt/slides/slide16.xml><?xml version="1.0" encoding="utf-8"?>
+<p:sld xmlns:a="http://schemas.openxmlformats.org/drawingml/2006/main" xmlns:p="http://schemas.openxmlformats.org/presentationml/2006/main" xmlns:r="http://schemas.openxmlformats.org/officeDocument/2006/relationships">
+  <p:cSld>
+    <p:bg>
+      <p:bgPr>
+        <a:solidFill>
+          <a:srgbClr val="F7F5EE"/>
+        </a:solidFill>
+        <a:effectLst/>
+      </p:bgPr>
+    </p:bg>
+    <p:spTree>
+      <p:nvGrpSpPr>
+        <p:cNvPr id="1" name=""/>
+        <p:cNvGrpSpPr/>
+        <p:nvPr/>
+      </p:nvGrpSpPr>
+      <p:grpSpPr/>
+      <p:sp>
+        <p:nvSpPr>
+          <p:cNvPr id="2" name="Rectangle 1"/>
+          <p:cNvSpPr/>
+          <p:nvPr/>
+        </p:nvSpPr>
+        <p:spPr>
+          <a:xfrm>
+            <a:off x="0" y="0"/>
+            <a:ext cx="228600" cy="6858000"/>
+          </a:xfrm>
+          <a:prstGeom prst="rect">
+            <a:avLst/>
+          </a:prstGeom>
+          <a:solidFill>
+            <a:srgbClr val="A83D2B"/>
+          </a:solidFill>
+          <a:ln>
+            <a:noFill/>
+          </a:ln>
+        </p:spPr>
+        <p:style>
+          <a:lnRef idx="1">
+            <a:schemeClr val="accent1"/>
+          </a:lnRef>
+          <a:fillRef idx="3">
+            <a:schemeClr val="accent1"/>
+          </a:fillRef>
+          <a:effectRef idx="2">
+            <a:schemeClr val="accent1"/>
+          </a:effectRef>
+          <a:fontRef idx="minor">
+            <a:schemeClr val="lt1"/>
+          </a:fontRef>
+        </p:style>
+        <p:txBody>
+          <a:bodyPr rtlCol="0" anchor="ctr"/>
+          <a:lstStyle/>
+          <a:p>
+            <a:pPr algn="ctr"/>
+          </a:p>
+        </p:txBody>
+      </p:sp>
+      <p:sp>
+        <p:nvSpPr>
+          <p:cNvPr id="3" name="TextBox 2"/>
+          <p:cNvSpPr txBox="1"/>
+          <p:nvPr/>
+        </p:nvSpPr>
+        <p:spPr>
+          <a:xfrm>
+            <a:off x="822960" y="548640"/>
+            <a:ext cx="10607040" cy="1188720"/>
+          </a:xfrm>
+          <a:prstGeom prst="rect">
+            <a:avLst/>
+          </a:prstGeom>
+          <a:noFill/>
+        </p:spPr>
+        <p:txBody>
+          <a:bodyPr wrap="square">
+            <a:spAutoFit/>
+          </a:bodyPr>
+          <a:lstStyle/>
+          <a:p>
+            <a:pPr>
+              <a:spcAft>
+                <a:spcPts val="1400"/>
+              </a:spcAft>
+            </a:pPr>
+            <a:r>
+              <a:rPr sz="4000" b="1">
+                <a:solidFill>
+                  <a:srgbClr val="272A25"/>
+                </a:solidFill>
+                <a:latin typeface="Fraunces"/>
+              </a:rPr>
+              <a:t>When free credits run out</a:t>
+            </a:r>
+          </a:p>
+        </p:txBody>
+      </p:sp>
+      <p:sp>
+        <p:nvSpPr>
+          <p:cNvPr id="4" name="TextBox 3"/>
+          <p:cNvSpPr txBox="1"/>
+          <p:nvPr/>
+        </p:nvSpPr>
+        <p:spPr>
+          <a:xfrm>
+            <a:off x="822960" y="2011680"/>
+            <a:ext cx="10607040" cy="4206240"/>
+          </a:xfrm>
+          <a:prstGeom prst="rect">
+            <a:avLst/>
+          </a:prstGeom>
+          <a:noFill/>
+        </p:spPr>
+        <p:txBody>
+          <a:bodyPr wrap="square">
+            <a:spAutoFit/>
+          </a:bodyPr>
+          <a:lstStyle/>
+          <a:p>
+            <a:pPr>
+              <a:spcAft>
+                <a:spcPts val="2200"/>
+              </a:spcAft>
+            </a:pPr>
+            <a:r>
+              <a:rPr sz="3000" b="0">
+                <a:solidFill>
+                  <a:srgbClr val="272A25"/>
+                </a:solidFill>
+                <a:latin typeface="DM Sans"/>
+              </a:rPr>
+              <a:t>•  Save files and a short note: what works, what failed, what to try next.</a:t>
+            </a:r>
+          </a:p>
+          <a:p>
+            <a:pPr>
+              <a:spcAft>
+                <a:spcPts val="2200"/>
+              </a:spcAft>
+            </a:pPr>
+            <a:r>
+              <a:rPr sz="3000" b="0">
+                <a:solidFill>
+                  <a:srgbClr val="272A25"/>
+                </a:solidFill>
+                <a:latin typeface="DM Sans"/>
+              </a:rPr>
+              <a:t>•  Use that note to continue in a fresh session or another tool.</a:t>
+            </a:r>
+          </a:p>
+          <a:p>
+            <a:pPr>
+              <a:spcAft>
+                <a:spcPts val="2200"/>
+              </a:spcAft>
+            </a:pPr>
+            <a:r>
+              <a:rPr sz="3000" b="0">
+                <a:solidFill>
+                  <a:srgbClr val="272A25"/>
+                </a:solidFill>
+                <a:latin typeface="DM Sans"/>
+              </a:rPr>
+              <a:t>•  Reduce the request: one change or one explanation at a time.</a:t>
+            </a:r>
+          </a:p>
+        </p:txBody>
+      </p:sp>
+      <p:sp>
+        <p:nvSpPr>
+          <p:cNvPr id="5" name="TextBox 4"/>
+          <p:cNvSpPr txBox="1"/>
+          <p:nvPr/>
+        </p:nvSpPr>
+        <p:spPr>
+          <a:xfrm>
+            <a:off x="822960" y="6263640"/>
+            <a:ext cx="10607040" cy="365760"/>
+          </a:xfrm>
+          <a:prstGeom prst="rect">
+            <a:avLst/>
+          </a:prstGeom>
+          <a:noFill/>
+        </p:spPr>
+        <p:txBody>
+          <a:bodyPr wrap="square">
+            <a:spAutoFit/>
+          </a:bodyPr>
+          <a:lstStyle/>
+          <a:p>
+            <a:pPr algn="r">
+              <a:spcAft>
+                <a:spcPts val="1400"/>
+              </a:spcAft>
+            </a:pPr>
+            <a:r>
+              <a:rPr sz="1600" b="0">
+                <a:solidFill>
+                  <a:srgbClr val="64665D"/>
+                </a:solidFill>
+                <a:latin typeface="DM Sans"/>
+              </a:rPr>
+              <a:t>Week 6 · Working within limits        16 / 26</a:t>
+            </a:r>
+          </a:p>
+        </p:txBody>
+      </p:sp>
+    </p:spTree>
+  </p:cSld>
+  <p:clrMapOvr>
+    <a:masterClrMapping/>
+  </p:clrMapOvr>
+</p:sld>
+</file>
+
+<file path=ppt/slides/slide17.xml><?xml version="1.0" encoding="utf-8"?>
+<p:sld xmlns:a="http://schemas.openxmlformats.org/drawingml/2006/main" xmlns:p="http://schemas.openxmlformats.org/presentationml/2006/main" xmlns:r="http://schemas.openxmlformats.org/officeDocument/2006/relationships">
+  <p:cSld>
+    <p:bg>
+      <p:bgPr>
+        <a:solidFill>
+          <a:srgbClr val="F7F5EE"/>
+        </a:solidFill>
+        <a:effectLst/>
+      </p:bgPr>
+    </p:bg>
+    <p:spTree>
+      <p:nvGrpSpPr>
+        <p:cNvPr id="1" name=""/>
+        <p:cNvGrpSpPr/>
+        <p:nvPr/>
+      </p:nvGrpSpPr>
+      <p:grpSpPr/>
+      <p:sp>
+        <p:nvSpPr>
+          <p:cNvPr id="2" name="Rectangle 1"/>
+          <p:cNvSpPr/>
+          <p:nvPr/>
+        </p:nvSpPr>
+        <p:spPr>
+          <a:xfrm>
+            <a:off x="0" y="0"/>
+            <a:ext cx="228600" cy="6858000"/>
+          </a:xfrm>
+          <a:prstGeom prst="rect">
+            <a:avLst/>
+          </a:prstGeom>
+          <a:solidFill>
+            <a:srgbClr val="A83D2B"/>
+          </a:solidFill>
+          <a:ln>
+            <a:noFill/>
+          </a:ln>
+        </p:spPr>
+        <p:style>
+          <a:lnRef idx="1">
+            <a:schemeClr val="accent1"/>
+          </a:lnRef>
+          <a:fillRef idx="3">
+            <a:schemeClr val="accent1"/>
+          </a:fillRef>
+          <a:effectRef idx="2">
+            <a:schemeClr val="accent1"/>
+          </a:effectRef>
+          <a:fontRef idx="minor">
+            <a:schemeClr val="lt1"/>
+          </a:fontRef>
+        </p:style>
+        <p:txBody>
+          <a:bodyPr rtlCol="0" anchor="ctr"/>
+          <a:lstStyle/>
+          <a:p>
+            <a:pPr algn="ctr"/>
+          </a:p>
+        </p:txBody>
+      </p:sp>
+      <p:sp>
+        <p:nvSpPr>
+          <p:cNvPr id="3" name="TextBox 2"/>
+          <p:cNvSpPr txBox="1"/>
+          <p:nvPr/>
+        </p:nvSpPr>
+        <p:spPr>
+          <a:xfrm>
+            <a:off x="822960" y="548640"/>
+            <a:ext cx="10607040" cy="1188720"/>
+          </a:xfrm>
+          <a:prstGeom prst="rect">
+            <a:avLst/>
+          </a:prstGeom>
+          <a:noFill/>
+        </p:spPr>
+        <p:txBody>
+          <a:bodyPr wrap="square">
+            <a:spAutoFit/>
+          </a:bodyPr>
+          <a:lstStyle/>
+          <a:p>
+            <a:pPr>
+              <a:spcAft>
+                <a:spcPts val="1400"/>
+              </a:spcAft>
+            </a:pPr>
+            <a:r>
+              <a:rPr sz="3200" b="1">
+                <a:solidFill>
+                  <a:srgbClr val="272A25"/>
+                </a:solidFill>
+                <a:latin typeface="Fraunces"/>
+              </a:rPr>
+              <a:t>Folder, repository, website: different things</a:t>
+            </a:r>
+          </a:p>
+        </p:txBody>
+      </p:sp>
+      <p:sp>
+        <p:nvSpPr>
+          <p:cNvPr id="4" name="TextBox 3"/>
+          <p:cNvSpPr txBox="1"/>
+          <p:nvPr/>
+        </p:nvSpPr>
+        <p:spPr>
+          <a:xfrm>
+            <a:off x="822960" y="2011680"/>
+            <a:ext cx="10607040" cy="4206240"/>
+          </a:xfrm>
+          <a:prstGeom prst="rect">
+            <a:avLst/>
+          </a:prstGeom>
+          <a:noFill/>
+        </p:spPr>
+        <p:txBody>
+          <a:bodyPr wrap="square">
+            <a:spAutoFit/>
+          </a:bodyPr>
+          <a:lstStyle/>
+          <a:p>
+            <a:pPr>
+              <a:spcAft>
+                <a:spcPts val="2200"/>
+              </a:spcAft>
+            </a:pPr>
+            <a:r>
+              <a:rPr sz="3000" b="0">
+                <a:solidFill>
+                  <a:srgbClr val="272A25"/>
+                </a:solidFill>
+                <a:latin typeface="DM Sans"/>
+              </a:rPr>
+              <a:t>•  Local folder: files on your own computer.</a:t>
+            </a:r>
+          </a:p>
+          <a:p>
+            <a:pPr>
+              <a:spcAft>
+                <a:spcPts val="2200"/>
+              </a:spcAft>
+            </a:pPr>
+            <a:r>
+              <a:rPr sz="3000" b="0">
+                <a:solidFill>
+                  <a:srgbClr val="272A25"/>
+                </a:solidFill>
+                <a:latin typeface="DM Sans"/>
+              </a:rPr>
+              <a:t>•  Git repository: those files plus a recorded history of versions.</a:t>
+            </a:r>
+          </a:p>
+          <a:p>
+            <a:pPr>
+              <a:spcAft>
+                <a:spcPts val="2200"/>
+              </a:spcAft>
+            </a:pPr>
+            <a:r>
+              <a:rPr sz="3000" b="0">
+                <a:solidFill>
+                  <a:srgbClr val="272A25"/>
+                </a:solidFill>
+                <a:latin typeface="DM Sans"/>
+              </a:rPr>
+              <a:t>•  Deployment: a published version that other people can open.</a:t>
+            </a:r>
+          </a:p>
+        </p:txBody>
+      </p:sp>
+      <p:sp>
+        <p:nvSpPr>
+          <p:cNvPr id="5" name="TextBox 4"/>
+          <p:cNvSpPr txBox="1"/>
+          <p:nvPr/>
+        </p:nvSpPr>
+        <p:spPr>
+          <a:xfrm>
+            <a:off x="822960" y="6263640"/>
+            <a:ext cx="10607040" cy="365760"/>
+          </a:xfrm>
+          <a:prstGeom prst="rect">
+            <a:avLst/>
+          </a:prstGeom>
+          <a:noFill/>
+        </p:spPr>
+        <p:txBody>
+          <a:bodyPr wrap="square">
+            <a:spAutoFit/>
+          </a:bodyPr>
+          <a:lstStyle/>
+          <a:p>
+            <a:pPr algn="r">
+              <a:spcAft>
+                <a:spcPts val="1400"/>
+              </a:spcAft>
+            </a:pPr>
+            <a:r>
+              <a:rPr sz="1600" b="0">
+                <a:solidFill>
+                  <a:srgbClr val="64665D"/>
+                </a:solidFill>
+                <a:latin typeface="DM Sans"/>
+              </a:rPr>
+              <a:t>Week 6 · Getting online        17 / 26</a:t>
+            </a:r>
+          </a:p>
+        </p:txBody>
+      </p:sp>
+    </p:spTree>
+  </p:cSld>
+  <p:clrMapOvr>
+    <a:masterClrMapping/>
+  </p:clrMapOvr>
+</p:sld>
+</file>
+
+<file path=ppt/slides/slide18.xml><?xml version="1.0" encoding="utf-8"?>
+<p:sld xmlns:a="http://schemas.openxmlformats.org/drawingml/2006/main" xmlns:p="http://schemas.openxmlformats.org/presentationml/2006/main" xmlns:r="http://schemas.openxmlformats.org/officeDocument/2006/relationships">
+  <p:cSld>
+    <p:bg>
+      <p:bgPr>
+        <a:solidFill>
+          <a:srgbClr val="F7F5EE"/>
+        </a:solidFill>
+        <a:effectLst/>
+      </p:bgPr>
+    </p:bg>
+    <p:spTree>
+      <p:nvGrpSpPr>
+        <p:cNvPr id="1" name=""/>
+        <p:cNvGrpSpPr/>
+        <p:nvPr/>
+      </p:nvGrpSpPr>
+      <p:grpSpPr/>
+      <p:sp>
+        <p:nvSpPr>
+          <p:cNvPr id="2" name="Rectangle 1"/>
+          <p:cNvSpPr/>
+          <p:nvPr/>
+        </p:nvSpPr>
+        <p:spPr>
+          <a:xfrm>
+            <a:off x="0" y="0"/>
+            <a:ext cx="228600" cy="6858000"/>
+          </a:xfrm>
+          <a:prstGeom prst="rect">
+            <a:avLst/>
+          </a:prstGeom>
+          <a:solidFill>
+            <a:srgbClr val="A83D2B"/>
+          </a:solidFill>
+          <a:ln>
+            <a:noFill/>
+          </a:ln>
+        </p:spPr>
+        <p:style>
+          <a:lnRef idx="1">
+            <a:schemeClr val="accent1"/>
+          </a:lnRef>
+          <a:fillRef idx="3">
+            <a:schemeClr val="accent1"/>
+          </a:fillRef>
+          <a:effectRef idx="2">
+            <a:schemeClr val="accent1"/>
+          </a:effectRef>
+          <a:fontRef idx="minor">
+            <a:schemeClr val="lt1"/>
+          </a:fontRef>
+        </p:style>
+        <p:txBody>
+          <a:bodyPr rtlCol="0" anchor="ctr"/>
+          <a:lstStyle/>
+          <a:p>
+            <a:pPr algn="ctr"/>
+          </a:p>
+        </p:txBody>
+      </p:sp>
+      <p:sp>
+        <p:nvSpPr>
+          <p:cNvPr id="3" name="TextBox 2"/>
+          <p:cNvSpPr txBox="1"/>
+          <p:nvPr/>
+        </p:nvSpPr>
+        <p:spPr>
+          <a:xfrm>
+            <a:off x="822960" y="548640"/>
+            <a:ext cx="10607040" cy="1188720"/>
+          </a:xfrm>
+          <a:prstGeom prst="rect">
+            <a:avLst/>
+          </a:prstGeom>
+          <a:noFill/>
+        </p:spPr>
+        <p:txBody>
+          <a:bodyPr wrap="square">
+            <a:spAutoFit/>
+          </a:bodyPr>
+          <a:lstStyle/>
+          <a:p>
+            <a:pPr>
+              <a:spcAft>
+                <a:spcPts val="1400"/>
+              </a:spcAft>
+            </a:pPr>
+            <a:r>
+              <a:rPr sz="4000" b="1">
+                <a:solidFill>
+                  <a:srgbClr val="272A25"/>
+                </a:solidFill>
+                <a:latin typeface="Fraunces"/>
+              </a:rPr>
+              <a:t>Commit, push, deploy: three actions</a:t>
+            </a:r>
+          </a:p>
+        </p:txBody>
+      </p:sp>
+      <p:sp>
+        <p:nvSpPr>
+          <p:cNvPr id="4" name="TextBox 3"/>
+          <p:cNvSpPr txBox="1"/>
+          <p:nvPr/>
+        </p:nvSpPr>
+        <p:spPr>
+          <a:xfrm>
+            <a:off x="822960" y="2011680"/>
+            <a:ext cx="10607040" cy="4206240"/>
+          </a:xfrm>
+          <a:prstGeom prst="rect">
+            <a:avLst/>
+          </a:prstGeom>
+          <a:noFill/>
+        </p:spPr>
+        <p:txBody>
+          <a:bodyPr wrap="square">
+            <a:spAutoFit/>
+          </a:bodyPr>
+          <a:lstStyle/>
+          <a:p>
+            <a:pPr>
+              <a:spcAft>
+                <a:spcPts val="2200"/>
+              </a:spcAft>
+            </a:pPr>
+            <a:r>
+              <a:rPr sz="3000" b="0">
+                <a:solidFill>
+                  <a:srgbClr val="272A25"/>
+                </a:solidFill>
+                <a:latin typeface="DM Sans"/>
+              </a:rPr>
+              <a:t>•  Commit saves a version and a message in your local Git history.</a:t>
+            </a:r>
+          </a:p>
+          <a:p>
+            <a:pPr>
+              <a:spcAft>
+                <a:spcPts val="2200"/>
+              </a:spcAft>
+            </a:pPr>
+            <a:r>
+              <a:rPr sz="3000" b="0">
+                <a:solidFill>
+                  <a:srgbClr val="272A25"/>
+                </a:solidFill>
+                <a:latin typeface="DM Sans"/>
+              </a:rPr>
+              <a:t>•  Push sends your commits to the repository on GitHub.</a:t>
+            </a:r>
+          </a:p>
+          <a:p>
+            <a:pPr>
+              <a:spcAft>
+                <a:spcPts val="2200"/>
+              </a:spcAft>
+            </a:pPr>
+            <a:r>
+              <a:rPr sz="3000" b="0">
+                <a:solidFill>
+                  <a:srgbClr val="272A25"/>
+                </a:solidFill>
+                <a:latin typeface="DM Sans"/>
+              </a:rPr>
+              <a:t>•  Deploy publishes the project through a host such as GitHub Pages or Vercel.</a:t>
+            </a:r>
+          </a:p>
+        </p:txBody>
+      </p:sp>
+      <p:sp>
+        <p:nvSpPr>
+          <p:cNvPr id="5" name="TextBox 4"/>
+          <p:cNvSpPr txBox="1"/>
+          <p:nvPr/>
+        </p:nvSpPr>
+        <p:spPr>
+          <a:xfrm>
+            <a:off x="822960" y="6263640"/>
+            <a:ext cx="10607040" cy="365760"/>
+          </a:xfrm>
+          <a:prstGeom prst="rect">
+            <a:avLst/>
+          </a:prstGeom>
+          <a:noFill/>
+        </p:spPr>
+        <p:txBody>
+          <a:bodyPr wrap="square">
+            <a:spAutoFit/>
+          </a:bodyPr>
+          <a:lstStyle/>
+          <a:p>
+            <a:pPr algn="r">
+              <a:spcAft>
+                <a:spcPts val="1400"/>
+              </a:spcAft>
+            </a:pPr>
+            <a:r>
+              <a:rPr sz="1600" b="0">
+                <a:solidFill>
+                  <a:srgbClr val="64665D"/>
+                </a:solidFill>
+                <a:latin typeface="DM Sans"/>
+              </a:rPr>
+              <a:t>Week 6 · Getting online        18 / 26</a:t>
+            </a:r>
+          </a:p>
+        </p:txBody>
+      </p:sp>
+    </p:spTree>
+  </p:cSld>
+  <p:clrMapOvr>
+    <a:masterClrMapping/>
+  </p:clrMapOvr>
+</p:sld>
+</file>
+
+<file path=ppt/slides/slide19.xml><?xml version="1.0" encoding="utf-8"?>
+<p:sld xmlns:a="http://schemas.openxmlformats.org/drawingml/2006/main" xmlns:p="http://schemas.openxmlformats.org/presentationml/2006/main" xmlns:r="http://schemas.openxmlformats.org/officeDocument/2006/relationships">
+  <p:cSld>
+    <p:bg>
+      <p:bgPr>
+        <a:solidFill>
+          <a:srgbClr val="F7F5EE"/>
+        </a:solidFill>
+        <a:effectLst/>
+      </p:bgPr>
+    </p:bg>
+    <p:spTree>
+      <p:nvGrpSpPr>
+        <p:cNvPr id="1" name=""/>
+        <p:cNvGrpSpPr/>
+        <p:nvPr/>
+      </p:nvGrpSpPr>
+      <p:grpSpPr/>
+      <p:sp>
+        <p:nvSpPr>
+          <p:cNvPr id="2" name="Rectangle 1"/>
+          <p:cNvSpPr/>
+          <p:nvPr/>
+        </p:nvSpPr>
+        <p:spPr>
+          <a:xfrm>
+            <a:off x="0" y="0"/>
+            <a:ext cx="228600" cy="6858000"/>
+          </a:xfrm>
+          <a:prstGeom prst="rect">
+            <a:avLst/>
+          </a:prstGeom>
+          <a:solidFill>
+            <a:srgbClr val="A83D2B"/>
+          </a:solidFill>
+          <a:ln>
+            <a:noFill/>
+          </a:ln>
+        </p:spPr>
+        <p:style>
+          <a:lnRef idx="1">
+            <a:schemeClr val="accent1"/>
+          </a:lnRef>
+          <a:fillRef idx="3">
+            <a:schemeClr val="accent1"/>
+          </a:fillRef>
+          <a:effectRef idx="2">
+            <a:schemeClr val="accent1"/>
+          </a:effectRef>
+          <a:fontRef idx="minor">
+            <a:schemeClr val="lt1"/>
+          </a:fontRef>
+        </p:style>
+        <p:txBody>
+          <a:bodyPr rtlCol="0" anchor="ctr"/>
+          <a:lstStyle/>
+          <a:p>
+            <a:pPr algn="ctr"/>
+          </a:p>
+        </p:txBody>
+      </p:sp>
+      <p:sp>
+        <p:nvSpPr>
+          <p:cNvPr id="3" name="TextBox 2"/>
+          <p:cNvSpPr txBox="1"/>
+          <p:nvPr/>
+        </p:nvSpPr>
+        <p:spPr>
+          <a:xfrm>
+            <a:off x="822960" y="548640"/>
+            <a:ext cx="10607040" cy="1188720"/>
+          </a:xfrm>
+          <a:prstGeom prst="rect">
+            <a:avLst/>
+          </a:prstGeom>
+          <a:noFill/>
+        </p:spPr>
+        <p:txBody>
+          <a:bodyPr wrap="square">
+            <a:spAutoFit/>
+          </a:bodyPr>
+          <a:lstStyle/>
+          <a:p>
+            <a:pPr>
+              <a:spcAft>
+                <a:spcPts val="1400"/>
+              </a:spcAft>
+            </a:pPr>
+            <a:r>
+              <a:rPr sz="3200" b="1">
+                <a:solidFill>
+                  <a:srgbClr val="272A25"/>
+                </a:solidFill>
+                <a:latin typeface="Fraunces"/>
+              </a:rPr>
+              <a:t>Your link must work on someone else’s phone</a:t>
+            </a:r>
+          </a:p>
+        </p:txBody>
+      </p:sp>
+      <p:sp>
+        <p:nvSpPr>
+          <p:cNvPr id="4" name="TextBox 3"/>
+          <p:cNvSpPr txBox="1"/>
+          <p:nvPr/>
+        </p:nvSpPr>
+        <p:spPr>
+          <a:xfrm>
+            <a:off x="822960" y="2011680"/>
+            <a:ext cx="10607040" cy="4206240"/>
+          </a:xfrm>
+          <a:prstGeom prst="rect">
+            <a:avLst/>
+          </a:prstGeom>
+          <a:noFill/>
+        </p:spPr>
+        <p:txBody>
+          <a:bodyPr wrap="square">
+            <a:spAutoFit/>
+          </a:bodyPr>
+          <a:lstStyle/>
+          <a:p>
+            <a:pPr>
+              <a:spcAft>
+                <a:spcPts val="2200"/>
+              </a:spcAft>
+            </a:pPr>
+            <a:r>
+              <a:rPr sz="3000" b="0">
+                <a:solidFill>
+                  <a:srgbClr val="272A25"/>
+                </a:solidFill>
+                <a:latin typeface="DM Sans"/>
+              </a:rPr>
+              <a:t>•  file:///… and localhost:8000 point to your own computer—not a public site.</a:t>
+            </a:r>
+          </a:p>
+          <a:p>
+            <a:pPr>
+              <a:spcAft>
+                <a:spcPts val="2200"/>
+              </a:spcAft>
+            </a:pPr>
+            <a:r>
+              <a:rPr sz="3000" b="0">
+                <a:solidFill>
+                  <a:srgbClr val="272A25"/>
+                </a:solidFill>
+                <a:latin typeface="DM Sans"/>
+              </a:rPr>
+              <a:t>•  A GitHub repository URL shows source; it may not be the live app URL.</a:t>
+            </a:r>
+          </a:p>
+          <a:p>
+            <a:pPr>
+              <a:spcAft>
+                <a:spcPts val="2200"/>
+              </a:spcAft>
+            </a:pPr>
+            <a:r>
+              <a:rPr sz="3000" b="0">
+                <a:solidFill>
+                  <a:srgbClr val="272A25"/>
+                </a:solidFill>
+                <a:latin typeface="DM Sans"/>
+              </a:rPr>
+              <a:t>•  Use the deployed HTTPS URL; test it on another device or in a private window.</a:t>
+            </a:r>
+          </a:p>
+        </p:txBody>
+      </p:sp>
+      <p:sp>
+        <p:nvSpPr>
+          <p:cNvPr id="5" name="TextBox 4"/>
+          <p:cNvSpPr txBox="1"/>
+          <p:nvPr/>
+        </p:nvSpPr>
+        <p:spPr>
+          <a:xfrm>
+            <a:off x="822960" y="6263640"/>
+            <a:ext cx="10607040" cy="365760"/>
+          </a:xfrm>
+          <a:prstGeom prst="rect">
+            <a:avLst/>
+          </a:prstGeom>
+          <a:noFill/>
+        </p:spPr>
+        <p:txBody>
+          <a:bodyPr wrap="square">
+            <a:spAutoFit/>
+          </a:bodyPr>
+          <a:lstStyle/>
+          <a:p>
+            <a:pPr algn="r">
+              <a:spcAft>
+                <a:spcPts val="1400"/>
+              </a:spcAft>
+            </a:pPr>
+            <a:r>
+              <a:rPr sz="1600" b="0">
+                <a:solidFill>
+                  <a:srgbClr val="64665D"/>
+                </a:solidFill>
+                <a:latin typeface="DM Sans"/>
+              </a:rPr>
+              <a:t>Week 6 · Getting online        19 / 26</a:t>
             </a:r>
           </a:p>
         </p:txBody>
@@ -5496,7 +7727,7 @@
                 </a:solidFill>
                 <a:latin typeface="Fraunces"/>
               </a:rPr>
-              <a:t>Your AI can help you learn about AI</a:t>
+              <a:t>What your recent builds taught us</a:t>
             </a:r>
           </a:p>
         </p:txBody>
@@ -5535,7 +7766,7 @@
                 </a:solidFill>
                 <a:latin typeface="DM Sans"/>
               </a:rPr>
-              <a:t>•  Ask for an explanation at your level.</a:t>
+              <a:t>•  The AI can finish a prompt and still miss the design you intended.</a:t>
             </a:r>
           </a:p>
           <a:p>
@@ -5551,7 +7782,7 @@
                 </a:solidFill>
                 <a:latin typeface="DM Sans"/>
               </a:rPr>
-              <a:t>•  Ask it to quiz you, then explain what you missed.</a:t>
+              <a:t>•  A page can look finished while its buttons do not work.</a:t>
             </a:r>
           </a:p>
           <a:p>
@@ -5567,7 +7798,7 @@
                 </a:solidFill>
                 <a:latin typeface="DM Sans"/>
               </a:rPr>
-              <a:t>•  Check its claims against the material you gave it.</a:t>
+              <a:t>•  A local link or a repo alone is not a published website.</a:t>
             </a:r>
           </a:p>
         </p:txBody>
@@ -5606,7 +7837,1533 @@
                 </a:solidFill>
                 <a:latin typeface="DM Sans"/>
               </a:rPr>
-              <a:t>Week 6 · Learn with AI        2 / 13</a:t>
+              <a:t>Week 6 · Why this matters        2 / 26</a:t>
+            </a:r>
+          </a:p>
+        </p:txBody>
+      </p:sp>
+    </p:spTree>
+  </p:cSld>
+  <p:clrMapOvr>
+    <a:masterClrMapping/>
+  </p:clrMapOvr>
+</p:sld>
+</file>
+
+<file path=ppt/slides/slide20.xml><?xml version="1.0" encoding="utf-8"?>
+<p:sld xmlns:a="http://schemas.openxmlformats.org/drawingml/2006/main" xmlns:p="http://schemas.openxmlformats.org/presentationml/2006/main" xmlns:r="http://schemas.openxmlformats.org/officeDocument/2006/relationships">
+  <p:cSld>
+    <p:bg>
+      <p:bgPr>
+        <a:solidFill>
+          <a:srgbClr val="F7F5EE"/>
+        </a:solidFill>
+        <a:effectLst/>
+      </p:bgPr>
+    </p:bg>
+    <p:spTree>
+      <p:nvGrpSpPr>
+        <p:cNvPr id="1" name=""/>
+        <p:cNvGrpSpPr/>
+        <p:nvPr/>
+      </p:nvGrpSpPr>
+      <p:grpSpPr/>
+      <p:sp>
+        <p:nvSpPr>
+          <p:cNvPr id="2" name="Rectangle 1"/>
+          <p:cNvSpPr/>
+          <p:nvPr/>
+        </p:nvSpPr>
+        <p:spPr>
+          <a:xfrm>
+            <a:off x="0" y="0"/>
+            <a:ext cx="228600" cy="6858000"/>
+          </a:xfrm>
+          <a:prstGeom prst="rect">
+            <a:avLst/>
+          </a:prstGeom>
+          <a:solidFill>
+            <a:srgbClr val="A83D2B"/>
+          </a:solidFill>
+          <a:ln>
+            <a:noFill/>
+          </a:ln>
+        </p:spPr>
+        <p:style>
+          <a:lnRef idx="1">
+            <a:schemeClr val="accent1"/>
+          </a:lnRef>
+          <a:fillRef idx="3">
+            <a:schemeClr val="accent1"/>
+          </a:fillRef>
+          <a:effectRef idx="2">
+            <a:schemeClr val="accent1"/>
+          </a:effectRef>
+          <a:fontRef idx="minor">
+            <a:schemeClr val="lt1"/>
+          </a:fontRef>
+        </p:style>
+        <p:txBody>
+          <a:bodyPr rtlCol="0" anchor="ctr"/>
+          <a:lstStyle/>
+          <a:p>
+            <a:pPr algn="ctr"/>
+          </a:p>
+        </p:txBody>
+      </p:sp>
+      <p:sp>
+        <p:nvSpPr>
+          <p:cNvPr id="3" name="TextBox 2"/>
+          <p:cNvSpPr txBox="1"/>
+          <p:nvPr/>
+        </p:nvSpPr>
+        <p:spPr>
+          <a:xfrm>
+            <a:off x="822960" y="548640"/>
+            <a:ext cx="10607040" cy="1188720"/>
+          </a:xfrm>
+          <a:prstGeom prst="rect">
+            <a:avLst/>
+          </a:prstGeom>
+          <a:noFill/>
+        </p:spPr>
+        <p:txBody>
+          <a:bodyPr wrap="square">
+            <a:spAutoFit/>
+          </a:bodyPr>
+          <a:lstStyle/>
+          <a:p>
+            <a:pPr>
+              <a:spcAft>
+                <a:spcPts val="1400"/>
+              </a:spcAft>
+            </a:pPr>
+            <a:r>
+              <a:rPr sz="4000" b="1">
+                <a:solidFill>
+                  <a:srgbClr val="272A25"/>
+                </a:solidFill>
+                <a:latin typeface="Fraunces"/>
+              </a:rPr>
+              <a:t>A practical path to publishing</a:t>
+            </a:r>
+          </a:p>
+        </p:txBody>
+      </p:sp>
+      <p:sp>
+        <p:nvSpPr>
+          <p:cNvPr id="4" name="TextBox 3"/>
+          <p:cNvSpPr txBox="1"/>
+          <p:nvPr/>
+        </p:nvSpPr>
+        <p:spPr>
+          <a:xfrm>
+            <a:off x="822960" y="2011680"/>
+            <a:ext cx="10607040" cy="4206240"/>
+          </a:xfrm>
+          <a:prstGeom prst="rect">
+            <a:avLst/>
+          </a:prstGeom>
+          <a:noFill/>
+        </p:spPr>
+        <p:txBody>
+          <a:bodyPr wrap="square">
+            <a:spAutoFit/>
+          </a:bodyPr>
+          <a:lstStyle/>
+          <a:p>
+            <a:pPr>
+              <a:spcAft>
+                <a:spcPts val="2200"/>
+              </a:spcAft>
+            </a:pPr>
+            <a:r>
+              <a:rPr sz="3000" b="0">
+                <a:solidFill>
+                  <a:srgbClr val="272A25"/>
+                </a:solidFill>
+                <a:latin typeface="DM Sans"/>
+              </a:rPr>
+              <a:t>•  GitHub Desktop: create a repository → commit → publish to GitHub.</a:t>
+            </a:r>
+          </a:p>
+          <a:p>
+            <a:pPr>
+              <a:spcAft>
+                <a:spcPts val="2200"/>
+              </a:spcAft>
+            </a:pPr>
+            <a:r>
+              <a:rPr sz="3000" b="0">
+                <a:solidFill>
+                  <a:srgbClr val="272A25"/>
+                </a:solidFill>
+                <a:latin typeface="DM Sans"/>
+              </a:rPr>
+              <a:t>•  Plain HTML/CSS: GitHub Settings → Pages → main branch / root → Save.</a:t>
+            </a:r>
+          </a:p>
+          <a:p>
+            <a:pPr>
+              <a:spcAft>
+                <a:spcPts val="2200"/>
+              </a:spcAft>
+            </a:pPr>
+            <a:r>
+              <a:rPr sz="3000" b="0">
+                <a:solidFill>
+                  <a:srgbClr val="272A25"/>
+                </a:solidFill>
+                <a:latin typeface="DM Sans"/>
+              </a:rPr>
+              <a:t>•  A framework app may need Vercel: allow repository access, deploy, then test the URL.</a:t>
+            </a:r>
+          </a:p>
+        </p:txBody>
+      </p:sp>
+      <p:sp>
+        <p:nvSpPr>
+          <p:cNvPr id="5" name="TextBox 4"/>
+          <p:cNvSpPr txBox="1"/>
+          <p:nvPr/>
+        </p:nvSpPr>
+        <p:spPr>
+          <a:xfrm>
+            <a:off x="822960" y="6263640"/>
+            <a:ext cx="10607040" cy="365760"/>
+          </a:xfrm>
+          <a:prstGeom prst="rect">
+            <a:avLst/>
+          </a:prstGeom>
+          <a:noFill/>
+        </p:spPr>
+        <p:txBody>
+          <a:bodyPr wrap="square">
+            <a:spAutoFit/>
+          </a:bodyPr>
+          <a:lstStyle/>
+          <a:p>
+            <a:pPr algn="r">
+              <a:spcAft>
+                <a:spcPts val="1400"/>
+              </a:spcAft>
+            </a:pPr>
+            <a:r>
+              <a:rPr sz="1600" b="0">
+                <a:solidFill>
+                  <a:srgbClr val="64665D"/>
+                </a:solidFill>
+                <a:latin typeface="DM Sans"/>
+              </a:rPr>
+              <a:t>Week 6 · Getting online        20 / 26</a:t>
+            </a:r>
+          </a:p>
+        </p:txBody>
+      </p:sp>
+    </p:spTree>
+  </p:cSld>
+  <p:clrMapOvr>
+    <a:masterClrMapping/>
+  </p:clrMapOvr>
+</p:sld>
+</file>
+
+<file path=ppt/slides/slide21.xml><?xml version="1.0" encoding="utf-8"?>
+<p:sld xmlns:a="http://schemas.openxmlformats.org/drawingml/2006/main" xmlns:p="http://schemas.openxmlformats.org/presentationml/2006/main" xmlns:r="http://schemas.openxmlformats.org/officeDocument/2006/relationships">
+  <p:cSld>
+    <p:bg>
+      <p:bgPr>
+        <a:solidFill>
+          <a:srgbClr val="F7F5EE"/>
+        </a:solidFill>
+        <a:effectLst/>
+      </p:bgPr>
+    </p:bg>
+    <p:spTree>
+      <p:nvGrpSpPr>
+        <p:cNvPr id="1" name=""/>
+        <p:cNvGrpSpPr/>
+        <p:nvPr/>
+      </p:nvGrpSpPr>
+      <p:grpSpPr/>
+      <p:sp>
+        <p:nvSpPr>
+          <p:cNvPr id="2" name="Rectangle 1"/>
+          <p:cNvSpPr/>
+          <p:nvPr/>
+        </p:nvSpPr>
+        <p:spPr>
+          <a:xfrm>
+            <a:off x="0" y="0"/>
+            <a:ext cx="228600" cy="6858000"/>
+          </a:xfrm>
+          <a:prstGeom prst="rect">
+            <a:avLst/>
+          </a:prstGeom>
+          <a:solidFill>
+            <a:srgbClr val="A83D2B"/>
+          </a:solidFill>
+          <a:ln>
+            <a:noFill/>
+          </a:ln>
+        </p:spPr>
+        <p:style>
+          <a:lnRef idx="1">
+            <a:schemeClr val="accent1"/>
+          </a:lnRef>
+          <a:fillRef idx="3">
+            <a:schemeClr val="accent1"/>
+          </a:fillRef>
+          <a:effectRef idx="2">
+            <a:schemeClr val="accent1"/>
+          </a:effectRef>
+          <a:fontRef idx="minor">
+            <a:schemeClr val="lt1"/>
+          </a:fontRef>
+        </p:style>
+        <p:txBody>
+          <a:bodyPr rtlCol="0" anchor="ctr"/>
+          <a:lstStyle/>
+          <a:p>
+            <a:pPr algn="ctr"/>
+          </a:p>
+        </p:txBody>
+      </p:sp>
+      <p:sp>
+        <p:nvSpPr>
+          <p:cNvPr id="3" name="TextBox 2"/>
+          <p:cNvSpPr txBox="1"/>
+          <p:nvPr/>
+        </p:nvSpPr>
+        <p:spPr>
+          <a:xfrm>
+            <a:off x="822960" y="548640"/>
+            <a:ext cx="10607040" cy="1188720"/>
+          </a:xfrm>
+          <a:prstGeom prst="rect">
+            <a:avLst/>
+          </a:prstGeom>
+          <a:noFill/>
+        </p:spPr>
+        <p:txBody>
+          <a:bodyPr wrap="square">
+            <a:spAutoFit/>
+          </a:bodyPr>
+          <a:lstStyle/>
+          <a:p>
+            <a:pPr>
+              <a:spcAft>
+                <a:spcPts val="1400"/>
+              </a:spcAft>
+            </a:pPr>
+            <a:r>
+              <a:rPr sz="3200" b="1">
+                <a:solidFill>
+                  <a:srgbClr val="272A25"/>
+                </a:solidFill>
+                <a:latin typeface="Fraunces"/>
+              </a:rPr>
+              <a:t>API, connector, MCP: what is the difference?</a:t>
+            </a:r>
+          </a:p>
+        </p:txBody>
+      </p:sp>
+      <p:sp>
+        <p:nvSpPr>
+          <p:cNvPr id="4" name="TextBox 3"/>
+          <p:cNvSpPr txBox="1"/>
+          <p:nvPr/>
+        </p:nvSpPr>
+        <p:spPr>
+          <a:xfrm>
+            <a:off x="822960" y="2011680"/>
+            <a:ext cx="10607040" cy="4206240"/>
+          </a:xfrm>
+          <a:prstGeom prst="rect">
+            <a:avLst/>
+          </a:prstGeom>
+          <a:noFill/>
+        </p:spPr>
+        <p:txBody>
+          <a:bodyPr wrap="square">
+            <a:spAutoFit/>
+          </a:bodyPr>
+          <a:lstStyle/>
+          <a:p>
+            <a:pPr>
+              <a:spcAft>
+                <a:spcPts val="2200"/>
+              </a:spcAft>
+            </a:pPr>
+            <a:r>
+              <a:rPr sz="3000" b="0">
+                <a:solidFill>
+                  <a:srgbClr val="272A25"/>
+                </a:solidFill>
+                <a:latin typeface="DM Sans"/>
+              </a:rPr>
+              <a:t>•  API: a service’s menu of requests that another program can make.</a:t>
+            </a:r>
+          </a:p>
+          <a:p>
+            <a:pPr>
+              <a:spcAft>
+                <a:spcPts val="2200"/>
+              </a:spcAft>
+            </a:pPr>
+            <a:r>
+              <a:rPr sz="3000" b="0">
+                <a:solidFill>
+                  <a:srgbClr val="272A25"/>
+                </a:solidFill>
+                <a:latin typeface="DM Sans"/>
+              </a:rPr>
+              <a:t>•  Connector: a bridge that lets your AI reach a service or files.</a:t>
+            </a:r>
+          </a:p>
+          <a:p>
+            <a:pPr>
+              <a:spcAft>
+                <a:spcPts val="2200"/>
+              </a:spcAft>
+            </a:pPr>
+            <a:r>
+              <a:rPr sz="3000" b="0">
+                <a:solidFill>
+                  <a:srgbClr val="272A25"/>
+                </a:solidFill>
+                <a:latin typeface="DM Sans"/>
+              </a:rPr>
+              <a:t>•  MCP: a shared protocol for AI apps to use tools; an MCP server may call an API.</a:t>
+            </a:r>
+          </a:p>
+        </p:txBody>
+      </p:sp>
+      <p:sp>
+        <p:nvSpPr>
+          <p:cNvPr id="5" name="TextBox 4"/>
+          <p:cNvSpPr txBox="1"/>
+          <p:nvPr/>
+        </p:nvSpPr>
+        <p:spPr>
+          <a:xfrm>
+            <a:off x="822960" y="6263640"/>
+            <a:ext cx="10607040" cy="365760"/>
+          </a:xfrm>
+          <a:prstGeom prst="rect">
+            <a:avLst/>
+          </a:prstGeom>
+          <a:noFill/>
+        </p:spPr>
+        <p:txBody>
+          <a:bodyPr wrap="square">
+            <a:spAutoFit/>
+          </a:bodyPr>
+          <a:lstStyle/>
+          <a:p>
+            <a:pPr algn="r">
+              <a:spcAft>
+                <a:spcPts val="1400"/>
+              </a:spcAft>
+            </a:pPr>
+            <a:r>
+              <a:rPr sz="1600" b="0">
+                <a:solidFill>
+                  <a:srgbClr val="64665D"/>
+                </a:solidFill>
+                <a:latin typeface="DM Sans"/>
+              </a:rPr>
+              <a:t>Week 6 · Connections—concept only        21 / 26</a:t>
+            </a:r>
+          </a:p>
+        </p:txBody>
+      </p:sp>
+    </p:spTree>
+  </p:cSld>
+  <p:clrMapOvr>
+    <a:masterClrMapping/>
+  </p:clrMapOvr>
+</p:sld>
+</file>
+
+<file path=ppt/slides/slide22.xml><?xml version="1.0" encoding="utf-8"?>
+<p:sld xmlns:a="http://schemas.openxmlformats.org/drawingml/2006/main" xmlns:p="http://schemas.openxmlformats.org/presentationml/2006/main" xmlns:r="http://schemas.openxmlformats.org/officeDocument/2006/relationships">
+  <p:cSld>
+    <p:bg>
+      <p:bgPr>
+        <a:solidFill>
+          <a:srgbClr val="F7F5EE"/>
+        </a:solidFill>
+        <a:effectLst/>
+      </p:bgPr>
+    </p:bg>
+    <p:spTree>
+      <p:nvGrpSpPr>
+        <p:cNvPr id="1" name=""/>
+        <p:cNvGrpSpPr/>
+        <p:nvPr/>
+      </p:nvGrpSpPr>
+      <p:grpSpPr/>
+      <p:sp>
+        <p:nvSpPr>
+          <p:cNvPr id="2" name="Rectangle 1"/>
+          <p:cNvSpPr/>
+          <p:nvPr/>
+        </p:nvSpPr>
+        <p:spPr>
+          <a:xfrm>
+            <a:off x="0" y="0"/>
+            <a:ext cx="228600" cy="6858000"/>
+          </a:xfrm>
+          <a:prstGeom prst="rect">
+            <a:avLst/>
+          </a:prstGeom>
+          <a:solidFill>
+            <a:srgbClr val="A83D2B"/>
+          </a:solidFill>
+          <a:ln>
+            <a:noFill/>
+          </a:ln>
+        </p:spPr>
+        <p:style>
+          <a:lnRef idx="1">
+            <a:schemeClr val="accent1"/>
+          </a:lnRef>
+          <a:fillRef idx="3">
+            <a:schemeClr val="accent1"/>
+          </a:fillRef>
+          <a:effectRef idx="2">
+            <a:schemeClr val="accent1"/>
+          </a:effectRef>
+          <a:fontRef idx="minor">
+            <a:schemeClr val="lt1"/>
+          </a:fontRef>
+        </p:style>
+        <p:txBody>
+          <a:bodyPr rtlCol="0" anchor="ctr"/>
+          <a:lstStyle/>
+          <a:p>
+            <a:pPr algn="ctr"/>
+          </a:p>
+        </p:txBody>
+      </p:sp>
+      <p:sp>
+        <p:nvSpPr>
+          <p:cNvPr id="3" name="TextBox 2"/>
+          <p:cNvSpPr txBox="1"/>
+          <p:nvPr/>
+        </p:nvSpPr>
+        <p:spPr>
+          <a:xfrm>
+            <a:off x="822960" y="548640"/>
+            <a:ext cx="10607040" cy="1188720"/>
+          </a:xfrm>
+          <a:prstGeom prst="rect">
+            <a:avLst/>
+          </a:prstGeom>
+          <a:noFill/>
+        </p:spPr>
+        <p:txBody>
+          <a:bodyPr wrap="square">
+            <a:spAutoFit/>
+          </a:bodyPr>
+          <a:lstStyle/>
+          <a:p>
+            <a:pPr>
+              <a:spcAft>
+                <a:spcPts val="1400"/>
+              </a:spcAft>
+            </a:pPr>
+            <a:r>
+              <a:rPr sz="4000" b="1">
+                <a:solidFill>
+                  <a:srgbClr val="272A25"/>
+                </a:solidFill>
+                <a:latin typeface="Fraunces"/>
+              </a:rPr>
+              <a:t>Access is a choice: read versus write</a:t>
+            </a:r>
+          </a:p>
+        </p:txBody>
+      </p:sp>
+      <p:sp>
+        <p:nvSpPr>
+          <p:cNvPr id="4" name="TextBox 3"/>
+          <p:cNvSpPr txBox="1"/>
+          <p:nvPr/>
+        </p:nvSpPr>
+        <p:spPr>
+          <a:xfrm>
+            <a:off x="822960" y="2011680"/>
+            <a:ext cx="10607040" cy="4206240"/>
+          </a:xfrm>
+          <a:prstGeom prst="rect">
+            <a:avLst/>
+          </a:prstGeom>
+          <a:noFill/>
+        </p:spPr>
+        <p:txBody>
+          <a:bodyPr wrap="square">
+            <a:spAutoFit/>
+          </a:bodyPr>
+          <a:lstStyle/>
+          <a:p>
+            <a:pPr>
+              <a:spcAft>
+                <a:spcPts val="2200"/>
+              </a:spcAft>
+            </a:pPr>
+            <a:r>
+              <a:rPr sz="3000" b="0">
+                <a:solidFill>
+                  <a:srgbClr val="272A25"/>
+                </a:solidFill>
+                <a:latin typeface="DM Sans"/>
+              </a:rPr>
+              <a:t>•  Read access can expose data; write access can change or delete it.</a:t>
+            </a:r>
+          </a:p>
+          <a:p>
+            <a:pPr>
+              <a:spcAft>
+                <a:spcPts val="2200"/>
+              </a:spcAft>
+            </a:pPr>
+            <a:r>
+              <a:rPr sz="3000" b="0">
+                <a:solidFill>
+                  <a:srgbClr val="272A25"/>
+                </a:solidFill>
+                <a:latin typeface="DM Sans"/>
+              </a:rPr>
+              <a:t>•  Give only the access needed; review changes before publishing or sending.</a:t>
+            </a:r>
+          </a:p>
+          <a:p>
+            <a:pPr>
+              <a:spcAft>
+                <a:spcPts val="2200"/>
+              </a:spcAft>
+            </a:pPr>
+            <a:r>
+              <a:rPr sz="3000" b="0">
+                <a:solidFill>
+                  <a:srgbClr val="272A25"/>
+                </a:solidFill>
+                <a:latin typeface="DM Sans"/>
+              </a:rPr>
+              <a:t>•  Keep keys, passwords and private data out of public files and repositories.</a:t>
+            </a:r>
+          </a:p>
+        </p:txBody>
+      </p:sp>
+      <p:sp>
+        <p:nvSpPr>
+          <p:cNvPr id="5" name="TextBox 4"/>
+          <p:cNvSpPr txBox="1"/>
+          <p:nvPr/>
+        </p:nvSpPr>
+        <p:spPr>
+          <a:xfrm>
+            <a:off x="822960" y="6263640"/>
+            <a:ext cx="10607040" cy="365760"/>
+          </a:xfrm>
+          <a:prstGeom prst="rect">
+            <a:avLst/>
+          </a:prstGeom>
+          <a:noFill/>
+        </p:spPr>
+        <p:txBody>
+          <a:bodyPr wrap="square">
+            <a:spAutoFit/>
+          </a:bodyPr>
+          <a:lstStyle/>
+          <a:p>
+            <a:pPr algn="r">
+              <a:spcAft>
+                <a:spcPts val="1400"/>
+              </a:spcAft>
+            </a:pPr>
+            <a:r>
+              <a:rPr sz="1600" b="0">
+                <a:solidFill>
+                  <a:srgbClr val="64665D"/>
+                </a:solidFill>
+                <a:latin typeface="DM Sans"/>
+              </a:rPr>
+              <a:t>Week 6 · Connections—concept only        22 / 26</a:t>
+            </a:r>
+          </a:p>
+        </p:txBody>
+      </p:sp>
+    </p:spTree>
+  </p:cSld>
+  <p:clrMapOvr>
+    <a:masterClrMapping/>
+  </p:clrMapOvr>
+</p:sld>
+</file>
+
+<file path=ppt/slides/slide23.xml><?xml version="1.0" encoding="utf-8"?>
+<p:sld xmlns:a="http://schemas.openxmlformats.org/drawingml/2006/main" xmlns:p="http://schemas.openxmlformats.org/presentationml/2006/main" xmlns:r="http://schemas.openxmlformats.org/officeDocument/2006/relationships">
+  <p:cSld>
+    <p:bg>
+      <p:bgPr>
+        <a:solidFill>
+          <a:srgbClr val="F7F5EE"/>
+        </a:solidFill>
+        <a:effectLst/>
+      </p:bgPr>
+    </p:bg>
+    <p:spTree>
+      <p:nvGrpSpPr>
+        <p:cNvPr id="1" name=""/>
+        <p:cNvGrpSpPr/>
+        <p:nvPr/>
+      </p:nvGrpSpPr>
+      <p:grpSpPr/>
+      <p:sp>
+        <p:nvSpPr>
+          <p:cNvPr id="2" name="Rectangle 1"/>
+          <p:cNvSpPr/>
+          <p:nvPr/>
+        </p:nvSpPr>
+        <p:spPr>
+          <a:xfrm>
+            <a:off x="0" y="0"/>
+            <a:ext cx="228600" cy="6858000"/>
+          </a:xfrm>
+          <a:prstGeom prst="rect">
+            <a:avLst/>
+          </a:prstGeom>
+          <a:solidFill>
+            <a:srgbClr val="A83D2B"/>
+          </a:solidFill>
+          <a:ln>
+            <a:noFill/>
+          </a:ln>
+        </p:spPr>
+        <p:style>
+          <a:lnRef idx="1">
+            <a:schemeClr val="accent1"/>
+          </a:lnRef>
+          <a:fillRef idx="3">
+            <a:schemeClr val="accent1"/>
+          </a:fillRef>
+          <a:effectRef idx="2">
+            <a:schemeClr val="accent1"/>
+          </a:effectRef>
+          <a:fontRef idx="minor">
+            <a:schemeClr val="lt1"/>
+          </a:fontRef>
+        </p:style>
+        <p:txBody>
+          <a:bodyPr rtlCol="0" anchor="ctr"/>
+          <a:lstStyle/>
+          <a:p>
+            <a:pPr algn="ctr"/>
+          </a:p>
+        </p:txBody>
+      </p:sp>
+      <p:sp>
+        <p:nvSpPr>
+          <p:cNvPr id="3" name="TextBox 2"/>
+          <p:cNvSpPr txBox="1"/>
+          <p:nvPr/>
+        </p:nvSpPr>
+        <p:spPr>
+          <a:xfrm>
+            <a:off x="822960" y="548640"/>
+            <a:ext cx="10607040" cy="1188720"/>
+          </a:xfrm>
+          <a:prstGeom prst="rect">
+            <a:avLst/>
+          </a:prstGeom>
+          <a:noFill/>
+        </p:spPr>
+        <p:txBody>
+          <a:bodyPr wrap="square">
+            <a:spAutoFit/>
+          </a:bodyPr>
+          <a:lstStyle/>
+          <a:p>
+            <a:pPr>
+              <a:spcAft>
+                <a:spcPts val="1400"/>
+              </a:spcAft>
+            </a:pPr>
+            <a:r>
+              <a:rPr sz="4000" b="1">
+                <a:solidFill>
+                  <a:srgbClr val="272A25"/>
+                </a:solidFill>
+                <a:latin typeface="Fraunces"/>
+              </a:rPr>
+              <a:t>Bring this lesson into your own AI</a:t>
+            </a:r>
+          </a:p>
+        </p:txBody>
+      </p:sp>
+      <p:sp>
+        <p:nvSpPr>
+          <p:cNvPr id="4" name="TextBox 3"/>
+          <p:cNvSpPr txBox="1"/>
+          <p:nvPr/>
+        </p:nvSpPr>
+        <p:spPr>
+          <a:xfrm>
+            <a:off x="822960" y="2011680"/>
+            <a:ext cx="10607040" cy="4206240"/>
+          </a:xfrm>
+          <a:prstGeom prst="rect">
+            <a:avLst/>
+          </a:prstGeom>
+          <a:noFill/>
+        </p:spPr>
+        <p:txBody>
+          <a:bodyPr wrap="square">
+            <a:spAutoFit/>
+          </a:bodyPr>
+          <a:lstStyle/>
+          <a:p>
+            <a:pPr>
+              <a:spcAft>
+                <a:spcPts val="2200"/>
+              </a:spcAft>
+            </a:pPr>
+            <a:r>
+              <a:rPr sz="3000" b="0">
+                <a:solidFill>
+                  <a:srgbClr val="272A25"/>
+                </a:solidFill>
+                <a:latin typeface="DM Sans"/>
+              </a:rPr>
+              <a:t>•  Open cu.learnvibe.build → Everything for Week 6.</a:t>
+            </a:r>
+          </a:p>
+          <a:p>
+            <a:pPr>
+              <a:spcAft>
+                <a:spcPts val="2200"/>
+              </a:spcAft>
+            </a:pPr>
+            <a:r>
+              <a:rPr sz="3000" b="0">
+                <a:solidFill>
+                  <a:srgbClr val="272A25"/>
+                </a:solidFill>
+                <a:latin typeface="DM Sans"/>
+              </a:rPr>
+              <a:t>•  Click “Copy lesson as markdown”; paste it into Claude or another AI.</a:t>
+            </a:r>
+          </a:p>
+          <a:p>
+            <a:pPr>
+              <a:spcAft>
+                <a:spcPts val="2200"/>
+              </a:spcAft>
+            </a:pPr>
+            <a:r>
+              <a:rPr sz="3000" b="0">
+                <a:solidFill>
+                  <a:srgbClr val="272A25"/>
+                </a:solidFill>
+                <a:latin typeface="DM Sans"/>
+              </a:rPr>
+              <a:t>•  Ask: “Teach me this and quiz me”—then ask follow-ups in your own words.</a:t>
+            </a:r>
+          </a:p>
+        </p:txBody>
+      </p:sp>
+      <p:sp>
+        <p:nvSpPr>
+          <p:cNvPr id="5" name="TextBox 4"/>
+          <p:cNvSpPr txBox="1"/>
+          <p:nvPr/>
+        </p:nvSpPr>
+        <p:spPr>
+          <a:xfrm>
+            <a:off x="822960" y="6263640"/>
+            <a:ext cx="10607040" cy="365760"/>
+          </a:xfrm>
+          <a:prstGeom prst="rect">
+            <a:avLst/>
+          </a:prstGeom>
+          <a:noFill/>
+        </p:spPr>
+        <p:txBody>
+          <a:bodyPr wrap="square">
+            <a:spAutoFit/>
+          </a:bodyPr>
+          <a:lstStyle/>
+          <a:p>
+            <a:pPr algn="r">
+              <a:spcAft>
+                <a:spcPts val="1400"/>
+              </a:spcAft>
+            </a:pPr>
+            <a:r>
+              <a:rPr sz="1600" b="0">
+                <a:solidFill>
+                  <a:srgbClr val="64665D"/>
+                </a:solidFill>
+                <a:latin typeface="DM Sans"/>
+              </a:rPr>
+              <a:t>Week 6 · Use the lesson        23 / 26</a:t>
+            </a:r>
+          </a:p>
+        </p:txBody>
+      </p:sp>
+    </p:spTree>
+  </p:cSld>
+  <p:clrMapOvr>
+    <a:masterClrMapping/>
+  </p:clrMapOvr>
+</p:sld>
+</file>
+
+<file path=ppt/slides/slide24.xml><?xml version="1.0" encoding="utf-8"?>
+<p:sld xmlns:a="http://schemas.openxmlformats.org/drawingml/2006/main" xmlns:p="http://schemas.openxmlformats.org/presentationml/2006/main" xmlns:r="http://schemas.openxmlformats.org/officeDocument/2006/relationships">
+  <p:cSld>
+    <p:bg>
+      <p:bgPr>
+        <a:solidFill>
+          <a:srgbClr val="F7F5EE"/>
+        </a:solidFill>
+        <a:effectLst/>
+      </p:bgPr>
+    </p:bg>
+    <p:spTree>
+      <p:nvGrpSpPr>
+        <p:cNvPr id="1" name=""/>
+        <p:cNvGrpSpPr/>
+        <p:nvPr/>
+      </p:nvGrpSpPr>
+      <p:grpSpPr/>
+      <p:sp>
+        <p:nvSpPr>
+          <p:cNvPr id="2" name="Rectangle 1"/>
+          <p:cNvSpPr/>
+          <p:nvPr/>
+        </p:nvSpPr>
+        <p:spPr>
+          <a:xfrm>
+            <a:off x="0" y="0"/>
+            <a:ext cx="228600" cy="6858000"/>
+          </a:xfrm>
+          <a:prstGeom prst="rect">
+            <a:avLst/>
+          </a:prstGeom>
+          <a:solidFill>
+            <a:srgbClr val="A83D2B"/>
+          </a:solidFill>
+          <a:ln>
+            <a:noFill/>
+          </a:ln>
+        </p:spPr>
+        <p:style>
+          <a:lnRef idx="1">
+            <a:schemeClr val="accent1"/>
+          </a:lnRef>
+          <a:fillRef idx="3">
+            <a:schemeClr val="accent1"/>
+          </a:fillRef>
+          <a:effectRef idx="2">
+            <a:schemeClr val="accent1"/>
+          </a:effectRef>
+          <a:fontRef idx="minor">
+            <a:schemeClr val="lt1"/>
+          </a:fontRef>
+        </p:style>
+        <p:txBody>
+          <a:bodyPr rtlCol="0" anchor="ctr"/>
+          <a:lstStyle/>
+          <a:p>
+            <a:pPr algn="ctr"/>
+          </a:p>
+        </p:txBody>
+      </p:sp>
+      <p:sp>
+        <p:nvSpPr>
+          <p:cNvPr id="3" name="TextBox 2"/>
+          <p:cNvSpPr txBox="1"/>
+          <p:nvPr/>
+        </p:nvSpPr>
+        <p:spPr>
+          <a:xfrm>
+            <a:off x="822960" y="548640"/>
+            <a:ext cx="10607040" cy="1188720"/>
+          </a:xfrm>
+          <a:prstGeom prst="rect">
+            <a:avLst/>
+          </a:prstGeom>
+          <a:noFill/>
+        </p:spPr>
+        <p:txBody>
+          <a:bodyPr wrap="square">
+            <a:spAutoFit/>
+          </a:bodyPr>
+          <a:lstStyle/>
+          <a:p>
+            <a:pPr>
+              <a:spcAft>
+                <a:spcPts val="1400"/>
+              </a:spcAft>
+            </a:pPr>
+            <a:r>
+              <a:rPr sz="3200" b="1">
+                <a:solidFill>
+                  <a:srgbClr val="272A25"/>
+                </a:solidFill>
+                <a:latin typeface="Fraunces"/>
+              </a:rPr>
+              <a:t>After the slides: one conversation with Claude</a:t>
+            </a:r>
+          </a:p>
+        </p:txBody>
+      </p:sp>
+      <p:sp>
+        <p:nvSpPr>
+          <p:cNvPr id="4" name="TextBox 3"/>
+          <p:cNvSpPr txBox="1"/>
+          <p:nvPr/>
+        </p:nvSpPr>
+        <p:spPr>
+          <a:xfrm>
+            <a:off x="822960" y="2011680"/>
+            <a:ext cx="10607040" cy="4206240"/>
+          </a:xfrm>
+          <a:prstGeom prst="rect">
+            <a:avLst/>
+          </a:prstGeom>
+          <a:noFill/>
+        </p:spPr>
+        <p:txBody>
+          <a:bodyPr wrap="square">
+            <a:spAutoFit/>
+          </a:bodyPr>
+          <a:lstStyle/>
+          <a:p>
+            <a:pPr>
+              <a:spcAft>
+                <a:spcPts val="2200"/>
+              </a:spcAft>
+            </a:pPr>
+            <a:r>
+              <a:rPr sz="3000" b="0">
+                <a:solidFill>
+                  <a:srgbClr val="272A25"/>
+                </a:solidFill>
+                <a:latin typeface="DM Sans"/>
+              </a:rPr>
+              <a:t>•  Aaron will paste the lesson and talk through it with Claude.</a:t>
+            </a:r>
+          </a:p>
+          <a:p>
+            <a:pPr>
+              <a:spcAft>
+                <a:spcPts val="2200"/>
+              </a:spcAft>
+            </a:pPr>
+            <a:r>
+              <a:rPr sz="3000" b="0">
+                <a:solidFill>
+                  <a:srgbClr val="272A25"/>
+                </a:solidFill>
+                <a:latin typeface="DM Sans"/>
+              </a:rPr>
+              <a:t>•  The conversation may lead to building a little thing.</a:t>
+            </a:r>
+          </a:p>
+          <a:p>
+            <a:pPr>
+              <a:spcAft>
+                <a:spcPts val="2200"/>
+              </a:spcAft>
+            </a:pPr>
+            <a:r>
+              <a:rPr sz="3000" b="0">
+                <a:solidFill>
+                  <a:srgbClr val="272A25"/>
+                </a:solidFill>
+                <a:latin typeface="DM Sans"/>
+              </a:rPr>
+              <a:t>•  Watch how questions, context and checking shape the result.</a:t>
+            </a:r>
+          </a:p>
+        </p:txBody>
+      </p:sp>
+      <p:sp>
+        <p:nvSpPr>
+          <p:cNvPr id="5" name="TextBox 4"/>
+          <p:cNvSpPr txBox="1"/>
+          <p:nvPr/>
+        </p:nvSpPr>
+        <p:spPr>
+          <a:xfrm>
+            <a:off x="822960" y="6263640"/>
+            <a:ext cx="10607040" cy="365760"/>
+          </a:xfrm>
+          <a:prstGeom prst="rect">
+            <a:avLst/>
+          </a:prstGeom>
+          <a:noFill/>
+        </p:spPr>
+        <p:txBody>
+          <a:bodyPr wrap="square">
+            <a:spAutoFit/>
+          </a:bodyPr>
+          <a:lstStyle/>
+          <a:p>
+            <a:pPr algn="r">
+              <a:spcAft>
+                <a:spcPts val="1400"/>
+              </a:spcAft>
+            </a:pPr>
+            <a:r>
+              <a:rPr sz="1600" b="0">
+                <a:solidFill>
+                  <a:srgbClr val="64665D"/>
+                </a:solidFill>
+                <a:latin typeface="DM Sans"/>
+              </a:rPr>
+              <a:t>Week 6 · One live demo        24 / 26</a:t>
+            </a:r>
+          </a:p>
+        </p:txBody>
+      </p:sp>
+    </p:spTree>
+  </p:cSld>
+  <p:clrMapOvr>
+    <a:masterClrMapping/>
+  </p:clrMapOvr>
+</p:sld>
+</file>
+
+<file path=ppt/slides/slide25.xml><?xml version="1.0" encoding="utf-8"?>
+<p:sld xmlns:a="http://schemas.openxmlformats.org/drawingml/2006/main" xmlns:p="http://schemas.openxmlformats.org/presentationml/2006/main" xmlns:r="http://schemas.openxmlformats.org/officeDocument/2006/relationships">
+  <p:cSld>
+    <p:bg>
+      <p:bgPr>
+        <a:solidFill>
+          <a:srgbClr val="F7F5EE"/>
+        </a:solidFill>
+        <a:effectLst/>
+      </p:bgPr>
+    </p:bg>
+    <p:spTree>
+      <p:nvGrpSpPr>
+        <p:cNvPr id="1" name=""/>
+        <p:cNvGrpSpPr/>
+        <p:nvPr/>
+      </p:nvGrpSpPr>
+      <p:grpSpPr/>
+      <p:sp>
+        <p:nvSpPr>
+          <p:cNvPr id="2" name="Rectangle 1"/>
+          <p:cNvSpPr/>
+          <p:nvPr/>
+        </p:nvSpPr>
+        <p:spPr>
+          <a:xfrm>
+            <a:off x="0" y="0"/>
+            <a:ext cx="228600" cy="6858000"/>
+          </a:xfrm>
+          <a:prstGeom prst="rect">
+            <a:avLst/>
+          </a:prstGeom>
+          <a:solidFill>
+            <a:srgbClr val="A83D2B"/>
+          </a:solidFill>
+          <a:ln>
+            <a:noFill/>
+          </a:ln>
+        </p:spPr>
+        <p:style>
+          <a:lnRef idx="1">
+            <a:schemeClr val="accent1"/>
+          </a:lnRef>
+          <a:fillRef idx="3">
+            <a:schemeClr val="accent1"/>
+          </a:fillRef>
+          <a:effectRef idx="2">
+            <a:schemeClr val="accent1"/>
+          </a:effectRef>
+          <a:fontRef idx="minor">
+            <a:schemeClr val="lt1"/>
+          </a:fontRef>
+        </p:style>
+        <p:txBody>
+          <a:bodyPr rtlCol="0" anchor="ctr"/>
+          <a:lstStyle/>
+          <a:p>
+            <a:pPr algn="ctr"/>
+          </a:p>
+        </p:txBody>
+      </p:sp>
+      <p:sp>
+        <p:nvSpPr>
+          <p:cNvPr id="3" name="TextBox 2"/>
+          <p:cNvSpPr txBox="1"/>
+          <p:nvPr/>
+        </p:nvSpPr>
+        <p:spPr>
+          <a:xfrm>
+            <a:off x="822960" y="548640"/>
+            <a:ext cx="10607040" cy="1188720"/>
+          </a:xfrm>
+          <a:prstGeom prst="rect">
+            <a:avLst/>
+          </a:prstGeom>
+          <a:noFill/>
+        </p:spPr>
+        <p:txBody>
+          <a:bodyPr wrap="square">
+            <a:spAutoFit/>
+          </a:bodyPr>
+          <a:lstStyle/>
+          <a:p>
+            <a:pPr>
+              <a:spcAft>
+                <a:spcPts val="1400"/>
+              </a:spcAft>
+            </a:pPr>
+            <a:r>
+              <a:rPr sz="3200" b="1">
+                <a:solidFill>
+                  <a:srgbClr val="272A25"/>
+                </a:solidFill>
+                <a:latin typeface="Fraunces"/>
+              </a:rPr>
+              <a:t>In small groups: build for your learning</a:t>
+            </a:r>
+          </a:p>
+        </p:txBody>
+      </p:sp>
+      <p:sp>
+        <p:nvSpPr>
+          <p:cNvPr id="4" name="TextBox 3"/>
+          <p:cNvSpPr txBox="1"/>
+          <p:nvPr/>
+        </p:nvSpPr>
+        <p:spPr>
+          <a:xfrm>
+            <a:off x="822960" y="2011680"/>
+            <a:ext cx="10607040" cy="4206240"/>
+          </a:xfrm>
+          <a:prstGeom prst="rect">
+            <a:avLst/>
+          </a:prstGeom>
+          <a:noFill/>
+        </p:spPr>
+        <p:txBody>
+          <a:bodyPr wrap="square">
+            <a:spAutoFit/>
+          </a:bodyPr>
+          <a:lstStyle/>
+          <a:p>
+            <a:pPr>
+              <a:spcAft>
+                <a:spcPts val="2200"/>
+              </a:spcAft>
+            </a:pPr>
+            <a:r>
+              <a:rPr sz="3000" b="0">
+                <a:solidFill>
+                  <a:srgbClr val="272A25"/>
+                </a:solidFill>
+                <a:latin typeface="DM Sans"/>
+              </a:rPr>
+              <a:t>•  Choose a topic you want to understand or practise, and your own approach.</a:t>
+            </a:r>
+          </a:p>
+          <a:p>
+            <a:pPr>
+              <a:spcAft>
+                <a:spcPts val="2200"/>
+              </a:spcAft>
+            </a:pPr>
+            <a:r>
+              <a:rPr sz="3000" b="0">
+                <a:solidFill>
+                  <a:srgbClr val="272A25"/>
+                </a:solidFill>
+                <a:latin typeface="DM Sans"/>
+              </a:rPr>
+              <a:t>•  Make a quiz, interactive explainer, practice tool—or an idea of your own.</a:t>
+            </a:r>
+          </a:p>
+          <a:p>
+            <a:pPr>
+              <a:spcAft>
+                <a:spcPts val="2200"/>
+              </a:spcAft>
+            </a:pPr>
+            <a:r>
+              <a:rPr sz="3000" b="0">
+                <a:solidFill>
+                  <a:srgbClr val="272A25"/>
+                </a:solidFill>
+                <a:latin typeface="DM Sans"/>
+              </a:rPr>
+              <a:t>•  Use your AI; try the first version yourselves; check it and revise.</a:t>
+            </a:r>
+          </a:p>
+        </p:txBody>
+      </p:sp>
+      <p:sp>
+        <p:nvSpPr>
+          <p:cNvPr id="5" name="TextBox 4"/>
+          <p:cNvSpPr txBox="1"/>
+          <p:nvPr/>
+        </p:nvSpPr>
+        <p:spPr>
+          <a:xfrm>
+            <a:off x="822960" y="6263640"/>
+            <a:ext cx="10607040" cy="365760"/>
+          </a:xfrm>
+          <a:prstGeom prst="rect">
+            <a:avLst/>
+          </a:prstGeom>
+          <a:noFill/>
+        </p:spPr>
+        <p:txBody>
+          <a:bodyPr wrap="square">
+            <a:spAutoFit/>
+          </a:bodyPr>
+          <a:lstStyle/>
+          <a:p>
+            <a:pPr algn="r">
+              <a:spcAft>
+                <a:spcPts val="1400"/>
+              </a:spcAft>
+            </a:pPr>
+            <a:r>
+              <a:rPr sz="1600" b="0">
+                <a:solidFill>
+                  <a:srgbClr val="64665D"/>
+                </a:solidFill>
+                <a:latin typeface="DM Sans"/>
+              </a:rPr>
+              <a:t>Week 6 · Group work        25 / 26</a:t>
+            </a:r>
+          </a:p>
+        </p:txBody>
+      </p:sp>
+    </p:spTree>
+  </p:cSld>
+  <p:clrMapOvr>
+    <a:masterClrMapping/>
+  </p:clrMapOvr>
+</p:sld>
+</file>
+
+<file path=ppt/slides/slide26.xml><?xml version="1.0" encoding="utf-8"?>
+<p:sld xmlns:a="http://schemas.openxmlformats.org/drawingml/2006/main" xmlns:p="http://schemas.openxmlformats.org/presentationml/2006/main" xmlns:r="http://schemas.openxmlformats.org/officeDocument/2006/relationships">
+  <p:cSld>
+    <p:bg>
+      <p:bgPr>
+        <a:solidFill>
+          <a:srgbClr val="F7F5EE"/>
+        </a:solidFill>
+        <a:effectLst/>
+      </p:bgPr>
+    </p:bg>
+    <p:spTree>
+      <p:nvGrpSpPr>
+        <p:cNvPr id="1" name=""/>
+        <p:cNvGrpSpPr/>
+        <p:nvPr/>
+      </p:nvGrpSpPr>
+      <p:grpSpPr/>
+      <p:sp>
+        <p:nvSpPr>
+          <p:cNvPr id="2" name="Rectangle 1"/>
+          <p:cNvSpPr/>
+          <p:nvPr/>
+        </p:nvSpPr>
+        <p:spPr>
+          <a:xfrm>
+            <a:off x="0" y="0"/>
+            <a:ext cx="228600" cy="6858000"/>
+          </a:xfrm>
+          <a:prstGeom prst="rect">
+            <a:avLst/>
+          </a:prstGeom>
+          <a:solidFill>
+            <a:srgbClr val="A83D2B"/>
+          </a:solidFill>
+          <a:ln>
+            <a:noFill/>
+          </a:ln>
+        </p:spPr>
+        <p:style>
+          <a:lnRef idx="1">
+            <a:schemeClr val="accent1"/>
+          </a:lnRef>
+          <a:fillRef idx="3">
+            <a:schemeClr val="accent1"/>
+          </a:fillRef>
+          <a:effectRef idx="2">
+            <a:schemeClr val="accent1"/>
+          </a:effectRef>
+          <a:fontRef idx="minor">
+            <a:schemeClr val="lt1"/>
+          </a:fontRef>
+        </p:style>
+        <p:txBody>
+          <a:bodyPr rtlCol="0" anchor="ctr"/>
+          <a:lstStyle/>
+          <a:p>
+            <a:pPr algn="ctr"/>
+          </a:p>
+        </p:txBody>
+      </p:sp>
+      <p:sp>
+        <p:nvSpPr>
+          <p:cNvPr id="3" name="TextBox 2"/>
+          <p:cNvSpPr txBox="1"/>
+          <p:nvPr/>
+        </p:nvSpPr>
+        <p:spPr>
+          <a:xfrm>
+            <a:off x="822960" y="548640"/>
+            <a:ext cx="10607040" cy="1188720"/>
+          </a:xfrm>
+          <a:prstGeom prst="rect">
+            <a:avLst/>
+          </a:prstGeom>
+          <a:noFill/>
+        </p:spPr>
+        <p:txBody>
+          <a:bodyPr wrap="square">
+            <a:spAutoFit/>
+          </a:bodyPr>
+          <a:lstStyle/>
+          <a:p>
+            <a:pPr>
+              <a:spcAft>
+                <a:spcPts val="1400"/>
+              </a:spcAft>
+            </a:pPr>
+            <a:r>
+              <a:rPr sz="4000" b="1">
+                <a:solidFill>
+                  <a:srgbClr val="272A25"/>
+                </a:solidFill>
+                <a:latin typeface="Fraunces"/>
+              </a:rPr>
+              <a:t>How to start—and what to share</a:t>
+            </a:r>
+          </a:p>
+        </p:txBody>
+      </p:sp>
+      <p:sp>
+        <p:nvSpPr>
+          <p:cNvPr id="4" name="TextBox 3"/>
+          <p:cNvSpPr txBox="1"/>
+          <p:nvPr/>
+        </p:nvSpPr>
+        <p:spPr>
+          <a:xfrm>
+            <a:off x="822960" y="2011680"/>
+            <a:ext cx="10607040" cy="4206240"/>
+          </a:xfrm>
+          <a:prstGeom prst="rect">
+            <a:avLst/>
+          </a:prstGeom>
+          <a:noFill/>
+        </p:spPr>
+        <p:txBody>
+          <a:bodyPr wrap="square">
+            <a:spAutoFit/>
+          </a:bodyPr>
+          <a:lstStyle/>
+          <a:p>
+            <a:pPr>
+              <a:spcAft>
+                <a:spcPts val="2200"/>
+              </a:spcAft>
+            </a:pPr>
+            <a:r>
+              <a:rPr sz="3000" b="0">
+                <a:solidFill>
+                  <a:srgbClr val="272A25"/>
+                </a:solidFill>
+                <a:latin typeface="DM Sans"/>
+              </a:rPr>
+              <a:t>•  Give your AI the lesson, your learning question, or both.</a:t>
+            </a:r>
+          </a:p>
+          <a:p>
+            <a:pPr>
+              <a:spcAft>
+                <a:spcPts val="2200"/>
+              </a:spcAft>
+            </a:pPr>
+            <a:r>
+              <a:rPr sz="3000" b="0">
+                <a:solidFill>
+                  <a:srgbClr val="272A25"/>
+                </a:solidFill>
+                <a:latin typeface="DM Sans"/>
+              </a:rPr>
+              <a:t>•  Ask for a small first version. Test whether it actually helps you learn.</a:t>
+            </a:r>
+          </a:p>
+          <a:p>
+            <a:pPr>
+              <a:spcAft>
+                <a:spcPts val="2200"/>
+              </a:spcAft>
+            </a:pPr>
+            <a:r>
+              <a:rPr sz="3000" b="0">
+                <a:solidFill>
+                  <a:srgbClr val="272A25"/>
+                </a:solidFill>
+                <a:latin typeface="DM Sans"/>
+              </a:rPr>
+              <a:t>•  Show what you made, what you learned, and one thing you checked or changed.</a:t>
+            </a:r>
+          </a:p>
+        </p:txBody>
+      </p:sp>
+      <p:sp>
+        <p:nvSpPr>
+          <p:cNvPr id="5" name="TextBox 4"/>
+          <p:cNvSpPr txBox="1"/>
+          <p:nvPr/>
+        </p:nvSpPr>
+        <p:spPr>
+          <a:xfrm>
+            <a:off x="822960" y="6263640"/>
+            <a:ext cx="10607040" cy="365760"/>
+          </a:xfrm>
+          <a:prstGeom prst="rect">
+            <a:avLst/>
+          </a:prstGeom>
+          <a:noFill/>
+        </p:spPr>
+        <p:txBody>
+          <a:bodyPr wrap="square">
+            <a:spAutoFit/>
+          </a:bodyPr>
+          <a:lstStyle/>
+          <a:p>
+            <a:pPr algn="r">
+              <a:spcAft>
+                <a:spcPts val="1400"/>
+              </a:spcAft>
+            </a:pPr>
+            <a:r>
+              <a:rPr sz="1600" b="0">
+                <a:solidFill>
+                  <a:srgbClr val="64665D"/>
+                </a:solidFill>
+                <a:latin typeface="DM Sans"/>
+              </a:rPr>
+              <a:t>Week 6 · Group work        26 / 26</a:t>
             </a:r>
           </a:p>
         </p:txBody>
@@ -5714,7 +9471,7 @@
                 </a:solidFill>
                 <a:latin typeface="Fraunces"/>
               </a:rPr>
-              <a:t>This week’s reading: your AI as a coach</a:t>
+              <a:t>Use AI to learn about AI</a:t>
             </a:r>
           </a:p>
         </p:txBody>
@@ -5753,7 +9510,7 @@
                 </a:solidFill>
                 <a:latin typeface="DM Sans"/>
               </a:rPr>
-              <a:t>•  Arielle Shipper · How to Get Better at AI by Asking AI</a:t>
+              <a:t>•  Ask for an explanation, an example, and a question to check your understanding.</a:t>
             </a:r>
           </a:p>
           <a:p>
@@ -5769,7 +9526,7 @@
                 </a:solidFill>
                 <a:latin typeface="DM Sans"/>
               </a:rPr>
-              <a:t>•  Use examples of your own work to ask: “What should I learn next?”</a:t>
+              <a:t>•  Say what you already know: “I know HTML; Git is new to me.”</a:t>
             </a:r>
           </a:p>
           <a:p>
@@ -5785,7 +9542,7 @@
                 </a:solidFill>
                 <a:latin typeface="DM Sans"/>
               </a:rPr>
-              <a:t>•  Then: “Teach me that next step.”</a:t>
+              <a:t>•  Compare its explanation with your source—not just how confident it sounds.</a:t>
             </a:r>
           </a:p>
         </p:txBody>
@@ -5824,7 +9581,7 @@
                 </a:solidFill>
                 <a:latin typeface="DM Sans"/>
               </a:rPr>
-              <a:t>Week 6 · Learn with AI        3 / 13</a:t>
+              <a:t>Week 6 · Learn with AI        3 / 26</a:t>
             </a:r>
           </a:p>
         </p:txBody>
@@ -5932,7 +9689,7 @@
                 </a:solidFill>
                 <a:latin typeface="Fraunces"/>
               </a:rPr>
-              <a:t>Markdown is just a text file</a:t>
+              <a:t>The reading: your AI as a coach</a:t>
             </a:r>
           </a:p>
         </p:txBody>
@@ -5971,7 +9728,7 @@
                 </a:solidFill>
                 <a:latin typeface="DM Sans"/>
               </a:rPr>
-              <a:t>•  A .md file is plain text, with headings and lists.</a:t>
+              <a:t>•  Arielle Shipper · “How to Get Better at AI by Asking AI” · Every</a:t>
             </a:r>
           </a:p>
           <a:p>
@@ -5987,7 +9744,7 @@
                 </a:solidFill>
                 <a:latin typeface="DM Sans"/>
               </a:rPr>
-              <a:t>•  You can read it. Your AI can read it.</a:t>
+              <a:t>•  Ask where you are on the Eight Levels of AI Adoption, with evidence from your work.</a:t>
             </a:r>
           </a:p>
           <a:p>
@@ -6003,7 +9760,7 @@
                 </a:solidFill>
                 <a:latin typeface="DM Sans"/>
               </a:rPr>
-              <a:t>•  A lesson or project context can live in that file.</a:t>
+              <a:t>•  Ask for one next step, then: “Teach me that and help me practise.”</a:t>
             </a:r>
           </a:p>
         </p:txBody>
@@ -6042,7 +9799,7 @@
                 </a:solidFill>
                 <a:latin typeface="DM Sans"/>
               </a:rPr>
-              <a:t>Week 6 · Context        4 / 13</a:t>
+              <a:t>Week 6 · Learn with AI        4 / 26</a:t>
             </a:r>
           </a:p>
         </p:txBody>
@@ -6144,13 +9901,13 @@
               </a:spcAft>
             </a:pPr>
             <a:r>
-              <a:rPr sz="4000" b="1">
+              <a:rPr sz="3200" b="1">
                 <a:solidFill>
                   <a:srgbClr val="272A25"/>
                 </a:solidFill>
                 <a:latin typeface="Fraunces"/>
               </a:rPr>
-              <a:t>Context that sticks</a:t>
+              <a:t>No long chat history? Bring your own evidence</a:t>
             </a:r>
           </a:p>
         </p:txBody>
@@ -6189,7 +9946,7 @@
                 </a:solidFill>
                 <a:latin typeface="DM Sans"/>
               </a:rPr>
-              <a:t>•  Claude Code loads CLAUDE.md at session start.</a:t>
+              <a:t>•  Paste your last two submissions or describe a recent project.</a:t>
             </a:r>
           </a:p>
           <a:p>
@@ -6205,7 +9962,7 @@
                 </a:solidFill>
                 <a:latin typeface="DM Sans"/>
               </a:rPr>
-              <a:t>•  Cursor and other coding tools can load AGENTS.md.</a:t>
+              <a:t>•  Ask: “What can I do already? Show examples. What should I learn next?”</a:t>
             </a:r>
           </a:p>
           <a:p>
@@ -6221,7 +9978,7 @@
                 </a:solidFill>
                 <a:latin typeface="DM Sans"/>
               </a:rPr>
-              <a:t>•  In a chat app: paste the file or add it to a Project.</a:t>
+              <a:t>•  Treat the AI’s assessment as a suggestion; correct its assumptions.</a:t>
             </a:r>
           </a:p>
         </p:txBody>
@@ -6260,7 +10017,7 @@
                 </a:solidFill>
                 <a:latin typeface="DM Sans"/>
               </a:rPr>
-              <a:t>Week 6 · Context        5 / 13</a:t>
+              <a:t>Week 6 · Learn with AI        5 / 26</a:t>
             </a:r>
           </a:p>
         </p:txBody>
@@ -6368,64 +10125,21 @@
                 </a:solidFill>
                 <a:latin typeface="Fraunces"/>
               </a:rPr>
-              <a:t>One small example</a:t>
-            </a:r>
-          </a:p>
-        </p:txBody>
-      </p:sp>
-      <p:sp>
-        <p:nvSpPr>
-          <p:cNvPr id="4" name="Rectangle 3"/>
-          <p:cNvSpPr/>
-          <p:nvPr/>
-        </p:nvSpPr>
-        <p:spPr>
-          <a:xfrm>
-            <a:off x="822960" y="1828800"/>
-            <a:ext cx="6583680" cy="4023360"/>
-          </a:xfrm>
-          <a:prstGeom prst="rect">
-            <a:avLst/>
-          </a:prstGeom>
-          <a:solidFill>
-            <a:srgbClr val="EEECE2"/>
-          </a:solidFill>
-          <a:ln>
-            <a:noFill/>
-          </a:ln>
-        </p:spPr>
-        <p:style>
-          <a:lnRef idx="1">
-            <a:schemeClr val="accent1"/>
-          </a:lnRef>
-          <a:fillRef idx="3">
-            <a:schemeClr val="accent1"/>
-          </a:fillRef>
-          <a:effectRef idx="2">
-            <a:schemeClr val="accent1"/>
-          </a:effectRef>
-          <a:fontRef idx="minor">
-            <a:schemeClr val="lt1"/>
-          </a:fontRef>
-        </p:style>
-        <p:txBody>
-          <a:bodyPr rtlCol="0" anchor="ctr"/>
-          <a:lstStyle/>
-          <a:p>
-            <a:pPr algn="ctr"/>
-          </a:p>
-        </p:txBody>
-      </p:sp>
-      <p:sp>
-        <p:nvSpPr>
-          <p:cNvPr id="5" name="TextBox 4"/>
+              <a:t>Markdown: readable, portable text</a:t>
+            </a:r>
+          </a:p>
+        </p:txBody>
+      </p:sp>
+      <p:sp>
+        <p:nvSpPr>
+          <p:cNvPr id="4" name="TextBox 3"/>
           <p:cNvSpPr txBox="1"/>
           <p:nvPr/>
         </p:nvSpPr>
         <p:spPr>
           <a:xfrm>
-            <a:off x="1097280" y="2011680"/>
-            <a:ext cx="6217920" cy="3749039"/>
+            <a:off x="822960" y="2011680"/>
+            <a:ext cx="10607040" cy="4206240"/>
           </a:xfrm>
           <a:prstGeom prst="rect">
             <a:avLst/>
@@ -6440,95 +10154,63 @@
           <a:p>
             <a:pPr>
               <a:spcAft>
-                <a:spcPts val="200"/>
-              </a:spcAft>
-            </a:pPr>
-            <a:r>
-              <a:rPr sz="1800" b="0">
+                <a:spcPts val="2200"/>
+              </a:spcAft>
+            </a:pPr>
+            <a:r>
+              <a:rPr sz="3000" b="0">
                 <a:solidFill>
                   <a:srgbClr val="272A25"/>
                 </a:solidFill>
-                <a:latin typeface="DejaVu Sans Mono"/>
-              </a:rPr>
-              <a:t># Hill Plant Swap</a:t>
+                <a:latin typeface="DM Sans"/>
+              </a:rPr>
+              <a:t>•  A .md file is a plain-text file—not a special app or database.</a:t>
             </a:r>
           </a:p>
           <a:p>
             <a:pPr>
               <a:spcAft>
-                <a:spcPts val="200"/>
-              </a:spcAft>
-            </a:pPr>
-            <a:r>
-              <a:rPr sz="1800" b="0">
+                <a:spcPts val="2200"/>
+              </a:spcAft>
+            </a:pPr>
+            <a:r>
+              <a:rPr sz="3000" b="0">
                 <a:solidFill>
                   <a:srgbClr val="272A25"/>
                 </a:solidFill>
-                <a:latin typeface="DejaVu Sans Mono"/>
-              </a:rPr>
-              <a:t>A one-page website for a free plant swap near CU.</a:t>
+                <a:latin typeface="DM Sans"/>
+              </a:rPr>
+              <a:t>•  A little punctuation adds structure: headings, lists, links, code.</a:t>
             </a:r>
           </a:p>
           <a:p>
             <a:pPr>
               <a:spcAft>
-                <a:spcPts val="200"/>
-              </a:spcAft>
-            </a:pPr>
-            <a:r>
-              <a:rPr sz="1800" b="0">
+                <a:spcPts val="2200"/>
+              </a:spcAft>
+            </a:pPr>
+            <a:r>
+              <a:rPr sz="3000" b="0">
                 <a:solidFill>
                   <a:srgbClr val="272A25"/>
                 </a:solidFill>
-                <a:latin typeface="DejaVu Sans Mono"/>
-              </a:rPr>
-              <a:t>For first-year students who are nervous about going.</a:t>
-            </a:r>
-          </a:p>
-          <a:p>
-            <a:pPr>
-              <a:spcAft>
-                <a:spcPts val="200"/>
-              </a:spcAft>
-            </a:pPr>
-            <a:r>
-              <a:rPr sz="1800" b="0">
-                <a:solidFill>
-                  <a:srgbClr val="272A25"/>
-                </a:solidFill>
-                <a:latin typeface="DejaVu Sans Mono"/>
-              </a:rPr>
-              <a:t>Keep it plain HTML and CSS. No JavaScript.</a:t>
-            </a:r>
-          </a:p>
-          <a:p>
-            <a:pPr>
-              <a:spcAft>
-                <a:spcPts val="200"/>
-              </a:spcAft>
-            </a:pPr>
-            <a:r>
-              <a:rPr sz="1800" b="0">
-                <a:solidFill>
-                  <a:srgbClr val="272A25"/>
-                </a:solidFill>
-                <a:latin typeface="DejaVu Sans Mono"/>
-              </a:rPr>
-              <a:t>Use docs/event-facts.md. Never make up dates.</a:t>
-            </a:r>
-          </a:p>
-        </p:txBody>
-      </p:sp>
-      <p:sp>
-        <p:nvSpPr>
-          <p:cNvPr id="6" name="TextBox 5"/>
+                <a:latin typeface="DM Sans"/>
+              </a:rPr>
+              <a:t>•  Read it in an editor, render it as a page, or paste it into your AI.</a:t>
+            </a:r>
+          </a:p>
+        </p:txBody>
+      </p:sp>
+      <p:sp>
+        <p:nvSpPr>
+          <p:cNvPr id="5" name="TextBox 4"/>
           <p:cNvSpPr txBox="1"/>
           <p:nvPr/>
         </p:nvSpPr>
         <p:spPr>
           <a:xfrm>
-            <a:off x="7772400" y="3108960"/>
-            <a:ext cx="3931920" cy="1828800"/>
+            <a:off x="822960" y="6263640"/>
+            <a:ext cx="10607040" cy="365760"/>
           </a:xfrm>
           <a:prstGeom prst="rect">
             <a:avLst/>
@@ -6541,58 +10223,19 @@
           </a:bodyPr>
           <a:lstStyle/>
           <a:p>
-            <a:pPr>
+            <a:pPr algn="r">
               <a:spcAft>
                 <a:spcPts val="1400"/>
               </a:spcAft>
             </a:pPr>
             <a:r>
-              <a:rPr sz="2800" b="0">
+              <a:rPr sz="1600" b="0">
                 <a:solidFill>
                   <a:srgbClr val="64665D"/>
                 </a:solidFill>
                 <a:latin typeface="DM Sans"/>
               </a:rPr>
-              <a:t>Plain words. Nothing fancy.</a:t>
-            </a:r>
-          </a:p>
-        </p:txBody>
-      </p:sp>
-      <p:sp>
-        <p:nvSpPr>
-          <p:cNvPr id="7" name="TextBox 6"/>
-          <p:cNvSpPr txBox="1"/>
-          <p:nvPr/>
-        </p:nvSpPr>
-        <p:spPr>
-          <a:xfrm>
-            <a:off x="822960" y="6263640"/>
-            <a:ext cx="10607040" cy="365760"/>
-          </a:xfrm>
-          <a:prstGeom prst="rect">
-            <a:avLst/>
-          </a:prstGeom>
-          <a:noFill/>
-        </p:spPr>
-        <p:txBody>
-          <a:bodyPr wrap="square">
-            <a:spAutoFit/>
-          </a:bodyPr>
-          <a:lstStyle/>
-          <a:p>
-            <a:pPr algn="r">
-              <a:spcAft>
-                <a:spcPts val="1400"/>
-              </a:spcAft>
-            </a:pPr>
-            <a:r>
-              <a:rPr sz="1600" b="0">
-                <a:solidFill>
-                  <a:srgbClr val="64665D"/>
-                </a:solidFill>
-                <a:latin typeface="DM Sans"/>
-              </a:rPr>
-              <a:t>Week 6 · Context        6 / 13</a:t>
+              <a:t>Week 6 · Markdown        6 / 26</a:t>
             </a:r>
           </a:p>
         </p:txBody>
@@ -6700,21 +10343,64 @@
                 </a:solidFill>
                 <a:latin typeface="Fraunces"/>
               </a:rPr>
-              <a:t>A link someone else can open</a:t>
-            </a:r>
-          </a:p>
-        </p:txBody>
-      </p:sp>
-      <p:sp>
-        <p:nvSpPr>
-          <p:cNvPr id="4" name="TextBox 3"/>
+              <a:t>Markdown you can read and write</a:t>
+            </a:r>
+          </a:p>
+        </p:txBody>
+      </p:sp>
+      <p:sp>
+        <p:nvSpPr>
+          <p:cNvPr id="4" name="Rectangle 3"/>
+          <p:cNvSpPr/>
+          <p:nvPr/>
+        </p:nvSpPr>
+        <p:spPr>
+          <a:xfrm>
+            <a:off x="822960" y="1828800"/>
+            <a:ext cx="6583680" cy="4023360"/>
+          </a:xfrm>
+          <a:prstGeom prst="rect">
+            <a:avLst/>
+          </a:prstGeom>
+          <a:solidFill>
+            <a:srgbClr val="EEECE2"/>
+          </a:solidFill>
+          <a:ln>
+            <a:noFill/>
+          </a:ln>
+        </p:spPr>
+        <p:style>
+          <a:lnRef idx="1">
+            <a:schemeClr val="accent1"/>
+          </a:lnRef>
+          <a:fillRef idx="3">
+            <a:schemeClr val="accent1"/>
+          </a:fillRef>
+          <a:effectRef idx="2">
+            <a:schemeClr val="accent1"/>
+          </a:effectRef>
+          <a:fontRef idx="minor">
+            <a:schemeClr val="lt1"/>
+          </a:fontRef>
+        </p:style>
+        <p:txBody>
+          <a:bodyPr rtlCol="0" anchor="ctr"/>
+          <a:lstStyle/>
+          <a:p>
+            <a:pPr algn="ctr"/>
+          </a:p>
+        </p:txBody>
+      </p:sp>
+      <p:sp>
+        <p:nvSpPr>
+          <p:cNvPr id="5" name="TextBox 4"/>
           <p:cNvSpPr txBox="1"/>
           <p:nvPr/>
         </p:nvSpPr>
         <p:spPr>
           <a:xfrm>
-            <a:off x="822960" y="2011680"/>
-            <a:ext cx="10607040" cy="4206240"/>
+            <a:off x="1097280" y="2011680"/>
+            <a:ext cx="6217920" cy="3749039"/>
           </a:xfrm>
           <a:prstGeom prst="rect">
             <a:avLst/>
@@ -6729,63 +10415,95 @@
           <a:p>
             <a:pPr>
               <a:spcAft>
-                <a:spcPts val="2200"/>
-              </a:spcAft>
-            </a:pPr>
-            <a:r>
-              <a:rPr sz="3000" b="0">
+                <a:spcPts val="200"/>
+              </a:spcAft>
+            </a:pPr>
+            <a:r>
+              <a:rPr sz="1800" b="0">
                 <a:solidFill>
                   <a:srgbClr val="272A25"/>
                 </a:solidFill>
-                <a:latin typeface="DM Sans"/>
-              </a:rPr>
-              <a:t>•  file:// and localhost links only work on your computer.</a:t>
+                <a:latin typeface="DejaVu Sans Mono"/>
+              </a:rPr>
+              <a:t># Project notes</a:t>
             </a:r>
           </a:p>
           <a:p>
             <a:pPr>
               <a:spcAft>
-                <a:spcPts val="2200"/>
-              </a:spcAft>
-            </a:pPr>
-            <a:r>
-              <a:rPr sz="3000" b="0">
+                <a:spcPts val="200"/>
+              </a:spcAft>
+            </a:pPr>
+            <a:r>
+              <a:rPr sz="1800" b="0">
                 <a:solidFill>
                   <a:srgbClr val="272A25"/>
                 </a:solidFill>
-                <a:latin typeface="DM Sans"/>
-              </a:rPr>
-              <a:t>•  A public HTTPS link works on someone else’s phone.</a:t>
+                <a:latin typeface="DejaVu Sans Mono"/>
+              </a:rPr>
+              <a:t>## What I want to learn</a:t>
             </a:r>
           </a:p>
           <a:p>
             <a:pPr>
               <a:spcAft>
-                <a:spcPts val="2200"/>
-              </a:spcAft>
-            </a:pPr>
-            <a:r>
-              <a:rPr sz="3000" b="0">
+                <a:spcPts val="200"/>
+              </a:spcAft>
+            </a:pPr>
+            <a:r>
+              <a:rPr sz="1800" b="0">
                 <a:solidFill>
                   <a:srgbClr val="272A25"/>
                 </a:solidFill>
-                <a:latin typeface="DM Sans"/>
-              </a:rPr>
-              <a:t>•  Commit → push → deploy are three different steps.</a:t>
-            </a:r>
-          </a:p>
-        </p:txBody>
-      </p:sp>
-      <p:sp>
-        <p:nvSpPr>
-          <p:cNvPr id="5" name="TextBox 4"/>
+                <a:latin typeface="DejaVu Sans Mono"/>
+              </a:rPr>
+              <a:t>- Explain commits before changing files.</a:t>
+            </a:r>
+          </a:p>
+          <a:p>
+            <a:pPr>
+              <a:spcAft>
+                <a:spcPts val="200"/>
+              </a:spcAft>
+            </a:pPr>
+            <a:r>
+              <a:rPr sz="1800" b="0">
+                <a:solidFill>
+                  <a:srgbClr val="272A25"/>
+                </a:solidFill>
+                <a:latin typeface="DejaVu Sans Mono"/>
+              </a:rPr>
+              <a:t>[Course lesson](https://cu.learnvibe.build/lessons/week-6/)</a:t>
+            </a:r>
+          </a:p>
+          <a:p>
+            <a:pPr>
+              <a:spcAft>
+                <a:spcPts val="200"/>
+              </a:spcAft>
+            </a:pPr>
+            <a:r>
+              <a:rPr sz="1800" b="0">
+                <a:solidFill>
+                  <a:srgbClr val="272A25"/>
+                </a:solidFill>
+                <a:latin typeface="DejaVu Sans Mono"/>
+              </a:rPr>
+              <a:t>Use `git status` to see what changed.</a:t>
+            </a:r>
+          </a:p>
+        </p:txBody>
+      </p:sp>
+      <p:sp>
+        <p:nvSpPr>
+          <p:cNvPr id="6" name="TextBox 5"/>
           <p:cNvSpPr txBox="1"/>
           <p:nvPr/>
         </p:nvSpPr>
         <p:spPr>
           <a:xfrm>
-            <a:off x="822960" y="6263640"/>
-            <a:ext cx="10607040" cy="365760"/>
+            <a:off x="7772400" y="3108960"/>
+            <a:ext cx="3931920" cy="1828800"/>
           </a:xfrm>
           <a:prstGeom prst="rect">
             <a:avLst/>
@@ -6798,6 +10516,45 @@
           </a:bodyPr>
           <a:lstStyle/>
           <a:p>
+            <a:pPr>
+              <a:spcAft>
+                <a:spcPts val="1400"/>
+              </a:spcAft>
+            </a:pPr>
+            <a:r>
+              <a:rPr sz="2800" b="0">
+                <a:solidFill>
+                  <a:srgbClr val="64665D"/>
+                </a:solidFill>
+                <a:latin typeface="DM Sans"/>
+              </a:rPr>
+              <a:t>Headings, lists, links, and code—with plain text underneath.</a:t>
+            </a:r>
+          </a:p>
+        </p:txBody>
+      </p:sp>
+      <p:sp>
+        <p:nvSpPr>
+          <p:cNvPr id="7" name="TextBox 6"/>
+          <p:cNvSpPr txBox="1"/>
+          <p:nvPr/>
+        </p:nvSpPr>
+        <p:spPr>
+          <a:xfrm>
+            <a:off x="822960" y="6263640"/>
+            <a:ext cx="10607040" cy="365760"/>
+          </a:xfrm>
+          <a:prstGeom prst="rect">
+            <a:avLst/>
+          </a:prstGeom>
+          <a:noFill/>
+        </p:spPr>
+        <p:txBody>
+          <a:bodyPr wrap="square">
+            <a:spAutoFit/>
+          </a:bodyPr>
+          <a:lstStyle/>
+          <a:p>
             <a:pPr algn="r">
               <a:spcAft>
                 <a:spcPts val="1400"/>
@@ -6810,7 +10567,7 @@
                 </a:solidFill>
                 <a:latin typeface="DM Sans"/>
               </a:rPr>
-              <a:t>Week 6 · Getting online        7 / 13</a:t>
+              <a:t>Week 6 · Markdown        7 / 26</a:t>
             </a:r>
           </a:p>
         </p:txBody>
@@ -6918,7 +10675,7 @@
                 </a:solidFill>
                 <a:latin typeface="Fraunces"/>
               </a:rPr>
-              <a:t>The short path online</a:t>
+              <a:t>Context: what the AI can actually see</a:t>
             </a:r>
           </a:p>
         </p:txBody>
@@ -6957,7 +10714,7 @@
                 </a:solidFill>
                 <a:latin typeface="DM Sans"/>
               </a:rPr>
-              <a:t>•  GitHub Desktop: create repo → commit → publish.</a:t>
+              <a:t>•  Its answer depends on the messages, files and tool results available now.</a:t>
             </a:r>
           </a:p>
           <a:p>
@@ -6973,7 +10730,7 @@
                 </a:solidFill>
                 <a:latin typeface="DM Sans"/>
               </a:rPr>
-              <a:t>•  GitHub: Settings → Pages → main / root → Save.</a:t>
+              <a:t>•  It does not automatically know your audience, preferences or project history.</a:t>
             </a:r>
           </a:p>
           <a:p>
@@ -6989,7 +10746,7 @@
                 </a:solidFill>
                 <a:latin typeface="DM Sans"/>
               </a:rPr>
-              <a:t>•  Open the published link on another phone.</a:t>
+              <a:t>•  “Improve my site” is weaker than a clear audience, goal and example.</a:t>
             </a:r>
           </a:p>
         </p:txBody>
@@ -7028,7 +10785,7 @@
                 </a:solidFill>
                 <a:latin typeface="DM Sans"/>
               </a:rPr>
-              <a:t>Week 6 · Getting online        8 / 13</a:t>
+              <a:t>Week 6 · Ongoing context        8 / 26</a:t>
             </a:r>
           </a:p>
         </p:txBody>
@@ -7130,13 +10887,13 @@
               </a:spcAft>
             </a:pPr>
             <a:r>
-              <a:rPr sz="4000" b="1">
+              <a:rPr sz="3200" b="1">
                 <a:solidFill>
                   <a:srgbClr val="272A25"/>
                 </a:solidFill>
                 <a:latin typeface="Fraunces"/>
               </a:rPr>
-              <a:t>Next week: your AI reaches your tools</a:t>
+              <a:t>Save project context instead of repeating it</a:t>
             </a:r>
           </a:p>
         </p:txBody>
@@ -7175,7 +10932,7 @@
                 </a:solidFill>
                 <a:latin typeface="DM Sans"/>
               </a:rPr>
-              <a:t>•  API: one program asking another for something.</a:t>
+              <a:t>•  Write down what the project is, who it is for, and what should stay true.</a:t>
             </a:r>
           </a:p>
           <a:p>
@@ -7191,7 +10948,7 @@
                 </a:solidFill>
                 <a:latin typeface="DM Sans"/>
               </a:rPr>
-              <a:t>•  Connector: your AI reaches tools directly, instead of you pasting.</a:t>
+              <a:t>•  Keep it short, correct and editable; update it when the project changes.</a:t>
             </a:r>
           </a:p>
           <a:p>
@@ -7207,7 +10964,7 @@
                 </a:solidFill>
                 <a:latin typeface="DM Sans"/>
               </a:rPr>
-              <a:t>•  This week we copy. Next week we’ll connect.</a:t>
+              <a:t>•  Example: “For nervous first-time visitors. Plain HTML/CSS. Do not invent event dates.”</a:t>
             </a:r>
           </a:p>
         </p:txBody>
@@ -7246,7 +11003,7 @@
                 </a:solidFill>
                 <a:latin typeface="DM Sans"/>
               </a:rPr>
-              <a:t>Week 6 · Looking ahead        9 / 13</a:t>
+              <a:t>Week 6 · Ongoing context        9 / 26</a:t>
             </a:r>
           </a:p>
         </p:txBody>

</xml_diff>

<commit_message>
Keep substantive teaching; move learning-with-AI/reading to end before the one demo
</commit_message>
<xml_diff>
--- a/lessons/week-6/_src/week6-lecture.pptx
+++ b/lessons/week-6/_src/week6-lecture.pptx
@@ -597,7 +597,7 @@
           <a:lstStyle/>
           <a:p>
             <a:r>
-              <a:t>Do not imply any file name works universally. Our tested Claude Code installation also found AGENTS.md, but teach documented primary filenames. A fresh-session question can reveal whether the tool saw the file.</a:t>
+              <a:t>Recent Week 5 work caught non-clickable cards through use. Specific observed behavior gives the agent something testable.</a:t>
             </a:r>
           </a:p>
         </p:txBody>
@@ -667,7 +667,7 @@
           <a:lstStyle/>
           <a:p>
             <a:r>
-              <a:t>Index files are a map, not evidence that the AI read the linked files. Ask it which sources it used.</a:t>
+              <a:t>Do not blindly rewrite the whole app. Before a risky fix, save a working version. Recent students used AI for testing/debugging but still needed to notice what failed.</a:t>
             </a:r>
           </a:p>
         </p:txBody>
@@ -737,7 +737,7 @@
           <a:lstStyle/>
           <a:p>
             <a:r>
-              <a:t>Week 4/5 reflections describe trouble communicating aesthetics; a recent rebuild improved when the student described the feeling instead of only listing features.</a:t>
+              <a:t>A running build is not proof it is correct or useful. This transfers directly to the small-group learning builds.</a:t>
             </a:r>
           </a:p>
         </p:txBody>
@@ -807,7 +807,7 @@
           <a:lstStyle/>
           <a:p>
             <a:r>
-              <a:t>Recent Week 5 work caught non-clickable cards through use. Specific observed behavior gives the agent something testable.</a:t>
+              <a:t>Recent Week 5 submissions described switching tools and running out of credits. Persistent context is a practical continuity aid; do not imply unlimited free usage.</a:t>
             </a:r>
           </a:p>
         </p:txBody>
@@ -877,7 +877,7 @@
           <a:lstStyle/>
           <a:p>
             <a:r>
-              <a:t>Do not blindly rewrite the whole app. Before a risky fix, save a working version. Recent students used AI for testing/debugging but still needed to notice what failed.</a:t>
+              <a:t>A GitHub repo can hold code without having a live website. A folder path cannot be submitted as an accessible build link.</a:t>
             </a:r>
           </a:p>
         </p:txBody>
@@ -947,7 +947,7 @@
           <a:lstStyle/>
           <a:p>
             <a:r>
-              <a:t>A running build is not proof it is correct or useful. This transfers directly to the small-group learning builds.</a:t>
+              <a:t>Use an ordinary change as an example: fix a heading, commit “Clarify heading”, push, wait for deployment, verify the live page.</a:t>
             </a:r>
           </a:p>
         </p:txBody>
@@ -1017,7 +1017,7 @@
           <a:lstStyle/>
           <a:p>
             <a:r>
-              <a:t>Recent Week 5 submissions described switching tools and running out of credits. Persistent context is a practical continuity aid; do not imply unlimited free usage.</a:t>
+              <a:t>Repeated local-link issues in actual submissions. For a public build, check that it does not require your account to open.</a:t>
             </a:r>
           </a:p>
         </p:txBody>
@@ -1087,7 +1087,7 @@
           <a:lstStyle/>
           <a:p>
             <a:r>
-              <a:t>A GitHub repo can hold code without having a live website. A folder path cannot be submitted as an accessible build link.</a:t>
+              <a:t>Recent Week 5 publishing confusion was partly Vercel needing GitHub repo access. Do not prescribe Pages for every framework app; the handout is supplemental detail, not essential to the invitation.</a:t>
             </a:r>
           </a:p>
         </p:txBody>
@@ -1157,7 +1157,7 @@
           <a:lstStyle/>
           <a:p>
             <a:r>
-              <a:t>Use an ordinary change as an example: fix a heading, commit “Clarify heading”, push, wait for deployment, verify the live page.</a:t>
+              <a:t>Example: weather service API returns a forecast; an AI connector calls it for a conversation. Conceptual only: no course server URL, setup or connector demo this week.</a:t>
             </a:r>
           </a:p>
         </p:txBody>
@@ -1227,7 +1227,7 @@
           <a:lstStyle/>
           <a:p>
             <a:r>
-              <a:t>Repeated local-link issues in actual submissions. For a public build, check that it does not require your account to open.</a:t>
+              <a:t>Tools extend what the AI can do, not what it should be allowed to do. Responsibilities remain with the person using it. Four Ds stay implicit.</a:t>
             </a:r>
           </a:p>
         </p:txBody>
@@ -1367,7 +1367,7 @@
           <a:lstStyle/>
           <a:p>
             <a:r>
-              <a:t>Recent Week 5 publishing confusion was partly Vercel needing GitHub repo access. Do not prescribe Pages for every framework app; the handout is supplemental detail, not essential to the invitation.</a:t>
+              <a:t>Students recently asked their tools to explain the tool itself while building. Model this as a learning practice, not outsourcing understanding.</a:t>
             </a:r>
           </a:p>
         </p:txBody>
@@ -1437,7 +1437,7 @@
           <a:lstStyle/>
           <a:p>
             <a:r>
-              <a:t>Example: weather service API returns a forecast; an AI connector calls it for a conversation. Conceptual only: no course server URL, setup or connector demo this week.</a:t>
+              <a:t>Assigned reading. Shipper turned reflection on actual projects into a coaching conversation. The reading link is in students’ accounts; no new due date.</a:t>
             </a:r>
           </a:p>
         </p:txBody>
@@ -1507,7 +1507,7 @@
           <a:lstStyle/>
           <a:p>
             <a:r>
-              <a:t>Tools extend what the AI can do, not what it should be allowed to do. Responsibilities remain with the person using it. Four Ds stay implicit.</a:t>
+              <a:t>Free plans need not have long-term memory. Give a small truthful sample, not every private conversation.</a:t>
             </a:r>
           </a:p>
         </p:txBody>
@@ -1857,7 +1857,7 @@
           <a:lstStyle/>
           <a:p>
             <a:r>
-              <a:t>Students recently asked their tools to explain the tool itself while building. Model this as a learning practice, not outsourcing understanding.</a:t>
+              <a:t>Explain portability: the same text works across tools. A file can be edited without a platform account.</a:t>
             </a:r>
           </a:p>
         </p:txBody>
@@ -1927,7 +1927,7 @@
           <a:lstStyle/>
           <a:p>
             <a:r>
-              <a:t>Assigned reading. Shipper turned reflection on actual projects into a coaching conversation. The reading link is in students’ accounts; no new due date.</a:t>
+              <a:t>Point out # and ## headings; - list; [label](URL) link; backticks for code. These are examples, not a context template.</a:t>
             </a:r>
           </a:p>
         </p:txBody>
@@ -1997,7 +1997,7 @@
           <a:lstStyle/>
           <a:p>
             <a:r>
-              <a:t>Free plans need not have long-term memory. Give a small truthful sample, not every private conversation.</a:t>
+              <a:t>Avoid claiming every app literally starts at zero: some add saved memory or project files. Ask what context the tool loaded.</a:t>
             </a:r>
           </a:p>
         </p:txBody>
@@ -2067,7 +2067,7 @@
           <a:lstStyle/>
           <a:p>
             <a:r>
-              <a:t>Explain portability: the same text works across tools. A file can be edited without a platform account.</a:t>
+              <a:t>These are useful questions, not a rigid template or pair interview. Student projects vary: portfolios, creative work, tools, simulations.</a:t>
             </a:r>
           </a:p>
         </p:txBody>
@@ -2137,7 +2137,7 @@
           <a:lstStyle/>
           <a:p>
             <a:r>
-              <a:t>Point out # and ## headings; - list; [label](URL) link; backticks for code. These are examples, not a context template.</a:t>
+              <a:t>Do not imply any file name works universally. Our tested Claude Code installation also found AGENTS.md, but teach documented primary filenames. A fresh-session question can reveal whether the tool saw the file.</a:t>
             </a:r>
           </a:p>
         </p:txBody>
@@ -2207,7 +2207,7 @@
           <a:lstStyle/>
           <a:p>
             <a:r>
-              <a:t>Avoid claiming every app literally starts at zero: some add saved memory or project files. Ask what context the tool loaded.</a:t>
+              <a:t>Index files are a map, not evidence that the AI read the linked files. Ask it which sources it used.</a:t>
             </a:r>
           </a:p>
         </p:txBody>
@@ -2277,7 +2277,7 @@
           <a:lstStyle/>
           <a:p>
             <a:r>
-              <a:t>These are useful questions, not a rigid template or pair interview. Student projects vary: portfolios, creative work, tools, simulations.</a:t>
+              <a:t>Week 4/5 reflections describe trouble communicating aesthetics; a recent rebuild improved when the student described the feeling instead of only listing features.</a:t>
             </a:r>
           </a:p>
         </p:txBody>
@@ -5368,7 +5368,7 @@
                 </a:solidFill>
                 <a:latin typeface="Fraunces"/>
               </a:rPr>
-              <a:t>Learn with your AI</a:t>
+              <a:t>Context, building, and learning with AI</a:t>
             </a:r>
           </a:p>
           <a:p>
@@ -5547,7 +5547,7 @@
                 </a:solidFill>
                 <a:latin typeface="Fraunces"/>
               </a:rPr>
-              <a:t>Automatic loading is tool-specific</a:t>
+              <a:t>Make your feedback observable</a:t>
             </a:r>
           </a:p>
         </p:txBody>
@@ -5586,7 +5586,7 @@
                 </a:solidFill>
                 <a:latin typeface="DM Sans"/>
               </a:rPr>
-              <a:t>•  Codex uses AGENTS.md; Claude Code uses CLAUDE.md.</a:t>
+              <a:t>•  Give a reference or screenshot; say what to keep and what to change.</a:t>
             </a:r>
           </a:p>
           <a:p>
@@ -5602,7 +5602,7 @@
                 </a:solidFill>
                 <a:latin typeface="DM Sans"/>
               </a:rPr>
-              <a:t>•  Other tools have their own rules and supported filenames—check yours.</a:t>
+              <a:t>•  Instead of “It’s broken”: “Clicking this card should open the project; nothing happens.”</a:t>
             </a:r>
           </a:p>
           <a:p>
@@ -5618,7 +5618,7 @@
                 </a:solidFill>
                 <a:latin typeface="DM Sans"/>
               </a:rPr>
-              <a:t>•  In a chat app, paste the context or add it to a Project; it may not read local files.</a:t>
+              <a:t>•  Ask for one small change, then compare the result with your intention.</a:t>
             </a:r>
           </a:p>
         </p:txBody>
@@ -5657,7 +5657,7 @@
                 </a:solidFill>
                 <a:latin typeface="DM Sans"/>
               </a:rPr>
-              <a:t>Week 6 · Ongoing context        10 / 26</a:t>
+              <a:t>Week 6 · Communicate intent        10 / 26</a:t>
             </a:r>
           </a:p>
         </p:txBody>
@@ -5765,7 +5765,7 @@
                 </a:solidFill>
                 <a:latin typeface="Fraunces"/>
               </a:rPr>
-              <a:t>An index points to deeper context</a:t>
+              <a:t>Debugging: find the mismatch</a:t>
             </a:r>
           </a:p>
         </p:txBody>
@@ -5804,7 +5804,7 @@
                 </a:solidFill>
                 <a:latin typeface="DM Sans"/>
               </a:rPr>
-              <a:t>•  A small index says which files exist and what each is for.</a:t>
+              <a:t>•  A bug is a difference between expected and observed behavior.</a:t>
             </a:r>
           </a:p>
           <a:p>
@@ -5820,7 +5820,7 @@
                 </a:solidFill>
                 <a:latin typeface="DM Sans"/>
               </a:rPr>
-              <a:t>•  Example: docs/facts.md → verified facts; docs/design.md → visual direction.</a:t>
+              <a:t>•  Reproduce it: what exact actions cause it? Capture the error or screenshot.</a:t>
             </a:r>
           </a:p>
           <a:p>
@@ -5836,7 +5836,7 @@
                 </a:solidFill>
                 <a:latin typeface="DM Sans"/>
               </a:rPr>
-              <a:t>•  The AI can open the relevant document instead of receiving one giant prompt.</a:t>
+              <a:t>•  Ask the AI for a cause and a small fix; rerun the same check afterward.</a:t>
             </a:r>
           </a:p>
         </p:txBody>
@@ -5875,7 +5875,7 @@
                 </a:solidFill>
                 <a:latin typeface="DM Sans"/>
               </a:rPr>
-              <a:t>Week 6 · Ongoing context        11 / 26</a:t>
+              <a:t>Week 6 · Check the work        11 / 26</a:t>
             </a:r>
           </a:p>
         </p:txBody>
@@ -5977,13 +5977,13 @@
               </a:spcAft>
             </a:pPr>
             <a:r>
-              <a:rPr sz="3200" b="1">
+              <a:rPr sz="4000" b="1">
                 <a:solidFill>
                   <a:srgbClr val="272A25"/>
                 </a:solidFill>
                 <a:latin typeface="Fraunces"/>
               </a:rPr>
-              <a:t>Describe the design, not just the features</a:t>
+              <a:t>Check the experience—not just the code</a:t>
             </a:r>
           </a:p>
         </p:txBody>
@@ -6022,7 +6022,7 @@
                 </a:solidFill>
                 <a:latin typeface="DM Sans"/>
               </a:rPr>
-              <a:t>•  “Make it better” leaves the visual choices to the model.</a:t>
+              <a:t>•  Open it on a phone. Click every important button and link.</a:t>
             </a:r>
           </a:p>
           <a:p>
@@ -6038,7 +6038,7 @@
                 </a:solidFill>
                 <a:latin typeface="DM Sans"/>
               </a:rPr>
-              <a:t>•  Name the audience, feeling, hierarchy and interactions you want.</a:t>
+              <a:t>•  Try empty input, a strange answer, or a first-time visitor’s path.</a:t>
             </a:r>
           </a:p>
           <a:p>
@@ -6054,7 +6054,7 @@
                 </a:solidFill>
                 <a:latin typeface="DM Sans"/>
               </a:rPr>
-              <a:t>•  Example: “Calm portfolio. Work first, muted colours, clickable project cards.”</a:t>
+              <a:t>•  For a learning tool, check its facts and quiz answers against a trustworthy source.</a:t>
             </a:r>
           </a:p>
         </p:txBody>
@@ -6093,7 +6093,7 @@
                 </a:solidFill>
                 <a:latin typeface="DM Sans"/>
               </a:rPr>
-              <a:t>Week 6 · Communicate intent        12 / 26</a:t>
+              <a:t>Week 6 · Check the work        12 / 26</a:t>
             </a:r>
           </a:p>
         </p:txBody>
@@ -6201,7 +6201,7 @@
                 </a:solidFill>
                 <a:latin typeface="Fraunces"/>
               </a:rPr>
-              <a:t>Make your feedback observable</a:t>
+              <a:t>When free credits run out</a:t>
             </a:r>
           </a:p>
         </p:txBody>
@@ -6240,7 +6240,7 @@
                 </a:solidFill>
                 <a:latin typeface="DM Sans"/>
               </a:rPr>
-              <a:t>•  Give a reference or screenshot; say what to keep and what to change.</a:t>
+              <a:t>•  Save files and a short note: what works, what failed, what to try next.</a:t>
             </a:r>
           </a:p>
           <a:p>
@@ -6256,7 +6256,7 @@
                 </a:solidFill>
                 <a:latin typeface="DM Sans"/>
               </a:rPr>
-              <a:t>•  Instead of “It’s broken”: “Clicking this card should open the project; nothing happens.”</a:t>
+              <a:t>•  Use that note to continue in a fresh session or another tool.</a:t>
             </a:r>
           </a:p>
           <a:p>
@@ -6272,7 +6272,7 @@
                 </a:solidFill>
                 <a:latin typeface="DM Sans"/>
               </a:rPr>
-              <a:t>•  Ask for one small change, then compare the result with your intention.</a:t>
+              <a:t>•  Reduce the request: one change or one explanation at a time.</a:t>
             </a:r>
           </a:p>
         </p:txBody>
@@ -6311,7 +6311,7 @@
                 </a:solidFill>
                 <a:latin typeface="DM Sans"/>
               </a:rPr>
-              <a:t>Week 6 · Communicate intent        13 / 26</a:t>
+              <a:t>Week 6 · Working within limits        13 / 26</a:t>
             </a:r>
           </a:p>
         </p:txBody>
@@ -6413,13 +6413,13 @@
               </a:spcAft>
             </a:pPr>
             <a:r>
-              <a:rPr sz="4000" b="1">
+              <a:rPr sz="3200" b="1">
                 <a:solidFill>
                   <a:srgbClr val="272A25"/>
                 </a:solidFill>
                 <a:latin typeface="Fraunces"/>
               </a:rPr>
-              <a:t>Debugging: find the mismatch</a:t>
+              <a:t>Folder, repository, website: different things</a:t>
             </a:r>
           </a:p>
         </p:txBody>
@@ -6458,7 +6458,7 @@
                 </a:solidFill>
                 <a:latin typeface="DM Sans"/>
               </a:rPr>
-              <a:t>•  A bug is a difference between expected and observed behavior.</a:t>
+              <a:t>•  Local folder: files on your own computer.</a:t>
             </a:r>
           </a:p>
           <a:p>
@@ -6474,7 +6474,7 @@
                 </a:solidFill>
                 <a:latin typeface="DM Sans"/>
               </a:rPr>
-              <a:t>•  Reproduce it: what exact actions cause it? Capture the error or screenshot.</a:t>
+              <a:t>•  Git repository: those files plus a recorded history of versions.</a:t>
             </a:r>
           </a:p>
           <a:p>
@@ -6490,7 +6490,7 @@
                 </a:solidFill>
                 <a:latin typeface="DM Sans"/>
               </a:rPr>
-              <a:t>•  Ask the AI for a cause and a small fix; rerun the same check afterward.</a:t>
+              <a:t>•  Deployment: a published version that other people can open.</a:t>
             </a:r>
           </a:p>
         </p:txBody>
@@ -6529,7 +6529,7 @@
                 </a:solidFill>
                 <a:latin typeface="DM Sans"/>
               </a:rPr>
-              <a:t>Week 6 · Check the work        14 / 26</a:t>
+              <a:t>Week 6 · Getting online        14 / 26</a:t>
             </a:r>
           </a:p>
         </p:txBody>
@@ -6637,7 +6637,7 @@
                 </a:solidFill>
                 <a:latin typeface="Fraunces"/>
               </a:rPr>
-              <a:t>Check the experience—not just the code</a:t>
+              <a:t>Commit, push, deploy: three actions</a:t>
             </a:r>
           </a:p>
         </p:txBody>
@@ -6676,7 +6676,7 @@
                 </a:solidFill>
                 <a:latin typeface="DM Sans"/>
               </a:rPr>
-              <a:t>•  Open it on a phone. Click every important button and link.</a:t>
+              <a:t>•  Commit saves a version and a message in your local Git history.</a:t>
             </a:r>
           </a:p>
           <a:p>
@@ -6692,7 +6692,7 @@
                 </a:solidFill>
                 <a:latin typeface="DM Sans"/>
               </a:rPr>
-              <a:t>•  Try empty input, a strange answer, or a first-time visitor’s path.</a:t>
+              <a:t>•  Push sends your commits to the repository on GitHub.</a:t>
             </a:r>
           </a:p>
           <a:p>
@@ -6708,7 +6708,7 @@
                 </a:solidFill>
                 <a:latin typeface="DM Sans"/>
               </a:rPr>
-              <a:t>•  For a learning tool, check its facts and quiz answers against a trustworthy source.</a:t>
+              <a:t>•  Deploy publishes the project through a host such as GitHub Pages or Vercel.</a:t>
             </a:r>
           </a:p>
         </p:txBody>
@@ -6747,7 +6747,7 @@
                 </a:solidFill>
                 <a:latin typeface="DM Sans"/>
               </a:rPr>
-              <a:t>Week 6 · Check the work        15 / 26</a:t>
+              <a:t>Week 6 · Getting online        15 / 26</a:t>
             </a:r>
           </a:p>
         </p:txBody>
@@ -6849,13 +6849,13 @@
               </a:spcAft>
             </a:pPr>
             <a:r>
-              <a:rPr sz="4000" b="1">
+              <a:rPr sz="3200" b="1">
                 <a:solidFill>
                   <a:srgbClr val="272A25"/>
                 </a:solidFill>
                 <a:latin typeface="Fraunces"/>
               </a:rPr>
-              <a:t>When free credits run out</a:t>
+              <a:t>Your link must work on someone else’s phone</a:t>
             </a:r>
           </a:p>
         </p:txBody>
@@ -6894,7 +6894,7 @@
                 </a:solidFill>
                 <a:latin typeface="DM Sans"/>
               </a:rPr>
-              <a:t>•  Save files and a short note: what works, what failed, what to try next.</a:t>
+              <a:t>•  file:///… and localhost:8000 point to your own computer—not a public site.</a:t>
             </a:r>
           </a:p>
           <a:p>
@@ -6910,7 +6910,7 @@
                 </a:solidFill>
                 <a:latin typeface="DM Sans"/>
               </a:rPr>
-              <a:t>•  Use that note to continue in a fresh session or another tool.</a:t>
+              <a:t>•  A GitHub repository URL shows source; it may not be the live app URL.</a:t>
             </a:r>
           </a:p>
           <a:p>
@@ -6926,7 +6926,7 @@
                 </a:solidFill>
                 <a:latin typeface="DM Sans"/>
               </a:rPr>
-              <a:t>•  Reduce the request: one change or one explanation at a time.</a:t>
+              <a:t>•  Use the deployed HTTPS URL; test it on another device or in a private window.</a:t>
             </a:r>
           </a:p>
         </p:txBody>
@@ -6965,7 +6965,7 @@
                 </a:solidFill>
                 <a:latin typeface="DM Sans"/>
               </a:rPr>
-              <a:t>Week 6 · Working within limits        16 / 26</a:t>
+              <a:t>Week 6 · Getting online        16 / 26</a:t>
             </a:r>
           </a:p>
         </p:txBody>
@@ -7067,13 +7067,13 @@
               </a:spcAft>
             </a:pPr>
             <a:r>
-              <a:rPr sz="3200" b="1">
+              <a:rPr sz="4000" b="1">
                 <a:solidFill>
                   <a:srgbClr val="272A25"/>
                 </a:solidFill>
                 <a:latin typeface="Fraunces"/>
               </a:rPr>
-              <a:t>Folder, repository, website: different things</a:t>
+              <a:t>A practical path to publishing</a:t>
             </a:r>
           </a:p>
         </p:txBody>
@@ -7112,7 +7112,7 @@
                 </a:solidFill>
                 <a:latin typeface="DM Sans"/>
               </a:rPr>
-              <a:t>•  Local folder: files on your own computer.</a:t>
+              <a:t>•  GitHub Desktop: create a repository → commit → publish to GitHub.</a:t>
             </a:r>
           </a:p>
           <a:p>
@@ -7128,7 +7128,7 @@
                 </a:solidFill>
                 <a:latin typeface="DM Sans"/>
               </a:rPr>
-              <a:t>•  Git repository: those files plus a recorded history of versions.</a:t>
+              <a:t>•  Plain HTML/CSS: GitHub Settings → Pages → main branch / root → Save.</a:t>
             </a:r>
           </a:p>
           <a:p>
@@ -7144,7 +7144,7 @@
                 </a:solidFill>
                 <a:latin typeface="DM Sans"/>
               </a:rPr>
-              <a:t>•  Deployment: a published version that other people can open.</a:t>
+              <a:t>•  A framework app may need Vercel: allow repository access, deploy, then test the URL.</a:t>
             </a:r>
           </a:p>
         </p:txBody>
@@ -7285,13 +7285,13 @@
               </a:spcAft>
             </a:pPr>
             <a:r>
-              <a:rPr sz="4000" b="1">
+              <a:rPr sz="3200" b="1">
                 <a:solidFill>
                   <a:srgbClr val="272A25"/>
                 </a:solidFill>
                 <a:latin typeface="Fraunces"/>
               </a:rPr>
-              <a:t>Commit, push, deploy: three actions</a:t>
+              <a:t>API, connector, MCP: what is the difference?</a:t>
             </a:r>
           </a:p>
         </p:txBody>
@@ -7330,7 +7330,7 @@
                 </a:solidFill>
                 <a:latin typeface="DM Sans"/>
               </a:rPr>
-              <a:t>•  Commit saves a version and a message in your local Git history.</a:t>
+              <a:t>•  API: a service’s menu of requests that another program can make.</a:t>
             </a:r>
           </a:p>
           <a:p>
@@ -7346,7 +7346,7 @@
                 </a:solidFill>
                 <a:latin typeface="DM Sans"/>
               </a:rPr>
-              <a:t>•  Push sends your commits to the repository on GitHub.</a:t>
+              <a:t>•  Connector: a bridge that lets your AI reach a service or files.</a:t>
             </a:r>
           </a:p>
           <a:p>
@@ -7362,7 +7362,7 @@
                 </a:solidFill>
                 <a:latin typeface="DM Sans"/>
               </a:rPr>
-              <a:t>•  Deploy publishes the project through a host such as GitHub Pages or Vercel.</a:t>
+              <a:t>•  MCP: a shared protocol for AI apps to use tools; an MCP server may call an API.</a:t>
             </a:r>
           </a:p>
         </p:txBody>
@@ -7401,7 +7401,7 @@
                 </a:solidFill>
                 <a:latin typeface="DM Sans"/>
               </a:rPr>
-              <a:t>Week 6 · Getting online        18 / 26</a:t>
+              <a:t>Week 6 · Connections—concept only        18 / 26</a:t>
             </a:r>
           </a:p>
         </p:txBody>
@@ -7503,13 +7503,13 @@
               </a:spcAft>
             </a:pPr>
             <a:r>
-              <a:rPr sz="3200" b="1">
+              <a:rPr sz="4000" b="1">
                 <a:solidFill>
                   <a:srgbClr val="272A25"/>
                 </a:solidFill>
                 <a:latin typeface="Fraunces"/>
               </a:rPr>
-              <a:t>Your link must work on someone else’s phone</a:t>
+              <a:t>Access is a choice: read versus write</a:t>
             </a:r>
           </a:p>
         </p:txBody>
@@ -7548,7 +7548,7 @@
                 </a:solidFill>
                 <a:latin typeface="DM Sans"/>
               </a:rPr>
-              <a:t>•  file:///… and localhost:8000 point to your own computer—not a public site.</a:t>
+              <a:t>•  Read access can expose data; write access can change or delete it.</a:t>
             </a:r>
           </a:p>
           <a:p>
@@ -7564,7 +7564,7 @@
                 </a:solidFill>
                 <a:latin typeface="DM Sans"/>
               </a:rPr>
-              <a:t>•  A GitHub repository URL shows source; it may not be the live app URL.</a:t>
+              <a:t>•  Give only the access needed; review changes before publishing or sending.</a:t>
             </a:r>
           </a:p>
           <a:p>
@@ -7580,7 +7580,7 @@
                 </a:solidFill>
                 <a:latin typeface="DM Sans"/>
               </a:rPr>
-              <a:t>•  Use the deployed HTTPS URL; test it on another device or in a private window.</a:t>
+              <a:t>•  Keep keys, passwords and private data out of public files and repositories.</a:t>
             </a:r>
           </a:p>
         </p:txBody>
@@ -7619,7 +7619,7 @@
                 </a:solidFill>
                 <a:latin typeface="DM Sans"/>
               </a:rPr>
-              <a:t>Week 6 · Getting online        19 / 26</a:t>
+              <a:t>Week 6 · Connections—concept only        19 / 26</a:t>
             </a:r>
           </a:p>
         </p:txBody>
@@ -7945,7 +7945,7 @@
                 </a:solidFill>
                 <a:latin typeface="Fraunces"/>
               </a:rPr>
-              <a:t>A practical path to publishing</a:t>
+              <a:t>Use AI to learn about AI</a:t>
             </a:r>
           </a:p>
         </p:txBody>
@@ -7984,7 +7984,7 @@
                 </a:solidFill>
                 <a:latin typeface="DM Sans"/>
               </a:rPr>
-              <a:t>•  GitHub Desktop: create a repository → commit → publish to GitHub.</a:t>
+              <a:t>•  Ask for an explanation, an example, and a question to check your understanding.</a:t>
             </a:r>
           </a:p>
           <a:p>
@@ -8000,7 +8000,7 @@
                 </a:solidFill>
                 <a:latin typeface="DM Sans"/>
               </a:rPr>
-              <a:t>•  Plain HTML/CSS: GitHub Settings → Pages → main branch / root → Save.</a:t>
+              <a:t>•  Say what you already know: “I know HTML; Git is new to me.”</a:t>
             </a:r>
           </a:p>
           <a:p>
@@ -8016,7 +8016,7 @@
                 </a:solidFill>
                 <a:latin typeface="DM Sans"/>
               </a:rPr>
-              <a:t>•  A framework app may need Vercel: allow repository access, deploy, then test the URL.</a:t>
+              <a:t>•  Compare its explanation with your source—not just how confident it sounds.</a:t>
             </a:r>
           </a:p>
         </p:txBody>
@@ -8055,7 +8055,7 @@
                 </a:solidFill>
                 <a:latin typeface="DM Sans"/>
               </a:rPr>
-              <a:t>Week 6 · Getting online        20 / 26</a:t>
+              <a:t>Week 6 · Learn with AI        20 / 26</a:t>
             </a:r>
           </a:p>
         </p:txBody>
@@ -8157,13 +8157,13 @@
               </a:spcAft>
             </a:pPr>
             <a:r>
-              <a:rPr sz="3200" b="1">
+              <a:rPr sz="4000" b="1">
                 <a:solidFill>
                   <a:srgbClr val="272A25"/>
                 </a:solidFill>
                 <a:latin typeface="Fraunces"/>
               </a:rPr>
-              <a:t>API, connector, MCP: what is the difference?</a:t>
+              <a:t>The reading: your AI as a coach</a:t>
             </a:r>
           </a:p>
         </p:txBody>
@@ -8202,7 +8202,7 @@
                 </a:solidFill>
                 <a:latin typeface="DM Sans"/>
               </a:rPr>
-              <a:t>•  API: a service’s menu of requests that another program can make.</a:t>
+              <a:t>•  Arielle Shipper · “How to Get Better at AI by Asking AI” · Every</a:t>
             </a:r>
           </a:p>
           <a:p>
@@ -8218,7 +8218,7 @@
                 </a:solidFill>
                 <a:latin typeface="DM Sans"/>
               </a:rPr>
-              <a:t>•  Connector: a bridge that lets your AI reach a service or files.</a:t>
+              <a:t>•  Ask where you are on the Eight Levels of AI Adoption, with evidence from your work.</a:t>
             </a:r>
           </a:p>
           <a:p>
@@ -8234,7 +8234,7 @@
                 </a:solidFill>
                 <a:latin typeface="DM Sans"/>
               </a:rPr>
-              <a:t>•  MCP: a shared protocol for AI apps to use tools; an MCP server may call an API.</a:t>
+              <a:t>•  Ask for one next step, then: “Teach me that and help me practise.”</a:t>
             </a:r>
           </a:p>
         </p:txBody>
@@ -8273,7 +8273,7 @@
                 </a:solidFill>
                 <a:latin typeface="DM Sans"/>
               </a:rPr>
-              <a:t>Week 6 · Connections—concept only        21 / 26</a:t>
+              <a:t>Week 6 · Learn with AI        21 / 26</a:t>
             </a:r>
           </a:p>
         </p:txBody>
@@ -8375,13 +8375,13 @@
               </a:spcAft>
             </a:pPr>
             <a:r>
-              <a:rPr sz="4000" b="1">
+              <a:rPr sz="3200" b="1">
                 <a:solidFill>
                   <a:srgbClr val="272A25"/>
                 </a:solidFill>
                 <a:latin typeface="Fraunces"/>
               </a:rPr>
-              <a:t>Access is a choice: read versus write</a:t>
+              <a:t>No long chat history? Bring your own evidence</a:t>
             </a:r>
           </a:p>
         </p:txBody>
@@ -8420,7 +8420,7 @@
                 </a:solidFill>
                 <a:latin typeface="DM Sans"/>
               </a:rPr>
-              <a:t>•  Read access can expose data; write access can change or delete it.</a:t>
+              <a:t>•  Paste your last two submissions or describe a recent project.</a:t>
             </a:r>
           </a:p>
           <a:p>
@@ -8436,7 +8436,7 @@
                 </a:solidFill>
                 <a:latin typeface="DM Sans"/>
               </a:rPr>
-              <a:t>•  Give only the access needed; review changes before publishing or sending.</a:t>
+              <a:t>•  Ask: “What can I do already? Show examples. What should I learn next?”</a:t>
             </a:r>
           </a:p>
           <a:p>
@@ -8452,7 +8452,7 @@
                 </a:solidFill>
                 <a:latin typeface="DM Sans"/>
               </a:rPr>
-              <a:t>•  Keep keys, passwords and private data out of public files and repositories.</a:t>
+              <a:t>•  Treat the AI’s assessment as a suggestion; correct its assumptions.</a:t>
             </a:r>
           </a:p>
         </p:txBody>
@@ -8491,7 +8491,7 @@
                 </a:solidFill>
                 <a:latin typeface="DM Sans"/>
               </a:rPr>
-              <a:t>Week 6 · Connections—concept only        22 / 26</a:t>
+              <a:t>Week 6 · Learn with AI        22 / 26</a:t>
             </a:r>
           </a:p>
         </p:txBody>
@@ -9471,7 +9471,7 @@
                 </a:solidFill>
                 <a:latin typeface="Fraunces"/>
               </a:rPr>
-              <a:t>Use AI to learn about AI</a:t>
+              <a:t>Markdown: readable, portable text</a:t>
             </a:r>
           </a:p>
         </p:txBody>
@@ -9510,7 +9510,7 @@
                 </a:solidFill>
                 <a:latin typeface="DM Sans"/>
               </a:rPr>
-              <a:t>•  Ask for an explanation, an example, and a question to check your understanding.</a:t>
+              <a:t>•  A .md file is a plain-text file—not a special app or database.</a:t>
             </a:r>
           </a:p>
           <a:p>
@@ -9526,7 +9526,7 @@
                 </a:solidFill>
                 <a:latin typeface="DM Sans"/>
               </a:rPr>
-              <a:t>•  Say what you already know: “I know HTML; Git is new to me.”</a:t>
+              <a:t>•  A little punctuation adds structure: headings, lists, links, code.</a:t>
             </a:r>
           </a:p>
           <a:p>
@@ -9542,7 +9542,7 @@
                 </a:solidFill>
                 <a:latin typeface="DM Sans"/>
               </a:rPr>
-              <a:t>•  Compare its explanation with your source—not just how confident it sounds.</a:t>
+              <a:t>•  Read it in an editor, render it as a page, or paste it into your AI.</a:t>
             </a:r>
           </a:p>
         </p:txBody>
@@ -9581,7 +9581,7 @@
                 </a:solidFill>
                 <a:latin typeface="DM Sans"/>
               </a:rPr>
-              <a:t>Week 6 · Learn with AI        3 / 26</a:t>
+              <a:t>Week 6 · Markdown        3 / 26</a:t>
             </a:r>
           </a:p>
         </p:txBody>
@@ -9689,21 +9689,64 @@
                 </a:solidFill>
                 <a:latin typeface="Fraunces"/>
               </a:rPr>
-              <a:t>The reading: your AI as a coach</a:t>
-            </a:r>
-          </a:p>
-        </p:txBody>
-      </p:sp>
-      <p:sp>
-        <p:nvSpPr>
-          <p:cNvPr id="4" name="TextBox 3"/>
+              <a:t>Markdown you can read and write</a:t>
+            </a:r>
+          </a:p>
+        </p:txBody>
+      </p:sp>
+      <p:sp>
+        <p:nvSpPr>
+          <p:cNvPr id="4" name="Rectangle 3"/>
+          <p:cNvSpPr/>
+          <p:nvPr/>
+        </p:nvSpPr>
+        <p:spPr>
+          <a:xfrm>
+            <a:off x="822960" y="1828800"/>
+            <a:ext cx="6583680" cy="4023360"/>
+          </a:xfrm>
+          <a:prstGeom prst="rect">
+            <a:avLst/>
+          </a:prstGeom>
+          <a:solidFill>
+            <a:srgbClr val="EEECE2"/>
+          </a:solidFill>
+          <a:ln>
+            <a:noFill/>
+          </a:ln>
+        </p:spPr>
+        <p:style>
+          <a:lnRef idx="1">
+            <a:schemeClr val="accent1"/>
+          </a:lnRef>
+          <a:fillRef idx="3">
+            <a:schemeClr val="accent1"/>
+          </a:fillRef>
+          <a:effectRef idx="2">
+            <a:schemeClr val="accent1"/>
+          </a:effectRef>
+          <a:fontRef idx="minor">
+            <a:schemeClr val="lt1"/>
+          </a:fontRef>
+        </p:style>
+        <p:txBody>
+          <a:bodyPr rtlCol="0" anchor="ctr"/>
+          <a:lstStyle/>
+          <a:p>
+            <a:pPr algn="ctr"/>
+          </a:p>
+        </p:txBody>
+      </p:sp>
+      <p:sp>
+        <p:nvSpPr>
+          <p:cNvPr id="5" name="TextBox 4"/>
           <p:cNvSpPr txBox="1"/>
           <p:nvPr/>
         </p:nvSpPr>
         <p:spPr>
           <a:xfrm>
-            <a:off x="822960" y="2011680"/>
-            <a:ext cx="10607040" cy="4206240"/>
+            <a:off x="1097280" y="2011680"/>
+            <a:ext cx="6217920" cy="3749039"/>
           </a:xfrm>
           <a:prstGeom prst="rect">
             <a:avLst/>
@@ -9718,63 +9761,95 @@
           <a:p>
             <a:pPr>
               <a:spcAft>
-                <a:spcPts val="2200"/>
-              </a:spcAft>
-            </a:pPr>
-            <a:r>
-              <a:rPr sz="3000" b="0">
+                <a:spcPts val="200"/>
+              </a:spcAft>
+            </a:pPr>
+            <a:r>
+              <a:rPr sz="1800" b="0">
                 <a:solidFill>
                   <a:srgbClr val="272A25"/>
                 </a:solidFill>
-                <a:latin typeface="DM Sans"/>
-              </a:rPr>
-              <a:t>•  Arielle Shipper · “How to Get Better at AI by Asking AI” · Every</a:t>
+                <a:latin typeface="DejaVu Sans Mono"/>
+              </a:rPr>
+              <a:t># Project notes</a:t>
             </a:r>
           </a:p>
           <a:p>
             <a:pPr>
               <a:spcAft>
-                <a:spcPts val="2200"/>
-              </a:spcAft>
-            </a:pPr>
-            <a:r>
-              <a:rPr sz="3000" b="0">
+                <a:spcPts val="200"/>
+              </a:spcAft>
+            </a:pPr>
+            <a:r>
+              <a:rPr sz="1800" b="0">
                 <a:solidFill>
                   <a:srgbClr val="272A25"/>
                 </a:solidFill>
-                <a:latin typeface="DM Sans"/>
-              </a:rPr>
-              <a:t>•  Ask where you are on the Eight Levels of AI Adoption, with evidence from your work.</a:t>
+                <a:latin typeface="DejaVu Sans Mono"/>
+              </a:rPr>
+              <a:t>## What I want to learn</a:t>
             </a:r>
           </a:p>
           <a:p>
             <a:pPr>
               <a:spcAft>
-                <a:spcPts val="2200"/>
-              </a:spcAft>
-            </a:pPr>
-            <a:r>
-              <a:rPr sz="3000" b="0">
+                <a:spcPts val="200"/>
+              </a:spcAft>
+            </a:pPr>
+            <a:r>
+              <a:rPr sz="1800" b="0">
                 <a:solidFill>
                   <a:srgbClr val="272A25"/>
                 </a:solidFill>
-                <a:latin typeface="DM Sans"/>
-              </a:rPr>
-              <a:t>•  Ask for one next step, then: “Teach me that and help me practise.”</a:t>
-            </a:r>
-          </a:p>
-        </p:txBody>
-      </p:sp>
-      <p:sp>
-        <p:nvSpPr>
-          <p:cNvPr id="5" name="TextBox 4"/>
+                <a:latin typeface="DejaVu Sans Mono"/>
+              </a:rPr>
+              <a:t>- Explain commits before changing files.</a:t>
+            </a:r>
+          </a:p>
+          <a:p>
+            <a:pPr>
+              <a:spcAft>
+                <a:spcPts val="200"/>
+              </a:spcAft>
+            </a:pPr>
+            <a:r>
+              <a:rPr sz="1800" b="0">
+                <a:solidFill>
+                  <a:srgbClr val="272A25"/>
+                </a:solidFill>
+                <a:latin typeface="DejaVu Sans Mono"/>
+              </a:rPr>
+              <a:t>[Course lesson](https://cu.learnvibe.build/lessons/week-6/)</a:t>
+            </a:r>
+          </a:p>
+          <a:p>
+            <a:pPr>
+              <a:spcAft>
+                <a:spcPts val="200"/>
+              </a:spcAft>
+            </a:pPr>
+            <a:r>
+              <a:rPr sz="1800" b="0">
+                <a:solidFill>
+                  <a:srgbClr val="272A25"/>
+                </a:solidFill>
+                <a:latin typeface="DejaVu Sans Mono"/>
+              </a:rPr>
+              <a:t>Use `git status` to see what changed.</a:t>
+            </a:r>
+          </a:p>
+        </p:txBody>
+      </p:sp>
+      <p:sp>
+        <p:nvSpPr>
+          <p:cNvPr id="6" name="TextBox 5"/>
           <p:cNvSpPr txBox="1"/>
           <p:nvPr/>
         </p:nvSpPr>
         <p:spPr>
           <a:xfrm>
-            <a:off x="822960" y="6263640"/>
-            <a:ext cx="10607040" cy="365760"/>
+            <a:off x="7772400" y="3108960"/>
+            <a:ext cx="3931920" cy="1828800"/>
           </a:xfrm>
           <a:prstGeom prst="rect">
             <a:avLst/>
@@ -9787,6 +9862,45 @@
           </a:bodyPr>
           <a:lstStyle/>
           <a:p>
+            <a:pPr>
+              <a:spcAft>
+                <a:spcPts val="1400"/>
+              </a:spcAft>
+            </a:pPr>
+            <a:r>
+              <a:rPr sz="2800" b="0">
+                <a:solidFill>
+                  <a:srgbClr val="64665D"/>
+                </a:solidFill>
+                <a:latin typeface="DM Sans"/>
+              </a:rPr>
+              <a:t>Headings, lists, links, and code—with plain text underneath.</a:t>
+            </a:r>
+          </a:p>
+        </p:txBody>
+      </p:sp>
+      <p:sp>
+        <p:nvSpPr>
+          <p:cNvPr id="7" name="TextBox 6"/>
+          <p:cNvSpPr txBox="1"/>
+          <p:nvPr/>
+        </p:nvSpPr>
+        <p:spPr>
+          <a:xfrm>
+            <a:off x="822960" y="6263640"/>
+            <a:ext cx="10607040" cy="365760"/>
+          </a:xfrm>
+          <a:prstGeom prst="rect">
+            <a:avLst/>
+          </a:prstGeom>
+          <a:noFill/>
+        </p:spPr>
+        <p:txBody>
+          <a:bodyPr wrap="square">
+            <a:spAutoFit/>
+          </a:bodyPr>
+          <a:lstStyle/>
+          <a:p>
             <a:pPr algn="r">
               <a:spcAft>
                 <a:spcPts val="1400"/>
@@ -9799,7 +9913,7 @@
                 </a:solidFill>
                 <a:latin typeface="DM Sans"/>
               </a:rPr>
-              <a:t>Week 6 · Learn with AI        4 / 26</a:t>
+              <a:t>Week 6 · Markdown        4 / 26</a:t>
             </a:r>
           </a:p>
         </p:txBody>
@@ -9901,13 +10015,13 @@
               </a:spcAft>
             </a:pPr>
             <a:r>
-              <a:rPr sz="3200" b="1">
+              <a:rPr sz="4000" b="1">
                 <a:solidFill>
                   <a:srgbClr val="272A25"/>
                 </a:solidFill>
                 <a:latin typeface="Fraunces"/>
               </a:rPr>
-              <a:t>No long chat history? Bring your own evidence</a:t>
+              <a:t>Context: what the AI can actually see</a:t>
             </a:r>
           </a:p>
         </p:txBody>
@@ -9946,7 +10060,7 @@
                 </a:solidFill>
                 <a:latin typeface="DM Sans"/>
               </a:rPr>
-              <a:t>•  Paste your last two submissions or describe a recent project.</a:t>
+              <a:t>•  Its answer depends on the messages, files and tool results available now.</a:t>
             </a:r>
           </a:p>
           <a:p>
@@ -9962,7 +10076,7 @@
                 </a:solidFill>
                 <a:latin typeface="DM Sans"/>
               </a:rPr>
-              <a:t>•  Ask: “What can I do already? Show examples. What should I learn next?”</a:t>
+              <a:t>•  It does not automatically know your audience, preferences or project history.</a:t>
             </a:r>
           </a:p>
           <a:p>
@@ -9978,7 +10092,7 @@
                 </a:solidFill>
                 <a:latin typeface="DM Sans"/>
               </a:rPr>
-              <a:t>•  Treat the AI’s assessment as a suggestion; correct its assumptions.</a:t>
+              <a:t>•  “Improve my site” is weaker than a clear audience, goal and example.</a:t>
             </a:r>
           </a:p>
         </p:txBody>
@@ -10017,7 +10131,7 @@
                 </a:solidFill>
                 <a:latin typeface="DM Sans"/>
               </a:rPr>
-              <a:t>Week 6 · Learn with AI        5 / 26</a:t>
+              <a:t>Week 6 · Ongoing context        5 / 26</a:t>
             </a:r>
           </a:p>
         </p:txBody>
@@ -10119,13 +10233,13 @@
               </a:spcAft>
             </a:pPr>
             <a:r>
-              <a:rPr sz="4000" b="1">
+              <a:rPr sz="3200" b="1">
                 <a:solidFill>
                   <a:srgbClr val="272A25"/>
                 </a:solidFill>
                 <a:latin typeface="Fraunces"/>
               </a:rPr>
-              <a:t>Markdown: readable, portable text</a:t>
+              <a:t>Save project context instead of repeating it</a:t>
             </a:r>
           </a:p>
         </p:txBody>
@@ -10164,7 +10278,7 @@
                 </a:solidFill>
                 <a:latin typeface="DM Sans"/>
               </a:rPr>
-              <a:t>•  A .md file is a plain-text file—not a special app or database.</a:t>
+              <a:t>•  Write down what the project is, who it is for, and what should stay true.</a:t>
             </a:r>
           </a:p>
           <a:p>
@@ -10180,7 +10294,7 @@
                 </a:solidFill>
                 <a:latin typeface="DM Sans"/>
               </a:rPr>
-              <a:t>•  A little punctuation adds structure: headings, lists, links, code.</a:t>
+              <a:t>•  Keep it short, correct and editable; update it when the project changes.</a:t>
             </a:r>
           </a:p>
           <a:p>
@@ -10196,7 +10310,7 @@
                 </a:solidFill>
                 <a:latin typeface="DM Sans"/>
               </a:rPr>
-              <a:t>•  Read it in an editor, render it as a page, or paste it into your AI.</a:t>
+              <a:t>•  Example: “For nervous first-time visitors. Plain HTML/CSS. Do not invent event dates.”</a:t>
             </a:r>
           </a:p>
         </p:txBody>
@@ -10235,7 +10349,7 @@
                 </a:solidFill>
                 <a:latin typeface="DM Sans"/>
               </a:rPr>
-              <a:t>Week 6 · Markdown        6 / 26</a:t>
+              <a:t>Week 6 · Ongoing context        6 / 26</a:t>
             </a:r>
           </a:p>
         </p:txBody>
@@ -10343,64 +10457,21 @@
                 </a:solidFill>
                 <a:latin typeface="Fraunces"/>
               </a:rPr>
-              <a:t>Markdown you can read and write</a:t>
-            </a:r>
-          </a:p>
-        </p:txBody>
-      </p:sp>
-      <p:sp>
-        <p:nvSpPr>
-          <p:cNvPr id="4" name="Rectangle 3"/>
-          <p:cNvSpPr/>
-          <p:nvPr/>
-        </p:nvSpPr>
-        <p:spPr>
-          <a:xfrm>
-            <a:off x="822960" y="1828800"/>
-            <a:ext cx="6583680" cy="4023360"/>
-          </a:xfrm>
-          <a:prstGeom prst="rect">
-            <a:avLst/>
-          </a:prstGeom>
-          <a:solidFill>
-            <a:srgbClr val="EEECE2"/>
-          </a:solidFill>
-          <a:ln>
-            <a:noFill/>
-          </a:ln>
-        </p:spPr>
-        <p:style>
-          <a:lnRef idx="1">
-            <a:schemeClr val="accent1"/>
-          </a:lnRef>
-          <a:fillRef idx="3">
-            <a:schemeClr val="accent1"/>
-          </a:fillRef>
-          <a:effectRef idx="2">
-            <a:schemeClr val="accent1"/>
-          </a:effectRef>
-          <a:fontRef idx="minor">
-            <a:schemeClr val="lt1"/>
-          </a:fontRef>
-        </p:style>
-        <p:txBody>
-          <a:bodyPr rtlCol="0" anchor="ctr"/>
-          <a:lstStyle/>
-          <a:p>
-            <a:pPr algn="ctr"/>
-          </a:p>
-        </p:txBody>
-      </p:sp>
-      <p:sp>
-        <p:nvSpPr>
-          <p:cNvPr id="5" name="TextBox 4"/>
+              <a:t>Automatic loading is tool-specific</a:t>
+            </a:r>
+          </a:p>
+        </p:txBody>
+      </p:sp>
+      <p:sp>
+        <p:nvSpPr>
+          <p:cNvPr id="4" name="TextBox 3"/>
           <p:cNvSpPr txBox="1"/>
           <p:nvPr/>
         </p:nvSpPr>
         <p:spPr>
           <a:xfrm>
-            <a:off x="1097280" y="2011680"/>
-            <a:ext cx="6217920" cy="3749039"/>
+            <a:off x="822960" y="2011680"/>
+            <a:ext cx="10607040" cy="4206240"/>
           </a:xfrm>
           <a:prstGeom prst="rect">
             <a:avLst/>
@@ -10415,95 +10486,63 @@
           <a:p>
             <a:pPr>
               <a:spcAft>
-                <a:spcPts val="200"/>
-              </a:spcAft>
-            </a:pPr>
-            <a:r>
-              <a:rPr sz="1800" b="0">
+                <a:spcPts val="2200"/>
+              </a:spcAft>
+            </a:pPr>
+            <a:r>
+              <a:rPr sz="3000" b="0">
                 <a:solidFill>
                   <a:srgbClr val="272A25"/>
                 </a:solidFill>
-                <a:latin typeface="DejaVu Sans Mono"/>
-              </a:rPr>
-              <a:t># Project notes</a:t>
+                <a:latin typeface="DM Sans"/>
+              </a:rPr>
+              <a:t>•  Codex uses AGENTS.md; Claude Code uses CLAUDE.md.</a:t>
             </a:r>
           </a:p>
           <a:p>
             <a:pPr>
               <a:spcAft>
-                <a:spcPts val="200"/>
-              </a:spcAft>
-            </a:pPr>
-            <a:r>
-              <a:rPr sz="1800" b="0">
+                <a:spcPts val="2200"/>
+              </a:spcAft>
+            </a:pPr>
+            <a:r>
+              <a:rPr sz="3000" b="0">
                 <a:solidFill>
                   <a:srgbClr val="272A25"/>
                 </a:solidFill>
-                <a:latin typeface="DejaVu Sans Mono"/>
-              </a:rPr>
-              <a:t>## What I want to learn</a:t>
+                <a:latin typeface="DM Sans"/>
+              </a:rPr>
+              <a:t>•  Other tools have their own rules and supported filenames—check yours.</a:t>
             </a:r>
           </a:p>
           <a:p>
             <a:pPr>
               <a:spcAft>
-                <a:spcPts val="200"/>
-              </a:spcAft>
-            </a:pPr>
-            <a:r>
-              <a:rPr sz="1800" b="0">
+                <a:spcPts val="2200"/>
+              </a:spcAft>
+            </a:pPr>
+            <a:r>
+              <a:rPr sz="3000" b="0">
                 <a:solidFill>
                   <a:srgbClr val="272A25"/>
                 </a:solidFill>
-                <a:latin typeface="DejaVu Sans Mono"/>
-              </a:rPr>
-              <a:t>- Explain commits before changing files.</a:t>
-            </a:r>
-          </a:p>
-          <a:p>
-            <a:pPr>
-              <a:spcAft>
-                <a:spcPts val="200"/>
-              </a:spcAft>
-            </a:pPr>
-            <a:r>
-              <a:rPr sz="1800" b="0">
-                <a:solidFill>
-                  <a:srgbClr val="272A25"/>
-                </a:solidFill>
-                <a:latin typeface="DejaVu Sans Mono"/>
-              </a:rPr>
-              <a:t>[Course lesson](https://cu.learnvibe.build/lessons/week-6/)</a:t>
-            </a:r>
-          </a:p>
-          <a:p>
-            <a:pPr>
-              <a:spcAft>
-                <a:spcPts val="200"/>
-              </a:spcAft>
-            </a:pPr>
-            <a:r>
-              <a:rPr sz="1800" b="0">
-                <a:solidFill>
-                  <a:srgbClr val="272A25"/>
-                </a:solidFill>
-                <a:latin typeface="DejaVu Sans Mono"/>
-              </a:rPr>
-              <a:t>Use `git status` to see what changed.</a:t>
-            </a:r>
-          </a:p>
-        </p:txBody>
-      </p:sp>
-      <p:sp>
-        <p:nvSpPr>
-          <p:cNvPr id="6" name="TextBox 5"/>
+                <a:latin typeface="DM Sans"/>
+              </a:rPr>
+              <a:t>•  In a chat app, paste the context or add it to a Project; it may not read local files.</a:t>
+            </a:r>
+          </a:p>
+        </p:txBody>
+      </p:sp>
+      <p:sp>
+        <p:nvSpPr>
+          <p:cNvPr id="5" name="TextBox 4"/>
           <p:cNvSpPr txBox="1"/>
           <p:nvPr/>
         </p:nvSpPr>
         <p:spPr>
           <a:xfrm>
-            <a:off x="7772400" y="3108960"/>
-            <a:ext cx="3931920" cy="1828800"/>
+            <a:off x="822960" y="6263640"/>
+            <a:ext cx="10607040" cy="365760"/>
           </a:xfrm>
           <a:prstGeom prst="rect">
             <a:avLst/>
@@ -10516,58 +10555,19 @@
           </a:bodyPr>
           <a:lstStyle/>
           <a:p>
-            <a:pPr>
+            <a:pPr algn="r">
               <a:spcAft>
                 <a:spcPts val="1400"/>
               </a:spcAft>
             </a:pPr>
             <a:r>
-              <a:rPr sz="2800" b="0">
+              <a:rPr sz="1600" b="0">
                 <a:solidFill>
                   <a:srgbClr val="64665D"/>
                 </a:solidFill>
                 <a:latin typeface="DM Sans"/>
               </a:rPr>
-              <a:t>Headings, lists, links, and code—with plain text underneath.</a:t>
-            </a:r>
-          </a:p>
-        </p:txBody>
-      </p:sp>
-      <p:sp>
-        <p:nvSpPr>
-          <p:cNvPr id="7" name="TextBox 6"/>
-          <p:cNvSpPr txBox="1"/>
-          <p:nvPr/>
-        </p:nvSpPr>
-        <p:spPr>
-          <a:xfrm>
-            <a:off x="822960" y="6263640"/>
-            <a:ext cx="10607040" cy="365760"/>
-          </a:xfrm>
-          <a:prstGeom prst="rect">
-            <a:avLst/>
-          </a:prstGeom>
-          <a:noFill/>
-        </p:spPr>
-        <p:txBody>
-          <a:bodyPr wrap="square">
-            <a:spAutoFit/>
-          </a:bodyPr>
-          <a:lstStyle/>
-          <a:p>
-            <a:pPr algn="r">
-              <a:spcAft>
-                <a:spcPts val="1400"/>
-              </a:spcAft>
-            </a:pPr>
-            <a:r>
-              <a:rPr sz="1600" b="0">
-                <a:solidFill>
-                  <a:srgbClr val="64665D"/>
-                </a:solidFill>
-                <a:latin typeface="DM Sans"/>
-              </a:rPr>
-              <a:t>Week 6 · Markdown        7 / 26</a:t>
+              <a:t>Week 6 · Ongoing context        7 / 26</a:t>
             </a:r>
           </a:p>
         </p:txBody>
@@ -10675,7 +10675,7 @@
                 </a:solidFill>
                 <a:latin typeface="Fraunces"/>
               </a:rPr>
-              <a:t>Context: what the AI can actually see</a:t>
+              <a:t>An index points to deeper context</a:t>
             </a:r>
           </a:p>
         </p:txBody>
@@ -10714,7 +10714,7 @@
                 </a:solidFill>
                 <a:latin typeface="DM Sans"/>
               </a:rPr>
-              <a:t>•  Its answer depends on the messages, files and tool results available now.</a:t>
+              <a:t>•  A small index says which files exist and what each is for.</a:t>
             </a:r>
           </a:p>
           <a:p>
@@ -10730,7 +10730,7 @@
                 </a:solidFill>
                 <a:latin typeface="DM Sans"/>
               </a:rPr>
-              <a:t>•  It does not automatically know your audience, preferences or project history.</a:t>
+              <a:t>•  Example: docs/facts.md → verified facts; docs/design.md → visual direction.</a:t>
             </a:r>
           </a:p>
           <a:p>
@@ -10746,7 +10746,7 @@
                 </a:solidFill>
                 <a:latin typeface="DM Sans"/>
               </a:rPr>
-              <a:t>•  “Improve my site” is weaker than a clear audience, goal and example.</a:t>
+              <a:t>•  The AI can open the relevant document instead of receiving one giant prompt.</a:t>
             </a:r>
           </a:p>
         </p:txBody>
@@ -10893,7 +10893,7 @@
                 </a:solidFill>
                 <a:latin typeface="Fraunces"/>
               </a:rPr>
-              <a:t>Save project context instead of repeating it</a:t>
+              <a:t>Describe the design, not just the features</a:t>
             </a:r>
           </a:p>
         </p:txBody>
@@ -10932,7 +10932,7 @@
                 </a:solidFill>
                 <a:latin typeface="DM Sans"/>
               </a:rPr>
-              <a:t>•  Write down what the project is, who it is for, and what should stay true.</a:t>
+              <a:t>•  “Make it better” leaves the visual choices to the model.</a:t>
             </a:r>
           </a:p>
           <a:p>
@@ -10948,7 +10948,7 @@
                 </a:solidFill>
                 <a:latin typeface="DM Sans"/>
               </a:rPr>
-              <a:t>•  Keep it short, correct and editable; update it when the project changes.</a:t>
+              <a:t>•  Name the audience, feeling, hierarchy and interactions you want.</a:t>
             </a:r>
           </a:p>
           <a:p>
@@ -10964,7 +10964,7 @@
                 </a:solidFill>
                 <a:latin typeface="DM Sans"/>
               </a:rPr>
-              <a:t>•  Example: “For nervous first-time visitors. Plain HTML/CSS. Do not invent event dates.”</a:t>
+              <a:t>•  Example: “Calm portfolio. Work first, muted colours, clickable project cards.”</a:t>
             </a:r>
           </a:p>
         </p:txBody>
@@ -11003,7 +11003,7 @@
                 </a:solidFill>
                 <a:latin typeface="DM Sans"/>
               </a:rPr>
-              <a:t>Week 6 · Ongoing context        9 / 26</a:t>
+              <a:t>Week 6 · Communicate intent        9 / 26</a:t>
             </a:r>
           </a:p>
         </p:txBody>

</xml_diff>

<commit_message>
Keep substantive teaching; move learning-with-AI/reading to end before the one demo (#12)
Co-authored-by: unforcedagi <agi@unforced.dev>
</commit_message>
<xml_diff>
--- a/lessons/week-6/_src/week6-lecture.pptx
+++ b/lessons/week-6/_src/week6-lecture.pptx
@@ -597,7 +597,7 @@
           <a:lstStyle/>
           <a:p>
             <a:r>
-              <a:t>Do not imply any file name works universally. Our tested Claude Code installation also found AGENTS.md, but teach documented primary filenames. A fresh-session question can reveal whether the tool saw the file.</a:t>
+              <a:t>Recent Week 5 work caught non-clickable cards through use. Specific observed behavior gives the agent something testable.</a:t>
             </a:r>
           </a:p>
         </p:txBody>
@@ -667,7 +667,7 @@
           <a:lstStyle/>
           <a:p>
             <a:r>
-              <a:t>Index files are a map, not evidence that the AI read the linked files. Ask it which sources it used.</a:t>
+              <a:t>Do not blindly rewrite the whole app. Before a risky fix, save a working version. Recent students used AI for testing/debugging but still needed to notice what failed.</a:t>
             </a:r>
           </a:p>
         </p:txBody>
@@ -737,7 +737,7 @@
           <a:lstStyle/>
           <a:p>
             <a:r>
-              <a:t>Week 4/5 reflections describe trouble communicating aesthetics; a recent rebuild improved when the student described the feeling instead of only listing features.</a:t>
+              <a:t>A running build is not proof it is correct or useful. This transfers directly to the small-group learning builds.</a:t>
             </a:r>
           </a:p>
         </p:txBody>
@@ -807,7 +807,7 @@
           <a:lstStyle/>
           <a:p>
             <a:r>
-              <a:t>Recent Week 5 work caught non-clickable cards through use. Specific observed behavior gives the agent something testable.</a:t>
+              <a:t>Recent Week 5 submissions described switching tools and running out of credits. Persistent context is a practical continuity aid; do not imply unlimited free usage.</a:t>
             </a:r>
           </a:p>
         </p:txBody>
@@ -877,7 +877,7 @@
           <a:lstStyle/>
           <a:p>
             <a:r>
-              <a:t>Do not blindly rewrite the whole app. Before a risky fix, save a working version. Recent students used AI for testing/debugging but still needed to notice what failed.</a:t>
+              <a:t>A GitHub repo can hold code without having a live website. A folder path cannot be submitted as an accessible build link.</a:t>
             </a:r>
           </a:p>
         </p:txBody>
@@ -947,7 +947,7 @@
           <a:lstStyle/>
           <a:p>
             <a:r>
-              <a:t>A running build is not proof it is correct or useful. This transfers directly to the small-group learning builds.</a:t>
+              <a:t>Use an ordinary change as an example: fix a heading, commit “Clarify heading”, push, wait for deployment, verify the live page.</a:t>
             </a:r>
           </a:p>
         </p:txBody>
@@ -1017,7 +1017,7 @@
           <a:lstStyle/>
           <a:p>
             <a:r>
-              <a:t>Recent Week 5 submissions described switching tools and running out of credits. Persistent context is a practical continuity aid; do not imply unlimited free usage.</a:t>
+              <a:t>Repeated local-link issues in actual submissions. For a public build, check that it does not require your account to open.</a:t>
             </a:r>
           </a:p>
         </p:txBody>
@@ -1087,7 +1087,7 @@
           <a:lstStyle/>
           <a:p>
             <a:r>
-              <a:t>A GitHub repo can hold code without having a live website. A folder path cannot be submitted as an accessible build link.</a:t>
+              <a:t>Recent Week 5 publishing confusion was partly Vercel needing GitHub repo access. Do not prescribe Pages for every framework app; the handout is supplemental detail, not essential to the invitation.</a:t>
             </a:r>
           </a:p>
         </p:txBody>
@@ -1157,7 +1157,7 @@
           <a:lstStyle/>
           <a:p>
             <a:r>
-              <a:t>Use an ordinary change as an example: fix a heading, commit “Clarify heading”, push, wait for deployment, verify the live page.</a:t>
+              <a:t>Example: weather service API returns a forecast; an AI connector calls it for a conversation. Conceptual only: no course server URL, setup or connector demo this week.</a:t>
             </a:r>
           </a:p>
         </p:txBody>
@@ -1227,7 +1227,7 @@
           <a:lstStyle/>
           <a:p>
             <a:r>
-              <a:t>Repeated local-link issues in actual submissions. For a public build, check that it does not require your account to open.</a:t>
+              <a:t>Tools extend what the AI can do, not what it should be allowed to do. Responsibilities remain with the person using it. Four Ds stay implicit.</a:t>
             </a:r>
           </a:p>
         </p:txBody>
@@ -1367,7 +1367,7 @@
           <a:lstStyle/>
           <a:p>
             <a:r>
-              <a:t>Recent Week 5 publishing confusion was partly Vercel needing GitHub repo access. Do not prescribe Pages for every framework app; the handout is supplemental detail, not essential to the invitation.</a:t>
+              <a:t>Students recently asked their tools to explain the tool itself while building. Model this as a learning practice, not outsourcing understanding.</a:t>
             </a:r>
           </a:p>
         </p:txBody>
@@ -1437,7 +1437,7 @@
           <a:lstStyle/>
           <a:p>
             <a:r>
-              <a:t>Example: weather service API returns a forecast; an AI connector calls it for a conversation. Conceptual only: no course server URL, setup or connector demo this week.</a:t>
+              <a:t>Assigned reading. Shipper turned reflection on actual projects into a coaching conversation. The reading link is in students’ accounts; no new due date.</a:t>
             </a:r>
           </a:p>
         </p:txBody>
@@ -1507,7 +1507,7 @@
           <a:lstStyle/>
           <a:p>
             <a:r>
-              <a:t>Tools extend what the AI can do, not what it should be allowed to do. Responsibilities remain with the person using it. Four Ds stay implicit.</a:t>
+              <a:t>Free plans need not have long-term memory. Give a small truthful sample, not every private conversation.</a:t>
             </a:r>
           </a:p>
         </p:txBody>
@@ -1857,7 +1857,7 @@
           <a:lstStyle/>
           <a:p>
             <a:r>
-              <a:t>Students recently asked their tools to explain the tool itself while building. Model this as a learning practice, not outsourcing understanding.</a:t>
+              <a:t>Explain portability: the same text works across tools. A file can be edited without a platform account.</a:t>
             </a:r>
           </a:p>
         </p:txBody>
@@ -1927,7 +1927,7 @@
           <a:lstStyle/>
           <a:p>
             <a:r>
-              <a:t>Assigned reading. Shipper turned reflection on actual projects into a coaching conversation. The reading link is in students’ accounts; no new due date.</a:t>
+              <a:t>Point out # and ## headings; - list; [label](URL) link; backticks for code. These are examples, not a context template.</a:t>
             </a:r>
           </a:p>
         </p:txBody>
@@ -1997,7 +1997,7 @@
           <a:lstStyle/>
           <a:p>
             <a:r>
-              <a:t>Free plans need not have long-term memory. Give a small truthful sample, not every private conversation.</a:t>
+              <a:t>Avoid claiming every app literally starts at zero: some add saved memory or project files. Ask what context the tool loaded.</a:t>
             </a:r>
           </a:p>
         </p:txBody>
@@ -2067,7 +2067,7 @@
           <a:lstStyle/>
           <a:p>
             <a:r>
-              <a:t>Explain portability: the same text works across tools. A file can be edited without a platform account.</a:t>
+              <a:t>These are useful questions, not a rigid template or pair interview. Student projects vary: portfolios, creative work, tools, simulations.</a:t>
             </a:r>
           </a:p>
         </p:txBody>
@@ -2137,7 +2137,7 @@
           <a:lstStyle/>
           <a:p>
             <a:r>
-              <a:t>Point out # and ## headings; - list; [label](URL) link; backticks for code. These are examples, not a context template.</a:t>
+              <a:t>Do not imply any file name works universally. Our tested Claude Code installation also found AGENTS.md, but teach documented primary filenames. A fresh-session question can reveal whether the tool saw the file.</a:t>
             </a:r>
           </a:p>
         </p:txBody>
@@ -2207,7 +2207,7 @@
           <a:lstStyle/>
           <a:p>
             <a:r>
-              <a:t>Avoid claiming every app literally starts at zero: some add saved memory or project files. Ask what context the tool loaded.</a:t>
+              <a:t>Index files are a map, not evidence that the AI read the linked files. Ask it which sources it used.</a:t>
             </a:r>
           </a:p>
         </p:txBody>
@@ -2277,7 +2277,7 @@
           <a:lstStyle/>
           <a:p>
             <a:r>
-              <a:t>These are useful questions, not a rigid template or pair interview. Student projects vary: portfolios, creative work, tools, simulations.</a:t>
+              <a:t>Week 4/5 reflections describe trouble communicating aesthetics; a recent rebuild improved when the student described the feeling instead of only listing features.</a:t>
             </a:r>
           </a:p>
         </p:txBody>
@@ -5368,7 +5368,7 @@
                 </a:solidFill>
                 <a:latin typeface="Fraunces"/>
               </a:rPr>
-              <a:t>Learn with your AI</a:t>
+              <a:t>Context, building, and learning with AI</a:t>
             </a:r>
           </a:p>
           <a:p>
@@ -5547,7 +5547,7 @@
                 </a:solidFill>
                 <a:latin typeface="Fraunces"/>
               </a:rPr>
-              <a:t>Automatic loading is tool-specific</a:t>
+              <a:t>Make your feedback observable</a:t>
             </a:r>
           </a:p>
         </p:txBody>
@@ -5586,7 +5586,7 @@
                 </a:solidFill>
                 <a:latin typeface="DM Sans"/>
               </a:rPr>
-              <a:t>•  Codex uses AGENTS.md; Claude Code uses CLAUDE.md.</a:t>
+              <a:t>•  Give a reference or screenshot; say what to keep and what to change.</a:t>
             </a:r>
           </a:p>
           <a:p>
@@ -5602,7 +5602,7 @@
                 </a:solidFill>
                 <a:latin typeface="DM Sans"/>
               </a:rPr>
-              <a:t>•  Other tools have their own rules and supported filenames—check yours.</a:t>
+              <a:t>•  Instead of “It’s broken”: “Clicking this card should open the project; nothing happens.”</a:t>
             </a:r>
           </a:p>
           <a:p>
@@ -5618,7 +5618,7 @@
                 </a:solidFill>
                 <a:latin typeface="DM Sans"/>
               </a:rPr>
-              <a:t>•  In a chat app, paste the context or add it to a Project; it may not read local files.</a:t>
+              <a:t>•  Ask for one small change, then compare the result with your intention.</a:t>
             </a:r>
           </a:p>
         </p:txBody>
@@ -5657,7 +5657,7 @@
                 </a:solidFill>
                 <a:latin typeface="DM Sans"/>
               </a:rPr>
-              <a:t>Week 6 · Ongoing context        10 / 26</a:t>
+              <a:t>Week 6 · Communicate intent        10 / 26</a:t>
             </a:r>
           </a:p>
         </p:txBody>
@@ -5765,7 +5765,7 @@
                 </a:solidFill>
                 <a:latin typeface="Fraunces"/>
               </a:rPr>
-              <a:t>An index points to deeper context</a:t>
+              <a:t>Debugging: find the mismatch</a:t>
             </a:r>
           </a:p>
         </p:txBody>
@@ -5804,7 +5804,7 @@
                 </a:solidFill>
                 <a:latin typeface="DM Sans"/>
               </a:rPr>
-              <a:t>•  A small index says which files exist and what each is for.</a:t>
+              <a:t>•  A bug is a difference between expected and observed behavior.</a:t>
             </a:r>
           </a:p>
           <a:p>
@@ -5820,7 +5820,7 @@
                 </a:solidFill>
                 <a:latin typeface="DM Sans"/>
               </a:rPr>
-              <a:t>•  Example: docs/facts.md → verified facts; docs/design.md → visual direction.</a:t>
+              <a:t>•  Reproduce it: what exact actions cause it? Capture the error or screenshot.</a:t>
             </a:r>
           </a:p>
           <a:p>
@@ -5836,7 +5836,7 @@
                 </a:solidFill>
                 <a:latin typeface="DM Sans"/>
               </a:rPr>
-              <a:t>•  The AI can open the relevant document instead of receiving one giant prompt.</a:t>
+              <a:t>•  Ask the AI for a cause and a small fix; rerun the same check afterward.</a:t>
             </a:r>
           </a:p>
         </p:txBody>
@@ -5875,7 +5875,7 @@
                 </a:solidFill>
                 <a:latin typeface="DM Sans"/>
               </a:rPr>
-              <a:t>Week 6 · Ongoing context        11 / 26</a:t>
+              <a:t>Week 6 · Check the work        11 / 26</a:t>
             </a:r>
           </a:p>
         </p:txBody>
@@ -5977,13 +5977,13 @@
               </a:spcAft>
             </a:pPr>
             <a:r>
-              <a:rPr sz="3200" b="1">
+              <a:rPr sz="4000" b="1">
                 <a:solidFill>
                   <a:srgbClr val="272A25"/>
                 </a:solidFill>
                 <a:latin typeface="Fraunces"/>
               </a:rPr>
-              <a:t>Describe the design, not just the features</a:t>
+              <a:t>Check the experience—not just the code</a:t>
             </a:r>
           </a:p>
         </p:txBody>
@@ -6022,7 +6022,7 @@
                 </a:solidFill>
                 <a:latin typeface="DM Sans"/>
               </a:rPr>
-              <a:t>•  “Make it better” leaves the visual choices to the model.</a:t>
+              <a:t>•  Open it on a phone. Click every important button and link.</a:t>
             </a:r>
           </a:p>
           <a:p>
@@ -6038,7 +6038,7 @@
                 </a:solidFill>
                 <a:latin typeface="DM Sans"/>
               </a:rPr>
-              <a:t>•  Name the audience, feeling, hierarchy and interactions you want.</a:t>
+              <a:t>•  Try empty input, a strange answer, or a first-time visitor’s path.</a:t>
             </a:r>
           </a:p>
           <a:p>
@@ -6054,7 +6054,7 @@
                 </a:solidFill>
                 <a:latin typeface="DM Sans"/>
               </a:rPr>
-              <a:t>•  Example: “Calm portfolio. Work first, muted colours, clickable project cards.”</a:t>
+              <a:t>•  For a learning tool, check its facts and quiz answers against a trustworthy source.</a:t>
             </a:r>
           </a:p>
         </p:txBody>
@@ -6093,7 +6093,7 @@
                 </a:solidFill>
                 <a:latin typeface="DM Sans"/>
               </a:rPr>
-              <a:t>Week 6 · Communicate intent        12 / 26</a:t>
+              <a:t>Week 6 · Check the work        12 / 26</a:t>
             </a:r>
           </a:p>
         </p:txBody>
@@ -6201,7 +6201,7 @@
                 </a:solidFill>
                 <a:latin typeface="Fraunces"/>
               </a:rPr>
-              <a:t>Make your feedback observable</a:t>
+              <a:t>When free credits run out</a:t>
             </a:r>
           </a:p>
         </p:txBody>
@@ -6240,7 +6240,7 @@
                 </a:solidFill>
                 <a:latin typeface="DM Sans"/>
               </a:rPr>
-              <a:t>•  Give a reference or screenshot; say what to keep and what to change.</a:t>
+              <a:t>•  Save files and a short note: what works, what failed, what to try next.</a:t>
             </a:r>
           </a:p>
           <a:p>
@@ -6256,7 +6256,7 @@
                 </a:solidFill>
                 <a:latin typeface="DM Sans"/>
               </a:rPr>
-              <a:t>•  Instead of “It’s broken”: “Clicking this card should open the project; nothing happens.”</a:t>
+              <a:t>•  Use that note to continue in a fresh session or another tool.</a:t>
             </a:r>
           </a:p>
           <a:p>
@@ -6272,7 +6272,7 @@
                 </a:solidFill>
                 <a:latin typeface="DM Sans"/>
               </a:rPr>
-              <a:t>•  Ask for one small change, then compare the result with your intention.</a:t>
+              <a:t>•  Reduce the request: one change or one explanation at a time.</a:t>
             </a:r>
           </a:p>
         </p:txBody>
@@ -6311,7 +6311,7 @@
                 </a:solidFill>
                 <a:latin typeface="DM Sans"/>
               </a:rPr>
-              <a:t>Week 6 · Communicate intent        13 / 26</a:t>
+              <a:t>Week 6 · Working within limits        13 / 26</a:t>
             </a:r>
           </a:p>
         </p:txBody>
@@ -6413,13 +6413,13 @@
               </a:spcAft>
             </a:pPr>
             <a:r>
-              <a:rPr sz="4000" b="1">
+              <a:rPr sz="3200" b="1">
                 <a:solidFill>
                   <a:srgbClr val="272A25"/>
                 </a:solidFill>
                 <a:latin typeface="Fraunces"/>
               </a:rPr>
-              <a:t>Debugging: find the mismatch</a:t>
+              <a:t>Folder, repository, website: different things</a:t>
             </a:r>
           </a:p>
         </p:txBody>
@@ -6458,7 +6458,7 @@
                 </a:solidFill>
                 <a:latin typeface="DM Sans"/>
               </a:rPr>
-              <a:t>•  A bug is a difference between expected and observed behavior.</a:t>
+              <a:t>•  Local folder: files on your own computer.</a:t>
             </a:r>
           </a:p>
           <a:p>
@@ -6474,7 +6474,7 @@
                 </a:solidFill>
                 <a:latin typeface="DM Sans"/>
               </a:rPr>
-              <a:t>•  Reproduce it: what exact actions cause it? Capture the error or screenshot.</a:t>
+              <a:t>•  Git repository: those files plus a recorded history of versions.</a:t>
             </a:r>
           </a:p>
           <a:p>
@@ -6490,7 +6490,7 @@
                 </a:solidFill>
                 <a:latin typeface="DM Sans"/>
               </a:rPr>
-              <a:t>•  Ask the AI for a cause and a small fix; rerun the same check afterward.</a:t>
+              <a:t>•  Deployment: a published version that other people can open.</a:t>
             </a:r>
           </a:p>
         </p:txBody>
@@ -6529,7 +6529,7 @@
                 </a:solidFill>
                 <a:latin typeface="DM Sans"/>
               </a:rPr>
-              <a:t>Week 6 · Check the work        14 / 26</a:t>
+              <a:t>Week 6 · Getting online        14 / 26</a:t>
             </a:r>
           </a:p>
         </p:txBody>
@@ -6637,7 +6637,7 @@
                 </a:solidFill>
                 <a:latin typeface="Fraunces"/>
               </a:rPr>
-              <a:t>Check the experience—not just the code</a:t>
+              <a:t>Commit, push, deploy: three actions</a:t>
             </a:r>
           </a:p>
         </p:txBody>
@@ -6676,7 +6676,7 @@
                 </a:solidFill>
                 <a:latin typeface="DM Sans"/>
               </a:rPr>
-              <a:t>•  Open it on a phone. Click every important button and link.</a:t>
+              <a:t>•  Commit saves a version and a message in your local Git history.</a:t>
             </a:r>
           </a:p>
           <a:p>
@@ -6692,7 +6692,7 @@
                 </a:solidFill>
                 <a:latin typeface="DM Sans"/>
               </a:rPr>
-              <a:t>•  Try empty input, a strange answer, or a first-time visitor’s path.</a:t>
+              <a:t>•  Push sends your commits to the repository on GitHub.</a:t>
             </a:r>
           </a:p>
           <a:p>
@@ -6708,7 +6708,7 @@
                 </a:solidFill>
                 <a:latin typeface="DM Sans"/>
               </a:rPr>
-              <a:t>•  For a learning tool, check its facts and quiz answers against a trustworthy source.</a:t>
+              <a:t>•  Deploy publishes the project through a host such as GitHub Pages or Vercel.</a:t>
             </a:r>
           </a:p>
         </p:txBody>
@@ -6747,7 +6747,7 @@
                 </a:solidFill>
                 <a:latin typeface="DM Sans"/>
               </a:rPr>
-              <a:t>Week 6 · Check the work        15 / 26</a:t>
+              <a:t>Week 6 · Getting online        15 / 26</a:t>
             </a:r>
           </a:p>
         </p:txBody>
@@ -6849,13 +6849,13 @@
               </a:spcAft>
             </a:pPr>
             <a:r>
-              <a:rPr sz="4000" b="1">
+              <a:rPr sz="3200" b="1">
                 <a:solidFill>
                   <a:srgbClr val="272A25"/>
                 </a:solidFill>
                 <a:latin typeface="Fraunces"/>
               </a:rPr>
-              <a:t>When free credits run out</a:t>
+              <a:t>Your link must work on someone else’s phone</a:t>
             </a:r>
           </a:p>
         </p:txBody>
@@ -6894,7 +6894,7 @@
                 </a:solidFill>
                 <a:latin typeface="DM Sans"/>
               </a:rPr>
-              <a:t>•  Save files and a short note: what works, what failed, what to try next.</a:t>
+              <a:t>•  file:///… and localhost:8000 point to your own computer—not a public site.</a:t>
             </a:r>
           </a:p>
           <a:p>
@@ -6910,7 +6910,7 @@
                 </a:solidFill>
                 <a:latin typeface="DM Sans"/>
               </a:rPr>
-              <a:t>•  Use that note to continue in a fresh session or another tool.</a:t>
+              <a:t>•  A GitHub repository URL shows source; it may not be the live app URL.</a:t>
             </a:r>
           </a:p>
           <a:p>
@@ -6926,7 +6926,7 @@
                 </a:solidFill>
                 <a:latin typeface="DM Sans"/>
               </a:rPr>
-              <a:t>•  Reduce the request: one change or one explanation at a time.</a:t>
+              <a:t>•  Use the deployed HTTPS URL; test it on another device or in a private window.</a:t>
             </a:r>
           </a:p>
         </p:txBody>
@@ -6965,7 +6965,7 @@
                 </a:solidFill>
                 <a:latin typeface="DM Sans"/>
               </a:rPr>
-              <a:t>Week 6 · Working within limits        16 / 26</a:t>
+              <a:t>Week 6 · Getting online        16 / 26</a:t>
             </a:r>
           </a:p>
         </p:txBody>
@@ -7067,13 +7067,13 @@
               </a:spcAft>
             </a:pPr>
             <a:r>
-              <a:rPr sz="3200" b="1">
+              <a:rPr sz="4000" b="1">
                 <a:solidFill>
                   <a:srgbClr val="272A25"/>
                 </a:solidFill>
                 <a:latin typeface="Fraunces"/>
               </a:rPr>
-              <a:t>Folder, repository, website: different things</a:t>
+              <a:t>A practical path to publishing</a:t>
             </a:r>
           </a:p>
         </p:txBody>
@@ -7112,7 +7112,7 @@
                 </a:solidFill>
                 <a:latin typeface="DM Sans"/>
               </a:rPr>
-              <a:t>•  Local folder: files on your own computer.</a:t>
+              <a:t>•  GitHub Desktop: create a repository → commit → publish to GitHub.</a:t>
             </a:r>
           </a:p>
           <a:p>
@@ -7128,7 +7128,7 @@
                 </a:solidFill>
                 <a:latin typeface="DM Sans"/>
               </a:rPr>
-              <a:t>•  Git repository: those files plus a recorded history of versions.</a:t>
+              <a:t>•  Plain HTML/CSS: GitHub Settings → Pages → main branch / root → Save.</a:t>
             </a:r>
           </a:p>
           <a:p>
@@ -7144,7 +7144,7 @@
                 </a:solidFill>
                 <a:latin typeface="DM Sans"/>
               </a:rPr>
-              <a:t>•  Deployment: a published version that other people can open.</a:t>
+              <a:t>•  A framework app may need Vercel: allow repository access, deploy, then test the URL.</a:t>
             </a:r>
           </a:p>
         </p:txBody>
@@ -7285,13 +7285,13 @@
               </a:spcAft>
             </a:pPr>
             <a:r>
-              <a:rPr sz="4000" b="1">
+              <a:rPr sz="3200" b="1">
                 <a:solidFill>
                   <a:srgbClr val="272A25"/>
                 </a:solidFill>
                 <a:latin typeface="Fraunces"/>
               </a:rPr>
-              <a:t>Commit, push, deploy: three actions</a:t>
+              <a:t>API, connector, MCP: what is the difference?</a:t>
             </a:r>
           </a:p>
         </p:txBody>
@@ -7330,7 +7330,7 @@
                 </a:solidFill>
                 <a:latin typeface="DM Sans"/>
               </a:rPr>
-              <a:t>•  Commit saves a version and a message in your local Git history.</a:t>
+              <a:t>•  API: a service’s menu of requests that another program can make.</a:t>
             </a:r>
           </a:p>
           <a:p>
@@ -7346,7 +7346,7 @@
                 </a:solidFill>
                 <a:latin typeface="DM Sans"/>
               </a:rPr>
-              <a:t>•  Push sends your commits to the repository on GitHub.</a:t>
+              <a:t>•  Connector: a bridge that lets your AI reach a service or files.</a:t>
             </a:r>
           </a:p>
           <a:p>
@@ -7362,7 +7362,7 @@
                 </a:solidFill>
                 <a:latin typeface="DM Sans"/>
               </a:rPr>
-              <a:t>•  Deploy publishes the project through a host such as GitHub Pages or Vercel.</a:t>
+              <a:t>•  MCP: a shared protocol for AI apps to use tools; an MCP server may call an API.</a:t>
             </a:r>
           </a:p>
         </p:txBody>
@@ -7401,7 +7401,7 @@
                 </a:solidFill>
                 <a:latin typeface="DM Sans"/>
               </a:rPr>
-              <a:t>Week 6 · Getting online        18 / 26</a:t>
+              <a:t>Week 6 · Connections—concept only        18 / 26</a:t>
             </a:r>
           </a:p>
         </p:txBody>
@@ -7503,13 +7503,13 @@
               </a:spcAft>
             </a:pPr>
             <a:r>
-              <a:rPr sz="3200" b="1">
+              <a:rPr sz="4000" b="1">
                 <a:solidFill>
                   <a:srgbClr val="272A25"/>
                 </a:solidFill>
                 <a:latin typeface="Fraunces"/>
               </a:rPr>
-              <a:t>Your link must work on someone else’s phone</a:t>
+              <a:t>Access is a choice: read versus write</a:t>
             </a:r>
           </a:p>
         </p:txBody>
@@ -7548,7 +7548,7 @@
                 </a:solidFill>
                 <a:latin typeface="DM Sans"/>
               </a:rPr>
-              <a:t>•  file:///… and localhost:8000 point to your own computer—not a public site.</a:t>
+              <a:t>•  Read access can expose data; write access can change or delete it.</a:t>
             </a:r>
           </a:p>
           <a:p>
@@ -7564,7 +7564,7 @@
                 </a:solidFill>
                 <a:latin typeface="DM Sans"/>
               </a:rPr>
-              <a:t>•  A GitHub repository URL shows source; it may not be the live app URL.</a:t>
+              <a:t>•  Give only the access needed; review changes before publishing or sending.</a:t>
             </a:r>
           </a:p>
           <a:p>
@@ -7580,7 +7580,7 @@
                 </a:solidFill>
                 <a:latin typeface="DM Sans"/>
               </a:rPr>
-              <a:t>•  Use the deployed HTTPS URL; test it on another device or in a private window.</a:t>
+              <a:t>•  Keep keys, passwords and private data out of public files and repositories.</a:t>
             </a:r>
           </a:p>
         </p:txBody>
@@ -7619,7 +7619,7 @@
                 </a:solidFill>
                 <a:latin typeface="DM Sans"/>
               </a:rPr>
-              <a:t>Week 6 · Getting online        19 / 26</a:t>
+              <a:t>Week 6 · Connections—concept only        19 / 26</a:t>
             </a:r>
           </a:p>
         </p:txBody>
@@ -7945,7 +7945,7 @@
                 </a:solidFill>
                 <a:latin typeface="Fraunces"/>
               </a:rPr>
-              <a:t>A practical path to publishing</a:t>
+              <a:t>Use AI to learn about AI</a:t>
             </a:r>
           </a:p>
         </p:txBody>
@@ -7984,7 +7984,7 @@
                 </a:solidFill>
                 <a:latin typeface="DM Sans"/>
               </a:rPr>
-              <a:t>•  GitHub Desktop: create a repository → commit → publish to GitHub.</a:t>
+              <a:t>•  Ask for an explanation, an example, and a question to check your understanding.</a:t>
             </a:r>
           </a:p>
           <a:p>
@@ -8000,7 +8000,7 @@
                 </a:solidFill>
                 <a:latin typeface="DM Sans"/>
               </a:rPr>
-              <a:t>•  Plain HTML/CSS: GitHub Settings → Pages → main branch / root → Save.</a:t>
+              <a:t>•  Say what you already know: “I know HTML; Git is new to me.”</a:t>
             </a:r>
           </a:p>
           <a:p>
@@ -8016,7 +8016,7 @@
                 </a:solidFill>
                 <a:latin typeface="DM Sans"/>
               </a:rPr>
-              <a:t>•  A framework app may need Vercel: allow repository access, deploy, then test the URL.</a:t>
+              <a:t>•  Compare its explanation with your source—not just how confident it sounds.</a:t>
             </a:r>
           </a:p>
         </p:txBody>
@@ -8055,7 +8055,7 @@
                 </a:solidFill>
                 <a:latin typeface="DM Sans"/>
               </a:rPr>
-              <a:t>Week 6 · Getting online        20 / 26</a:t>
+              <a:t>Week 6 · Learn with AI        20 / 26</a:t>
             </a:r>
           </a:p>
         </p:txBody>
@@ -8157,13 +8157,13 @@
               </a:spcAft>
             </a:pPr>
             <a:r>
-              <a:rPr sz="3200" b="1">
+              <a:rPr sz="4000" b="1">
                 <a:solidFill>
                   <a:srgbClr val="272A25"/>
                 </a:solidFill>
                 <a:latin typeface="Fraunces"/>
               </a:rPr>
-              <a:t>API, connector, MCP: what is the difference?</a:t>
+              <a:t>The reading: your AI as a coach</a:t>
             </a:r>
           </a:p>
         </p:txBody>
@@ -8202,7 +8202,7 @@
                 </a:solidFill>
                 <a:latin typeface="DM Sans"/>
               </a:rPr>
-              <a:t>•  API: a service’s menu of requests that another program can make.</a:t>
+              <a:t>•  Arielle Shipper · “How to Get Better at AI by Asking AI” · Every</a:t>
             </a:r>
           </a:p>
           <a:p>
@@ -8218,7 +8218,7 @@
                 </a:solidFill>
                 <a:latin typeface="DM Sans"/>
               </a:rPr>
-              <a:t>•  Connector: a bridge that lets your AI reach a service or files.</a:t>
+              <a:t>•  Ask where you are on the Eight Levels of AI Adoption, with evidence from your work.</a:t>
             </a:r>
           </a:p>
           <a:p>
@@ -8234,7 +8234,7 @@
                 </a:solidFill>
                 <a:latin typeface="DM Sans"/>
               </a:rPr>
-              <a:t>•  MCP: a shared protocol for AI apps to use tools; an MCP server may call an API.</a:t>
+              <a:t>•  Ask for one next step, then: “Teach me that and help me practise.”</a:t>
             </a:r>
           </a:p>
         </p:txBody>
@@ -8273,7 +8273,7 @@
                 </a:solidFill>
                 <a:latin typeface="DM Sans"/>
               </a:rPr>
-              <a:t>Week 6 · Connections—concept only        21 / 26</a:t>
+              <a:t>Week 6 · Learn with AI        21 / 26</a:t>
             </a:r>
           </a:p>
         </p:txBody>
@@ -8375,13 +8375,13 @@
               </a:spcAft>
             </a:pPr>
             <a:r>
-              <a:rPr sz="4000" b="1">
+              <a:rPr sz="3200" b="1">
                 <a:solidFill>
                   <a:srgbClr val="272A25"/>
                 </a:solidFill>
                 <a:latin typeface="Fraunces"/>
               </a:rPr>
-              <a:t>Access is a choice: read versus write</a:t>
+              <a:t>No long chat history? Bring your own evidence</a:t>
             </a:r>
           </a:p>
         </p:txBody>
@@ -8420,7 +8420,7 @@
                 </a:solidFill>
                 <a:latin typeface="DM Sans"/>
               </a:rPr>
-              <a:t>•  Read access can expose data; write access can change or delete it.</a:t>
+              <a:t>•  Paste your last two submissions or describe a recent project.</a:t>
             </a:r>
           </a:p>
           <a:p>
@@ -8436,7 +8436,7 @@
                 </a:solidFill>
                 <a:latin typeface="DM Sans"/>
               </a:rPr>
-              <a:t>•  Give only the access needed; review changes before publishing or sending.</a:t>
+              <a:t>•  Ask: “What can I do already? Show examples. What should I learn next?”</a:t>
             </a:r>
           </a:p>
           <a:p>
@@ -8452,7 +8452,7 @@
                 </a:solidFill>
                 <a:latin typeface="DM Sans"/>
               </a:rPr>
-              <a:t>•  Keep keys, passwords and private data out of public files and repositories.</a:t>
+              <a:t>•  Treat the AI’s assessment as a suggestion; correct its assumptions.</a:t>
             </a:r>
           </a:p>
         </p:txBody>
@@ -8491,7 +8491,7 @@
                 </a:solidFill>
                 <a:latin typeface="DM Sans"/>
               </a:rPr>
-              <a:t>Week 6 · Connections—concept only        22 / 26</a:t>
+              <a:t>Week 6 · Learn with AI        22 / 26</a:t>
             </a:r>
           </a:p>
         </p:txBody>
@@ -9471,7 +9471,7 @@
                 </a:solidFill>
                 <a:latin typeface="Fraunces"/>
               </a:rPr>
-              <a:t>Use AI to learn about AI</a:t>
+              <a:t>Markdown: readable, portable text</a:t>
             </a:r>
           </a:p>
         </p:txBody>
@@ -9510,7 +9510,7 @@
                 </a:solidFill>
                 <a:latin typeface="DM Sans"/>
               </a:rPr>
-              <a:t>•  Ask for an explanation, an example, and a question to check your understanding.</a:t>
+              <a:t>•  A .md file is a plain-text file—not a special app or database.</a:t>
             </a:r>
           </a:p>
           <a:p>
@@ -9526,7 +9526,7 @@
                 </a:solidFill>
                 <a:latin typeface="DM Sans"/>
               </a:rPr>
-              <a:t>•  Say what you already know: “I know HTML; Git is new to me.”</a:t>
+              <a:t>•  A little punctuation adds structure: headings, lists, links, code.</a:t>
             </a:r>
           </a:p>
           <a:p>
@@ -9542,7 +9542,7 @@
                 </a:solidFill>
                 <a:latin typeface="DM Sans"/>
               </a:rPr>
-              <a:t>•  Compare its explanation with your source—not just how confident it sounds.</a:t>
+              <a:t>•  Read it in an editor, render it as a page, or paste it into your AI.</a:t>
             </a:r>
           </a:p>
         </p:txBody>
@@ -9581,7 +9581,7 @@
                 </a:solidFill>
                 <a:latin typeface="DM Sans"/>
               </a:rPr>
-              <a:t>Week 6 · Learn with AI        3 / 26</a:t>
+              <a:t>Week 6 · Markdown        3 / 26</a:t>
             </a:r>
           </a:p>
         </p:txBody>
@@ -9689,21 +9689,64 @@
                 </a:solidFill>
                 <a:latin typeface="Fraunces"/>
               </a:rPr>
-              <a:t>The reading: your AI as a coach</a:t>
-            </a:r>
-          </a:p>
-        </p:txBody>
-      </p:sp>
-      <p:sp>
-        <p:nvSpPr>
-          <p:cNvPr id="4" name="TextBox 3"/>
+              <a:t>Markdown you can read and write</a:t>
+            </a:r>
+          </a:p>
+        </p:txBody>
+      </p:sp>
+      <p:sp>
+        <p:nvSpPr>
+          <p:cNvPr id="4" name="Rectangle 3"/>
+          <p:cNvSpPr/>
+          <p:nvPr/>
+        </p:nvSpPr>
+        <p:spPr>
+          <a:xfrm>
+            <a:off x="822960" y="1828800"/>
+            <a:ext cx="6583680" cy="4023360"/>
+          </a:xfrm>
+          <a:prstGeom prst="rect">
+            <a:avLst/>
+          </a:prstGeom>
+          <a:solidFill>
+            <a:srgbClr val="EEECE2"/>
+          </a:solidFill>
+          <a:ln>
+            <a:noFill/>
+          </a:ln>
+        </p:spPr>
+        <p:style>
+          <a:lnRef idx="1">
+            <a:schemeClr val="accent1"/>
+          </a:lnRef>
+          <a:fillRef idx="3">
+            <a:schemeClr val="accent1"/>
+          </a:fillRef>
+          <a:effectRef idx="2">
+            <a:schemeClr val="accent1"/>
+          </a:effectRef>
+          <a:fontRef idx="minor">
+            <a:schemeClr val="lt1"/>
+          </a:fontRef>
+        </p:style>
+        <p:txBody>
+          <a:bodyPr rtlCol="0" anchor="ctr"/>
+          <a:lstStyle/>
+          <a:p>
+            <a:pPr algn="ctr"/>
+          </a:p>
+        </p:txBody>
+      </p:sp>
+      <p:sp>
+        <p:nvSpPr>
+          <p:cNvPr id="5" name="TextBox 4"/>
           <p:cNvSpPr txBox="1"/>
           <p:nvPr/>
         </p:nvSpPr>
         <p:spPr>
           <a:xfrm>
-            <a:off x="822960" y="2011680"/>
-            <a:ext cx="10607040" cy="4206240"/>
+            <a:off x="1097280" y="2011680"/>
+            <a:ext cx="6217920" cy="3749039"/>
           </a:xfrm>
           <a:prstGeom prst="rect">
             <a:avLst/>
@@ -9718,63 +9761,95 @@
           <a:p>
             <a:pPr>
               <a:spcAft>
-                <a:spcPts val="2200"/>
-              </a:spcAft>
-            </a:pPr>
-            <a:r>
-              <a:rPr sz="3000" b="0">
+                <a:spcPts val="200"/>
+              </a:spcAft>
+            </a:pPr>
+            <a:r>
+              <a:rPr sz="1800" b="0">
                 <a:solidFill>
                   <a:srgbClr val="272A25"/>
                 </a:solidFill>
-                <a:latin typeface="DM Sans"/>
-              </a:rPr>
-              <a:t>•  Arielle Shipper · “How to Get Better at AI by Asking AI” · Every</a:t>
+                <a:latin typeface="DejaVu Sans Mono"/>
+              </a:rPr>
+              <a:t># Project notes</a:t>
             </a:r>
           </a:p>
           <a:p>
             <a:pPr>
               <a:spcAft>
-                <a:spcPts val="2200"/>
-              </a:spcAft>
-            </a:pPr>
-            <a:r>
-              <a:rPr sz="3000" b="0">
+                <a:spcPts val="200"/>
+              </a:spcAft>
+            </a:pPr>
+            <a:r>
+              <a:rPr sz="1800" b="0">
                 <a:solidFill>
                   <a:srgbClr val="272A25"/>
                 </a:solidFill>
-                <a:latin typeface="DM Sans"/>
-              </a:rPr>
-              <a:t>•  Ask where you are on the Eight Levels of AI Adoption, with evidence from your work.</a:t>
+                <a:latin typeface="DejaVu Sans Mono"/>
+              </a:rPr>
+              <a:t>## What I want to learn</a:t>
             </a:r>
           </a:p>
           <a:p>
             <a:pPr>
               <a:spcAft>
-                <a:spcPts val="2200"/>
-              </a:spcAft>
-            </a:pPr>
-            <a:r>
-              <a:rPr sz="3000" b="0">
+                <a:spcPts val="200"/>
+              </a:spcAft>
+            </a:pPr>
+            <a:r>
+              <a:rPr sz="1800" b="0">
                 <a:solidFill>
                   <a:srgbClr val="272A25"/>
                 </a:solidFill>
-                <a:latin typeface="DM Sans"/>
-              </a:rPr>
-              <a:t>•  Ask for one next step, then: “Teach me that and help me practise.”</a:t>
-            </a:r>
-          </a:p>
-        </p:txBody>
-      </p:sp>
-      <p:sp>
-        <p:nvSpPr>
-          <p:cNvPr id="5" name="TextBox 4"/>
+                <a:latin typeface="DejaVu Sans Mono"/>
+              </a:rPr>
+              <a:t>- Explain commits before changing files.</a:t>
+            </a:r>
+          </a:p>
+          <a:p>
+            <a:pPr>
+              <a:spcAft>
+                <a:spcPts val="200"/>
+              </a:spcAft>
+            </a:pPr>
+            <a:r>
+              <a:rPr sz="1800" b="0">
+                <a:solidFill>
+                  <a:srgbClr val="272A25"/>
+                </a:solidFill>
+                <a:latin typeface="DejaVu Sans Mono"/>
+              </a:rPr>
+              <a:t>[Course lesson](https://cu.learnvibe.build/lessons/week-6/)</a:t>
+            </a:r>
+          </a:p>
+          <a:p>
+            <a:pPr>
+              <a:spcAft>
+                <a:spcPts val="200"/>
+              </a:spcAft>
+            </a:pPr>
+            <a:r>
+              <a:rPr sz="1800" b="0">
+                <a:solidFill>
+                  <a:srgbClr val="272A25"/>
+                </a:solidFill>
+                <a:latin typeface="DejaVu Sans Mono"/>
+              </a:rPr>
+              <a:t>Use `git status` to see what changed.</a:t>
+            </a:r>
+          </a:p>
+        </p:txBody>
+      </p:sp>
+      <p:sp>
+        <p:nvSpPr>
+          <p:cNvPr id="6" name="TextBox 5"/>
           <p:cNvSpPr txBox="1"/>
           <p:nvPr/>
         </p:nvSpPr>
         <p:spPr>
           <a:xfrm>
-            <a:off x="822960" y="6263640"/>
-            <a:ext cx="10607040" cy="365760"/>
+            <a:off x="7772400" y="3108960"/>
+            <a:ext cx="3931920" cy="1828800"/>
           </a:xfrm>
           <a:prstGeom prst="rect">
             <a:avLst/>
@@ -9787,6 +9862,45 @@
           </a:bodyPr>
           <a:lstStyle/>
           <a:p>
+            <a:pPr>
+              <a:spcAft>
+                <a:spcPts val="1400"/>
+              </a:spcAft>
+            </a:pPr>
+            <a:r>
+              <a:rPr sz="2800" b="0">
+                <a:solidFill>
+                  <a:srgbClr val="64665D"/>
+                </a:solidFill>
+                <a:latin typeface="DM Sans"/>
+              </a:rPr>
+              <a:t>Headings, lists, links, and code—with plain text underneath.</a:t>
+            </a:r>
+          </a:p>
+        </p:txBody>
+      </p:sp>
+      <p:sp>
+        <p:nvSpPr>
+          <p:cNvPr id="7" name="TextBox 6"/>
+          <p:cNvSpPr txBox="1"/>
+          <p:nvPr/>
+        </p:nvSpPr>
+        <p:spPr>
+          <a:xfrm>
+            <a:off x="822960" y="6263640"/>
+            <a:ext cx="10607040" cy="365760"/>
+          </a:xfrm>
+          <a:prstGeom prst="rect">
+            <a:avLst/>
+          </a:prstGeom>
+          <a:noFill/>
+        </p:spPr>
+        <p:txBody>
+          <a:bodyPr wrap="square">
+            <a:spAutoFit/>
+          </a:bodyPr>
+          <a:lstStyle/>
+          <a:p>
             <a:pPr algn="r">
               <a:spcAft>
                 <a:spcPts val="1400"/>
@@ -9799,7 +9913,7 @@
                 </a:solidFill>
                 <a:latin typeface="DM Sans"/>
               </a:rPr>
-              <a:t>Week 6 · Learn with AI        4 / 26</a:t>
+              <a:t>Week 6 · Markdown        4 / 26</a:t>
             </a:r>
           </a:p>
         </p:txBody>
@@ -9901,13 +10015,13 @@
               </a:spcAft>
             </a:pPr>
             <a:r>
-              <a:rPr sz="3200" b="1">
+              <a:rPr sz="4000" b="1">
                 <a:solidFill>
                   <a:srgbClr val="272A25"/>
                 </a:solidFill>
                 <a:latin typeface="Fraunces"/>
               </a:rPr>
-              <a:t>No long chat history? Bring your own evidence</a:t>
+              <a:t>Context: what the AI can actually see</a:t>
             </a:r>
           </a:p>
         </p:txBody>
@@ -9946,7 +10060,7 @@
                 </a:solidFill>
                 <a:latin typeface="DM Sans"/>
               </a:rPr>
-              <a:t>•  Paste your last two submissions or describe a recent project.</a:t>
+              <a:t>•  Its answer depends on the messages, files and tool results available now.</a:t>
             </a:r>
           </a:p>
           <a:p>
@@ -9962,7 +10076,7 @@
                 </a:solidFill>
                 <a:latin typeface="DM Sans"/>
               </a:rPr>
-              <a:t>•  Ask: “What can I do already? Show examples. What should I learn next?”</a:t>
+              <a:t>•  It does not automatically know your audience, preferences or project history.</a:t>
             </a:r>
           </a:p>
           <a:p>
@@ -9978,7 +10092,7 @@
                 </a:solidFill>
                 <a:latin typeface="DM Sans"/>
               </a:rPr>
-              <a:t>•  Treat the AI’s assessment as a suggestion; correct its assumptions.</a:t>
+              <a:t>•  “Improve my site” is weaker than a clear audience, goal and example.</a:t>
             </a:r>
           </a:p>
         </p:txBody>
@@ -10017,7 +10131,7 @@
                 </a:solidFill>
                 <a:latin typeface="DM Sans"/>
               </a:rPr>
-              <a:t>Week 6 · Learn with AI        5 / 26</a:t>
+              <a:t>Week 6 · Ongoing context        5 / 26</a:t>
             </a:r>
           </a:p>
         </p:txBody>
@@ -10119,13 +10233,13 @@
               </a:spcAft>
             </a:pPr>
             <a:r>
-              <a:rPr sz="4000" b="1">
+              <a:rPr sz="3200" b="1">
                 <a:solidFill>
                   <a:srgbClr val="272A25"/>
                 </a:solidFill>
                 <a:latin typeface="Fraunces"/>
               </a:rPr>
-              <a:t>Markdown: readable, portable text</a:t>
+              <a:t>Save project context instead of repeating it</a:t>
             </a:r>
           </a:p>
         </p:txBody>
@@ -10164,7 +10278,7 @@
                 </a:solidFill>
                 <a:latin typeface="DM Sans"/>
               </a:rPr>
-              <a:t>•  A .md file is a plain-text file—not a special app or database.</a:t>
+              <a:t>•  Write down what the project is, who it is for, and what should stay true.</a:t>
             </a:r>
           </a:p>
           <a:p>
@@ -10180,7 +10294,7 @@
                 </a:solidFill>
                 <a:latin typeface="DM Sans"/>
               </a:rPr>
-              <a:t>•  A little punctuation adds structure: headings, lists, links, code.</a:t>
+              <a:t>•  Keep it short, correct and editable; update it when the project changes.</a:t>
             </a:r>
           </a:p>
           <a:p>
@@ -10196,7 +10310,7 @@
                 </a:solidFill>
                 <a:latin typeface="DM Sans"/>
               </a:rPr>
-              <a:t>•  Read it in an editor, render it as a page, or paste it into your AI.</a:t>
+              <a:t>•  Example: “For nervous first-time visitors. Plain HTML/CSS. Do not invent event dates.”</a:t>
             </a:r>
           </a:p>
         </p:txBody>
@@ -10235,7 +10349,7 @@
                 </a:solidFill>
                 <a:latin typeface="DM Sans"/>
               </a:rPr>
-              <a:t>Week 6 · Markdown        6 / 26</a:t>
+              <a:t>Week 6 · Ongoing context        6 / 26</a:t>
             </a:r>
           </a:p>
         </p:txBody>
@@ -10343,64 +10457,21 @@
                 </a:solidFill>
                 <a:latin typeface="Fraunces"/>
               </a:rPr>
-              <a:t>Markdown you can read and write</a:t>
-            </a:r>
-          </a:p>
-        </p:txBody>
-      </p:sp>
-      <p:sp>
-        <p:nvSpPr>
-          <p:cNvPr id="4" name="Rectangle 3"/>
-          <p:cNvSpPr/>
-          <p:nvPr/>
-        </p:nvSpPr>
-        <p:spPr>
-          <a:xfrm>
-            <a:off x="822960" y="1828800"/>
-            <a:ext cx="6583680" cy="4023360"/>
-          </a:xfrm>
-          <a:prstGeom prst="rect">
-            <a:avLst/>
-          </a:prstGeom>
-          <a:solidFill>
-            <a:srgbClr val="EEECE2"/>
-          </a:solidFill>
-          <a:ln>
-            <a:noFill/>
-          </a:ln>
-        </p:spPr>
-        <p:style>
-          <a:lnRef idx="1">
-            <a:schemeClr val="accent1"/>
-          </a:lnRef>
-          <a:fillRef idx="3">
-            <a:schemeClr val="accent1"/>
-          </a:fillRef>
-          <a:effectRef idx="2">
-            <a:schemeClr val="accent1"/>
-          </a:effectRef>
-          <a:fontRef idx="minor">
-            <a:schemeClr val="lt1"/>
-          </a:fontRef>
-        </p:style>
-        <p:txBody>
-          <a:bodyPr rtlCol="0" anchor="ctr"/>
-          <a:lstStyle/>
-          <a:p>
-            <a:pPr algn="ctr"/>
-          </a:p>
-        </p:txBody>
-      </p:sp>
-      <p:sp>
-        <p:nvSpPr>
-          <p:cNvPr id="5" name="TextBox 4"/>
+              <a:t>Automatic loading is tool-specific</a:t>
+            </a:r>
+          </a:p>
+        </p:txBody>
+      </p:sp>
+      <p:sp>
+        <p:nvSpPr>
+          <p:cNvPr id="4" name="TextBox 3"/>
           <p:cNvSpPr txBox="1"/>
           <p:nvPr/>
         </p:nvSpPr>
         <p:spPr>
           <a:xfrm>
-            <a:off x="1097280" y="2011680"/>
-            <a:ext cx="6217920" cy="3749039"/>
+            <a:off x="822960" y="2011680"/>
+            <a:ext cx="10607040" cy="4206240"/>
           </a:xfrm>
           <a:prstGeom prst="rect">
             <a:avLst/>
@@ -10415,95 +10486,63 @@
           <a:p>
             <a:pPr>
               <a:spcAft>
-                <a:spcPts val="200"/>
-              </a:spcAft>
-            </a:pPr>
-            <a:r>
-              <a:rPr sz="1800" b="0">
+                <a:spcPts val="2200"/>
+              </a:spcAft>
+            </a:pPr>
+            <a:r>
+              <a:rPr sz="3000" b="0">
                 <a:solidFill>
                   <a:srgbClr val="272A25"/>
                 </a:solidFill>
-                <a:latin typeface="DejaVu Sans Mono"/>
-              </a:rPr>
-              <a:t># Project notes</a:t>
+                <a:latin typeface="DM Sans"/>
+              </a:rPr>
+              <a:t>•  Codex uses AGENTS.md; Claude Code uses CLAUDE.md.</a:t>
             </a:r>
           </a:p>
           <a:p>
             <a:pPr>
               <a:spcAft>
-                <a:spcPts val="200"/>
-              </a:spcAft>
-            </a:pPr>
-            <a:r>
-              <a:rPr sz="1800" b="0">
+                <a:spcPts val="2200"/>
+              </a:spcAft>
+            </a:pPr>
+            <a:r>
+              <a:rPr sz="3000" b="0">
                 <a:solidFill>
                   <a:srgbClr val="272A25"/>
                 </a:solidFill>
-                <a:latin typeface="DejaVu Sans Mono"/>
-              </a:rPr>
-              <a:t>## What I want to learn</a:t>
+                <a:latin typeface="DM Sans"/>
+              </a:rPr>
+              <a:t>•  Other tools have their own rules and supported filenames—check yours.</a:t>
             </a:r>
           </a:p>
           <a:p>
             <a:pPr>
               <a:spcAft>
-                <a:spcPts val="200"/>
-              </a:spcAft>
-            </a:pPr>
-            <a:r>
-              <a:rPr sz="1800" b="0">
+                <a:spcPts val="2200"/>
+              </a:spcAft>
+            </a:pPr>
+            <a:r>
+              <a:rPr sz="3000" b="0">
                 <a:solidFill>
                   <a:srgbClr val="272A25"/>
                 </a:solidFill>
-                <a:latin typeface="DejaVu Sans Mono"/>
-              </a:rPr>
-              <a:t>- Explain commits before changing files.</a:t>
-            </a:r>
-          </a:p>
-          <a:p>
-            <a:pPr>
-              <a:spcAft>
-                <a:spcPts val="200"/>
-              </a:spcAft>
-            </a:pPr>
-            <a:r>
-              <a:rPr sz="1800" b="0">
-                <a:solidFill>
-                  <a:srgbClr val="272A25"/>
-                </a:solidFill>
-                <a:latin typeface="DejaVu Sans Mono"/>
-              </a:rPr>
-              <a:t>[Course lesson](https://cu.learnvibe.build/lessons/week-6/)</a:t>
-            </a:r>
-          </a:p>
-          <a:p>
-            <a:pPr>
-              <a:spcAft>
-                <a:spcPts val="200"/>
-              </a:spcAft>
-            </a:pPr>
-            <a:r>
-              <a:rPr sz="1800" b="0">
-                <a:solidFill>
-                  <a:srgbClr val="272A25"/>
-                </a:solidFill>
-                <a:latin typeface="DejaVu Sans Mono"/>
-              </a:rPr>
-              <a:t>Use `git status` to see what changed.</a:t>
-            </a:r>
-          </a:p>
-        </p:txBody>
-      </p:sp>
-      <p:sp>
-        <p:nvSpPr>
-          <p:cNvPr id="6" name="TextBox 5"/>
+                <a:latin typeface="DM Sans"/>
+              </a:rPr>
+              <a:t>•  In a chat app, paste the context or add it to a Project; it may not read local files.</a:t>
+            </a:r>
+          </a:p>
+        </p:txBody>
+      </p:sp>
+      <p:sp>
+        <p:nvSpPr>
+          <p:cNvPr id="5" name="TextBox 4"/>
           <p:cNvSpPr txBox="1"/>
           <p:nvPr/>
         </p:nvSpPr>
         <p:spPr>
           <a:xfrm>
-            <a:off x="7772400" y="3108960"/>
-            <a:ext cx="3931920" cy="1828800"/>
+            <a:off x="822960" y="6263640"/>
+            <a:ext cx="10607040" cy="365760"/>
           </a:xfrm>
           <a:prstGeom prst="rect">
             <a:avLst/>
@@ -10516,58 +10555,19 @@
           </a:bodyPr>
           <a:lstStyle/>
           <a:p>
-            <a:pPr>
+            <a:pPr algn="r">
               <a:spcAft>
                 <a:spcPts val="1400"/>
               </a:spcAft>
             </a:pPr>
             <a:r>
-              <a:rPr sz="2800" b="0">
+              <a:rPr sz="1600" b="0">
                 <a:solidFill>
                   <a:srgbClr val="64665D"/>
                 </a:solidFill>
                 <a:latin typeface="DM Sans"/>
               </a:rPr>
-              <a:t>Headings, lists, links, and code—with plain text underneath.</a:t>
-            </a:r>
-          </a:p>
-        </p:txBody>
-      </p:sp>
-      <p:sp>
-        <p:nvSpPr>
-          <p:cNvPr id="7" name="TextBox 6"/>
-          <p:cNvSpPr txBox="1"/>
-          <p:nvPr/>
-        </p:nvSpPr>
-        <p:spPr>
-          <a:xfrm>
-            <a:off x="822960" y="6263640"/>
-            <a:ext cx="10607040" cy="365760"/>
-          </a:xfrm>
-          <a:prstGeom prst="rect">
-            <a:avLst/>
-          </a:prstGeom>
-          <a:noFill/>
-        </p:spPr>
-        <p:txBody>
-          <a:bodyPr wrap="square">
-            <a:spAutoFit/>
-          </a:bodyPr>
-          <a:lstStyle/>
-          <a:p>
-            <a:pPr algn="r">
-              <a:spcAft>
-                <a:spcPts val="1400"/>
-              </a:spcAft>
-            </a:pPr>
-            <a:r>
-              <a:rPr sz="1600" b="0">
-                <a:solidFill>
-                  <a:srgbClr val="64665D"/>
-                </a:solidFill>
-                <a:latin typeface="DM Sans"/>
-              </a:rPr>
-              <a:t>Week 6 · Markdown        7 / 26</a:t>
+              <a:t>Week 6 · Ongoing context        7 / 26</a:t>
             </a:r>
           </a:p>
         </p:txBody>
@@ -10675,7 +10675,7 @@
                 </a:solidFill>
                 <a:latin typeface="Fraunces"/>
               </a:rPr>
-              <a:t>Context: what the AI can actually see</a:t>
+              <a:t>An index points to deeper context</a:t>
             </a:r>
           </a:p>
         </p:txBody>
@@ -10714,7 +10714,7 @@
                 </a:solidFill>
                 <a:latin typeface="DM Sans"/>
               </a:rPr>
-              <a:t>•  Its answer depends on the messages, files and tool results available now.</a:t>
+              <a:t>•  A small index says which files exist and what each is for.</a:t>
             </a:r>
           </a:p>
           <a:p>
@@ -10730,7 +10730,7 @@
                 </a:solidFill>
                 <a:latin typeface="DM Sans"/>
               </a:rPr>
-              <a:t>•  It does not automatically know your audience, preferences or project history.</a:t>
+              <a:t>•  Example: docs/facts.md → verified facts; docs/design.md → visual direction.</a:t>
             </a:r>
           </a:p>
           <a:p>
@@ -10746,7 +10746,7 @@
                 </a:solidFill>
                 <a:latin typeface="DM Sans"/>
               </a:rPr>
-              <a:t>•  “Improve my site” is weaker than a clear audience, goal and example.</a:t>
+              <a:t>•  The AI can open the relevant document instead of receiving one giant prompt.</a:t>
             </a:r>
           </a:p>
         </p:txBody>
@@ -10893,7 +10893,7 @@
                 </a:solidFill>
                 <a:latin typeface="Fraunces"/>
               </a:rPr>
-              <a:t>Save project context instead of repeating it</a:t>
+              <a:t>Describe the design, not just the features</a:t>
             </a:r>
           </a:p>
         </p:txBody>
@@ -10932,7 +10932,7 @@
                 </a:solidFill>
                 <a:latin typeface="DM Sans"/>
               </a:rPr>
-              <a:t>•  Write down what the project is, who it is for, and what should stay true.</a:t>
+              <a:t>•  “Make it better” leaves the visual choices to the model.</a:t>
             </a:r>
           </a:p>
           <a:p>
@@ -10948,7 +10948,7 @@
                 </a:solidFill>
                 <a:latin typeface="DM Sans"/>
               </a:rPr>
-              <a:t>•  Keep it short, correct and editable; update it when the project changes.</a:t>
+              <a:t>•  Name the audience, feeling, hierarchy and interactions you want.</a:t>
             </a:r>
           </a:p>
           <a:p>
@@ -10964,7 +10964,7 @@
                 </a:solidFill>
                 <a:latin typeface="DM Sans"/>
               </a:rPr>
-              <a:t>•  Example: “For nervous first-time visitors. Plain HTML/CSS. Do not invent event dates.”</a:t>
+              <a:t>•  Example: “Calm portfolio. Work first, muted colours, clickable project cards.”</a:t>
             </a:r>
           </a:p>
         </p:txBody>
@@ -11003,7 +11003,7 @@
                 </a:solidFill>
                 <a:latin typeface="DM Sans"/>
               </a:rPr>
-              <a:t>Week 6 · Ongoing context        9 / 26</a:t>
+              <a:t>Week 6 · Communicate intent        9 / 26</a:t>
             </a:r>
           </a:p>
         </p:txBody>

</xml_diff>

<commit_message>
Week 6: one-page learning reflection replaces required build; persistent peer pods, optional link, Canvas draft only
</commit_message>
<xml_diff>
--- a/lessons/week-6/_src/week6-lecture.pptx
+++ b/lessons/week-6/_src/week6-lecture.pptx
@@ -31,6 +31,7 @@
     <p:sldId id="279" r:id="rId31"/>
     <p:sldId id="280" r:id="rId32"/>
     <p:sldId id="281" r:id="rId33"/>
+    <p:sldId id="282" r:id="rId34"/>
   </p:sldIdLst>
   <p:sldSz cx="12191695" cy="6858000" type="screen4x3"/>
   <p:notesSz cx="6858000" cy="9144000"/>
@@ -1788,6 +1789,76 @@
           <a:p>
             <a:r>
               <a:t>Optional: ask your AI what it needs to know about your project; save the useful context in markdown. Students can find the lesson from the preceding slide. No due date added.</a:t>
+            </a:r>
+          </a:p>
+        </p:txBody>
+      </p:sp>
+      <p:sp>
+        <p:nvSpPr>
+          <p:cNvPr id="4" name="Slide Number Placeholder 3"/>
+          <p:cNvSpPr>
+            <a:spLocks noGrp="1"/>
+          </p:cNvSpPr>
+          <p:nvPr>
+            <p:ph type="sldNum" idx="5" sz="quarter"/>
+          </p:nvPr>
+        </p:nvSpPr>
+        <p:spPr/>
+      </p:sp>
+    </p:spTree>
+  </p:cSld>
+  <p:clrMapOvr>
+    <a:masterClrMapping/>
+  </p:clrMapOvr>
+</p:notes>
+</file>
+
+<file path=ppt/notesSlides/notesSlide27.xml><?xml version="1.0" encoding="utf-8"?>
+<p:notes xmlns:a="http://schemas.openxmlformats.org/drawingml/2006/main" xmlns:p="http://schemas.openxmlformats.org/presentationml/2006/main" xmlns:r="http://schemas.openxmlformats.org/officeDocument/2006/relationships">
+  <p:cSld>
+    <p:spTree>
+      <p:nvGrpSpPr>
+        <p:cNvPr id="1" name=""/>
+        <p:cNvGrpSpPr/>
+        <p:nvPr/>
+      </p:nvGrpSpPr>
+      <p:grpSpPr>
+        <a:xfrm>
+          <a:off x="0" y="0"/>
+          <a:ext cx="0" cy="0"/>
+          <a:chOff x="0" y="0"/>
+          <a:chExt cx="0" cy="0"/>
+        </a:xfrm>
+      </p:grpSpPr>
+      <p:sp>
+        <p:nvSpPr>
+          <p:cNvPr id="2" name="Slide Image Placeholder 1"/>
+          <p:cNvSpPr>
+            <a:spLocks noGrp="1"/>
+          </p:cNvSpPr>
+          <p:nvPr>
+            <p:ph type="sldImg" idx="2"/>
+          </p:nvPr>
+        </p:nvSpPr>
+        <p:spPr/>
+      </p:sp>
+      <p:sp>
+        <p:nvSpPr>
+          <p:cNvPr id="3" name="Notes Placeholder 2"/>
+          <p:cNvSpPr>
+            <a:spLocks noGrp="1"/>
+          </p:cNvSpPr>
+          <p:nvPr>
+            <p:ph type="body" idx="3" sz="quarter"/>
+          </p:nvPr>
+        </p:nvSpPr>
+        <p:spPr/>
+        <p:txBody>
+          <a:bodyPr/>
+          <a:lstStyle/>
+          <a:p>
+            <a:r>
+              <a:t>Authoritative Week 6 assignment replaces the required build. One page, not one paragraph. Existing due date remains October 11 at 11:59 PM MT. Pods share learning and support each other in class for AT LEAST the next three weeks; do not invent size, rubric, or final-project requirements. Canvas copy is a draft, not yet published.</a:t>
             </a:r>
           </a:p>
         </p:txBody>
@@ -5439,7 +5510,7 @@
                 </a:solidFill>
                 <a:latin typeface="DM Sans"/>
               </a:rPr>
-              <a:t>Week 6 · Opening        1 / 26</a:t>
+              <a:t>Week 6 · Opening        1 / 27</a:t>
             </a:r>
           </a:p>
         </p:txBody>
@@ -5657,7 +5728,7 @@
                 </a:solidFill>
                 <a:latin typeface="DM Sans"/>
               </a:rPr>
-              <a:t>Week 6 · Communicate intent        10 / 26</a:t>
+              <a:t>Week 6 · Communicate intent        10 / 27</a:t>
             </a:r>
           </a:p>
         </p:txBody>
@@ -5875,7 +5946,7 @@
                 </a:solidFill>
                 <a:latin typeface="DM Sans"/>
               </a:rPr>
-              <a:t>Week 6 · Check the work        11 / 26</a:t>
+              <a:t>Week 6 · Check the work        11 / 27</a:t>
             </a:r>
           </a:p>
         </p:txBody>
@@ -6093,7 +6164,7 @@
                 </a:solidFill>
                 <a:latin typeface="DM Sans"/>
               </a:rPr>
-              <a:t>Week 6 · Check the work        12 / 26</a:t>
+              <a:t>Week 6 · Check the work        12 / 27</a:t>
             </a:r>
           </a:p>
         </p:txBody>
@@ -6311,7 +6382,7 @@
                 </a:solidFill>
                 <a:latin typeface="DM Sans"/>
               </a:rPr>
-              <a:t>Week 6 · Working within limits        13 / 26</a:t>
+              <a:t>Week 6 · Working within limits        13 / 27</a:t>
             </a:r>
           </a:p>
         </p:txBody>
@@ -6529,7 +6600,7 @@
                 </a:solidFill>
                 <a:latin typeface="DM Sans"/>
               </a:rPr>
-              <a:t>Week 6 · Getting online        14 / 26</a:t>
+              <a:t>Week 6 · Getting online        14 / 27</a:t>
             </a:r>
           </a:p>
         </p:txBody>
@@ -6747,7 +6818,7 @@
                 </a:solidFill>
                 <a:latin typeface="DM Sans"/>
               </a:rPr>
-              <a:t>Week 6 · Getting online        15 / 26</a:t>
+              <a:t>Week 6 · Getting online        15 / 27</a:t>
             </a:r>
           </a:p>
         </p:txBody>
@@ -6965,7 +7036,7 @@
                 </a:solidFill>
                 <a:latin typeface="DM Sans"/>
               </a:rPr>
-              <a:t>Week 6 · Getting online        16 / 26</a:t>
+              <a:t>Week 6 · Getting online        16 / 27</a:t>
             </a:r>
           </a:p>
         </p:txBody>
@@ -7183,7 +7254,7 @@
                 </a:solidFill>
                 <a:latin typeface="DM Sans"/>
               </a:rPr>
-              <a:t>Week 6 · Getting online        17 / 26</a:t>
+              <a:t>Week 6 · Getting online        17 / 27</a:t>
             </a:r>
           </a:p>
         </p:txBody>
@@ -7401,7 +7472,7 @@
                 </a:solidFill>
                 <a:latin typeface="DM Sans"/>
               </a:rPr>
-              <a:t>Week 6 · Connections—concept only        18 / 26</a:t>
+              <a:t>Week 6 · Connections—concept only        18 / 27</a:t>
             </a:r>
           </a:p>
         </p:txBody>
@@ -7619,7 +7690,7 @@
                 </a:solidFill>
                 <a:latin typeface="DM Sans"/>
               </a:rPr>
-              <a:t>Week 6 · Connections—concept only        19 / 26</a:t>
+              <a:t>Week 6 · Connections—concept only        19 / 27</a:t>
             </a:r>
           </a:p>
         </p:txBody>
@@ -7837,7 +7908,7 @@
                 </a:solidFill>
                 <a:latin typeface="DM Sans"/>
               </a:rPr>
-              <a:t>Week 6 · Why this matters        2 / 26</a:t>
+              <a:t>Week 6 · Why this matters        2 / 27</a:t>
             </a:r>
           </a:p>
         </p:txBody>
@@ -8055,7 +8126,7 @@
                 </a:solidFill>
                 <a:latin typeface="DM Sans"/>
               </a:rPr>
-              <a:t>Week 6 · Learn with AI        20 / 26</a:t>
+              <a:t>Week 6 · Learn with AI        20 / 27</a:t>
             </a:r>
           </a:p>
         </p:txBody>
@@ -8273,7 +8344,7 @@
                 </a:solidFill>
                 <a:latin typeface="DM Sans"/>
               </a:rPr>
-              <a:t>Week 6 · Learn with AI        21 / 26</a:t>
+              <a:t>Week 6 · Learn with AI        21 / 27</a:t>
             </a:r>
           </a:p>
         </p:txBody>
@@ -8491,7 +8562,7 @@
                 </a:solidFill>
                 <a:latin typeface="DM Sans"/>
               </a:rPr>
-              <a:t>Week 6 · Learn with AI        22 / 26</a:t>
+              <a:t>Week 6 · Learn with AI        22 / 27</a:t>
             </a:r>
           </a:p>
         </p:txBody>
@@ -8709,7 +8780,7 @@
                 </a:solidFill>
                 <a:latin typeface="DM Sans"/>
               </a:rPr>
-              <a:t>Week 6 · Use the lesson        23 / 26</a:t>
+              <a:t>Week 6 · Use the lesson        23 / 27</a:t>
             </a:r>
           </a:p>
         </p:txBody>
@@ -8927,7 +8998,7 @@
                 </a:solidFill>
                 <a:latin typeface="DM Sans"/>
               </a:rPr>
-              <a:t>Week 6 · One live demo        24 / 26</a:t>
+              <a:t>Week 6 · One live demo        24 / 27</a:t>
             </a:r>
           </a:p>
         </p:txBody>
@@ -9029,13 +9100,13 @@
               </a:spcAft>
             </a:pPr>
             <a:r>
-              <a:rPr sz="3200" b="1">
+              <a:rPr sz="4000" b="1">
                 <a:solidFill>
                   <a:srgbClr val="272A25"/>
                 </a:solidFill>
                 <a:latin typeface="Fraunces"/>
               </a:rPr>
-              <a:t>In small groups: build for your learning</a:t>
+              <a:t>Optional in-class small-group building</a:t>
             </a:r>
           </a:p>
         </p:txBody>
@@ -9074,7 +9145,7 @@
                 </a:solidFill>
                 <a:latin typeface="DM Sans"/>
               </a:rPr>
-              <a:t>•  Choose a topic you want to understand or practise, and your own approach.</a:t>
+              <a:t>•  Choose a topic and your own approach; building/sharing is optional.</a:t>
             </a:r>
           </a:p>
           <a:p>
@@ -9145,7 +9216,7 @@
                 </a:solidFill>
                 <a:latin typeface="DM Sans"/>
               </a:rPr>
-              <a:t>Week 6 · Group work        25 / 26</a:t>
+              <a:t>Week 6 · Group work        25 / 27</a:t>
             </a:r>
           </a:p>
         </p:txBody>
@@ -9363,7 +9434,241 @@
                 </a:solidFill>
                 <a:latin typeface="DM Sans"/>
               </a:rPr>
-              <a:t>Week 6 · Group work        26 / 26</a:t>
+              <a:t>Week 6 · Group work        26 / 27</a:t>
+            </a:r>
+          </a:p>
+        </p:txBody>
+      </p:sp>
+    </p:spTree>
+  </p:cSld>
+  <p:clrMapOvr>
+    <a:masterClrMapping/>
+  </p:clrMapOvr>
+</p:sld>
+</file>
+
+<file path=ppt/slides/slide27.xml><?xml version="1.0" encoding="utf-8"?>
+<p:sld xmlns:a="http://schemas.openxmlformats.org/drawingml/2006/main" xmlns:p="http://schemas.openxmlformats.org/presentationml/2006/main" xmlns:r="http://schemas.openxmlformats.org/officeDocument/2006/relationships">
+  <p:cSld>
+    <p:bg>
+      <p:bgPr>
+        <a:solidFill>
+          <a:srgbClr val="F7F5EE"/>
+        </a:solidFill>
+        <a:effectLst/>
+      </p:bgPr>
+    </p:bg>
+    <p:spTree>
+      <p:nvGrpSpPr>
+        <p:cNvPr id="1" name=""/>
+        <p:cNvGrpSpPr/>
+        <p:nvPr/>
+      </p:nvGrpSpPr>
+      <p:grpSpPr/>
+      <p:sp>
+        <p:nvSpPr>
+          <p:cNvPr id="2" name="Rectangle 1"/>
+          <p:cNvSpPr/>
+          <p:nvPr/>
+        </p:nvSpPr>
+        <p:spPr>
+          <a:xfrm>
+            <a:off x="0" y="0"/>
+            <a:ext cx="228600" cy="6858000"/>
+          </a:xfrm>
+          <a:prstGeom prst="rect">
+            <a:avLst/>
+          </a:prstGeom>
+          <a:solidFill>
+            <a:srgbClr val="A83D2B"/>
+          </a:solidFill>
+          <a:ln>
+            <a:noFill/>
+          </a:ln>
+        </p:spPr>
+        <p:style>
+          <a:lnRef idx="1">
+            <a:schemeClr val="accent1"/>
+          </a:lnRef>
+          <a:fillRef idx="3">
+            <a:schemeClr val="accent1"/>
+          </a:fillRef>
+          <a:effectRef idx="2">
+            <a:schemeClr val="accent1"/>
+          </a:effectRef>
+          <a:fontRef idx="minor">
+            <a:schemeClr val="lt1"/>
+          </a:fontRef>
+        </p:style>
+        <p:txBody>
+          <a:bodyPr rtlCol="0" anchor="ctr"/>
+          <a:lstStyle/>
+          <a:p>
+            <a:pPr algn="ctr"/>
+          </a:p>
+        </p:txBody>
+      </p:sp>
+      <p:sp>
+        <p:nvSpPr>
+          <p:cNvPr id="3" name="TextBox 2"/>
+          <p:cNvSpPr txBox="1"/>
+          <p:nvPr/>
+        </p:nvSpPr>
+        <p:spPr>
+          <a:xfrm>
+            <a:off x="822960" y="548640"/>
+            <a:ext cx="10607040" cy="1188720"/>
+          </a:xfrm>
+          <a:prstGeom prst="rect">
+            <a:avLst/>
+          </a:prstGeom>
+          <a:noFill/>
+        </p:spPr>
+        <p:txBody>
+          <a:bodyPr wrap="square">
+            <a:spAutoFit/>
+          </a:bodyPr>
+          <a:lstStyle/>
+          <a:p>
+            <a:pPr>
+              <a:spcAft>
+                <a:spcPts val="1400"/>
+              </a:spcAft>
+            </a:pPr>
+            <a:r>
+              <a:rPr sz="4000" b="1">
+                <a:solidFill>
+                  <a:srgbClr val="272A25"/>
+                </a:solidFill>
+                <a:latin typeface="Fraunces"/>
+              </a:rPr>
+              <a:t>This week: ONE PAGE about your learning</a:t>
+            </a:r>
+          </a:p>
+        </p:txBody>
+      </p:sp>
+      <p:sp>
+        <p:nvSpPr>
+          <p:cNvPr id="4" name="TextBox 3"/>
+          <p:cNvSpPr txBox="1"/>
+          <p:nvPr/>
+        </p:nvSpPr>
+        <p:spPr>
+          <a:xfrm>
+            <a:off x="822960" y="2011680"/>
+            <a:ext cx="10607040" cy="4206240"/>
+          </a:xfrm>
+          <a:prstGeom prst="rect">
+            <a:avLst/>
+          </a:prstGeom>
+          <a:noFill/>
+        </p:spPr>
+        <p:txBody>
+          <a:bodyPr wrap="square">
+            <a:spAutoFit/>
+          </a:bodyPr>
+          <a:lstStyle/>
+          <a:p>
+            <a:pPr>
+              <a:spcAft>
+                <a:spcPts val="1600"/>
+              </a:spcAft>
+            </a:pPr>
+            <a:r>
+              <a:rPr sz="2600" b="0">
+                <a:solidFill>
+                  <a:srgbClr val="272A25"/>
+                </a:solidFill>
+                <a:latin typeface="DM Sans"/>
+              </a:rPr>
+              <a:t>•  What you’ve learned, are learning, and want to learn.</a:t>
+            </a:r>
+          </a:p>
+          <a:p>
+            <a:pPr>
+              <a:spcAft>
+                <a:spcPts val="1600"/>
+              </a:spcAft>
+            </a:pPr>
+            <a:r>
+              <a:rPr sz="2600" b="0">
+                <a:solidFill>
+                  <a:srgbClr val="272A25"/>
+                </a:solidFill>
+                <a:latin typeface="DM Sans"/>
+              </a:rPr>
+              <a:t>•  What you want to build; emerging final-project ideas.</a:t>
+            </a:r>
+          </a:p>
+          <a:p>
+            <a:pPr>
+              <a:spcAft>
+                <a:spcPts val="1600"/>
+              </a:spcAft>
+            </a:pPr>
+            <a:r>
+              <a:rPr sz="2600" b="0">
+                <a:solidFill>
+                  <a:srgbClr val="272A25"/>
+                </a:solidFill>
+                <a:latin typeface="DM Sans"/>
+              </a:rPr>
+              <a:t>•  Building/sharing is welcome but OPTIONAL—not required.</a:t>
+            </a:r>
+          </a:p>
+          <a:p>
+            <a:pPr>
+              <a:spcAft>
+                <a:spcPts val="1600"/>
+              </a:spcAft>
+            </a:pPr>
+            <a:r>
+              <a:rPr sz="2600" b="0">
+                <a:solidFill>
+                  <a:srgbClr val="272A25"/>
+                </a:solidFill>
+                <a:latin typeface="DM Sans"/>
+              </a:rPr>
+              <a:t>•  Your reflections will shape consistent peer pods for at least three weeks.</a:t>
+            </a:r>
+          </a:p>
+        </p:txBody>
+      </p:sp>
+      <p:sp>
+        <p:nvSpPr>
+          <p:cNvPr id="5" name="TextBox 4"/>
+          <p:cNvSpPr txBox="1"/>
+          <p:nvPr/>
+        </p:nvSpPr>
+        <p:spPr>
+          <a:xfrm>
+            <a:off x="822960" y="6263640"/>
+            <a:ext cx="10607040" cy="365760"/>
+          </a:xfrm>
+          <a:prstGeom prst="rect">
+            <a:avLst/>
+          </a:prstGeom>
+          <a:noFill/>
+        </p:spPr>
+        <p:txBody>
+          <a:bodyPr wrap="square">
+            <a:spAutoFit/>
+          </a:bodyPr>
+          <a:lstStyle/>
+          <a:p>
+            <a:pPr algn="r">
+              <a:spcAft>
+                <a:spcPts val="1400"/>
+              </a:spcAft>
+            </a:pPr>
+            <a:r>
+              <a:rPr sz="1600" b="0">
+                <a:solidFill>
+                  <a:srgbClr val="64665D"/>
+                </a:solidFill>
+                <a:latin typeface="DM Sans"/>
+              </a:rPr>
+              <a:t>Week 6 · Weekly assignment        27 / 27</a:t>
             </a:r>
           </a:p>
         </p:txBody>
@@ -9581,7 +9886,7 @@
                 </a:solidFill>
                 <a:latin typeface="DM Sans"/>
               </a:rPr>
-              <a:t>Week 6 · Markdown        3 / 26</a:t>
+              <a:t>Week 6 · Markdown        3 / 27</a:t>
             </a:r>
           </a:p>
         </p:txBody>
@@ -9913,7 +10218,7 @@
                 </a:solidFill>
                 <a:latin typeface="DM Sans"/>
               </a:rPr>
-              <a:t>Week 6 · Markdown        4 / 26</a:t>
+              <a:t>Week 6 · Markdown        4 / 27</a:t>
             </a:r>
           </a:p>
         </p:txBody>
@@ -10131,7 +10436,7 @@
                 </a:solidFill>
                 <a:latin typeface="DM Sans"/>
               </a:rPr>
-              <a:t>Week 6 · Ongoing context        5 / 26</a:t>
+              <a:t>Week 6 · Ongoing context        5 / 27</a:t>
             </a:r>
           </a:p>
         </p:txBody>
@@ -10349,7 +10654,7 @@
                 </a:solidFill>
                 <a:latin typeface="DM Sans"/>
               </a:rPr>
-              <a:t>Week 6 · Ongoing context        6 / 26</a:t>
+              <a:t>Week 6 · Ongoing context        6 / 27</a:t>
             </a:r>
           </a:p>
         </p:txBody>
@@ -10567,7 +10872,7 @@
                 </a:solidFill>
                 <a:latin typeface="DM Sans"/>
               </a:rPr>
-              <a:t>Week 6 · Ongoing context        7 / 26</a:t>
+              <a:t>Week 6 · Ongoing context        7 / 27</a:t>
             </a:r>
           </a:p>
         </p:txBody>
@@ -10785,7 +11090,7 @@
                 </a:solidFill>
                 <a:latin typeface="DM Sans"/>
               </a:rPr>
-              <a:t>Week 6 · Ongoing context        8 / 26</a:t>
+              <a:t>Week 6 · Ongoing context        8 / 27</a:t>
             </a:r>
           </a:p>
         </p:txBody>
@@ -11003,7 +11308,7 @@
                 </a:solidFill>
                 <a:latin typeface="DM Sans"/>
               </a:rPr>
-              <a:t>Week 6 · Communicate intent        9 / 26</a:t>
+              <a:t>Week 6 · Communicate intent        9 / 27</a:t>
             </a:r>
           </a:p>
         </p:txBody>

</xml_diff>

<commit_message>
Week 6: one-page learning reflection replaces required build; persistent peer pods, optional link, Canvas draft only (#13)
Co-authored-by: unforcedagi <agi@unforced.dev>
</commit_message>
<xml_diff>
--- a/lessons/week-6/_src/week6-lecture.pptx
+++ b/lessons/week-6/_src/week6-lecture.pptx
@@ -31,6 +31,7 @@
     <p:sldId id="279" r:id="rId31"/>
     <p:sldId id="280" r:id="rId32"/>
     <p:sldId id="281" r:id="rId33"/>
+    <p:sldId id="282" r:id="rId34"/>
   </p:sldIdLst>
   <p:sldSz cx="12191695" cy="6858000" type="screen4x3"/>
   <p:notesSz cx="6858000" cy="9144000"/>
@@ -1788,6 +1789,76 @@
           <a:p>
             <a:r>
               <a:t>Optional: ask your AI what it needs to know about your project; save the useful context in markdown. Students can find the lesson from the preceding slide. No due date added.</a:t>
+            </a:r>
+          </a:p>
+        </p:txBody>
+      </p:sp>
+      <p:sp>
+        <p:nvSpPr>
+          <p:cNvPr id="4" name="Slide Number Placeholder 3"/>
+          <p:cNvSpPr>
+            <a:spLocks noGrp="1"/>
+          </p:cNvSpPr>
+          <p:nvPr>
+            <p:ph type="sldNum" idx="5" sz="quarter"/>
+          </p:nvPr>
+        </p:nvSpPr>
+        <p:spPr/>
+      </p:sp>
+    </p:spTree>
+  </p:cSld>
+  <p:clrMapOvr>
+    <a:masterClrMapping/>
+  </p:clrMapOvr>
+</p:notes>
+</file>
+
+<file path=ppt/notesSlides/notesSlide27.xml><?xml version="1.0" encoding="utf-8"?>
+<p:notes xmlns:a="http://schemas.openxmlformats.org/drawingml/2006/main" xmlns:p="http://schemas.openxmlformats.org/presentationml/2006/main" xmlns:r="http://schemas.openxmlformats.org/officeDocument/2006/relationships">
+  <p:cSld>
+    <p:spTree>
+      <p:nvGrpSpPr>
+        <p:cNvPr id="1" name=""/>
+        <p:cNvGrpSpPr/>
+        <p:nvPr/>
+      </p:nvGrpSpPr>
+      <p:grpSpPr>
+        <a:xfrm>
+          <a:off x="0" y="0"/>
+          <a:ext cx="0" cy="0"/>
+          <a:chOff x="0" y="0"/>
+          <a:chExt cx="0" cy="0"/>
+        </a:xfrm>
+      </p:grpSpPr>
+      <p:sp>
+        <p:nvSpPr>
+          <p:cNvPr id="2" name="Slide Image Placeholder 1"/>
+          <p:cNvSpPr>
+            <a:spLocks noGrp="1"/>
+          </p:cNvSpPr>
+          <p:nvPr>
+            <p:ph type="sldImg" idx="2"/>
+          </p:nvPr>
+        </p:nvSpPr>
+        <p:spPr/>
+      </p:sp>
+      <p:sp>
+        <p:nvSpPr>
+          <p:cNvPr id="3" name="Notes Placeholder 2"/>
+          <p:cNvSpPr>
+            <a:spLocks noGrp="1"/>
+          </p:cNvSpPr>
+          <p:nvPr>
+            <p:ph type="body" idx="3" sz="quarter"/>
+          </p:nvPr>
+        </p:nvSpPr>
+        <p:spPr/>
+        <p:txBody>
+          <a:bodyPr/>
+          <a:lstStyle/>
+          <a:p>
+            <a:r>
+              <a:t>Authoritative Week 6 assignment replaces the required build. One page, not one paragraph. Existing due date remains October 11 at 11:59 PM MT. Pods share learning and support each other in class for AT LEAST the next three weeks; do not invent size, rubric, or final-project requirements. Canvas copy is a draft, not yet published.</a:t>
             </a:r>
           </a:p>
         </p:txBody>
@@ -5439,7 +5510,7 @@
                 </a:solidFill>
                 <a:latin typeface="DM Sans"/>
               </a:rPr>
-              <a:t>Week 6 · Opening        1 / 26</a:t>
+              <a:t>Week 6 · Opening        1 / 27</a:t>
             </a:r>
           </a:p>
         </p:txBody>
@@ -5657,7 +5728,7 @@
                 </a:solidFill>
                 <a:latin typeface="DM Sans"/>
               </a:rPr>
-              <a:t>Week 6 · Communicate intent        10 / 26</a:t>
+              <a:t>Week 6 · Communicate intent        10 / 27</a:t>
             </a:r>
           </a:p>
         </p:txBody>
@@ -5875,7 +5946,7 @@
                 </a:solidFill>
                 <a:latin typeface="DM Sans"/>
               </a:rPr>
-              <a:t>Week 6 · Check the work        11 / 26</a:t>
+              <a:t>Week 6 · Check the work        11 / 27</a:t>
             </a:r>
           </a:p>
         </p:txBody>
@@ -6093,7 +6164,7 @@
                 </a:solidFill>
                 <a:latin typeface="DM Sans"/>
               </a:rPr>
-              <a:t>Week 6 · Check the work        12 / 26</a:t>
+              <a:t>Week 6 · Check the work        12 / 27</a:t>
             </a:r>
           </a:p>
         </p:txBody>
@@ -6311,7 +6382,7 @@
                 </a:solidFill>
                 <a:latin typeface="DM Sans"/>
               </a:rPr>
-              <a:t>Week 6 · Working within limits        13 / 26</a:t>
+              <a:t>Week 6 · Working within limits        13 / 27</a:t>
             </a:r>
           </a:p>
         </p:txBody>
@@ -6529,7 +6600,7 @@
                 </a:solidFill>
                 <a:latin typeface="DM Sans"/>
               </a:rPr>
-              <a:t>Week 6 · Getting online        14 / 26</a:t>
+              <a:t>Week 6 · Getting online        14 / 27</a:t>
             </a:r>
           </a:p>
         </p:txBody>
@@ -6747,7 +6818,7 @@
                 </a:solidFill>
                 <a:latin typeface="DM Sans"/>
               </a:rPr>
-              <a:t>Week 6 · Getting online        15 / 26</a:t>
+              <a:t>Week 6 · Getting online        15 / 27</a:t>
             </a:r>
           </a:p>
         </p:txBody>
@@ -6965,7 +7036,7 @@
                 </a:solidFill>
                 <a:latin typeface="DM Sans"/>
               </a:rPr>
-              <a:t>Week 6 · Getting online        16 / 26</a:t>
+              <a:t>Week 6 · Getting online        16 / 27</a:t>
             </a:r>
           </a:p>
         </p:txBody>
@@ -7183,7 +7254,7 @@
                 </a:solidFill>
                 <a:latin typeface="DM Sans"/>
               </a:rPr>
-              <a:t>Week 6 · Getting online        17 / 26</a:t>
+              <a:t>Week 6 · Getting online        17 / 27</a:t>
             </a:r>
           </a:p>
         </p:txBody>
@@ -7401,7 +7472,7 @@
                 </a:solidFill>
                 <a:latin typeface="DM Sans"/>
               </a:rPr>
-              <a:t>Week 6 · Connections—concept only        18 / 26</a:t>
+              <a:t>Week 6 · Connections—concept only        18 / 27</a:t>
             </a:r>
           </a:p>
         </p:txBody>
@@ -7619,7 +7690,7 @@
                 </a:solidFill>
                 <a:latin typeface="DM Sans"/>
               </a:rPr>
-              <a:t>Week 6 · Connections—concept only        19 / 26</a:t>
+              <a:t>Week 6 · Connections—concept only        19 / 27</a:t>
             </a:r>
           </a:p>
         </p:txBody>
@@ -7837,7 +7908,7 @@
                 </a:solidFill>
                 <a:latin typeface="DM Sans"/>
               </a:rPr>
-              <a:t>Week 6 · Why this matters        2 / 26</a:t>
+              <a:t>Week 6 · Why this matters        2 / 27</a:t>
             </a:r>
           </a:p>
         </p:txBody>
@@ -8055,7 +8126,7 @@
                 </a:solidFill>
                 <a:latin typeface="DM Sans"/>
               </a:rPr>
-              <a:t>Week 6 · Learn with AI        20 / 26</a:t>
+              <a:t>Week 6 · Learn with AI        20 / 27</a:t>
             </a:r>
           </a:p>
         </p:txBody>
@@ -8273,7 +8344,7 @@
                 </a:solidFill>
                 <a:latin typeface="DM Sans"/>
               </a:rPr>
-              <a:t>Week 6 · Learn with AI        21 / 26</a:t>
+              <a:t>Week 6 · Learn with AI        21 / 27</a:t>
             </a:r>
           </a:p>
         </p:txBody>
@@ -8491,7 +8562,7 @@
                 </a:solidFill>
                 <a:latin typeface="DM Sans"/>
               </a:rPr>
-              <a:t>Week 6 · Learn with AI        22 / 26</a:t>
+              <a:t>Week 6 · Learn with AI        22 / 27</a:t>
             </a:r>
           </a:p>
         </p:txBody>
@@ -8709,7 +8780,7 @@
                 </a:solidFill>
                 <a:latin typeface="DM Sans"/>
               </a:rPr>
-              <a:t>Week 6 · Use the lesson        23 / 26</a:t>
+              <a:t>Week 6 · Use the lesson        23 / 27</a:t>
             </a:r>
           </a:p>
         </p:txBody>
@@ -8927,7 +8998,7 @@
                 </a:solidFill>
                 <a:latin typeface="DM Sans"/>
               </a:rPr>
-              <a:t>Week 6 · One live demo        24 / 26</a:t>
+              <a:t>Week 6 · One live demo        24 / 27</a:t>
             </a:r>
           </a:p>
         </p:txBody>
@@ -9029,13 +9100,13 @@
               </a:spcAft>
             </a:pPr>
             <a:r>
-              <a:rPr sz="3200" b="1">
+              <a:rPr sz="4000" b="1">
                 <a:solidFill>
                   <a:srgbClr val="272A25"/>
                 </a:solidFill>
                 <a:latin typeface="Fraunces"/>
               </a:rPr>
-              <a:t>In small groups: build for your learning</a:t>
+              <a:t>Optional in-class small-group building</a:t>
             </a:r>
           </a:p>
         </p:txBody>
@@ -9074,7 +9145,7 @@
                 </a:solidFill>
                 <a:latin typeface="DM Sans"/>
               </a:rPr>
-              <a:t>•  Choose a topic you want to understand or practise, and your own approach.</a:t>
+              <a:t>•  Choose a topic and your own approach; building/sharing is optional.</a:t>
             </a:r>
           </a:p>
           <a:p>
@@ -9145,7 +9216,7 @@
                 </a:solidFill>
                 <a:latin typeface="DM Sans"/>
               </a:rPr>
-              <a:t>Week 6 · Group work        25 / 26</a:t>
+              <a:t>Week 6 · Group work        25 / 27</a:t>
             </a:r>
           </a:p>
         </p:txBody>
@@ -9363,7 +9434,241 @@
                 </a:solidFill>
                 <a:latin typeface="DM Sans"/>
               </a:rPr>
-              <a:t>Week 6 · Group work        26 / 26</a:t>
+              <a:t>Week 6 · Group work        26 / 27</a:t>
+            </a:r>
+          </a:p>
+        </p:txBody>
+      </p:sp>
+    </p:spTree>
+  </p:cSld>
+  <p:clrMapOvr>
+    <a:masterClrMapping/>
+  </p:clrMapOvr>
+</p:sld>
+</file>
+
+<file path=ppt/slides/slide27.xml><?xml version="1.0" encoding="utf-8"?>
+<p:sld xmlns:a="http://schemas.openxmlformats.org/drawingml/2006/main" xmlns:p="http://schemas.openxmlformats.org/presentationml/2006/main" xmlns:r="http://schemas.openxmlformats.org/officeDocument/2006/relationships">
+  <p:cSld>
+    <p:bg>
+      <p:bgPr>
+        <a:solidFill>
+          <a:srgbClr val="F7F5EE"/>
+        </a:solidFill>
+        <a:effectLst/>
+      </p:bgPr>
+    </p:bg>
+    <p:spTree>
+      <p:nvGrpSpPr>
+        <p:cNvPr id="1" name=""/>
+        <p:cNvGrpSpPr/>
+        <p:nvPr/>
+      </p:nvGrpSpPr>
+      <p:grpSpPr/>
+      <p:sp>
+        <p:nvSpPr>
+          <p:cNvPr id="2" name="Rectangle 1"/>
+          <p:cNvSpPr/>
+          <p:nvPr/>
+        </p:nvSpPr>
+        <p:spPr>
+          <a:xfrm>
+            <a:off x="0" y="0"/>
+            <a:ext cx="228600" cy="6858000"/>
+          </a:xfrm>
+          <a:prstGeom prst="rect">
+            <a:avLst/>
+          </a:prstGeom>
+          <a:solidFill>
+            <a:srgbClr val="A83D2B"/>
+          </a:solidFill>
+          <a:ln>
+            <a:noFill/>
+          </a:ln>
+        </p:spPr>
+        <p:style>
+          <a:lnRef idx="1">
+            <a:schemeClr val="accent1"/>
+          </a:lnRef>
+          <a:fillRef idx="3">
+            <a:schemeClr val="accent1"/>
+          </a:fillRef>
+          <a:effectRef idx="2">
+            <a:schemeClr val="accent1"/>
+          </a:effectRef>
+          <a:fontRef idx="minor">
+            <a:schemeClr val="lt1"/>
+          </a:fontRef>
+        </p:style>
+        <p:txBody>
+          <a:bodyPr rtlCol="0" anchor="ctr"/>
+          <a:lstStyle/>
+          <a:p>
+            <a:pPr algn="ctr"/>
+          </a:p>
+        </p:txBody>
+      </p:sp>
+      <p:sp>
+        <p:nvSpPr>
+          <p:cNvPr id="3" name="TextBox 2"/>
+          <p:cNvSpPr txBox="1"/>
+          <p:nvPr/>
+        </p:nvSpPr>
+        <p:spPr>
+          <a:xfrm>
+            <a:off x="822960" y="548640"/>
+            <a:ext cx="10607040" cy="1188720"/>
+          </a:xfrm>
+          <a:prstGeom prst="rect">
+            <a:avLst/>
+          </a:prstGeom>
+          <a:noFill/>
+        </p:spPr>
+        <p:txBody>
+          <a:bodyPr wrap="square">
+            <a:spAutoFit/>
+          </a:bodyPr>
+          <a:lstStyle/>
+          <a:p>
+            <a:pPr>
+              <a:spcAft>
+                <a:spcPts val="1400"/>
+              </a:spcAft>
+            </a:pPr>
+            <a:r>
+              <a:rPr sz="4000" b="1">
+                <a:solidFill>
+                  <a:srgbClr val="272A25"/>
+                </a:solidFill>
+                <a:latin typeface="Fraunces"/>
+              </a:rPr>
+              <a:t>This week: ONE PAGE about your learning</a:t>
+            </a:r>
+          </a:p>
+        </p:txBody>
+      </p:sp>
+      <p:sp>
+        <p:nvSpPr>
+          <p:cNvPr id="4" name="TextBox 3"/>
+          <p:cNvSpPr txBox="1"/>
+          <p:nvPr/>
+        </p:nvSpPr>
+        <p:spPr>
+          <a:xfrm>
+            <a:off x="822960" y="2011680"/>
+            <a:ext cx="10607040" cy="4206240"/>
+          </a:xfrm>
+          <a:prstGeom prst="rect">
+            <a:avLst/>
+          </a:prstGeom>
+          <a:noFill/>
+        </p:spPr>
+        <p:txBody>
+          <a:bodyPr wrap="square">
+            <a:spAutoFit/>
+          </a:bodyPr>
+          <a:lstStyle/>
+          <a:p>
+            <a:pPr>
+              <a:spcAft>
+                <a:spcPts val="1600"/>
+              </a:spcAft>
+            </a:pPr>
+            <a:r>
+              <a:rPr sz="2600" b="0">
+                <a:solidFill>
+                  <a:srgbClr val="272A25"/>
+                </a:solidFill>
+                <a:latin typeface="DM Sans"/>
+              </a:rPr>
+              <a:t>•  What you’ve learned, are learning, and want to learn.</a:t>
+            </a:r>
+          </a:p>
+          <a:p>
+            <a:pPr>
+              <a:spcAft>
+                <a:spcPts val="1600"/>
+              </a:spcAft>
+            </a:pPr>
+            <a:r>
+              <a:rPr sz="2600" b="0">
+                <a:solidFill>
+                  <a:srgbClr val="272A25"/>
+                </a:solidFill>
+                <a:latin typeface="DM Sans"/>
+              </a:rPr>
+              <a:t>•  What you want to build; emerging final-project ideas.</a:t>
+            </a:r>
+          </a:p>
+          <a:p>
+            <a:pPr>
+              <a:spcAft>
+                <a:spcPts val="1600"/>
+              </a:spcAft>
+            </a:pPr>
+            <a:r>
+              <a:rPr sz="2600" b="0">
+                <a:solidFill>
+                  <a:srgbClr val="272A25"/>
+                </a:solidFill>
+                <a:latin typeface="DM Sans"/>
+              </a:rPr>
+              <a:t>•  Building/sharing is welcome but OPTIONAL—not required.</a:t>
+            </a:r>
+          </a:p>
+          <a:p>
+            <a:pPr>
+              <a:spcAft>
+                <a:spcPts val="1600"/>
+              </a:spcAft>
+            </a:pPr>
+            <a:r>
+              <a:rPr sz="2600" b="0">
+                <a:solidFill>
+                  <a:srgbClr val="272A25"/>
+                </a:solidFill>
+                <a:latin typeface="DM Sans"/>
+              </a:rPr>
+              <a:t>•  Your reflections will shape consistent peer pods for at least three weeks.</a:t>
+            </a:r>
+          </a:p>
+        </p:txBody>
+      </p:sp>
+      <p:sp>
+        <p:nvSpPr>
+          <p:cNvPr id="5" name="TextBox 4"/>
+          <p:cNvSpPr txBox="1"/>
+          <p:nvPr/>
+        </p:nvSpPr>
+        <p:spPr>
+          <a:xfrm>
+            <a:off x="822960" y="6263640"/>
+            <a:ext cx="10607040" cy="365760"/>
+          </a:xfrm>
+          <a:prstGeom prst="rect">
+            <a:avLst/>
+          </a:prstGeom>
+          <a:noFill/>
+        </p:spPr>
+        <p:txBody>
+          <a:bodyPr wrap="square">
+            <a:spAutoFit/>
+          </a:bodyPr>
+          <a:lstStyle/>
+          <a:p>
+            <a:pPr algn="r">
+              <a:spcAft>
+                <a:spcPts val="1400"/>
+              </a:spcAft>
+            </a:pPr>
+            <a:r>
+              <a:rPr sz="1600" b="0">
+                <a:solidFill>
+                  <a:srgbClr val="64665D"/>
+                </a:solidFill>
+                <a:latin typeface="DM Sans"/>
+              </a:rPr>
+              <a:t>Week 6 · Weekly assignment        27 / 27</a:t>
             </a:r>
           </a:p>
         </p:txBody>
@@ -9581,7 +9886,7 @@
                 </a:solidFill>
                 <a:latin typeface="DM Sans"/>
               </a:rPr>
-              <a:t>Week 6 · Markdown        3 / 26</a:t>
+              <a:t>Week 6 · Markdown        3 / 27</a:t>
             </a:r>
           </a:p>
         </p:txBody>
@@ -9913,7 +10218,7 @@
                 </a:solidFill>
                 <a:latin typeface="DM Sans"/>
               </a:rPr>
-              <a:t>Week 6 · Markdown        4 / 26</a:t>
+              <a:t>Week 6 · Markdown        4 / 27</a:t>
             </a:r>
           </a:p>
         </p:txBody>
@@ -10131,7 +10436,7 @@
                 </a:solidFill>
                 <a:latin typeface="DM Sans"/>
               </a:rPr>
-              <a:t>Week 6 · Ongoing context        5 / 26</a:t>
+              <a:t>Week 6 · Ongoing context        5 / 27</a:t>
             </a:r>
           </a:p>
         </p:txBody>
@@ -10349,7 +10654,7 @@
                 </a:solidFill>
                 <a:latin typeface="DM Sans"/>
               </a:rPr>
-              <a:t>Week 6 · Ongoing context        6 / 26</a:t>
+              <a:t>Week 6 · Ongoing context        6 / 27</a:t>
             </a:r>
           </a:p>
         </p:txBody>
@@ -10567,7 +10872,7 @@
                 </a:solidFill>
                 <a:latin typeface="DM Sans"/>
               </a:rPr>
-              <a:t>Week 6 · Ongoing context        7 / 26</a:t>
+              <a:t>Week 6 · Ongoing context        7 / 27</a:t>
             </a:r>
           </a:p>
         </p:txBody>
@@ -10785,7 +11090,7 @@
                 </a:solidFill>
                 <a:latin typeface="DM Sans"/>
               </a:rPr>
-              <a:t>Week 6 · Ongoing context        8 / 26</a:t>
+              <a:t>Week 6 · Ongoing context        8 / 27</a:t>
             </a:r>
           </a:p>
         </p:txBody>
@@ -11003,7 +11308,7 @@
                 </a:solidFill>
                 <a:latin typeface="DM Sans"/>
               </a:rPr>
-              <a:t>Week 6 · Communicate intent        9 / 26</a:t>
+              <a:t>Week 6 · Communicate intent        9 / 27</a:t>
             </a:r>
           </a:p>
         </p:txBody>

</xml_diff>

<commit_message>
Week 6: AGENTS.md works across coding agents incl. Claude Code; API vs MCP (connectors in Claude); drop permissions slide
</commit_message>
<xml_diff>
--- a/lessons/week-6/_src/week6-lecture.pptx
+++ b/lessons/week-6/_src/week6-lecture.pptx
@@ -31,7 +31,6 @@
     <p:sldId id="279" r:id="rId31"/>
     <p:sldId id="280" r:id="rId32"/>
     <p:sldId id="281" r:id="rId33"/>
-    <p:sldId id="282" r:id="rId34"/>
   </p:sldIdLst>
   <p:sldSz cx="12191695" cy="6858000" type="screen4x3"/>
   <p:notesSz cx="6858000" cy="9144000"/>
@@ -1158,7 +1157,7 @@
           <a:lstStyle/>
           <a:p>
             <a:r>
-              <a:t>Example: weather service API returns a forecast; an AI connector calls it for a conversation. Conceptual only: no course server URL, setup or connector demo this week.</a:t>
+              <a:t>Example: a weather service has an API that returns a forecast. An MCP connection lets your AI use services like that inside a conversation. In Claude these show up as connectors. Concept only tonight; next week we connect.</a:t>
             </a:r>
           </a:p>
         </p:txBody>
@@ -1228,7 +1227,7 @@
           <a:lstStyle/>
           <a:p>
             <a:r>
-              <a:t>Tools extend what the AI can do, not what it should be allowed to do. Responsibilities remain with the person using it. Four Ds stay implicit.</a:t>
+              <a:t>Students recently asked their tools to explain the tool itself while building. Model this as a learning practice, not outsourcing understanding.</a:t>
             </a:r>
           </a:p>
         </p:txBody>
@@ -1368,7 +1367,7 @@
           <a:lstStyle/>
           <a:p>
             <a:r>
-              <a:t>Students recently asked their tools to explain the tool itself while building. Model this as a learning practice, not outsourcing understanding.</a:t>
+              <a:t>Assigned reading. Shipper turned reflection on actual projects into a coaching conversation. The reading link is in students’ accounts; no new due date.</a:t>
             </a:r>
           </a:p>
         </p:txBody>
@@ -1438,7 +1437,7 @@
           <a:lstStyle/>
           <a:p>
             <a:r>
-              <a:t>Assigned reading. Shipper turned reflection on actual projects into a coaching conversation. The reading link is in students’ accounts; no new due date.</a:t>
+              <a:t>Free plans need not have long-term memory. Give a small truthful sample, not every private conversation.</a:t>
             </a:r>
           </a:p>
         </p:txBody>
@@ -1508,7 +1507,7 @@
           <a:lstStyle/>
           <a:p>
             <a:r>
-              <a:t>Free plans need not have long-term memory. Give a small truthful sample, not every private conversation.</a:t>
+              <a:t>Every essential access instruction is here, not hidden in a handout. This is how the reading’s coaching idea becomes something students can do tonight.</a:t>
             </a:r>
           </a:p>
         </p:txBody>
@@ -1578,7 +1577,7 @@
           <a:lstStyle/>
           <a:p>
             <a:r>
-              <a:t>Every essential access instruction is here, not hidden in a handout. This is how the reading’s coaching idea becomes something students can do tonight.</a:t>
+              <a:t>This is the only live demo slot, after the teaching content. Do not prescribe a project, script or output. If delayed, discuss a question from the lesson and move to group work.</a:t>
             </a:r>
           </a:p>
         </p:txBody>
@@ -1648,7 +1647,7 @@
           <a:lstStyle/>
           <a:p>
             <a:r>
-              <a:t>This is the only live demo slot, after the teaching content. Do not prescribe a project, script or output. If delayed, discuss a question from the lesson and move to group work.</a:t>
+              <a:t>Open-ended invitation, no fixed template or prescribed roles. Help students choose a small first learning goal without deciding their project for them.</a:t>
             </a:r>
           </a:p>
         </p:txBody>
@@ -1718,7 +1717,7 @@
           <a:lstStyle/>
           <a:p>
             <a:r>
-              <a:t>Open-ended invitation, no fixed template or prescribed roles. Help students choose a small first learning goal without deciding their project for them.</a:t>
+              <a:t>Optional: ask your AI what it needs to know about your project; save the useful context in markdown. Students can find the lesson from the preceding slide. No due date added.</a:t>
             </a:r>
           </a:p>
         </p:txBody>
@@ -1788,76 +1787,6 @@
           <a:lstStyle/>
           <a:p>
             <a:r>
-              <a:t>Optional: ask your AI what it needs to know about your project; save the useful context in markdown. Students can find the lesson from the preceding slide. No due date added.</a:t>
-            </a:r>
-          </a:p>
-        </p:txBody>
-      </p:sp>
-      <p:sp>
-        <p:nvSpPr>
-          <p:cNvPr id="4" name="Slide Number Placeholder 3"/>
-          <p:cNvSpPr>
-            <a:spLocks noGrp="1"/>
-          </p:cNvSpPr>
-          <p:nvPr>
-            <p:ph type="sldNum" idx="5" sz="quarter"/>
-          </p:nvPr>
-        </p:nvSpPr>
-        <p:spPr/>
-      </p:sp>
-    </p:spTree>
-  </p:cSld>
-  <p:clrMapOvr>
-    <a:masterClrMapping/>
-  </p:clrMapOvr>
-</p:notes>
-</file>
-
-<file path=ppt/notesSlides/notesSlide27.xml><?xml version="1.0" encoding="utf-8"?>
-<p:notes xmlns:a="http://schemas.openxmlformats.org/drawingml/2006/main" xmlns:p="http://schemas.openxmlformats.org/presentationml/2006/main" xmlns:r="http://schemas.openxmlformats.org/officeDocument/2006/relationships">
-  <p:cSld>
-    <p:spTree>
-      <p:nvGrpSpPr>
-        <p:cNvPr id="1" name=""/>
-        <p:cNvGrpSpPr/>
-        <p:nvPr/>
-      </p:nvGrpSpPr>
-      <p:grpSpPr>
-        <a:xfrm>
-          <a:off x="0" y="0"/>
-          <a:ext cx="0" cy="0"/>
-          <a:chOff x="0" y="0"/>
-          <a:chExt cx="0" cy="0"/>
-        </a:xfrm>
-      </p:grpSpPr>
-      <p:sp>
-        <p:nvSpPr>
-          <p:cNvPr id="2" name="Slide Image Placeholder 1"/>
-          <p:cNvSpPr>
-            <a:spLocks noGrp="1"/>
-          </p:cNvSpPr>
-          <p:nvPr>
-            <p:ph type="sldImg" idx="2"/>
-          </p:nvPr>
-        </p:nvSpPr>
-        <p:spPr/>
-      </p:sp>
-      <p:sp>
-        <p:nvSpPr>
-          <p:cNvPr id="3" name="Notes Placeholder 2"/>
-          <p:cNvSpPr>
-            <a:spLocks noGrp="1"/>
-          </p:cNvSpPr>
-          <p:nvPr>
-            <p:ph type="body" idx="3" sz="quarter"/>
-          </p:nvPr>
-        </p:nvSpPr>
-        <p:spPr/>
-        <p:txBody>
-          <a:bodyPr/>
-          <a:lstStyle/>
-          <a:p>
-            <a:r>
               <a:t>Authoritative Week 6 assignment replaces the required build. One page, not one paragraph. Existing due date remains October 11 at 11:59 PM MT. Pods share learning and support each other in class for AT LEAST the next three weeks; do not invent size, rubric, or final-project requirements. Canvas copy is a draft, not yet published.</a:t>
             </a:r>
           </a:p>
@@ -2208,7 +2137,7 @@
           <a:lstStyle/>
           <a:p>
             <a:r>
-              <a:t>Do not imply any file name works universally. Our tested Claude Code installation also found AGENTS.md, but teach documented primary filenames. A fresh-session question can reveal whether the tool saw the file.</a:t>
+              <a:t>Put the file in the top folder of the project. Verified tonight: Claude Code picked up AGENTS.md in a fresh session. Keep the point simple: write the context once, and the agent starts with it.</a:t>
             </a:r>
           </a:p>
         </p:txBody>
@@ -5510,7 +5439,7 @@
                 </a:solidFill>
                 <a:latin typeface="DM Sans"/>
               </a:rPr>
-              <a:t>Week 6 · Opening        1 / 27</a:t>
+              <a:t>Week 6 · Opening        1 / 26</a:t>
             </a:r>
           </a:p>
         </p:txBody>
@@ -5728,7 +5657,7 @@
                 </a:solidFill>
                 <a:latin typeface="DM Sans"/>
               </a:rPr>
-              <a:t>Week 6 · Communicate intent        10 / 27</a:t>
+              <a:t>Week 6 · Communicate intent        10 / 26</a:t>
             </a:r>
           </a:p>
         </p:txBody>
@@ -5946,7 +5875,7 @@
                 </a:solidFill>
                 <a:latin typeface="DM Sans"/>
               </a:rPr>
-              <a:t>Week 6 · Check the work        11 / 27</a:t>
+              <a:t>Week 6 · Check the work        11 / 26</a:t>
             </a:r>
           </a:p>
         </p:txBody>
@@ -6164,7 +6093,7 @@
                 </a:solidFill>
                 <a:latin typeface="DM Sans"/>
               </a:rPr>
-              <a:t>Week 6 · Check the work        12 / 27</a:t>
+              <a:t>Week 6 · Check the work        12 / 26</a:t>
             </a:r>
           </a:p>
         </p:txBody>
@@ -6382,7 +6311,7 @@
                 </a:solidFill>
                 <a:latin typeface="DM Sans"/>
               </a:rPr>
-              <a:t>Week 6 · Working within limits        13 / 27</a:t>
+              <a:t>Week 6 · Working within limits        13 / 26</a:t>
             </a:r>
           </a:p>
         </p:txBody>
@@ -6600,7 +6529,7 @@
                 </a:solidFill>
                 <a:latin typeface="DM Sans"/>
               </a:rPr>
-              <a:t>Week 6 · Getting online        14 / 27</a:t>
+              <a:t>Week 6 · Getting online        14 / 26</a:t>
             </a:r>
           </a:p>
         </p:txBody>
@@ -6818,7 +6747,7 @@
                 </a:solidFill>
                 <a:latin typeface="DM Sans"/>
               </a:rPr>
-              <a:t>Week 6 · Getting online        15 / 27</a:t>
+              <a:t>Week 6 · Getting online        15 / 26</a:t>
             </a:r>
           </a:p>
         </p:txBody>
@@ -7036,7 +6965,7 @@
                 </a:solidFill>
                 <a:latin typeface="DM Sans"/>
               </a:rPr>
-              <a:t>Week 6 · Getting online        16 / 27</a:t>
+              <a:t>Week 6 · Getting online        16 / 26</a:t>
             </a:r>
           </a:p>
         </p:txBody>
@@ -7254,7 +7183,7 @@
                 </a:solidFill>
                 <a:latin typeface="DM Sans"/>
               </a:rPr>
-              <a:t>Week 6 · Getting online        17 / 27</a:t>
+              <a:t>Week 6 · Getting online        17 / 26</a:t>
             </a:r>
           </a:p>
         </p:txBody>
@@ -7362,7 +7291,7 @@
                 </a:solidFill>
                 <a:latin typeface="Fraunces"/>
               </a:rPr>
-              <a:t>API, connector, MCP: what is the difference?</a:t>
+              <a:t>APIs and MCP: how AI connects to other tools</a:t>
             </a:r>
           </a:p>
         </p:txBody>
@@ -7401,7 +7330,7 @@
                 </a:solidFill>
                 <a:latin typeface="DM Sans"/>
               </a:rPr>
-              <a:t>•  API: a service’s menu of requests that another program can make.</a:t>
+              <a:t>•  API: how one program requests information or actions from another.</a:t>
             </a:r>
           </a:p>
           <a:p>
@@ -7417,7 +7346,7 @@
                 </a:solidFill>
                 <a:latin typeface="DM Sans"/>
               </a:rPr>
-              <a:t>•  Connector: a bridge that lets your AI reach a service or files.</a:t>
+              <a:t>•  MCP: a standard way for AI tools to connect to other services and data.</a:t>
             </a:r>
           </a:p>
           <a:p>
@@ -7433,7 +7362,7 @@
                 </a:solidFill>
                 <a:latin typeface="DM Sans"/>
               </a:rPr>
-              <a:t>•  MCP: a shared protocol for AI apps to use tools; an MCP server may call an API.</a:t>
+              <a:t>•  In Claude, these MCP connections are called connectors.</a:t>
             </a:r>
           </a:p>
         </p:txBody>
@@ -7472,7 +7401,7 @@
                 </a:solidFill>
                 <a:latin typeface="DM Sans"/>
               </a:rPr>
-              <a:t>Week 6 · Connections—concept only        18 / 27</a:t>
+              <a:t>Week 6 · Connections—concept only        18 / 26</a:t>
             </a:r>
           </a:p>
         </p:txBody>
@@ -7580,7 +7509,7 @@
                 </a:solidFill>
                 <a:latin typeface="Fraunces"/>
               </a:rPr>
-              <a:t>Access is a choice: read versus write</a:t>
+              <a:t>Use AI to learn about AI</a:t>
             </a:r>
           </a:p>
         </p:txBody>
@@ -7619,7 +7548,7 @@
                 </a:solidFill>
                 <a:latin typeface="DM Sans"/>
               </a:rPr>
-              <a:t>•  Read access can expose data; write access can change or delete it.</a:t>
+              <a:t>•  Ask for an explanation, an example, and a question to check your understanding.</a:t>
             </a:r>
           </a:p>
           <a:p>
@@ -7635,7 +7564,7 @@
                 </a:solidFill>
                 <a:latin typeface="DM Sans"/>
               </a:rPr>
-              <a:t>•  Give only the access needed; review changes before publishing or sending.</a:t>
+              <a:t>•  Say what you already know: “I know HTML; Git is new to me.”</a:t>
             </a:r>
           </a:p>
           <a:p>
@@ -7651,7 +7580,7 @@
                 </a:solidFill>
                 <a:latin typeface="DM Sans"/>
               </a:rPr>
-              <a:t>•  Keep keys, passwords and private data out of public files and repositories.</a:t>
+              <a:t>•  Compare its explanation with your source—not just how confident it sounds.</a:t>
             </a:r>
           </a:p>
         </p:txBody>
@@ -7690,7 +7619,7 @@
                 </a:solidFill>
                 <a:latin typeface="DM Sans"/>
               </a:rPr>
-              <a:t>Week 6 · Connections—concept only        19 / 27</a:t>
+              <a:t>Week 6 · Learn with AI        19 / 26</a:t>
             </a:r>
           </a:p>
         </p:txBody>
@@ -7908,7 +7837,7 @@
                 </a:solidFill>
                 <a:latin typeface="DM Sans"/>
               </a:rPr>
-              <a:t>Week 6 · Why this matters        2 / 27</a:t>
+              <a:t>Week 6 · Why this matters        2 / 26</a:t>
             </a:r>
           </a:p>
         </p:txBody>
@@ -8016,7 +7945,7 @@
                 </a:solidFill>
                 <a:latin typeface="Fraunces"/>
               </a:rPr>
-              <a:t>Use AI to learn about AI</a:t>
+              <a:t>The reading: your AI as a coach</a:t>
             </a:r>
           </a:p>
         </p:txBody>
@@ -8055,7 +7984,7 @@
                 </a:solidFill>
                 <a:latin typeface="DM Sans"/>
               </a:rPr>
-              <a:t>•  Ask for an explanation, an example, and a question to check your understanding.</a:t>
+              <a:t>•  Arielle Shipper · “How to Get Better at AI by Asking AI” · Every</a:t>
             </a:r>
           </a:p>
           <a:p>
@@ -8071,7 +8000,7 @@
                 </a:solidFill>
                 <a:latin typeface="DM Sans"/>
               </a:rPr>
-              <a:t>•  Say what you already know: “I know HTML; Git is new to me.”</a:t>
+              <a:t>•  Ask where you are on the Eight Levels of AI Adoption, with evidence from your work.</a:t>
             </a:r>
           </a:p>
           <a:p>
@@ -8087,7 +8016,7 @@
                 </a:solidFill>
                 <a:latin typeface="DM Sans"/>
               </a:rPr>
-              <a:t>•  Compare its explanation with your source—not just how confident it sounds.</a:t>
+              <a:t>•  Ask for one next step, then: “Teach me that and help me practise.”</a:t>
             </a:r>
           </a:p>
         </p:txBody>
@@ -8126,7 +8055,7 @@
                 </a:solidFill>
                 <a:latin typeface="DM Sans"/>
               </a:rPr>
-              <a:t>Week 6 · Learn with AI        20 / 27</a:t>
+              <a:t>Week 6 · Learn with AI        20 / 26</a:t>
             </a:r>
           </a:p>
         </p:txBody>
@@ -8228,13 +8157,13 @@
               </a:spcAft>
             </a:pPr>
             <a:r>
-              <a:rPr sz="4000" b="1">
+              <a:rPr sz="3200" b="1">
                 <a:solidFill>
                   <a:srgbClr val="272A25"/>
                 </a:solidFill>
                 <a:latin typeface="Fraunces"/>
               </a:rPr>
-              <a:t>The reading: your AI as a coach</a:t>
+              <a:t>No long chat history? Bring your own evidence</a:t>
             </a:r>
           </a:p>
         </p:txBody>
@@ -8273,7 +8202,7 @@
                 </a:solidFill>
                 <a:latin typeface="DM Sans"/>
               </a:rPr>
-              <a:t>•  Arielle Shipper · “How to Get Better at AI by Asking AI” · Every</a:t>
+              <a:t>•  Paste your last two submissions or describe a recent project.</a:t>
             </a:r>
           </a:p>
           <a:p>
@@ -8289,7 +8218,7 @@
                 </a:solidFill>
                 <a:latin typeface="DM Sans"/>
               </a:rPr>
-              <a:t>•  Ask where you are on the Eight Levels of AI Adoption, with evidence from your work.</a:t>
+              <a:t>•  Ask: “What can I do already? Show examples. What should I learn next?”</a:t>
             </a:r>
           </a:p>
           <a:p>
@@ -8305,7 +8234,7 @@
                 </a:solidFill>
                 <a:latin typeface="DM Sans"/>
               </a:rPr>
-              <a:t>•  Ask for one next step, then: “Teach me that and help me practise.”</a:t>
+              <a:t>•  Treat the AI’s assessment as a suggestion; correct its assumptions.</a:t>
             </a:r>
           </a:p>
         </p:txBody>
@@ -8344,7 +8273,7 @@
                 </a:solidFill>
                 <a:latin typeface="DM Sans"/>
               </a:rPr>
-              <a:t>Week 6 · Learn with AI        21 / 27</a:t>
+              <a:t>Week 6 · Learn with AI        21 / 26</a:t>
             </a:r>
           </a:p>
         </p:txBody>
@@ -8446,13 +8375,13 @@
               </a:spcAft>
             </a:pPr>
             <a:r>
-              <a:rPr sz="3200" b="1">
+              <a:rPr sz="4000" b="1">
                 <a:solidFill>
                   <a:srgbClr val="272A25"/>
                 </a:solidFill>
                 <a:latin typeface="Fraunces"/>
               </a:rPr>
-              <a:t>No long chat history? Bring your own evidence</a:t>
+              <a:t>Bring this lesson into your own AI</a:t>
             </a:r>
           </a:p>
         </p:txBody>
@@ -8491,7 +8420,7 @@
                 </a:solidFill>
                 <a:latin typeface="DM Sans"/>
               </a:rPr>
-              <a:t>•  Paste your last two submissions or describe a recent project.</a:t>
+              <a:t>•  Open cu.learnvibe.build → Everything for Week 6.</a:t>
             </a:r>
           </a:p>
           <a:p>
@@ -8507,7 +8436,7 @@
                 </a:solidFill>
                 <a:latin typeface="DM Sans"/>
               </a:rPr>
-              <a:t>•  Ask: “What can I do already? Show examples. What should I learn next?”</a:t>
+              <a:t>•  Click “Copy lesson as markdown”; paste it into Claude or another AI.</a:t>
             </a:r>
           </a:p>
           <a:p>
@@ -8523,7 +8452,7 @@
                 </a:solidFill>
                 <a:latin typeface="DM Sans"/>
               </a:rPr>
-              <a:t>•  Treat the AI’s assessment as a suggestion; correct its assumptions.</a:t>
+              <a:t>•  Ask: “Teach me this and quiz me”—then ask follow-ups in your own words.</a:t>
             </a:r>
           </a:p>
         </p:txBody>
@@ -8562,7 +8491,7 @@
                 </a:solidFill>
                 <a:latin typeface="DM Sans"/>
               </a:rPr>
-              <a:t>Week 6 · Learn with AI        22 / 27</a:t>
+              <a:t>Week 6 · Use the lesson        22 / 26</a:t>
             </a:r>
           </a:p>
         </p:txBody>
@@ -8664,13 +8593,13 @@
               </a:spcAft>
             </a:pPr>
             <a:r>
-              <a:rPr sz="4000" b="1">
+              <a:rPr sz="3200" b="1">
                 <a:solidFill>
                   <a:srgbClr val="272A25"/>
                 </a:solidFill>
                 <a:latin typeface="Fraunces"/>
               </a:rPr>
-              <a:t>Bring this lesson into your own AI</a:t>
+              <a:t>After the slides: one conversation with Claude</a:t>
             </a:r>
           </a:p>
         </p:txBody>
@@ -8709,7 +8638,7 @@
                 </a:solidFill>
                 <a:latin typeface="DM Sans"/>
               </a:rPr>
-              <a:t>•  Open cu.learnvibe.build → Everything for Week 6.</a:t>
+              <a:t>•  Aaron will paste the lesson and talk through it with Claude.</a:t>
             </a:r>
           </a:p>
           <a:p>
@@ -8725,7 +8654,7 @@
                 </a:solidFill>
                 <a:latin typeface="DM Sans"/>
               </a:rPr>
-              <a:t>•  Click “Copy lesson as markdown”; paste it into Claude or another AI.</a:t>
+              <a:t>•  The conversation may lead to building a little thing.</a:t>
             </a:r>
           </a:p>
           <a:p>
@@ -8741,7 +8670,7 @@
                 </a:solidFill>
                 <a:latin typeface="DM Sans"/>
               </a:rPr>
-              <a:t>•  Ask: “Teach me this and quiz me”—then ask follow-ups in your own words.</a:t>
+              <a:t>•  Watch how questions, context and checking shape the result.</a:t>
             </a:r>
           </a:p>
         </p:txBody>
@@ -8780,7 +8709,7 @@
                 </a:solidFill>
                 <a:latin typeface="DM Sans"/>
               </a:rPr>
-              <a:t>Week 6 · Use the lesson        23 / 27</a:t>
+              <a:t>Week 6 · One live demo        23 / 26</a:t>
             </a:r>
           </a:p>
         </p:txBody>
@@ -8882,13 +8811,13 @@
               </a:spcAft>
             </a:pPr>
             <a:r>
-              <a:rPr sz="3200" b="1">
+              <a:rPr sz="4000" b="1">
                 <a:solidFill>
                   <a:srgbClr val="272A25"/>
                 </a:solidFill>
                 <a:latin typeface="Fraunces"/>
               </a:rPr>
-              <a:t>After the slides: one conversation with Claude</a:t>
+              <a:t>Optional in-class small-group building</a:t>
             </a:r>
           </a:p>
         </p:txBody>
@@ -8927,7 +8856,7 @@
                 </a:solidFill>
                 <a:latin typeface="DM Sans"/>
               </a:rPr>
-              <a:t>•  Aaron will paste the lesson and talk through it with Claude.</a:t>
+              <a:t>•  Choose a topic and your own approach; building/sharing is optional.</a:t>
             </a:r>
           </a:p>
           <a:p>
@@ -8943,7 +8872,7 @@
                 </a:solidFill>
                 <a:latin typeface="DM Sans"/>
               </a:rPr>
-              <a:t>•  The conversation may lead to building a little thing.</a:t>
+              <a:t>•  Make a quiz, interactive explainer, practice tool—or an idea of your own.</a:t>
             </a:r>
           </a:p>
           <a:p>
@@ -8959,7 +8888,7 @@
                 </a:solidFill>
                 <a:latin typeface="DM Sans"/>
               </a:rPr>
-              <a:t>•  Watch how questions, context and checking shape the result.</a:t>
+              <a:t>•  Use your AI; try the first version yourselves; check it and revise.</a:t>
             </a:r>
           </a:p>
         </p:txBody>
@@ -8998,7 +8927,7 @@
                 </a:solidFill>
                 <a:latin typeface="DM Sans"/>
               </a:rPr>
-              <a:t>Week 6 · One live demo        24 / 27</a:t>
+              <a:t>Week 6 · Group work        24 / 26</a:t>
             </a:r>
           </a:p>
         </p:txBody>
@@ -9106,7 +9035,7 @@
                 </a:solidFill>
                 <a:latin typeface="Fraunces"/>
               </a:rPr>
-              <a:t>Optional in-class small-group building</a:t>
+              <a:t>How to start—and what to share</a:t>
             </a:r>
           </a:p>
         </p:txBody>
@@ -9145,7 +9074,7 @@
                 </a:solidFill>
                 <a:latin typeface="DM Sans"/>
               </a:rPr>
-              <a:t>•  Choose a topic and your own approach; building/sharing is optional.</a:t>
+              <a:t>•  Give your AI the lesson, your learning question, or both.</a:t>
             </a:r>
           </a:p>
           <a:p>
@@ -9161,7 +9090,7 @@
                 </a:solidFill>
                 <a:latin typeface="DM Sans"/>
               </a:rPr>
-              <a:t>•  Make a quiz, interactive explainer, practice tool—or an idea of your own.</a:t>
+              <a:t>•  Ask for a small first version. Test whether it actually helps you learn.</a:t>
             </a:r>
           </a:p>
           <a:p>
@@ -9177,7 +9106,7 @@
                 </a:solidFill>
                 <a:latin typeface="DM Sans"/>
               </a:rPr>
-              <a:t>•  Use your AI; try the first version yourselves; check it and revise.</a:t>
+              <a:t>•  Show what you made, what you learned, and one thing you checked or changed.</a:t>
             </a:r>
           </a:p>
         </p:txBody>
@@ -9216,7 +9145,7 @@
                 </a:solidFill>
                 <a:latin typeface="DM Sans"/>
               </a:rPr>
-              <a:t>Week 6 · Group work        25 / 27</a:t>
+              <a:t>Week 6 · Group work        25 / 26</a:t>
             </a:r>
           </a:p>
         </p:txBody>
@@ -9324,7 +9253,7 @@
                 </a:solidFill>
                 <a:latin typeface="Fraunces"/>
               </a:rPr>
-              <a:t>How to start—and what to share</a:t>
+              <a:t>This week: ONE PAGE about your learning</a:t>
             </a:r>
           </a:p>
         </p:txBody>
@@ -9353,49 +9282,65 @@
           <a:p>
             <a:pPr>
               <a:spcAft>
-                <a:spcPts val="2200"/>
-              </a:spcAft>
-            </a:pPr>
-            <a:r>
-              <a:rPr sz="3000" b="0">
+                <a:spcPts val="1600"/>
+              </a:spcAft>
+            </a:pPr>
+            <a:r>
+              <a:rPr sz="2600" b="0">
                 <a:solidFill>
                   <a:srgbClr val="272A25"/>
                 </a:solidFill>
                 <a:latin typeface="DM Sans"/>
               </a:rPr>
-              <a:t>•  Give your AI the lesson, your learning question, or both.</a:t>
+              <a:t>•  What you’ve learned, are learning, and want to learn.</a:t>
             </a:r>
           </a:p>
           <a:p>
             <a:pPr>
               <a:spcAft>
-                <a:spcPts val="2200"/>
-              </a:spcAft>
-            </a:pPr>
-            <a:r>
-              <a:rPr sz="3000" b="0">
+                <a:spcPts val="1600"/>
+              </a:spcAft>
+            </a:pPr>
+            <a:r>
+              <a:rPr sz="2600" b="0">
                 <a:solidFill>
                   <a:srgbClr val="272A25"/>
                 </a:solidFill>
                 <a:latin typeface="DM Sans"/>
               </a:rPr>
-              <a:t>•  Ask for a small first version. Test whether it actually helps you learn.</a:t>
+              <a:t>•  What you want to build; emerging final-project ideas.</a:t>
             </a:r>
           </a:p>
           <a:p>
             <a:pPr>
               <a:spcAft>
-                <a:spcPts val="2200"/>
-              </a:spcAft>
-            </a:pPr>
-            <a:r>
-              <a:rPr sz="3000" b="0">
+                <a:spcPts val="1600"/>
+              </a:spcAft>
+            </a:pPr>
+            <a:r>
+              <a:rPr sz="2600" b="0">
                 <a:solidFill>
                   <a:srgbClr val="272A25"/>
                 </a:solidFill>
                 <a:latin typeface="DM Sans"/>
               </a:rPr>
-              <a:t>•  Show what you made, what you learned, and one thing you checked or changed.</a:t>
+              <a:t>•  Building/sharing is welcome but OPTIONAL—not required.</a:t>
+            </a:r>
+          </a:p>
+          <a:p>
+            <a:pPr>
+              <a:spcAft>
+                <a:spcPts val="1600"/>
+              </a:spcAft>
+            </a:pPr>
+            <a:r>
+              <a:rPr sz="2600" b="0">
+                <a:solidFill>
+                  <a:srgbClr val="272A25"/>
+                </a:solidFill>
+                <a:latin typeface="DM Sans"/>
+              </a:rPr>
+              <a:t>•  Your reflections will shape consistent peer pods for at least three weeks.</a:t>
             </a:r>
           </a:p>
         </p:txBody>
@@ -9434,241 +9379,7 @@
                 </a:solidFill>
                 <a:latin typeface="DM Sans"/>
               </a:rPr>
-              <a:t>Week 6 · Group work        26 / 27</a:t>
-            </a:r>
-          </a:p>
-        </p:txBody>
-      </p:sp>
-    </p:spTree>
-  </p:cSld>
-  <p:clrMapOvr>
-    <a:masterClrMapping/>
-  </p:clrMapOvr>
-</p:sld>
-</file>
-
-<file path=ppt/slides/slide27.xml><?xml version="1.0" encoding="utf-8"?>
-<p:sld xmlns:a="http://schemas.openxmlformats.org/drawingml/2006/main" xmlns:p="http://schemas.openxmlformats.org/presentationml/2006/main" xmlns:r="http://schemas.openxmlformats.org/officeDocument/2006/relationships">
-  <p:cSld>
-    <p:bg>
-      <p:bgPr>
-        <a:solidFill>
-          <a:srgbClr val="F7F5EE"/>
-        </a:solidFill>
-        <a:effectLst/>
-      </p:bgPr>
-    </p:bg>
-    <p:spTree>
-      <p:nvGrpSpPr>
-        <p:cNvPr id="1" name=""/>
-        <p:cNvGrpSpPr/>
-        <p:nvPr/>
-      </p:nvGrpSpPr>
-      <p:grpSpPr/>
-      <p:sp>
-        <p:nvSpPr>
-          <p:cNvPr id="2" name="Rectangle 1"/>
-          <p:cNvSpPr/>
-          <p:nvPr/>
-        </p:nvSpPr>
-        <p:spPr>
-          <a:xfrm>
-            <a:off x="0" y="0"/>
-            <a:ext cx="228600" cy="6858000"/>
-          </a:xfrm>
-          <a:prstGeom prst="rect">
-            <a:avLst/>
-          </a:prstGeom>
-          <a:solidFill>
-            <a:srgbClr val="A83D2B"/>
-          </a:solidFill>
-          <a:ln>
-            <a:noFill/>
-          </a:ln>
-        </p:spPr>
-        <p:style>
-          <a:lnRef idx="1">
-            <a:schemeClr val="accent1"/>
-          </a:lnRef>
-          <a:fillRef idx="3">
-            <a:schemeClr val="accent1"/>
-          </a:fillRef>
-          <a:effectRef idx="2">
-            <a:schemeClr val="accent1"/>
-          </a:effectRef>
-          <a:fontRef idx="minor">
-            <a:schemeClr val="lt1"/>
-          </a:fontRef>
-        </p:style>
-        <p:txBody>
-          <a:bodyPr rtlCol="0" anchor="ctr"/>
-          <a:lstStyle/>
-          <a:p>
-            <a:pPr algn="ctr"/>
-          </a:p>
-        </p:txBody>
-      </p:sp>
-      <p:sp>
-        <p:nvSpPr>
-          <p:cNvPr id="3" name="TextBox 2"/>
-          <p:cNvSpPr txBox="1"/>
-          <p:nvPr/>
-        </p:nvSpPr>
-        <p:spPr>
-          <a:xfrm>
-            <a:off x="822960" y="548640"/>
-            <a:ext cx="10607040" cy="1188720"/>
-          </a:xfrm>
-          <a:prstGeom prst="rect">
-            <a:avLst/>
-          </a:prstGeom>
-          <a:noFill/>
-        </p:spPr>
-        <p:txBody>
-          <a:bodyPr wrap="square">
-            <a:spAutoFit/>
-          </a:bodyPr>
-          <a:lstStyle/>
-          <a:p>
-            <a:pPr>
-              <a:spcAft>
-                <a:spcPts val="1400"/>
-              </a:spcAft>
-            </a:pPr>
-            <a:r>
-              <a:rPr sz="4000" b="1">
-                <a:solidFill>
-                  <a:srgbClr val="272A25"/>
-                </a:solidFill>
-                <a:latin typeface="Fraunces"/>
-              </a:rPr>
-              <a:t>This week: ONE PAGE about your learning</a:t>
-            </a:r>
-          </a:p>
-        </p:txBody>
-      </p:sp>
-      <p:sp>
-        <p:nvSpPr>
-          <p:cNvPr id="4" name="TextBox 3"/>
-          <p:cNvSpPr txBox="1"/>
-          <p:nvPr/>
-        </p:nvSpPr>
-        <p:spPr>
-          <a:xfrm>
-            <a:off x="822960" y="2011680"/>
-            <a:ext cx="10607040" cy="4206240"/>
-          </a:xfrm>
-          <a:prstGeom prst="rect">
-            <a:avLst/>
-          </a:prstGeom>
-          <a:noFill/>
-        </p:spPr>
-        <p:txBody>
-          <a:bodyPr wrap="square">
-            <a:spAutoFit/>
-          </a:bodyPr>
-          <a:lstStyle/>
-          <a:p>
-            <a:pPr>
-              <a:spcAft>
-                <a:spcPts val="1600"/>
-              </a:spcAft>
-            </a:pPr>
-            <a:r>
-              <a:rPr sz="2600" b="0">
-                <a:solidFill>
-                  <a:srgbClr val="272A25"/>
-                </a:solidFill>
-                <a:latin typeface="DM Sans"/>
-              </a:rPr>
-              <a:t>•  What you’ve learned, are learning, and want to learn.</a:t>
-            </a:r>
-          </a:p>
-          <a:p>
-            <a:pPr>
-              <a:spcAft>
-                <a:spcPts val="1600"/>
-              </a:spcAft>
-            </a:pPr>
-            <a:r>
-              <a:rPr sz="2600" b="0">
-                <a:solidFill>
-                  <a:srgbClr val="272A25"/>
-                </a:solidFill>
-                <a:latin typeface="DM Sans"/>
-              </a:rPr>
-              <a:t>•  What you want to build; emerging final-project ideas.</a:t>
-            </a:r>
-          </a:p>
-          <a:p>
-            <a:pPr>
-              <a:spcAft>
-                <a:spcPts val="1600"/>
-              </a:spcAft>
-            </a:pPr>
-            <a:r>
-              <a:rPr sz="2600" b="0">
-                <a:solidFill>
-                  <a:srgbClr val="272A25"/>
-                </a:solidFill>
-                <a:latin typeface="DM Sans"/>
-              </a:rPr>
-              <a:t>•  Building/sharing is welcome but OPTIONAL—not required.</a:t>
-            </a:r>
-          </a:p>
-          <a:p>
-            <a:pPr>
-              <a:spcAft>
-                <a:spcPts val="1600"/>
-              </a:spcAft>
-            </a:pPr>
-            <a:r>
-              <a:rPr sz="2600" b="0">
-                <a:solidFill>
-                  <a:srgbClr val="272A25"/>
-                </a:solidFill>
-                <a:latin typeface="DM Sans"/>
-              </a:rPr>
-              <a:t>•  Your reflections will shape consistent peer pods for at least three weeks.</a:t>
-            </a:r>
-          </a:p>
-        </p:txBody>
-      </p:sp>
-      <p:sp>
-        <p:nvSpPr>
-          <p:cNvPr id="5" name="TextBox 4"/>
-          <p:cNvSpPr txBox="1"/>
-          <p:nvPr/>
-        </p:nvSpPr>
-        <p:spPr>
-          <a:xfrm>
-            <a:off x="822960" y="6263640"/>
-            <a:ext cx="10607040" cy="365760"/>
-          </a:xfrm>
-          <a:prstGeom prst="rect">
-            <a:avLst/>
-          </a:prstGeom>
-          <a:noFill/>
-        </p:spPr>
-        <p:txBody>
-          <a:bodyPr wrap="square">
-            <a:spAutoFit/>
-          </a:bodyPr>
-          <a:lstStyle/>
-          <a:p>
-            <a:pPr algn="r">
-              <a:spcAft>
-                <a:spcPts val="1400"/>
-              </a:spcAft>
-            </a:pPr>
-            <a:r>
-              <a:rPr sz="1600" b="0">
-                <a:solidFill>
-                  <a:srgbClr val="64665D"/>
-                </a:solidFill>
-                <a:latin typeface="DM Sans"/>
-              </a:rPr>
-              <a:t>Week 6 · Weekly assignment        27 / 27</a:t>
+              <a:t>Week 6 · Weekly assignment        26 / 26</a:t>
             </a:r>
           </a:p>
         </p:txBody>
@@ -9886,7 +9597,7 @@
                 </a:solidFill>
                 <a:latin typeface="DM Sans"/>
               </a:rPr>
-              <a:t>Week 6 · Markdown        3 / 27</a:t>
+              <a:t>Week 6 · Markdown        3 / 26</a:t>
             </a:r>
           </a:p>
         </p:txBody>
@@ -10218,7 +9929,7 @@
                 </a:solidFill>
                 <a:latin typeface="DM Sans"/>
               </a:rPr>
-              <a:t>Week 6 · Markdown        4 / 27</a:t>
+              <a:t>Week 6 · Markdown        4 / 26</a:t>
             </a:r>
           </a:p>
         </p:txBody>
@@ -10436,7 +10147,7 @@
                 </a:solidFill>
                 <a:latin typeface="DM Sans"/>
               </a:rPr>
-              <a:t>Week 6 · Ongoing context        5 / 27</a:t>
+              <a:t>Week 6 · Ongoing context        5 / 26</a:t>
             </a:r>
           </a:p>
         </p:txBody>
@@ -10654,7 +10365,7 @@
                 </a:solidFill>
                 <a:latin typeface="DM Sans"/>
               </a:rPr>
-              <a:t>Week 6 · Ongoing context        6 / 27</a:t>
+              <a:t>Week 6 · Ongoing context        6 / 26</a:t>
             </a:r>
           </a:p>
         </p:txBody>
@@ -10762,7 +10473,7 @@
                 </a:solidFill>
                 <a:latin typeface="Fraunces"/>
               </a:rPr>
-              <a:t>Automatic loading is tool-specific</a:t>
+              <a:t>A context file loads every session</a:t>
             </a:r>
           </a:p>
         </p:txBody>
@@ -10801,7 +10512,7 @@
                 </a:solidFill>
                 <a:latin typeface="DM Sans"/>
               </a:rPr>
-              <a:t>•  Codex uses AGENTS.md; Claude Code uses CLAUDE.md.</a:t>
+              <a:t>•  Coding agents such as Claude Code, Codex and Cursor can read AGENTS.md automatically.</a:t>
             </a:r>
           </a:p>
           <a:p>
@@ -10817,7 +10528,7 @@
                 </a:solidFill>
                 <a:latin typeface="DM Sans"/>
               </a:rPr>
-              <a:t>•  Other tools have their own rules and supported filenames—check yours.</a:t>
+              <a:t>•  Your project context is there at the start of every session—no retyping.</a:t>
             </a:r>
           </a:p>
           <a:p>
@@ -10833,7 +10544,7 @@
                 </a:solidFill>
                 <a:latin typeface="DM Sans"/>
               </a:rPr>
-              <a:t>•  In a chat app, paste the context or add it to a Project; it may not read local files.</a:t>
+              <a:t>•  In a chat app, paste the context or add it to a Project.</a:t>
             </a:r>
           </a:p>
         </p:txBody>
@@ -10872,7 +10583,7 @@
                 </a:solidFill>
                 <a:latin typeface="DM Sans"/>
               </a:rPr>
-              <a:t>Week 6 · Ongoing context        7 / 27</a:t>
+              <a:t>Week 6 · Ongoing context        7 / 26</a:t>
             </a:r>
           </a:p>
         </p:txBody>
@@ -11090,7 +10801,7 @@
                 </a:solidFill>
                 <a:latin typeface="DM Sans"/>
               </a:rPr>
-              <a:t>Week 6 · Ongoing context        8 / 27</a:t>
+              <a:t>Week 6 · Ongoing context        8 / 26</a:t>
             </a:r>
           </a:p>
         </p:txBody>
@@ -11308,7 +11019,7 @@
                 </a:solidFill>
                 <a:latin typeface="DM Sans"/>
               </a:rPr>
-              <a:t>Week 6 · Communicate intent        9 / 27</a:t>
+              <a:t>Week 6 · Communicate intent        9 / 26</a:t>
             </a:r>
           </a:p>
         </p:txBody>

</xml_diff>

<commit_message>
Week 6: AGENTS.md works across coding agents incl. Claude Code; API vs MCP (connectors in Claude); drop permissions slide (#15)
Co-authored-by: unforcedagi <agi@unforced.dev>
</commit_message>
<xml_diff>
--- a/lessons/week-6/_src/week6-lecture.pptx
+++ b/lessons/week-6/_src/week6-lecture.pptx
@@ -31,7 +31,6 @@
     <p:sldId id="279" r:id="rId31"/>
     <p:sldId id="280" r:id="rId32"/>
     <p:sldId id="281" r:id="rId33"/>
-    <p:sldId id="282" r:id="rId34"/>
   </p:sldIdLst>
   <p:sldSz cx="12191695" cy="6858000" type="screen4x3"/>
   <p:notesSz cx="6858000" cy="9144000"/>
@@ -1158,7 +1157,7 @@
           <a:lstStyle/>
           <a:p>
             <a:r>
-              <a:t>Example: weather service API returns a forecast; an AI connector calls it for a conversation. Conceptual only: no course server URL, setup or connector demo this week.</a:t>
+              <a:t>Example: a weather service has an API that returns a forecast. An MCP connection lets your AI use services like that inside a conversation. In Claude these show up as connectors. Concept only tonight; next week we connect.</a:t>
             </a:r>
           </a:p>
         </p:txBody>
@@ -1228,7 +1227,7 @@
           <a:lstStyle/>
           <a:p>
             <a:r>
-              <a:t>Tools extend what the AI can do, not what it should be allowed to do. Responsibilities remain with the person using it. Four Ds stay implicit.</a:t>
+              <a:t>Students recently asked their tools to explain the tool itself while building. Model this as a learning practice, not outsourcing understanding.</a:t>
             </a:r>
           </a:p>
         </p:txBody>
@@ -1368,7 +1367,7 @@
           <a:lstStyle/>
           <a:p>
             <a:r>
-              <a:t>Students recently asked their tools to explain the tool itself while building. Model this as a learning practice, not outsourcing understanding.</a:t>
+              <a:t>Assigned reading. Shipper turned reflection on actual projects into a coaching conversation. The reading link is in students’ accounts; no new due date.</a:t>
             </a:r>
           </a:p>
         </p:txBody>
@@ -1438,7 +1437,7 @@
           <a:lstStyle/>
           <a:p>
             <a:r>
-              <a:t>Assigned reading. Shipper turned reflection on actual projects into a coaching conversation. The reading link is in students’ accounts; no new due date.</a:t>
+              <a:t>Free plans need not have long-term memory. Give a small truthful sample, not every private conversation.</a:t>
             </a:r>
           </a:p>
         </p:txBody>
@@ -1508,7 +1507,7 @@
           <a:lstStyle/>
           <a:p>
             <a:r>
-              <a:t>Free plans need not have long-term memory. Give a small truthful sample, not every private conversation.</a:t>
+              <a:t>Every essential access instruction is here, not hidden in a handout. This is how the reading’s coaching idea becomes something students can do tonight.</a:t>
             </a:r>
           </a:p>
         </p:txBody>
@@ -1578,7 +1577,7 @@
           <a:lstStyle/>
           <a:p>
             <a:r>
-              <a:t>Every essential access instruction is here, not hidden in a handout. This is how the reading’s coaching idea becomes something students can do tonight.</a:t>
+              <a:t>This is the only live demo slot, after the teaching content. Do not prescribe a project, script or output. If delayed, discuss a question from the lesson and move to group work.</a:t>
             </a:r>
           </a:p>
         </p:txBody>
@@ -1648,7 +1647,7 @@
           <a:lstStyle/>
           <a:p>
             <a:r>
-              <a:t>This is the only live demo slot, after the teaching content. Do not prescribe a project, script or output. If delayed, discuss a question from the lesson and move to group work.</a:t>
+              <a:t>Open-ended invitation, no fixed template or prescribed roles. Help students choose a small first learning goal without deciding their project for them.</a:t>
             </a:r>
           </a:p>
         </p:txBody>
@@ -1718,7 +1717,7 @@
           <a:lstStyle/>
           <a:p>
             <a:r>
-              <a:t>Open-ended invitation, no fixed template or prescribed roles. Help students choose a small first learning goal without deciding their project for them.</a:t>
+              <a:t>Optional: ask your AI what it needs to know about your project; save the useful context in markdown. Students can find the lesson from the preceding slide. No due date added.</a:t>
             </a:r>
           </a:p>
         </p:txBody>
@@ -1788,76 +1787,6 @@
           <a:lstStyle/>
           <a:p>
             <a:r>
-              <a:t>Optional: ask your AI what it needs to know about your project; save the useful context in markdown. Students can find the lesson from the preceding slide. No due date added.</a:t>
-            </a:r>
-          </a:p>
-        </p:txBody>
-      </p:sp>
-      <p:sp>
-        <p:nvSpPr>
-          <p:cNvPr id="4" name="Slide Number Placeholder 3"/>
-          <p:cNvSpPr>
-            <a:spLocks noGrp="1"/>
-          </p:cNvSpPr>
-          <p:nvPr>
-            <p:ph type="sldNum" idx="5" sz="quarter"/>
-          </p:nvPr>
-        </p:nvSpPr>
-        <p:spPr/>
-      </p:sp>
-    </p:spTree>
-  </p:cSld>
-  <p:clrMapOvr>
-    <a:masterClrMapping/>
-  </p:clrMapOvr>
-</p:notes>
-</file>
-
-<file path=ppt/notesSlides/notesSlide27.xml><?xml version="1.0" encoding="utf-8"?>
-<p:notes xmlns:a="http://schemas.openxmlformats.org/drawingml/2006/main" xmlns:p="http://schemas.openxmlformats.org/presentationml/2006/main" xmlns:r="http://schemas.openxmlformats.org/officeDocument/2006/relationships">
-  <p:cSld>
-    <p:spTree>
-      <p:nvGrpSpPr>
-        <p:cNvPr id="1" name=""/>
-        <p:cNvGrpSpPr/>
-        <p:nvPr/>
-      </p:nvGrpSpPr>
-      <p:grpSpPr>
-        <a:xfrm>
-          <a:off x="0" y="0"/>
-          <a:ext cx="0" cy="0"/>
-          <a:chOff x="0" y="0"/>
-          <a:chExt cx="0" cy="0"/>
-        </a:xfrm>
-      </p:grpSpPr>
-      <p:sp>
-        <p:nvSpPr>
-          <p:cNvPr id="2" name="Slide Image Placeholder 1"/>
-          <p:cNvSpPr>
-            <a:spLocks noGrp="1"/>
-          </p:cNvSpPr>
-          <p:nvPr>
-            <p:ph type="sldImg" idx="2"/>
-          </p:nvPr>
-        </p:nvSpPr>
-        <p:spPr/>
-      </p:sp>
-      <p:sp>
-        <p:nvSpPr>
-          <p:cNvPr id="3" name="Notes Placeholder 2"/>
-          <p:cNvSpPr>
-            <a:spLocks noGrp="1"/>
-          </p:cNvSpPr>
-          <p:nvPr>
-            <p:ph type="body" idx="3" sz="quarter"/>
-          </p:nvPr>
-        </p:nvSpPr>
-        <p:spPr/>
-        <p:txBody>
-          <a:bodyPr/>
-          <a:lstStyle/>
-          <a:p>
-            <a:r>
               <a:t>Authoritative Week 6 assignment replaces the required build. One page, not one paragraph. Existing due date remains October 11 at 11:59 PM MT. Pods share learning and support each other in class for AT LEAST the next three weeks; do not invent size, rubric, or final-project requirements. Canvas copy is a draft, not yet published.</a:t>
             </a:r>
           </a:p>
@@ -2208,7 +2137,7 @@
           <a:lstStyle/>
           <a:p>
             <a:r>
-              <a:t>Do not imply any file name works universally. Our tested Claude Code installation also found AGENTS.md, but teach documented primary filenames. A fresh-session question can reveal whether the tool saw the file.</a:t>
+              <a:t>Put the file in the top folder of the project. Verified tonight: Claude Code picked up AGENTS.md in a fresh session. Keep the point simple: write the context once, and the agent starts with it.</a:t>
             </a:r>
           </a:p>
         </p:txBody>
@@ -5510,7 +5439,7 @@
                 </a:solidFill>
                 <a:latin typeface="DM Sans"/>
               </a:rPr>
-              <a:t>Week 6 · Opening        1 / 27</a:t>
+              <a:t>Week 6 · Opening        1 / 26</a:t>
             </a:r>
           </a:p>
         </p:txBody>
@@ -5728,7 +5657,7 @@
                 </a:solidFill>
                 <a:latin typeface="DM Sans"/>
               </a:rPr>
-              <a:t>Week 6 · Communicate intent        10 / 27</a:t>
+              <a:t>Week 6 · Communicate intent        10 / 26</a:t>
             </a:r>
           </a:p>
         </p:txBody>
@@ -5946,7 +5875,7 @@
                 </a:solidFill>
                 <a:latin typeface="DM Sans"/>
               </a:rPr>
-              <a:t>Week 6 · Check the work        11 / 27</a:t>
+              <a:t>Week 6 · Check the work        11 / 26</a:t>
             </a:r>
           </a:p>
         </p:txBody>
@@ -6164,7 +6093,7 @@
                 </a:solidFill>
                 <a:latin typeface="DM Sans"/>
               </a:rPr>
-              <a:t>Week 6 · Check the work        12 / 27</a:t>
+              <a:t>Week 6 · Check the work        12 / 26</a:t>
             </a:r>
           </a:p>
         </p:txBody>
@@ -6382,7 +6311,7 @@
                 </a:solidFill>
                 <a:latin typeface="DM Sans"/>
               </a:rPr>
-              <a:t>Week 6 · Working within limits        13 / 27</a:t>
+              <a:t>Week 6 · Working within limits        13 / 26</a:t>
             </a:r>
           </a:p>
         </p:txBody>
@@ -6600,7 +6529,7 @@
                 </a:solidFill>
                 <a:latin typeface="DM Sans"/>
               </a:rPr>
-              <a:t>Week 6 · Getting online        14 / 27</a:t>
+              <a:t>Week 6 · Getting online        14 / 26</a:t>
             </a:r>
           </a:p>
         </p:txBody>
@@ -6818,7 +6747,7 @@
                 </a:solidFill>
                 <a:latin typeface="DM Sans"/>
               </a:rPr>
-              <a:t>Week 6 · Getting online        15 / 27</a:t>
+              <a:t>Week 6 · Getting online        15 / 26</a:t>
             </a:r>
           </a:p>
         </p:txBody>
@@ -7036,7 +6965,7 @@
                 </a:solidFill>
                 <a:latin typeface="DM Sans"/>
               </a:rPr>
-              <a:t>Week 6 · Getting online        16 / 27</a:t>
+              <a:t>Week 6 · Getting online        16 / 26</a:t>
             </a:r>
           </a:p>
         </p:txBody>
@@ -7254,7 +7183,7 @@
                 </a:solidFill>
                 <a:latin typeface="DM Sans"/>
               </a:rPr>
-              <a:t>Week 6 · Getting online        17 / 27</a:t>
+              <a:t>Week 6 · Getting online        17 / 26</a:t>
             </a:r>
           </a:p>
         </p:txBody>
@@ -7362,7 +7291,7 @@
                 </a:solidFill>
                 <a:latin typeface="Fraunces"/>
               </a:rPr>
-              <a:t>API, connector, MCP: what is the difference?</a:t>
+              <a:t>APIs and MCP: how AI connects to other tools</a:t>
             </a:r>
           </a:p>
         </p:txBody>
@@ -7401,7 +7330,7 @@
                 </a:solidFill>
                 <a:latin typeface="DM Sans"/>
               </a:rPr>
-              <a:t>•  API: a service’s menu of requests that another program can make.</a:t>
+              <a:t>•  API: how one program requests information or actions from another.</a:t>
             </a:r>
           </a:p>
           <a:p>
@@ -7417,7 +7346,7 @@
                 </a:solidFill>
                 <a:latin typeface="DM Sans"/>
               </a:rPr>
-              <a:t>•  Connector: a bridge that lets your AI reach a service or files.</a:t>
+              <a:t>•  MCP: a standard way for AI tools to connect to other services and data.</a:t>
             </a:r>
           </a:p>
           <a:p>
@@ -7433,7 +7362,7 @@
                 </a:solidFill>
                 <a:latin typeface="DM Sans"/>
               </a:rPr>
-              <a:t>•  MCP: a shared protocol for AI apps to use tools; an MCP server may call an API.</a:t>
+              <a:t>•  In Claude, these MCP connections are called connectors.</a:t>
             </a:r>
           </a:p>
         </p:txBody>
@@ -7472,7 +7401,7 @@
                 </a:solidFill>
                 <a:latin typeface="DM Sans"/>
               </a:rPr>
-              <a:t>Week 6 · Connections—concept only        18 / 27</a:t>
+              <a:t>Week 6 · Connections—concept only        18 / 26</a:t>
             </a:r>
           </a:p>
         </p:txBody>
@@ -7580,7 +7509,7 @@
                 </a:solidFill>
                 <a:latin typeface="Fraunces"/>
               </a:rPr>
-              <a:t>Access is a choice: read versus write</a:t>
+              <a:t>Use AI to learn about AI</a:t>
             </a:r>
           </a:p>
         </p:txBody>
@@ -7619,7 +7548,7 @@
                 </a:solidFill>
                 <a:latin typeface="DM Sans"/>
               </a:rPr>
-              <a:t>•  Read access can expose data; write access can change or delete it.</a:t>
+              <a:t>•  Ask for an explanation, an example, and a question to check your understanding.</a:t>
             </a:r>
           </a:p>
           <a:p>
@@ -7635,7 +7564,7 @@
                 </a:solidFill>
                 <a:latin typeface="DM Sans"/>
               </a:rPr>
-              <a:t>•  Give only the access needed; review changes before publishing or sending.</a:t>
+              <a:t>•  Say what you already know: “I know HTML; Git is new to me.”</a:t>
             </a:r>
           </a:p>
           <a:p>
@@ -7651,7 +7580,7 @@
                 </a:solidFill>
                 <a:latin typeface="DM Sans"/>
               </a:rPr>
-              <a:t>•  Keep keys, passwords and private data out of public files and repositories.</a:t>
+              <a:t>•  Compare its explanation with your source—not just how confident it sounds.</a:t>
             </a:r>
           </a:p>
         </p:txBody>
@@ -7690,7 +7619,7 @@
                 </a:solidFill>
                 <a:latin typeface="DM Sans"/>
               </a:rPr>
-              <a:t>Week 6 · Connections—concept only        19 / 27</a:t>
+              <a:t>Week 6 · Learn with AI        19 / 26</a:t>
             </a:r>
           </a:p>
         </p:txBody>
@@ -7908,7 +7837,7 @@
                 </a:solidFill>
                 <a:latin typeface="DM Sans"/>
               </a:rPr>
-              <a:t>Week 6 · Why this matters        2 / 27</a:t>
+              <a:t>Week 6 · Why this matters        2 / 26</a:t>
             </a:r>
           </a:p>
         </p:txBody>
@@ -8016,7 +7945,7 @@
                 </a:solidFill>
                 <a:latin typeface="Fraunces"/>
               </a:rPr>
-              <a:t>Use AI to learn about AI</a:t>
+              <a:t>The reading: your AI as a coach</a:t>
             </a:r>
           </a:p>
         </p:txBody>
@@ -8055,7 +7984,7 @@
                 </a:solidFill>
                 <a:latin typeface="DM Sans"/>
               </a:rPr>
-              <a:t>•  Ask for an explanation, an example, and a question to check your understanding.</a:t>
+              <a:t>•  Arielle Shipper · “How to Get Better at AI by Asking AI” · Every</a:t>
             </a:r>
           </a:p>
           <a:p>
@@ -8071,7 +8000,7 @@
                 </a:solidFill>
                 <a:latin typeface="DM Sans"/>
               </a:rPr>
-              <a:t>•  Say what you already know: “I know HTML; Git is new to me.”</a:t>
+              <a:t>•  Ask where you are on the Eight Levels of AI Adoption, with evidence from your work.</a:t>
             </a:r>
           </a:p>
           <a:p>
@@ -8087,7 +8016,7 @@
                 </a:solidFill>
                 <a:latin typeface="DM Sans"/>
               </a:rPr>
-              <a:t>•  Compare its explanation with your source—not just how confident it sounds.</a:t>
+              <a:t>•  Ask for one next step, then: “Teach me that and help me practise.”</a:t>
             </a:r>
           </a:p>
         </p:txBody>
@@ -8126,7 +8055,7 @@
                 </a:solidFill>
                 <a:latin typeface="DM Sans"/>
               </a:rPr>
-              <a:t>Week 6 · Learn with AI        20 / 27</a:t>
+              <a:t>Week 6 · Learn with AI        20 / 26</a:t>
             </a:r>
           </a:p>
         </p:txBody>
@@ -8228,13 +8157,13 @@
               </a:spcAft>
             </a:pPr>
             <a:r>
-              <a:rPr sz="4000" b="1">
+              <a:rPr sz="3200" b="1">
                 <a:solidFill>
                   <a:srgbClr val="272A25"/>
                 </a:solidFill>
                 <a:latin typeface="Fraunces"/>
               </a:rPr>
-              <a:t>The reading: your AI as a coach</a:t>
+              <a:t>No long chat history? Bring your own evidence</a:t>
             </a:r>
           </a:p>
         </p:txBody>
@@ -8273,7 +8202,7 @@
                 </a:solidFill>
                 <a:latin typeface="DM Sans"/>
               </a:rPr>
-              <a:t>•  Arielle Shipper · “How to Get Better at AI by Asking AI” · Every</a:t>
+              <a:t>•  Paste your last two submissions or describe a recent project.</a:t>
             </a:r>
           </a:p>
           <a:p>
@@ -8289,7 +8218,7 @@
                 </a:solidFill>
                 <a:latin typeface="DM Sans"/>
               </a:rPr>
-              <a:t>•  Ask where you are on the Eight Levels of AI Adoption, with evidence from your work.</a:t>
+              <a:t>•  Ask: “What can I do already? Show examples. What should I learn next?”</a:t>
             </a:r>
           </a:p>
           <a:p>
@@ -8305,7 +8234,7 @@
                 </a:solidFill>
                 <a:latin typeface="DM Sans"/>
               </a:rPr>
-              <a:t>•  Ask for one next step, then: “Teach me that and help me practise.”</a:t>
+              <a:t>•  Treat the AI’s assessment as a suggestion; correct its assumptions.</a:t>
             </a:r>
           </a:p>
         </p:txBody>
@@ -8344,7 +8273,7 @@
                 </a:solidFill>
                 <a:latin typeface="DM Sans"/>
               </a:rPr>
-              <a:t>Week 6 · Learn with AI        21 / 27</a:t>
+              <a:t>Week 6 · Learn with AI        21 / 26</a:t>
             </a:r>
           </a:p>
         </p:txBody>
@@ -8446,13 +8375,13 @@
               </a:spcAft>
             </a:pPr>
             <a:r>
-              <a:rPr sz="3200" b="1">
+              <a:rPr sz="4000" b="1">
                 <a:solidFill>
                   <a:srgbClr val="272A25"/>
                 </a:solidFill>
                 <a:latin typeface="Fraunces"/>
               </a:rPr>
-              <a:t>No long chat history? Bring your own evidence</a:t>
+              <a:t>Bring this lesson into your own AI</a:t>
             </a:r>
           </a:p>
         </p:txBody>
@@ -8491,7 +8420,7 @@
                 </a:solidFill>
                 <a:latin typeface="DM Sans"/>
               </a:rPr>
-              <a:t>•  Paste your last two submissions or describe a recent project.</a:t>
+              <a:t>•  Open cu.learnvibe.build → Everything for Week 6.</a:t>
             </a:r>
           </a:p>
           <a:p>
@@ -8507,7 +8436,7 @@
                 </a:solidFill>
                 <a:latin typeface="DM Sans"/>
               </a:rPr>
-              <a:t>•  Ask: “What can I do already? Show examples. What should I learn next?”</a:t>
+              <a:t>•  Click “Copy lesson as markdown”; paste it into Claude or another AI.</a:t>
             </a:r>
           </a:p>
           <a:p>
@@ -8523,7 +8452,7 @@
                 </a:solidFill>
                 <a:latin typeface="DM Sans"/>
               </a:rPr>
-              <a:t>•  Treat the AI’s assessment as a suggestion; correct its assumptions.</a:t>
+              <a:t>•  Ask: “Teach me this and quiz me”—then ask follow-ups in your own words.</a:t>
             </a:r>
           </a:p>
         </p:txBody>
@@ -8562,7 +8491,7 @@
                 </a:solidFill>
                 <a:latin typeface="DM Sans"/>
               </a:rPr>
-              <a:t>Week 6 · Learn with AI        22 / 27</a:t>
+              <a:t>Week 6 · Use the lesson        22 / 26</a:t>
             </a:r>
           </a:p>
         </p:txBody>
@@ -8664,13 +8593,13 @@
               </a:spcAft>
             </a:pPr>
             <a:r>
-              <a:rPr sz="4000" b="1">
+              <a:rPr sz="3200" b="1">
                 <a:solidFill>
                   <a:srgbClr val="272A25"/>
                 </a:solidFill>
                 <a:latin typeface="Fraunces"/>
               </a:rPr>
-              <a:t>Bring this lesson into your own AI</a:t>
+              <a:t>After the slides: one conversation with Claude</a:t>
             </a:r>
           </a:p>
         </p:txBody>
@@ -8709,7 +8638,7 @@
                 </a:solidFill>
                 <a:latin typeface="DM Sans"/>
               </a:rPr>
-              <a:t>•  Open cu.learnvibe.build → Everything for Week 6.</a:t>
+              <a:t>•  Aaron will paste the lesson and talk through it with Claude.</a:t>
             </a:r>
           </a:p>
           <a:p>
@@ -8725,7 +8654,7 @@
                 </a:solidFill>
                 <a:latin typeface="DM Sans"/>
               </a:rPr>
-              <a:t>•  Click “Copy lesson as markdown”; paste it into Claude or another AI.</a:t>
+              <a:t>•  The conversation may lead to building a little thing.</a:t>
             </a:r>
           </a:p>
           <a:p>
@@ -8741,7 +8670,7 @@
                 </a:solidFill>
                 <a:latin typeface="DM Sans"/>
               </a:rPr>
-              <a:t>•  Ask: “Teach me this and quiz me”—then ask follow-ups in your own words.</a:t>
+              <a:t>•  Watch how questions, context and checking shape the result.</a:t>
             </a:r>
           </a:p>
         </p:txBody>
@@ -8780,7 +8709,7 @@
                 </a:solidFill>
                 <a:latin typeface="DM Sans"/>
               </a:rPr>
-              <a:t>Week 6 · Use the lesson        23 / 27</a:t>
+              <a:t>Week 6 · One live demo        23 / 26</a:t>
             </a:r>
           </a:p>
         </p:txBody>
@@ -8882,13 +8811,13 @@
               </a:spcAft>
             </a:pPr>
             <a:r>
-              <a:rPr sz="3200" b="1">
+              <a:rPr sz="4000" b="1">
                 <a:solidFill>
                   <a:srgbClr val="272A25"/>
                 </a:solidFill>
                 <a:latin typeface="Fraunces"/>
               </a:rPr>
-              <a:t>After the slides: one conversation with Claude</a:t>
+              <a:t>Optional in-class small-group building</a:t>
             </a:r>
           </a:p>
         </p:txBody>
@@ -8927,7 +8856,7 @@
                 </a:solidFill>
                 <a:latin typeface="DM Sans"/>
               </a:rPr>
-              <a:t>•  Aaron will paste the lesson and talk through it with Claude.</a:t>
+              <a:t>•  Choose a topic and your own approach; building/sharing is optional.</a:t>
             </a:r>
           </a:p>
           <a:p>
@@ -8943,7 +8872,7 @@
                 </a:solidFill>
                 <a:latin typeface="DM Sans"/>
               </a:rPr>
-              <a:t>•  The conversation may lead to building a little thing.</a:t>
+              <a:t>•  Make a quiz, interactive explainer, practice tool—or an idea of your own.</a:t>
             </a:r>
           </a:p>
           <a:p>
@@ -8959,7 +8888,7 @@
                 </a:solidFill>
                 <a:latin typeface="DM Sans"/>
               </a:rPr>
-              <a:t>•  Watch how questions, context and checking shape the result.</a:t>
+              <a:t>•  Use your AI; try the first version yourselves; check it and revise.</a:t>
             </a:r>
           </a:p>
         </p:txBody>
@@ -8998,7 +8927,7 @@
                 </a:solidFill>
                 <a:latin typeface="DM Sans"/>
               </a:rPr>
-              <a:t>Week 6 · One live demo        24 / 27</a:t>
+              <a:t>Week 6 · Group work        24 / 26</a:t>
             </a:r>
           </a:p>
         </p:txBody>
@@ -9106,7 +9035,7 @@
                 </a:solidFill>
                 <a:latin typeface="Fraunces"/>
               </a:rPr>
-              <a:t>Optional in-class small-group building</a:t>
+              <a:t>How to start—and what to share</a:t>
             </a:r>
           </a:p>
         </p:txBody>
@@ -9145,7 +9074,7 @@
                 </a:solidFill>
                 <a:latin typeface="DM Sans"/>
               </a:rPr>
-              <a:t>•  Choose a topic and your own approach; building/sharing is optional.</a:t>
+              <a:t>•  Give your AI the lesson, your learning question, or both.</a:t>
             </a:r>
           </a:p>
           <a:p>
@@ -9161,7 +9090,7 @@
                 </a:solidFill>
                 <a:latin typeface="DM Sans"/>
               </a:rPr>
-              <a:t>•  Make a quiz, interactive explainer, practice tool—or an idea of your own.</a:t>
+              <a:t>•  Ask for a small first version. Test whether it actually helps you learn.</a:t>
             </a:r>
           </a:p>
           <a:p>
@@ -9177,7 +9106,7 @@
                 </a:solidFill>
                 <a:latin typeface="DM Sans"/>
               </a:rPr>
-              <a:t>•  Use your AI; try the first version yourselves; check it and revise.</a:t>
+              <a:t>•  Show what you made, what you learned, and one thing you checked or changed.</a:t>
             </a:r>
           </a:p>
         </p:txBody>
@@ -9216,7 +9145,7 @@
                 </a:solidFill>
                 <a:latin typeface="DM Sans"/>
               </a:rPr>
-              <a:t>Week 6 · Group work        25 / 27</a:t>
+              <a:t>Week 6 · Group work        25 / 26</a:t>
             </a:r>
           </a:p>
         </p:txBody>
@@ -9324,7 +9253,7 @@
                 </a:solidFill>
                 <a:latin typeface="Fraunces"/>
               </a:rPr>
-              <a:t>How to start—and what to share</a:t>
+              <a:t>This week: ONE PAGE about your learning</a:t>
             </a:r>
           </a:p>
         </p:txBody>
@@ -9353,49 +9282,65 @@
           <a:p>
             <a:pPr>
               <a:spcAft>
-                <a:spcPts val="2200"/>
-              </a:spcAft>
-            </a:pPr>
-            <a:r>
-              <a:rPr sz="3000" b="0">
+                <a:spcPts val="1600"/>
+              </a:spcAft>
+            </a:pPr>
+            <a:r>
+              <a:rPr sz="2600" b="0">
                 <a:solidFill>
                   <a:srgbClr val="272A25"/>
                 </a:solidFill>
                 <a:latin typeface="DM Sans"/>
               </a:rPr>
-              <a:t>•  Give your AI the lesson, your learning question, or both.</a:t>
+              <a:t>•  What you’ve learned, are learning, and want to learn.</a:t>
             </a:r>
           </a:p>
           <a:p>
             <a:pPr>
               <a:spcAft>
-                <a:spcPts val="2200"/>
-              </a:spcAft>
-            </a:pPr>
-            <a:r>
-              <a:rPr sz="3000" b="0">
+                <a:spcPts val="1600"/>
+              </a:spcAft>
+            </a:pPr>
+            <a:r>
+              <a:rPr sz="2600" b="0">
                 <a:solidFill>
                   <a:srgbClr val="272A25"/>
                 </a:solidFill>
                 <a:latin typeface="DM Sans"/>
               </a:rPr>
-              <a:t>•  Ask for a small first version. Test whether it actually helps you learn.</a:t>
+              <a:t>•  What you want to build; emerging final-project ideas.</a:t>
             </a:r>
           </a:p>
           <a:p>
             <a:pPr>
               <a:spcAft>
-                <a:spcPts val="2200"/>
-              </a:spcAft>
-            </a:pPr>
-            <a:r>
-              <a:rPr sz="3000" b="0">
+                <a:spcPts val="1600"/>
+              </a:spcAft>
+            </a:pPr>
+            <a:r>
+              <a:rPr sz="2600" b="0">
                 <a:solidFill>
                   <a:srgbClr val="272A25"/>
                 </a:solidFill>
                 <a:latin typeface="DM Sans"/>
               </a:rPr>
-              <a:t>•  Show what you made, what you learned, and one thing you checked or changed.</a:t>
+              <a:t>•  Building/sharing is welcome but OPTIONAL—not required.</a:t>
+            </a:r>
+          </a:p>
+          <a:p>
+            <a:pPr>
+              <a:spcAft>
+                <a:spcPts val="1600"/>
+              </a:spcAft>
+            </a:pPr>
+            <a:r>
+              <a:rPr sz="2600" b="0">
+                <a:solidFill>
+                  <a:srgbClr val="272A25"/>
+                </a:solidFill>
+                <a:latin typeface="DM Sans"/>
+              </a:rPr>
+              <a:t>•  Your reflections will shape consistent peer pods for at least three weeks.</a:t>
             </a:r>
           </a:p>
         </p:txBody>
@@ -9434,241 +9379,7 @@
                 </a:solidFill>
                 <a:latin typeface="DM Sans"/>
               </a:rPr>
-              <a:t>Week 6 · Group work        26 / 27</a:t>
-            </a:r>
-          </a:p>
-        </p:txBody>
-      </p:sp>
-    </p:spTree>
-  </p:cSld>
-  <p:clrMapOvr>
-    <a:masterClrMapping/>
-  </p:clrMapOvr>
-</p:sld>
-</file>
-
-<file path=ppt/slides/slide27.xml><?xml version="1.0" encoding="utf-8"?>
-<p:sld xmlns:a="http://schemas.openxmlformats.org/drawingml/2006/main" xmlns:p="http://schemas.openxmlformats.org/presentationml/2006/main" xmlns:r="http://schemas.openxmlformats.org/officeDocument/2006/relationships">
-  <p:cSld>
-    <p:bg>
-      <p:bgPr>
-        <a:solidFill>
-          <a:srgbClr val="F7F5EE"/>
-        </a:solidFill>
-        <a:effectLst/>
-      </p:bgPr>
-    </p:bg>
-    <p:spTree>
-      <p:nvGrpSpPr>
-        <p:cNvPr id="1" name=""/>
-        <p:cNvGrpSpPr/>
-        <p:nvPr/>
-      </p:nvGrpSpPr>
-      <p:grpSpPr/>
-      <p:sp>
-        <p:nvSpPr>
-          <p:cNvPr id="2" name="Rectangle 1"/>
-          <p:cNvSpPr/>
-          <p:nvPr/>
-        </p:nvSpPr>
-        <p:spPr>
-          <a:xfrm>
-            <a:off x="0" y="0"/>
-            <a:ext cx="228600" cy="6858000"/>
-          </a:xfrm>
-          <a:prstGeom prst="rect">
-            <a:avLst/>
-          </a:prstGeom>
-          <a:solidFill>
-            <a:srgbClr val="A83D2B"/>
-          </a:solidFill>
-          <a:ln>
-            <a:noFill/>
-          </a:ln>
-        </p:spPr>
-        <p:style>
-          <a:lnRef idx="1">
-            <a:schemeClr val="accent1"/>
-          </a:lnRef>
-          <a:fillRef idx="3">
-            <a:schemeClr val="accent1"/>
-          </a:fillRef>
-          <a:effectRef idx="2">
-            <a:schemeClr val="accent1"/>
-          </a:effectRef>
-          <a:fontRef idx="minor">
-            <a:schemeClr val="lt1"/>
-          </a:fontRef>
-        </p:style>
-        <p:txBody>
-          <a:bodyPr rtlCol="0" anchor="ctr"/>
-          <a:lstStyle/>
-          <a:p>
-            <a:pPr algn="ctr"/>
-          </a:p>
-        </p:txBody>
-      </p:sp>
-      <p:sp>
-        <p:nvSpPr>
-          <p:cNvPr id="3" name="TextBox 2"/>
-          <p:cNvSpPr txBox="1"/>
-          <p:nvPr/>
-        </p:nvSpPr>
-        <p:spPr>
-          <a:xfrm>
-            <a:off x="822960" y="548640"/>
-            <a:ext cx="10607040" cy="1188720"/>
-          </a:xfrm>
-          <a:prstGeom prst="rect">
-            <a:avLst/>
-          </a:prstGeom>
-          <a:noFill/>
-        </p:spPr>
-        <p:txBody>
-          <a:bodyPr wrap="square">
-            <a:spAutoFit/>
-          </a:bodyPr>
-          <a:lstStyle/>
-          <a:p>
-            <a:pPr>
-              <a:spcAft>
-                <a:spcPts val="1400"/>
-              </a:spcAft>
-            </a:pPr>
-            <a:r>
-              <a:rPr sz="4000" b="1">
-                <a:solidFill>
-                  <a:srgbClr val="272A25"/>
-                </a:solidFill>
-                <a:latin typeface="Fraunces"/>
-              </a:rPr>
-              <a:t>This week: ONE PAGE about your learning</a:t>
-            </a:r>
-          </a:p>
-        </p:txBody>
-      </p:sp>
-      <p:sp>
-        <p:nvSpPr>
-          <p:cNvPr id="4" name="TextBox 3"/>
-          <p:cNvSpPr txBox="1"/>
-          <p:nvPr/>
-        </p:nvSpPr>
-        <p:spPr>
-          <a:xfrm>
-            <a:off x="822960" y="2011680"/>
-            <a:ext cx="10607040" cy="4206240"/>
-          </a:xfrm>
-          <a:prstGeom prst="rect">
-            <a:avLst/>
-          </a:prstGeom>
-          <a:noFill/>
-        </p:spPr>
-        <p:txBody>
-          <a:bodyPr wrap="square">
-            <a:spAutoFit/>
-          </a:bodyPr>
-          <a:lstStyle/>
-          <a:p>
-            <a:pPr>
-              <a:spcAft>
-                <a:spcPts val="1600"/>
-              </a:spcAft>
-            </a:pPr>
-            <a:r>
-              <a:rPr sz="2600" b="0">
-                <a:solidFill>
-                  <a:srgbClr val="272A25"/>
-                </a:solidFill>
-                <a:latin typeface="DM Sans"/>
-              </a:rPr>
-              <a:t>•  What you’ve learned, are learning, and want to learn.</a:t>
-            </a:r>
-          </a:p>
-          <a:p>
-            <a:pPr>
-              <a:spcAft>
-                <a:spcPts val="1600"/>
-              </a:spcAft>
-            </a:pPr>
-            <a:r>
-              <a:rPr sz="2600" b="0">
-                <a:solidFill>
-                  <a:srgbClr val="272A25"/>
-                </a:solidFill>
-                <a:latin typeface="DM Sans"/>
-              </a:rPr>
-              <a:t>•  What you want to build; emerging final-project ideas.</a:t>
-            </a:r>
-          </a:p>
-          <a:p>
-            <a:pPr>
-              <a:spcAft>
-                <a:spcPts val="1600"/>
-              </a:spcAft>
-            </a:pPr>
-            <a:r>
-              <a:rPr sz="2600" b="0">
-                <a:solidFill>
-                  <a:srgbClr val="272A25"/>
-                </a:solidFill>
-                <a:latin typeface="DM Sans"/>
-              </a:rPr>
-              <a:t>•  Building/sharing is welcome but OPTIONAL—not required.</a:t>
-            </a:r>
-          </a:p>
-          <a:p>
-            <a:pPr>
-              <a:spcAft>
-                <a:spcPts val="1600"/>
-              </a:spcAft>
-            </a:pPr>
-            <a:r>
-              <a:rPr sz="2600" b="0">
-                <a:solidFill>
-                  <a:srgbClr val="272A25"/>
-                </a:solidFill>
-                <a:latin typeface="DM Sans"/>
-              </a:rPr>
-              <a:t>•  Your reflections will shape consistent peer pods for at least three weeks.</a:t>
-            </a:r>
-          </a:p>
-        </p:txBody>
-      </p:sp>
-      <p:sp>
-        <p:nvSpPr>
-          <p:cNvPr id="5" name="TextBox 4"/>
-          <p:cNvSpPr txBox="1"/>
-          <p:nvPr/>
-        </p:nvSpPr>
-        <p:spPr>
-          <a:xfrm>
-            <a:off x="822960" y="6263640"/>
-            <a:ext cx="10607040" cy="365760"/>
-          </a:xfrm>
-          <a:prstGeom prst="rect">
-            <a:avLst/>
-          </a:prstGeom>
-          <a:noFill/>
-        </p:spPr>
-        <p:txBody>
-          <a:bodyPr wrap="square">
-            <a:spAutoFit/>
-          </a:bodyPr>
-          <a:lstStyle/>
-          <a:p>
-            <a:pPr algn="r">
-              <a:spcAft>
-                <a:spcPts val="1400"/>
-              </a:spcAft>
-            </a:pPr>
-            <a:r>
-              <a:rPr sz="1600" b="0">
-                <a:solidFill>
-                  <a:srgbClr val="64665D"/>
-                </a:solidFill>
-                <a:latin typeface="DM Sans"/>
-              </a:rPr>
-              <a:t>Week 6 · Weekly assignment        27 / 27</a:t>
+              <a:t>Week 6 · Weekly assignment        26 / 26</a:t>
             </a:r>
           </a:p>
         </p:txBody>
@@ -9886,7 +9597,7 @@
                 </a:solidFill>
                 <a:latin typeface="DM Sans"/>
               </a:rPr>
-              <a:t>Week 6 · Markdown        3 / 27</a:t>
+              <a:t>Week 6 · Markdown        3 / 26</a:t>
             </a:r>
           </a:p>
         </p:txBody>
@@ -10218,7 +9929,7 @@
                 </a:solidFill>
                 <a:latin typeface="DM Sans"/>
               </a:rPr>
-              <a:t>Week 6 · Markdown        4 / 27</a:t>
+              <a:t>Week 6 · Markdown        4 / 26</a:t>
             </a:r>
           </a:p>
         </p:txBody>
@@ -10436,7 +10147,7 @@
                 </a:solidFill>
                 <a:latin typeface="DM Sans"/>
               </a:rPr>
-              <a:t>Week 6 · Ongoing context        5 / 27</a:t>
+              <a:t>Week 6 · Ongoing context        5 / 26</a:t>
             </a:r>
           </a:p>
         </p:txBody>
@@ -10654,7 +10365,7 @@
                 </a:solidFill>
                 <a:latin typeface="DM Sans"/>
               </a:rPr>
-              <a:t>Week 6 · Ongoing context        6 / 27</a:t>
+              <a:t>Week 6 · Ongoing context        6 / 26</a:t>
             </a:r>
           </a:p>
         </p:txBody>
@@ -10762,7 +10473,7 @@
                 </a:solidFill>
                 <a:latin typeface="Fraunces"/>
               </a:rPr>
-              <a:t>Automatic loading is tool-specific</a:t>
+              <a:t>A context file loads every session</a:t>
             </a:r>
           </a:p>
         </p:txBody>
@@ -10801,7 +10512,7 @@
                 </a:solidFill>
                 <a:latin typeface="DM Sans"/>
               </a:rPr>
-              <a:t>•  Codex uses AGENTS.md; Claude Code uses CLAUDE.md.</a:t>
+              <a:t>•  Coding agents such as Claude Code, Codex and Cursor can read AGENTS.md automatically.</a:t>
             </a:r>
           </a:p>
           <a:p>
@@ -10817,7 +10528,7 @@
                 </a:solidFill>
                 <a:latin typeface="DM Sans"/>
               </a:rPr>
-              <a:t>•  Other tools have their own rules and supported filenames—check yours.</a:t>
+              <a:t>•  Your project context is there at the start of every session—no retyping.</a:t>
             </a:r>
           </a:p>
           <a:p>
@@ -10833,7 +10544,7 @@
                 </a:solidFill>
                 <a:latin typeface="DM Sans"/>
               </a:rPr>
-              <a:t>•  In a chat app, paste the context or add it to a Project; it may not read local files.</a:t>
+              <a:t>•  In a chat app, paste the context or add it to a Project.</a:t>
             </a:r>
           </a:p>
         </p:txBody>
@@ -10872,7 +10583,7 @@
                 </a:solidFill>
                 <a:latin typeface="DM Sans"/>
               </a:rPr>
-              <a:t>Week 6 · Ongoing context        7 / 27</a:t>
+              <a:t>Week 6 · Ongoing context        7 / 26</a:t>
             </a:r>
           </a:p>
         </p:txBody>
@@ -11090,7 +10801,7 @@
                 </a:solidFill>
                 <a:latin typeface="DM Sans"/>
               </a:rPr>
-              <a:t>Week 6 · Ongoing context        8 / 27</a:t>
+              <a:t>Week 6 · Ongoing context        8 / 26</a:t>
             </a:r>
           </a:p>
         </p:txBody>
@@ -11308,7 +11019,7 @@
                 </a:solidFill>
                 <a:latin typeface="DM Sans"/>
               </a:rPr>
-              <a:t>Week 6 · Communicate intent        9 / 27</a:t>
+              <a:t>Week 6 · Communicate intent        9 / 26</a:t>
             </a:r>
           </a:p>
         </p:txBody>

</xml_diff>

<commit_message>
Week 6 slides: replace GitHub Desktop path with 'get it online your way' (Aaron)
</commit_message>
<xml_diff>
--- a/lessons/week-6/_src/week6-lecture.pptx
+++ b/lessons/week-6/_src/week6-lecture.pptx
@@ -1087,7 +1087,7 @@
           <a:lstStyle/>
           <a:p>
             <a:r>
-              <a:t>Recent Week 5 publishing confusion was partly Vercel needing GitHub repo access. Do not prescribe Pages for every framework app; the handout is supplemental detail, not essential to the invitation.</a:t>
+              <a:t>No prescribed app. Students use whatever tool they already have; the point is understanding the steps and checking the public link.</a:t>
             </a:r>
           </a:p>
         </p:txBody>
@@ -7073,7 +7073,7 @@
                 </a:solidFill>
                 <a:latin typeface="Fraunces"/>
               </a:rPr>
-              <a:t>A practical path to publishing</a:t>
+              <a:t>Getting it online, your way</a:t>
             </a:r>
           </a:p>
         </p:txBody>
@@ -7112,7 +7112,7 @@
                 </a:solidFill>
                 <a:latin typeface="DM Sans"/>
               </a:rPr>
-              <a:t>•  GitHub Desktop: create a repository → commit → publish to GitHub.</a:t>
+              <a:t>•  Ask the AI tool you already use: “Help me get this online with the tools I have. Explain each step as we go.”</a:t>
             </a:r>
           </a:p>
           <a:p>
@@ -7128,7 +7128,7 @@
                 </a:solidFill>
                 <a:latin typeface="DM Sans"/>
               </a:rPr>
-              <a:t>•  Plain HTML/CSS: GitHub Settings → Pages → main branch / root → Save.</a:t>
+              <a:t>•  It will save a version, send it to GitHub, and publish it with a host.</a:t>
             </a:r>
           </a:p>
           <a:p>
@@ -7144,7 +7144,7 @@
                 </a:solidFill>
                 <a:latin typeface="DM Sans"/>
               </a:rPr>
-              <a:t>•  A framework app may need Vercel: allow repository access, deploy, then test the URL.</a:t>
+              <a:t>•  Done means a public link that opens on someone else’s phone.</a:t>
             </a:r>
           </a:p>
         </p:txBody>

</xml_diff>

<commit_message>
Week 6 slides: replace GitHub Desktop path with 'get it online your way' (Aaron) (#17)
Co-authored-by: Unforced AGI <agi@unforced.dev>
</commit_message>
<xml_diff>
--- a/lessons/week-6/_src/week6-lecture.pptx
+++ b/lessons/week-6/_src/week6-lecture.pptx
@@ -1087,7 +1087,7 @@
           <a:lstStyle/>
           <a:p>
             <a:r>
-              <a:t>Recent Week 5 publishing confusion was partly Vercel needing GitHub repo access. Do not prescribe Pages for every framework app; the handout is supplemental detail, not essential to the invitation.</a:t>
+              <a:t>No prescribed app. Students use whatever tool they already have; the point is understanding the steps and checking the public link.</a:t>
             </a:r>
           </a:p>
         </p:txBody>
@@ -7073,7 +7073,7 @@
                 </a:solidFill>
                 <a:latin typeface="Fraunces"/>
               </a:rPr>
-              <a:t>A practical path to publishing</a:t>
+              <a:t>Getting it online, your way</a:t>
             </a:r>
           </a:p>
         </p:txBody>
@@ -7112,7 +7112,7 @@
                 </a:solidFill>
                 <a:latin typeface="DM Sans"/>
               </a:rPr>
-              <a:t>•  GitHub Desktop: create a repository → commit → publish to GitHub.</a:t>
+              <a:t>•  Ask the AI tool you already use: “Help me get this online with the tools I have. Explain each step as we go.”</a:t>
             </a:r>
           </a:p>
           <a:p>
@@ -7128,7 +7128,7 @@
                 </a:solidFill>
                 <a:latin typeface="DM Sans"/>
               </a:rPr>
-              <a:t>•  Plain HTML/CSS: GitHub Settings → Pages → main branch / root → Save.</a:t>
+              <a:t>•  It will save a version, send it to GitHub, and publish it with a host.</a:t>
             </a:r>
           </a:p>
           <a:p>
@@ -7144,7 +7144,7 @@
                 </a:solidFill>
                 <a:latin typeface="DM Sans"/>
               </a:rPr>
-              <a:t>•  A framework app may need Vercel: allow repository access, deploy, then test the URL.</a:t>
+              <a:t>•  Done means a public link that opens on someone else’s phone.</a:t>
             </a:r>
           </a:p>
         </p:txBody>

</xml_diff>

<commit_message>
Week 6 slides: class overview of builds + shared friction; merge design/feedback/debug; drop credits slide (Aaron)
</commit_message>
<xml_diff>
--- a/lessons/week-6/_src/week6-lecture.pptx
+++ b/lessons/week-6/_src/week6-lecture.pptx
@@ -29,8 +29,6 @@
     <p:sldId id="277" r:id="rId29"/>
     <p:sldId id="278" r:id="rId30"/>
     <p:sldId id="279" r:id="rId31"/>
-    <p:sldId id="280" r:id="rId32"/>
-    <p:sldId id="281" r:id="rId33"/>
   </p:sldIdLst>
   <p:sldSz cx="12191695" cy="6858000" type="screen4x3"/>
   <p:notesSz cx="6858000" cy="9144000"/>
@@ -597,7 +595,7 @@
           <a:lstStyle/>
           <a:p>
             <a:r>
-              <a:t>Recent Week 5 work caught non-clickable cards through use. Specific observed behavior gives the agent something testable.</a:t>
+              <a:t>One idea: close the gap between what you pictured and what you got by being concrete. Covers design, feedback and bugs in one move.</a:t>
             </a:r>
           </a:p>
         </p:txBody>
@@ -667,7 +665,7 @@
           <a:lstStyle/>
           <a:p>
             <a:r>
-              <a:t>Do not blindly rewrite the whole app. Before a risky fix, save a working version. Recent students used AI for testing/debugging but still needed to notice what failed.</a:t>
+              <a:t>A running build is not proof it is correct or useful. This transfers directly to the small-group learning builds.</a:t>
             </a:r>
           </a:p>
         </p:txBody>
@@ -737,7 +735,7 @@
           <a:lstStyle/>
           <a:p>
             <a:r>
-              <a:t>A running build is not proof it is correct or useful. This transfers directly to the small-group learning builds.</a:t>
+              <a:t>A GitHub repo can hold code without having a live website. A folder path cannot be submitted as an accessible build link.</a:t>
             </a:r>
           </a:p>
         </p:txBody>
@@ -807,7 +805,7 @@
           <a:lstStyle/>
           <a:p>
             <a:r>
-              <a:t>Recent Week 5 submissions described switching tools and running out of credits. Persistent context is a practical continuity aid; do not imply unlimited free usage.</a:t>
+              <a:t>Use an ordinary change as an example: fix a heading, commit “Clarify heading”, push, wait for deployment, verify the live page.</a:t>
             </a:r>
           </a:p>
         </p:txBody>
@@ -877,7 +875,7 @@
           <a:lstStyle/>
           <a:p>
             <a:r>
-              <a:t>A GitHub repo can hold code without having a live website. A folder path cannot be submitted as an accessible build link.</a:t>
+              <a:t>Repeated local-link issues in actual submissions. For a public build, check that it does not require your account to open.</a:t>
             </a:r>
           </a:p>
         </p:txBody>
@@ -947,7 +945,7 @@
           <a:lstStyle/>
           <a:p>
             <a:r>
-              <a:t>Use an ordinary change as an example: fix a heading, commit “Clarify heading”, push, wait for deployment, verify the live page.</a:t>
+              <a:t>No prescribed app. Students use whatever tool they already have; the point is understanding the steps and checking the public link.</a:t>
             </a:r>
           </a:p>
         </p:txBody>
@@ -1017,7 +1015,7 @@
           <a:lstStyle/>
           <a:p>
             <a:r>
-              <a:t>Repeated local-link issues in actual submissions. For a public build, check that it does not require your account to open.</a:t>
+              <a:t>Example: a weather service has an API that returns a forecast. An MCP connection lets your AI use services like that inside a conversation. In Claude these show up as connectors. Concept only tonight; next week we connect.</a:t>
             </a:r>
           </a:p>
         </p:txBody>
@@ -1087,7 +1085,7 @@
           <a:lstStyle/>
           <a:p>
             <a:r>
-              <a:t>No prescribed app. Students use whatever tool they already have; the point is understanding the steps and checking the public link.</a:t>
+              <a:t>Students recently asked their tools to explain the tool itself while building. Model this as a learning practice, not outsourcing understanding.</a:t>
             </a:r>
           </a:p>
         </p:txBody>
@@ -1157,7 +1155,7 @@
           <a:lstStyle/>
           <a:p>
             <a:r>
-              <a:t>Example: a weather service has an API that returns a forecast. An MCP connection lets your AI use services like that inside a conversation. In Claude these show up as connectors. Concept only tonight; next week we connect.</a:t>
+              <a:t>Assigned reading. Shipper turned reflection on actual projects into a coaching conversation. The reading link is in students’ accounts; no new due date.</a:t>
             </a:r>
           </a:p>
         </p:txBody>
@@ -1227,7 +1225,7 @@
           <a:lstStyle/>
           <a:p>
             <a:r>
-              <a:t>Students recently asked their tools to explain the tool itself while building. Model this as a learning practice, not outsourcing understanding.</a:t>
+              <a:t>Free plans need not have long-term memory. Give a small truthful sample, not every private conversation.</a:t>
             </a:r>
           </a:p>
         </p:txBody>
@@ -1297,7 +1295,7 @@
           <a:lstStyle/>
           <a:p>
             <a:r>
-              <a:t>Grounded in actual Week 4/5 submissions: visual intent failed to translate; one build had non-clickable cards; localhost and deployment-permission confusion persisted. Public slides deliberately omit names and private quotes.</a:t>
+              <a:t>Week 5 work, anonymised. Celebrate range: different starting points, all real builds. Invite a couple of people to say a sentence about theirs if the room is warm.</a:t>
             </a:r>
           </a:p>
         </p:txBody>
@@ -1367,7 +1365,7 @@
           <a:lstStyle/>
           <a:p>
             <a:r>
-              <a:t>Assigned reading. Shipper turned reflection on actual projects into a coaching conversation. The reading link is in students’ accounts; no new due date.</a:t>
+              <a:t>Every essential access instruction is here, not hidden in a handout. This is how the reading’s coaching idea becomes something students can do tonight.</a:t>
             </a:r>
           </a:p>
         </p:txBody>
@@ -1437,7 +1435,7 @@
           <a:lstStyle/>
           <a:p>
             <a:r>
-              <a:t>Free plans need not have long-term memory. Give a small truthful sample, not every private conversation.</a:t>
+              <a:t>This is the only live demo slot, after the teaching content. Do not prescribe a project, script or output. If delayed, discuss a question from the lesson and move to group work.</a:t>
             </a:r>
           </a:p>
         </p:txBody>
@@ -1507,7 +1505,7 @@
           <a:lstStyle/>
           <a:p>
             <a:r>
-              <a:t>Every essential access instruction is here, not hidden in a handout. This is how the reading’s coaching idea becomes something students can do tonight.</a:t>
+              <a:t>Open-ended invitation, no fixed template or prescribed roles. Help students choose a small first learning goal without deciding their project for them.</a:t>
             </a:r>
           </a:p>
         </p:txBody>
@@ -1577,7 +1575,7 @@
           <a:lstStyle/>
           <a:p>
             <a:r>
-              <a:t>This is the only live demo slot, after the teaching content. Do not prescribe a project, script or output. If delayed, discuss a question from the lesson and move to group work.</a:t>
+              <a:t>Optional: ask your AI what it needs to know about your project; save the useful context in markdown. Students can find the lesson from the preceding slide. No due date added.</a:t>
             </a:r>
           </a:p>
         </p:txBody>
@@ -1647,146 +1645,6 @@
           <a:lstStyle/>
           <a:p>
             <a:r>
-              <a:t>Open-ended invitation, no fixed template or prescribed roles. Help students choose a small first learning goal without deciding their project for them.</a:t>
-            </a:r>
-          </a:p>
-        </p:txBody>
-      </p:sp>
-      <p:sp>
-        <p:nvSpPr>
-          <p:cNvPr id="4" name="Slide Number Placeholder 3"/>
-          <p:cNvSpPr>
-            <a:spLocks noGrp="1"/>
-          </p:cNvSpPr>
-          <p:nvPr>
-            <p:ph type="sldNum" idx="5" sz="quarter"/>
-          </p:nvPr>
-        </p:nvSpPr>
-        <p:spPr/>
-      </p:sp>
-    </p:spTree>
-  </p:cSld>
-  <p:clrMapOvr>
-    <a:masterClrMapping/>
-  </p:clrMapOvr>
-</p:notes>
-</file>
-
-<file path=ppt/notesSlides/notesSlide25.xml><?xml version="1.0" encoding="utf-8"?>
-<p:notes xmlns:a="http://schemas.openxmlformats.org/drawingml/2006/main" xmlns:p="http://schemas.openxmlformats.org/presentationml/2006/main" xmlns:r="http://schemas.openxmlformats.org/officeDocument/2006/relationships">
-  <p:cSld>
-    <p:spTree>
-      <p:nvGrpSpPr>
-        <p:cNvPr id="1" name=""/>
-        <p:cNvGrpSpPr/>
-        <p:nvPr/>
-      </p:nvGrpSpPr>
-      <p:grpSpPr>
-        <a:xfrm>
-          <a:off x="0" y="0"/>
-          <a:ext cx="0" cy="0"/>
-          <a:chOff x="0" y="0"/>
-          <a:chExt cx="0" cy="0"/>
-        </a:xfrm>
-      </p:grpSpPr>
-      <p:sp>
-        <p:nvSpPr>
-          <p:cNvPr id="2" name="Slide Image Placeholder 1"/>
-          <p:cNvSpPr>
-            <a:spLocks noGrp="1"/>
-          </p:cNvSpPr>
-          <p:nvPr>
-            <p:ph type="sldImg" idx="2"/>
-          </p:nvPr>
-        </p:nvSpPr>
-        <p:spPr/>
-      </p:sp>
-      <p:sp>
-        <p:nvSpPr>
-          <p:cNvPr id="3" name="Notes Placeholder 2"/>
-          <p:cNvSpPr>
-            <a:spLocks noGrp="1"/>
-          </p:cNvSpPr>
-          <p:nvPr>
-            <p:ph type="body" idx="3" sz="quarter"/>
-          </p:nvPr>
-        </p:nvSpPr>
-        <p:spPr/>
-        <p:txBody>
-          <a:bodyPr/>
-          <a:lstStyle/>
-          <a:p>
-            <a:r>
-              <a:t>Optional: ask your AI what it needs to know about your project; save the useful context in markdown. Students can find the lesson from the preceding slide. No due date added.</a:t>
-            </a:r>
-          </a:p>
-        </p:txBody>
-      </p:sp>
-      <p:sp>
-        <p:nvSpPr>
-          <p:cNvPr id="4" name="Slide Number Placeholder 3"/>
-          <p:cNvSpPr>
-            <a:spLocks noGrp="1"/>
-          </p:cNvSpPr>
-          <p:nvPr>
-            <p:ph type="sldNum" idx="5" sz="quarter"/>
-          </p:nvPr>
-        </p:nvSpPr>
-        <p:spPr/>
-      </p:sp>
-    </p:spTree>
-  </p:cSld>
-  <p:clrMapOvr>
-    <a:masterClrMapping/>
-  </p:clrMapOvr>
-</p:notes>
-</file>
-
-<file path=ppt/notesSlides/notesSlide26.xml><?xml version="1.0" encoding="utf-8"?>
-<p:notes xmlns:a="http://schemas.openxmlformats.org/drawingml/2006/main" xmlns:p="http://schemas.openxmlformats.org/presentationml/2006/main" xmlns:r="http://schemas.openxmlformats.org/officeDocument/2006/relationships">
-  <p:cSld>
-    <p:spTree>
-      <p:nvGrpSpPr>
-        <p:cNvPr id="1" name=""/>
-        <p:cNvGrpSpPr/>
-        <p:nvPr/>
-      </p:nvGrpSpPr>
-      <p:grpSpPr>
-        <a:xfrm>
-          <a:off x="0" y="0"/>
-          <a:ext cx="0" cy="0"/>
-          <a:chOff x="0" y="0"/>
-          <a:chExt cx="0" cy="0"/>
-        </a:xfrm>
-      </p:grpSpPr>
-      <p:sp>
-        <p:nvSpPr>
-          <p:cNvPr id="2" name="Slide Image Placeholder 1"/>
-          <p:cNvSpPr>
-            <a:spLocks noGrp="1"/>
-          </p:cNvSpPr>
-          <p:nvPr>
-            <p:ph type="sldImg" idx="2"/>
-          </p:nvPr>
-        </p:nvSpPr>
-        <p:spPr/>
-      </p:sp>
-      <p:sp>
-        <p:nvSpPr>
-          <p:cNvPr id="3" name="Notes Placeholder 2"/>
-          <p:cNvSpPr>
-            <a:spLocks noGrp="1"/>
-          </p:cNvSpPr>
-          <p:nvPr>
-            <p:ph type="body" idx="3" sz="quarter"/>
-          </p:nvPr>
-        </p:nvSpPr>
-        <p:spPr/>
-        <p:txBody>
-          <a:bodyPr/>
-          <a:lstStyle/>
-          <a:p>
-            <a:r>
               <a:t>Authoritative Week 6 assignment replaces the required build. One page, not one paragraph. Existing due date remains October 11 at 11:59 PM MT. Pods share learning and support each other in class for AT LEAST the next three weeks; do not invent size, rubric, or final-project requirements. Canvas copy is a draft, not yet published.</a:t>
             </a:r>
           </a:p>
@@ -1857,7 +1715,7 @@
           <a:lstStyle/>
           <a:p>
             <a:r>
-              <a:t>Explain portability: the same text works across tools. A file can be edited without a platform account.</a:t>
+              <a:t>Pulled from reflections. Name these as normal, shared experiences, not failures. Each maps to a section of tonight: context, saying what you mean, getting online.</a:t>
             </a:r>
           </a:p>
         </p:txBody>
@@ -1927,7 +1785,7 @@
           <a:lstStyle/>
           <a:p>
             <a:r>
-              <a:t>Point out # and ## headings; - list; [label](URL) link; backticks for code. These are examples, not a context template.</a:t>
+              <a:t>Explain portability: the same text works across tools. A file can be edited without a platform account.</a:t>
             </a:r>
           </a:p>
         </p:txBody>
@@ -1997,7 +1855,7 @@
           <a:lstStyle/>
           <a:p>
             <a:r>
-              <a:t>Avoid claiming every app literally starts at zero: some add saved memory or project files. Ask what context the tool loaded.</a:t>
+              <a:t>Point out # and ## headings; - list; [label](URL) link; backticks for code. These are examples, not a context template.</a:t>
             </a:r>
           </a:p>
         </p:txBody>
@@ -2067,7 +1925,7 @@
           <a:lstStyle/>
           <a:p>
             <a:r>
-              <a:t>These are useful questions, not a rigid template or pair interview. Student projects vary: portfolios, creative work, tools, simulations.</a:t>
+              <a:t>Avoid claiming every app literally starts at zero: some add saved memory or project files. Ask what context the tool loaded.</a:t>
             </a:r>
           </a:p>
         </p:txBody>
@@ -2137,7 +1995,7 @@
           <a:lstStyle/>
           <a:p>
             <a:r>
-              <a:t>Put the file in the top folder of the project. Verified tonight: Claude Code picked up AGENTS.md in a fresh session. Keep the point simple: write the context once, and the agent starts with it.</a:t>
+              <a:t>These are useful questions, not a rigid template or pair interview. Student projects vary: portfolios, creative work, tools, simulations.</a:t>
             </a:r>
           </a:p>
         </p:txBody>
@@ -2207,7 +2065,7 @@
           <a:lstStyle/>
           <a:p>
             <a:r>
-              <a:t>Index files are a map, not evidence that the AI read the linked files. Ask it which sources it used.</a:t>
+              <a:t>Put the file in the top folder of the project. Verified tonight: Claude Code picked up AGENTS.md in a fresh session. Keep the point simple: write the context once, and the agent starts with it.</a:t>
             </a:r>
           </a:p>
         </p:txBody>
@@ -2277,7 +2135,7 @@
           <a:lstStyle/>
           <a:p>
             <a:r>
-              <a:t>Week 4/5 reflections describe trouble communicating aesthetics; a recent rebuild improved when the student described the feeling instead of only listing features.</a:t>
+              <a:t>Index files are a map, not evidence that the AI read the linked files. Ask it which sources it used.</a:t>
             </a:r>
           </a:p>
         </p:txBody>
@@ -5439,7 +5297,7 @@
                 </a:solidFill>
                 <a:latin typeface="DM Sans"/>
               </a:rPr>
-              <a:t>Week 6 · Opening        1 / 26</a:t>
+              <a:t>Week 6 · Opening        1 / 24</a:t>
             </a:r>
           </a:p>
         </p:txBody>
@@ -5547,7 +5405,7 @@
                 </a:solidFill>
                 <a:latin typeface="Fraunces"/>
               </a:rPr>
-              <a:t>Make your feedback observable</a:t>
+              <a:t>When the result isn’t what you meant</a:t>
             </a:r>
           </a:p>
         </p:txBody>
@@ -5586,7 +5444,7 @@
                 </a:solidFill>
                 <a:latin typeface="DM Sans"/>
               </a:rPr>
-              <a:t>•  Give a reference or screenshot; say what to keep and what to change.</a:t>
+              <a:t>•  Say what you expected and what you actually see: “Clicking the card should open the project; nothing happens.”</a:t>
             </a:r>
           </a:p>
           <a:p>
@@ -5602,7 +5460,7 @@
                 </a:solidFill>
                 <a:latin typeface="DM Sans"/>
               </a:rPr>
-              <a:t>•  Instead of “It’s broken”: “Clicking this card should open the project; nothing happens.”</a:t>
+              <a:t>•  Show it: a screenshot or a site you like says more than “make it better”.</a:t>
             </a:r>
           </a:p>
           <a:p>
@@ -5618,7 +5476,7 @@
                 </a:solidFill>
                 <a:latin typeface="DM Sans"/>
               </a:rPr>
-              <a:t>•  Ask for one small change, then compare the result with your intention.</a:t>
+              <a:t>•  Ask for one change at a time, then look again.</a:t>
             </a:r>
           </a:p>
         </p:txBody>
@@ -5657,7 +5515,7 @@
                 </a:solidFill>
                 <a:latin typeface="DM Sans"/>
               </a:rPr>
-              <a:t>Week 6 · Communicate intent        10 / 26</a:t>
+              <a:t>Week 6 · Communicate intent        10 / 24</a:t>
             </a:r>
           </a:p>
         </p:txBody>
@@ -5765,7 +5623,7 @@
                 </a:solidFill>
                 <a:latin typeface="Fraunces"/>
               </a:rPr>
-              <a:t>Debugging: find the mismatch</a:t>
+              <a:t>Check the experience—not just the code</a:t>
             </a:r>
           </a:p>
         </p:txBody>
@@ -5804,7 +5662,7 @@
                 </a:solidFill>
                 <a:latin typeface="DM Sans"/>
               </a:rPr>
-              <a:t>•  A bug is a difference between expected and observed behavior.</a:t>
+              <a:t>•  Open it on a phone. Click every important button and link.</a:t>
             </a:r>
           </a:p>
           <a:p>
@@ -5820,7 +5678,7 @@
                 </a:solidFill>
                 <a:latin typeface="DM Sans"/>
               </a:rPr>
-              <a:t>•  Reproduce it: what exact actions cause it? Capture the error or screenshot.</a:t>
+              <a:t>•  Try empty input, a strange answer, or a first-time visitor’s path.</a:t>
             </a:r>
           </a:p>
           <a:p>
@@ -5836,7 +5694,7 @@
                 </a:solidFill>
                 <a:latin typeface="DM Sans"/>
               </a:rPr>
-              <a:t>•  Ask the AI for a cause and a small fix; rerun the same check afterward.</a:t>
+              <a:t>•  For a learning tool, check its facts and quiz answers against a trustworthy source.</a:t>
             </a:r>
           </a:p>
         </p:txBody>
@@ -5875,7 +5733,7 @@
                 </a:solidFill>
                 <a:latin typeface="DM Sans"/>
               </a:rPr>
-              <a:t>Week 6 · Check the work        11 / 26</a:t>
+              <a:t>Week 6 · Check the work        11 / 24</a:t>
             </a:r>
           </a:p>
         </p:txBody>
@@ -5977,13 +5835,13 @@
               </a:spcAft>
             </a:pPr>
             <a:r>
-              <a:rPr sz="4000" b="1">
+              <a:rPr sz="3200" b="1">
                 <a:solidFill>
                   <a:srgbClr val="272A25"/>
                 </a:solidFill>
                 <a:latin typeface="Fraunces"/>
               </a:rPr>
-              <a:t>Check the experience—not just the code</a:t>
+              <a:t>Folder, repository, website: different things</a:t>
             </a:r>
           </a:p>
         </p:txBody>
@@ -6022,7 +5880,7 @@
                 </a:solidFill>
                 <a:latin typeface="DM Sans"/>
               </a:rPr>
-              <a:t>•  Open it on a phone. Click every important button and link.</a:t>
+              <a:t>•  Local folder: files on your own computer.</a:t>
             </a:r>
           </a:p>
           <a:p>
@@ -6038,7 +5896,7 @@
                 </a:solidFill>
                 <a:latin typeface="DM Sans"/>
               </a:rPr>
-              <a:t>•  Try empty input, a strange answer, or a first-time visitor’s path.</a:t>
+              <a:t>•  Git repository: those files plus a recorded history of versions.</a:t>
             </a:r>
           </a:p>
           <a:p>
@@ -6054,7 +5912,7 @@
                 </a:solidFill>
                 <a:latin typeface="DM Sans"/>
               </a:rPr>
-              <a:t>•  For a learning tool, check its facts and quiz answers against a trustworthy source.</a:t>
+              <a:t>•  Deployment: a published version that other people can open.</a:t>
             </a:r>
           </a:p>
         </p:txBody>
@@ -6093,7 +5951,7 @@
                 </a:solidFill>
                 <a:latin typeface="DM Sans"/>
               </a:rPr>
-              <a:t>Week 6 · Check the work        12 / 26</a:t>
+              <a:t>Week 6 · Getting online        12 / 24</a:t>
             </a:r>
           </a:p>
         </p:txBody>
@@ -6201,7 +6059,7 @@
                 </a:solidFill>
                 <a:latin typeface="Fraunces"/>
               </a:rPr>
-              <a:t>When free credits run out</a:t>
+              <a:t>Commit, push, deploy: three actions</a:t>
             </a:r>
           </a:p>
         </p:txBody>
@@ -6240,7 +6098,7 @@
                 </a:solidFill>
                 <a:latin typeface="DM Sans"/>
               </a:rPr>
-              <a:t>•  Save files and a short note: what works, what failed, what to try next.</a:t>
+              <a:t>•  Commit saves a version and a message in your local Git history.</a:t>
             </a:r>
           </a:p>
           <a:p>
@@ -6256,7 +6114,7 @@
                 </a:solidFill>
                 <a:latin typeface="DM Sans"/>
               </a:rPr>
-              <a:t>•  Use that note to continue in a fresh session or another tool.</a:t>
+              <a:t>•  Push sends your commits to the repository on GitHub.</a:t>
             </a:r>
           </a:p>
           <a:p>
@@ -6272,7 +6130,7 @@
                 </a:solidFill>
                 <a:latin typeface="DM Sans"/>
               </a:rPr>
-              <a:t>•  Reduce the request: one change or one explanation at a time.</a:t>
+              <a:t>•  Deploy publishes the project through a host such as GitHub Pages or Vercel.</a:t>
             </a:r>
           </a:p>
         </p:txBody>
@@ -6311,7 +6169,7 @@
                 </a:solidFill>
                 <a:latin typeface="DM Sans"/>
               </a:rPr>
-              <a:t>Week 6 · Working within limits        13 / 26</a:t>
+              <a:t>Week 6 · Getting online        13 / 24</a:t>
             </a:r>
           </a:p>
         </p:txBody>
@@ -6419,7 +6277,7 @@
                 </a:solidFill>
                 <a:latin typeface="Fraunces"/>
               </a:rPr>
-              <a:t>Folder, repository, website: different things</a:t>
+              <a:t>Your link must work on someone else’s phone</a:t>
             </a:r>
           </a:p>
         </p:txBody>
@@ -6458,7 +6316,7 @@
                 </a:solidFill>
                 <a:latin typeface="DM Sans"/>
               </a:rPr>
-              <a:t>•  Local folder: files on your own computer.</a:t>
+              <a:t>•  file:///… and localhost:8000 point to your own computer—not a public site.</a:t>
             </a:r>
           </a:p>
           <a:p>
@@ -6474,7 +6332,7 @@
                 </a:solidFill>
                 <a:latin typeface="DM Sans"/>
               </a:rPr>
-              <a:t>•  Git repository: those files plus a recorded history of versions.</a:t>
+              <a:t>•  A GitHub repository URL shows source; it may not be the live app URL.</a:t>
             </a:r>
           </a:p>
           <a:p>
@@ -6490,7 +6348,7 @@
                 </a:solidFill>
                 <a:latin typeface="DM Sans"/>
               </a:rPr>
-              <a:t>•  Deployment: a published version that other people can open.</a:t>
+              <a:t>•  Use the deployed HTTPS URL; test it on another device or in a private window.</a:t>
             </a:r>
           </a:p>
         </p:txBody>
@@ -6529,7 +6387,7 @@
                 </a:solidFill>
                 <a:latin typeface="DM Sans"/>
               </a:rPr>
-              <a:t>Week 6 · Getting online        14 / 26</a:t>
+              <a:t>Week 6 · Getting online        14 / 24</a:t>
             </a:r>
           </a:p>
         </p:txBody>
@@ -6637,7 +6495,7 @@
                 </a:solidFill>
                 <a:latin typeface="Fraunces"/>
               </a:rPr>
-              <a:t>Commit, push, deploy: three actions</a:t>
+              <a:t>Getting it online, your way</a:t>
             </a:r>
           </a:p>
         </p:txBody>
@@ -6676,7 +6534,7 @@
                 </a:solidFill>
                 <a:latin typeface="DM Sans"/>
               </a:rPr>
-              <a:t>•  Commit saves a version and a message in your local Git history.</a:t>
+              <a:t>•  Ask the AI tool you already use: “Help me get this online with the tools I have. Explain each step as we go.”</a:t>
             </a:r>
           </a:p>
           <a:p>
@@ -6692,7 +6550,7 @@
                 </a:solidFill>
                 <a:latin typeface="DM Sans"/>
               </a:rPr>
-              <a:t>•  Push sends your commits to the repository on GitHub.</a:t>
+              <a:t>•  It will save a version, send it to GitHub, and publish it with a host.</a:t>
             </a:r>
           </a:p>
           <a:p>
@@ -6708,7 +6566,7 @@
                 </a:solidFill>
                 <a:latin typeface="DM Sans"/>
               </a:rPr>
-              <a:t>•  Deploy publishes the project through a host such as GitHub Pages or Vercel.</a:t>
+              <a:t>•  Done means a public link that opens on someone else’s phone.</a:t>
             </a:r>
           </a:p>
         </p:txBody>
@@ -6747,7 +6605,7 @@
                 </a:solidFill>
                 <a:latin typeface="DM Sans"/>
               </a:rPr>
-              <a:t>Week 6 · Getting online        15 / 26</a:t>
+              <a:t>Week 6 · Getting online        15 / 24</a:t>
             </a:r>
           </a:p>
         </p:txBody>
@@ -6855,7 +6713,7 @@
                 </a:solidFill>
                 <a:latin typeface="Fraunces"/>
               </a:rPr>
-              <a:t>Your link must work on someone else’s phone</a:t>
+              <a:t>APIs and MCP: how AI connects to other tools</a:t>
             </a:r>
           </a:p>
         </p:txBody>
@@ -6894,7 +6752,7 @@
                 </a:solidFill>
                 <a:latin typeface="DM Sans"/>
               </a:rPr>
-              <a:t>•  file:///… and localhost:8000 point to your own computer—not a public site.</a:t>
+              <a:t>•  API: how one program requests information or actions from another.</a:t>
             </a:r>
           </a:p>
           <a:p>
@@ -6910,7 +6768,7 @@
                 </a:solidFill>
                 <a:latin typeface="DM Sans"/>
               </a:rPr>
-              <a:t>•  A GitHub repository URL shows source; it may not be the live app URL.</a:t>
+              <a:t>•  MCP: a standard way for AI tools to connect to other services and data.</a:t>
             </a:r>
           </a:p>
           <a:p>
@@ -6926,7 +6784,7 @@
                 </a:solidFill>
                 <a:latin typeface="DM Sans"/>
               </a:rPr>
-              <a:t>•  Use the deployed HTTPS URL; test it on another device or in a private window.</a:t>
+              <a:t>•  In Claude, these MCP connections are called connectors.</a:t>
             </a:r>
           </a:p>
         </p:txBody>
@@ -6965,7 +6823,7 @@
                 </a:solidFill>
                 <a:latin typeface="DM Sans"/>
               </a:rPr>
-              <a:t>Week 6 · Getting online        16 / 26</a:t>
+              <a:t>Week 6 · Connections—concept only        16 / 24</a:t>
             </a:r>
           </a:p>
         </p:txBody>
@@ -7073,7 +6931,7 @@
                 </a:solidFill>
                 <a:latin typeface="Fraunces"/>
               </a:rPr>
-              <a:t>Getting it online, your way</a:t>
+              <a:t>Use AI to learn about AI</a:t>
             </a:r>
           </a:p>
         </p:txBody>
@@ -7112,7 +6970,7 @@
                 </a:solidFill>
                 <a:latin typeface="DM Sans"/>
               </a:rPr>
-              <a:t>•  Ask the AI tool you already use: “Help me get this online with the tools I have. Explain each step as we go.”</a:t>
+              <a:t>•  Ask for an explanation, an example, and a question to check your understanding.</a:t>
             </a:r>
           </a:p>
           <a:p>
@@ -7128,7 +6986,7 @@
                 </a:solidFill>
                 <a:latin typeface="DM Sans"/>
               </a:rPr>
-              <a:t>•  It will save a version, send it to GitHub, and publish it with a host.</a:t>
+              <a:t>•  Say what you already know: “I know HTML; Git is new to me.”</a:t>
             </a:r>
           </a:p>
           <a:p>
@@ -7144,7 +7002,7 @@
                 </a:solidFill>
                 <a:latin typeface="DM Sans"/>
               </a:rPr>
-              <a:t>•  Done means a public link that opens on someone else’s phone.</a:t>
+              <a:t>•  Compare its explanation with your source—not just how confident it sounds.</a:t>
             </a:r>
           </a:p>
         </p:txBody>
@@ -7183,7 +7041,7 @@
                 </a:solidFill>
                 <a:latin typeface="DM Sans"/>
               </a:rPr>
-              <a:t>Week 6 · Getting online        17 / 26</a:t>
+              <a:t>Week 6 · Learn with AI        17 / 24</a:t>
             </a:r>
           </a:p>
         </p:txBody>
@@ -7285,13 +7143,13 @@
               </a:spcAft>
             </a:pPr>
             <a:r>
-              <a:rPr sz="3200" b="1">
+              <a:rPr sz="4000" b="1">
                 <a:solidFill>
                   <a:srgbClr val="272A25"/>
                 </a:solidFill>
                 <a:latin typeface="Fraunces"/>
               </a:rPr>
-              <a:t>APIs and MCP: how AI connects to other tools</a:t>
+              <a:t>The reading: your AI as a coach</a:t>
             </a:r>
           </a:p>
         </p:txBody>
@@ -7330,7 +7188,7 @@
                 </a:solidFill>
                 <a:latin typeface="DM Sans"/>
               </a:rPr>
-              <a:t>•  API: how one program requests information or actions from another.</a:t>
+              <a:t>•  Arielle Shipper · “How to Get Better at AI by Asking AI” · Every</a:t>
             </a:r>
           </a:p>
           <a:p>
@@ -7346,7 +7204,7 @@
                 </a:solidFill>
                 <a:latin typeface="DM Sans"/>
               </a:rPr>
-              <a:t>•  MCP: a standard way for AI tools to connect to other services and data.</a:t>
+              <a:t>•  Ask where you are on the Eight Levels of AI Adoption, with evidence from your work.</a:t>
             </a:r>
           </a:p>
           <a:p>
@@ -7362,7 +7220,7 @@
                 </a:solidFill>
                 <a:latin typeface="DM Sans"/>
               </a:rPr>
-              <a:t>•  In Claude, these MCP connections are called connectors.</a:t>
+              <a:t>•  Ask for one next step, then: “Teach me that and help me practise.”</a:t>
             </a:r>
           </a:p>
         </p:txBody>
@@ -7401,7 +7259,7 @@
                 </a:solidFill>
                 <a:latin typeface="DM Sans"/>
               </a:rPr>
-              <a:t>Week 6 · Connections—concept only        18 / 26</a:t>
+              <a:t>Week 6 · Learn with AI        18 / 24</a:t>
             </a:r>
           </a:p>
         </p:txBody>
@@ -7503,13 +7361,13 @@
               </a:spcAft>
             </a:pPr>
             <a:r>
-              <a:rPr sz="4000" b="1">
+              <a:rPr sz="3200" b="1">
                 <a:solidFill>
                   <a:srgbClr val="272A25"/>
                 </a:solidFill>
                 <a:latin typeface="Fraunces"/>
               </a:rPr>
-              <a:t>Use AI to learn about AI</a:t>
+              <a:t>No long chat history? Bring your own evidence</a:t>
             </a:r>
           </a:p>
         </p:txBody>
@@ -7548,7 +7406,7 @@
                 </a:solidFill>
                 <a:latin typeface="DM Sans"/>
               </a:rPr>
-              <a:t>•  Ask for an explanation, an example, and a question to check your understanding.</a:t>
+              <a:t>•  Paste your last two submissions or describe a recent project.</a:t>
             </a:r>
           </a:p>
           <a:p>
@@ -7564,7 +7422,7 @@
                 </a:solidFill>
                 <a:latin typeface="DM Sans"/>
               </a:rPr>
-              <a:t>•  Say what you already know: “I know HTML; Git is new to me.”</a:t>
+              <a:t>•  Ask: “What can I do already? Show examples. What should I learn next?”</a:t>
             </a:r>
           </a:p>
           <a:p>
@@ -7580,7 +7438,7 @@
                 </a:solidFill>
                 <a:latin typeface="DM Sans"/>
               </a:rPr>
-              <a:t>•  Compare its explanation with your source—not just how confident it sounds.</a:t>
+              <a:t>•  Treat the AI’s assessment as a suggestion; correct its assumptions.</a:t>
             </a:r>
           </a:p>
         </p:txBody>
@@ -7619,7 +7477,7 @@
                 </a:solidFill>
                 <a:latin typeface="DM Sans"/>
               </a:rPr>
-              <a:t>Week 6 · Learn with AI        19 / 26</a:t>
+              <a:t>Week 6 · Learn with AI        19 / 24</a:t>
             </a:r>
           </a:p>
         </p:txBody>
@@ -7727,7 +7585,7 @@
                 </a:solidFill>
                 <a:latin typeface="Fraunces"/>
               </a:rPr>
-              <a:t>What your recent builds taught us</a:t>
+              <a:t>What you’ve been building</a:t>
             </a:r>
           </a:p>
         </p:txBody>
@@ -7756,49 +7614,97 @@
           <a:p>
             <a:pPr>
               <a:spcAft>
-                <a:spcPts val="2200"/>
-              </a:spcAft>
-            </a:pPr>
-            <a:r>
-              <a:rPr sz="3000" b="0">
+                <a:spcPts val="1600"/>
+              </a:spcAft>
+            </a:pPr>
+            <a:r>
+              <a:rPr sz="2600" b="0">
                 <a:solidFill>
                   <a:srgbClr val="272A25"/>
                 </a:solidFill>
                 <a:latin typeface="DM Sans"/>
               </a:rPr>
-              <a:t>•  The AI can finish a prompt and still miss the design you intended.</a:t>
+              <a:t>•  A startup proof of concept, built in about eight hours.</a:t>
             </a:r>
           </a:p>
           <a:p>
             <a:pPr>
               <a:spcAft>
-                <a:spcPts val="2200"/>
-              </a:spcAft>
-            </a:pPr>
-            <a:r>
-              <a:rPr sz="3000" b="0">
+                <a:spcPts val="1600"/>
+              </a:spcAft>
+            </a:pPr>
+            <a:r>
+              <a:rPr sz="2600" b="0">
                 <a:solidFill>
                   <a:srgbClr val="272A25"/>
                 </a:solidFill>
                 <a:latin typeface="DM Sans"/>
               </a:rPr>
-              <a:t>•  A page can look finished while its buttons do not work.</a:t>
+              <a:t>•  A Three.js pop-up storybook, live on Vercel.</a:t>
             </a:r>
           </a:p>
           <a:p>
             <a:pPr>
               <a:spcAft>
-                <a:spcPts val="2200"/>
-              </a:spcAft>
-            </a:pPr>
-            <a:r>
-              <a:rPr sz="3000" b="0">
+                <a:spcPts val="1600"/>
+              </a:spcAft>
+            </a:pPr>
+            <a:r>
+              <a:rPr sz="2600" b="0">
                 <a:solidFill>
                   <a:srgbClr val="272A25"/>
                 </a:solidFill>
                 <a:latin typeface="DM Sans"/>
               </a:rPr>
-              <a:t>•  A local link or a repo alone is not a published website.</a:t>
+              <a:t>•  A planet-formation simulator grounded in a course textbook.</a:t>
+            </a:r>
+          </a:p>
+          <a:p>
+            <a:pPr>
+              <a:spcAft>
+                <a:spcPts val="1600"/>
+              </a:spcAft>
+            </a:pPr>
+            <a:r>
+              <a:rPr sz="2600" b="0">
+                <a:solidFill>
+                  <a:srgbClr val="272A25"/>
+                </a:solidFill>
+                <a:latin typeface="DM Sans"/>
+              </a:rPr>
+              <a:t>•  A Canvas browser extension, planned by letting the AI ask 20+ questions first.</a:t>
+            </a:r>
+          </a:p>
+          <a:p>
+            <a:pPr>
+              <a:spcAft>
+                <a:spcPts val="1600"/>
+              </a:spcAft>
+            </a:pPr>
+            <a:r>
+              <a:rPr sz="2600" b="0">
+                <a:solidFill>
+                  <a:srgbClr val="272A25"/>
+                </a:solidFill>
+                <a:latin typeface="DM Sans"/>
+              </a:rPr>
+              <a:t>•  A household assistant, with 3D-printed parts on order.</a:t>
+            </a:r>
+          </a:p>
+          <a:p>
+            <a:pPr>
+              <a:spcAft>
+                <a:spcPts val="1600"/>
+              </a:spcAft>
+            </a:pPr>
+            <a:r>
+              <a:rPr sz="2600" b="0">
+                <a:solidFill>
+                  <a:srgbClr val="272A25"/>
+                </a:solidFill>
+                <a:latin typeface="DM Sans"/>
+              </a:rPr>
+              <a:t>•  A music visualizer where one AI writes prompts for another.</a:t>
             </a:r>
           </a:p>
         </p:txBody>
@@ -7837,7 +7743,7 @@
                 </a:solidFill>
                 <a:latin typeface="DM Sans"/>
               </a:rPr>
-              <a:t>Week 6 · Why this matters        2 / 26</a:t>
+              <a:t>Week 6 · Why this matters        2 / 24</a:t>
             </a:r>
           </a:p>
         </p:txBody>
@@ -7945,7 +7851,7 @@
                 </a:solidFill>
                 <a:latin typeface="Fraunces"/>
               </a:rPr>
-              <a:t>The reading: your AI as a coach</a:t>
+              <a:t>Bring this lesson into your own AI</a:t>
             </a:r>
           </a:p>
         </p:txBody>
@@ -7984,7 +7890,7 @@
                 </a:solidFill>
                 <a:latin typeface="DM Sans"/>
               </a:rPr>
-              <a:t>•  Arielle Shipper · “How to Get Better at AI by Asking AI” · Every</a:t>
+              <a:t>•  Open cu.learnvibe.build → Everything for Week 6.</a:t>
             </a:r>
           </a:p>
           <a:p>
@@ -8000,7 +7906,7 @@
                 </a:solidFill>
                 <a:latin typeface="DM Sans"/>
               </a:rPr>
-              <a:t>•  Ask where you are on the Eight Levels of AI Adoption, with evidence from your work.</a:t>
+              <a:t>•  Click “Copy lesson as markdown”; paste it into Claude or another AI.</a:t>
             </a:r>
           </a:p>
           <a:p>
@@ -8016,7 +7922,7 @@
                 </a:solidFill>
                 <a:latin typeface="DM Sans"/>
               </a:rPr>
-              <a:t>•  Ask for one next step, then: “Teach me that and help me practise.”</a:t>
+              <a:t>•  Ask: “Teach me this and quiz me”—then ask follow-ups in your own words.</a:t>
             </a:r>
           </a:p>
         </p:txBody>
@@ -8055,7 +7961,7 @@
                 </a:solidFill>
                 <a:latin typeface="DM Sans"/>
               </a:rPr>
-              <a:t>Week 6 · Learn with AI        20 / 26</a:t>
+              <a:t>Week 6 · Use the lesson        20 / 24</a:t>
             </a:r>
           </a:p>
         </p:txBody>
@@ -8163,7 +8069,7 @@
                 </a:solidFill>
                 <a:latin typeface="Fraunces"/>
               </a:rPr>
-              <a:t>No long chat history? Bring your own evidence</a:t>
+              <a:t>After the slides: one conversation with Claude</a:t>
             </a:r>
           </a:p>
         </p:txBody>
@@ -8202,7 +8108,7 @@
                 </a:solidFill>
                 <a:latin typeface="DM Sans"/>
               </a:rPr>
-              <a:t>•  Paste your last two submissions or describe a recent project.</a:t>
+              <a:t>•  Aaron will paste the lesson and talk through it with Claude.</a:t>
             </a:r>
           </a:p>
           <a:p>
@@ -8218,7 +8124,7 @@
                 </a:solidFill>
                 <a:latin typeface="DM Sans"/>
               </a:rPr>
-              <a:t>•  Ask: “What can I do already? Show examples. What should I learn next?”</a:t>
+              <a:t>•  The conversation may lead to building a little thing.</a:t>
             </a:r>
           </a:p>
           <a:p>
@@ -8234,7 +8140,7 @@
                 </a:solidFill>
                 <a:latin typeface="DM Sans"/>
               </a:rPr>
-              <a:t>•  Treat the AI’s assessment as a suggestion; correct its assumptions.</a:t>
+              <a:t>•  Watch how questions, context and checking shape the result.</a:t>
             </a:r>
           </a:p>
         </p:txBody>
@@ -8273,7 +8179,7 @@
                 </a:solidFill>
                 <a:latin typeface="DM Sans"/>
               </a:rPr>
-              <a:t>Week 6 · Learn with AI        21 / 26</a:t>
+              <a:t>Week 6 · One live demo        21 / 24</a:t>
             </a:r>
           </a:p>
         </p:txBody>
@@ -8381,7 +8287,7 @@
                 </a:solidFill>
                 <a:latin typeface="Fraunces"/>
               </a:rPr>
-              <a:t>Bring this lesson into your own AI</a:t>
+              <a:t>Optional in-class small-group building</a:t>
             </a:r>
           </a:p>
         </p:txBody>
@@ -8420,7 +8326,7 @@
                 </a:solidFill>
                 <a:latin typeface="DM Sans"/>
               </a:rPr>
-              <a:t>•  Open cu.learnvibe.build → Everything for Week 6.</a:t>
+              <a:t>•  Choose a topic and your own approach; building/sharing is optional.</a:t>
             </a:r>
           </a:p>
           <a:p>
@@ -8436,7 +8342,7 @@
                 </a:solidFill>
                 <a:latin typeface="DM Sans"/>
               </a:rPr>
-              <a:t>•  Click “Copy lesson as markdown”; paste it into Claude or another AI.</a:t>
+              <a:t>•  Make a quiz, interactive explainer, practice tool—or an idea of your own.</a:t>
             </a:r>
           </a:p>
           <a:p>
@@ -8452,7 +8358,7 @@
                 </a:solidFill>
                 <a:latin typeface="DM Sans"/>
               </a:rPr>
-              <a:t>•  Ask: “Teach me this and quiz me”—then ask follow-ups in your own words.</a:t>
+              <a:t>•  Use your AI; try the first version yourselves; check it and revise.</a:t>
             </a:r>
           </a:p>
         </p:txBody>
@@ -8491,7 +8397,7 @@
                 </a:solidFill>
                 <a:latin typeface="DM Sans"/>
               </a:rPr>
-              <a:t>Week 6 · Use the lesson        22 / 26</a:t>
+              <a:t>Week 6 · Group work        22 / 24</a:t>
             </a:r>
           </a:p>
         </p:txBody>
@@ -8593,13 +8499,13 @@
               </a:spcAft>
             </a:pPr>
             <a:r>
-              <a:rPr sz="3200" b="1">
+              <a:rPr sz="4000" b="1">
                 <a:solidFill>
                   <a:srgbClr val="272A25"/>
                 </a:solidFill>
                 <a:latin typeface="Fraunces"/>
               </a:rPr>
-              <a:t>After the slides: one conversation with Claude</a:t>
+              <a:t>How to start—and what to share</a:t>
             </a:r>
           </a:p>
         </p:txBody>
@@ -8638,7 +8544,7 @@
                 </a:solidFill>
                 <a:latin typeface="DM Sans"/>
               </a:rPr>
-              <a:t>•  Aaron will paste the lesson and talk through it with Claude.</a:t>
+              <a:t>•  Give your AI the lesson, your learning question, or both.</a:t>
             </a:r>
           </a:p>
           <a:p>
@@ -8654,7 +8560,7 @@
                 </a:solidFill>
                 <a:latin typeface="DM Sans"/>
               </a:rPr>
-              <a:t>•  The conversation may lead to building a little thing.</a:t>
+              <a:t>•  Ask for a small first version. Test whether it actually helps you learn.</a:t>
             </a:r>
           </a:p>
           <a:p>
@@ -8670,7 +8576,7 @@
                 </a:solidFill>
                 <a:latin typeface="DM Sans"/>
               </a:rPr>
-              <a:t>•  Watch how questions, context and checking shape the result.</a:t>
+              <a:t>•  Show what you made, what you learned, and one thing you checked or changed.</a:t>
             </a:r>
           </a:p>
         </p:txBody>
@@ -8709,7 +8615,7 @@
                 </a:solidFill>
                 <a:latin typeface="DM Sans"/>
               </a:rPr>
-              <a:t>Week 6 · One live demo        23 / 26</a:t>
+              <a:t>Week 6 · Group work        23 / 24</a:t>
             </a:r>
           </a:p>
         </p:txBody>
@@ -8817,7 +8723,7 @@
                 </a:solidFill>
                 <a:latin typeface="Fraunces"/>
               </a:rPr>
-              <a:t>Optional in-class small-group building</a:t>
+              <a:t>This week: ONE PAGE about your learning</a:t>
             </a:r>
           </a:p>
         </p:txBody>
@@ -8846,49 +8752,65 @@
           <a:p>
             <a:pPr>
               <a:spcAft>
-                <a:spcPts val="2200"/>
-              </a:spcAft>
-            </a:pPr>
-            <a:r>
-              <a:rPr sz="3000" b="0">
+                <a:spcPts val="1600"/>
+              </a:spcAft>
+            </a:pPr>
+            <a:r>
+              <a:rPr sz="2600" b="0">
                 <a:solidFill>
                   <a:srgbClr val="272A25"/>
                 </a:solidFill>
                 <a:latin typeface="DM Sans"/>
               </a:rPr>
-              <a:t>•  Choose a topic and your own approach; building/sharing is optional.</a:t>
+              <a:t>•  What you’ve learned, are learning, and want to learn.</a:t>
             </a:r>
           </a:p>
           <a:p>
             <a:pPr>
               <a:spcAft>
-                <a:spcPts val="2200"/>
-              </a:spcAft>
-            </a:pPr>
-            <a:r>
-              <a:rPr sz="3000" b="0">
+                <a:spcPts val="1600"/>
+              </a:spcAft>
+            </a:pPr>
+            <a:r>
+              <a:rPr sz="2600" b="0">
                 <a:solidFill>
                   <a:srgbClr val="272A25"/>
                 </a:solidFill>
                 <a:latin typeface="DM Sans"/>
               </a:rPr>
-              <a:t>•  Make a quiz, interactive explainer, practice tool—or an idea of your own.</a:t>
+              <a:t>•  What you want to build; emerging final-project ideas.</a:t>
             </a:r>
           </a:p>
           <a:p>
             <a:pPr>
               <a:spcAft>
-                <a:spcPts val="2200"/>
-              </a:spcAft>
-            </a:pPr>
-            <a:r>
-              <a:rPr sz="3000" b="0">
+                <a:spcPts val="1600"/>
+              </a:spcAft>
+            </a:pPr>
+            <a:r>
+              <a:rPr sz="2600" b="0">
                 <a:solidFill>
                   <a:srgbClr val="272A25"/>
                 </a:solidFill>
                 <a:latin typeface="DM Sans"/>
               </a:rPr>
-              <a:t>•  Use your AI; try the first version yourselves; check it and revise.</a:t>
+              <a:t>•  Building/sharing is welcome but OPTIONAL—not required.</a:t>
+            </a:r>
+          </a:p>
+          <a:p>
+            <a:pPr>
+              <a:spcAft>
+                <a:spcPts val="1600"/>
+              </a:spcAft>
+            </a:pPr>
+            <a:r>
+              <a:rPr sz="2600" b="0">
+                <a:solidFill>
+                  <a:srgbClr val="272A25"/>
+                </a:solidFill>
+                <a:latin typeface="DM Sans"/>
+              </a:rPr>
+              <a:t>•  Your reflections will shape consistent peer pods for at least three weeks.</a:t>
             </a:r>
           </a:p>
         </p:txBody>
@@ -8927,459 +8849,7 @@
                 </a:solidFill>
                 <a:latin typeface="DM Sans"/>
               </a:rPr>
-              <a:t>Week 6 · Group work        24 / 26</a:t>
-            </a:r>
-          </a:p>
-        </p:txBody>
-      </p:sp>
-    </p:spTree>
-  </p:cSld>
-  <p:clrMapOvr>
-    <a:masterClrMapping/>
-  </p:clrMapOvr>
-</p:sld>
-</file>
-
-<file path=ppt/slides/slide25.xml><?xml version="1.0" encoding="utf-8"?>
-<p:sld xmlns:a="http://schemas.openxmlformats.org/drawingml/2006/main" xmlns:p="http://schemas.openxmlformats.org/presentationml/2006/main" xmlns:r="http://schemas.openxmlformats.org/officeDocument/2006/relationships">
-  <p:cSld>
-    <p:bg>
-      <p:bgPr>
-        <a:solidFill>
-          <a:srgbClr val="F7F5EE"/>
-        </a:solidFill>
-        <a:effectLst/>
-      </p:bgPr>
-    </p:bg>
-    <p:spTree>
-      <p:nvGrpSpPr>
-        <p:cNvPr id="1" name=""/>
-        <p:cNvGrpSpPr/>
-        <p:nvPr/>
-      </p:nvGrpSpPr>
-      <p:grpSpPr/>
-      <p:sp>
-        <p:nvSpPr>
-          <p:cNvPr id="2" name="Rectangle 1"/>
-          <p:cNvSpPr/>
-          <p:nvPr/>
-        </p:nvSpPr>
-        <p:spPr>
-          <a:xfrm>
-            <a:off x="0" y="0"/>
-            <a:ext cx="228600" cy="6858000"/>
-          </a:xfrm>
-          <a:prstGeom prst="rect">
-            <a:avLst/>
-          </a:prstGeom>
-          <a:solidFill>
-            <a:srgbClr val="A83D2B"/>
-          </a:solidFill>
-          <a:ln>
-            <a:noFill/>
-          </a:ln>
-        </p:spPr>
-        <p:style>
-          <a:lnRef idx="1">
-            <a:schemeClr val="accent1"/>
-          </a:lnRef>
-          <a:fillRef idx="3">
-            <a:schemeClr val="accent1"/>
-          </a:fillRef>
-          <a:effectRef idx="2">
-            <a:schemeClr val="accent1"/>
-          </a:effectRef>
-          <a:fontRef idx="minor">
-            <a:schemeClr val="lt1"/>
-          </a:fontRef>
-        </p:style>
-        <p:txBody>
-          <a:bodyPr rtlCol="0" anchor="ctr"/>
-          <a:lstStyle/>
-          <a:p>
-            <a:pPr algn="ctr"/>
-          </a:p>
-        </p:txBody>
-      </p:sp>
-      <p:sp>
-        <p:nvSpPr>
-          <p:cNvPr id="3" name="TextBox 2"/>
-          <p:cNvSpPr txBox="1"/>
-          <p:nvPr/>
-        </p:nvSpPr>
-        <p:spPr>
-          <a:xfrm>
-            <a:off x="822960" y="548640"/>
-            <a:ext cx="10607040" cy="1188720"/>
-          </a:xfrm>
-          <a:prstGeom prst="rect">
-            <a:avLst/>
-          </a:prstGeom>
-          <a:noFill/>
-        </p:spPr>
-        <p:txBody>
-          <a:bodyPr wrap="square">
-            <a:spAutoFit/>
-          </a:bodyPr>
-          <a:lstStyle/>
-          <a:p>
-            <a:pPr>
-              <a:spcAft>
-                <a:spcPts val="1400"/>
-              </a:spcAft>
-            </a:pPr>
-            <a:r>
-              <a:rPr sz="4000" b="1">
-                <a:solidFill>
-                  <a:srgbClr val="272A25"/>
-                </a:solidFill>
-                <a:latin typeface="Fraunces"/>
-              </a:rPr>
-              <a:t>How to start—and what to share</a:t>
-            </a:r>
-          </a:p>
-        </p:txBody>
-      </p:sp>
-      <p:sp>
-        <p:nvSpPr>
-          <p:cNvPr id="4" name="TextBox 3"/>
-          <p:cNvSpPr txBox="1"/>
-          <p:nvPr/>
-        </p:nvSpPr>
-        <p:spPr>
-          <a:xfrm>
-            <a:off x="822960" y="2011680"/>
-            <a:ext cx="10607040" cy="4206240"/>
-          </a:xfrm>
-          <a:prstGeom prst="rect">
-            <a:avLst/>
-          </a:prstGeom>
-          <a:noFill/>
-        </p:spPr>
-        <p:txBody>
-          <a:bodyPr wrap="square">
-            <a:spAutoFit/>
-          </a:bodyPr>
-          <a:lstStyle/>
-          <a:p>
-            <a:pPr>
-              <a:spcAft>
-                <a:spcPts val="2200"/>
-              </a:spcAft>
-            </a:pPr>
-            <a:r>
-              <a:rPr sz="3000" b="0">
-                <a:solidFill>
-                  <a:srgbClr val="272A25"/>
-                </a:solidFill>
-                <a:latin typeface="DM Sans"/>
-              </a:rPr>
-              <a:t>•  Give your AI the lesson, your learning question, or both.</a:t>
-            </a:r>
-          </a:p>
-          <a:p>
-            <a:pPr>
-              <a:spcAft>
-                <a:spcPts val="2200"/>
-              </a:spcAft>
-            </a:pPr>
-            <a:r>
-              <a:rPr sz="3000" b="0">
-                <a:solidFill>
-                  <a:srgbClr val="272A25"/>
-                </a:solidFill>
-                <a:latin typeface="DM Sans"/>
-              </a:rPr>
-              <a:t>•  Ask for a small first version. Test whether it actually helps you learn.</a:t>
-            </a:r>
-          </a:p>
-          <a:p>
-            <a:pPr>
-              <a:spcAft>
-                <a:spcPts val="2200"/>
-              </a:spcAft>
-            </a:pPr>
-            <a:r>
-              <a:rPr sz="3000" b="0">
-                <a:solidFill>
-                  <a:srgbClr val="272A25"/>
-                </a:solidFill>
-                <a:latin typeface="DM Sans"/>
-              </a:rPr>
-              <a:t>•  Show what you made, what you learned, and one thing you checked or changed.</a:t>
-            </a:r>
-          </a:p>
-        </p:txBody>
-      </p:sp>
-      <p:sp>
-        <p:nvSpPr>
-          <p:cNvPr id="5" name="TextBox 4"/>
-          <p:cNvSpPr txBox="1"/>
-          <p:nvPr/>
-        </p:nvSpPr>
-        <p:spPr>
-          <a:xfrm>
-            <a:off x="822960" y="6263640"/>
-            <a:ext cx="10607040" cy="365760"/>
-          </a:xfrm>
-          <a:prstGeom prst="rect">
-            <a:avLst/>
-          </a:prstGeom>
-          <a:noFill/>
-        </p:spPr>
-        <p:txBody>
-          <a:bodyPr wrap="square">
-            <a:spAutoFit/>
-          </a:bodyPr>
-          <a:lstStyle/>
-          <a:p>
-            <a:pPr algn="r">
-              <a:spcAft>
-                <a:spcPts val="1400"/>
-              </a:spcAft>
-            </a:pPr>
-            <a:r>
-              <a:rPr sz="1600" b="0">
-                <a:solidFill>
-                  <a:srgbClr val="64665D"/>
-                </a:solidFill>
-                <a:latin typeface="DM Sans"/>
-              </a:rPr>
-              <a:t>Week 6 · Group work        25 / 26</a:t>
-            </a:r>
-          </a:p>
-        </p:txBody>
-      </p:sp>
-    </p:spTree>
-  </p:cSld>
-  <p:clrMapOvr>
-    <a:masterClrMapping/>
-  </p:clrMapOvr>
-</p:sld>
-</file>
-
-<file path=ppt/slides/slide26.xml><?xml version="1.0" encoding="utf-8"?>
-<p:sld xmlns:a="http://schemas.openxmlformats.org/drawingml/2006/main" xmlns:p="http://schemas.openxmlformats.org/presentationml/2006/main" xmlns:r="http://schemas.openxmlformats.org/officeDocument/2006/relationships">
-  <p:cSld>
-    <p:bg>
-      <p:bgPr>
-        <a:solidFill>
-          <a:srgbClr val="F7F5EE"/>
-        </a:solidFill>
-        <a:effectLst/>
-      </p:bgPr>
-    </p:bg>
-    <p:spTree>
-      <p:nvGrpSpPr>
-        <p:cNvPr id="1" name=""/>
-        <p:cNvGrpSpPr/>
-        <p:nvPr/>
-      </p:nvGrpSpPr>
-      <p:grpSpPr/>
-      <p:sp>
-        <p:nvSpPr>
-          <p:cNvPr id="2" name="Rectangle 1"/>
-          <p:cNvSpPr/>
-          <p:nvPr/>
-        </p:nvSpPr>
-        <p:spPr>
-          <a:xfrm>
-            <a:off x="0" y="0"/>
-            <a:ext cx="228600" cy="6858000"/>
-          </a:xfrm>
-          <a:prstGeom prst="rect">
-            <a:avLst/>
-          </a:prstGeom>
-          <a:solidFill>
-            <a:srgbClr val="A83D2B"/>
-          </a:solidFill>
-          <a:ln>
-            <a:noFill/>
-          </a:ln>
-        </p:spPr>
-        <p:style>
-          <a:lnRef idx="1">
-            <a:schemeClr val="accent1"/>
-          </a:lnRef>
-          <a:fillRef idx="3">
-            <a:schemeClr val="accent1"/>
-          </a:fillRef>
-          <a:effectRef idx="2">
-            <a:schemeClr val="accent1"/>
-          </a:effectRef>
-          <a:fontRef idx="minor">
-            <a:schemeClr val="lt1"/>
-          </a:fontRef>
-        </p:style>
-        <p:txBody>
-          <a:bodyPr rtlCol="0" anchor="ctr"/>
-          <a:lstStyle/>
-          <a:p>
-            <a:pPr algn="ctr"/>
-          </a:p>
-        </p:txBody>
-      </p:sp>
-      <p:sp>
-        <p:nvSpPr>
-          <p:cNvPr id="3" name="TextBox 2"/>
-          <p:cNvSpPr txBox="1"/>
-          <p:nvPr/>
-        </p:nvSpPr>
-        <p:spPr>
-          <a:xfrm>
-            <a:off x="822960" y="548640"/>
-            <a:ext cx="10607040" cy="1188720"/>
-          </a:xfrm>
-          <a:prstGeom prst="rect">
-            <a:avLst/>
-          </a:prstGeom>
-          <a:noFill/>
-        </p:spPr>
-        <p:txBody>
-          <a:bodyPr wrap="square">
-            <a:spAutoFit/>
-          </a:bodyPr>
-          <a:lstStyle/>
-          <a:p>
-            <a:pPr>
-              <a:spcAft>
-                <a:spcPts val="1400"/>
-              </a:spcAft>
-            </a:pPr>
-            <a:r>
-              <a:rPr sz="4000" b="1">
-                <a:solidFill>
-                  <a:srgbClr val="272A25"/>
-                </a:solidFill>
-                <a:latin typeface="Fraunces"/>
-              </a:rPr>
-              <a:t>This week: ONE PAGE about your learning</a:t>
-            </a:r>
-          </a:p>
-        </p:txBody>
-      </p:sp>
-      <p:sp>
-        <p:nvSpPr>
-          <p:cNvPr id="4" name="TextBox 3"/>
-          <p:cNvSpPr txBox="1"/>
-          <p:nvPr/>
-        </p:nvSpPr>
-        <p:spPr>
-          <a:xfrm>
-            <a:off x="822960" y="2011680"/>
-            <a:ext cx="10607040" cy="4206240"/>
-          </a:xfrm>
-          <a:prstGeom prst="rect">
-            <a:avLst/>
-          </a:prstGeom>
-          <a:noFill/>
-        </p:spPr>
-        <p:txBody>
-          <a:bodyPr wrap="square">
-            <a:spAutoFit/>
-          </a:bodyPr>
-          <a:lstStyle/>
-          <a:p>
-            <a:pPr>
-              <a:spcAft>
-                <a:spcPts val="1600"/>
-              </a:spcAft>
-            </a:pPr>
-            <a:r>
-              <a:rPr sz="2600" b="0">
-                <a:solidFill>
-                  <a:srgbClr val="272A25"/>
-                </a:solidFill>
-                <a:latin typeface="DM Sans"/>
-              </a:rPr>
-              <a:t>•  What you’ve learned, are learning, and want to learn.</a:t>
-            </a:r>
-          </a:p>
-          <a:p>
-            <a:pPr>
-              <a:spcAft>
-                <a:spcPts val="1600"/>
-              </a:spcAft>
-            </a:pPr>
-            <a:r>
-              <a:rPr sz="2600" b="0">
-                <a:solidFill>
-                  <a:srgbClr val="272A25"/>
-                </a:solidFill>
-                <a:latin typeface="DM Sans"/>
-              </a:rPr>
-              <a:t>•  What you want to build; emerging final-project ideas.</a:t>
-            </a:r>
-          </a:p>
-          <a:p>
-            <a:pPr>
-              <a:spcAft>
-                <a:spcPts val="1600"/>
-              </a:spcAft>
-            </a:pPr>
-            <a:r>
-              <a:rPr sz="2600" b="0">
-                <a:solidFill>
-                  <a:srgbClr val="272A25"/>
-                </a:solidFill>
-                <a:latin typeface="DM Sans"/>
-              </a:rPr>
-              <a:t>•  Building/sharing is welcome but OPTIONAL—not required.</a:t>
-            </a:r>
-          </a:p>
-          <a:p>
-            <a:pPr>
-              <a:spcAft>
-                <a:spcPts val="1600"/>
-              </a:spcAft>
-            </a:pPr>
-            <a:r>
-              <a:rPr sz="2600" b="0">
-                <a:solidFill>
-                  <a:srgbClr val="272A25"/>
-                </a:solidFill>
-                <a:latin typeface="DM Sans"/>
-              </a:rPr>
-              <a:t>•  Your reflections will shape consistent peer pods for at least three weeks.</a:t>
-            </a:r>
-          </a:p>
-        </p:txBody>
-      </p:sp>
-      <p:sp>
-        <p:nvSpPr>
-          <p:cNvPr id="5" name="TextBox 4"/>
-          <p:cNvSpPr txBox="1"/>
-          <p:nvPr/>
-        </p:nvSpPr>
-        <p:spPr>
-          <a:xfrm>
-            <a:off x="822960" y="6263640"/>
-            <a:ext cx="10607040" cy="365760"/>
-          </a:xfrm>
-          <a:prstGeom prst="rect">
-            <a:avLst/>
-          </a:prstGeom>
-          <a:noFill/>
-        </p:spPr>
-        <p:txBody>
-          <a:bodyPr wrap="square">
-            <a:spAutoFit/>
-          </a:bodyPr>
-          <a:lstStyle/>
-          <a:p>
-            <a:pPr algn="r">
-              <a:spcAft>
-                <a:spcPts val="1400"/>
-              </a:spcAft>
-            </a:pPr>
-            <a:r>
-              <a:rPr sz="1600" b="0">
-                <a:solidFill>
-                  <a:srgbClr val="64665D"/>
-                </a:solidFill>
-                <a:latin typeface="DM Sans"/>
-              </a:rPr>
-              <a:t>Week 6 · Weekly assignment        26 / 26</a:t>
+              <a:t>Week 6 · Weekly assignment        24 / 24</a:t>
             </a:r>
           </a:p>
         </p:txBody>
@@ -9487,7 +8957,7 @@
                 </a:solidFill>
                 <a:latin typeface="Fraunces"/>
               </a:rPr>
-              <a:t>Markdown: readable, portable text</a:t>
+              <a:t>What you’ve been running into</a:t>
             </a:r>
           </a:p>
         </p:txBody>
@@ -9516,49 +8986,81 @@
           <a:p>
             <a:pPr>
               <a:spcAft>
-                <a:spcPts val="2200"/>
-              </a:spcAft>
-            </a:pPr>
-            <a:r>
-              <a:rPr sz="3000" b="0">
+                <a:spcPts val="1600"/>
+              </a:spcAft>
+            </a:pPr>
+            <a:r>
+              <a:rPr sz="2600" b="0">
                 <a:solidFill>
                   <a:srgbClr val="272A25"/>
                 </a:solidFill>
                 <a:latin typeface="DM Sans"/>
               </a:rPr>
-              <a:t>•  A .md file is a plain-text file—not a special app or database.</a:t>
+              <a:t>•  Getting the AI to build what you actually pictured.</a:t>
             </a:r>
           </a:p>
           <a:p>
             <a:pPr>
               <a:spcAft>
-                <a:spcPts val="2200"/>
-              </a:spcAft>
-            </a:pPr>
-            <a:r>
-              <a:rPr sz="3000" b="0">
+                <a:spcPts val="1600"/>
+              </a:spcAft>
+            </a:pPr>
+            <a:r>
+              <a:rPr sz="2600" b="0">
                 <a:solidFill>
                   <a:srgbClr val="272A25"/>
                 </a:solidFill>
                 <a:latin typeface="DM Sans"/>
               </a:rPr>
-              <a:t>•  A little punctuation adds structure: headings, lists, links, code.</a:t>
+              <a:t>•  Links that work for you but not for anyone else.</a:t>
             </a:r>
           </a:p>
           <a:p>
             <a:pPr>
               <a:spcAft>
-                <a:spcPts val="2200"/>
-              </a:spcAft>
-            </a:pPr>
-            <a:r>
-              <a:rPr sz="3000" b="0">
+                <a:spcPts val="1600"/>
+              </a:spcAft>
+            </a:pPr>
+            <a:r>
+              <a:rPr sz="2600" b="0">
                 <a:solidFill>
                   <a:srgbClr val="272A25"/>
                 </a:solidFill>
                 <a:latin typeface="DM Sans"/>
               </a:rPr>
-              <a:t>•  Read it in an editor, render it as a page, or paste it into your AI.</a:t>
+              <a:t>•  Running out of free credits mid-build.</a:t>
+            </a:r>
+          </a:p>
+          <a:p>
+            <a:pPr>
+              <a:spcAft>
+                <a:spcPts val="1600"/>
+              </a:spcAft>
+            </a:pPr>
+            <a:r>
+              <a:rPr sz="2600" b="0">
+                <a:solidFill>
+                  <a:srgbClr val="272A25"/>
+                </a:solidFill>
+                <a:latin typeface="DM Sans"/>
+              </a:rPr>
+              <a:t>•  Very different starting points—and that is fine.</a:t>
+            </a:r>
+          </a:p>
+          <a:p>
+            <a:pPr>
+              <a:spcAft>
+                <a:spcPts val="1600"/>
+              </a:spcAft>
+            </a:pPr>
+            <a:r>
+              <a:rPr sz="2600" b="0">
+                <a:solidFill>
+                  <a:srgbClr val="272A25"/>
+                </a:solidFill>
+                <a:latin typeface="DM Sans"/>
+              </a:rPr>
+              <a:t>•  Tonight: the foundations behind each of these.</a:t>
             </a:r>
           </a:p>
         </p:txBody>
@@ -9597,7 +9099,7 @@
                 </a:solidFill>
                 <a:latin typeface="DM Sans"/>
               </a:rPr>
-              <a:t>Week 6 · Markdown        3 / 26</a:t>
+              <a:t>Week 6 · Where we are        3 / 24</a:t>
             </a:r>
           </a:p>
         </p:txBody>
@@ -9705,64 +9207,21 @@
                 </a:solidFill>
                 <a:latin typeface="Fraunces"/>
               </a:rPr>
-              <a:t>Markdown you can read and write</a:t>
-            </a:r>
-          </a:p>
-        </p:txBody>
-      </p:sp>
-      <p:sp>
-        <p:nvSpPr>
-          <p:cNvPr id="4" name="Rectangle 3"/>
-          <p:cNvSpPr/>
-          <p:nvPr/>
-        </p:nvSpPr>
-        <p:spPr>
-          <a:xfrm>
-            <a:off x="822960" y="1828800"/>
-            <a:ext cx="6583680" cy="4023360"/>
-          </a:xfrm>
-          <a:prstGeom prst="rect">
-            <a:avLst/>
-          </a:prstGeom>
-          <a:solidFill>
-            <a:srgbClr val="EEECE2"/>
-          </a:solidFill>
-          <a:ln>
-            <a:noFill/>
-          </a:ln>
-        </p:spPr>
-        <p:style>
-          <a:lnRef idx="1">
-            <a:schemeClr val="accent1"/>
-          </a:lnRef>
-          <a:fillRef idx="3">
-            <a:schemeClr val="accent1"/>
-          </a:fillRef>
-          <a:effectRef idx="2">
-            <a:schemeClr val="accent1"/>
-          </a:effectRef>
-          <a:fontRef idx="minor">
-            <a:schemeClr val="lt1"/>
-          </a:fontRef>
-        </p:style>
-        <p:txBody>
-          <a:bodyPr rtlCol="0" anchor="ctr"/>
-          <a:lstStyle/>
-          <a:p>
-            <a:pPr algn="ctr"/>
-          </a:p>
-        </p:txBody>
-      </p:sp>
-      <p:sp>
-        <p:nvSpPr>
-          <p:cNvPr id="5" name="TextBox 4"/>
+              <a:t>Markdown: readable, portable text</a:t>
+            </a:r>
+          </a:p>
+        </p:txBody>
+      </p:sp>
+      <p:sp>
+        <p:nvSpPr>
+          <p:cNvPr id="4" name="TextBox 3"/>
           <p:cNvSpPr txBox="1"/>
           <p:nvPr/>
         </p:nvSpPr>
         <p:spPr>
           <a:xfrm>
-            <a:off x="1097280" y="2011680"/>
-            <a:ext cx="6217920" cy="3749039"/>
+            <a:off x="822960" y="2011680"/>
+            <a:ext cx="10607040" cy="4206240"/>
           </a:xfrm>
           <a:prstGeom prst="rect">
             <a:avLst/>
@@ -9777,95 +9236,63 @@
           <a:p>
             <a:pPr>
               <a:spcAft>
-                <a:spcPts val="200"/>
-              </a:spcAft>
-            </a:pPr>
-            <a:r>
-              <a:rPr sz="1800" b="0">
+                <a:spcPts val="2200"/>
+              </a:spcAft>
+            </a:pPr>
+            <a:r>
+              <a:rPr sz="3000" b="0">
                 <a:solidFill>
                   <a:srgbClr val="272A25"/>
                 </a:solidFill>
-                <a:latin typeface="DejaVu Sans Mono"/>
-              </a:rPr>
-              <a:t># Project notes</a:t>
+                <a:latin typeface="DM Sans"/>
+              </a:rPr>
+              <a:t>•  A .md file is a plain-text file—not a special app or database.</a:t>
             </a:r>
           </a:p>
           <a:p>
             <a:pPr>
               <a:spcAft>
-                <a:spcPts val="200"/>
-              </a:spcAft>
-            </a:pPr>
-            <a:r>
-              <a:rPr sz="1800" b="0">
+                <a:spcPts val="2200"/>
+              </a:spcAft>
+            </a:pPr>
+            <a:r>
+              <a:rPr sz="3000" b="0">
                 <a:solidFill>
                   <a:srgbClr val="272A25"/>
                 </a:solidFill>
-                <a:latin typeface="DejaVu Sans Mono"/>
-              </a:rPr>
-              <a:t>## What I want to learn</a:t>
+                <a:latin typeface="DM Sans"/>
+              </a:rPr>
+              <a:t>•  A little punctuation adds structure: headings, lists, links, code.</a:t>
             </a:r>
           </a:p>
           <a:p>
             <a:pPr>
               <a:spcAft>
-                <a:spcPts val="200"/>
-              </a:spcAft>
-            </a:pPr>
-            <a:r>
-              <a:rPr sz="1800" b="0">
+                <a:spcPts val="2200"/>
+              </a:spcAft>
+            </a:pPr>
+            <a:r>
+              <a:rPr sz="3000" b="0">
                 <a:solidFill>
                   <a:srgbClr val="272A25"/>
                 </a:solidFill>
-                <a:latin typeface="DejaVu Sans Mono"/>
-              </a:rPr>
-              <a:t>- Explain commits before changing files.</a:t>
-            </a:r>
-          </a:p>
-          <a:p>
-            <a:pPr>
-              <a:spcAft>
-                <a:spcPts val="200"/>
-              </a:spcAft>
-            </a:pPr>
-            <a:r>
-              <a:rPr sz="1800" b="0">
-                <a:solidFill>
-                  <a:srgbClr val="272A25"/>
-                </a:solidFill>
-                <a:latin typeface="DejaVu Sans Mono"/>
-              </a:rPr>
-              <a:t>[Course lesson](https://cu.learnvibe.build/lessons/week-6/)</a:t>
-            </a:r>
-          </a:p>
-          <a:p>
-            <a:pPr>
-              <a:spcAft>
-                <a:spcPts val="200"/>
-              </a:spcAft>
-            </a:pPr>
-            <a:r>
-              <a:rPr sz="1800" b="0">
-                <a:solidFill>
-                  <a:srgbClr val="272A25"/>
-                </a:solidFill>
-                <a:latin typeface="DejaVu Sans Mono"/>
-              </a:rPr>
-              <a:t>Use `git status` to see what changed.</a:t>
-            </a:r>
-          </a:p>
-        </p:txBody>
-      </p:sp>
-      <p:sp>
-        <p:nvSpPr>
-          <p:cNvPr id="6" name="TextBox 5"/>
+                <a:latin typeface="DM Sans"/>
+              </a:rPr>
+              <a:t>•  Read it in an editor, render it as a page, or paste it into your AI.</a:t>
+            </a:r>
+          </a:p>
+        </p:txBody>
+      </p:sp>
+      <p:sp>
+        <p:nvSpPr>
+          <p:cNvPr id="5" name="TextBox 4"/>
           <p:cNvSpPr txBox="1"/>
           <p:nvPr/>
         </p:nvSpPr>
         <p:spPr>
           <a:xfrm>
-            <a:off x="7772400" y="3108960"/>
-            <a:ext cx="3931920" cy="1828800"/>
+            <a:off x="822960" y="6263640"/>
+            <a:ext cx="10607040" cy="365760"/>
           </a:xfrm>
           <a:prstGeom prst="rect">
             <a:avLst/>
@@ -9878,58 +9305,19 @@
           </a:bodyPr>
           <a:lstStyle/>
           <a:p>
-            <a:pPr>
+            <a:pPr algn="r">
               <a:spcAft>
                 <a:spcPts val="1400"/>
               </a:spcAft>
             </a:pPr>
             <a:r>
-              <a:rPr sz="2800" b="0">
+              <a:rPr sz="1600" b="0">
                 <a:solidFill>
                   <a:srgbClr val="64665D"/>
                 </a:solidFill>
                 <a:latin typeface="DM Sans"/>
               </a:rPr>
-              <a:t>Headings, lists, links, and code—with plain text underneath.</a:t>
-            </a:r>
-          </a:p>
-        </p:txBody>
-      </p:sp>
-      <p:sp>
-        <p:nvSpPr>
-          <p:cNvPr id="7" name="TextBox 6"/>
-          <p:cNvSpPr txBox="1"/>
-          <p:nvPr/>
-        </p:nvSpPr>
-        <p:spPr>
-          <a:xfrm>
-            <a:off x="822960" y="6263640"/>
-            <a:ext cx="10607040" cy="365760"/>
-          </a:xfrm>
-          <a:prstGeom prst="rect">
-            <a:avLst/>
-          </a:prstGeom>
-          <a:noFill/>
-        </p:spPr>
-        <p:txBody>
-          <a:bodyPr wrap="square">
-            <a:spAutoFit/>
-          </a:bodyPr>
-          <a:lstStyle/>
-          <a:p>
-            <a:pPr algn="r">
-              <a:spcAft>
-                <a:spcPts val="1400"/>
-              </a:spcAft>
-            </a:pPr>
-            <a:r>
-              <a:rPr sz="1600" b="0">
-                <a:solidFill>
-                  <a:srgbClr val="64665D"/>
-                </a:solidFill>
-                <a:latin typeface="DM Sans"/>
-              </a:rPr>
-              <a:t>Week 6 · Markdown        4 / 26</a:t>
+              <a:t>Week 6 · Markdown        4 / 24</a:t>
             </a:r>
           </a:p>
         </p:txBody>
@@ -10037,21 +9425,64 @@
                 </a:solidFill>
                 <a:latin typeface="Fraunces"/>
               </a:rPr>
-              <a:t>Context: what the AI can actually see</a:t>
-            </a:r>
-          </a:p>
-        </p:txBody>
-      </p:sp>
-      <p:sp>
-        <p:nvSpPr>
-          <p:cNvPr id="4" name="TextBox 3"/>
+              <a:t>Markdown you can read and write</a:t>
+            </a:r>
+          </a:p>
+        </p:txBody>
+      </p:sp>
+      <p:sp>
+        <p:nvSpPr>
+          <p:cNvPr id="4" name="Rectangle 3"/>
+          <p:cNvSpPr/>
+          <p:nvPr/>
+        </p:nvSpPr>
+        <p:spPr>
+          <a:xfrm>
+            <a:off x="822960" y="1828800"/>
+            <a:ext cx="6583680" cy="4023360"/>
+          </a:xfrm>
+          <a:prstGeom prst="rect">
+            <a:avLst/>
+          </a:prstGeom>
+          <a:solidFill>
+            <a:srgbClr val="EEECE2"/>
+          </a:solidFill>
+          <a:ln>
+            <a:noFill/>
+          </a:ln>
+        </p:spPr>
+        <p:style>
+          <a:lnRef idx="1">
+            <a:schemeClr val="accent1"/>
+          </a:lnRef>
+          <a:fillRef idx="3">
+            <a:schemeClr val="accent1"/>
+          </a:fillRef>
+          <a:effectRef idx="2">
+            <a:schemeClr val="accent1"/>
+          </a:effectRef>
+          <a:fontRef idx="minor">
+            <a:schemeClr val="lt1"/>
+          </a:fontRef>
+        </p:style>
+        <p:txBody>
+          <a:bodyPr rtlCol="0" anchor="ctr"/>
+          <a:lstStyle/>
+          <a:p>
+            <a:pPr algn="ctr"/>
+          </a:p>
+        </p:txBody>
+      </p:sp>
+      <p:sp>
+        <p:nvSpPr>
+          <p:cNvPr id="5" name="TextBox 4"/>
           <p:cNvSpPr txBox="1"/>
           <p:nvPr/>
         </p:nvSpPr>
         <p:spPr>
           <a:xfrm>
-            <a:off x="822960" y="2011680"/>
-            <a:ext cx="10607040" cy="4206240"/>
+            <a:off x="1097280" y="2011680"/>
+            <a:ext cx="6217920" cy="3749039"/>
           </a:xfrm>
           <a:prstGeom prst="rect">
             <a:avLst/>
@@ -10066,63 +9497,95 @@
           <a:p>
             <a:pPr>
               <a:spcAft>
-                <a:spcPts val="2200"/>
-              </a:spcAft>
-            </a:pPr>
-            <a:r>
-              <a:rPr sz="3000" b="0">
+                <a:spcPts val="200"/>
+              </a:spcAft>
+            </a:pPr>
+            <a:r>
+              <a:rPr sz="1800" b="0">
                 <a:solidFill>
                   <a:srgbClr val="272A25"/>
                 </a:solidFill>
-                <a:latin typeface="DM Sans"/>
-              </a:rPr>
-              <a:t>•  Its answer depends on the messages, files and tool results available now.</a:t>
+                <a:latin typeface="DejaVu Sans Mono"/>
+              </a:rPr>
+              <a:t># Project notes</a:t>
             </a:r>
           </a:p>
           <a:p>
             <a:pPr>
               <a:spcAft>
-                <a:spcPts val="2200"/>
-              </a:spcAft>
-            </a:pPr>
-            <a:r>
-              <a:rPr sz="3000" b="0">
+                <a:spcPts val="200"/>
+              </a:spcAft>
+            </a:pPr>
+            <a:r>
+              <a:rPr sz="1800" b="0">
                 <a:solidFill>
                   <a:srgbClr val="272A25"/>
                 </a:solidFill>
-                <a:latin typeface="DM Sans"/>
-              </a:rPr>
-              <a:t>•  It does not automatically know your audience, preferences or project history.</a:t>
+                <a:latin typeface="DejaVu Sans Mono"/>
+              </a:rPr>
+              <a:t>## What I want to learn</a:t>
             </a:r>
           </a:p>
           <a:p>
             <a:pPr>
               <a:spcAft>
-                <a:spcPts val="2200"/>
-              </a:spcAft>
-            </a:pPr>
-            <a:r>
-              <a:rPr sz="3000" b="0">
+                <a:spcPts val="200"/>
+              </a:spcAft>
+            </a:pPr>
+            <a:r>
+              <a:rPr sz="1800" b="0">
                 <a:solidFill>
                   <a:srgbClr val="272A25"/>
                 </a:solidFill>
-                <a:latin typeface="DM Sans"/>
-              </a:rPr>
-              <a:t>•  “Improve my site” is weaker than a clear audience, goal and example.</a:t>
-            </a:r>
-          </a:p>
-        </p:txBody>
-      </p:sp>
-      <p:sp>
-        <p:nvSpPr>
-          <p:cNvPr id="5" name="TextBox 4"/>
+                <a:latin typeface="DejaVu Sans Mono"/>
+              </a:rPr>
+              <a:t>- Explain commits before changing files.</a:t>
+            </a:r>
+          </a:p>
+          <a:p>
+            <a:pPr>
+              <a:spcAft>
+                <a:spcPts val="200"/>
+              </a:spcAft>
+            </a:pPr>
+            <a:r>
+              <a:rPr sz="1800" b="0">
+                <a:solidFill>
+                  <a:srgbClr val="272A25"/>
+                </a:solidFill>
+                <a:latin typeface="DejaVu Sans Mono"/>
+              </a:rPr>
+              <a:t>[Course lesson](https://cu.learnvibe.build/lessons/week-6/)</a:t>
+            </a:r>
+          </a:p>
+          <a:p>
+            <a:pPr>
+              <a:spcAft>
+                <a:spcPts val="200"/>
+              </a:spcAft>
+            </a:pPr>
+            <a:r>
+              <a:rPr sz="1800" b="0">
+                <a:solidFill>
+                  <a:srgbClr val="272A25"/>
+                </a:solidFill>
+                <a:latin typeface="DejaVu Sans Mono"/>
+              </a:rPr>
+              <a:t>Use `git status` to see what changed.</a:t>
+            </a:r>
+          </a:p>
+        </p:txBody>
+      </p:sp>
+      <p:sp>
+        <p:nvSpPr>
+          <p:cNvPr id="6" name="TextBox 5"/>
           <p:cNvSpPr txBox="1"/>
           <p:nvPr/>
         </p:nvSpPr>
         <p:spPr>
           <a:xfrm>
-            <a:off x="822960" y="6263640"/>
-            <a:ext cx="10607040" cy="365760"/>
+            <a:off x="7772400" y="3108960"/>
+            <a:ext cx="3931920" cy="1828800"/>
           </a:xfrm>
           <a:prstGeom prst="rect">
             <a:avLst/>
@@ -10135,6 +9598,45 @@
           </a:bodyPr>
           <a:lstStyle/>
           <a:p>
+            <a:pPr>
+              <a:spcAft>
+                <a:spcPts val="1400"/>
+              </a:spcAft>
+            </a:pPr>
+            <a:r>
+              <a:rPr sz="2800" b="0">
+                <a:solidFill>
+                  <a:srgbClr val="64665D"/>
+                </a:solidFill>
+                <a:latin typeface="DM Sans"/>
+              </a:rPr>
+              <a:t>Headings, lists, links, and code—with plain text underneath.</a:t>
+            </a:r>
+          </a:p>
+        </p:txBody>
+      </p:sp>
+      <p:sp>
+        <p:nvSpPr>
+          <p:cNvPr id="7" name="TextBox 6"/>
+          <p:cNvSpPr txBox="1"/>
+          <p:nvPr/>
+        </p:nvSpPr>
+        <p:spPr>
+          <a:xfrm>
+            <a:off x="822960" y="6263640"/>
+            <a:ext cx="10607040" cy="365760"/>
+          </a:xfrm>
+          <a:prstGeom prst="rect">
+            <a:avLst/>
+          </a:prstGeom>
+          <a:noFill/>
+        </p:spPr>
+        <p:txBody>
+          <a:bodyPr wrap="square">
+            <a:spAutoFit/>
+          </a:bodyPr>
+          <a:lstStyle/>
+          <a:p>
             <a:pPr algn="r">
               <a:spcAft>
                 <a:spcPts val="1400"/>
@@ -10147,7 +9649,7 @@
                 </a:solidFill>
                 <a:latin typeface="DM Sans"/>
               </a:rPr>
-              <a:t>Week 6 · Ongoing context        5 / 26</a:t>
+              <a:t>Week 6 · Markdown        5 / 24</a:t>
             </a:r>
           </a:p>
         </p:txBody>
@@ -10249,13 +9751,13 @@
               </a:spcAft>
             </a:pPr>
             <a:r>
-              <a:rPr sz="3200" b="1">
+              <a:rPr sz="4000" b="1">
                 <a:solidFill>
                   <a:srgbClr val="272A25"/>
                 </a:solidFill>
                 <a:latin typeface="Fraunces"/>
               </a:rPr>
-              <a:t>Save project context instead of repeating it</a:t>
+              <a:t>Context: what the AI can actually see</a:t>
             </a:r>
           </a:p>
         </p:txBody>
@@ -10294,7 +9796,7 @@
                 </a:solidFill>
                 <a:latin typeface="DM Sans"/>
               </a:rPr>
-              <a:t>•  Write down what the project is, who it is for, and what should stay true.</a:t>
+              <a:t>•  Its answer depends on the messages, files and tool results available now.</a:t>
             </a:r>
           </a:p>
           <a:p>
@@ -10310,7 +9812,7 @@
                 </a:solidFill>
                 <a:latin typeface="DM Sans"/>
               </a:rPr>
-              <a:t>•  Keep it short, correct and editable; update it when the project changes.</a:t>
+              <a:t>•  It does not automatically know your audience, preferences or project history.</a:t>
             </a:r>
           </a:p>
           <a:p>
@@ -10326,7 +9828,7 @@
                 </a:solidFill>
                 <a:latin typeface="DM Sans"/>
               </a:rPr>
-              <a:t>•  Example: “For nervous first-time visitors. Plain HTML/CSS. Do not invent event dates.”</a:t>
+              <a:t>•  “Improve my site” is weaker than a clear audience, goal and example.</a:t>
             </a:r>
           </a:p>
         </p:txBody>
@@ -10365,7 +9867,7 @@
                 </a:solidFill>
                 <a:latin typeface="DM Sans"/>
               </a:rPr>
-              <a:t>Week 6 · Ongoing context        6 / 26</a:t>
+              <a:t>Week 6 · Ongoing context        6 / 24</a:t>
             </a:r>
           </a:p>
         </p:txBody>
@@ -10467,13 +9969,13 @@
               </a:spcAft>
             </a:pPr>
             <a:r>
-              <a:rPr sz="4000" b="1">
+              <a:rPr sz="3200" b="1">
                 <a:solidFill>
                   <a:srgbClr val="272A25"/>
                 </a:solidFill>
                 <a:latin typeface="Fraunces"/>
               </a:rPr>
-              <a:t>A context file loads every session</a:t>
+              <a:t>Save project context instead of repeating it</a:t>
             </a:r>
           </a:p>
         </p:txBody>
@@ -10512,7 +10014,7 @@
                 </a:solidFill>
                 <a:latin typeface="DM Sans"/>
               </a:rPr>
-              <a:t>•  Coding agents such as Claude Code, Codex and Cursor can read AGENTS.md automatically.</a:t>
+              <a:t>•  Write down what the project is, who it is for, and what should stay true.</a:t>
             </a:r>
           </a:p>
           <a:p>
@@ -10528,7 +10030,7 @@
                 </a:solidFill>
                 <a:latin typeface="DM Sans"/>
               </a:rPr>
-              <a:t>•  Your project context is there at the start of every session—no retyping.</a:t>
+              <a:t>•  Keep it short, correct and editable; update it when the project changes.</a:t>
             </a:r>
           </a:p>
           <a:p>
@@ -10544,7 +10046,7 @@
                 </a:solidFill>
                 <a:latin typeface="DM Sans"/>
               </a:rPr>
-              <a:t>•  In a chat app, paste the context or add it to a Project.</a:t>
+              <a:t>•  Example: “For nervous first-time visitors. Plain HTML/CSS. Do not invent event dates.”</a:t>
             </a:r>
           </a:p>
         </p:txBody>
@@ -10583,7 +10085,7 @@
                 </a:solidFill>
                 <a:latin typeface="DM Sans"/>
               </a:rPr>
-              <a:t>Week 6 · Ongoing context        7 / 26</a:t>
+              <a:t>Week 6 · Ongoing context        7 / 24</a:t>
             </a:r>
           </a:p>
         </p:txBody>
@@ -10691,7 +10193,7 @@
                 </a:solidFill>
                 <a:latin typeface="Fraunces"/>
               </a:rPr>
-              <a:t>An index points to deeper context</a:t>
+              <a:t>A context file loads every session</a:t>
             </a:r>
           </a:p>
         </p:txBody>
@@ -10730,7 +10232,7 @@
                 </a:solidFill>
                 <a:latin typeface="DM Sans"/>
               </a:rPr>
-              <a:t>•  A small index says which files exist and what each is for.</a:t>
+              <a:t>•  Coding agents such as Claude Code, Codex and Cursor can read AGENTS.md automatically.</a:t>
             </a:r>
           </a:p>
           <a:p>
@@ -10746,7 +10248,7 @@
                 </a:solidFill>
                 <a:latin typeface="DM Sans"/>
               </a:rPr>
-              <a:t>•  Example: docs/facts.md → verified facts; docs/design.md → visual direction.</a:t>
+              <a:t>•  Your project context is there at the start of every session—no retyping.</a:t>
             </a:r>
           </a:p>
           <a:p>
@@ -10762,7 +10264,7 @@
                 </a:solidFill>
                 <a:latin typeface="DM Sans"/>
               </a:rPr>
-              <a:t>•  The AI can open the relevant document instead of receiving one giant prompt.</a:t>
+              <a:t>•  In a chat app, paste the context or add it to a Project.</a:t>
             </a:r>
           </a:p>
         </p:txBody>
@@ -10801,7 +10303,7 @@
                 </a:solidFill>
                 <a:latin typeface="DM Sans"/>
               </a:rPr>
-              <a:t>Week 6 · Ongoing context        8 / 26</a:t>
+              <a:t>Week 6 · Ongoing context        8 / 24</a:t>
             </a:r>
           </a:p>
         </p:txBody>
@@ -10903,13 +10405,13 @@
               </a:spcAft>
             </a:pPr>
             <a:r>
-              <a:rPr sz="3200" b="1">
+              <a:rPr sz="4000" b="1">
                 <a:solidFill>
                   <a:srgbClr val="272A25"/>
                 </a:solidFill>
                 <a:latin typeface="Fraunces"/>
               </a:rPr>
-              <a:t>Describe the design, not just the features</a:t>
+              <a:t>An index points to deeper context</a:t>
             </a:r>
           </a:p>
         </p:txBody>
@@ -10948,7 +10450,7 @@
                 </a:solidFill>
                 <a:latin typeface="DM Sans"/>
               </a:rPr>
-              <a:t>•  “Make it better” leaves the visual choices to the model.</a:t>
+              <a:t>•  A small index says which files exist and what each is for.</a:t>
             </a:r>
           </a:p>
           <a:p>
@@ -10964,7 +10466,7 @@
                 </a:solidFill>
                 <a:latin typeface="DM Sans"/>
               </a:rPr>
-              <a:t>•  Name the audience, feeling, hierarchy and interactions you want.</a:t>
+              <a:t>•  Example: docs/facts.md → verified facts; docs/design.md → visual direction.</a:t>
             </a:r>
           </a:p>
           <a:p>
@@ -10980,7 +10482,7 @@
                 </a:solidFill>
                 <a:latin typeface="DM Sans"/>
               </a:rPr>
-              <a:t>•  Example: “Calm portfolio. Work first, muted colours, clickable project cards.”</a:t>
+              <a:t>•  The AI can open the relevant document instead of receiving one giant prompt.</a:t>
             </a:r>
           </a:p>
         </p:txBody>
@@ -11019,7 +10521,7 @@
                 </a:solidFill>
                 <a:latin typeface="DM Sans"/>
               </a:rPr>
-              <a:t>Week 6 · Communicate intent        9 / 26</a:t>
+              <a:t>Week 6 · Ongoing context        9 / 24</a:t>
             </a:r>
           </a:p>
         </p:txBody>

</xml_diff>

<commit_message>
Week 6 slides: class overview of builds + shared friction; merge design/feedback/debug; drop credits slide (Aaron) (#18)
Co-authored-by: Unforced AGI <agi@unforced.dev>
</commit_message>
<xml_diff>
--- a/lessons/week-6/_src/week6-lecture.pptx
+++ b/lessons/week-6/_src/week6-lecture.pptx
@@ -29,8 +29,6 @@
     <p:sldId id="277" r:id="rId29"/>
     <p:sldId id="278" r:id="rId30"/>
     <p:sldId id="279" r:id="rId31"/>
-    <p:sldId id="280" r:id="rId32"/>
-    <p:sldId id="281" r:id="rId33"/>
   </p:sldIdLst>
   <p:sldSz cx="12191695" cy="6858000" type="screen4x3"/>
   <p:notesSz cx="6858000" cy="9144000"/>
@@ -597,7 +595,7 @@
           <a:lstStyle/>
           <a:p>
             <a:r>
-              <a:t>Recent Week 5 work caught non-clickable cards through use. Specific observed behavior gives the agent something testable.</a:t>
+              <a:t>One idea: close the gap between what you pictured and what you got by being concrete. Covers design, feedback and bugs in one move.</a:t>
             </a:r>
           </a:p>
         </p:txBody>
@@ -667,7 +665,7 @@
           <a:lstStyle/>
           <a:p>
             <a:r>
-              <a:t>Do not blindly rewrite the whole app. Before a risky fix, save a working version. Recent students used AI for testing/debugging but still needed to notice what failed.</a:t>
+              <a:t>A running build is not proof it is correct or useful. This transfers directly to the small-group learning builds.</a:t>
             </a:r>
           </a:p>
         </p:txBody>
@@ -737,7 +735,7 @@
           <a:lstStyle/>
           <a:p>
             <a:r>
-              <a:t>A running build is not proof it is correct or useful. This transfers directly to the small-group learning builds.</a:t>
+              <a:t>A GitHub repo can hold code without having a live website. A folder path cannot be submitted as an accessible build link.</a:t>
             </a:r>
           </a:p>
         </p:txBody>
@@ -807,7 +805,7 @@
           <a:lstStyle/>
           <a:p>
             <a:r>
-              <a:t>Recent Week 5 submissions described switching tools and running out of credits. Persistent context is a practical continuity aid; do not imply unlimited free usage.</a:t>
+              <a:t>Use an ordinary change as an example: fix a heading, commit “Clarify heading”, push, wait for deployment, verify the live page.</a:t>
             </a:r>
           </a:p>
         </p:txBody>
@@ -877,7 +875,7 @@
           <a:lstStyle/>
           <a:p>
             <a:r>
-              <a:t>A GitHub repo can hold code without having a live website. A folder path cannot be submitted as an accessible build link.</a:t>
+              <a:t>Repeated local-link issues in actual submissions. For a public build, check that it does not require your account to open.</a:t>
             </a:r>
           </a:p>
         </p:txBody>
@@ -947,7 +945,7 @@
           <a:lstStyle/>
           <a:p>
             <a:r>
-              <a:t>Use an ordinary change as an example: fix a heading, commit “Clarify heading”, push, wait for deployment, verify the live page.</a:t>
+              <a:t>No prescribed app. Students use whatever tool they already have; the point is understanding the steps and checking the public link.</a:t>
             </a:r>
           </a:p>
         </p:txBody>
@@ -1017,7 +1015,7 @@
           <a:lstStyle/>
           <a:p>
             <a:r>
-              <a:t>Repeated local-link issues in actual submissions. For a public build, check that it does not require your account to open.</a:t>
+              <a:t>Example: a weather service has an API that returns a forecast. An MCP connection lets your AI use services like that inside a conversation. In Claude these show up as connectors. Concept only tonight; next week we connect.</a:t>
             </a:r>
           </a:p>
         </p:txBody>
@@ -1087,7 +1085,7 @@
           <a:lstStyle/>
           <a:p>
             <a:r>
-              <a:t>No prescribed app. Students use whatever tool they already have; the point is understanding the steps and checking the public link.</a:t>
+              <a:t>Students recently asked their tools to explain the tool itself while building. Model this as a learning practice, not outsourcing understanding.</a:t>
             </a:r>
           </a:p>
         </p:txBody>
@@ -1157,7 +1155,7 @@
           <a:lstStyle/>
           <a:p>
             <a:r>
-              <a:t>Example: a weather service has an API that returns a forecast. An MCP connection lets your AI use services like that inside a conversation. In Claude these show up as connectors. Concept only tonight; next week we connect.</a:t>
+              <a:t>Assigned reading. Shipper turned reflection on actual projects into a coaching conversation. The reading link is in students’ accounts; no new due date.</a:t>
             </a:r>
           </a:p>
         </p:txBody>
@@ -1227,7 +1225,7 @@
           <a:lstStyle/>
           <a:p>
             <a:r>
-              <a:t>Students recently asked their tools to explain the tool itself while building. Model this as a learning practice, not outsourcing understanding.</a:t>
+              <a:t>Free plans need not have long-term memory. Give a small truthful sample, not every private conversation.</a:t>
             </a:r>
           </a:p>
         </p:txBody>
@@ -1297,7 +1295,7 @@
           <a:lstStyle/>
           <a:p>
             <a:r>
-              <a:t>Grounded in actual Week 4/5 submissions: visual intent failed to translate; one build had non-clickable cards; localhost and deployment-permission confusion persisted. Public slides deliberately omit names and private quotes.</a:t>
+              <a:t>Week 5 work, anonymised. Celebrate range: different starting points, all real builds. Invite a couple of people to say a sentence about theirs if the room is warm.</a:t>
             </a:r>
           </a:p>
         </p:txBody>
@@ -1367,7 +1365,7 @@
           <a:lstStyle/>
           <a:p>
             <a:r>
-              <a:t>Assigned reading. Shipper turned reflection on actual projects into a coaching conversation. The reading link is in students’ accounts; no new due date.</a:t>
+              <a:t>Every essential access instruction is here, not hidden in a handout. This is how the reading’s coaching idea becomes something students can do tonight.</a:t>
             </a:r>
           </a:p>
         </p:txBody>
@@ -1437,7 +1435,7 @@
           <a:lstStyle/>
           <a:p>
             <a:r>
-              <a:t>Free plans need not have long-term memory. Give a small truthful sample, not every private conversation.</a:t>
+              <a:t>This is the only live demo slot, after the teaching content. Do not prescribe a project, script or output. If delayed, discuss a question from the lesson and move to group work.</a:t>
             </a:r>
           </a:p>
         </p:txBody>
@@ -1507,7 +1505,7 @@
           <a:lstStyle/>
           <a:p>
             <a:r>
-              <a:t>Every essential access instruction is here, not hidden in a handout. This is how the reading’s coaching idea becomes something students can do tonight.</a:t>
+              <a:t>Open-ended invitation, no fixed template or prescribed roles. Help students choose a small first learning goal without deciding their project for them.</a:t>
             </a:r>
           </a:p>
         </p:txBody>
@@ -1577,7 +1575,7 @@
           <a:lstStyle/>
           <a:p>
             <a:r>
-              <a:t>This is the only live demo slot, after the teaching content. Do not prescribe a project, script or output. If delayed, discuss a question from the lesson and move to group work.</a:t>
+              <a:t>Optional: ask your AI what it needs to know about your project; save the useful context in markdown. Students can find the lesson from the preceding slide. No due date added.</a:t>
             </a:r>
           </a:p>
         </p:txBody>
@@ -1647,146 +1645,6 @@
           <a:lstStyle/>
           <a:p>
             <a:r>
-              <a:t>Open-ended invitation, no fixed template or prescribed roles. Help students choose a small first learning goal without deciding their project for them.</a:t>
-            </a:r>
-          </a:p>
-        </p:txBody>
-      </p:sp>
-      <p:sp>
-        <p:nvSpPr>
-          <p:cNvPr id="4" name="Slide Number Placeholder 3"/>
-          <p:cNvSpPr>
-            <a:spLocks noGrp="1"/>
-          </p:cNvSpPr>
-          <p:nvPr>
-            <p:ph type="sldNum" idx="5" sz="quarter"/>
-          </p:nvPr>
-        </p:nvSpPr>
-        <p:spPr/>
-      </p:sp>
-    </p:spTree>
-  </p:cSld>
-  <p:clrMapOvr>
-    <a:masterClrMapping/>
-  </p:clrMapOvr>
-</p:notes>
-</file>
-
-<file path=ppt/notesSlides/notesSlide25.xml><?xml version="1.0" encoding="utf-8"?>
-<p:notes xmlns:a="http://schemas.openxmlformats.org/drawingml/2006/main" xmlns:p="http://schemas.openxmlformats.org/presentationml/2006/main" xmlns:r="http://schemas.openxmlformats.org/officeDocument/2006/relationships">
-  <p:cSld>
-    <p:spTree>
-      <p:nvGrpSpPr>
-        <p:cNvPr id="1" name=""/>
-        <p:cNvGrpSpPr/>
-        <p:nvPr/>
-      </p:nvGrpSpPr>
-      <p:grpSpPr>
-        <a:xfrm>
-          <a:off x="0" y="0"/>
-          <a:ext cx="0" cy="0"/>
-          <a:chOff x="0" y="0"/>
-          <a:chExt cx="0" cy="0"/>
-        </a:xfrm>
-      </p:grpSpPr>
-      <p:sp>
-        <p:nvSpPr>
-          <p:cNvPr id="2" name="Slide Image Placeholder 1"/>
-          <p:cNvSpPr>
-            <a:spLocks noGrp="1"/>
-          </p:cNvSpPr>
-          <p:nvPr>
-            <p:ph type="sldImg" idx="2"/>
-          </p:nvPr>
-        </p:nvSpPr>
-        <p:spPr/>
-      </p:sp>
-      <p:sp>
-        <p:nvSpPr>
-          <p:cNvPr id="3" name="Notes Placeholder 2"/>
-          <p:cNvSpPr>
-            <a:spLocks noGrp="1"/>
-          </p:cNvSpPr>
-          <p:nvPr>
-            <p:ph type="body" idx="3" sz="quarter"/>
-          </p:nvPr>
-        </p:nvSpPr>
-        <p:spPr/>
-        <p:txBody>
-          <a:bodyPr/>
-          <a:lstStyle/>
-          <a:p>
-            <a:r>
-              <a:t>Optional: ask your AI what it needs to know about your project; save the useful context in markdown. Students can find the lesson from the preceding slide. No due date added.</a:t>
-            </a:r>
-          </a:p>
-        </p:txBody>
-      </p:sp>
-      <p:sp>
-        <p:nvSpPr>
-          <p:cNvPr id="4" name="Slide Number Placeholder 3"/>
-          <p:cNvSpPr>
-            <a:spLocks noGrp="1"/>
-          </p:cNvSpPr>
-          <p:nvPr>
-            <p:ph type="sldNum" idx="5" sz="quarter"/>
-          </p:nvPr>
-        </p:nvSpPr>
-        <p:spPr/>
-      </p:sp>
-    </p:spTree>
-  </p:cSld>
-  <p:clrMapOvr>
-    <a:masterClrMapping/>
-  </p:clrMapOvr>
-</p:notes>
-</file>
-
-<file path=ppt/notesSlides/notesSlide26.xml><?xml version="1.0" encoding="utf-8"?>
-<p:notes xmlns:a="http://schemas.openxmlformats.org/drawingml/2006/main" xmlns:p="http://schemas.openxmlformats.org/presentationml/2006/main" xmlns:r="http://schemas.openxmlformats.org/officeDocument/2006/relationships">
-  <p:cSld>
-    <p:spTree>
-      <p:nvGrpSpPr>
-        <p:cNvPr id="1" name=""/>
-        <p:cNvGrpSpPr/>
-        <p:nvPr/>
-      </p:nvGrpSpPr>
-      <p:grpSpPr>
-        <a:xfrm>
-          <a:off x="0" y="0"/>
-          <a:ext cx="0" cy="0"/>
-          <a:chOff x="0" y="0"/>
-          <a:chExt cx="0" cy="0"/>
-        </a:xfrm>
-      </p:grpSpPr>
-      <p:sp>
-        <p:nvSpPr>
-          <p:cNvPr id="2" name="Slide Image Placeholder 1"/>
-          <p:cNvSpPr>
-            <a:spLocks noGrp="1"/>
-          </p:cNvSpPr>
-          <p:nvPr>
-            <p:ph type="sldImg" idx="2"/>
-          </p:nvPr>
-        </p:nvSpPr>
-        <p:spPr/>
-      </p:sp>
-      <p:sp>
-        <p:nvSpPr>
-          <p:cNvPr id="3" name="Notes Placeholder 2"/>
-          <p:cNvSpPr>
-            <a:spLocks noGrp="1"/>
-          </p:cNvSpPr>
-          <p:nvPr>
-            <p:ph type="body" idx="3" sz="quarter"/>
-          </p:nvPr>
-        </p:nvSpPr>
-        <p:spPr/>
-        <p:txBody>
-          <a:bodyPr/>
-          <a:lstStyle/>
-          <a:p>
-            <a:r>
               <a:t>Authoritative Week 6 assignment replaces the required build. One page, not one paragraph. Existing due date remains October 11 at 11:59 PM MT. Pods share learning and support each other in class for AT LEAST the next three weeks; do not invent size, rubric, or final-project requirements. Canvas copy is a draft, not yet published.</a:t>
             </a:r>
           </a:p>
@@ -1857,7 +1715,7 @@
           <a:lstStyle/>
           <a:p>
             <a:r>
-              <a:t>Explain portability: the same text works across tools. A file can be edited without a platform account.</a:t>
+              <a:t>Pulled from reflections. Name these as normal, shared experiences, not failures. Each maps to a section of tonight: context, saying what you mean, getting online.</a:t>
             </a:r>
           </a:p>
         </p:txBody>
@@ -1927,7 +1785,7 @@
           <a:lstStyle/>
           <a:p>
             <a:r>
-              <a:t>Point out # and ## headings; - list; [label](URL) link; backticks for code. These are examples, not a context template.</a:t>
+              <a:t>Explain portability: the same text works across tools. A file can be edited without a platform account.</a:t>
             </a:r>
           </a:p>
         </p:txBody>
@@ -1997,7 +1855,7 @@
           <a:lstStyle/>
           <a:p>
             <a:r>
-              <a:t>Avoid claiming every app literally starts at zero: some add saved memory or project files. Ask what context the tool loaded.</a:t>
+              <a:t>Point out # and ## headings; - list; [label](URL) link; backticks for code. These are examples, not a context template.</a:t>
             </a:r>
           </a:p>
         </p:txBody>
@@ -2067,7 +1925,7 @@
           <a:lstStyle/>
           <a:p>
             <a:r>
-              <a:t>These are useful questions, not a rigid template or pair interview. Student projects vary: portfolios, creative work, tools, simulations.</a:t>
+              <a:t>Avoid claiming every app literally starts at zero: some add saved memory or project files. Ask what context the tool loaded.</a:t>
             </a:r>
           </a:p>
         </p:txBody>
@@ -2137,7 +1995,7 @@
           <a:lstStyle/>
           <a:p>
             <a:r>
-              <a:t>Put the file in the top folder of the project. Verified tonight: Claude Code picked up AGENTS.md in a fresh session. Keep the point simple: write the context once, and the agent starts with it.</a:t>
+              <a:t>These are useful questions, not a rigid template or pair interview. Student projects vary: portfolios, creative work, tools, simulations.</a:t>
             </a:r>
           </a:p>
         </p:txBody>
@@ -2207,7 +2065,7 @@
           <a:lstStyle/>
           <a:p>
             <a:r>
-              <a:t>Index files are a map, not evidence that the AI read the linked files. Ask it which sources it used.</a:t>
+              <a:t>Put the file in the top folder of the project. Verified tonight: Claude Code picked up AGENTS.md in a fresh session. Keep the point simple: write the context once, and the agent starts with it.</a:t>
             </a:r>
           </a:p>
         </p:txBody>
@@ -2277,7 +2135,7 @@
           <a:lstStyle/>
           <a:p>
             <a:r>
-              <a:t>Week 4/5 reflections describe trouble communicating aesthetics; a recent rebuild improved when the student described the feeling instead of only listing features.</a:t>
+              <a:t>Index files are a map, not evidence that the AI read the linked files. Ask it which sources it used.</a:t>
             </a:r>
           </a:p>
         </p:txBody>
@@ -5439,7 +5297,7 @@
                 </a:solidFill>
                 <a:latin typeface="DM Sans"/>
               </a:rPr>
-              <a:t>Week 6 · Opening        1 / 26</a:t>
+              <a:t>Week 6 · Opening        1 / 24</a:t>
             </a:r>
           </a:p>
         </p:txBody>
@@ -5547,7 +5405,7 @@
                 </a:solidFill>
                 <a:latin typeface="Fraunces"/>
               </a:rPr>
-              <a:t>Make your feedback observable</a:t>
+              <a:t>When the result isn’t what you meant</a:t>
             </a:r>
           </a:p>
         </p:txBody>
@@ -5586,7 +5444,7 @@
                 </a:solidFill>
                 <a:latin typeface="DM Sans"/>
               </a:rPr>
-              <a:t>•  Give a reference or screenshot; say what to keep and what to change.</a:t>
+              <a:t>•  Say what you expected and what you actually see: “Clicking the card should open the project; nothing happens.”</a:t>
             </a:r>
           </a:p>
           <a:p>
@@ -5602,7 +5460,7 @@
                 </a:solidFill>
                 <a:latin typeface="DM Sans"/>
               </a:rPr>
-              <a:t>•  Instead of “It’s broken”: “Clicking this card should open the project; nothing happens.”</a:t>
+              <a:t>•  Show it: a screenshot or a site you like says more than “make it better”.</a:t>
             </a:r>
           </a:p>
           <a:p>
@@ -5618,7 +5476,7 @@
                 </a:solidFill>
                 <a:latin typeface="DM Sans"/>
               </a:rPr>
-              <a:t>•  Ask for one small change, then compare the result with your intention.</a:t>
+              <a:t>•  Ask for one change at a time, then look again.</a:t>
             </a:r>
           </a:p>
         </p:txBody>
@@ -5657,7 +5515,7 @@
                 </a:solidFill>
                 <a:latin typeface="DM Sans"/>
               </a:rPr>
-              <a:t>Week 6 · Communicate intent        10 / 26</a:t>
+              <a:t>Week 6 · Communicate intent        10 / 24</a:t>
             </a:r>
           </a:p>
         </p:txBody>
@@ -5765,7 +5623,7 @@
                 </a:solidFill>
                 <a:latin typeface="Fraunces"/>
               </a:rPr>
-              <a:t>Debugging: find the mismatch</a:t>
+              <a:t>Check the experience—not just the code</a:t>
             </a:r>
           </a:p>
         </p:txBody>
@@ -5804,7 +5662,7 @@
                 </a:solidFill>
                 <a:latin typeface="DM Sans"/>
               </a:rPr>
-              <a:t>•  A bug is a difference between expected and observed behavior.</a:t>
+              <a:t>•  Open it on a phone. Click every important button and link.</a:t>
             </a:r>
           </a:p>
           <a:p>
@@ -5820,7 +5678,7 @@
                 </a:solidFill>
                 <a:latin typeface="DM Sans"/>
               </a:rPr>
-              <a:t>•  Reproduce it: what exact actions cause it? Capture the error or screenshot.</a:t>
+              <a:t>•  Try empty input, a strange answer, or a first-time visitor’s path.</a:t>
             </a:r>
           </a:p>
           <a:p>
@@ -5836,7 +5694,7 @@
                 </a:solidFill>
                 <a:latin typeface="DM Sans"/>
               </a:rPr>
-              <a:t>•  Ask the AI for a cause and a small fix; rerun the same check afterward.</a:t>
+              <a:t>•  For a learning tool, check its facts and quiz answers against a trustworthy source.</a:t>
             </a:r>
           </a:p>
         </p:txBody>
@@ -5875,7 +5733,7 @@
                 </a:solidFill>
                 <a:latin typeface="DM Sans"/>
               </a:rPr>
-              <a:t>Week 6 · Check the work        11 / 26</a:t>
+              <a:t>Week 6 · Check the work        11 / 24</a:t>
             </a:r>
           </a:p>
         </p:txBody>
@@ -5977,13 +5835,13 @@
               </a:spcAft>
             </a:pPr>
             <a:r>
-              <a:rPr sz="4000" b="1">
+              <a:rPr sz="3200" b="1">
                 <a:solidFill>
                   <a:srgbClr val="272A25"/>
                 </a:solidFill>
                 <a:latin typeface="Fraunces"/>
               </a:rPr>
-              <a:t>Check the experience—not just the code</a:t>
+              <a:t>Folder, repository, website: different things</a:t>
             </a:r>
           </a:p>
         </p:txBody>
@@ -6022,7 +5880,7 @@
                 </a:solidFill>
                 <a:latin typeface="DM Sans"/>
               </a:rPr>
-              <a:t>•  Open it on a phone. Click every important button and link.</a:t>
+              <a:t>•  Local folder: files on your own computer.</a:t>
             </a:r>
           </a:p>
           <a:p>
@@ -6038,7 +5896,7 @@
                 </a:solidFill>
                 <a:latin typeface="DM Sans"/>
               </a:rPr>
-              <a:t>•  Try empty input, a strange answer, or a first-time visitor’s path.</a:t>
+              <a:t>•  Git repository: those files plus a recorded history of versions.</a:t>
             </a:r>
           </a:p>
           <a:p>
@@ -6054,7 +5912,7 @@
                 </a:solidFill>
                 <a:latin typeface="DM Sans"/>
               </a:rPr>
-              <a:t>•  For a learning tool, check its facts and quiz answers against a trustworthy source.</a:t>
+              <a:t>•  Deployment: a published version that other people can open.</a:t>
             </a:r>
           </a:p>
         </p:txBody>
@@ -6093,7 +5951,7 @@
                 </a:solidFill>
                 <a:latin typeface="DM Sans"/>
               </a:rPr>
-              <a:t>Week 6 · Check the work        12 / 26</a:t>
+              <a:t>Week 6 · Getting online        12 / 24</a:t>
             </a:r>
           </a:p>
         </p:txBody>
@@ -6201,7 +6059,7 @@
                 </a:solidFill>
                 <a:latin typeface="Fraunces"/>
               </a:rPr>
-              <a:t>When free credits run out</a:t>
+              <a:t>Commit, push, deploy: three actions</a:t>
             </a:r>
           </a:p>
         </p:txBody>
@@ -6240,7 +6098,7 @@
                 </a:solidFill>
                 <a:latin typeface="DM Sans"/>
               </a:rPr>
-              <a:t>•  Save files and a short note: what works, what failed, what to try next.</a:t>
+              <a:t>•  Commit saves a version and a message in your local Git history.</a:t>
             </a:r>
           </a:p>
           <a:p>
@@ -6256,7 +6114,7 @@
                 </a:solidFill>
                 <a:latin typeface="DM Sans"/>
               </a:rPr>
-              <a:t>•  Use that note to continue in a fresh session or another tool.</a:t>
+              <a:t>•  Push sends your commits to the repository on GitHub.</a:t>
             </a:r>
           </a:p>
           <a:p>
@@ -6272,7 +6130,7 @@
                 </a:solidFill>
                 <a:latin typeface="DM Sans"/>
               </a:rPr>
-              <a:t>•  Reduce the request: one change or one explanation at a time.</a:t>
+              <a:t>•  Deploy publishes the project through a host such as GitHub Pages or Vercel.</a:t>
             </a:r>
           </a:p>
         </p:txBody>
@@ -6311,7 +6169,7 @@
                 </a:solidFill>
                 <a:latin typeface="DM Sans"/>
               </a:rPr>
-              <a:t>Week 6 · Working within limits        13 / 26</a:t>
+              <a:t>Week 6 · Getting online        13 / 24</a:t>
             </a:r>
           </a:p>
         </p:txBody>
@@ -6419,7 +6277,7 @@
                 </a:solidFill>
                 <a:latin typeface="Fraunces"/>
               </a:rPr>
-              <a:t>Folder, repository, website: different things</a:t>
+              <a:t>Your link must work on someone else’s phone</a:t>
             </a:r>
           </a:p>
         </p:txBody>
@@ -6458,7 +6316,7 @@
                 </a:solidFill>
                 <a:latin typeface="DM Sans"/>
               </a:rPr>
-              <a:t>•  Local folder: files on your own computer.</a:t>
+              <a:t>•  file:///… and localhost:8000 point to your own computer—not a public site.</a:t>
             </a:r>
           </a:p>
           <a:p>
@@ -6474,7 +6332,7 @@
                 </a:solidFill>
                 <a:latin typeface="DM Sans"/>
               </a:rPr>
-              <a:t>•  Git repository: those files plus a recorded history of versions.</a:t>
+              <a:t>•  A GitHub repository URL shows source; it may not be the live app URL.</a:t>
             </a:r>
           </a:p>
           <a:p>
@@ -6490,7 +6348,7 @@
                 </a:solidFill>
                 <a:latin typeface="DM Sans"/>
               </a:rPr>
-              <a:t>•  Deployment: a published version that other people can open.</a:t>
+              <a:t>•  Use the deployed HTTPS URL; test it on another device or in a private window.</a:t>
             </a:r>
           </a:p>
         </p:txBody>
@@ -6529,7 +6387,7 @@
                 </a:solidFill>
                 <a:latin typeface="DM Sans"/>
               </a:rPr>
-              <a:t>Week 6 · Getting online        14 / 26</a:t>
+              <a:t>Week 6 · Getting online        14 / 24</a:t>
             </a:r>
           </a:p>
         </p:txBody>
@@ -6637,7 +6495,7 @@
                 </a:solidFill>
                 <a:latin typeface="Fraunces"/>
               </a:rPr>
-              <a:t>Commit, push, deploy: three actions</a:t>
+              <a:t>Getting it online, your way</a:t>
             </a:r>
           </a:p>
         </p:txBody>
@@ -6676,7 +6534,7 @@
                 </a:solidFill>
                 <a:latin typeface="DM Sans"/>
               </a:rPr>
-              <a:t>•  Commit saves a version and a message in your local Git history.</a:t>
+              <a:t>•  Ask the AI tool you already use: “Help me get this online with the tools I have. Explain each step as we go.”</a:t>
             </a:r>
           </a:p>
           <a:p>
@@ -6692,7 +6550,7 @@
                 </a:solidFill>
                 <a:latin typeface="DM Sans"/>
               </a:rPr>
-              <a:t>•  Push sends your commits to the repository on GitHub.</a:t>
+              <a:t>•  It will save a version, send it to GitHub, and publish it with a host.</a:t>
             </a:r>
           </a:p>
           <a:p>
@@ -6708,7 +6566,7 @@
                 </a:solidFill>
                 <a:latin typeface="DM Sans"/>
               </a:rPr>
-              <a:t>•  Deploy publishes the project through a host such as GitHub Pages or Vercel.</a:t>
+              <a:t>•  Done means a public link that opens on someone else’s phone.</a:t>
             </a:r>
           </a:p>
         </p:txBody>
@@ -6747,7 +6605,7 @@
                 </a:solidFill>
                 <a:latin typeface="DM Sans"/>
               </a:rPr>
-              <a:t>Week 6 · Getting online        15 / 26</a:t>
+              <a:t>Week 6 · Getting online        15 / 24</a:t>
             </a:r>
           </a:p>
         </p:txBody>
@@ -6855,7 +6713,7 @@
                 </a:solidFill>
                 <a:latin typeface="Fraunces"/>
               </a:rPr>
-              <a:t>Your link must work on someone else’s phone</a:t>
+              <a:t>APIs and MCP: how AI connects to other tools</a:t>
             </a:r>
           </a:p>
         </p:txBody>
@@ -6894,7 +6752,7 @@
                 </a:solidFill>
                 <a:latin typeface="DM Sans"/>
               </a:rPr>
-              <a:t>•  file:///… and localhost:8000 point to your own computer—not a public site.</a:t>
+              <a:t>•  API: how one program requests information or actions from another.</a:t>
             </a:r>
           </a:p>
           <a:p>
@@ -6910,7 +6768,7 @@
                 </a:solidFill>
                 <a:latin typeface="DM Sans"/>
               </a:rPr>
-              <a:t>•  A GitHub repository URL shows source; it may not be the live app URL.</a:t>
+              <a:t>•  MCP: a standard way for AI tools to connect to other services and data.</a:t>
             </a:r>
           </a:p>
           <a:p>
@@ -6926,7 +6784,7 @@
                 </a:solidFill>
                 <a:latin typeface="DM Sans"/>
               </a:rPr>
-              <a:t>•  Use the deployed HTTPS URL; test it on another device or in a private window.</a:t>
+              <a:t>•  In Claude, these MCP connections are called connectors.</a:t>
             </a:r>
           </a:p>
         </p:txBody>
@@ -6965,7 +6823,7 @@
                 </a:solidFill>
                 <a:latin typeface="DM Sans"/>
               </a:rPr>
-              <a:t>Week 6 · Getting online        16 / 26</a:t>
+              <a:t>Week 6 · Connections—concept only        16 / 24</a:t>
             </a:r>
           </a:p>
         </p:txBody>
@@ -7073,7 +6931,7 @@
                 </a:solidFill>
                 <a:latin typeface="Fraunces"/>
               </a:rPr>
-              <a:t>Getting it online, your way</a:t>
+              <a:t>Use AI to learn about AI</a:t>
             </a:r>
           </a:p>
         </p:txBody>
@@ -7112,7 +6970,7 @@
                 </a:solidFill>
                 <a:latin typeface="DM Sans"/>
               </a:rPr>
-              <a:t>•  Ask the AI tool you already use: “Help me get this online with the tools I have. Explain each step as we go.”</a:t>
+              <a:t>•  Ask for an explanation, an example, and a question to check your understanding.</a:t>
             </a:r>
           </a:p>
           <a:p>
@@ -7128,7 +6986,7 @@
                 </a:solidFill>
                 <a:latin typeface="DM Sans"/>
               </a:rPr>
-              <a:t>•  It will save a version, send it to GitHub, and publish it with a host.</a:t>
+              <a:t>•  Say what you already know: “I know HTML; Git is new to me.”</a:t>
             </a:r>
           </a:p>
           <a:p>
@@ -7144,7 +7002,7 @@
                 </a:solidFill>
                 <a:latin typeface="DM Sans"/>
               </a:rPr>
-              <a:t>•  Done means a public link that opens on someone else’s phone.</a:t>
+              <a:t>•  Compare its explanation with your source—not just how confident it sounds.</a:t>
             </a:r>
           </a:p>
         </p:txBody>
@@ -7183,7 +7041,7 @@
                 </a:solidFill>
                 <a:latin typeface="DM Sans"/>
               </a:rPr>
-              <a:t>Week 6 · Getting online        17 / 26</a:t>
+              <a:t>Week 6 · Learn with AI        17 / 24</a:t>
             </a:r>
           </a:p>
         </p:txBody>
@@ -7285,13 +7143,13 @@
               </a:spcAft>
             </a:pPr>
             <a:r>
-              <a:rPr sz="3200" b="1">
+              <a:rPr sz="4000" b="1">
                 <a:solidFill>
                   <a:srgbClr val="272A25"/>
                 </a:solidFill>
                 <a:latin typeface="Fraunces"/>
               </a:rPr>
-              <a:t>APIs and MCP: how AI connects to other tools</a:t>
+              <a:t>The reading: your AI as a coach</a:t>
             </a:r>
           </a:p>
         </p:txBody>
@@ -7330,7 +7188,7 @@
                 </a:solidFill>
                 <a:latin typeface="DM Sans"/>
               </a:rPr>
-              <a:t>•  API: how one program requests information or actions from another.</a:t>
+              <a:t>•  Arielle Shipper · “How to Get Better at AI by Asking AI” · Every</a:t>
             </a:r>
           </a:p>
           <a:p>
@@ -7346,7 +7204,7 @@
                 </a:solidFill>
                 <a:latin typeface="DM Sans"/>
               </a:rPr>
-              <a:t>•  MCP: a standard way for AI tools to connect to other services and data.</a:t>
+              <a:t>•  Ask where you are on the Eight Levels of AI Adoption, with evidence from your work.</a:t>
             </a:r>
           </a:p>
           <a:p>
@@ -7362,7 +7220,7 @@
                 </a:solidFill>
                 <a:latin typeface="DM Sans"/>
               </a:rPr>
-              <a:t>•  In Claude, these MCP connections are called connectors.</a:t>
+              <a:t>•  Ask for one next step, then: “Teach me that and help me practise.”</a:t>
             </a:r>
           </a:p>
         </p:txBody>
@@ -7401,7 +7259,7 @@
                 </a:solidFill>
                 <a:latin typeface="DM Sans"/>
               </a:rPr>
-              <a:t>Week 6 · Connections—concept only        18 / 26</a:t>
+              <a:t>Week 6 · Learn with AI        18 / 24</a:t>
             </a:r>
           </a:p>
         </p:txBody>
@@ -7503,13 +7361,13 @@
               </a:spcAft>
             </a:pPr>
             <a:r>
-              <a:rPr sz="4000" b="1">
+              <a:rPr sz="3200" b="1">
                 <a:solidFill>
                   <a:srgbClr val="272A25"/>
                 </a:solidFill>
                 <a:latin typeface="Fraunces"/>
               </a:rPr>
-              <a:t>Use AI to learn about AI</a:t>
+              <a:t>No long chat history? Bring your own evidence</a:t>
             </a:r>
           </a:p>
         </p:txBody>
@@ -7548,7 +7406,7 @@
                 </a:solidFill>
                 <a:latin typeface="DM Sans"/>
               </a:rPr>
-              <a:t>•  Ask for an explanation, an example, and a question to check your understanding.</a:t>
+              <a:t>•  Paste your last two submissions or describe a recent project.</a:t>
             </a:r>
           </a:p>
           <a:p>
@@ -7564,7 +7422,7 @@
                 </a:solidFill>
                 <a:latin typeface="DM Sans"/>
               </a:rPr>
-              <a:t>•  Say what you already know: “I know HTML; Git is new to me.”</a:t>
+              <a:t>•  Ask: “What can I do already? Show examples. What should I learn next?”</a:t>
             </a:r>
           </a:p>
           <a:p>
@@ -7580,7 +7438,7 @@
                 </a:solidFill>
                 <a:latin typeface="DM Sans"/>
               </a:rPr>
-              <a:t>•  Compare its explanation with your source—not just how confident it sounds.</a:t>
+              <a:t>•  Treat the AI’s assessment as a suggestion; correct its assumptions.</a:t>
             </a:r>
           </a:p>
         </p:txBody>
@@ -7619,7 +7477,7 @@
                 </a:solidFill>
                 <a:latin typeface="DM Sans"/>
               </a:rPr>
-              <a:t>Week 6 · Learn with AI        19 / 26</a:t>
+              <a:t>Week 6 · Learn with AI        19 / 24</a:t>
             </a:r>
           </a:p>
         </p:txBody>
@@ -7727,7 +7585,7 @@
                 </a:solidFill>
                 <a:latin typeface="Fraunces"/>
               </a:rPr>
-              <a:t>What your recent builds taught us</a:t>
+              <a:t>What you’ve been building</a:t>
             </a:r>
           </a:p>
         </p:txBody>
@@ -7756,49 +7614,97 @@
           <a:p>
             <a:pPr>
               <a:spcAft>
-                <a:spcPts val="2200"/>
-              </a:spcAft>
-            </a:pPr>
-            <a:r>
-              <a:rPr sz="3000" b="0">
+                <a:spcPts val="1600"/>
+              </a:spcAft>
+            </a:pPr>
+            <a:r>
+              <a:rPr sz="2600" b="0">
                 <a:solidFill>
                   <a:srgbClr val="272A25"/>
                 </a:solidFill>
                 <a:latin typeface="DM Sans"/>
               </a:rPr>
-              <a:t>•  The AI can finish a prompt and still miss the design you intended.</a:t>
+              <a:t>•  A startup proof of concept, built in about eight hours.</a:t>
             </a:r>
           </a:p>
           <a:p>
             <a:pPr>
               <a:spcAft>
-                <a:spcPts val="2200"/>
-              </a:spcAft>
-            </a:pPr>
-            <a:r>
-              <a:rPr sz="3000" b="0">
+                <a:spcPts val="1600"/>
+              </a:spcAft>
+            </a:pPr>
+            <a:r>
+              <a:rPr sz="2600" b="0">
                 <a:solidFill>
                   <a:srgbClr val="272A25"/>
                 </a:solidFill>
                 <a:latin typeface="DM Sans"/>
               </a:rPr>
-              <a:t>•  A page can look finished while its buttons do not work.</a:t>
+              <a:t>•  A Three.js pop-up storybook, live on Vercel.</a:t>
             </a:r>
           </a:p>
           <a:p>
             <a:pPr>
               <a:spcAft>
-                <a:spcPts val="2200"/>
-              </a:spcAft>
-            </a:pPr>
-            <a:r>
-              <a:rPr sz="3000" b="0">
+                <a:spcPts val="1600"/>
+              </a:spcAft>
+            </a:pPr>
+            <a:r>
+              <a:rPr sz="2600" b="0">
                 <a:solidFill>
                   <a:srgbClr val="272A25"/>
                 </a:solidFill>
                 <a:latin typeface="DM Sans"/>
               </a:rPr>
-              <a:t>•  A local link or a repo alone is not a published website.</a:t>
+              <a:t>•  A planet-formation simulator grounded in a course textbook.</a:t>
+            </a:r>
+          </a:p>
+          <a:p>
+            <a:pPr>
+              <a:spcAft>
+                <a:spcPts val="1600"/>
+              </a:spcAft>
+            </a:pPr>
+            <a:r>
+              <a:rPr sz="2600" b="0">
+                <a:solidFill>
+                  <a:srgbClr val="272A25"/>
+                </a:solidFill>
+                <a:latin typeface="DM Sans"/>
+              </a:rPr>
+              <a:t>•  A Canvas browser extension, planned by letting the AI ask 20+ questions first.</a:t>
+            </a:r>
+          </a:p>
+          <a:p>
+            <a:pPr>
+              <a:spcAft>
+                <a:spcPts val="1600"/>
+              </a:spcAft>
+            </a:pPr>
+            <a:r>
+              <a:rPr sz="2600" b="0">
+                <a:solidFill>
+                  <a:srgbClr val="272A25"/>
+                </a:solidFill>
+                <a:latin typeface="DM Sans"/>
+              </a:rPr>
+              <a:t>•  A household assistant, with 3D-printed parts on order.</a:t>
+            </a:r>
+          </a:p>
+          <a:p>
+            <a:pPr>
+              <a:spcAft>
+                <a:spcPts val="1600"/>
+              </a:spcAft>
+            </a:pPr>
+            <a:r>
+              <a:rPr sz="2600" b="0">
+                <a:solidFill>
+                  <a:srgbClr val="272A25"/>
+                </a:solidFill>
+                <a:latin typeface="DM Sans"/>
+              </a:rPr>
+              <a:t>•  A music visualizer where one AI writes prompts for another.</a:t>
             </a:r>
           </a:p>
         </p:txBody>
@@ -7837,7 +7743,7 @@
                 </a:solidFill>
                 <a:latin typeface="DM Sans"/>
               </a:rPr>
-              <a:t>Week 6 · Why this matters        2 / 26</a:t>
+              <a:t>Week 6 · Why this matters        2 / 24</a:t>
             </a:r>
           </a:p>
         </p:txBody>
@@ -7945,7 +7851,7 @@
                 </a:solidFill>
                 <a:latin typeface="Fraunces"/>
               </a:rPr>
-              <a:t>The reading: your AI as a coach</a:t>
+              <a:t>Bring this lesson into your own AI</a:t>
             </a:r>
           </a:p>
         </p:txBody>
@@ -7984,7 +7890,7 @@
                 </a:solidFill>
                 <a:latin typeface="DM Sans"/>
               </a:rPr>
-              <a:t>•  Arielle Shipper · “How to Get Better at AI by Asking AI” · Every</a:t>
+              <a:t>•  Open cu.learnvibe.build → Everything for Week 6.</a:t>
             </a:r>
           </a:p>
           <a:p>
@@ -8000,7 +7906,7 @@
                 </a:solidFill>
                 <a:latin typeface="DM Sans"/>
               </a:rPr>
-              <a:t>•  Ask where you are on the Eight Levels of AI Adoption, with evidence from your work.</a:t>
+              <a:t>•  Click “Copy lesson as markdown”; paste it into Claude or another AI.</a:t>
             </a:r>
           </a:p>
           <a:p>
@@ -8016,7 +7922,7 @@
                 </a:solidFill>
                 <a:latin typeface="DM Sans"/>
               </a:rPr>
-              <a:t>•  Ask for one next step, then: “Teach me that and help me practise.”</a:t>
+              <a:t>•  Ask: “Teach me this and quiz me”—then ask follow-ups in your own words.</a:t>
             </a:r>
           </a:p>
         </p:txBody>
@@ -8055,7 +7961,7 @@
                 </a:solidFill>
                 <a:latin typeface="DM Sans"/>
               </a:rPr>
-              <a:t>Week 6 · Learn with AI        20 / 26</a:t>
+              <a:t>Week 6 · Use the lesson        20 / 24</a:t>
             </a:r>
           </a:p>
         </p:txBody>
@@ -8163,7 +8069,7 @@
                 </a:solidFill>
                 <a:latin typeface="Fraunces"/>
               </a:rPr>
-              <a:t>No long chat history? Bring your own evidence</a:t>
+              <a:t>After the slides: one conversation with Claude</a:t>
             </a:r>
           </a:p>
         </p:txBody>
@@ -8202,7 +8108,7 @@
                 </a:solidFill>
                 <a:latin typeface="DM Sans"/>
               </a:rPr>
-              <a:t>•  Paste your last two submissions or describe a recent project.</a:t>
+              <a:t>•  Aaron will paste the lesson and talk through it with Claude.</a:t>
             </a:r>
           </a:p>
           <a:p>
@@ -8218,7 +8124,7 @@
                 </a:solidFill>
                 <a:latin typeface="DM Sans"/>
               </a:rPr>
-              <a:t>•  Ask: “What can I do already? Show examples. What should I learn next?”</a:t>
+              <a:t>•  The conversation may lead to building a little thing.</a:t>
             </a:r>
           </a:p>
           <a:p>
@@ -8234,7 +8140,7 @@
                 </a:solidFill>
                 <a:latin typeface="DM Sans"/>
               </a:rPr>
-              <a:t>•  Treat the AI’s assessment as a suggestion; correct its assumptions.</a:t>
+              <a:t>•  Watch how questions, context and checking shape the result.</a:t>
             </a:r>
           </a:p>
         </p:txBody>
@@ -8273,7 +8179,7 @@
                 </a:solidFill>
                 <a:latin typeface="DM Sans"/>
               </a:rPr>
-              <a:t>Week 6 · Learn with AI        21 / 26</a:t>
+              <a:t>Week 6 · One live demo        21 / 24</a:t>
             </a:r>
           </a:p>
         </p:txBody>
@@ -8381,7 +8287,7 @@
                 </a:solidFill>
                 <a:latin typeface="Fraunces"/>
               </a:rPr>
-              <a:t>Bring this lesson into your own AI</a:t>
+              <a:t>Optional in-class small-group building</a:t>
             </a:r>
           </a:p>
         </p:txBody>
@@ -8420,7 +8326,7 @@
                 </a:solidFill>
                 <a:latin typeface="DM Sans"/>
               </a:rPr>
-              <a:t>•  Open cu.learnvibe.build → Everything for Week 6.</a:t>
+              <a:t>•  Choose a topic and your own approach; building/sharing is optional.</a:t>
             </a:r>
           </a:p>
           <a:p>
@@ -8436,7 +8342,7 @@
                 </a:solidFill>
                 <a:latin typeface="DM Sans"/>
               </a:rPr>
-              <a:t>•  Click “Copy lesson as markdown”; paste it into Claude or another AI.</a:t>
+              <a:t>•  Make a quiz, interactive explainer, practice tool—or an idea of your own.</a:t>
             </a:r>
           </a:p>
           <a:p>
@@ -8452,7 +8358,7 @@
                 </a:solidFill>
                 <a:latin typeface="DM Sans"/>
               </a:rPr>
-              <a:t>•  Ask: “Teach me this and quiz me”—then ask follow-ups in your own words.</a:t>
+              <a:t>•  Use your AI; try the first version yourselves; check it and revise.</a:t>
             </a:r>
           </a:p>
         </p:txBody>
@@ -8491,7 +8397,7 @@
                 </a:solidFill>
                 <a:latin typeface="DM Sans"/>
               </a:rPr>
-              <a:t>Week 6 · Use the lesson        22 / 26</a:t>
+              <a:t>Week 6 · Group work        22 / 24</a:t>
             </a:r>
           </a:p>
         </p:txBody>
@@ -8593,13 +8499,13 @@
               </a:spcAft>
             </a:pPr>
             <a:r>
-              <a:rPr sz="3200" b="1">
+              <a:rPr sz="4000" b="1">
                 <a:solidFill>
                   <a:srgbClr val="272A25"/>
                 </a:solidFill>
                 <a:latin typeface="Fraunces"/>
               </a:rPr>
-              <a:t>After the slides: one conversation with Claude</a:t>
+              <a:t>How to start—and what to share</a:t>
             </a:r>
           </a:p>
         </p:txBody>
@@ -8638,7 +8544,7 @@
                 </a:solidFill>
                 <a:latin typeface="DM Sans"/>
               </a:rPr>
-              <a:t>•  Aaron will paste the lesson and talk through it with Claude.</a:t>
+              <a:t>•  Give your AI the lesson, your learning question, or both.</a:t>
             </a:r>
           </a:p>
           <a:p>
@@ -8654,7 +8560,7 @@
                 </a:solidFill>
                 <a:latin typeface="DM Sans"/>
               </a:rPr>
-              <a:t>•  The conversation may lead to building a little thing.</a:t>
+              <a:t>•  Ask for a small first version. Test whether it actually helps you learn.</a:t>
             </a:r>
           </a:p>
           <a:p>
@@ -8670,7 +8576,7 @@
                 </a:solidFill>
                 <a:latin typeface="DM Sans"/>
               </a:rPr>
-              <a:t>•  Watch how questions, context and checking shape the result.</a:t>
+              <a:t>•  Show what you made, what you learned, and one thing you checked or changed.</a:t>
             </a:r>
           </a:p>
         </p:txBody>
@@ -8709,7 +8615,7 @@
                 </a:solidFill>
                 <a:latin typeface="DM Sans"/>
               </a:rPr>
-              <a:t>Week 6 · One live demo        23 / 26</a:t>
+              <a:t>Week 6 · Group work        23 / 24</a:t>
             </a:r>
           </a:p>
         </p:txBody>
@@ -8817,7 +8723,7 @@
                 </a:solidFill>
                 <a:latin typeface="Fraunces"/>
               </a:rPr>
-              <a:t>Optional in-class small-group building</a:t>
+              <a:t>This week: ONE PAGE about your learning</a:t>
             </a:r>
           </a:p>
         </p:txBody>
@@ -8846,49 +8752,65 @@
           <a:p>
             <a:pPr>
               <a:spcAft>
-                <a:spcPts val="2200"/>
-              </a:spcAft>
-            </a:pPr>
-            <a:r>
-              <a:rPr sz="3000" b="0">
+                <a:spcPts val="1600"/>
+              </a:spcAft>
+            </a:pPr>
+            <a:r>
+              <a:rPr sz="2600" b="0">
                 <a:solidFill>
                   <a:srgbClr val="272A25"/>
                 </a:solidFill>
                 <a:latin typeface="DM Sans"/>
               </a:rPr>
-              <a:t>•  Choose a topic and your own approach; building/sharing is optional.</a:t>
+              <a:t>•  What you’ve learned, are learning, and want to learn.</a:t>
             </a:r>
           </a:p>
           <a:p>
             <a:pPr>
               <a:spcAft>
-                <a:spcPts val="2200"/>
-              </a:spcAft>
-            </a:pPr>
-            <a:r>
-              <a:rPr sz="3000" b="0">
+                <a:spcPts val="1600"/>
+              </a:spcAft>
+            </a:pPr>
+            <a:r>
+              <a:rPr sz="2600" b="0">
                 <a:solidFill>
                   <a:srgbClr val="272A25"/>
                 </a:solidFill>
                 <a:latin typeface="DM Sans"/>
               </a:rPr>
-              <a:t>•  Make a quiz, interactive explainer, practice tool—or an idea of your own.</a:t>
+              <a:t>•  What you want to build; emerging final-project ideas.</a:t>
             </a:r>
           </a:p>
           <a:p>
             <a:pPr>
               <a:spcAft>
-                <a:spcPts val="2200"/>
-              </a:spcAft>
-            </a:pPr>
-            <a:r>
-              <a:rPr sz="3000" b="0">
+                <a:spcPts val="1600"/>
+              </a:spcAft>
+            </a:pPr>
+            <a:r>
+              <a:rPr sz="2600" b="0">
                 <a:solidFill>
                   <a:srgbClr val="272A25"/>
                 </a:solidFill>
                 <a:latin typeface="DM Sans"/>
               </a:rPr>
-              <a:t>•  Use your AI; try the first version yourselves; check it and revise.</a:t>
+              <a:t>•  Building/sharing is welcome but OPTIONAL—not required.</a:t>
+            </a:r>
+          </a:p>
+          <a:p>
+            <a:pPr>
+              <a:spcAft>
+                <a:spcPts val="1600"/>
+              </a:spcAft>
+            </a:pPr>
+            <a:r>
+              <a:rPr sz="2600" b="0">
+                <a:solidFill>
+                  <a:srgbClr val="272A25"/>
+                </a:solidFill>
+                <a:latin typeface="DM Sans"/>
+              </a:rPr>
+              <a:t>•  Your reflections will shape consistent peer pods for at least three weeks.</a:t>
             </a:r>
           </a:p>
         </p:txBody>
@@ -8927,459 +8849,7 @@
                 </a:solidFill>
                 <a:latin typeface="DM Sans"/>
               </a:rPr>
-              <a:t>Week 6 · Group work        24 / 26</a:t>
-            </a:r>
-          </a:p>
-        </p:txBody>
-      </p:sp>
-    </p:spTree>
-  </p:cSld>
-  <p:clrMapOvr>
-    <a:masterClrMapping/>
-  </p:clrMapOvr>
-</p:sld>
-</file>
-
-<file path=ppt/slides/slide25.xml><?xml version="1.0" encoding="utf-8"?>
-<p:sld xmlns:a="http://schemas.openxmlformats.org/drawingml/2006/main" xmlns:p="http://schemas.openxmlformats.org/presentationml/2006/main" xmlns:r="http://schemas.openxmlformats.org/officeDocument/2006/relationships">
-  <p:cSld>
-    <p:bg>
-      <p:bgPr>
-        <a:solidFill>
-          <a:srgbClr val="F7F5EE"/>
-        </a:solidFill>
-        <a:effectLst/>
-      </p:bgPr>
-    </p:bg>
-    <p:spTree>
-      <p:nvGrpSpPr>
-        <p:cNvPr id="1" name=""/>
-        <p:cNvGrpSpPr/>
-        <p:nvPr/>
-      </p:nvGrpSpPr>
-      <p:grpSpPr/>
-      <p:sp>
-        <p:nvSpPr>
-          <p:cNvPr id="2" name="Rectangle 1"/>
-          <p:cNvSpPr/>
-          <p:nvPr/>
-        </p:nvSpPr>
-        <p:spPr>
-          <a:xfrm>
-            <a:off x="0" y="0"/>
-            <a:ext cx="228600" cy="6858000"/>
-          </a:xfrm>
-          <a:prstGeom prst="rect">
-            <a:avLst/>
-          </a:prstGeom>
-          <a:solidFill>
-            <a:srgbClr val="A83D2B"/>
-          </a:solidFill>
-          <a:ln>
-            <a:noFill/>
-          </a:ln>
-        </p:spPr>
-        <p:style>
-          <a:lnRef idx="1">
-            <a:schemeClr val="accent1"/>
-          </a:lnRef>
-          <a:fillRef idx="3">
-            <a:schemeClr val="accent1"/>
-          </a:fillRef>
-          <a:effectRef idx="2">
-            <a:schemeClr val="accent1"/>
-          </a:effectRef>
-          <a:fontRef idx="minor">
-            <a:schemeClr val="lt1"/>
-          </a:fontRef>
-        </p:style>
-        <p:txBody>
-          <a:bodyPr rtlCol="0" anchor="ctr"/>
-          <a:lstStyle/>
-          <a:p>
-            <a:pPr algn="ctr"/>
-          </a:p>
-        </p:txBody>
-      </p:sp>
-      <p:sp>
-        <p:nvSpPr>
-          <p:cNvPr id="3" name="TextBox 2"/>
-          <p:cNvSpPr txBox="1"/>
-          <p:nvPr/>
-        </p:nvSpPr>
-        <p:spPr>
-          <a:xfrm>
-            <a:off x="822960" y="548640"/>
-            <a:ext cx="10607040" cy="1188720"/>
-          </a:xfrm>
-          <a:prstGeom prst="rect">
-            <a:avLst/>
-          </a:prstGeom>
-          <a:noFill/>
-        </p:spPr>
-        <p:txBody>
-          <a:bodyPr wrap="square">
-            <a:spAutoFit/>
-          </a:bodyPr>
-          <a:lstStyle/>
-          <a:p>
-            <a:pPr>
-              <a:spcAft>
-                <a:spcPts val="1400"/>
-              </a:spcAft>
-            </a:pPr>
-            <a:r>
-              <a:rPr sz="4000" b="1">
-                <a:solidFill>
-                  <a:srgbClr val="272A25"/>
-                </a:solidFill>
-                <a:latin typeface="Fraunces"/>
-              </a:rPr>
-              <a:t>How to start—and what to share</a:t>
-            </a:r>
-          </a:p>
-        </p:txBody>
-      </p:sp>
-      <p:sp>
-        <p:nvSpPr>
-          <p:cNvPr id="4" name="TextBox 3"/>
-          <p:cNvSpPr txBox="1"/>
-          <p:nvPr/>
-        </p:nvSpPr>
-        <p:spPr>
-          <a:xfrm>
-            <a:off x="822960" y="2011680"/>
-            <a:ext cx="10607040" cy="4206240"/>
-          </a:xfrm>
-          <a:prstGeom prst="rect">
-            <a:avLst/>
-          </a:prstGeom>
-          <a:noFill/>
-        </p:spPr>
-        <p:txBody>
-          <a:bodyPr wrap="square">
-            <a:spAutoFit/>
-          </a:bodyPr>
-          <a:lstStyle/>
-          <a:p>
-            <a:pPr>
-              <a:spcAft>
-                <a:spcPts val="2200"/>
-              </a:spcAft>
-            </a:pPr>
-            <a:r>
-              <a:rPr sz="3000" b="0">
-                <a:solidFill>
-                  <a:srgbClr val="272A25"/>
-                </a:solidFill>
-                <a:latin typeface="DM Sans"/>
-              </a:rPr>
-              <a:t>•  Give your AI the lesson, your learning question, or both.</a:t>
-            </a:r>
-          </a:p>
-          <a:p>
-            <a:pPr>
-              <a:spcAft>
-                <a:spcPts val="2200"/>
-              </a:spcAft>
-            </a:pPr>
-            <a:r>
-              <a:rPr sz="3000" b="0">
-                <a:solidFill>
-                  <a:srgbClr val="272A25"/>
-                </a:solidFill>
-                <a:latin typeface="DM Sans"/>
-              </a:rPr>
-              <a:t>•  Ask for a small first version. Test whether it actually helps you learn.</a:t>
-            </a:r>
-          </a:p>
-          <a:p>
-            <a:pPr>
-              <a:spcAft>
-                <a:spcPts val="2200"/>
-              </a:spcAft>
-            </a:pPr>
-            <a:r>
-              <a:rPr sz="3000" b="0">
-                <a:solidFill>
-                  <a:srgbClr val="272A25"/>
-                </a:solidFill>
-                <a:latin typeface="DM Sans"/>
-              </a:rPr>
-              <a:t>•  Show what you made, what you learned, and one thing you checked or changed.</a:t>
-            </a:r>
-          </a:p>
-        </p:txBody>
-      </p:sp>
-      <p:sp>
-        <p:nvSpPr>
-          <p:cNvPr id="5" name="TextBox 4"/>
-          <p:cNvSpPr txBox="1"/>
-          <p:nvPr/>
-        </p:nvSpPr>
-        <p:spPr>
-          <a:xfrm>
-            <a:off x="822960" y="6263640"/>
-            <a:ext cx="10607040" cy="365760"/>
-          </a:xfrm>
-          <a:prstGeom prst="rect">
-            <a:avLst/>
-          </a:prstGeom>
-          <a:noFill/>
-        </p:spPr>
-        <p:txBody>
-          <a:bodyPr wrap="square">
-            <a:spAutoFit/>
-          </a:bodyPr>
-          <a:lstStyle/>
-          <a:p>
-            <a:pPr algn="r">
-              <a:spcAft>
-                <a:spcPts val="1400"/>
-              </a:spcAft>
-            </a:pPr>
-            <a:r>
-              <a:rPr sz="1600" b="0">
-                <a:solidFill>
-                  <a:srgbClr val="64665D"/>
-                </a:solidFill>
-                <a:latin typeface="DM Sans"/>
-              </a:rPr>
-              <a:t>Week 6 · Group work        25 / 26</a:t>
-            </a:r>
-          </a:p>
-        </p:txBody>
-      </p:sp>
-    </p:spTree>
-  </p:cSld>
-  <p:clrMapOvr>
-    <a:masterClrMapping/>
-  </p:clrMapOvr>
-</p:sld>
-</file>
-
-<file path=ppt/slides/slide26.xml><?xml version="1.0" encoding="utf-8"?>
-<p:sld xmlns:a="http://schemas.openxmlformats.org/drawingml/2006/main" xmlns:p="http://schemas.openxmlformats.org/presentationml/2006/main" xmlns:r="http://schemas.openxmlformats.org/officeDocument/2006/relationships">
-  <p:cSld>
-    <p:bg>
-      <p:bgPr>
-        <a:solidFill>
-          <a:srgbClr val="F7F5EE"/>
-        </a:solidFill>
-        <a:effectLst/>
-      </p:bgPr>
-    </p:bg>
-    <p:spTree>
-      <p:nvGrpSpPr>
-        <p:cNvPr id="1" name=""/>
-        <p:cNvGrpSpPr/>
-        <p:nvPr/>
-      </p:nvGrpSpPr>
-      <p:grpSpPr/>
-      <p:sp>
-        <p:nvSpPr>
-          <p:cNvPr id="2" name="Rectangle 1"/>
-          <p:cNvSpPr/>
-          <p:nvPr/>
-        </p:nvSpPr>
-        <p:spPr>
-          <a:xfrm>
-            <a:off x="0" y="0"/>
-            <a:ext cx="228600" cy="6858000"/>
-          </a:xfrm>
-          <a:prstGeom prst="rect">
-            <a:avLst/>
-          </a:prstGeom>
-          <a:solidFill>
-            <a:srgbClr val="A83D2B"/>
-          </a:solidFill>
-          <a:ln>
-            <a:noFill/>
-          </a:ln>
-        </p:spPr>
-        <p:style>
-          <a:lnRef idx="1">
-            <a:schemeClr val="accent1"/>
-          </a:lnRef>
-          <a:fillRef idx="3">
-            <a:schemeClr val="accent1"/>
-          </a:fillRef>
-          <a:effectRef idx="2">
-            <a:schemeClr val="accent1"/>
-          </a:effectRef>
-          <a:fontRef idx="minor">
-            <a:schemeClr val="lt1"/>
-          </a:fontRef>
-        </p:style>
-        <p:txBody>
-          <a:bodyPr rtlCol="0" anchor="ctr"/>
-          <a:lstStyle/>
-          <a:p>
-            <a:pPr algn="ctr"/>
-          </a:p>
-        </p:txBody>
-      </p:sp>
-      <p:sp>
-        <p:nvSpPr>
-          <p:cNvPr id="3" name="TextBox 2"/>
-          <p:cNvSpPr txBox="1"/>
-          <p:nvPr/>
-        </p:nvSpPr>
-        <p:spPr>
-          <a:xfrm>
-            <a:off x="822960" y="548640"/>
-            <a:ext cx="10607040" cy="1188720"/>
-          </a:xfrm>
-          <a:prstGeom prst="rect">
-            <a:avLst/>
-          </a:prstGeom>
-          <a:noFill/>
-        </p:spPr>
-        <p:txBody>
-          <a:bodyPr wrap="square">
-            <a:spAutoFit/>
-          </a:bodyPr>
-          <a:lstStyle/>
-          <a:p>
-            <a:pPr>
-              <a:spcAft>
-                <a:spcPts val="1400"/>
-              </a:spcAft>
-            </a:pPr>
-            <a:r>
-              <a:rPr sz="4000" b="1">
-                <a:solidFill>
-                  <a:srgbClr val="272A25"/>
-                </a:solidFill>
-                <a:latin typeface="Fraunces"/>
-              </a:rPr>
-              <a:t>This week: ONE PAGE about your learning</a:t>
-            </a:r>
-          </a:p>
-        </p:txBody>
-      </p:sp>
-      <p:sp>
-        <p:nvSpPr>
-          <p:cNvPr id="4" name="TextBox 3"/>
-          <p:cNvSpPr txBox="1"/>
-          <p:nvPr/>
-        </p:nvSpPr>
-        <p:spPr>
-          <a:xfrm>
-            <a:off x="822960" y="2011680"/>
-            <a:ext cx="10607040" cy="4206240"/>
-          </a:xfrm>
-          <a:prstGeom prst="rect">
-            <a:avLst/>
-          </a:prstGeom>
-          <a:noFill/>
-        </p:spPr>
-        <p:txBody>
-          <a:bodyPr wrap="square">
-            <a:spAutoFit/>
-          </a:bodyPr>
-          <a:lstStyle/>
-          <a:p>
-            <a:pPr>
-              <a:spcAft>
-                <a:spcPts val="1600"/>
-              </a:spcAft>
-            </a:pPr>
-            <a:r>
-              <a:rPr sz="2600" b="0">
-                <a:solidFill>
-                  <a:srgbClr val="272A25"/>
-                </a:solidFill>
-                <a:latin typeface="DM Sans"/>
-              </a:rPr>
-              <a:t>•  What you’ve learned, are learning, and want to learn.</a:t>
-            </a:r>
-          </a:p>
-          <a:p>
-            <a:pPr>
-              <a:spcAft>
-                <a:spcPts val="1600"/>
-              </a:spcAft>
-            </a:pPr>
-            <a:r>
-              <a:rPr sz="2600" b="0">
-                <a:solidFill>
-                  <a:srgbClr val="272A25"/>
-                </a:solidFill>
-                <a:latin typeface="DM Sans"/>
-              </a:rPr>
-              <a:t>•  What you want to build; emerging final-project ideas.</a:t>
-            </a:r>
-          </a:p>
-          <a:p>
-            <a:pPr>
-              <a:spcAft>
-                <a:spcPts val="1600"/>
-              </a:spcAft>
-            </a:pPr>
-            <a:r>
-              <a:rPr sz="2600" b="0">
-                <a:solidFill>
-                  <a:srgbClr val="272A25"/>
-                </a:solidFill>
-                <a:latin typeface="DM Sans"/>
-              </a:rPr>
-              <a:t>•  Building/sharing is welcome but OPTIONAL—not required.</a:t>
-            </a:r>
-          </a:p>
-          <a:p>
-            <a:pPr>
-              <a:spcAft>
-                <a:spcPts val="1600"/>
-              </a:spcAft>
-            </a:pPr>
-            <a:r>
-              <a:rPr sz="2600" b="0">
-                <a:solidFill>
-                  <a:srgbClr val="272A25"/>
-                </a:solidFill>
-                <a:latin typeface="DM Sans"/>
-              </a:rPr>
-              <a:t>•  Your reflections will shape consistent peer pods for at least three weeks.</a:t>
-            </a:r>
-          </a:p>
-        </p:txBody>
-      </p:sp>
-      <p:sp>
-        <p:nvSpPr>
-          <p:cNvPr id="5" name="TextBox 4"/>
-          <p:cNvSpPr txBox="1"/>
-          <p:nvPr/>
-        </p:nvSpPr>
-        <p:spPr>
-          <a:xfrm>
-            <a:off x="822960" y="6263640"/>
-            <a:ext cx="10607040" cy="365760"/>
-          </a:xfrm>
-          <a:prstGeom prst="rect">
-            <a:avLst/>
-          </a:prstGeom>
-          <a:noFill/>
-        </p:spPr>
-        <p:txBody>
-          <a:bodyPr wrap="square">
-            <a:spAutoFit/>
-          </a:bodyPr>
-          <a:lstStyle/>
-          <a:p>
-            <a:pPr algn="r">
-              <a:spcAft>
-                <a:spcPts val="1400"/>
-              </a:spcAft>
-            </a:pPr>
-            <a:r>
-              <a:rPr sz="1600" b="0">
-                <a:solidFill>
-                  <a:srgbClr val="64665D"/>
-                </a:solidFill>
-                <a:latin typeface="DM Sans"/>
-              </a:rPr>
-              <a:t>Week 6 · Weekly assignment        26 / 26</a:t>
+              <a:t>Week 6 · Weekly assignment        24 / 24</a:t>
             </a:r>
           </a:p>
         </p:txBody>
@@ -9487,7 +8957,7 @@
                 </a:solidFill>
                 <a:latin typeface="Fraunces"/>
               </a:rPr>
-              <a:t>Markdown: readable, portable text</a:t>
+              <a:t>What you’ve been running into</a:t>
             </a:r>
           </a:p>
         </p:txBody>
@@ -9516,49 +8986,81 @@
           <a:p>
             <a:pPr>
               <a:spcAft>
-                <a:spcPts val="2200"/>
-              </a:spcAft>
-            </a:pPr>
-            <a:r>
-              <a:rPr sz="3000" b="0">
+                <a:spcPts val="1600"/>
+              </a:spcAft>
+            </a:pPr>
+            <a:r>
+              <a:rPr sz="2600" b="0">
                 <a:solidFill>
                   <a:srgbClr val="272A25"/>
                 </a:solidFill>
                 <a:latin typeface="DM Sans"/>
               </a:rPr>
-              <a:t>•  A .md file is a plain-text file—not a special app or database.</a:t>
+              <a:t>•  Getting the AI to build what you actually pictured.</a:t>
             </a:r>
           </a:p>
           <a:p>
             <a:pPr>
               <a:spcAft>
-                <a:spcPts val="2200"/>
-              </a:spcAft>
-            </a:pPr>
-            <a:r>
-              <a:rPr sz="3000" b="0">
+                <a:spcPts val="1600"/>
+              </a:spcAft>
+            </a:pPr>
+            <a:r>
+              <a:rPr sz="2600" b="0">
                 <a:solidFill>
                   <a:srgbClr val="272A25"/>
                 </a:solidFill>
                 <a:latin typeface="DM Sans"/>
               </a:rPr>
-              <a:t>•  A little punctuation adds structure: headings, lists, links, code.</a:t>
+              <a:t>•  Links that work for you but not for anyone else.</a:t>
             </a:r>
           </a:p>
           <a:p>
             <a:pPr>
               <a:spcAft>
-                <a:spcPts val="2200"/>
-              </a:spcAft>
-            </a:pPr>
-            <a:r>
-              <a:rPr sz="3000" b="0">
+                <a:spcPts val="1600"/>
+              </a:spcAft>
+            </a:pPr>
+            <a:r>
+              <a:rPr sz="2600" b="0">
                 <a:solidFill>
                   <a:srgbClr val="272A25"/>
                 </a:solidFill>
                 <a:latin typeface="DM Sans"/>
               </a:rPr>
-              <a:t>•  Read it in an editor, render it as a page, or paste it into your AI.</a:t>
+              <a:t>•  Running out of free credits mid-build.</a:t>
+            </a:r>
+          </a:p>
+          <a:p>
+            <a:pPr>
+              <a:spcAft>
+                <a:spcPts val="1600"/>
+              </a:spcAft>
+            </a:pPr>
+            <a:r>
+              <a:rPr sz="2600" b="0">
+                <a:solidFill>
+                  <a:srgbClr val="272A25"/>
+                </a:solidFill>
+                <a:latin typeface="DM Sans"/>
+              </a:rPr>
+              <a:t>•  Very different starting points—and that is fine.</a:t>
+            </a:r>
+          </a:p>
+          <a:p>
+            <a:pPr>
+              <a:spcAft>
+                <a:spcPts val="1600"/>
+              </a:spcAft>
+            </a:pPr>
+            <a:r>
+              <a:rPr sz="2600" b="0">
+                <a:solidFill>
+                  <a:srgbClr val="272A25"/>
+                </a:solidFill>
+                <a:latin typeface="DM Sans"/>
+              </a:rPr>
+              <a:t>•  Tonight: the foundations behind each of these.</a:t>
             </a:r>
           </a:p>
         </p:txBody>
@@ -9597,7 +9099,7 @@
                 </a:solidFill>
                 <a:latin typeface="DM Sans"/>
               </a:rPr>
-              <a:t>Week 6 · Markdown        3 / 26</a:t>
+              <a:t>Week 6 · Where we are        3 / 24</a:t>
             </a:r>
           </a:p>
         </p:txBody>
@@ -9705,64 +9207,21 @@
                 </a:solidFill>
                 <a:latin typeface="Fraunces"/>
               </a:rPr>
-              <a:t>Markdown you can read and write</a:t>
-            </a:r>
-          </a:p>
-        </p:txBody>
-      </p:sp>
-      <p:sp>
-        <p:nvSpPr>
-          <p:cNvPr id="4" name="Rectangle 3"/>
-          <p:cNvSpPr/>
-          <p:nvPr/>
-        </p:nvSpPr>
-        <p:spPr>
-          <a:xfrm>
-            <a:off x="822960" y="1828800"/>
-            <a:ext cx="6583680" cy="4023360"/>
-          </a:xfrm>
-          <a:prstGeom prst="rect">
-            <a:avLst/>
-          </a:prstGeom>
-          <a:solidFill>
-            <a:srgbClr val="EEECE2"/>
-          </a:solidFill>
-          <a:ln>
-            <a:noFill/>
-          </a:ln>
-        </p:spPr>
-        <p:style>
-          <a:lnRef idx="1">
-            <a:schemeClr val="accent1"/>
-          </a:lnRef>
-          <a:fillRef idx="3">
-            <a:schemeClr val="accent1"/>
-          </a:fillRef>
-          <a:effectRef idx="2">
-            <a:schemeClr val="accent1"/>
-          </a:effectRef>
-          <a:fontRef idx="minor">
-            <a:schemeClr val="lt1"/>
-          </a:fontRef>
-        </p:style>
-        <p:txBody>
-          <a:bodyPr rtlCol="0" anchor="ctr"/>
-          <a:lstStyle/>
-          <a:p>
-            <a:pPr algn="ctr"/>
-          </a:p>
-        </p:txBody>
-      </p:sp>
-      <p:sp>
-        <p:nvSpPr>
-          <p:cNvPr id="5" name="TextBox 4"/>
+              <a:t>Markdown: readable, portable text</a:t>
+            </a:r>
+          </a:p>
+        </p:txBody>
+      </p:sp>
+      <p:sp>
+        <p:nvSpPr>
+          <p:cNvPr id="4" name="TextBox 3"/>
           <p:cNvSpPr txBox="1"/>
           <p:nvPr/>
         </p:nvSpPr>
         <p:spPr>
           <a:xfrm>
-            <a:off x="1097280" y="2011680"/>
-            <a:ext cx="6217920" cy="3749039"/>
+            <a:off x="822960" y="2011680"/>
+            <a:ext cx="10607040" cy="4206240"/>
           </a:xfrm>
           <a:prstGeom prst="rect">
             <a:avLst/>
@@ -9777,95 +9236,63 @@
           <a:p>
             <a:pPr>
               <a:spcAft>
-                <a:spcPts val="200"/>
-              </a:spcAft>
-            </a:pPr>
-            <a:r>
-              <a:rPr sz="1800" b="0">
+                <a:spcPts val="2200"/>
+              </a:spcAft>
+            </a:pPr>
+            <a:r>
+              <a:rPr sz="3000" b="0">
                 <a:solidFill>
                   <a:srgbClr val="272A25"/>
                 </a:solidFill>
-                <a:latin typeface="DejaVu Sans Mono"/>
-              </a:rPr>
-              <a:t># Project notes</a:t>
+                <a:latin typeface="DM Sans"/>
+              </a:rPr>
+              <a:t>•  A .md file is a plain-text file—not a special app or database.</a:t>
             </a:r>
           </a:p>
           <a:p>
             <a:pPr>
               <a:spcAft>
-                <a:spcPts val="200"/>
-              </a:spcAft>
-            </a:pPr>
-            <a:r>
-              <a:rPr sz="1800" b="0">
+                <a:spcPts val="2200"/>
+              </a:spcAft>
+            </a:pPr>
+            <a:r>
+              <a:rPr sz="3000" b="0">
                 <a:solidFill>
                   <a:srgbClr val="272A25"/>
                 </a:solidFill>
-                <a:latin typeface="DejaVu Sans Mono"/>
-              </a:rPr>
-              <a:t>## What I want to learn</a:t>
+                <a:latin typeface="DM Sans"/>
+              </a:rPr>
+              <a:t>•  A little punctuation adds structure: headings, lists, links, code.</a:t>
             </a:r>
           </a:p>
           <a:p>
             <a:pPr>
               <a:spcAft>
-                <a:spcPts val="200"/>
-              </a:spcAft>
-            </a:pPr>
-            <a:r>
-              <a:rPr sz="1800" b="0">
+                <a:spcPts val="2200"/>
+              </a:spcAft>
+            </a:pPr>
+            <a:r>
+              <a:rPr sz="3000" b="0">
                 <a:solidFill>
                   <a:srgbClr val="272A25"/>
                 </a:solidFill>
-                <a:latin typeface="DejaVu Sans Mono"/>
-              </a:rPr>
-              <a:t>- Explain commits before changing files.</a:t>
-            </a:r>
-          </a:p>
-          <a:p>
-            <a:pPr>
-              <a:spcAft>
-                <a:spcPts val="200"/>
-              </a:spcAft>
-            </a:pPr>
-            <a:r>
-              <a:rPr sz="1800" b="0">
-                <a:solidFill>
-                  <a:srgbClr val="272A25"/>
-                </a:solidFill>
-                <a:latin typeface="DejaVu Sans Mono"/>
-              </a:rPr>
-              <a:t>[Course lesson](https://cu.learnvibe.build/lessons/week-6/)</a:t>
-            </a:r>
-          </a:p>
-          <a:p>
-            <a:pPr>
-              <a:spcAft>
-                <a:spcPts val="200"/>
-              </a:spcAft>
-            </a:pPr>
-            <a:r>
-              <a:rPr sz="1800" b="0">
-                <a:solidFill>
-                  <a:srgbClr val="272A25"/>
-                </a:solidFill>
-                <a:latin typeface="DejaVu Sans Mono"/>
-              </a:rPr>
-              <a:t>Use `git status` to see what changed.</a:t>
-            </a:r>
-          </a:p>
-        </p:txBody>
-      </p:sp>
-      <p:sp>
-        <p:nvSpPr>
-          <p:cNvPr id="6" name="TextBox 5"/>
+                <a:latin typeface="DM Sans"/>
+              </a:rPr>
+              <a:t>•  Read it in an editor, render it as a page, or paste it into your AI.</a:t>
+            </a:r>
+          </a:p>
+        </p:txBody>
+      </p:sp>
+      <p:sp>
+        <p:nvSpPr>
+          <p:cNvPr id="5" name="TextBox 4"/>
           <p:cNvSpPr txBox="1"/>
           <p:nvPr/>
         </p:nvSpPr>
         <p:spPr>
           <a:xfrm>
-            <a:off x="7772400" y="3108960"/>
-            <a:ext cx="3931920" cy="1828800"/>
+            <a:off x="822960" y="6263640"/>
+            <a:ext cx="10607040" cy="365760"/>
           </a:xfrm>
           <a:prstGeom prst="rect">
             <a:avLst/>
@@ -9878,58 +9305,19 @@
           </a:bodyPr>
           <a:lstStyle/>
           <a:p>
-            <a:pPr>
+            <a:pPr algn="r">
               <a:spcAft>
                 <a:spcPts val="1400"/>
               </a:spcAft>
             </a:pPr>
             <a:r>
-              <a:rPr sz="2800" b="0">
+              <a:rPr sz="1600" b="0">
                 <a:solidFill>
                   <a:srgbClr val="64665D"/>
                 </a:solidFill>
                 <a:latin typeface="DM Sans"/>
               </a:rPr>
-              <a:t>Headings, lists, links, and code—with plain text underneath.</a:t>
-            </a:r>
-          </a:p>
-        </p:txBody>
-      </p:sp>
-      <p:sp>
-        <p:nvSpPr>
-          <p:cNvPr id="7" name="TextBox 6"/>
-          <p:cNvSpPr txBox="1"/>
-          <p:nvPr/>
-        </p:nvSpPr>
-        <p:spPr>
-          <a:xfrm>
-            <a:off x="822960" y="6263640"/>
-            <a:ext cx="10607040" cy="365760"/>
-          </a:xfrm>
-          <a:prstGeom prst="rect">
-            <a:avLst/>
-          </a:prstGeom>
-          <a:noFill/>
-        </p:spPr>
-        <p:txBody>
-          <a:bodyPr wrap="square">
-            <a:spAutoFit/>
-          </a:bodyPr>
-          <a:lstStyle/>
-          <a:p>
-            <a:pPr algn="r">
-              <a:spcAft>
-                <a:spcPts val="1400"/>
-              </a:spcAft>
-            </a:pPr>
-            <a:r>
-              <a:rPr sz="1600" b="0">
-                <a:solidFill>
-                  <a:srgbClr val="64665D"/>
-                </a:solidFill>
-                <a:latin typeface="DM Sans"/>
-              </a:rPr>
-              <a:t>Week 6 · Markdown        4 / 26</a:t>
+              <a:t>Week 6 · Markdown        4 / 24</a:t>
             </a:r>
           </a:p>
         </p:txBody>
@@ -10037,21 +9425,64 @@
                 </a:solidFill>
                 <a:latin typeface="Fraunces"/>
               </a:rPr>
-              <a:t>Context: what the AI can actually see</a:t>
-            </a:r>
-          </a:p>
-        </p:txBody>
-      </p:sp>
-      <p:sp>
-        <p:nvSpPr>
-          <p:cNvPr id="4" name="TextBox 3"/>
+              <a:t>Markdown you can read and write</a:t>
+            </a:r>
+          </a:p>
+        </p:txBody>
+      </p:sp>
+      <p:sp>
+        <p:nvSpPr>
+          <p:cNvPr id="4" name="Rectangle 3"/>
+          <p:cNvSpPr/>
+          <p:nvPr/>
+        </p:nvSpPr>
+        <p:spPr>
+          <a:xfrm>
+            <a:off x="822960" y="1828800"/>
+            <a:ext cx="6583680" cy="4023360"/>
+          </a:xfrm>
+          <a:prstGeom prst="rect">
+            <a:avLst/>
+          </a:prstGeom>
+          <a:solidFill>
+            <a:srgbClr val="EEECE2"/>
+          </a:solidFill>
+          <a:ln>
+            <a:noFill/>
+          </a:ln>
+        </p:spPr>
+        <p:style>
+          <a:lnRef idx="1">
+            <a:schemeClr val="accent1"/>
+          </a:lnRef>
+          <a:fillRef idx="3">
+            <a:schemeClr val="accent1"/>
+          </a:fillRef>
+          <a:effectRef idx="2">
+            <a:schemeClr val="accent1"/>
+          </a:effectRef>
+          <a:fontRef idx="minor">
+            <a:schemeClr val="lt1"/>
+          </a:fontRef>
+        </p:style>
+        <p:txBody>
+          <a:bodyPr rtlCol="0" anchor="ctr"/>
+          <a:lstStyle/>
+          <a:p>
+            <a:pPr algn="ctr"/>
+          </a:p>
+        </p:txBody>
+      </p:sp>
+      <p:sp>
+        <p:nvSpPr>
+          <p:cNvPr id="5" name="TextBox 4"/>
           <p:cNvSpPr txBox="1"/>
           <p:nvPr/>
         </p:nvSpPr>
         <p:spPr>
           <a:xfrm>
-            <a:off x="822960" y="2011680"/>
-            <a:ext cx="10607040" cy="4206240"/>
+            <a:off x="1097280" y="2011680"/>
+            <a:ext cx="6217920" cy="3749039"/>
           </a:xfrm>
           <a:prstGeom prst="rect">
             <a:avLst/>
@@ -10066,63 +9497,95 @@
           <a:p>
             <a:pPr>
               <a:spcAft>
-                <a:spcPts val="2200"/>
-              </a:spcAft>
-            </a:pPr>
-            <a:r>
-              <a:rPr sz="3000" b="0">
+                <a:spcPts val="200"/>
+              </a:spcAft>
+            </a:pPr>
+            <a:r>
+              <a:rPr sz="1800" b="0">
                 <a:solidFill>
                   <a:srgbClr val="272A25"/>
                 </a:solidFill>
-                <a:latin typeface="DM Sans"/>
-              </a:rPr>
-              <a:t>•  Its answer depends on the messages, files and tool results available now.</a:t>
+                <a:latin typeface="DejaVu Sans Mono"/>
+              </a:rPr>
+              <a:t># Project notes</a:t>
             </a:r>
           </a:p>
           <a:p>
             <a:pPr>
               <a:spcAft>
-                <a:spcPts val="2200"/>
-              </a:spcAft>
-            </a:pPr>
-            <a:r>
-              <a:rPr sz="3000" b="0">
+                <a:spcPts val="200"/>
+              </a:spcAft>
+            </a:pPr>
+            <a:r>
+              <a:rPr sz="1800" b="0">
                 <a:solidFill>
                   <a:srgbClr val="272A25"/>
                 </a:solidFill>
-                <a:latin typeface="DM Sans"/>
-              </a:rPr>
-              <a:t>•  It does not automatically know your audience, preferences or project history.</a:t>
+                <a:latin typeface="DejaVu Sans Mono"/>
+              </a:rPr>
+              <a:t>## What I want to learn</a:t>
             </a:r>
           </a:p>
           <a:p>
             <a:pPr>
               <a:spcAft>
-                <a:spcPts val="2200"/>
-              </a:spcAft>
-            </a:pPr>
-            <a:r>
-              <a:rPr sz="3000" b="0">
+                <a:spcPts val="200"/>
+              </a:spcAft>
+            </a:pPr>
+            <a:r>
+              <a:rPr sz="1800" b="0">
                 <a:solidFill>
                   <a:srgbClr val="272A25"/>
                 </a:solidFill>
-                <a:latin typeface="DM Sans"/>
-              </a:rPr>
-              <a:t>•  “Improve my site” is weaker than a clear audience, goal and example.</a:t>
-            </a:r>
-          </a:p>
-        </p:txBody>
-      </p:sp>
-      <p:sp>
-        <p:nvSpPr>
-          <p:cNvPr id="5" name="TextBox 4"/>
+                <a:latin typeface="DejaVu Sans Mono"/>
+              </a:rPr>
+              <a:t>- Explain commits before changing files.</a:t>
+            </a:r>
+          </a:p>
+          <a:p>
+            <a:pPr>
+              <a:spcAft>
+                <a:spcPts val="200"/>
+              </a:spcAft>
+            </a:pPr>
+            <a:r>
+              <a:rPr sz="1800" b="0">
+                <a:solidFill>
+                  <a:srgbClr val="272A25"/>
+                </a:solidFill>
+                <a:latin typeface="DejaVu Sans Mono"/>
+              </a:rPr>
+              <a:t>[Course lesson](https://cu.learnvibe.build/lessons/week-6/)</a:t>
+            </a:r>
+          </a:p>
+          <a:p>
+            <a:pPr>
+              <a:spcAft>
+                <a:spcPts val="200"/>
+              </a:spcAft>
+            </a:pPr>
+            <a:r>
+              <a:rPr sz="1800" b="0">
+                <a:solidFill>
+                  <a:srgbClr val="272A25"/>
+                </a:solidFill>
+                <a:latin typeface="DejaVu Sans Mono"/>
+              </a:rPr>
+              <a:t>Use `git status` to see what changed.</a:t>
+            </a:r>
+          </a:p>
+        </p:txBody>
+      </p:sp>
+      <p:sp>
+        <p:nvSpPr>
+          <p:cNvPr id="6" name="TextBox 5"/>
           <p:cNvSpPr txBox="1"/>
           <p:nvPr/>
         </p:nvSpPr>
         <p:spPr>
           <a:xfrm>
-            <a:off x="822960" y="6263640"/>
-            <a:ext cx="10607040" cy="365760"/>
+            <a:off x="7772400" y="3108960"/>
+            <a:ext cx="3931920" cy="1828800"/>
           </a:xfrm>
           <a:prstGeom prst="rect">
             <a:avLst/>
@@ -10135,6 +9598,45 @@
           </a:bodyPr>
           <a:lstStyle/>
           <a:p>
+            <a:pPr>
+              <a:spcAft>
+                <a:spcPts val="1400"/>
+              </a:spcAft>
+            </a:pPr>
+            <a:r>
+              <a:rPr sz="2800" b="0">
+                <a:solidFill>
+                  <a:srgbClr val="64665D"/>
+                </a:solidFill>
+                <a:latin typeface="DM Sans"/>
+              </a:rPr>
+              <a:t>Headings, lists, links, and code—with plain text underneath.</a:t>
+            </a:r>
+          </a:p>
+        </p:txBody>
+      </p:sp>
+      <p:sp>
+        <p:nvSpPr>
+          <p:cNvPr id="7" name="TextBox 6"/>
+          <p:cNvSpPr txBox="1"/>
+          <p:nvPr/>
+        </p:nvSpPr>
+        <p:spPr>
+          <a:xfrm>
+            <a:off x="822960" y="6263640"/>
+            <a:ext cx="10607040" cy="365760"/>
+          </a:xfrm>
+          <a:prstGeom prst="rect">
+            <a:avLst/>
+          </a:prstGeom>
+          <a:noFill/>
+        </p:spPr>
+        <p:txBody>
+          <a:bodyPr wrap="square">
+            <a:spAutoFit/>
+          </a:bodyPr>
+          <a:lstStyle/>
+          <a:p>
             <a:pPr algn="r">
               <a:spcAft>
                 <a:spcPts val="1400"/>
@@ -10147,7 +9649,7 @@
                 </a:solidFill>
                 <a:latin typeface="DM Sans"/>
               </a:rPr>
-              <a:t>Week 6 · Ongoing context        5 / 26</a:t>
+              <a:t>Week 6 · Markdown        5 / 24</a:t>
             </a:r>
           </a:p>
         </p:txBody>
@@ -10249,13 +9751,13 @@
               </a:spcAft>
             </a:pPr>
             <a:r>
-              <a:rPr sz="3200" b="1">
+              <a:rPr sz="4000" b="1">
                 <a:solidFill>
                   <a:srgbClr val="272A25"/>
                 </a:solidFill>
                 <a:latin typeface="Fraunces"/>
               </a:rPr>
-              <a:t>Save project context instead of repeating it</a:t>
+              <a:t>Context: what the AI can actually see</a:t>
             </a:r>
           </a:p>
         </p:txBody>
@@ -10294,7 +9796,7 @@
                 </a:solidFill>
                 <a:latin typeface="DM Sans"/>
               </a:rPr>
-              <a:t>•  Write down what the project is, who it is for, and what should stay true.</a:t>
+              <a:t>•  Its answer depends on the messages, files and tool results available now.</a:t>
             </a:r>
           </a:p>
           <a:p>
@@ -10310,7 +9812,7 @@
                 </a:solidFill>
                 <a:latin typeface="DM Sans"/>
               </a:rPr>
-              <a:t>•  Keep it short, correct and editable; update it when the project changes.</a:t>
+              <a:t>•  It does not automatically know your audience, preferences or project history.</a:t>
             </a:r>
           </a:p>
           <a:p>
@@ -10326,7 +9828,7 @@
                 </a:solidFill>
                 <a:latin typeface="DM Sans"/>
               </a:rPr>
-              <a:t>•  Example: “For nervous first-time visitors. Plain HTML/CSS. Do not invent event dates.”</a:t>
+              <a:t>•  “Improve my site” is weaker than a clear audience, goal and example.</a:t>
             </a:r>
           </a:p>
         </p:txBody>
@@ -10365,7 +9867,7 @@
                 </a:solidFill>
                 <a:latin typeface="DM Sans"/>
               </a:rPr>
-              <a:t>Week 6 · Ongoing context        6 / 26</a:t>
+              <a:t>Week 6 · Ongoing context        6 / 24</a:t>
             </a:r>
           </a:p>
         </p:txBody>
@@ -10467,13 +9969,13 @@
               </a:spcAft>
             </a:pPr>
             <a:r>
-              <a:rPr sz="4000" b="1">
+              <a:rPr sz="3200" b="1">
                 <a:solidFill>
                   <a:srgbClr val="272A25"/>
                 </a:solidFill>
                 <a:latin typeface="Fraunces"/>
               </a:rPr>
-              <a:t>A context file loads every session</a:t>
+              <a:t>Save project context instead of repeating it</a:t>
             </a:r>
           </a:p>
         </p:txBody>
@@ -10512,7 +10014,7 @@
                 </a:solidFill>
                 <a:latin typeface="DM Sans"/>
               </a:rPr>
-              <a:t>•  Coding agents such as Claude Code, Codex and Cursor can read AGENTS.md automatically.</a:t>
+              <a:t>•  Write down what the project is, who it is for, and what should stay true.</a:t>
             </a:r>
           </a:p>
           <a:p>
@@ -10528,7 +10030,7 @@
                 </a:solidFill>
                 <a:latin typeface="DM Sans"/>
               </a:rPr>
-              <a:t>•  Your project context is there at the start of every session—no retyping.</a:t>
+              <a:t>•  Keep it short, correct and editable; update it when the project changes.</a:t>
             </a:r>
           </a:p>
           <a:p>
@@ -10544,7 +10046,7 @@
                 </a:solidFill>
                 <a:latin typeface="DM Sans"/>
               </a:rPr>
-              <a:t>•  In a chat app, paste the context or add it to a Project.</a:t>
+              <a:t>•  Example: “For nervous first-time visitors. Plain HTML/CSS. Do not invent event dates.”</a:t>
             </a:r>
           </a:p>
         </p:txBody>
@@ -10583,7 +10085,7 @@
                 </a:solidFill>
                 <a:latin typeface="DM Sans"/>
               </a:rPr>
-              <a:t>Week 6 · Ongoing context        7 / 26</a:t>
+              <a:t>Week 6 · Ongoing context        7 / 24</a:t>
             </a:r>
           </a:p>
         </p:txBody>
@@ -10691,7 +10193,7 @@
                 </a:solidFill>
                 <a:latin typeface="Fraunces"/>
               </a:rPr>
-              <a:t>An index points to deeper context</a:t>
+              <a:t>A context file loads every session</a:t>
             </a:r>
           </a:p>
         </p:txBody>
@@ -10730,7 +10232,7 @@
                 </a:solidFill>
                 <a:latin typeface="DM Sans"/>
               </a:rPr>
-              <a:t>•  A small index says which files exist and what each is for.</a:t>
+              <a:t>•  Coding agents such as Claude Code, Codex and Cursor can read AGENTS.md automatically.</a:t>
             </a:r>
           </a:p>
           <a:p>
@@ -10746,7 +10248,7 @@
                 </a:solidFill>
                 <a:latin typeface="DM Sans"/>
               </a:rPr>
-              <a:t>•  Example: docs/facts.md → verified facts; docs/design.md → visual direction.</a:t>
+              <a:t>•  Your project context is there at the start of every session—no retyping.</a:t>
             </a:r>
           </a:p>
           <a:p>
@@ -10762,7 +10264,7 @@
                 </a:solidFill>
                 <a:latin typeface="DM Sans"/>
               </a:rPr>
-              <a:t>•  The AI can open the relevant document instead of receiving one giant prompt.</a:t>
+              <a:t>•  In a chat app, paste the context or add it to a Project.</a:t>
             </a:r>
           </a:p>
         </p:txBody>
@@ -10801,7 +10303,7 @@
                 </a:solidFill>
                 <a:latin typeface="DM Sans"/>
               </a:rPr>
-              <a:t>Week 6 · Ongoing context        8 / 26</a:t>
+              <a:t>Week 6 · Ongoing context        8 / 24</a:t>
             </a:r>
           </a:p>
         </p:txBody>
@@ -10903,13 +10405,13 @@
               </a:spcAft>
             </a:pPr>
             <a:r>
-              <a:rPr sz="3200" b="1">
+              <a:rPr sz="4000" b="1">
                 <a:solidFill>
                   <a:srgbClr val="272A25"/>
                 </a:solidFill>
                 <a:latin typeface="Fraunces"/>
               </a:rPr>
-              <a:t>Describe the design, not just the features</a:t>
+              <a:t>An index points to deeper context</a:t>
             </a:r>
           </a:p>
         </p:txBody>
@@ -10948,7 +10450,7 @@
                 </a:solidFill>
                 <a:latin typeface="DM Sans"/>
               </a:rPr>
-              <a:t>•  “Make it better” leaves the visual choices to the model.</a:t>
+              <a:t>•  A small index says which files exist and what each is for.</a:t>
             </a:r>
           </a:p>
           <a:p>
@@ -10964,7 +10466,7 @@
                 </a:solidFill>
                 <a:latin typeface="DM Sans"/>
               </a:rPr>
-              <a:t>•  Name the audience, feeling, hierarchy and interactions you want.</a:t>
+              <a:t>•  Example: docs/facts.md → verified facts; docs/design.md → visual direction.</a:t>
             </a:r>
           </a:p>
           <a:p>
@@ -10980,7 +10482,7 @@
                 </a:solidFill>
                 <a:latin typeface="DM Sans"/>
               </a:rPr>
-              <a:t>•  Example: “Calm portfolio. Work first, muted colours, clickable project cards.”</a:t>
+              <a:t>•  The AI can open the relevant document instead of receiving one giant prompt.</a:t>
             </a:r>
           </a:p>
         </p:txBody>
@@ -11019,7 +10521,7 @@
                 </a:solidFill>
                 <a:latin typeface="DM Sans"/>
               </a:rPr>
-              <a:t>Week 6 · Communicate intent        9 / 26</a:t>
+              <a:t>Week 6 · Ongoing context        9 / 24</a:t>
             </a:r>
           </a:p>
         </p:txBody>

</xml_diff>